<commit_message>
docs(slides): diagnosis page now lists six evidence-backed problems mapped to fixes
</commit_message>
<xml_diff>
--- a/docs/slides/qwenpi-optimization.pptx
+++ b/docs/slides/qwenpi-optimization.pptx
@@ -1043,8 +1043,9 @@
           <a:p>
             <a:r>
               <a:rPr lang="en-US" dirty="0"/>
-              <a:t>Timeline bars are real busy intervals from the nsys sqlite export (kernels classified compute vs NCCL vs memcpy).
-[IMPORTANT] Key message: this workload was CPU-launch-bound, not GPU-bound. That ordering drives the whole optimization plan.</a:t>
+              <a:t>Timeline bars are real busy intervals from the nsys sqlite; badges 1/2/4/5 point at where each problem is visible.
+Rows 2+3 land as one ladder level (pipeline &amp; caching, -117 ms); row 5 combines bucket sizing (PR11) and the redundant-flatten removal (PR12); row 6 covers the two config-level fixes.
+[IMPORTANT] Key message: every fix in this deck was first SEEN here as a trace shape or a measured kernel cost - problems first, solutions second.</a:t>
             </a:r>
             <a:endParaRPr lang="en-US" dirty="0"/>
           </a:p>
@@ -8489,7 +8490,7 @@
                 <a:ea typeface="NVIDIA Sans" pitchFamily="34" charset="-122"/>
                 <a:cs typeface="NVIDIA Sans" pitchFamily="34" charset="-120"/>
               </a:rPr>
-              <a:t>One baseline step from the nsys sqlite (866 ms), aligned to the model phases</a:t>
+              <a:t>One baseline step (nsys, 866 ms): six problems you can see in the trace — each maps to a fix</a:t>
             </a:r>
             <a:endParaRPr lang="en-US" sz="1500" dirty="0"/>
           </a:p>
@@ -8503,7 +8504,7 @@
         </p:nvSpPr>
         <p:spPr>
           <a:xfrm>
-            <a:off x="1508760" y="1325880"/>
+            <a:off x="1508760" y="1261872"/>
             <a:ext cx="1912226" cy="237744"/>
           </a:xfrm>
           <a:prstGeom prst="rect">
@@ -8523,7 +8524,7 @@
         </p:nvSpPr>
         <p:spPr>
           <a:xfrm>
-            <a:off x="1508760" y="1325880"/>
+            <a:off x="1508760" y="1261872"/>
             <a:ext cx="1912226" cy="237744"/>
           </a:xfrm>
           <a:prstGeom prst="rect">
@@ -8562,7 +8563,7 @@
         </p:nvSpPr>
         <p:spPr>
           <a:xfrm>
-            <a:off x="3421693" y="1325880"/>
+            <a:off x="3421693" y="1261872"/>
             <a:ext cx="3639101" cy="237744"/>
           </a:xfrm>
           <a:prstGeom prst="rect">
@@ -8582,7 +8583,7 @@
         </p:nvSpPr>
         <p:spPr>
           <a:xfrm>
-            <a:off x="3421693" y="1325880"/>
+            <a:off x="3421693" y="1261872"/>
             <a:ext cx="3639101" cy="237744"/>
           </a:xfrm>
           <a:prstGeom prst="rect">
@@ -8621,7 +8622,7 @@
         </p:nvSpPr>
         <p:spPr>
           <a:xfrm>
-            <a:off x="7060794" y="1325880"/>
+            <a:off x="7060794" y="1261872"/>
             <a:ext cx="574446" cy="237744"/>
           </a:xfrm>
           <a:prstGeom prst="rect">
@@ -8641,7 +8642,7 @@
         </p:nvSpPr>
         <p:spPr>
           <a:xfrm>
-            <a:off x="7060794" y="1325880"/>
+            <a:off x="7060794" y="1261872"/>
             <a:ext cx="574446" cy="237744"/>
           </a:xfrm>
           <a:prstGeom prst="rect">
@@ -8680,7 +8681,7 @@
         </p:nvSpPr>
         <p:spPr>
           <a:xfrm>
-            <a:off x="457200" y="1325880"/>
+            <a:off x="457200" y="1261872"/>
             <a:ext cx="978408" cy="237744"/>
           </a:xfrm>
           <a:prstGeom prst="rect">
@@ -8719,8 +8720,8 @@
         </p:nvSpPr>
         <p:spPr>
           <a:xfrm>
-            <a:off x="457200" y="1600200"/>
-            <a:ext cx="978408" cy="384048"/>
+            <a:off x="457200" y="1536192"/>
+            <a:ext cx="978408" cy="310896"/>
           </a:xfrm>
           <a:prstGeom prst="rect">
             <a:avLst/>
@@ -8758,8 +8759,8 @@
         </p:nvSpPr>
         <p:spPr>
           <a:xfrm>
-            <a:off x="1508760" y="1600200"/>
-            <a:ext cx="6126480" cy="384048"/>
+            <a:off x="1508760" y="1536192"/>
+            <a:ext cx="6126480" cy="310896"/>
           </a:xfrm>
           <a:prstGeom prst="rect">
             <a:avLst/>
@@ -8783,8 +8784,8 @@
         </p:nvSpPr>
         <p:spPr>
           <a:xfrm>
-            <a:off x="2073655" y="1627632"/>
-            <a:ext cx="4572" cy="329184"/>
+            <a:off x="2073655" y="1563624"/>
+            <a:ext cx="4572" cy="256032"/>
           </a:xfrm>
           <a:prstGeom prst="rect">
             <a:avLst/>
@@ -8803,8 +8804,8 @@
         </p:nvSpPr>
         <p:spPr>
           <a:xfrm>
-            <a:off x="2112919" y="1627632"/>
-            <a:ext cx="4572" cy="329184"/>
+            <a:off x="2112919" y="1563624"/>
+            <a:ext cx="4572" cy="256032"/>
           </a:xfrm>
           <a:prstGeom prst="rect">
             <a:avLst/>
@@ -8823,8 +8824,8 @@
         </p:nvSpPr>
         <p:spPr>
           <a:xfrm>
-            <a:off x="2114970" y="1627632"/>
-            <a:ext cx="5660" cy="329184"/>
+            <a:off x="2114970" y="1563624"/>
+            <a:ext cx="5660" cy="256032"/>
           </a:xfrm>
           <a:prstGeom prst="rect">
             <a:avLst/>
@@ -8843,8 +8844,8 @@
         </p:nvSpPr>
         <p:spPr>
           <a:xfrm>
-            <a:off x="2123106" y="1627632"/>
-            <a:ext cx="25539" cy="329184"/>
+            <a:off x="2123106" y="1563624"/>
+            <a:ext cx="25539" cy="256032"/>
           </a:xfrm>
           <a:prstGeom prst="rect">
             <a:avLst/>
@@ -8863,8 +8864,8 @@
         </p:nvSpPr>
         <p:spPr>
           <a:xfrm>
-            <a:off x="2151121" y="1627632"/>
-            <a:ext cx="4572" cy="329184"/>
+            <a:off x="2151121" y="1563624"/>
+            <a:ext cx="4572" cy="256032"/>
           </a:xfrm>
           <a:prstGeom prst="rect">
             <a:avLst/>
@@ -8883,8 +8884,8 @@
         </p:nvSpPr>
         <p:spPr>
           <a:xfrm>
-            <a:off x="2156285" y="1627632"/>
-            <a:ext cx="5094" cy="329184"/>
+            <a:off x="2156285" y="1563624"/>
+            <a:ext cx="5094" cy="256032"/>
           </a:xfrm>
           <a:prstGeom prst="rect">
             <a:avLst/>
@@ -8903,8 +8904,8 @@
         </p:nvSpPr>
         <p:spPr>
           <a:xfrm>
-            <a:off x="2162086" y="1627632"/>
-            <a:ext cx="6579" cy="329184"/>
+            <a:off x="2162086" y="1563624"/>
+            <a:ext cx="6579" cy="256032"/>
           </a:xfrm>
           <a:prstGeom prst="rect">
             <a:avLst/>
@@ -8923,8 +8924,8 @@
         </p:nvSpPr>
         <p:spPr>
           <a:xfrm>
-            <a:off x="2170363" y="1627632"/>
-            <a:ext cx="11956" cy="329184"/>
+            <a:off x="2170363" y="1563624"/>
+            <a:ext cx="11956" cy="256032"/>
           </a:xfrm>
           <a:prstGeom prst="rect">
             <a:avLst/>
@@ -8943,8 +8944,8 @@
         </p:nvSpPr>
         <p:spPr>
           <a:xfrm>
-            <a:off x="2184017" y="1627632"/>
-            <a:ext cx="11602" cy="329184"/>
+            <a:off x="2184017" y="1563624"/>
+            <a:ext cx="11602" cy="256032"/>
           </a:xfrm>
           <a:prstGeom prst="rect">
             <a:avLst/>
@@ -8963,8 +8964,8 @@
         </p:nvSpPr>
         <p:spPr>
           <a:xfrm>
-            <a:off x="2197317" y="1627632"/>
-            <a:ext cx="11390" cy="329184"/>
+            <a:off x="2197317" y="1563624"/>
+            <a:ext cx="11390" cy="256032"/>
           </a:xfrm>
           <a:prstGeom prst="rect">
             <a:avLst/>
@@ -8983,8 +8984,8 @@
         </p:nvSpPr>
         <p:spPr>
           <a:xfrm>
-            <a:off x="2210263" y="1627632"/>
-            <a:ext cx="4881" cy="329184"/>
+            <a:off x="2210263" y="1563624"/>
+            <a:ext cx="4881" cy="256032"/>
           </a:xfrm>
           <a:prstGeom prst="rect">
             <a:avLst/>
@@ -9003,8 +9004,8 @@
         </p:nvSpPr>
         <p:spPr>
           <a:xfrm>
-            <a:off x="2215781" y="1627632"/>
-            <a:ext cx="7711" cy="329184"/>
+            <a:off x="2215781" y="1563624"/>
+            <a:ext cx="7711" cy="256032"/>
           </a:xfrm>
           <a:prstGeom prst="rect">
             <a:avLst/>
@@ -9023,8 +9024,8 @@
         </p:nvSpPr>
         <p:spPr>
           <a:xfrm>
-            <a:off x="2225473" y="1627632"/>
-            <a:ext cx="5023" cy="329184"/>
+            <a:off x="2225473" y="1563624"/>
+            <a:ext cx="5023" cy="256032"/>
           </a:xfrm>
           <a:prstGeom prst="rect">
             <a:avLst/>
@@ -9043,8 +9044,8 @@
         </p:nvSpPr>
         <p:spPr>
           <a:xfrm>
-            <a:off x="2231133" y="1627632"/>
-            <a:ext cx="6296" cy="329184"/>
+            <a:off x="2231133" y="1563624"/>
+            <a:ext cx="6296" cy="256032"/>
           </a:xfrm>
           <a:prstGeom prst="rect">
             <a:avLst/>
@@ -9063,8 +9064,8 @@
         </p:nvSpPr>
         <p:spPr>
           <a:xfrm>
-            <a:off x="2239127" y="1627632"/>
-            <a:ext cx="4811" cy="329184"/>
+            <a:off x="2239127" y="1563624"/>
+            <a:ext cx="4811" cy="256032"/>
           </a:xfrm>
           <a:prstGeom prst="rect">
             <a:avLst/>
@@ -9083,8 +9084,8 @@
         </p:nvSpPr>
         <p:spPr>
           <a:xfrm>
-            <a:off x="2244504" y="1627632"/>
-            <a:ext cx="6650" cy="329184"/>
+            <a:off x="2244504" y="1563624"/>
+            <a:ext cx="6650" cy="256032"/>
           </a:xfrm>
           <a:prstGeom prst="rect">
             <a:avLst/>
@@ -9103,8 +9104,8 @@
         </p:nvSpPr>
         <p:spPr>
           <a:xfrm>
-            <a:off x="2252993" y="1627632"/>
-            <a:ext cx="4881" cy="329184"/>
+            <a:off x="2252993" y="1563624"/>
+            <a:ext cx="4881" cy="256032"/>
           </a:xfrm>
           <a:prstGeom prst="rect">
             <a:avLst/>
@@ -9123,8 +9124,8 @@
         </p:nvSpPr>
         <p:spPr>
           <a:xfrm>
-            <a:off x="2258723" y="1627632"/>
-            <a:ext cx="7499" cy="329184"/>
+            <a:off x="2258723" y="1563624"/>
+            <a:ext cx="7499" cy="256032"/>
           </a:xfrm>
           <a:prstGeom prst="rect">
             <a:avLst/>
@@ -9143,8 +9144,8 @@
         </p:nvSpPr>
         <p:spPr>
           <a:xfrm>
-            <a:off x="2268061" y="1627632"/>
-            <a:ext cx="4881" cy="329184"/>
+            <a:off x="2268061" y="1563624"/>
+            <a:ext cx="4881" cy="256032"/>
           </a:xfrm>
           <a:prstGeom prst="rect">
             <a:avLst/>
@@ -9163,8 +9164,8 @@
         </p:nvSpPr>
         <p:spPr>
           <a:xfrm>
-            <a:off x="2273580" y="1627632"/>
-            <a:ext cx="6296" cy="329184"/>
+            <a:off x="2273580" y="1563624"/>
+            <a:ext cx="6296" cy="256032"/>
           </a:xfrm>
           <a:prstGeom prst="rect">
             <a:avLst/>
@@ -9183,8 +9184,8 @@
         </p:nvSpPr>
         <p:spPr>
           <a:xfrm>
-            <a:off x="2281574" y="1627632"/>
-            <a:ext cx="12310" cy="329184"/>
+            <a:off x="2281574" y="1563624"/>
+            <a:ext cx="12310" cy="256032"/>
           </a:xfrm>
           <a:prstGeom prst="rect">
             <a:avLst/>
@@ -9203,8 +9204,8 @@
         </p:nvSpPr>
         <p:spPr>
           <a:xfrm>
-            <a:off x="2296713" y="1627632"/>
-            <a:ext cx="5164" cy="329184"/>
+            <a:off x="2296713" y="1563624"/>
+            <a:ext cx="5164" cy="256032"/>
           </a:xfrm>
           <a:prstGeom prst="rect">
             <a:avLst/>
@@ -9223,8 +9224,8 @@
         </p:nvSpPr>
         <p:spPr>
           <a:xfrm>
-            <a:off x="2302514" y="1627632"/>
-            <a:ext cx="6650" cy="329184"/>
+            <a:off x="2302514" y="1563624"/>
+            <a:ext cx="6650" cy="256032"/>
           </a:xfrm>
           <a:prstGeom prst="rect">
             <a:avLst/>
@@ -9243,8 +9244,8 @@
         </p:nvSpPr>
         <p:spPr>
           <a:xfrm>
-            <a:off x="2310791" y="1627632"/>
-            <a:ext cx="11531" cy="329184"/>
+            <a:off x="2310791" y="1563624"/>
+            <a:ext cx="11531" cy="256032"/>
           </a:xfrm>
           <a:prstGeom prst="rect">
             <a:avLst/>
@@ -9263,8 +9264,8 @@
         </p:nvSpPr>
         <p:spPr>
           <a:xfrm>
-            <a:off x="2324020" y="1627632"/>
-            <a:ext cx="4952" cy="329184"/>
+            <a:off x="2324020" y="1563624"/>
+            <a:ext cx="4952" cy="256032"/>
           </a:xfrm>
           <a:prstGeom prst="rect">
             <a:avLst/>
@@ -9283,8 +9284,8 @@
         </p:nvSpPr>
         <p:spPr>
           <a:xfrm>
-            <a:off x="2329609" y="1627632"/>
-            <a:ext cx="7074" cy="329184"/>
+            <a:off x="2329609" y="1563624"/>
+            <a:ext cx="7074" cy="256032"/>
           </a:xfrm>
           <a:prstGeom prst="rect">
             <a:avLst/>
@@ -9303,8 +9304,8 @@
         </p:nvSpPr>
         <p:spPr>
           <a:xfrm>
-            <a:off x="2338382" y="1627632"/>
-            <a:ext cx="4952" cy="329184"/>
+            <a:off x="2338382" y="1563624"/>
+            <a:ext cx="4952" cy="256032"/>
           </a:xfrm>
           <a:prstGeom prst="rect">
             <a:avLst/>
@@ -9323,8 +9324,8 @@
         </p:nvSpPr>
         <p:spPr>
           <a:xfrm>
-            <a:off x="2344041" y="1627632"/>
-            <a:ext cx="6509" cy="329184"/>
+            <a:off x="2344041" y="1563624"/>
+            <a:ext cx="6509" cy="256032"/>
           </a:xfrm>
           <a:prstGeom prst="rect">
             <a:avLst/>
@@ -9343,8 +9344,8 @@
         </p:nvSpPr>
         <p:spPr>
           <a:xfrm>
-            <a:off x="2352177" y="1627632"/>
-            <a:ext cx="4740" cy="329184"/>
+            <a:off x="2352177" y="1563624"/>
+            <a:ext cx="4740" cy="256032"/>
           </a:xfrm>
           <a:prstGeom prst="rect">
             <a:avLst/>
@@ -9363,8 +9364,8 @@
         </p:nvSpPr>
         <p:spPr>
           <a:xfrm>
-            <a:off x="2357553" y="1627632"/>
-            <a:ext cx="6226" cy="329184"/>
+            <a:off x="2357553" y="1563624"/>
+            <a:ext cx="6226" cy="256032"/>
           </a:xfrm>
           <a:prstGeom prst="rect">
             <a:avLst/>
@@ -9383,8 +9384,8 @@
         </p:nvSpPr>
         <p:spPr>
           <a:xfrm>
-            <a:off x="2365830" y="1627632"/>
-            <a:ext cx="12734" cy="329184"/>
+            <a:off x="2365830" y="1563624"/>
+            <a:ext cx="12734" cy="256032"/>
           </a:xfrm>
           <a:prstGeom prst="rect">
             <a:avLst/>
@@ -9403,8 +9404,8 @@
         </p:nvSpPr>
         <p:spPr>
           <a:xfrm>
-            <a:off x="2380262" y="1627632"/>
-            <a:ext cx="11390" cy="329184"/>
+            <a:off x="2380262" y="1563624"/>
+            <a:ext cx="11390" cy="256032"/>
           </a:xfrm>
           <a:prstGeom prst="rect">
             <a:avLst/>
@@ -9423,8 +9424,8 @@
         </p:nvSpPr>
         <p:spPr>
           <a:xfrm>
-            <a:off x="2393350" y="1627632"/>
-            <a:ext cx="11178" cy="329184"/>
+            <a:off x="2393350" y="1563624"/>
+            <a:ext cx="11178" cy="256032"/>
           </a:xfrm>
           <a:prstGeom prst="rect">
             <a:avLst/>
@@ -9443,8 +9444,8 @@
         </p:nvSpPr>
         <p:spPr>
           <a:xfrm>
-            <a:off x="2406013" y="1627632"/>
-            <a:ext cx="11319" cy="329184"/>
+            <a:off x="2406013" y="1563624"/>
+            <a:ext cx="11319" cy="256032"/>
           </a:xfrm>
           <a:prstGeom prst="rect">
             <a:avLst/>
@@ -9463,8 +9464,8 @@
         </p:nvSpPr>
         <p:spPr>
           <a:xfrm>
-            <a:off x="2418889" y="1627632"/>
-            <a:ext cx="11814" cy="329184"/>
+            <a:off x="2418889" y="1563624"/>
+            <a:ext cx="11814" cy="256032"/>
           </a:xfrm>
           <a:prstGeom prst="rect">
             <a:avLst/>
@@ -9483,8 +9484,8 @@
         </p:nvSpPr>
         <p:spPr>
           <a:xfrm>
-            <a:off x="2432330" y="1627632"/>
-            <a:ext cx="4811" cy="329184"/>
+            <a:off x="2432330" y="1563624"/>
+            <a:ext cx="4811" cy="256032"/>
           </a:xfrm>
           <a:prstGeom prst="rect">
             <a:avLst/>
@@ -9503,8 +9504,8 @@
         </p:nvSpPr>
         <p:spPr>
           <a:xfrm>
-            <a:off x="2437707" y="1627632"/>
-            <a:ext cx="6438" cy="329184"/>
+            <a:off x="2437707" y="1563624"/>
+            <a:ext cx="6438" cy="256032"/>
           </a:xfrm>
           <a:prstGeom prst="rect">
             <a:avLst/>
@@ -9523,8 +9524,8 @@
         </p:nvSpPr>
         <p:spPr>
           <a:xfrm>
-            <a:off x="2445843" y="1627632"/>
-            <a:ext cx="11885" cy="329184"/>
+            <a:off x="2445843" y="1563624"/>
+            <a:ext cx="11885" cy="256032"/>
           </a:xfrm>
           <a:prstGeom prst="rect">
             <a:avLst/>
@@ -9543,8 +9544,8 @@
         </p:nvSpPr>
         <p:spPr>
           <a:xfrm>
-            <a:off x="2459921" y="1627632"/>
-            <a:ext cx="12097" cy="329184"/>
+            <a:off x="2459921" y="1563624"/>
+            <a:ext cx="12097" cy="256032"/>
           </a:xfrm>
           <a:prstGeom prst="rect">
             <a:avLst/>
@@ -9563,8 +9564,8 @@
         </p:nvSpPr>
         <p:spPr>
           <a:xfrm>
-            <a:off x="2473928" y="1627632"/>
-            <a:ext cx="4881" cy="329184"/>
+            <a:off x="2473928" y="1563624"/>
+            <a:ext cx="4881" cy="256032"/>
           </a:xfrm>
           <a:prstGeom prst="rect">
             <a:avLst/>
@@ -9583,8 +9584,8 @@
         </p:nvSpPr>
         <p:spPr>
           <a:xfrm>
-            <a:off x="2479376" y="1627632"/>
-            <a:ext cx="5094" cy="329184"/>
+            <a:off x="2479376" y="1563624"/>
+            <a:ext cx="5094" cy="256032"/>
           </a:xfrm>
           <a:prstGeom prst="rect">
             <a:avLst/>
@@ -9603,8 +9604,8 @@
         </p:nvSpPr>
         <p:spPr>
           <a:xfrm>
-            <a:off x="2485389" y="1627632"/>
-            <a:ext cx="5660" cy="329184"/>
+            <a:off x="2485389" y="1563624"/>
+            <a:ext cx="5660" cy="256032"/>
           </a:xfrm>
           <a:prstGeom prst="rect">
             <a:avLst/>
@@ -9623,8 +9624,8 @@
         </p:nvSpPr>
         <p:spPr>
           <a:xfrm>
-            <a:off x="2492534" y="1627632"/>
-            <a:ext cx="41386" cy="329184"/>
+            <a:off x="2492534" y="1563624"/>
+            <a:ext cx="41386" cy="256032"/>
           </a:xfrm>
           <a:prstGeom prst="rect">
             <a:avLst/>
@@ -9643,8 +9644,8 @@
         </p:nvSpPr>
         <p:spPr>
           <a:xfrm>
-            <a:off x="2534556" y="1627632"/>
-            <a:ext cx="18111" cy="329184"/>
+            <a:off x="2534556" y="1563624"/>
+            <a:ext cx="18111" cy="256032"/>
           </a:xfrm>
           <a:prstGeom prst="rect">
             <a:avLst/>
@@ -9663,8 +9664,8 @@
         </p:nvSpPr>
         <p:spPr>
           <a:xfrm>
-            <a:off x="2555072" y="1627632"/>
-            <a:ext cx="4572" cy="329184"/>
+            <a:off x="2555072" y="1563624"/>
+            <a:ext cx="4572" cy="256032"/>
           </a:xfrm>
           <a:prstGeom prst="rect">
             <a:avLst/>
@@ -9683,8 +9684,8 @@
         </p:nvSpPr>
         <p:spPr>
           <a:xfrm>
-            <a:off x="2560307" y="1627632"/>
-            <a:ext cx="4572" cy="329184"/>
+            <a:off x="2560307" y="1563624"/>
+            <a:ext cx="4572" cy="256032"/>
           </a:xfrm>
           <a:prstGeom prst="rect">
             <a:avLst/>
@@ -9703,8 +9704,8 @@
         </p:nvSpPr>
         <p:spPr>
           <a:xfrm>
-            <a:off x="2563066" y="1627632"/>
-            <a:ext cx="4572" cy="329184"/>
+            <a:off x="2563066" y="1563624"/>
+            <a:ext cx="4572" cy="256032"/>
           </a:xfrm>
           <a:prstGeom prst="rect">
             <a:avLst/>
@@ -9723,8 +9724,8 @@
         </p:nvSpPr>
         <p:spPr>
           <a:xfrm>
-            <a:off x="2565542" y="1627632"/>
-            <a:ext cx="5094" cy="329184"/>
+            <a:off x="2565542" y="1563624"/>
+            <a:ext cx="5094" cy="256032"/>
           </a:xfrm>
           <a:prstGeom prst="rect">
             <a:avLst/>
@@ -9743,8 +9744,8 @@
         </p:nvSpPr>
         <p:spPr>
           <a:xfrm>
-            <a:off x="2574244" y="1627632"/>
-            <a:ext cx="4572" cy="329184"/>
+            <a:off x="2574244" y="1563624"/>
+            <a:ext cx="4572" cy="256032"/>
           </a:xfrm>
           <a:prstGeom prst="rect">
             <a:avLst/>
@@ -9763,8 +9764,8 @@
         </p:nvSpPr>
         <p:spPr>
           <a:xfrm>
-            <a:off x="2580682" y="1627632"/>
-            <a:ext cx="4572" cy="329184"/>
+            <a:off x="2580682" y="1563624"/>
+            <a:ext cx="4572" cy="256032"/>
           </a:xfrm>
           <a:prstGeom prst="rect">
             <a:avLst/>
@@ -9783,8 +9784,8 @@
         </p:nvSpPr>
         <p:spPr>
           <a:xfrm>
-            <a:off x="2583229" y="1627632"/>
-            <a:ext cx="9055" cy="329184"/>
+            <a:off x="2583229" y="1563624"/>
+            <a:ext cx="9055" cy="256032"/>
           </a:xfrm>
           <a:prstGeom prst="rect">
             <a:avLst/>
@@ -9803,8 +9804,8 @@
         </p:nvSpPr>
         <p:spPr>
           <a:xfrm>
-            <a:off x="2595750" y="1627632"/>
-            <a:ext cx="4572" cy="329184"/>
+            <a:off x="2595750" y="1563624"/>
+            <a:ext cx="4572" cy="256032"/>
           </a:xfrm>
           <a:prstGeom prst="rect">
             <a:avLst/>
@@ -9823,8 +9824,8 @@
         </p:nvSpPr>
         <p:spPr>
           <a:xfrm>
-            <a:off x="2598368" y="1627632"/>
-            <a:ext cx="4572" cy="329184"/>
+            <a:off x="2598368" y="1563624"/>
+            <a:ext cx="4572" cy="256032"/>
           </a:xfrm>
           <a:prstGeom prst="rect">
             <a:avLst/>
@@ -9843,8 +9844,8 @@
         </p:nvSpPr>
         <p:spPr>
           <a:xfrm>
-            <a:off x="2601834" y="1627632"/>
-            <a:ext cx="10541" cy="329184"/>
+            <a:off x="2601834" y="1563624"/>
+            <a:ext cx="10541" cy="256032"/>
           </a:xfrm>
           <a:prstGeom prst="rect">
             <a:avLst/>
@@ -9863,8 +9864,8 @@
         </p:nvSpPr>
         <p:spPr>
           <a:xfrm>
-            <a:off x="2615488" y="1627632"/>
-            <a:ext cx="4572" cy="329184"/>
+            <a:off x="2615488" y="1563624"/>
+            <a:ext cx="4572" cy="256032"/>
           </a:xfrm>
           <a:prstGeom prst="rect">
             <a:avLst/>
@@ -9883,8 +9884,8 @@
         </p:nvSpPr>
         <p:spPr>
           <a:xfrm>
-            <a:off x="2621006" y="1627632"/>
-            <a:ext cx="4572" cy="329184"/>
+            <a:off x="2621006" y="1563624"/>
+            <a:ext cx="4572" cy="256032"/>
           </a:xfrm>
           <a:prstGeom prst="rect">
             <a:avLst/>
@@ -9903,8 +9904,8 @@
         </p:nvSpPr>
         <p:spPr>
           <a:xfrm>
-            <a:off x="2623836" y="1627632"/>
-            <a:ext cx="4572" cy="329184"/>
+            <a:off x="2623836" y="1563624"/>
+            <a:ext cx="4572" cy="256032"/>
           </a:xfrm>
           <a:prstGeom prst="rect">
             <a:avLst/>
@@ -9923,8 +9924,8 @@
         </p:nvSpPr>
         <p:spPr>
           <a:xfrm>
-            <a:off x="2627585" y="1627632"/>
-            <a:ext cx="20657" cy="329184"/>
+            <a:off x="2627585" y="1563624"/>
+            <a:ext cx="20657" cy="256032"/>
           </a:xfrm>
           <a:prstGeom prst="rect">
             <a:avLst/>
@@ -9943,8 +9944,8 @@
         </p:nvSpPr>
         <p:spPr>
           <a:xfrm>
-            <a:off x="2650719" y="1627632"/>
-            <a:ext cx="4572" cy="329184"/>
+            <a:off x="2650719" y="1563624"/>
+            <a:ext cx="4572" cy="256032"/>
           </a:xfrm>
           <a:prstGeom prst="rect">
             <a:avLst/>
@@ -9963,8 +9964,8 @@
         </p:nvSpPr>
         <p:spPr>
           <a:xfrm>
-            <a:off x="2656874" y="1627632"/>
-            <a:ext cx="4572" cy="329184"/>
+            <a:off x="2656874" y="1563624"/>
+            <a:ext cx="4572" cy="256032"/>
           </a:xfrm>
           <a:prstGeom prst="rect">
             <a:avLst/>
@@ -9983,8 +9984,8 @@
         </p:nvSpPr>
         <p:spPr>
           <a:xfrm>
-            <a:off x="2659279" y="1627632"/>
-            <a:ext cx="8419" cy="329184"/>
+            <a:off x="2659279" y="1563624"/>
+            <a:ext cx="8419" cy="256032"/>
           </a:xfrm>
           <a:prstGeom prst="rect">
             <a:avLst/>
@@ -10003,8 +10004,8 @@
         </p:nvSpPr>
         <p:spPr>
           <a:xfrm>
-            <a:off x="2670103" y="1627632"/>
-            <a:ext cx="4572" cy="329184"/>
+            <a:off x="2670103" y="1563624"/>
+            <a:ext cx="4572" cy="256032"/>
           </a:xfrm>
           <a:prstGeom prst="rect">
             <a:avLst/>
@@ -10023,8 +10024,8 @@
         </p:nvSpPr>
         <p:spPr>
           <a:xfrm>
-            <a:off x="2672862" y="1627632"/>
-            <a:ext cx="4572" cy="329184"/>
+            <a:off x="2672862" y="1563624"/>
+            <a:ext cx="4572" cy="256032"/>
           </a:xfrm>
           <a:prstGeom prst="rect">
             <a:avLst/>
@@ -10043,8 +10044,8 @@
         </p:nvSpPr>
         <p:spPr>
           <a:xfrm>
-            <a:off x="2676116" y="1627632"/>
-            <a:ext cx="11319" cy="329184"/>
+            <a:off x="2676116" y="1563624"/>
+            <a:ext cx="11319" cy="256032"/>
           </a:xfrm>
           <a:prstGeom prst="rect">
             <a:avLst/>
@@ -10063,8 +10064,8 @@
         </p:nvSpPr>
         <p:spPr>
           <a:xfrm>
-            <a:off x="2690619" y="1627632"/>
-            <a:ext cx="4572" cy="329184"/>
+            <a:off x="2690619" y="1563624"/>
+            <a:ext cx="4572" cy="256032"/>
           </a:xfrm>
           <a:prstGeom prst="rect">
             <a:avLst/>
@@ -10083,8 +10084,8 @@
         </p:nvSpPr>
         <p:spPr>
           <a:xfrm>
-            <a:off x="2693095" y="1627632"/>
-            <a:ext cx="4572" cy="329184"/>
+            <a:off x="2693095" y="1563624"/>
+            <a:ext cx="4572" cy="256032"/>
           </a:xfrm>
           <a:prstGeom prst="rect">
             <a:avLst/>
@@ -10103,8 +10104,8 @@
         </p:nvSpPr>
         <p:spPr>
           <a:xfrm>
-            <a:off x="2696915" y="1627632"/>
-            <a:ext cx="4572" cy="329184"/>
+            <a:off x="2696915" y="1563624"/>
+            <a:ext cx="4572" cy="256032"/>
           </a:xfrm>
           <a:prstGeom prst="rect">
             <a:avLst/>
@@ -10123,8 +10124,8 @@
         </p:nvSpPr>
         <p:spPr>
           <a:xfrm>
-            <a:off x="2699603" y="1627632"/>
-            <a:ext cx="17828" cy="329184"/>
+            <a:off x="2699603" y="1563624"/>
+            <a:ext cx="17828" cy="256032"/>
           </a:xfrm>
           <a:prstGeom prst="rect">
             <a:avLst/>
@@ -10143,8 +10144,8 @@
         </p:nvSpPr>
         <p:spPr>
           <a:xfrm>
-            <a:off x="2718138" y="1627632"/>
-            <a:ext cx="5094" cy="329184"/>
+            <a:off x="2718138" y="1563624"/>
+            <a:ext cx="5094" cy="256032"/>
           </a:xfrm>
           <a:prstGeom prst="rect">
             <a:avLst/>
@@ -10163,8 +10164,8 @@
         </p:nvSpPr>
         <p:spPr>
           <a:xfrm>
-            <a:off x="2726203" y="1627632"/>
-            <a:ext cx="4572" cy="329184"/>
+            <a:off x="2726203" y="1563624"/>
+            <a:ext cx="4572" cy="256032"/>
           </a:xfrm>
           <a:prstGeom prst="rect">
             <a:avLst/>
@@ -10183,8 +10184,8 @@
         </p:nvSpPr>
         <p:spPr>
           <a:xfrm>
-            <a:off x="2728538" y="1627632"/>
-            <a:ext cx="4572" cy="329184"/>
+            <a:off x="2728538" y="1563624"/>
+            <a:ext cx="4572" cy="256032"/>
           </a:xfrm>
           <a:prstGeom prst="rect">
             <a:avLst/>
@@ -10203,8 +10204,8 @@
         </p:nvSpPr>
         <p:spPr>
           <a:xfrm>
-            <a:off x="2735188" y="1627632"/>
-            <a:ext cx="10329" cy="329184"/>
+            <a:off x="2735188" y="1563624"/>
+            <a:ext cx="10329" cy="256032"/>
           </a:xfrm>
           <a:prstGeom prst="rect">
             <a:avLst/>
@@ -10223,8 +10224,8 @@
         </p:nvSpPr>
         <p:spPr>
           <a:xfrm>
-            <a:off x="2748488" y="1627632"/>
-            <a:ext cx="4572" cy="329184"/>
+            <a:off x="2748488" y="1563624"/>
+            <a:ext cx="4572" cy="256032"/>
           </a:xfrm>
           <a:prstGeom prst="rect">
             <a:avLst/>
@@ -10243,8 +10244,8 @@
         </p:nvSpPr>
         <p:spPr>
           <a:xfrm>
-            <a:off x="2754006" y="1627632"/>
-            <a:ext cx="10116" cy="329184"/>
+            <a:off x="2754006" y="1563624"/>
+            <a:ext cx="10116" cy="256032"/>
           </a:xfrm>
           <a:prstGeom prst="rect">
             <a:avLst/>
@@ -10263,8 +10264,8 @@
         </p:nvSpPr>
         <p:spPr>
           <a:xfrm>
-            <a:off x="2767023" y="1627632"/>
-            <a:ext cx="4572" cy="329184"/>
+            <a:off x="2767023" y="1563624"/>
+            <a:ext cx="4572" cy="256032"/>
           </a:xfrm>
           <a:prstGeom prst="rect">
             <a:avLst/>
@@ -10283,8 +10284,8 @@
         </p:nvSpPr>
         <p:spPr>
           <a:xfrm>
-            <a:off x="2769358" y="1627632"/>
-            <a:ext cx="4572" cy="329184"/>
+            <a:off x="2769358" y="1563624"/>
+            <a:ext cx="4572" cy="256032"/>
           </a:xfrm>
           <a:prstGeom prst="rect">
             <a:avLst/>
@@ -10303,8 +10304,8 @@
         </p:nvSpPr>
         <p:spPr>
           <a:xfrm>
-            <a:off x="2772400" y="1627632"/>
-            <a:ext cx="4572" cy="329184"/>
+            <a:off x="2772400" y="1563624"/>
+            <a:ext cx="4572" cy="256032"/>
           </a:xfrm>
           <a:prstGeom prst="rect">
             <a:avLst/>
@@ -10323,8 +10324,8 @@
         </p:nvSpPr>
         <p:spPr>
           <a:xfrm>
-            <a:off x="2774876" y="1627632"/>
-            <a:ext cx="15069" cy="329184"/>
+            <a:off x="2774876" y="1563624"/>
+            <a:ext cx="15069" cy="256032"/>
           </a:xfrm>
           <a:prstGeom prst="rect">
             <a:avLst/>
@@ -10343,8 +10344,8 @@
         </p:nvSpPr>
         <p:spPr>
           <a:xfrm>
-            <a:off x="2790581" y="1627632"/>
-            <a:ext cx="8065" cy="329184"/>
+            <a:off x="2790581" y="1563624"/>
+            <a:ext cx="8065" cy="256032"/>
           </a:xfrm>
           <a:prstGeom prst="rect">
             <a:avLst/>
@@ -10363,8 +10364,8 @@
         </p:nvSpPr>
         <p:spPr>
           <a:xfrm>
-            <a:off x="2801405" y="1627632"/>
-            <a:ext cx="4572" cy="329184"/>
+            <a:off x="2801405" y="1563624"/>
+            <a:ext cx="4572" cy="256032"/>
           </a:xfrm>
           <a:prstGeom prst="rect">
             <a:avLst/>
@@ -10383,8 +10384,8 @@
         </p:nvSpPr>
         <p:spPr>
           <a:xfrm>
-            <a:off x="2806145" y="1627632"/>
-            <a:ext cx="4572" cy="329184"/>
+            <a:off x="2806145" y="1563624"/>
+            <a:ext cx="4572" cy="256032"/>
           </a:xfrm>
           <a:prstGeom prst="rect">
             <a:avLst/>
@@ -10403,8 +10404,8 @@
         </p:nvSpPr>
         <p:spPr>
           <a:xfrm>
-            <a:off x="2808762" y="1627632"/>
-            <a:ext cx="4572" cy="329184"/>
+            <a:off x="2808762" y="1563624"/>
+            <a:ext cx="4572" cy="256032"/>
           </a:xfrm>
           <a:prstGeom prst="rect">
             <a:avLst/>
@@ -10423,8 +10424,8 @@
         </p:nvSpPr>
         <p:spPr>
           <a:xfrm>
-            <a:off x="2812370" y="1627632"/>
-            <a:ext cx="10399" cy="329184"/>
+            <a:off x="2812370" y="1563624"/>
+            <a:ext cx="10399" cy="256032"/>
           </a:xfrm>
           <a:prstGeom prst="rect">
             <a:avLst/>
@@ -10443,8 +10444,8 @@
         </p:nvSpPr>
         <p:spPr>
           <a:xfrm>
-            <a:off x="2825034" y="1627632"/>
-            <a:ext cx="4572" cy="329184"/>
+            <a:off x="2825034" y="1563624"/>
+            <a:ext cx="4572" cy="256032"/>
           </a:xfrm>
           <a:prstGeom prst="rect">
             <a:avLst/>
@@ -10463,8 +10464,8 @@
         </p:nvSpPr>
         <p:spPr>
           <a:xfrm>
-            <a:off x="2830764" y="1627632"/>
-            <a:ext cx="4572" cy="329184"/>
+            <a:off x="2830764" y="1563624"/>
+            <a:ext cx="4572" cy="256032"/>
           </a:xfrm>
           <a:prstGeom prst="rect">
             <a:avLst/>
@@ -10483,8 +10484,8 @@
         </p:nvSpPr>
         <p:spPr>
           <a:xfrm>
-            <a:off x="2833664" y="1627632"/>
-            <a:ext cx="9338" cy="329184"/>
+            <a:off x="2833664" y="1563624"/>
+            <a:ext cx="9338" cy="256032"/>
           </a:xfrm>
           <a:prstGeom prst="rect">
             <a:avLst/>
@@ -10503,8 +10504,8 @@
         </p:nvSpPr>
         <p:spPr>
           <a:xfrm>
-            <a:off x="2846328" y="1627632"/>
-            <a:ext cx="4572" cy="329184"/>
+            <a:off x="2846328" y="1563624"/>
+            <a:ext cx="4572" cy="256032"/>
           </a:xfrm>
           <a:prstGeom prst="rect">
             <a:avLst/>
@@ -10523,8 +10524,8 @@
         </p:nvSpPr>
         <p:spPr>
           <a:xfrm>
-            <a:off x="2851633" y="1627632"/>
-            <a:ext cx="23770" cy="329184"/>
+            <a:off x="2851633" y="1563624"/>
+            <a:ext cx="23770" cy="256032"/>
           </a:xfrm>
           <a:prstGeom prst="rect">
             <a:avLst/>
@@ -10543,8 +10544,8 @@
         </p:nvSpPr>
         <p:spPr>
           <a:xfrm>
-            <a:off x="2877667" y="1627632"/>
-            <a:ext cx="4572" cy="329184"/>
+            <a:off x="2877667" y="1563624"/>
+            <a:ext cx="4572" cy="256032"/>
           </a:xfrm>
           <a:prstGeom prst="rect">
             <a:avLst/>
@@ -10563,8 +10564,8 @@
         </p:nvSpPr>
         <p:spPr>
           <a:xfrm>
-            <a:off x="2880427" y="1627632"/>
-            <a:ext cx="4572" cy="329184"/>
+            <a:off x="2880427" y="1563624"/>
+            <a:ext cx="4572" cy="256032"/>
           </a:xfrm>
           <a:prstGeom prst="rect">
             <a:avLst/>
@@ -10583,8 +10584,8 @@
         </p:nvSpPr>
         <p:spPr>
           <a:xfrm>
-            <a:off x="2883539" y="1627632"/>
-            <a:ext cx="10824" cy="329184"/>
+            <a:off x="2883539" y="1563624"/>
+            <a:ext cx="10824" cy="256032"/>
           </a:xfrm>
           <a:prstGeom prst="rect">
             <a:avLst/>
@@ -10603,8 +10604,8 @@
         </p:nvSpPr>
         <p:spPr>
           <a:xfrm>
-            <a:off x="2897051" y="1627632"/>
-            <a:ext cx="4572" cy="329184"/>
+            <a:off x="2897051" y="1563624"/>
+            <a:ext cx="4572" cy="256032"/>
           </a:xfrm>
           <a:prstGeom prst="rect">
             <a:avLst/>
@@ -10623,8 +10624,8 @@
         </p:nvSpPr>
         <p:spPr>
           <a:xfrm>
-            <a:off x="2903065" y="1627632"/>
-            <a:ext cx="10187" cy="329184"/>
+            <a:off x="2903065" y="1563624"/>
+            <a:ext cx="10187" cy="256032"/>
           </a:xfrm>
           <a:prstGeom prst="rect">
             <a:avLst/>
@@ -10643,8 +10644,8 @@
         </p:nvSpPr>
         <p:spPr>
           <a:xfrm>
-            <a:off x="2915304" y="1627632"/>
-            <a:ext cx="4572" cy="329184"/>
+            <a:off x="2915304" y="1563624"/>
+            <a:ext cx="4572" cy="256032"/>
           </a:xfrm>
           <a:prstGeom prst="rect">
             <a:avLst/>
@@ -10663,8 +10664,8 @@
         </p:nvSpPr>
         <p:spPr>
           <a:xfrm>
-            <a:off x="2921105" y="1627632"/>
-            <a:ext cx="4572" cy="329184"/>
+            <a:off x="2921105" y="1563624"/>
+            <a:ext cx="4572" cy="256032"/>
           </a:xfrm>
           <a:prstGeom prst="rect">
             <a:avLst/>
@@ -10683,8 +10684,8 @@
         </p:nvSpPr>
         <p:spPr>
           <a:xfrm>
-            <a:off x="2923651" y="1627632"/>
-            <a:ext cx="13583" cy="329184"/>
+            <a:off x="2923651" y="1563624"/>
+            <a:ext cx="13583" cy="256032"/>
           </a:xfrm>
           <a:prstGeom prst="rect">
             <a:avLst/>
@@ -10703,8 +10704,8 @@
         </p:nvSpPr>
         <p:spPr>
           <a:xfrm>
-            <a:off x="2937800" y="1627632"/>
-            <a:ext cx="7428" cy="329184"/>
+            <a:off x="2937800" y="1563624"/>
+            <a:ext cx="7428" cy="256032"/>
           </a:xfrm>
           <a:prstGeom prst="rect">
             <a:avLst/>
@@ -10723,8 +10724,8 @@
         </p:nvSpPr>
         <p:spPr>
           <a:xfrm>
-            <a:off x="2948129" y="1627632"/>
-            <a:ext cx="4572" cy="329184"/>
+            <a:off x="2948129" y="1563624"/>
+            <a:ext cx="4572" cy="256032"/>
           </a:xfrm>
           <a:prstGeom prst="rect">
             <a:avLst/>
@@ -10743,8 +10744,8 @@
         </p:nvSpPr>
         <p:spPr>
           <a:xfrm>
-            <a:off x="2950888" y="1627632"/>
-            <a:ext cx="4572" cy="329184"/>
+            <a:off x="2950888" y="1563624"/>
+            <a:ext cx="4572" cy="256032"/>
           </a:xfrm>
           <a:prstGeom prst="rect">
             <a:avLst/>
@@ -10763,8 +10764,8 @@
         </p:nvSpPr>
         <p:spPr>
           <a:xfrm>
-            <a:off x="2954001" y="1627632"/>
-            <a:ext cx="10187" cy="329184"/>
+            <a:off x="2954001" y="1563624"/>
+            <a:ext cx="10187" cy="256032"/>
           </a:xfrm>
           <a:prstGeom prst="rect">
             <a:avLst/>
@@ -10783,8 +10784,8 @@
         </p:nvSpPr>
         <p:spPr>
           <a:xfrm>
-            <a:off x="2966523" y="1627632"/>
-            <a:ext cx="4572" cy="329184"/>
+            <a:off x="2966523" y="1563624"/>
+            <a:ext cx="4572" cy="256032"/>
           </a:xfrm>
           <a:prstGeom prst="rect">
             <a:avLst/>
@@ -10803,8 +10804,8 @@
         </p:nvSpPr>
         <p:spPr>
           <a:xfrm>
-            <a:off x="2972111" y="1627632"/>
-            <a:ext cx="9975" cy="329184"/>
+            <a:off x="2972111" y="1563624"/>
+            <a:ext cx="9975" cy="256032"/>
           </a:xfrm>
           <a:prstGeom prst="rect">
             <a:avLst/>
@@ -10823,8 +10824,8 @@
         </p:nvSpPr>
         <p:spPr>
           <a:xfrm>
-            <a:off x="2984280" y="1627632"/>
-            <a:ext cx="4572" cy="329184"/>
+            <a:off x="2984280" y="1563624"/>
+            <a:ext cx="4572" cy="256032"/>
           </a:xfrm>
           <a:prstGeom prst="rect">
             <a:avLst/>
@@ -10843,8 +10844,8 @@
         </p:nvSpPr>
         <p:spPr>
           <a:xfrm>
-            <a:off x="2989939" y="1627632"/>
-            <a:ext cx="23841" cy="329184"/>
+            <a:off x="2989939" y="1563624"/>
+            <a:ext cx="23841" cy="256032"/>
           </a:xfrm>
           <a:prstGeom prst="rect">
             <a:avLst/>
@@ -10863,8 +10864,8 @@
         </p:nvSpPr>
         <p:spPr>
           <a:xfrm>
-            <a:off x="3016751" y="1627632"/>
-            <a:ext cx="4572" cy="329184"/>
+            <a:off x="3016751" y="1563624"/>
+            <a:ext cx="4572" cy="256032"/>
           </a:xfrm>
           <a:prstGeom prst="rect">
             <a:avLst/>
@@ -10883,8 +10884,8 @@
         </p:nvSpPr>
         <p:spPr>
           <a:xfrm>
-            <a:off x="3021916" y="1627632"/>
-            <a:ext cx="9904" cy="329184"/>
+            <a:off x="3021916" y="1563624"/>
+            <a:ext cx="9904" cy="256032"/>
           </a:xfrm>
           <a:prstGeom prst="rect">
             <a:avLst/>
@@ -10903,8 +10904,8 @@
         </p:nvSpPr>
         <p:spPr>
           <a:xfrm>
-            <a:off x="3034013" y="1627632"/>
-            <a:ext cx="4572" cy="329184"/>
+            <a:off x="3034013" y="1563624"/>
+            <a:ext cx="4572" cy="256032"/>
           </a:xfrm>
           <a:prstGeom prst="rect">
             <a:avLst/>
@@ -10923,8 +10924,8 @@
         </p:nvSpPr>
         <p:spPr>
           <a:xfrm>
-            <a:off x="3039673" y="1627632"/>
-            <a:ext cx="9551" cy="329184"/>
+            <a:off x="3039673" y="1563624"/>
+            <a:ext cx="9551" cy="256032"/>
           </a:xfrm>
           <a:prstGeom prst="rect">
             <a:avLst/>
@@ -10943,8 +10944,8 @@
         </p:nvSpPr>
         <p:spPr>
           <a:xfrm>
-            <a:off x="3052407" y="1627632"/>
-            <a:ext cx="4572" cy="329184"/>
+            <a:off x="3052407" y="1563624"/>
+            <a:ext cx="4572" cy="256032"/>
           </a:xfrm>
           <a:prstGeom prst="rect">
             <a:avLst/>
@@ -10963,8 +10964,8 @@
         </p:nvSpPr>
         <p:spPr>
           <a:xfrm>
-            <a:off x="3057642" y="1627632"/>
-            <a:ext cx="21153" cy="329184"/>
+            <a:off x="3057642" y="1563624"/>
+            <a:ext cx="21153" cy="256032"/>
           </a:xfrm>
           <a:prstGeom prst="rect">
             <a:avLst/>
@@ -10983,8 +10984,8 @@
         </p:nvSpPr>
         <p:spPr>
           <a:xfrm>
-            <a:off x="3080987" y="1627632"/>
-            <a:ext cx="4572" cy="329184"/>
+            <a:off x="3080987" y="1563624"/>
+            <a:ext cx="4572" cy="256032"/>
           </a:xfrm>
           <a:prstGeom prst="rect">
             <a:avLst/>
@@ -11003,8 +11004,8 @@
         </p:nvSpPr>
         <p:spPr>
           <a:xfrm>
-            <a:off x="3086435" y="1627632"/>
-            <a:ext cx="9197" cy="329184"/>
+            <a:off x="3086435" y="1563624"/>
+            <a:ext cx="9197" cy="256032"/>
           </a:xfrm>
           <a:prstGeom prst="rect">
             <a:avLst/>
@@ -11023,8 +11024,8 @@
         </p:nvSpPr>
         <p:spPr>
           <a:xfrm>
-            <a:off x="3096410" y="1627632"/>
-            <a:ext cx="4572" cy="329184"/>
+            <a:off x="3096410" y="1563624"/>
+            <a:ext cx="4572" cy="256032"/>
           </a:xfrm>
           <a:prstGeom prst="rect">
             <a:avLst/>
@@ -11043,8 +11044,8 @@
         </p:nvSpPr>
         <p:spPr>
           <a:xfrm>
-            <a:off x="3102564" y="1627632"/>
-            <a:ext cx="8560" cy="329184"/>
+            <a:off x="3102564" y="1563624"/>
+            <a:ext cx="8560" cy="256032"/>
           </a:xfrm>
           <a:prstGeom prst="rect">
             <a:avLst/>
@@ -11063,8 +11064,8 @@
         </p:nvSpPr>
         <p:spPr>
           <a:xfrm>
-            <a:off x="3111832" y="1627632"/>
-            <a:ext cx="4572" cy="329184"/>
+            <a:off x="3111832" y="1563624"/>
+            <a:ext cx="4572" cy="256032"/>
           </a:xfrm>
           <a:prstGeom prst="rect">
             <a:avLst/>
@@ -11083,8 +11084,8 @@
         </p:nvSpPr>
         <p:spPr>
           <a:xfrm>
-            <a:off x="3117562" y="1627632"/>
-            <a:ext cx="35089" cy="329184"/>
+            <a:off x="3117562" y="1563624"/>
+            <a:ext cx="35089" cy="256032"/>
           </a:xfrm>
           <a:prstGeom prst="rect">
             <a:avLst/>
@@ -11103,8 +11104,8 @@
         </p:nvSpPr>
         <p:spPr>
           <a:xfrm>
-            <a:off x="3154067" y="1627632"/>
-            <a:ext cx="4740" cy="329184"/>
+            <a:off x="3154067" y="1563624"/>
+            <a:ext cx="4740" cy="256032"/>
           </a:xfrm>
           <a:prstGeom prst="rect">
             <a:avLst/>
@@ -11123,8 +11124,8 @@
         </p:nvSpPr>
         <p:spPr>
           <a:xfrm>
-            <a:off x="3160292" y="1627632"/>
-            <a:ext cx="4572" cy="329184"/>
+            <a:off x="3160292" y="1563624"/>
+            <a:ext cx="4572" cy="256032"/>
           </a:xfrm>
           <a:prstGeom prst="rect">
             <a:avLst/>
@@ -11143,8 +11144,8 @@
         </p:nvSpPr>
         <p:spPr>
           <a:xfrm>
-            <a:off x="3162697" y="1627632"/>
-            <a:ext cx="10258" cy="329184"/>
+            <a:off x="3162697" y="1563624"/>
+            <a:ext cx="10258" cy="256032"/>
           </a:xfrm>
           <a:prstGeom prst="rect">
             <a:avLst/>
@@ -11163,8 +11164,8 @@
         </p:nvSpPr>
         <p:spPr>
           <a:xfrm>
-            <a:off x="3173875" y="1627632"/>
-            <a:ext cx="2551686" cy="329184"/>
+            <a:off x="3173875" y="1563624"/>
+            <a:ext cx="2551686" cy="256032"/>
           </a:xfrm>
           <a:prstGeom prst="rect">
             <a:avLst/>
@@ -11183,8 +11184,8 @@
         </p:nvSpPr>
         <p:spPr>
           <a:xfrm>
-            <a:off x="5727896" y="1627632"/>
-            <a:ext cx="536315" cy="329184"/>
+            <a:off x="5727896" y="1563624"/>
+            <a:ext cx="536315" cy="256032"/>
           </a:xfrm>
           <a:prstGeom prst="rect">
             <a:avLst/>
@@ -11203,8 +11204,8 @@
         </p:nvSpPr>
         <p:spPr>
           <a:xfrm>
-            <a:off x="6266191" y="1627632"/>
-            <a:ext cx="12663" cy="329184"/>
+            <a:off x="6266191" y="1563624"/>
+            <a:ext cx="12663" cy="256032"/>
           </a:xfrm>
           <a:prstGeom prst="rect">
             <a:avLst/>
@@ -11223,8 +11224,8 @@
         </p:nvSpPr>
         <p:spPr>
           <a:xfrm>
-            <a:off x="6285292" y="1627632"/>
-            <a:ext cx="4572" cy="329184"/>
+            <a:off x="6285292" y="1563624"/>
+            <a:ext cx="4572" cy="256032"/>
           </a:xfrm>
           <a:prstGeom prst="rect">
             <a:avLst/>
@@ -11243,8 +11244,8 @@
         </p:nvSpPr>
         <p:spPr>
           <a:xfrm>
-            <a:off x="6290103" y="1627632"/>
-            <a:ext cx="4572" cy="329184"/>
+            <a:off x="6290103" y="1563624"/>
+            <a:ext cx="4572" cy="256032"/>
           </a:xfrm>
           <a:prstGeom prst="rect">
             <a:avLst/>
@@ -11263,8 +11264,8 @@
         </p:nvSpPr>
         <p:spPr>
           <a:xfrm>
-            <a:off x="6292013" y="1627632"/>
-            <a:ext cx="4572" cy="329184"/>
+            <a:off x="6292013" y="1563624"/>
+            <a:ext cx="4572" cy="256032"/>
           </a:xfrm>
           <a:prstGeom prst="rect">
             <a:avLst/>
@@ -11283,8 +11284,8 @@
         </p:nvSpPr>
         <p:spPr>
           <a:xfrm>
-            <a:off x="6296965" y="1627632"/>
-            <a:ext cx="8702" cy="329184"/>
+            <a:off x="6296965" y="1563624"/>
+            <a:ext cx="8702" cy="256032"/>
           </a:xfrm>
           <a:prstGeom prst="rect">
             <a:avLst/>
@@ -11303,8 +11304,8 @@
         </p:nvSpPr>
         <p:spPr>
           <a:xfrm>
-            <a:off x="6306657" y="1627632"/>
-            <a:ext cx="20940" cy="329184"/>
+            <a:off x="6306657" y="1563624"/>
+            <a:ext cx="20940" cy="256032"/>
           </a:xfrm>
           <a:prstGeom prst="rect">
             <a:avLst/>
@@ -11323,8 +11324,8 @@
         </p:nvSpPr>
         <p:spPr>
           <a:xfrm>
-            <a:off x="6328163" y="1627632"/>
-            <a:ext cx="4572" cy="329184"/>
+            <a:off x="6328163" y="1563624"/>
+            <a:ext cx="4572" cy="256032"/>
           </a:xfrm>
           <a:prstGeom prst="rect">
             <a:avLst/>
@@ -11343,8 +11344,8 @@
         </p:nvSpPr>
         <p:spPr>
           <a:xfrm>
-            <a:off x="6330073" y="1627632"/>
-            <a:ext cx="4572" cy="329184"/>
+            <a:off x="6330073" y="1563624"/>
+            <a:ext cx="4572" cy="256032"/>
           </a:xfrm>
           <a:prstGeom prst="rect">
             <a:avLst/>
@@ -11363,8 +11364,8 @@
         </p:nvSpPr>
         <p:spPr>
           <a:xfrm>
-            <a:off x="6335308" y="1627632"/>
-            <a:ext cx="40466" cy="329184"/>
+            <a:off x="6335308" y="1563624"/>
+            <a:ext cx="40466" cy="256032"/>
           </a:xfrm>
           <a:prstGeom prst="rect">
             <a:avLst/>
@@ -11383,8 +11384,8 @@
         </p:nvSpPr>
         <p:spPr>
           <a:xfrm>
-            <a:off x="6379029" y="1627632"/>
-            <a:ext cx="4598" cy="329184"/>
+            <a:off x="6379029" y="1563624"/>
+            <a:ext cx="4598" cy="256032"/>
           </a:xfrm>
           <a:prstGeom prst="rect">
             <a:avLst/>
@@ -11403,8 +11404,8 @@
         </p:nvSpPr>
         <p:spPr>
           <a:xfrm>
-            <a:off x="6385396" y="1627632"/>
-            <a:ext cx="4572" cy="329184"/>
+            <a:off x="6385396" y="1563624"/>
+            <a:ext cx="4572" cy="256032"/>
           </a:xfrm>
           <a:prstGeom prst="rect">
             <a:avLst/>
@@ -11423,8 +11424,8 @@
         </p:nvSpPr>
         <p:spPr>
           <a:xfrm>
-            <a:off x="6387306" y="1627632"/>
-            <a:ext cx="4572" cy="329184"/>
+            <a:off x="6387306" y="1563624"/>
+            <a:ext cx="4572" cy="256032"/>
           </a:xfrm>
           <a:prstGeom prst="rect">
             <a:avLst/>
@@ -11443,8 +11444,8 @@
         </p:nvSpPr>
         <p:spPr>
           <a:xfrm>
-            <a:off x="6389994" y="1627632"/>
-            <a:ext cx="4572" cy="329184"/>
+            <a:off x="6389994" y="1563624"/>
+            <a:ext cx="4572" cy="256032"/>
           </a:xfrm>
           <a:prstGeom prst="rect">
             <a:avLst/>
@@ -11463,8 +11464,8 @@
         </p:nvSpPr>
         <p:spPr>
           <a:xfrm>
-            <a:off x="6392046" y="1627632"/>
-            <a:ext cx="12522" cy="329184"/>
+            <a:off x="6392046" y="1563624"/>
+            <a:ext cx="12522" cy="256032"/>
           </a:xfrm>
           <a:prstGeom prst="rect">
             <a:avLst/>
@@ -11483,8 +11484,8 @@
         </p:nvSpPr>
         <p:spPr>
           <a:xfrm>
-            <a:off x="6411430" y="1627632"/>
-            <a:ext cx="4572" cy="329184"/>
+            <a:off x="6411430" y="1563624"/>
+            <a:ext cx="4572" cy="256032"/>
           </a:xfrm>
           <a:prstGeom prst="rect">
             <a:avLst/>
@@ -11503,8 +11504,8 @@
         </p:nvSpPr>
         <p:spPr>
           <a:xfrm>
-            <a:off x="6415108" y="1627632"/>
-            <a:ext cx="4572" cy="329184"/>
+            <a:off x="6415108" y="1563624"/>
+            <a:ext cx="4572" cy="256032"/>
           </a:xfrm>
           <a:prstGeom prst="rect">
             <a:avLst/>
@@ -11523,8 +11524,8 @@
         </p:nvSpPr>
         <p:spPr>
           <a:xfrm>
-            <a:off x="6416806" y="1627632"/>
-            <a:ext cx="4572" cy="329184"/>
+            <a:off x="6416806" y="1563624"/>
+            <a:ext cx="4572" cy="256032"/>
           </a:xfrm>
           <a:prstGeom prst="rect">
             <a:avLst/>
@@ -11543,8 +11544,8 @@
         </p:nvSpPr>
         <p:spPr>
           <a:xfrm>
-            <a:off x="6419495" y="1627632"/>
-            <a:ext cx="4572" cy="329184"/>
+            <a:off x="6419495" y="1563624"/>
+            <a:ext cx="4572" cy="256032"/>
           </a:xfrm>
           <a:prstGeom prst="rect">
             <a:avLst/>
@@ -11563,8 +11564,8 @@
         </p:nvSpPr>
         <p:spPr>
           <a:xfrm>
-            <a:off x="6421546" y="1627632"/>
-            <a:ext cx="12451" cy="329184"/>
+            <a:off x="6421546" y="1563624"/>
+            <a:ext cx="12451" cy="256032"/>
           </a:xfrm>
           <a:prstGeom prst="rect">
             <a:avLst/>
@@ -11583,8 +11584,8 @@
         </p:nvSpPr>
         <p:spPr>
           <a:xfrm>
-            <a:off x="6435554" y="1627632"/>
-            <a:ext cx="21153" cy="329184"/>
+            <a:off x="6435554" y="1563624"/>
+            <a:ext cx="21153" cy="256032"/>
           </a:xfrm>
           <a:prstGeom prst="rect">
             <a:avLst/>
@@ -11603,8 +11604,8 @@
         </p:nvSpPr>
         <p:spPr>
           <a:xfrm>
-            <a:off x="6457484" y="1627632"/>
-            <a:ext cx="20162" cy="329184"/>
+            <a:off x="6457484" y="1563624"/>
+            <a:ext cx="20162" cy="256032"/>
           </a:xfrm>
           <a:prstGeom prst="rect">
             <a:avLst/>
@@ -11623,8 +11624,8 @@
         </p:nvSpPr>
         <p:spPr>
           <a:xfrm>
-            <a:off x="6478354" y="1627632"/>
-            <a:ext cx="13017" cy="329184"/>
+            <a:off x="6478354" y="1563624"/>
+            <a:ext cx="13017" cy="256032"/>
           </a:xfrm>
           <a:prstGeom prst="rect">
             <a:avLst/>
@@ -11643,8 +11644,8 @@
         </p:nvSpPr>
         <p:spPr>
           <a:xfrm>
-            <a:off x="6492149" y="1627632"/>
-            <a:ext cx="4572" cy="329184"/>
+            <a:off x="6492149" y="1563624"/>
+            <a:ext cx="4572" cy="256032"/>
           </a:xfrm>
           <a:prstGeom prst="rect">
             <a:avLst/>
@@ -11663,8 +11664,8 @@
         </p:nvSpPr>
         <p:spPr>
           <a:xfrm>
-            <a:off x="6493918" y="1627632"/>
-            <a:ext cx="4740" cy="329184"/>
+            <a:off x="6493918" y="1563624"/>
+            <a:ext cx="4740" cy="256032"/>
           </a:xfrm>
           <a:prstGeom prst="rect">
             <a:avLst/>
@@ -11683,8 +11684,8 @@
         </p:nvSpPr>
         <p:spPr>
           <a:xfrm>
-            <a:off x="6500002" y="1627632"/>
-            <a:ext cx="12451" cy="329184"/>
+            <a:off x="6500002" y="1563624"/>
+            <a:ext cx="12451" cy="256032"/>
           </a:xfrm>
           <a:prstGeom prst="rect">
             <a:avLst/>
@@ -11703,8 +11704,8 @@
         </p:nvSpPr>
         <p:spPr>
           <a:xfrm>
-            <a:off x="6513160" y="1627632"/>
-            <a:ext cx="4572" cy="329184"/>
+            <a:off x="6513160" y="1563624"/>
+            <a:ext cx="4572" cy="256032"/>
           </a:xfrm>
           <a:prstGeom prst="rect">
             <a:avLst/>
@@ -11723,8 +11724,8 @@
         </p:nvSpPr>
         <p:spPr>
           <a:xfrm>
-            <a:off x="6514787" y="1627632"/>
-            <a:ext cx="4598" cy="329184"/>
+            <a:off x="6514787" y="1563624"/>
+            <a:ext cx="4598" cy="256032"/>
           </a:xfrm>
           <a:prstGeom prst="rect">
             <a:avLst/>
@@ -11743,8 +11744,8 @@
         </p:nvSpPr>
         <p:spPr>
           <a:xfrm>
-            <a:off x="6520659" y="1627632"/>
-            <a:ext cx="12097" cy="329184"/>
+            <a:off x="6520659" y="1563624"/>
+            <a:ext cx="12097" cy="256032"/>
           </a:xfrm>
           <a:prstGeom prst="rect">
             <a:avLst/>
@@ -11763,8 +11764,8 @@
         </p:nvSpPr>
         <p:spPr>
           <a:xfrm>
-            <a:off x="6533323" y="1627632"/>
-            <a:ext cx="4572" cy="329184"/>
+            <a:off x="6533323" y="1563624"/>
+            <a:ext cx="4572" cy="256032"/>
           </a:xfrm>
           <a:prstGeom prst="rect">
             <a:avLst/>
@@ -11783,8 +11784,8 @@
         </p:nvSpPr>
         <p:spPr>
           <a:xfrm>
-            <a:off x="6535020" y="1627632"/>
-            <a:ext cx="4572" cy="329184"/>
+            <a:off x="6535020" y="1563624"/>
+            <a:ext cx="4572" cy="256032"/>
           </a:xfrm>
           <a:prstGeom prst="rect">
             <a:avLst/>
@@ -11803,8 +11804,8 @@
         </p:nvSpPr>
         <p:spPr>
           <a:xfrm>
-            <a:off x="6540751" y="1627632"/>
-            <a:ext cx="4572" cy="329184"/>
+            <a:off x="6540751" y="1563624"/>
+            <a:ext cx="4572" cy="256032"/>
           </a:xfrm>
           <a:prstGeom prst="rect">
             <a:avLst/>
@@ -11823,8 +11824,8 @@
         </p:nvSpPr>
         <p:spPr>
           <a:xfrm>
-            <a:off x="6544076" y="1627632"/>
-            <a:ext cx="4572" cy="329184"/>
+            <a:off x="6544076" y="1563624"/>
+            <a:ext cx="4572" cy="256032"/>
           </a:xfrm>
           <a:prstGeom prst="rect">
             <a:avLst/>
@@ -11843,8 +11844,8 @@
         </p:nvSpPr>
         <p:spPr>
           <a:xfrm>
-            <a:off x="6546623" y="1627632"/>
-            <a:ext cx="4572" cy="329184"/>
+            <a:off x="6546623" y="1563624"/>
+            <a:ext cx="4572" cy="256032"/>
           </a:xfrm>
           <a:prstGeom prst="rect">
             <a:avLst/>
@@ -11863,8 +11864,8 @@
         </p:nvSpPr>
         <p:spPr>
           <a:xfrm>
-            <a:off x="6549877" y="1627632"/>
-            <a:ext cx="4572" cy="329184"/>
+            <a:off x="6549877" y="1563624"/>
+            <a:ext cx="4572" cy="256032"/>
           </a:xfrm>
           <a:prstGeom prst="rect">
             <a:avLst/>
@@ -11883,8 +11884,8 @@
         </p:nvSpPr>
         <p:spPr>
           <a:xfrm>
-            <a:off x="6551716" y="1627632"/>
-            <a:ext cx="6650" cy="329184"/>
+            <a:off x="6551716" y="1563624"/>
+            <a:ext cx="6650" cy="256032"/>
           </a:xfrm>
           <a:prstGeom prst="rect">
             <a:avLst/>
@@ -11903,8 +11904,8 @@
         </p:nvSpPr>
         <p:spPr>
           <a:xfrm>
-            <a:off x="6561196" y="1627632"/>
-            <a:ext cx="4572" cy="329184"/>
+            <a:off x="6561196" y="1563624"/>
+            <a:ext cx="4572" cy="256032"/>
           </a:xfrm>
           <a:prstGeom prst="rect">
             <a:avLst/>
@@ -11923,8 +11924,8 @@
         </p:nvSpPr>
         <p:spPr>
           <a:xfrm>
-            <a:off x="6585956" y="1627632"/>
-            <a:ext cx="4572" cy="329184"/>
+            <a:off x="6585956" y="1563624"/>
+            <a:ext cx="4572" cy="256032"/>
           </a:xfrm>
           <a:prstGeom prst="rect">
             <a:avLst/>
@@ -11943,8 +11944,8 @@
         </p:nvSpPr>
         <p:spPr>
           <a:xfrm>
-            <a:off x="6591050" y="1627632"/>
-            <a:ext cx="11531" cy="329184"/>
+            <a:off x="6591050" y="1563624"/>
+            <a:ext cx="11531" cy="256032"/>
           </a:xfrm>
           <a:prstGeom prst="rect">
             <a:avLst/>
@@ -11963,8 +11964,8 @@
         </p:nvSpPr>
         <p:spPr>
           <a:xfrm>
-            <a:off x="6603218" y="1627632"/>
-            <a:ext cx="5306" cy="329184"/>
+            <a:off x="6603218" y="1563624"/>
+            <a:ext cx="5306" cy="256032"/>
           </a:xfrm>
           <a:prstGeom prst="rect">
             <a:avLst/>
@@ -11983,8 +11984,8 @@
         </p:nvSpPr>
         <p:spPr>
           <a:xfrm>
-            <a:off x="6609656" y="1627632"/>
-            <a:ext cx="15422" cy="329184"/>
+            <a:off x="6609656" y="1563624"/>
+            <a:ext cx="15422" cy="256032"/>
           </a:xfrm>
           <a:prstGeom prst="rect">
             <a:avLst/>
@@ -12003,8 +12004,8 @@
         </p:nvSpPr>
         <p:spPr>
           <a:xfrm>
-            <a:off x="6626069" y="1627632"/>
-            <a:ext cx="15352" cy="329184"/>
+            <a:off x="6626069" y="1563624"/>
+            <a:ext cx="15352" cy="256032"/>
           </a:xfrm>
           <a:prstGeom prst="rect">
             <a:avLst/>
@@ -12023,8 +12024,8 @@
         </p:nvSpPr>
         <p:spPr>
           <a:xfrm>
-            <a:off x="6642340" y="1627632"/>
-            <a:ext cx="15493" cy="329184"/>
+            <a:off x="6642340" y="1563624"/>
+            <a:ext cx="15493" cy="256032"/>
           </a:xfrm>
           <a:prstGeom prst="rect">
             <a:avLst/>
@@ -12043,8 +12044,8 @@
         </p:nvSpPr>
         <p:spPr>
           <a:xfrm>
-            <a:off x="6658965" y="1627632"/>
-            <a:ext cx="15564" cy="329184"/>
+            <a:off x="6658965" y="1563624"/>
+            <a:ext cx="15564" cy="256032"/>
           </a:xfrm>
           <a:prstGeom prst="rect">
             <a:avLst/>
@@ -12063,8 +12064,8 @@
         </p:nvSpPr>
         <p:spPr>
           <a:xfrm>
-            <a:off x="6675590" y="1627632"/>
-            <a:ext cx="16342" cy="329184"/>
+            <a:off x="6675590" y="1563624"/>
+            <a:ext cx="16342" cy="256032"/>
           </a:xfrm>
           <a:prstGeom prst="rect">
             <a:avLst/>
@@ -12083,8 +12084,8 @@
         </p:nvSpPr>
         <p:spPr>
           <a:xfrm>
-            <a:off x="6692993" y="1627632"/>
-            <a:ext cx="15635" cy="329184"/>
+            <a:off x="6692993" y="1563624"/>
+            <a:ext cx="15635" cy="256032"/>
           </a:xfrm>
           <a:prstGeom prst="rect">
             <a:avLst/>
@@ -12103,8 +12104,8 @@
         </p:nvSpPr>
         <p:spPr>
           <a:xfrm>
-            <a:off x="6709689" y="1627632"/>
-            <a:ext cx="15139" cy="329184"/>
+            <a:off x="6709689" y="1563624"/>
+            <a:ext cx="15139" cy="256032"/>
           </a:xfrm>
           <a:prstGeom prst="rect">
             <a:avLst/>
@@ -12123,8 +12124,8 @@
         </p:nvSpPr>
         <p:spPr>
           <a:xfrm>
-            <a:off x="6725748" y="1627632"/>
-            <a:ext cx="14503" cy="329184"/>
+            <a:off x="6725748" y="1563624"/>
+            <a:ext cx="14503" cy="256032"/>
           </a:xfrm>
           <a:prstGeom prst="rect">
             <a:avLst/>
@@ -12143,8 +12144,8 @@
         </p:nvSpPr>
         <p:spPr>
           <a:xfrm>
-            <a:off x="6742656" y="1627632"/>
-            <a:ext cx="15705" cy="329184"/>
+            <a:off x="6742656" y="1563624"/>
+            <a:ext cx="15705" cy="256032"/>
           </a:xfrm>
           <a:prstGeom prst="rect">
             <a:avLst/>
@@ -12163,8 +12164,8 @@
         </p:nvSpPr>
         <p:spPr>
           <a:xfrm>
-            <a:off x="6759422" y="1627632"/>
-            <a:ext cx="15281" cy="329184"/>
+            <a:off x="6759422" y="1563624"/>
+            <a:ext cx="15281" cy="256032"/>
           </a:xfrm>
           <a:prstGeom prst="rect">
             <a:avLst/>
@@ -12183,8 +12184,8 @@
         </p:nvSpPr>
         <p:spPr>
           <a:xfrm>
-            <a:off x="6775623" y="1627632"/>
-            <a:ext cx="15281" cy="329184"/>
+            <a:off x="6775623" y="1563624"/>
+            <a:ext cx="15281" cy="256032"/>
           </a:xfrm>
           <a:prstGeom prst="rect">
             <a:avLst/>
@@ -12203,8 +12204,8 @@
         </p:nvSpPr>
         <p:spPr>
           <a:xfrm>
-            <a:off x="6791823" y="1627632"/>
-            <a:ext cx="15069" cy="329184"/>
+            <a:off x="6791823" y="1563624"/>
+            <a:ext cx="15069" cy="256032"/>
           </a:xfrm>
           <a:prstGeom prst="rect">
             <a:avLst/>
@@ -12223,8 +12224,8 @@
         </p:nvSpPr>
         <p:spPr>
           <a:xfrm>
-            <a:off x="6807953" y="1627632"/>
-            <a:ext cx="15069" cy="329184"/>
+            <a:off x="6807953" y="1563624"/>
+            <a:ext cx="15069" cy="256032"/>
           </a:xfrm>
           <a:prstGeom prst="rect">
             <a:avLst/>
@@ -12243,8 +12244,8 @@
         </p:nvSpPr>
         <p:spPr>
           <a:xfrm>
-            <a:off x="6823941" y="1627632"/>
-            <a:ext cx="14927" cy="329184"/>
+            <a:off x="6823941" y="1563624"/>
+            <a:ext cx="14927" cy="256032"/>
           </a:xfrm>
           <a:prstGeom prst="rect">
             <a:avLst/>
@@ -12263,8 +12264,8 @@
         </p:nvSpPr>
         <p:spPr>
           <a:xfrm>
-            <a:off x="6839859" y="1627632"/>
-            <a:ext cx="14856" cy="329184"/>
+            <a:off x="6839859" y="1563624"/>
+            <a:ext cx="14856" cy="256032"/>
           </a:xfrm>
           <a:prstGeom prst="rect">
             <a:avLst/>
@@ -12283,8 +12284,8 @@
         </p:nvSpPr>
         <p:spPr>
           <a:xfrm>
-            <a:off x="6855706" y="1627632"/>
-            <a:ext cx="15069" cy="329184"/>
+            <a:off x="6855706" y="1563624"/>
+            <a:ext cx="15069" cy="256032"/>
           </a:xfrm>
           <a:prstGeom prst="rect">
             <a:avLst/>
@@ -12303,8 +12304,8 @@
         </p:nvSpPr>
         <p:spPr>
           <a:xfrm>
-            <a:off x="6871835" y="1627632"/>
-            <a:ext cx="14927" cy="329184"/>
+            <a:off x="6871835" y="1563624"/>
+            <a:ext cx="14927" cy="256032"/>
           </a:xfrm>
           <a:prstGeom prst="rect">
             <a:avLst/>
@@ -12323,8 +12324,8 @@
         </p:nvSpPr>
         <p:spPr>
           <a:xfrm>
-            <a:off x="6887611" y="1627632"/>
-            <a:ext cx="14998" cy="329184"/>
+            <a:off x="6887611" y="1563624"/>
+            <a:ext cx="14998" cy="256032"/>
           </a:xfrm>
           <a:prstGeom prst="rect">
             <a:avLst/>
@@ -12343,8 +12344,8 @@
         </p:nvSpPr>
         <p:spPr>
           <a:xfrm>
-            <a:off x="6903600" y="1627632"/>
-            <a:ext cx="10824" cy="329184"/>
+            <a:off x="6903600" y="1563624"/>
+            <a:ext cx="10824" cy="256032"/>
           </a:xfrm>
           <a:prstGeom prst="rect">
             <a:avLst/>
@@ -12363,8 +12364,8 @@
         </p:nvSpPr>
         <p:spPr>
           <a:xfrm>
-            <a:off x="6915202" y="1627632"/>
-            <a:ext cx="6721" cy="329184"/>
+            <a:off x="6915202" y="1563624"/>
+            <a:ext cx="6721" cy="256032"/>
           </a:xfrm>
           <a:prstGeom prst="rect">
             <a:avLst/>
@@ -12383,8 +12384,8 @@
         </p:nvSpPr>
         <p:spPr>
           <a:xfrm>
-            <a:off x="6922630" y="1627632"/>
-            <a:ext cx="17403" cy="329184"/>
+            <a:off x="6922630" y="1563624"/>
+            <a:ext cx="17403" cy="256032"/>
           </a:xfrm>
           <a:prstGeom prst="rect">
             <a:avLst/>
@@ -12403,8 +12404,8 @@
         </p:nvSpPr>
         <p:spPr>
           <a:xfrm>
-            <a:off x="6984956" y="1627632"/>
-            <a:ext cx="15352" cy="329184"/>
+            <a:off x="6984956" y="1563624"/>
+            <a:ext cx="15352" cy="256032"/>
           </a:xfrm>
           <a:prstGeom prst="rect">
             <a:avLst/>
@@ -12423,8 +12424,8 @@
         </p:nvSpPr>
         <p:spPr>
           <a:xfrm>
-            <a:off x="7061289" y="1627632"/>
-            <a:ext cx="67420" cy="329184"/>
+            <a:off x="7061289" y="1563624"/>
+            <a:ext cx="67420" cy="256032"/>
           </a:xfrm>
           <a:prstGeom prst="rect">
             <a:avLst/>
@@ -12443,8 +12444,8 @@
         </p:nvSpPr>
         <p:spPr>
           <a:xfrm>
-            <a:off x="7130902" y="1627632"/>
-            <a:ext cx="23558" cy="329184"/>
+            <a:off x="7130902" y="1563624"/>
+            <a:ext cx="23558" cy="256032"/>
           </a:xfrm>
           <a:prstGeom prst="rect">
             <a:avLst/>
@@ -12463,8 +12464,8 @@
         </p:nvSpPr>
         <p:spPr>
           <a:xfrm>
-            <a:off x="7158280" y="1627632"/>
-            <a:ext cx="127552" cy="329184"/>
+            <a:off x="7158280" y="1563624"/>
+            <a:ext cx="127552" cy="256032"/>
           </a:xfrm>
           <a:prstGeom prst="rect">
             <a:avLst/>
@@ -12483,8 +12484,8 @@
         </p:nvSpPr>
         <p:spPr>
           <a:xfrm>
-            <a:off x="7671816" y="1600200"/>
-            <a:ext cx="914400" cy="384048"/>
+            <a:off x="7671816" y="1536192"/>
+            <a:ext cx="914400" cy="310896"/>
           </a:xfrm>
           <a:prstGeom prst="rect">
             <a:avLst/>
@@ -12522,8 +12523,8 @@
         </p:nvSpPr>
         <p:spPr>
           <a:xfrm>
-            <a:off x="457200" y="2075688"/>
-            <a:ext cx="978408" cy="384048"/>
+            <a:off x="457200" y="1938528"/>
+            <a:ext cx="978408" cy="310896"/>
           </a:xfrm>
           <a:prstGeom prst="rect">
             <a:avLst/>
@@ -12561,8 +12562,8 @@
         </p:nvSpPr>
         <p:spPr>
           <a:xfrm>
-            <a:off x="1508760" y="2075688"/>
-            <a:ext cx="6126480" cy="384048"/>
+            <a:off x="1508760" y="1938528"/>
+            <a:ext cx="6126480" cy="310896"/>
           </a:xfrm>
           <a:prstGeom prst="rect">
             <a:avLst/>
@@ -12586,8 +12587,8 @@
         </p:nvSpPr>
         <p:spPr>
           <a:xfrm>
-            <a:off x="4308689" y="2103120"/>
-            <a:ext cx="27307" cy="329184"/>
+            <a:off x="4308689" y="1965960"/>
+            <a:ext cx="27307" cy="256032"/>
           </a:xfrm>
           <a:prstGeom prst="rect">
             <a:avLst/>
@@ -12606,8 +12607,8 @@
         </p:nvSpPr>
         <p:spPr>
           <a:xfrm>
-            <a:off x="4589615" y="2103120"/>
-            <a:ext cx="28510" cy="329184"/>
+            <a:off x="4589615" y="1965960"/>
+            <a:ext cx="28510" cy="256032"/>
           </a:xfrm>
           <a:prstGeom prst="rect">
             <a:avLst/>
@@ -12626,8 +12627,8 @@
         </p:nvSpPr>
         <p:spPr>
           <a:xfrm>
-            <a:off x="4879951" y="2103120"/>
-            <a:ext cx="27095" cy="329184"/>
+            <a:off x="4879951" y="1965960"/>
+            <a:ext cx="27095" cy="256032"/>
           </a:xfrm>
           <a:prstGeom prst="rect">
             <a:avLst/>
@@ -12646,8 +12647,8 @@
         </p:nvSpPr>
         <p:spPr>
           <a:xfrm>
-            <a:off x="5138240" y="2103120"/>
-            <a:ext cx="26812" cy="329184"/>
+            <a:off x="5138240" y="1965960"/>
+            <a:ext cx="26812" cy="256032"/>
           </a:xfrm>
           <a:prstGeom prst="rect">
             <a:avLst/>
@@ -12666,8 +12667,8 @@
         </p:nvSpPr>
         <p:spPr>
           <a:xfrm>
-            <a:off x="5418247" y="2103120"/>
-            <a:ext cx="28298" cy="329184"/>
+            <a:off x="5418247" y="1965960"/>
+            <a:ext cx="28298" cy="256032"/>
           </a:xfrm>
           <a:prstGeom prst="rect">
             <a:avLst/>
@@ -12686,8 +12687,8 @@
         </p:nvSpPr>
         <p:spPr>
           <a:xfrm>
-            <a:off x="5694433" y="2103120"/>
-            <a:ext cx="30774" cy="329184"/>
+            <a:off x="5694433" y="1965960"/>
+            <a:ext cx="30774" cy="256032"/>
           </a:xfrm>
           <a:prstGeom prst="rect">
             <a:avLst/>
@@ -12706,8 +12707,8 @@
         </p:nvSpPr>
         <p:spPr>
           <a:xfrm>
-            <a:off x="5801328" y="2103120"/>
-            <a:ext cx="40112" cy="329184"/>
+            <a:off x="5801328" y="1965960"/>
+            <a:ext cx="40112" cy="256032"/>
           </a:xfrm>
           <a:prstGeom prst="rect">
             <a:avLst/>
@@ -12726,8 +12727,8 @@
         </p:nvSpPr>
         <p:spPr>
           <a:xfrm>
-            <a:off x="5901291" y="2103120"/>
-            <a:ext cx="40466" cy="329184"/>
+            <a:off x="5901291" y="1965960"/>
+            <a:ext cx="40466" cy="256032"/>
           </a:xfrm>
           <a:prstGeom prst="rect">
             <a:avLst/>
@@ -12746,8 +12747,8 @@
         </p:nvSpPr>
         <p:spPr>
           <a:xfrm>
-            <a:off x="6006771" y="2103120"/>
-            <a:ext cx="40254" cy="329184"/>
+            <a:off x="6006771" y="1965960"/>
+            <a:ext cx="40254" cy="256032"/>
           </a:xfrm>
           <a:prstGeom prst="rect">
             <a:avLst/>
@@ -12766,8 +12767,8 @@
         </p:nvSpPr>
         <p:spPr>
           <a:xfrm>
-            <a:off x="6104681" y="2103120"/>
-            <a:ext cx="41103" cy="329184"/>
+            <a:off x="6104681" y="1965960"/>
+            <a:ext cx="41103" cy="256032"/>
           </a:xfrm>
           <a:prstGeom prst="rect">
             <a:avLst/>
@@ -12786,8 +12787,8 @@
         </p:nvSpPr>
         <p:spPr>
           <a:xfrm>
-            <a:off x="6204148" y="2103120"/>
-            <a:ext cx="40890" cy="329184"/>
+            <a:off x="6204148" y="1965960"/>
+            <a:ext cx="40890" cy="256032"/>
           </a:xfrm>
           <a:prstGeom prst="rect">
             <a:avLst/>
@@ -12806,8 +12807,8 @@
         </p:nvSpPr>
         <p:spPr>
           <a:xfrm>
-            <a:off x="6318825" y="2103120"/>
-            <a:ext cx="39900" cy="329184"/>
+            <a:off x="6318825" y="1965960"/>
+            <a:ext cx="39900" cy="256032"/>
           </a:xfrm>
           <a:prstGeom prst="rect">
             <a:avLst/>
@@ -12826,8 +12827,8 @@
         </p:nvSpPr>
         <p:spPr>
           <a:xfrm>
-            <a:off x="6448641" y="2103120"/>
-            <a:ext cx="29500" cy="329184"/>
+            <a:off x="6448641" y="1965960"/>
+            <a:ext cx="29500" cy="256032"/>
           </a:xfrm>
           <a:prstGeom prst="rect">
             <a:avLst/>
@@ -12846,8 +12847,8 @@
         </p:nvSpPr>
         <p:spPr>
           <a:xfrm>
-            <a:off x="6940033" y="2103120"/>
-            <a:ext cx="20233" cy="329184"/>
+            <a:off x="6940033" y="1965960"/>
+            <a:ext cx="20233" cy="256032"/>
           </a:xfrm>
           <a:prstGeom prst="rect">
             <a:avLst/>
@@ -12866,8 +12867,8 @@
         </p:nvSpPr>
         <p:spPr>
           <a:xfrm>
-            <a:off x="7011202" y="2103120"/>
-            <a:ext cx="33391" cy="329184"/>
+            <a:off x="7011202" y="1965960"/>
+            <a:ext cx="33391" cy="256032"/>
           </a:xfrm>
           <a:prstGeom prst="rect">
             <a:avLst/>
@@ -12886,8 +12887,8 @@
         </p:nvSpPr>
         <p:spPr>
           <a:xfrm>
-            <a:off x="7285833" y="2103120"/>
-            <a:ext cx="310498" cy="329184"/>
+            <a:off x="7285833" y="1965960"/>
+            <a:ext cx="310498" cy="256032"/>
           </a:xfrm>
           <a:prstGeom prst="rect">
             <a:avLst/>
@@ -12906,8 +12907,8 @@
         </p:nvSpPr>
         <p:spPr>
           <a:xfrm>
-            <a:off x="7671816" y="2075688"/>
-            <a:ext cx="914400" cy="384048"/>
+            <a:off x="7671816" y="1938528"/>
+            <a:ext cx="914400" cy="310896"/>
           </a:xfrm>
           <a:prstGeom prst="rect">
             <a:avLst/>
@@ -12945,8 +12946,8 @@
         </p:nvSpPr>
         <p:spPr>
           <a:xfrm>
-            <a:off x="3421693" y="1600200"/>
-            <a:ext cx="0" cy="859536"/>
+            <a:off x="3421693" y="1536192"/>
+            <a:ext cx="0" cy="713232"/>
           </a:xfrm>
           <a:prstGeom prst="line">
             <a:avLst/>
@@ -12968,8 +12969,8 @@
         </p:nvSpPr>
         <p:spPr>
           <a:xfrm>
-            <a:off x="7060794" y="1600200"/>
-            <a:ext cx="0" cy="859536"/>
+            <a:off x="7060794" y="1536192"/>
+            <a:ext cx="0" cy="713232"/>
           </a:xfrm>
           <a:prstGeom prst="line">
             <a:avLst/>
@@ -12991,7 +12992,7 @@
         </p:nvSpPr>
         <p:spPr>
           <a:xfrm>
-            <a:off x="1508760" y="2569464"/>
+            <a:off x="1508760" y="2359152"/>
             <a:ext cx="6126480" cy="0"/>
           </a:xfrm>
           <a:prstGeom prst="line">
@@ -13014,7 +13015,7 @@
         </p:nvSpPr>
         <p:spPr>
           <a:xfrm>
-            <a:off x="1508760" y="2569464"/>
+            <a:off x="1508760" y="2359152"/>
             <a:ext cx="0" cy="45720"/>
           </a:xfrm>
           <a:prstGeom prst="line">
@@ -13037,7 +13038,7 @@
         </p:nvSpPr>
         <p:spPr>
           <a:xfrm>
-            <a:off x="1234440" y="2615184"/>
+            <a:off x="1234440" y="2404872"/>
             <a:ext cx="548640" cy="182880"/>
           </a:xfrm>
           <a:prstGeom prst="rect">
@@ -13076,7 +13077,7 @@
         </p:nvSpPr>
         <p:spPr>
           <a:xfrm>
-            <a:off x="2923651" y="2569464"/>
+            <a:off x="2923651" y="2359152"/>
             <a:ext cx="0" cy="45720"/>
           </a:xfrm>
           <a:prstGeom prst="line">
@@ -13099,7 +13100,7 @@
         </p:nvSpPr>
         <p:spPr>
           <a:xfrm>
-            <a:off x="2649331" y="2615184"/>
+            <a:off x="2649331" y="2404872"/>
             <a:ext cx="548640" cy="182880"/>
           </a:xfrm>
           <a:prstGeom prst="rect">
@@ -13138,7 +13139,7 @@
         </p:nvSpPr>
         <p:spPr>
           <a:xfrm>
-            <a:off x="4338543" y="2569464"/>
+            <a:off x="4338543" y="2359152"/>
             <a:ext cx="0" cy="45720"/>
           </a:xfrm>
           <a:prstGeom prst="line">
@@ -13161,7 +13162,7 @@
         </p:nvSpPr>
         <p:spPr>
           <a:xfrm>
-            <a:off x="4064223" y="2615184"/>
+            <a:off x="4064223" y="2404872"/>
             <a:ext cx="548640" cy="182880"/>
           </a:xfrm>
           <a:prstGeom prst="rect">
@@ -13200,7 +13201,7 @@
         </p:nvSpPr>
         <p:spPr>
           <a:xfrm>
-            <a:off x="5753434" y="2569464"/>
+            <a:off x="5753434" y="2359152"/>
             <a:ext cx="0" cy="45720"/>
           </a:xfrm>
           <a:prstGeom prst="line">
@@ -13223,7 +13224,7 @@
         </p:nvSpPr>
         <p:spPr>
           <a:xfrm>
-            <a:off x="5479114" y="2615184"/>
+            <a:off x="5479114" y="2404872"/>
             <a:ext cx="548640" cy="182880"/>
           </a:xfrm>
           <a:prstGeom prst="rect">
@@ -13262,7 +13263,7 @@
         </p:nvSpPr>
         <p:spPr>
           <a:xfrm>
-            <a:off x="7168326" y="2569464"/>
+            <a:off x="7168326" y="2359152"/>
             <a:ext cx="0" cy="45720"/>
           </a:xfrm>
           <a:prstGeom prst="line">
@@ -13285,7 +13286,7 @@
         </p:nvSpPr>
         <p:spPr>
           <a:xfrm>
-            <a:off x="6894006" y="2615184"/>
+            <a:off x="6894006" y="2404872"/>
             <a:ext cx="548640" cy="182880"/>
           </a:xfrm>
           <a:prstGeom prst="rect">
@@ -13324,7 +13325,7 @@
         </p:nvSpPr>
         <p:spPr>
           <a:xfrm>
-            <a:off x="5806440" y="2770632"/>
+            <a:off x="5806440" y="2560320"/>
             <a:ext cx="1828800" cy="182880"/>
           </a:xfrm>
           <a:prstGeom prst="rect">
@@ -13363,14 +13364,14 @@
         </p:nvSpPr>
         <p:spPr>
           <a:xfrm>
-            <a:off x="457200" y="3090672"/>
-            <a:ext cx="45720" cy="475488"/>
-          </a:xfrm>
-          <a:prstGeom prst="rect">
-            <a:avLst/>
-          </a:prstGeom>
-          <a:solidFill>
-            <a:srgbClr val="76B900"/>
+            <a:off x="1700298" y="1600200"/>
+            <a:ext cx="182880" cy="182880"/>
+          </a:xfrm>
+          <a:prstGeom prst="ellipse">
+            <a:avLst/>
+          </a:prstGeom>
+          <a:solidFill>
+            <a:srgbClr val="1A1A1A"/>
           </a:solidFill>
           <a:ln/>
         </p:spPr>
@@ -13383,8 +13384,8 @@
         </p:nvSpPr>
         <p:spPr>
           <a:xfrm>
-            <a:off x="621792" y="3072384"/>
-            <a:ext cx="3840480" cy="548640"/>
+            <a:off x="1700298" y="1600200"/>
+            <a:ext cx="182880" cy="182880"/>
           </a:xfrm>
           <a:prstGeom prst="rect">
             <a:avLst/>
@@ -13393,71 +13394,116 @@
           <a:ln/>
         </p:spPr>
         <p:txBody>
-          <a:bodyPr wrap="square" lIns="0" tIns="0" rIns="0" bIns="0" rtlCol="0" anchor="t"/>
+          <a:bodyPr wrap="square" lIns="0" tIns="0" rIns="0" bIns="0" rtlCol="0" anchor="ctr"/>
           <a:lstStyle/>
           <a:p>
-            <a:pPr indent="0" marL="0">
+            <a:pPr algn="ctr" indent="0" marL="0">
               <a:buNone/>
             </a:pPr>
             <a:r>
-              <a:rPr lang="en-US" sz="1050" b="1" dirty="0">
+              <a:rPr lang="en-US" sz="850" b="1" dirty="0">
                 <a:solidFill>
-                  <a:srgbClr val="000000"/>
+                  <a:srgbClr val="FFFFFF"/>
                 </a:solidFill>
                 <a:latin typeface="NVIDIA Sans" pitchFamily="34" charset="0"/>
                 <a:ea typeface="NVIDIA Sans" pitchFamily="34" charset="-122"/>
                 <a:cs typeface="NVIDIA Sans" pitchFamily="34" charset="-120"/>
               </a:rPr>
-              <a:t>29% pure GPU idle — </a:t>
+              <a:t>2</a:t>
             </a:r>
-            <a:pPr indent="0" marL="0">
+            <a:endParaRPr lang="en-US" sz="850" dirty="0"/>
+          </a:p>
+        </p:txBody>
+      </p:sp>
+      <p:sp>
+        <p:nvSpPr>
+          <p:cNvPr id="234" name="Shape 232"/>
+          <p:cNvSpPr/>
+          <p:nvPr/>
+        </p:nvSpPr>
+        <p:spPr>
+          <a:xfrm>
+            <a:off x="2655350" y="1600200"/>
+            <a:ext cx="182880" cy="182880"/>
+          </a:xfrm>
+          <a:prstGeom prst="ellipse">
+            <a:avLst/>
+          </a:prstGeom>
+          <a:solidFill>
+            <a:srgbClr val="1A1A1A"/>
+          </a:solidFill>
+          <a:ln/>
+        </p:spPr>
+      </p:sp>
+      <p:sp>
+        <p:nvSpPr>
+          <p:cNvPr id="235" name="Text 233"/>
+          <p:cNvSpPr/>
+          <p:nvPr/>
+        </p:nvSpPr>
+        <p:spPr>
+          <a:xfrm>
+            <a:off x="2655350" y="1600200"/>
+            <a:ext cx="182880" cy="182880"/>
+          </a:xfrm>
+          <a:prstGeom prst="rect">
+            <a:avLst/>
+          </a:prstGeom>
+          <a:noFill/>
+          <a:ln/>
+        </p:spPr>
+        <p:txBody>
+          <a:bodyPr wrap="square" lIns="0" tIns="0" rIns="0" bIns="0" rtlCol="0" anchor="ctr"/>
+          <a:lstStyle/>
+          <a:p>
+            <a:pPr algn="ctr" indent="0" marL="0">
               <a:buNone/>
             </a:pPr>
             <a:r>
-              <a:rPr lang="en-US" sz="1050" dirty="0">
+              <a:rPr lang="en-US" sz="850" b="1" dirty="0">
                 <a:solidFill>
-                  <a:srgbClr val="5E5E5E"/>
+                  <a:srgbClr val="FFFFFF"/>
                 </a:solidFill>
                 <a:latin typeface="NVIDIA Sans" pitchFamily="34" charset="0"/>
                 <a:ea typeface="NVIDIA Sans" pitchFamily="34" charset="-122"/>
                 <a:cs typeface="NVIDIA Sans" pitchFamily="34" charset="-120"/>
               </a:rPr>
-              <a:t>254 ms with no kernel on any stream — the GPU waits for the CPU</a:t>
+              <a:t>4</a:t>
             </a:r>
-            <a:endParaRPr lang="en-US" sz="1050" dirty="0"/>
+            <a:endParaRPr lang="en-US" sz="850" dirty="0"/>
           </a:p>
         </p:txBody>
       </p:sp>
       <p:sp>
         <p:nvSpPr>
-          <p:cNvPr id="234" name="Shape 232"/>
-          <p:cNvSpPr/>
-          <p:nvPr/>
-        </p:nvSpPr>
-        <p:spPr>
-          <a:xfrm>
-            <a:off x="4663440" y="3090672"/>
-            <a:ext cx="45720" cy="475488"/>
-          </a:xfrm>
-          <a:prstGeom prst="rect">
-            <a:avLst/>
-          </a:prstGeom>
-          <a:solidFill>
-            <a:srgbClr val="76B900"/>
-          </a:solidFill>
-          <a:ln/>
-        </p:spPr>
-      </p:sp>
-      <p:sp>
-        <p:nvSpPr>
-          <p:cNvPr id="235" name="Text 233"/>
-          <p:cNvSpPr/>
-          <p:nvPr/>
-        </p:nvSpPr>
-        <p:spPr>
-          <a:xfrm>
-            <a:off x="4828032" y="3072384"/>
-            <a:ext cx="3840480" cy="548640"/>
+          <p:cNvPr id="236" name="Shape 234"/>
+          <p:cNvSpPr/>
+          <p:nvPr/>
+        </p:nvSpPr>
+        <p:spPr>
+          <a:xfrm>
+            <a:off x="4459337" y="1600200"/>
+            <a:ext cx="182880" cy="182880"/>
+          </a:xfrm>
+          <a:prstGeom prst="ellipse">
+            <a:avLst/>
+          </a:prstGeom>
+          <a:solidFill>
+            <a:srgbClr val="1A1A1A"/>
+          </a:solidFill>
+          <a:ln/>
+        </p:spPr>
+      </p:sp>
+      <p:sp>
+        <p:nvSpPr>
+          <p:cNvPr id="237" name="Text 235"/>
+          <p:cNvSpPr/>
+          <p:nvPr/>
+        </p:nvSpPr>
+        <p:spPr>
+          <a:xfrm>
+            <a:off x="4459337" y="1600200"/>
+            <a:ext cx="182880" cy="182880"/>
           </a:xfrm>
           <a:prstGeom prst="rect">
             <a:avLst/>
@@ -13466,190 +13512,1302 @@
           <a:ln/>
         </p:spPr>
         <p:txBody>
-          <a:bodyPr wrap="square" lIns="0" tIns="0" rIns="0" bIns="0" rtlCol="0" anchor="t"/>
+          <a:bodyPr wrap="square" lIns="0" tIns="0" rIns="0" bIns="0" rtlCol="0" anchor="ctr"/>
           <a:lstStyle/>
           <a:p>
-            <a:pPr indent="0" marL="0">
+            <a:pPr algn="ctr" indent="0" marL="0">
               <a:buNone/>
             </a:pPr>
             <a:r>
-              <a:rPr lang="en-US" sz="1050" b="1" dirty="0">
+              <a:rPr lang="en-US" sz="850" b="1" dirty="0">
                 <a:solidFill>
-                  <a:srgbClr val="000000"/>
+                  <a:srgbClr val="FFFFFF"/>
                 </a:solidFill>
                 <a:latin typeface="NVIDIA Sans" pitchFamily="34" charset="0"/>
                 <a:ea typeface="NVIDIA Sans" pitchFamily="34" charset="-122"/>
                 <a:cs typeface="NVIDIA Sans" pitchFamily="34" charset="-120"/>
               </a:rPr>
-              <a:t>13,868 kernel launches / step — </a:t>
+              <a:t>1</a:t>
             </a:r>
-            <a:pPr indent="0" marL="0">
+            <a:endParaRPr lang="en-US" sz="850" dirty="0"/>
+          </a:p>
+        </p:txBody>
+      </p:sp>
+      <p:sp>
+        <p:nvSpPr>
+          <p:cNvPr id="238" name="Shape 236"/>
+          <p:cNvSpPr/>
+          <p:nvPr/>
+        </p:nvSpPr>
+        <p:spPr>
+          <a:xfrm>
+            <a:off x="7345715" y="2002536"/>
+            <a:ext cx="182880" cy="182880"/>
+          </a:xfrm>
+          <a:prstGeom prst="ellipse">
+            <a:avLst/>
+          </a:prstGeom>
+          <a:solidFill>
+            <a:srgbClr val="1A1A1A"/>
+          </a:solidFill>
+          <a:ln/>
+        </p:spPr>
+      </p:sp>
+      <p:sp>
+        <p:nvSpPr>
+          <p:cNvPr id="239" name="Text 237"/>
+          <p:cNvSpPr/>
+          <p:nvPr/>
+        </p:nvSpPr>
+        <p:spPr>
+          <a:xfrm>
+            <a:off x="7345715" y="2002536"/>
+            <a:ext cx="182880" cy="182880"/>
+          </a:xfrm>
+          <a:prstGeom prst="rect">
+            <a:avLst/>
+          </a:prstGeom>
+          <a:noFill/>
+          <a:ln/>
+        </p:spPr>
+        <p:txBody>
+          <a:bodyPr wrap="square" lIns="0" tIns="0" rIns="0" bIns="0" rtlCol="0" anchor="ctr"/>
+          <a:lstStyle/>
+          <a:p>
+            <a:pPr algn="ctr" indent="0" marL="0">
               <a:buNone/>
             </a:pPr>
             <a:r>
-              <a:rPr lang="en-US" sz="1050" dirty="0">
+              <a:rPr lang="en-US" sz="850" b="1" dirty="0">
                 <a:solidFill>
-                  <a:srgbClr val="5E5E5E"/>
+                  <a:srgbClr val="FFFFFF"/>
                 </a:solidFill>
                 <a:latin typeface="NVIDIA Sans" pitchFamily="34" charset="0"/>
                 <a:ea typeface="NVIDIA Sans" pitchFamily="34" charset="-122"/>
                 <a:cs typeface="NVIDIA Sans" pitchFamily="34" charset="-120"/>
               </a:rPr>
-              <a:t>eager launch overhead dominates; many kernels run &lt; 20 µs</a:t>
+              <a:t>5</a:t>
             </a:r>
-            <a:endParaRPr lang="en-US" sz="1050" dirty="0"/>
+            <a:endParaRPr lang="en-US" sz="850" dirty="0"/>
           </a:p>
         </p:txBody>
       </p:sp>
-      <p:sp>
-        <p:nvSpPr>
-          <p:cNvPr id="236" name="Shape 234"/>
-          <p:cNvSpPr/>
-          <p:nvPr/>
-        </p:nvSpPr>
-        <p:spPr>
-          <a:xfrm>
-            <a:off x="457200" y="3657600"/>
-            <a:ext cx="45720" cy="475488"/>
-          </a:xfrm>
-          <a:prstGeom prst="rect">
-            <a:avLst/>
-          </a:prstGeom>
-          <a:solidFill>
-            <a:srgbClr val="76B900"/>
-          </a:solidFill>
-          <a:ln/>
-        </p:spPr>
-      </p:sp>
-      <p:sp>
-        <p:nvSpPr>
-          <p:cNvPr id="237" name="Text 235"/>
-          <p:cNvSpPr/>
-          <p:nvPr/>
-        </p:nvSpPr>
-        <p:spPr>
-          <a:xfrm>
-            <a:off x="621792" y="3639312"/>
-            <a:ext cx="3840480" cy="548640"/>
-          </a:xfrm>
-          <a:prstGeom prst="rect">
-            <a:avLst/>
-          </a:prstGeom>
-          <a:noFill/>
-          <a:ln/>
-        </p:spPr>
-        <p:txBody>
-          <a:bodyPr wrap="square" lIns="0" tIns="0" rIns="0" bIns="0" rtlCol="0" anchor="t"/>
-          <a:lstStyle/>
-          <a:p>
-            <a:pPr indent="0" marL="0">
-              <a:buNone/>
-            </a:pPr>
-            <a:r>
-              <a:rPr lang="en-US" sz="1050" b="1" dirty="0">
-                <a:solidFill>
-                  <a:srgbClr val="000000"/>
-                </a:solidFill>
-                <a:latin typeface="NVIDIA Sans" pitchFamily="34" charset="0"/>
-                <a:ea typeface="NVIDIA Sans" pitchFamily="34" charset="-122"/>
-                <a:cs typeface="NVIDIA Sans" pitchFamily="34" charset="-120"/>
-              </a:rPr>
-              <a:t>Action head runs in fp32 — </a:t>
-            </a:r>
-            <a:pPr indent="0" marL="0">
-              <a:buNone/>
-            </a:pPr>
-            <a:r>
-              <a:rPr lang="en-US" sz="1050" dirty="0">
-                <a:solidFill>
-                  <a:srgbClr val="5E5E5E"/>
-                </a:solidFill>
-                <a:latin typeface="NVIDIA Sans" pitchFamily="34" charset="0"/>
-                <a:ea typeface="NVIDIA Sans" pitchFamily="34" charset="-122"/>
-                <a:cs typeface="NVIDIA Sans" pitchFamily="34" charset="-120"/>
-              </a:rPr>
-              <a:t>the 2.96B DiT sits outside autocast — half the achievable math rate</a:t>
-            </a:r>
-            <a:endParaRPr lang="en-US" sz="1050" dirty="0"/>
-          </a:p>
-        </p:txBody>
-      </p:sp>
-      <p:sp>
-        <p:nvSpPr>
-          <p:cNvPr id="238" name="Shape 236"/>
-          <p:cNvSpPr/>
-          <p:nvPr/>
-        </p:nvSpPr>
-        <p:spPr>
-          <a:xfrm>
-            <a:off x="4663440" y="3657600"/>
-            <a:ext cx="45720" cy="475488"/>
-          </a:xfrm>
-          <a:prstGeom prst="rect">
-            <a:avLst/>
-          </a:prstGeom>
-          <a:solidFill>
-            <a:srgbClr val="76B900"/>
-          </a:solidFill>
-          <a:ln/>
-        </p:spPr>
-      </p:sp>
-      <p:sp>
-        <p:nvSpPr>
-          <p:cNvPr id="239" name="Text 237"/>
-          <p:cNvSpPr/>
-          <p:nvPr/>
-        </p:nvSpPr>
-        <p:spPr>
-          <a:xfrm>
-            <a:off x="4828032" y="3639312"/>
-            <a:ext cx="3840480" cy="548640"/>
-          </a:xfrm>
-          <a:prstGeom prst="rect">
-            <a:avLst/>
-          </a:prstGeom>
-          <a:noFill/>
-          <a:ln/>
-        </p:spPr>
-        <p:txBody>
-          <a:bodyPr wrap="square" lIns="0" tIns="0" rIns="0" bIns="0" rtlCol="0" anchor="t"/>
-          <a:lstStyle/>
-          <a:p>
-            <a:pPr indent="0" marL="0">
-              <a:buNone/>
-            </a:pPr>
-            <a:r>
-              <a:rPr lang="en-US" sz="1050" b="1" dirty="0">
-                <a:solidFill>
-                  <a:srgbClr val="000000"/>
-                </a:solidFill>
-                <a:latin typeface="NVIDIA Sans" pitchFamily="34" charset="0"/>
-                <a:ea typeface="NVIDIA Sans" pitchFamily="34" charset="-122"/>
-                <a:cs typeface="NVIDIA Sans" pitchFamily="34" charset="-120"/>
-              </a:rPr>
-              <a:t>CPU work inside forward() — </a:t>
-            </a:r>
-            <a:pPr indent="0" marL="0">
-              <a:buNone/>
-            </a:pPr>
-            <a:r>
-              <a:rPr lang="en-US" sz="1050" dirty="0">
-                <a:solidFill>
-                  <a:srgbClr val="5E5E5E"/>
-                </a:solidFill>
-                <a:latin typeface="NVIDIA Sans" pitchFamily="34" charset="0"/>
-                <a:ea typeface="NVIDIA Sans" pitchFamily="34" charset="-122"/>
-                <a:cs typeface="NVIDIA Sans" pitchFamily="34" charset="-120"/>
-              </a:rPr>
-              <a:t>HF preprocessing + per-step syncs serialize CPU and GPU</a:t>
-            </a:r>
-            <a:endParaRPr lang="en-US" sz="1050" dirty="0"/>
-          </a:p>
-        </p:txBody>
-      </p:sp>
-      <p:sp>
-        <p:nvSpPr>
-          <p:cNvPr id="240" name="Text 238"/>
+      <p:graphicFrame>
+        <p:nvGraphicFramePr>
+          <p:cNvPr id="5" name="Table 0"/>
+          <p:cNvGraphicFramePr>
+            <a:graphicFrameLocks noGrp="1"/>
+          </p:cNvGraphicFramePr>
+          <p:nvPr>
+            <p:extLst>
+              <p:ext uri="{D42A27DB-BD31-4B8C-83A1-F6EECF244321}">
+                <p14:modId xmlns:p14="http://schemas.microsoft.com/office/powerpoint/2010/main" val="1579011935"/>
+              </p:ext>
+            </p:extLst>
+          </p:nvPr>
+        </p:nvGraphicFramePr>
+        <p:xfrm>
+          <a:off x="457200" y="2825496"/>
+          <a:ext cx="8229600" cy="914400"/>
+        </p:xfrm>
+        <a:graphic>
+          <a:graphicData uri="http://schemas.openxmlformats.org/drawingml/2006/table">
+            <a:tbl>
+              <a:tblPr/>
+              <a:tblGrid>
+                <a:gridCol w="1645920"/>
+                <a:gridCol w="4114800"/>
+                <a:gridCol w="2468880"/>
+              </a:tblGrid>
+              <a:tr h="237744">
+                <a:tc>
+                  <a:txBody>
+                    <a:bodyPr/>
+                    <a:lstStyle/>
+                    <a:p>
+                      <a:pPr algn="l" indent="0" marL="0">
+                        <a:buNone/>
+                      </a:pPr>
+                      <a:r>
+                        <a:rPr lang="en-US" sz="850" b="1" dirty="0">
+                          <a:solidFill>
+                            <a:srgbClr val="000000"/>
+                          </a:solidFill>
+                          <a:latin typeface="NVIDIA Sans" pitchFamily="34" charset="0"/>
+                          <a:ea typeface="NVIDIA Sans" pitchFamily="34" charset="-122"/>
+                          <a:cs typeface="NVIDIA Sans" pitchFamily="34" charset="-120"/>
+                        </a:rPr>
+                        <a:t>1 · fp32 action head</a:t>
+                      </a:r>
+                      <a:endParaRPr lang="en-US" sz="850" dirty="0">
+                        <a:latin typeface="NVIDIA Sans" charset="0"/>
+                        <a:ea typeface="NVIDIA Sans" charset="0"/>
+                        <a:cs typeface="NVIDIA Sans" charset="0"/>
+                      </a:endParaRPr>
+                    </a:p>
+                  </a:txBody>
+                  <a:tcPr marL="91440" marR="91440" marT="45720" marB="45720" anchor="ctr">
+                    <a:lnL w="6350" cap="flat" cmpd="sng" algn="ctr">
+                      <a:solidFill>
+                        <a:srgbClr val="CDCDCD"/>
+                      </a:solidFill>
+                      <a:prstDash val="solid"/>
+                      <a:round/>
+                      <a:headEnd type="none" w="med" len="med"/>
+                      <a:tailEnd type="none" w="med" len="med"/>
+                    </a:lnL>
+                    <a:lnR w="6350" cap="flat" cmpd="sng" algn="ctr">
+                      <a:solidFill>
+                        <a:srgbClr val="CDCDCD"/>
+                      </a:solidFill>
+                      <a:prstDash val="solid"/>
+                      <a:round/>
+                      <a:headEnd type="none" w="med" len="med"/>
+                      <a:tailEnd type="none" w="med" len="med"/>
+                    </a:lnR>
+                    <a:lnT w="6350" cap="flat" cmpd="sng" algn="ctr">
+                      <a:solidFill>
+                        <a:srgbClr val="CDCDCD"/>
+                      </a:solidFill>
+                      <a:prstDash val="solid"/>
+                      <a:round/>
+                      <a:headEnd type="none" w="med" len="med"/>
+                      <a:tailEnd type="none" w="med" len="med"/>
+                    </a:lnT>
+                    <a:lnB w="6350" cap="flat" cmpd="sng" algn="ctr">
+                      <a:solidFill>
+                        <a:srgbClr val="CDCDCD"/>
+                      </a:solidFill>
+                      <a:prstDash val="solid"/>
+                      <a:round/>
+                      <a:headEnd type="none" w="med" len="med"/>
+                      <a:tailEnd type="none" w="med" len="med"/>
+                    </a:lnB>
+                  </a:tcPr>
+                </a:tc>
+                <a:tc>
+                  <a:txBody>
+                    <a:bodyPr/>
+                    <a:lstStyle/>
+                    <a:p>
+                      <a:pPr algn="l" indent="0" marL="0">
+                        <a:buNone/>
+                      </a:pPr>
+                      <a:r>
+                        <a:rPr lang="en-US" sz="850" dirty="0">
+                          <a:solidFill>
+                            <a:srgbClr val="000000"/>
+                          </a:solidFill>
+                          <a:latin typeface="NVIDIA Sans" pitchFamily="34" charset="0"/>
+                          <a:ea typeface="NVIDIA Sans" pitchFamily="34" charset="-122"/>
+                          <a:cs typeface="NVIDIA Sans" pitchFamily="34" charset="-120"/>
+                        </a:rPr>
+                        <a:t>201 ms fp32 GEMMs vs 66 ms bf16 — 2.96B DiT outside autocast</a:t>
+                      </a:r>
+                      <a:endParaRPr lang="en-US" sz="850" dirty="0">
+                        <a:latin typeface="NVIDIA Sans" charset="0"/>
+                        <a:ea typeface="NVIDIA Sans" charset="0"/>
+                        <a:cs typeface="NVIDIA Sans" charset="0"/>
+                      </a:endParaRPr>
+                    </a:p>
+                  </a:txBody>
+                  <a:tcPr marL="91440" marR="91440" marT="45720" marB="45720" anchor="ctr">
+                    <a:lnL w="6350" cap="flat" cmpd="sng" algn="ctr">
+                      <a:solidFill>
+                        <a:srgbClr val="CDCDCD"/>
+                      </a:solidFill>
+                      <a:prstDash val="solid"/>
+                      <a:round/>
+                      <a:headEnd type="none" w="med" len="med"/>
+                      <a:tailEnd type="none" w="med" len="med"/>
+                    </a:lnL>
+                    <a:lnR w="6350" cap="flat" cmpd="sng" algn="ctr">
+                      <a:solidFill>
+                        <a:srgbClr val="CDCDCD"/>
+                      </a:solidFill>
+                      <a:prstDash val="solid"/>
+                      <a:round/>
+                      <a:headEnd type="none" w="med" len="med"/>
+                      <a:tailEnd type="none" w="med" len="med"/>
+                    </a:lnR>
+                    <a:lnT w="6350" cap="flat" cmpd="sng" algn="ctr">
+                      <a:solidFill>
+                        <a:srgbClr val="CDCDCD"/>
+                      </a:solidFill>
+                      <a:prstDash val="solid"/>
+                      <a:round/>
+                      <a:headEnd type="none" w="med" len="med"/>
+                      <a:tailEnd type="none" w="med" len="med"/>
+                    </a:lnT>
+                    <a:lnB w="6350" cap="flat" cmpd="sng" algn="ctr">
+                      <a:solidFill>
+                        <a:srgbClr val="CDCDCD"/>
+                      </a:solidFill>
+                      <a:prstDash val="solid"/>
+                      <a:round/>
+                      <a:headEnd type="none" w="med" len="med"/>
+                      <a:tailEnd type="none" w="med" len="med"/>
+                    </a:lnB>
+                  </a:tcPr>
+                </a:tc>
+                <a:tc>
+                  <a:txBody>
+                    <a:bodyPr/>
+                    <a:lstStyle/>
+                    <a:p>
+                      <a:pPr algn="l" indent="0" marL="0">
+                        <a:buNone/>
+                      </a:pPr>
+                      <a:r>
+                        <a:rPr lang="en-US" sz="850" b="1" dirty="0">
+                          <a:solidFill>
+                            <a:srgbClr val="008564"/>
+                          </a:solidFill>
+                          <a:latin typeface="NVIDIA Sans" pitchFamily="34" charset="0"/>
+                          <a:ea typeface="NVIDIA Sans" pitchFamily="34" charset="-122"/>
+                          <a:cs typeface="NVIDIA Sans" pitchFamily="34" charset="-120"/>
+                        </a:rPr>
+                        <a:t>bf16 DiT  (−218 ms)</a:t>
+                      </a:r>
+                      <a:endParaRPr lang="en-US" sz="850" dirty="0">
+                        <a:latin typeface="NVIDIA Sans" charset="0"/>
+                        <a:ea typeface="NVIDIA Sans" charset="0"/>
+                        <a:cs typeface="NVIDIA Sans" charset="0"/>
+                      </a:endParaRPr>
+                    </a:p>
+                  </a:txBody>
+                  <a:tcPr marL="91440" marR="91440" marT="45720" marB="45720" anchor="ctr">
+                    <a:lnL w="6350" cap="flat" cmpd="sng" algn="ctr">
+                      <a:solidFill>
+                        <a:srgbClr val="CDCDCD"/>
+                      </a:solidFill>
+                      <a:prstDash val="solid"/>
+                      <a:round/>
+                      <a:headEnd type="none" w="med" len="med"/>
+                      <a:tailEnd type="none" w="med" len="med"/>
+                    </a:lnL>
+                    <a:lnR w="6350" cap="flat" cmpd="sng" algn="ctr">
+                      <a:solidFill>
+                        <a:srgbClr val="CDCDCD"/>
+                      </a:solidFill>
+                      <a:prstDash val="solid"/>
+                      <a:round/>
+                      <a:headEnd type="none" w="med" len="med"/>
+                      <a:tailEnd type="none" w="med" len="med"/>
+                    </a:lnR>
+                    <a:lnT w="6350" cap="flat" cmpd="sng" algn="ctr">
+                      <a:solidFill>
+                        <a:srgbClr val="CDCDCD"/>
+                      </a:solidFill>
+                      <a:prstDash val="solid"/>
+                      <a:round/>
+                      <a:headEnd type="none" w="med" len="med"/>
+                      <a:tailEnd type="none" w="med" len="med"/>
+                    </a:lnT>
+                    <a:lnB w="6350" cap="flat" cmpd="sng" algn="ctr">
+                      <a:solidFill>
+                        <a:srgbClr val="CDCDCD"/>
+                      </a:solidFill>
+                      <a:prstDash val="solid"/>
+                      <a:round/>
+                      <a:headEnd type="none" w="med" len="med"/>
+                      <a:tailEnd type="none" w="med" len="med"/>
+                    </a:lnB>
+                  </a:tcPr>
+                </a:tc>
+              </a:tr>
+              <a:tr h="237744">
+                <a:tc>
+                  <a:txBody>
+                    <a:bodyPr/>
+                    <a:lstStyle/>
+                    <a:p>
+                      <a:pPr algn="l" indent="0" marL="0">
+                        <a:buNone/>
+                      </a:pPr>
+                      <a:r>
+                        <a:rPr lang="en-US" sz="850" b="1" dirty="0">
+                          <a:solidFill>
+                            <a:srgbClr val="000000"/>
+                          </a:solidFill>
+                          <a:latin typeface="NVIDIA Sans" pitchFamily="34" charset="0"/>
+                          <a:ea typeface="NVIDIA Sans" pitchFamily="34" charset="-122"/>
+                          <a:cs typeface="NVIDIA Sans" pitchFamily="34" charset="-120"/>
+                        </a:rPr>
+                        <a:t>2 · CPU inside forward()</a:t>
+                      </a:r>
+                      <a:endParaRPr lang="en-US" sz="850" dirty="0">
+                        <a:latin typeface="NVIDIA Sans" charset="0"/>
+                        <a:ea typeface="NVIDIA Sans" charset="0"/>
+                        <a:cs typeface="NVIDIA Sans" charset="0"/>
+                      </a:endParaRPr>
+                    </a:p>
+                  </a:txBody>
+                  <a:tcPr marL="91440" marR="91440" marT="45720" marB="45720" anchor="ctr">
+                    <a:lnL w="6350" cap="flat" cmpd="sng" algn="ctr">
+                      <a:solidFill>
+                        <a:srgbClr val="CDCDCD"/>
+                      </a:solidFill>
+                      <a:prstDash val="solid"/>
+                      <a:round/>
+                      <a:headEnd type="none" w="med" len="med"/>
+                      <a:tailEnd type="none" w="med" len="med"/>
+                    </a:lnL>
+                    <a:lnR w="6350" cap="flat" cmpd="sng" algn="ctr">
+                      <a:solidFill>
+                        <a:srgbClr val="CDCDCD"/>
+                      </a:solidFill>
+                      <a:prstDash val="solid"/>
+                      <a:round/>
+                      <a:headEnd type="none" w="med" len="med"/>
+                      <a:tailEnd type="none" w="med" len="med"/>
+                    </a:lnR>
+                    <a:lnT w="6350" cap="flat" cmpd="sng" algn="ctr">
+                      <a:solidFill>
+                        <a:srgbClr val="CDCDCD"/>
+                      </a:solidFill>
+                      <a:prstDash val="solid"/>
+                      <a:round/>
+                      <a:headEnd type="none" w="med" len="med"/>
+                      <a:tailEnd type="none" w="med" len="med"/>
+                    </a:lnT>
+                    <a:lnB w="6350" cap="flat" cmpd="sng" algn="ctr">
+                      <a:solidFill>
+                        <a:srgbClr val="CDCDCD"/>
+                      </a:solidFill>
+                      <a:prstDash val="solid"/>
+                      <a:round/>
+                      <a:headEnd type="none" w="med" len="med"/>
+                      <a:tailEnd type="none" w="med" len="med"/>
+                    </a:lnB>
+                  </a:tcPr>
+                </a:tc>
+                <a:tc>
+                  <a:txBody>
+                    <a:bodyPr/>
+                    <a:lstStyle/>
+                    <a:p>
+                      <a:pPr algn="l" indent="0" marL="0">
+                        <a:buNone/>
+                      </a:pPr>
+                      <a:r>
+                        <a:rPr lang="en-US" sz="850" dirty="0">
+                          <a:solidFill>
+                            <a:srgbClr val="000000"/>
+                          </a:solidFill>
+                          <a:latin typeface="NVIDIA Sans" pitchFamily="34" charset="0"/>
+                          <a:ea typeface="NVIDIA Sans" pitchFamily="34" charset="-122"/>
+                          <a:cs typeface="NVIDIA Sans" pitchFamily="34" charset="-120"/>
+                        </a:rPr>
+                        <a:t>first 80 ms of every step: compute idle, HF preprocessing on critical path</a:t>
+                      </a:r>
+                      <a:endParaRPr lang="en-US" sz="850" dirty="0">
+                        <a:latin typeface="NVIDIA Sans" charset="0"/>
+                        <a:ea typeface="NVIDIA Sans" charset="0"/>
+                        <a:cs typeface="NVIDIA Sans" charset="0"/>
+                      </a:endParaRPr>
+                    </a:p>
+                  </a:txBody>
+                  <a:tcPr marL="91440" marR="91440" marT="45720" marB="45720" anchor="ctr">
+                    <a:lnL w="6350" cap="flat" cmpd="sng" algn="ctr">
+                      <a:solidFill>
+                        <a:srgbClr val="CDCDCD"/>
+                      </a:solidFill>
+                      <a:prstDash val="solid"/>
+                      <a:round/>
+                      <a:headEnd type="none" w="med" len="med"/>
+                      <a:tailEnd type="none" w="med" len="med"/>
+                    </a:lnL>
+                    <a:lnR w="6350" cap="flat" cmpd="sng" algn="ctr">
+                      <a:solidFill>
+                        <a:srgbClr val="CDCDCD"/>
+                      </a:solidFill>
+                      <a:prstDash val="solid"/>
+                      <a:round/>
+                      <a:headEnd type="none" w="med" len="med"/>
+                      <a:tailEnd type="none" w="med" len="med"/>
+                    </a:lnR>
+                    <a:lnT w="6350" cap="flat" cmpd="sng" algn="ctr">
+                      <a:solidFill>
+                        <a:srgbClr val="CDCDCD"/>
+                      </a:solidFill>
+                      <a:prstDash val="solid"/>
+                      <a:round/>
+                      <a:headEnd type="none" w="med" len="med"/>
+                      <a:tailEnd type="none" w="med" len="med"/>
+                    </a:lnT>
+                    <a:lnB w="6350" cap="flat" cmpd="sng" algn="ctr">
+                      <a:solidFill>
+                        <a:srgbClr val="CDCDCD"/>
+                      </a:solidFill>
+                      <a:prstDash val="solid"/>
+                      <a:round/>
+                      <a:headEnd type="none" w="med" len="med"/>
+                      <a:tailEnd type="none" w="med" len="med"/>
+                    </a:lnB>
+                  </a:tcPr>
+                </a:tc>
+                <a:tc>
+                  <a:txBody>
+                    <a:bodyPr/>
+                    <a:lstStyle/>
+                    <a:p>
+                      <a:pPr algn="l" indent="0" marL="0">
+                        <a:buNone/>
+                      </a:pPr>
+                      <a:r>
+                        <a:rPr lang="en-US" sz="850" b="1" dirty="0">
+                          <a:solidFill>
+                            <a:srgbClr val="008564"/>
+                          </a:solidFill>
+                          <a:latin typeface="NVIDIA Sans" pitchFamily="34" charset="0"/>
+                          <a:ea typeface="NVIDIA Sans" pitchFamily="34" charset="-122"/>
+                          <a:cs typeface="NVIDIA Sans" pitchFamily="34" charset="-120"/>
+                        </a:rPr>
+                        <a:t>collate in DataLoader workers</a:t>
+                      </a:r>
+                      <a:endParaRPr lang="en-US" sz="850" dirty="0">
+                        <a:latin typeface="NVIDIA Sans" charset="0"/>
+                        <a:ea typeface="NVIDIA Sans" charset="0"/>
+                        <a:cs typeface="NVIDIA Sans" charset="0"/>
+                      </a:endParaRPr>
+                    </a:p>
+                  </a:txBody>
+                  <a:tcPr marL="91440" marR="91440" marT="45720" marB="45720" anchor="ctr">
+                    <a:lnL w="6350" cap="flat" cmpd="sng" algn="ctr">
+                      <a:solidFill>
+                        <a:srgbClr val="CDCDCD"/>
+                      </a:solidFill>
+                      <a:prstDash val="solid"/>
+                      <a:round/>
+                      <a:headEnd type="none" w="med" len="med"/>
+                      <a:tailEnd type="none" w="med" len="med"/>
+                    </a:lnL>
+                    <a:lnR w="6350" cap="flat" cmpd="sng" algn="ctr">
+                      <a:solidFill>
+                        <a:srgbClr val="CDCDCD"/>
+                      </a:solidFill>
+                      <a:prstDash val="solid"/>
+                      <a:round/>
+                      <a:headEnd type="none" w="med" len="med"/>
+                      <a:tailEnd type="none" w="med" len="med"/>
+                    </a:lnR>
+                    <a:lnT w="6350" cap="flat" cmpd="sng" algn="ctr">
+                      <a:solidFill>
+                        <a:srgbClr val="CDCDCD"/>
+                      </a:solidFill>
+                      <a:prstDash val="solid"/>
+                      <a:round/>
+                      <a:headEnd type="none" w="med" len="med"/>
+                      <a:tailEnd type="none" w="med" len="med"/>
+                    </a:lnT>
+                    <a:lnB w="6350" cap="flat" cmpd="sng" algn="ctr">
+                      <a:solidFill>
+                        <a:srgbClr val="CDCDCD"/>
+                      </a:solidFill>
+                      <a:prstDash val="solid"/>
+                      <a:round/>
+                      <a:headEnd type="none" w="med" len="med"/>
+                      <a:tailEnd type="none" w="med" len="med"/>
+                    </a:lnB>
+                  </a:tcPr>
+                </a:tc>
+              </a:tr>
+              <a:tr h="237744">
+                <a:tc>
+                  <a:txBody>
+                    <a:bodyPr/>
+                    <a:lstStyle/>
+                    <a:p>
+                      <a:pPr algn="l" indent="0" marL="0">
+                        <a:buNone/>
+                      </a:pPr>
+                      <a:r>
+                        <a:rPr lang="en-US" sz="850" b="1" dirty="0">
+                          <a:solidFill>
+                            <a:srgbClr val="000000"/>
+                          </a:solidFill>
+                          <a:latin typeface="NVIDIA Sans" pitchFamily="34" charset="0"/>
+                          <a:ea typeface="NVIDIA Sans" pitchFamily="34" charset="-122"/>
+                          <a:cs typeface="NVIDIA Sans" pitchFamily="34" charset="-120"/>
+                        </a:rPr>
+                        <a:t>3 · Per-step syncs</a:t>
+                      </a:r>
+                      <a:endParaRPr lang="en-US" sz="850" dirty="0">
+                        <a:latin typeface="NVIDIA Sans" charset="0"/>
+                        <a:ea typeface="NVIDIA Sans" charset="0"/>
+                        <a:cs typeface="NVIDIA Sans" charset="0"/>
+                      </a:endParaRPr>
+                    </a:p>
+                  </a:txBody>
+                  <a:tcPr marL="91440" marR="91440" marT="45720" marB="45720" anchor="ctr">
+                    <a:lnL w="6350" cap="flat" cmpd="sng" algn="ctr">
+                      <a:solidFill>
+                        <a:srgbClr val="CDCDCD"/>
+                      </a:solidFill>
+                      <a:prstDash val="solid"/>
+                      <a:round/>
+                      <a:headEnd type="none" w="med" len="med"/>
+                      <a:tailEnd type="none" w="med" len="med"/>
+                    </a:lnL>
+                    <a:lnR w="6350" cap="flat" cmpd="sng" algn="ctr">
+                      <a:solidFill>
+                        <a:srgbClr val="CDCDCD"/>
+                      </a:solidFill>
+                      <a:prstDash val="solid"/>
+                      <a:round/>
+                      <a:headEnd type="none" w="med" len="med"/>
+                      <a:tailEnd type="none" w="med" len="med"/>
+                    </a:lnR>
+                    <a:lnT w="6350" cap="flat" cmpd="sng" algn="ctr">
+                      <a:solidFill>
+                        <a:srgbClr val="CDCDCD"/>
+                      </a:solidFill>
+                      <a:prstDash val="solid"/>
+                      <a:round/>
+                      <a:headEnd type="none" w="med" len="med"/>
+                      <a:tailEnd type="none" w="med" len="med"/>
+                    </a:lnT>
+                    <a:lnB w="6350" cap="flat" cmpd="sng" algn="ctr">
+                      <a:solidFill>
+                        <a:srgbClr val="CDCDCD"/>
+                      </a:solidFill>
+                      <a:prstDash val="solid"/>
+                      <a:round/>
+                      <a:headEnd type="none" w="med" len="med"/>
+                      <a:tailEnd type="none" w="med" len="med"/>
+                    </a:lnB>
+                  </a:tcPr>
+                </a:tc>
+                <a:tc>
+                  <a:txBody>
+                    <a:bodyPr/>
+                    <a:lstStyle/>
+                    <a:p>
+                      <a:pPr algn="l" indent="0" marL="0">
+                        <a:buNone/>
+                      </a:pPr>
+                      <a:r>
+                        <a:rPr lang="en-US" sz="850" dirty="0">
+                          <a:solidFill>
+                            <a:srgbClr val="000000"/>
+                          </a:solidFill>
+                          <a:latin typeface="NVIDIA Sans" pitchFamily="34" charset="0"/>
+                          <a:ea typeface="NVIDIA Sans" pitchFamily="34" charset="-122"/>
+                          <a:cs typeface="NVIDIA Sans" pitchFamily="34" charset="-120"/>
+                        </a:rPr>
+                        <a:t>loss readback, DS timers, MRoPE position-ids, mm-merge check</a:t>
+                      </a:r>
+                      <a:endParaRPr lang="en-US" sz="850" dirty="0">
+                        <a:latin typeface="NVIDIA Sans" charset="0"/>
+                        <a:ea typeface="NVIDIA Sans" charset="0"/>
+                        <a:cs typeface="NVIDIA Sans" charset="0"/>
+                      </a:endParaRPr>
+                    </a:p>
+                  </a:txBody>
+                  <a:tcPr marL="91440" marR="91440" marT="45720" marB="45720" anchor="ctr">
+                    <a:lnL w="6350" cap="flat" cmpd="sng" algn="ctr">
+                      <a:solidFill>
+                        <a:srgbClr val="CDCDCD"/>
+                      </a:solidFill>
+                      <a:prstDash val="solid"/>
+                      <a:round/>
+                      <a:headEnd type="none" w="med" len="med"/>
+                      <a:tailEnd type="none" w="med" len="med"/>
+                    </a:lnL>
+                    <a:lnR w="6350" cap="flat" cmpd="sng" algn="ctr">
+                      <a:solidFill>
+                        <a:srgbClr val="CDCDCD"/>
+                      </a:solidFill>
+                      <a:prstDash val="solid"/>
+                      <a:round/>
+                      <a:headEnd type="none" w="med" len="med"/>
+                      <a:tailEnd type="none" w="med" len="med"/>
+                    </a:lnR>
+                    <a:lnT w="6350" cap="flat" cmpd="sng" algn="ctr">
+                      <a:solidFill>
+                        <a:srgbClr val="CDCDCD"/>
+                      </a:solidFill>
+                      <a:prstDash val="solid"/>
+                      <a:round/>
+                      <a:headEnd type="none" w="med" len="med"/>
+                      <a:tailEnd type="none" w="med" len="med"/>
+                    </a:lnT>
+                    <a:lnB w="6350" cap="flat" cmpd="sng" algn="ctr">
+                      <a:solidFill>
+                        <a:srgbClr val="CDCDCD"/>
+                      </a:solidFill>
+                      <a:prstDash val="solid"/>
+                      <a:round/>
+                      <a:headEnd type="none" w="med" len="med"/>
+                      <a:tailEnd type="none" w="med" len="med"/>
+                    </a:lnB>
+                  </a:tcPr>
+                </a:tc>
+                <a:tc>
+                  <a:txBody>
+                    <a:bodyPr/>
+                    <a:lstStyle/>
+                    <a:p>
+                      <a:pPr algn="l" indent="0" marL="0">
+                        <a:buNone/>
+                      </a:pPr>
+                      <a:r>
+                        <a:rPr lang="en-US" sz="850" b="1" dirty="0">
+                          <a:solidFill>
+                            <a:srgbClr val="008564"/>
+                          </a:solidFill>
+                          <a:latin typeface="NVIDIA Sans" pitchFamily="34" charset="0"/>
+                          <a:ea typeface="NVIDIA Sans" pitchFamily="34" charset="-122"/>
+                          <a:cs typeface="NVIDIA Sans" pitchFamily="34" charset="-120"/>
+                        </a:rPr>
+                        <a:t>sync-free logging + caches  (2+3: −117)</a:t>
+                      </a:r>
+                      <a:endParaRPr lang="en-US" sz="850" dirty="0">
+                        <a:latin typeface="NVIDIA Sans" charset="0"/>
+                        <a:ea typeface="NVIDIA Sans" charset="0"/>
+                        <a:cs typeface="NVIDIA Sans" charset="0"/>
+                      </a:endParaRPr>
+                    </a:p>
+                  </a:txBody>
+                  <a:tcPr marL="91440" marR="91440" marT="45720" marB="45720" anchor="ctr">
+                    <a:lnL w="6350" cap="flat" cmpd="sng" algn="ctr">
+                      <a:solidFill>
+                        <a:srgbClr val="CDCDCD"/>
+                      </a:solidFill>
+                      <a:prstDash val="solid"/>
+                      <a:round/>
+                      <a:headEnd type="none" w="med" len="med"/>
+                      <a:tailEnd type="none" w="med" len="med"/>
+                    </a:lnL>
+                    <a:lnR w="6350" cap="flat" cmpd="sng" algn="ctr">
+                      <a:solidFill>
+                        <a:srgbClr val="CDCDCD"/>
+                      </a:solidFill>
+                      <a:prstDash val="solid"/>
+                      <a:round/>
+                      <a:headEnd type="none" w="med" len="med"/>
+                      <a:tailEnd type="none" w="med" len="med"/>
+                    </a:lnR>
+                    <a:lnT w="6350" cap="flat" cmpd="sng" algn="ctr">
+                      <a:solidFill>
+                        <a:srgbClr val="CDCDCD"/>
+                      </a:solidFill>
+                      <a:prstDash val="solid"/>
+                      <a:round/>
+                      <a:headEnd type="none" w="med" len="med"/>
+                      <a:tailEnd type="none" w="med" len="med"/>
+                    </a:lnT>
+                    <a:lnB w="6350" cap="flat" cmpd="sng" algn="ctr">
+                      <a:solidFill>
+                        <a:srgbClr val="CDCDCD"/>
+                      </a:solidFill>
+                      <a:prstDash val="solid"/>
+                      <a:round/>
+                      <a:headEnd type="none" w="med" len="med"/>
+                      <a:tailEnd type="none" w="med" len="med"/>
+                    </a:lnB>
+                  </a:tcPr>
+                </a:tc>
+              </a:tr>
+              <a:tr h="237744">
+                <a:tc>
+                  <a:txBody>
+                    <a:bodyPr/>
+                    <a:lstStyle/>
+                    <a:p>
+                      <a:pPr algn="l" indent="0" marL="0">
+                        <a:buNone/>
+                      </a:pPr>
+                      <a:r>
+                        <a:rPr lang="en-US" sz="850" b="1" dirty="0">
+                          <a:solidFill>
+                            <a:srgbClr val="000000"/>
+                          </a:solidFill>
+                          <a:latin typeface="NVIDIA Sans" pitchFamily="34" charset="0"/>
+                          <a:ea typeface="NVIDIA Sans" pitchFamily="34" charset="-122"/>
+                          <a:cs typeface="NVIDIA Sans" pitchFamily="34" charset="-120"/>
+                        </a:rPr>
+                        <a:t>4 · Launch-bound eager</a:t>
+                      </a:r>
+                      <a:endParaRPr lang="en-US" sz="850" dirty="0">
+                        <a:latin typeface="NVIDIA Sans" charset="0"/>
+                        <a:ea typeface="NVIDIA Sans" charset="0"/>
+                        <a:cs typeface="NVIDIA Sans" charset="0"/>
+                      </a:endParaRPr>
+                    </a:p>
+                  </a:txBody>
+                  <a:tcPr marL="91440" marR="91440" marT="45720" marB="45720" anchor="ctr">
+                    <a:lnL w="6350" cap="flat" cmpd="sng" algn="ctr">
+                      <a:solidFill>
+                        <a:srgbClr val="CDCDCD"/>
+                      </a:solidFill>
+                      <a:prstDash val="solid"/>
+                      <a:round/>
+                      <a:headEnd type="none" w="med" len="med"/>
+                      <a:tailEnd type="none" w="med" len="med"/>
+                    </a:lnL>
+                    <a:lnR w="6350" cap="flat" cmpd="sng" algn="ctr">
+                      <a:solidFill>
+                        <a:srgbClr val="CDCDCD"/>
+                      </a:solidFill>
+                      <a:prstDash val="solid"/>
+                      <a:round/>
+                      <a:headEnd type="none" w="med" len="med"/>
+                      <a:tailEnd type="none" w="med" len="med"/>
+                    </a:lnR>
+                    <a:lnT w="6350" cap="flat" cmpd="sng" algn="ctr">
+                      <a:solidFill>
+                        <a:srgbClr val="CDCDCD"/>
+                      </a:solidFill>
+                      <a:prstDash val="solid"/>
+                      <a:round/>
+                      <a:headEnd type="none" w="med" len="med"/>
+                      <a:tailEnd type="none" w="med" len="med"/>
+                    </a:lnT>
+                    <a:lnB w="6350" cap="flat" cmpd="sng" algn="ctr">
+                      <a:solidFill>
+                        <a:srgbClr val="CDCDCD"/>
+                      </a:solidFill>
+                      <a:prstDash val="solid"/>
+                      <a:round/>
+                      <a:headEnd type="none" w="med" len="med"/>
+                      <a:tailEnd type="none" w="med" len="med"/>
+                    </a:lnB>
+                  </a:tcPr>
+                </a:tc>
+                <a:tc>
+                  <a:txBody>
+                    <a:bodyPr/>
+                    <a:lstStyle/>
+                    <a:p>
+                      <a:pPr algn="l" indent="0" marL="0">
+                        <a:buNone/>
+                      </a:pPr>
+                      <a:r>
+                        <a:rPr lang="en-US" sz="850" dirty="0">
+                          <a:solidFill>
+                            <a:srgbClr val="000000"/>
+                          </a:solidFill>
+                          <a:latin typeface="NVIDIA Sans" pitchFamily="34" charset="0"/>
+                          <a:ea typeface="NVIDIA Sans" pitchFamily="34" charset="-122"/>
+                          <a:cs typeface="NVIDIA Sans" pitchFamily="34" charset="-120"/>
+                        </a:rPr>
+                        <a:t>13,868 launches/step, median 8 µs, 79% &lt; 20 µs — 254 ms pure idle</a:t>
+                      </a:r>
+                      <a:endParaRPr lang="en-US" sz="850" dirty="0">
+                        <a:latin typeface="NVIDIA Sans" charset="0"/>
+                        <a:ea typeface="NVIDIA Sans" charset="0"/>
+                        <a:cs typeface="NVIDIA Sans" charset="0"/>
+                      </a:endParaRPr>
+                    </a:p>
+                  </a:txBody>
+                  <a:tcPr marL="91440" marR="91440" marT="45720" marB="45720" anchor="ctr">
+                    <a:lnL w="6350" cap="flat" cmpd="sng" algn="ctr">
+                      <a:solidFill>
+                        <a:srgbClr val="CDCDCD"/>
+                      </a:solidFill>
+                      <a:prstDash val="solid"/>
+                      <a:round/>
+                      <a:headEnd type="none" w="med" len="med"/>
+                      <a:tailEnd type="none" w="med" len="med"/>
+                    </a:lnL>
+                    <a:lnR w="6350" cap="flat" cmpd="sng" algn="ctr">
+                      <a:solidFill>
+                        <a:srgbClr val="CDCDCD"/>
+                      </a:solidFill>
+                      <a:prstDash val="solid"/>
+                      <a:round/>
+                      <a:headEnd type="none" w="med" len="med"/>
+                      <a:tailEnd type="none" w="med" len="med"/>
+                    </a:lnR>
+                    <a:lnT w="6350" cap="flat" cmpd="sng" algn="ctr">
+                      <a:solidFill>
+                        <a:srgbClr val="CDCDCD"/>
+                      </a:solidFill>
+                      <a:prstDash val="solid"/>
+                      <a:round/>
+                      <a:headEnd type="none" w="med" len="med"/>
+                      <a:tailEnd type="none" w="med" len="med"/>
+                    </a:lnT>
+                    <a:lnB w="6350" cap="flat" cmpd="sng" algn="ctr">
+                      <a:solidFill>
+                        <a:srgbClr val="CDCDCD"/>
+                      </a:solidFill>
+                      <a:prstDash val="solid"/>
+                      <a:round/>
+                      <a:headEnd type="none" w="med" len="med"/>
+                      <a:tailEnd type="none" w="med" len="med"/>
+                    </a:lnB>
+                  </a:tcPr>
+                </a:tc>
+                <a:tc>
+                  <a:txBody>
+                    <a:bodyPr/>
+                    <a:lstStyle/>
+                    <a:p>
+                      <a:pPr algn="l" indent="0" marL="0">
+                        <a:buNone/>
+                      </a:pPr>
+                      <a:r>
+                        <a:rPr lang="en-US" sz="850" b="1" dirty="0">
+                          <a:solidFill>
+                            <a:srgbClr val="008564"/>
+                          </a:solidFill>
+                          <a:latin typeface="NVIDIA Sans" pitchFamily="34" charset="0"/>
+                          <a:ea typeface="NVIDIA Sans" pitchFamily="34" charset="-122"/>
+                          <a:cs typeface="NVIDIA Sans" pitchFamily="34" charset="-120"/>
+                        </a:rPr>
+                        <a:t>CUDA Graphs + compile  (−126 ms)</a:t>
+                      </a:r>
+                      <a:endParaRPr lang="en-US" sz="850" dirty="0">
+                        <a:latin typeface="NVIDIA Sans" charset="0"/>
+                        <a:ea typeface="NVIDIA Sans" charset="0"/>
+                        <a:cs typeface="NVIDIA Sans" charset="0"/>
+                      </a:endParaRPr>
+                    </a:p>
+                  </a:txBody>
+                  <a:tcPr marL="91440" marR="91440" marT="45720" marB="45720" anchor="ctr">
+                    <a:lnL w="6350" cap="flat" cmpd="sng" algn="ctr">
+                      <a:solidFill>
+                        <a:srgbClr val="CDCDCD"/>
+                      </a:solidFill>
+                      <a:prstDash val="solid"/>
+                      <a:round/>
+                      <a:headEnd type="none" w="med" len="med"/>
+                      <a:tailEnd type="none" w="med" len="med"/>
+                    </a:lnL>
+                    <a:lnR w="6350" cap="flat" cmpd="sng" algn="ctr">
+                      <a:solidFill>
+                        <a:srgbClr val="CDCDCD"/>
+                      </a:solidFill>
+                      <a:prstDash val="solid"/>
+                      <a:round/>
+                      <a:headEnd type="none" w="med" len="med"/>
+                      <a:tailEnd type="none" w="med" len="med"/>
+                    </a:lnR>
+                    <a:lnT w="6350" cap="flat" cmpd="sng" algn="ctr">
+                      <a:solidFill>
+                        <a:srgbClr val="CDCDCD"/>
+                      </a:solidFill>
+                      <a:prstDash val="solid"/>
+                      <a:round/>
+                      <a:headEnd type="none" w="med" len="med"/>
+                      <a:tailEnd type="none" w="med" len="med"/>
+                    </a:lnT>
+                    <a:lnB w="6350" cap="flat" cmpd="sng" algn="ctr">
+                      <a:solidFill>
+                        <a:srgbClr val="CDCDCD"/>
+                      </a:solidFill>
+                      <a:prstDash val="solid"/>
+                      <a:round/>
+                      <a:headEnd type="none" w="med" len="med"/>
+                      <a:tailEnd type="none" w="med" len="med"/>
+                    </a:lnB>
+                  </a:tcPr>
+                </a:tc>
+              </a:tr>
+              <a:tr h="237744">
+                <a:tc>
+                  <a:txBody>
+                    <a:bodyPr/>
+                    <a:lstStyle/>
+                    <a:p>
+                      <a:pPr algn="l" indent="0" marL="0">
+                        <a:buNone/>
+                      </a:pPr>
+                      <a:r>
+                        <a:rPr lang="en-US" sz="850" b="1" dirty="0">
+                          <a:solidFill>
+                            <a:srgbClr val="000000"/>
+                          </a:solidFill>
+                          <a:latin typeface="NVIDIA Sans" pitchFamily="34" charset="0"/>
+                          <a:ea typeface="NVIDIA Sans" pitchFamily="34" charset="-122"/>
+                          <a:cs typeface="NVIDIA Sans" pitchFamily="34" charset="-120"/>
+                        </a:rPr>
+                        <a:t>5 · Comm configuration</a:t>
+                      </a:r>
+                      <a:endParaRPr lang="en-US" sz="850" dirty="0">
+                        <a:latin typeface="NVIDIA Sans" charset="0"/>
+                        <a:ea typeface="NVIDIA Sans" charset="0"/>
+                        <a:cs typeface="NVIDIA Sans" charset="0"/>
+                      </a:endParaRPr>
+                    </a:p>
+                  </a:txBody>
+                  <a:tcPr marL="91440" marR="91440" marT="45720" marB="45720" anchor="ctr">
+                    <a:lnL w="6350" cap="flat" cmpd="sng" algn="ctr">
+                      <a:solidFill>
+                        <a:srgbClr val="CDCDCD"/>
+                      </a:solidFill>
+                      <a:prstDash val="solid"/>
+                      <a:round/>
+                      <a:headEnd type="none" w="med" len="med"/>
+                      <a:tailEnd type="none" w="med" len="med"/>
+                    </a:lnL>
+                    <a:lnR w="6350" cap="flat" cmpd="sng" algn="ctr">
+                      <a:solidFill>
+                        <a:srgbClr val="CDCDCD"/>
+                      </a:solidFill>
+                      <a:prstDash val="solid"/>
+                      <a:round/>
+                      <a:headEnd type="none" w="med" len="med"/>
+                      <a:tailEnd type="none" w="med" len="med"/>
+                    </a:lnR>
+                    <a:lnT w="6350" cap="flat" cmpd="sng" algn="ctr">
+                      <a:solidFill>
+                        <a:srgbClr val="CDCDCD"/>
+                      </a:solidFill>
+                      <a:prstDash val="solid"/>
+                      <a:round/>
+                      <a:headEnd type="none" w="med" len="med"/>
+                      <a:tailEnd type="none" w="med" len="med"/>
+                    </a:lnT>
+                    <a:lnB w="6350" cap="flat" cmpd="sng" algn="ctr">
+                      <a:solidFill>
+                        <a:srgbClr val="CDCDCD"/>
+                      </a:solidFill>
+                      <a:prstDash val="solid"/>
+                      <a:round/>
+                      <a:headEnd type="none" w="med" len="med"/>
+                      <a:tailEnd type="none" w="med" len="med"/>
+                    </a:lnB>
+                  </a:tcPr>
+                </a:tc>
+                <a:tc>
+                  <a:txBody>
+                    <a:bodyPr/>
+                    <a:lstStyle/>
+                    <a:p>
+                      <a:pPr algn="l" indent="0" marL="0">
+                        <a:buNone/>
+                      </a:pPr>
+                      <a:r>
+                        <a:rPr lang="en-US" sz="850" dirty="0">
+                          <a:solidFill>
+                            <a:srgbClr val="000000"/>
+                          </a:solidFill>
+                          <a:latin typeface="NVIDIA Sans" pitchFamily="34" charset="0"/>
+                          <a:ea typeface="NVIDIA Sans" pitchFamily="34" charset="-122"/>
+                          <a:cs typeface="NVIDIA Sans" pitchFamily="34" charset="-120"/>
+                        </a:rPr>
+                        <a:t>15 small AR buckets; 22 ms redundant flatten; 44 ms exposed AllGather</a:t>
+                      </a:r>
+                      <a:endParaRPr lang="en-US" sz="850" dirty="0">
+                        <a:latin typeface="NVIDIA Sans" charset="0"/>
+                        <a:ea typeface="NVIDIA Sans" charset="0"/>
+                        <a:cs typeface="NVIDIA Sans" charset="0"/>
+                      </a:endParaRPr>
+                    </a:p>
+                  </a:txBody>
+                  <a:tcPr marL="91440" marR="91440" marT="45720" marB="45720" anchor="ctr">
+                    <a:lnL w="6350" cap="flat" cmpd="sng" algn="ctr">
+                      <a:solidFill>
+                        <a:srgbClr val="CDCDCD"/>
+                      </a:solidFill>
+                      <a:prstDash val="solid"/>
+                      <a:round/>
+                      <a:headEnd type="none" w="med" len="med"/>
+                      <a:tailEnd type="none" w="med" len="med"/>
+                    </a:lnL>
+                    <a:lnR w="6350" cap="flat" cmpd="sng" algn="ctr">
+                      <a:solidFill>
+                        <a:srgbClr val="CDCDCD"/>
+                      </a:solidFill>
+                      <a:prstDash val="solid"/>
+                      <a:round/>
+                      <a:headEnd type="none" w="med" len="med"/>
+                      <a:tailEnd type="none" w="med" len="med"/>
+                    </a:lnR>
+                    <a:lnT w="6350" cap="flat" cmpd="sng" algn="ctr">
+                      <a:solidFill>
+                        <a:srgbClr val="CDCDCD"/>
+                      </a:solidFill>
+                      <a:prstDash val="solid"/>
+                      <a:round/>
+                      <a:headEnd type="none" w="med" len="med"/>
+                      <a:tailEnd type="none" w="med" len="med"/>
+                    </a:lnT>
+                    <a:lnB w="6350" cap="flat" cmpd="sng" algn="ctr">
+                      <a:solidFill>
+                        <a:srgbClr val="CDCDCD"/>
+                      </a:solidFill>
+                      <a:prstDash val="solid"/>
+                      <a:round/>
+                      <a:headEnd type="none" w="med" len="med"/>
+                      <a:tailEnd type="none" w="med" len="med"/>
+                    </a:lnB>
+                  </a:tcPr>
+                </a:tc>
+                <a:tc>
+                  <a:txBody>
+                    <a:bodyPr/>
+                    <a:lstStyle/>
+                    <a:p>
+                      <a:pPr algn="l" indent="0" marL="0">
+                        <a:buNone/>
+                      </a:pPr>
+                      <a:r>
+                        <a:rPr lang="en-US" sz="850" b="1" dirty="0">
+                          <a:solidFill>
+                            <a:srgbClr val="008564"/>
+                          </a:solidFill>
+                          <a:latin typeface="NVIDIA Sans" pitchFamily="34" charset="0"/>
+                          <a:ea typeface="NVIDIA Sans" pitchFamily="34" charset="-122"/>
+                          <a:cs typeface="NVIDIA Sans" pitchFamily="34" charset="-120"/>
+                        </a:rPr>
+                        <a:t>bucket 1.5e9 + reduce_scatter off  (−22)</a:t>
+                      </a:r>
+                      <a:endParaRPr lang="en-US" sz="850" dirty="0">
+                        <a:latin typeface="NVIDIA Sans" charset="0"/>
+                        <a:ea typeface="NVIDIA Sans" charset="0"/>
+                        <a:cs typeface="NVIDIA Sans" charset="0"/>
+                      </a:endParaRPr>
+                    </a:p>
+                  </a:txBody>
+                  <a:tcPr marL="91440" marR="91440" marT="45720" marB="45720" anchor="ctr">
+                    <a:lnL w="6350" cap="flat" cmpd="sng" algn="ctr">
+                      <a:solidFill>
+                        <a:srgbClr val="CDCDCD"/>
+                      </a:solidFill>
+                      <a:prstDash val="solid"/>
+                      <a:round/>
+                      <a:headEnd type="none" w="med" len="med"/>
+                      <a:tailEnd type="none" w="med" len="med"/>
+                    </a:lnL>
+                    <a:lnR w="6350" cap="flat" cmpd="sng" algn="ctr">
+                      <a:solidFill>
+                        <a:srgbClr val="CDCDCD"/>
+                      </a:solidFill>
+                      <a:prstDash val="solid"/>
+                      <a:round/>
+                      <a:headEnd type="none" w="med" len="med"/>
+                      <a:tailEnd type="none" w="med" len="med"/>
+                    </a:lnR>
+                    <a:lnT w="6350" cap="flat" cmpd="sng" algn="ctr">
+                      <a:solidFill>
+                        <a:srgbClr val="CDCDCD"/>
+                      </a:solidFill>
+                      <a:prstDash val="solid"/>
+                      <a:round/>
+                      <a:headEnd type="none" w="med" len="med"/>
+                      <a:tailEnd type="none" w="med" len="med"/>
+                    </a:lnT>
+                    <a:lnB w="6350" cap="flat" cmpd="sng" algn="ctr">
+                      <a:solidFill>
+                        <a:srgbClr val="CDCDCD"/>
+                      </a:solidFill>
+                      <a:prstDash val="solid"/>
+                      <a:round/>
+                      <a:headEnd type="none" w="med" len="med"/>
+                      <a:tailEnd type="none" w="med" len="med"/>
+                    </a:lnB>
+                  </a:tcPr>
+                </a:tc>
+              </a:tr>
+              <a:tr h="237744">
+                <a:tc>
+                  <a:txBody>
+                    <a:bodyPr/>
+                    <a:lstStyle/>
+                    <a:p>
+                      <a:pPr algn="l" indent="0" marL="0">
+                        <a:buNone/>
+                      </a:pPr>
+                      <a:r>
+                        <a:rPr lang="en-US" sz="850" b="1" dirty="0">
+                          <a:solidFill>
+                            <a:srgbClr val="000000"/>
+                          </a:solidFill>
+                          <a:latin typeface="NVIDIA Sans" pitchFamily="34" charset="0"/>
+                          <a:ea typeface="NVIDIA Sans" pitchFamily="34" charset="-122"/>
+                          <a:cs typeface="NVIDIA Sans" pitchFamily="34" charset="-120"/>
+                        </a:rPr>
+                        <a:t>6 · Config-level</a:t>
+                      </a:r>
+                      <a:endParaRPr lang="en-US" sz="850" dirty="0">
+                        <a:latin typeface="NVIDIA Sans" charset="0"/>
+                        <a:ea typeface="NVIDIA Sans" charset="0"/>
+                        <a:cs typeface="NVIDIA Sans" charset="0"/>
+                      </a:endParaRPr>
+                    </a:p>
+                  </a:txBody>
+                  <a:tcPr marL="91440" marR="91440" marT="45720" marB="45720" anchor="ctr">
+                    <a:lnL w="6350" cap="flat" cmpd="sng" algn="ctr">
+                      <a:solidFill>
+                        <a:srgbClr val="CDCDCD"/>
+                      </a:solidFill>
+                      <a:prstDash val="solid"/>
+                      <a:round/>
+                      <a:headEnd type="none" w="med" len="med"/>
+                      <a:tailEnd type="none" w="med" len="med"/>
+                    </a:lnL>
+                    <a:lnR w="6350" cap="flat" cmpd="sng" algn="ctr">
+                      <a:solidFill>
+                        <a:srgbClr val="CDCDCD"/>
+                      </a:solidFill>
+                      <a:prstDash val="solid"/>
+                      <a:round/>
+                      <a:headEnd type="none" w="med" len="med"/>
+                      <a:tailEnd type="none" w="med" len="med"/>
+                    </a:lnR>
+                    <a:lnT w="6350" cap="flat" cmpd="sng" algn="ctr">
+                      <a:solidFill>
+                        <a:srgbClr val="CDCDCD"/>
+                      </a:solidFill>
+                      <a:prstDash val="solid"/>
+                      <a:round/>
+                      <a:headEnd type="none" w="med" len="med"/>
+                      <a:tailEnd type="none" w="med" len="med"/>
+                    </a:lnT>
+                    <a:lnB w="6350" cap="flat" cmpd="sng" algn="ctr">
+                      <a:solidFill>
+                        <a:srgbClr val="CDCDCD"/>
+                      </a:solidFill>
+                      <a:prstDash val="solid"/>
+                      <a:round/>
+                      <a:headEnd type="none" w="med" len="med"/>
+                      <a:tailEnd type="none" w="med" len="med"/>
+                    </a:lnB>
+                  </a:tcPr>
+                </a:tc>
+                <a:tc>
+                  <a:txBody>
+                    <a:bodyPr/>
+                    <a:lstStyle/>
+                    <a:p>
+                      <a:pPr algn="l" indent="0" marL="0">
+                        <a:buNone/>
+                      </a:pPr>
+                      <a:r>
+                        <a:rPr lang="en-US" sz="850" dirty="0">
+                          <a:solidFill>
+                            <a:srgbClr val="000000"/>
+                          </a:solidFill>
+                          <a:latin typeface="NVIDIA Sans" pitchFamily="34" charset="0"/>
+                          <a:ea typeface="NVIDIA Sans" pitchFamily="34" charset="-122"/>
+                          <a:cs typeface="NVIDIA Sans" pitchFamily="34" charset="-120"/>
+                        </a:rPr>
+                        <a:t>torch 2.6-era kernels; one attention backend for vision + text</a:t>
+                      </a:r>
+                      <a:endParaRPr lang="en-US" sz="850" dirty="0">
+                        <a:latin typeface="NVIDIA Sans" charset="0"/>
+                        <a:ea typeface="NVIDIA Sans" charset="0"/>
+                        <a:cs typeface="NVIDIA Sans" charset="0"/>
+                      </a:endParaRPr>
+                    </a:p>
+                  </a:txBody>
+                  <a:tcPr marL="91440" marR="91440" marT="45720" marB="45720" anchor="ctr">
+                    <a:lnL w="6350" cap="flat" cmpd="sng" algn="ctr">
+                      <a:solidFill>
+                        <a:srgbClr val="CDCDCD"/>
+                      </a:solidFill>
+                      <a:prstDash val="solid"/>
+                      <a:round/>
+                      <a:headEnd type="none" w="med" len="med"/>
+                      <a:tailEnd type="none" w="med" len="med"/>
+                    </a:lnL>
+                    <a:lnR w="6350" cap="flat" cmpd="sng" algn="ctr">
+                      <a:solidFill>
+                        <a:srgbClr val="CDCDCD"/>
+                      </a:solidFill>
+                      <a:prstDash val="solid"/>
+                      <a:round/>
+                      <a:headEnd type="none" w="med" len="med"/>
+                      <a:tailEnd type="none" w="med" len="med"/>
+                    </a:lnR>
+                    <a:lnT w="6350" cap="flat" cmpd="sng" algn="ctr">
+                      <a:solidFill>
+                        <a:srgbClr val="CDCDCD"/>
+                      </a:solidFill>
+                      <a:prstDash val="solid"/>
+                      <a:round/>
+                      <a:headEnd type="none" w="med" len="med"/>
+                      <a:tailEnd type="none" w="med" len="med"/>
+                    </a:lnT>
+                    <a:lnB w="6350" cap="flat" cmpd="sng" algn="ctr">
+                      <a:solidFill>
+                        <a:srgbClr val="CDCDCD"/>
+                      </a:solidFill>
+                      <a:prstDash val="solid"/>
+                      <a:round/>
+                      <a:headEnd type="none" w="med" len="med"/>
+                      <a:tailEnd type="none" w="med" len="med"/>
+                    </a:lnB>
+                  </a:tcPr>
+                </a:tc>
+                <a:tc>
+                  <a:txBody>
+                    <a:bodyPr/>
+                    <a:lstStyle/>
+                    <a:p>
+                      <a:pPr algn="l" indent="0" marL="0">
+                        <a:buNone/>
+                      </a:pPr>
+                      <a:r>
+                        <a:rPr lang="en-US" sz="850" b="1" dirty="0">
+                          <a:solidFill>
+                            <a:srgbClr val="008564"/>
+                          </a:solidFill>
+                          <a:latin typeface="NVIDIA Sans" pitchFamily="34" charset="0"/>
+                          <a:ea typeface="NVIDIA Sans" pitchFamily="34" charset="-122"/>
+                          <a:cs typeface="NVIDIA Sans" pitchFamily="34" charset="-120"/>
+                        </a:rPr>
+                        <a:t>torch 2.7.1  (−37); mixed attn  (−30)</a:t>
+                      </a:r>
+                      <a:endParaRPr lang="en-US" sz="850" dirty="0">
+                        <a:latin typeface="NVIDIA Sans" charset="0"/>
+                        <a:ea typeface="NVIDIA Sans" charset="0"/>
+                        <a:cs typeface="NVIDIA Sans" charset="0"/>
+                      </a:endParaRPr>
+                    </a:p>
+                  </a:txBody>
+                  <a:tcPr marL="91440" marR="91440" marT="45720" marB="45720" anchor="ctr">
+                    <a:lnL w="6350" cap="flat" cmpd="sng" algn="ctr">
+                      <a:solidFill>
+                        <a:srgbClr val="CDCDCD"/>
+                      </a:solidFill>
+                      <a:prstDash val="solid"/>
+                      <a:round/>
+                      <a:headEnd type="none" w="med" len="med"/>
+                      <a:tailEnd type="none" w="med" len="med"/>
+                    </a:lnL>
+                    <a:lnR w="6350" cap="flat" cmpd="sng" algn="ctr">
+                      <a:solidFill>
+                        <a:srgbClr val="CDCDCD"/>
+                      </a:solidFill>
+                      <a:prstDash val="solid"/>
+                      <a:round/>
+                      <a:headEnd type="none" w="med" len="med"/>
+                      <a:tailEnd type="none" w="med" len="med"/>
+                    </a:lnR>
+                    <a:lnT w="6350" cap="flat" cmpd="sng" algn="ctr">
+                      <a:solidFill>
+                        <a:srgbClr val="CDCDCD"/>
+                      </a:solidFill>
+                      <a:prstDash val="solid"/>
+                      <a:round/>
+                      <a:headEnd type="none" w="med" len="med"/>
+                      <a:tailEnd type="none" w="med" len="med"/>
+                    </a:lnT>
+                    <a:lnB w="6350" cap="flat" cmpd="sng" algn="ctr">
+                      <a:solidFill>
+                        <a:srgbClr val="CDCDCD"/>
+                      </a:solidFill>
+                      <a:prstDash val="solid"/>
+                      <a:round/>
+                      <a:headEnd type="none" w="med" len="med"/>
+                      <a:tailEnd type="none" w="med" len="med"/>
+                    </a:lnB>
+                  </a:tcPr>
+                </a:tc>
+              </a:tr>
+            </a:tbl>
+          </a:graphicData>
+        </a:graphic>
+      </p:graphicFrame>
+      <p:sp>
+        <p:nvSpPr>
+          <p:cNvPr id="241" name="Text 238"/>
           <p:cNvSpPr/>
           <p:nvPr/>
         </p:nvSpPr>
@@ -13688,7 +14846,7 @@
       </p:sp>
       <p:sp>
         <p:nvSpPr>
-          <p:cNvPr id="241" name="Text 239"/>
+          <p:cNvPr id="242" name="Text 239"/>
           <p:cNvSpPr/>
           <p:nvPr/>
         </p:nvSpPr>
@@ -13727,7 +14885,7 @@
       </p:sp>
       <p:sp>
         <p:nvSpPr>
-          <p:cNvPr id="242" name="Shape 240"/>
+          <p:cNvPr id="243" name="Shape 240"/>
           <p:cNvSpPr/>
           <p:nvPr/>
         </p:nvSpPr>
@@ -13747,7 +14905,7 @@
       </p:sp>
       <p:pic>
         <p:nvPicPr>
-          <p:cNvPr id="243" name="Image 0" descr="/app/logos/nvidia-logo-blk-sm.png">    </p:cNvPr>
+          <p:cNvPr id="244" name="Image 0" descr="/app/logos/nvidia-logo-blk-sm.png">    </p:cNvPr>
           <p:cNvPicPr>
             <a:picLocks noChangeAspect="1"/>
           </p:cNvPicPr>

</xml_diff>

<commit_message>
docs(slides): diagnosis timeline on unified GPU-execution clock, aligned phase/module boundaries
</commit_message>
<xml_diff>
--- a/docs/slides/qwenpi-optimization.pptx
+++ b/docs/slides/qwenpi-optimization.pptx
@@ -3795,7 +3795,9 @@
           <a:p>
             <a:r>
               <a:rPr lang="en-US" dirty="0"/>
-              <a:t>Timeline from the NVTX-instrumented baseline re-capture (qwenpi_baseline_nvtx, viking-prod-303, 807 ms step).
+              <a:t>Timeline from the NVTX-instrumented baseline re-capture (qwenpi_baseline_nvtx, viking-prod-303, train_step_33, 807 ms, bs 8/GPU). Both strips use the GPU-execution clock: kernels attributed to phases/modules by their CPU launch window (correlationId join).
+CPU-side forward() returns at 225 ms - the GPU is still executing DiT forward kernels until 309 ms (eager launch-ahead). That is why phases here are defined on GPU execution, not CPU ranges.
+Qwen3.5 bwd:fwd busy = 123:50 = 2.46x, matching theory (GEMM exactly 1.94x). The SPAN ratio is only 1.18x because forward is launch-starved: occupancy 34% vs 70% in backward (Python-side launches vs C++ autograd).
 Module bands = GPU execution spans, attributed by launch-window correlation (kernels joined to their CPU launch time via correlationId). GPU busy inside the bands: Qwen3.5 fwd 50 ms, DiT fwd 120 ms, DiT bwd 224 ms, Qwen3.5 bwd 123 ms - DiT owns 43% of all GPU busy time.
 Rows 2+3 land as one ladder level (pipeline &amp; caching, -117 ms); row 5 combines bucket sizing (PR11) and the redundant-flatten removal (PR12); row 6 covers the two config-level fixes.
 [IMPORTANT] Key message: every fix in this deck was first SEEN here as a trace shape or a measured kernel cost - problems first, solutions second.</a:t>
@@ -11244,7 +11246,7 @@
                 <a:ea typeface="NVIDIA Sans" pitchFamily="34" charset="-122"/>
                 <a:cs typeface="NVIDIA Sans" pitchFamily="34" charset="-120"/>
               </a:rPr>
-              <a:t>Five problems visible in one baseline step (nsys, 806.9 ms) — each maps to a fix</a:t>
+              <a:t>One baseline step on the GPU-execution clock (807 ms, bs 8/GPU) — five problems, five fixes</a:t>
             </a:r>
             <a:endParaRPr lang="en-US" sz="1500" dirty="0"/>
           </a:p>
@@ -11259,7 +11261,7 @@
         <p:spPr>
           <a:xfrm>
             <a:off x="1508760" y="1261872"/>
-            <a:ext cx="1711375" cy="237744"/>
+            <a:ext cx="2346877" cy="237744"/>
           </a:xfrm>
           <a:prstGeom prst="rect">
             <a:avLst/>
@@ -11279,7 +11281,7 @@
         <p:spPr>
           <a:xfrm>
             <a:off x="1508760" y="1261872"/>
-            <a:ext cx="1711375" cy="237744"/>
+            <a:ext cx="2346877" cy="237744"/>
           </a:xfrm>
           <a:prstGeom prst="rect">
             <a:avLst/>
@@ -11303,7 +11305,7 @@
                 <a:ea typeface="NVIDIA Sans" pitchFamily="34" charset="-122"/>
                 <a:cs typeface="NVIDIA Sans" pitchFamily="34" charset="-120"/>
               </a:rPr>
-              <a:t>Forward 225 ms</a:t>
+              <a:t>Forward 309 ms</a:t>
             </a:r>
             <a:endParaRPr lang="en-US" sz="900" dirty="0"/>
           </a:p>
@@ -11317,8 +11319,8 @@
         </p:nvSpPr>
         <p:spPr>
           <a:xfrm>
-            <a:off x="3220135" y="1261872"/>
-            <a:ext cx="3799344" cy="237744"/>
+            <a:off x="3855637" y="1261872"/>
+            <a:ext cx="3102342" cy="237744"/>
           </a:xfrm>
           <a:prstGeom prst="rect">
             <a:avLst/>
@@ -11337,8 +11339,8 @@
         </p:nvSpPr>
         <p:spPr>
           <a:xfrm>
-            <a:off x="3220135" y="1261872"/>
-            <a:ext cx="3799344" cy="237744"/>
+            <a:off x="3855637" y="1261872"/>
+            <a:ext cx="3102342" cy="237744"/>
           </a:xfrm>
           <a:prstGeom prst="rect">
             <a:avLst/>
@@ -11362,7 +11364,7 @@
                 <a:ea typeface="NVIDIA Sans" pitchFamily="34" charset="-122"/>
                 <a:cs typeface="NVIDIA Sans" pitchFamily="34" charset="-120"/>
               </a:rPr>
-              <a:t>Backward 500 ms</a:t>
+              <a:t>Backward 409 ms</a:t>
             </a:r>
             <a:endParaRPr lang="en-US" sz="900" dirty="0"/>
           </a:p>
@@ -11376,8 +11378,8 @@
         </p:nvSpPr>
         <p:spPr>
           <a:xfrm>
-            <a:off x="7019479" y="1261872"/>
-            <a:ext cx="615761" cy="237744"/>
+            <a:off x="6957979" y="1261872"/>
+            <a:ext cx="677261" cy="237744"/>
           </a:xfrm>
           <a:prstGeom prst="rect">
             <a:avLst/>
@@ -11396,8 +11398,8 @@
         </p:nvSpPr>
         <p:spPr>
           <a:xfrm>
-            <a:off x="7019479" y="1261872"/>
-            <a:ext cx="615761" cy="237744"/>
+            <a:off x="6957979" y="1261872"/>
+            <a:ext cx="677261" cy="237744"/>
           </a:xfrm>
           <a:prstGeom prst="rect">
             <a:avLst/>
@@ -11421,7 +11423,7 @@
                 <a:ea typeface="NVIDIA Sans" pitchFamily="34" charset="-122"/>
                 <a:cs typeface="NVIDIA Sans" pitchFamily="34" charset="-120"/>
               </a:rPr>
-              <a:t>Optimizer 81 ms</a:t>
+              <a:t>Optimizer + AG 89 ms</a:t>
             </a:r>
             <a:endParaRPr lang="en-US" sz="900" dirty="0"/>
           </a:p>
@@ -11637,7 +11639,7 @@
                 <a:ea typeface="NVIDIA Sans" pitchFamily="34" charset="-122"/>
                 <a:cs typeface="NVIDIA Sans" pitchFamily="34" charset="-120"/>
               </a:rPr>
-              <a:t>DiT · 124 ms</a:t>
+              <a:t>DiT · 125 ms</a:t>
             </a:r>
             <a:endParaRPr lang="en-US" sz="850" dirty="0"/>
           </a:p>
@@ -11789,6 +11791,45 @@
         </p:nvSpPr>
         <p:spPr>
           <a:xfrm>
+            <a:off x="6957979" y="1536192"/>
+            <a:ext cx="677261" cy="237744"/>
+          </a:xfrm>
+          <a:prstGeom prst="rect">
+            <a:avLst/>
+          </a:prstGeom>
+          <a:noFill/>
+          <a:ln/>
+        </p:spPr>
+        <p:txBody>
+          <a:bodyPr wrap="square" lIns="0" tIns="0" rIns="0" bIns="0" rtlCol="0" anchor="ctr"/>
+          <a:lstStyle/>
+          <a:p>
+            <a:pPr algn="ctr" indent="0" marL="0">
+              <a:buNone/>
+            </a:pPr>
+            <a:r>
+              <a:rPr lang="en-US" sz="850" b="1" dirty="0">
+                <a:solidFill>
+                  <a:srgbClr val="5E5E5E"/>
+                </a:solidFill>
+                <a:latin typeface="NVIDIA Sans" pitchFamily="34" charset="0"/>
+                <a:ea typeface="NVIDIA Sans" pitchFamily="34" charset="-122"/>
+                <a:cs typeface="NVIDIA Sans" pitchFamily="34" charset="-120"/>
+              </a:rPr>
+              <a:t>optim · AG</a:t>
+            </a:r>
+            <a:endParaRPr lang="en-US" sz="850" dirty="0"/>
+          </a:p>
+        </p:txBody>
+      </p:sp>
+      <p:sp>
+        <p:nvSpPr>
+          <p:cNvPr id="23" name="Text 21"/>
+          <p:cNvSpPr/>
+          <p:nvPr/>
+        </p:nvSpPr>
+        <p:spPr>
+          <a:xfrm>
             <a:off x="457200" y="1536192"/>
             <a:ext cx="978408" cy="237744"/>
           </a:xfrm>
@@ -11822,7 +11863,7 @@
       </p:sp>
       <p:sp>
         <p:nvSpPr>
-          <p:cNvPr id="23" name="Text 21"/>
+          <p:cNvPr id="24" name="Text 22"/>
           <p:cNvSpPr/>
           <p:nvPr/>
         </p:nvSpPr>
@@ -11861,7 +11902,7 @@
       </p:sp>
       <p:sp>
         <p:nvSpPr>
-          <p:cNvPr id="24" name="Shape 22"/>
+          <p:cNvPr id="25" name="Shape 23"/>
           <p:cNvSpPr/>
           <p:nvPr/>
         </p:nvSpPr>
@@ -11886,7 +11927,7 @@
       </p:sp>
       <p:sp>
         <p:nvSpPr>
-          <p:cNvPr id="25" name="Shape 23"/>
+          <p:cNvPr id="26" name="Shape 24"/>
           <p:cNvSpPr/>
           <p:nvPr/>
         </p:nvSpPr>
@@ -11906,7 +11947,7 @@
       </p:sp>
       <p:sp>
         <p:nvSpPr>
-          <p:cNvPr id="26" name="Shape 24"/>
+          <p:cNvPr id="27" name="Shape 25"/>
           <p:cNvSpPr/>
           <p:nvPr/>
         </p:nvSpPr>
@@ -11926,7 +11967,7 @@
       </p:sp>
       <p:sp>
         <p:nvSpPr>
-          <p:cNvPr id="27" name="Shape 25"/>
+          <p:cNvPr id="28" name="Shape 26"/>
           <p:cNvSpPr/>
           <p:nvPr/>
         </p:nvSpPr>
@@ -11946,7 +11987,7 @@
       </p:sp>
       <p:sp>
         <p:nvSpPr>
-          <p:cNvPr id="28" name="Shape 26"/>
+          <p:cNvPr id="29" name="Shape 27"/>
           <p:cNvSpPr/>
           <p:nvPr/>
         </p:nvSpPr>
@@ -11966,7 +12007,7 @@
       </p:sp>
       <p:sp>
         <p:nvSpPr>
-          <p:cNvPr id="29" name="Shape 27"/>
+          <p:cNvPr id="30" name="Shape 28"/>
           <p:cNvSpPr/>
           <p:nvPr/>
         </p:nvSpPr>
@@ -11986,7 +12027,7 @@
       </p:sp>
       <p:sp>
         <p:nvSpPr>
-          <p:cNvPr id="30" name="Shape 28"/>
+          <p:cNvPr id="31" name="Shape 29"/>
           <p:cNvSpPr/>
           <p:nvPr/>
         </p:nvSpPr>
@@ -12006,7 +12047,7 @@
       </p:sp>
       <p:sp>
         <p:nvSpPr>
-          <p:cNvPr id="31" name="Shape 29"/>
+          <p:cNvPr id="32" name="Shape 30"/>
           <p:cNvSpPr/>
           <p:nvPr/>
         </p:nvSpPr>
@@ -12026,7 +12067,7 @@
       </p:sp>
       <p:sp>
         <p:nvSpPr>
-          <p:cNvPr id="32" name="Shape 30"/>
+          <p:cNvPr id="33" name="Shape 31"/>
           <p:cNvSpPr/>
           <p:nvPr/>
         </p:nvSpPr>
@@ -12046,7 +12087,7 @@
       </p:sp>
       <p:sp>
         <p:nvSpPr>
-          <p:cNvPr id="33" name="Shape 31"/>
+          <p:cNvPr id="34" name="Shape 32"/>
           <p:cNvSpPr/>
           <p:nvPr/>
         </p:nvSpPr>
@@ -12066,7 +12107,7 @@
       </p:sp>
       <p:sp>
         <p:nvSpPr>
-          <p:cNvPr id="34" name="Shape 32"/>
+          <p:cNvPr id="35" name="Shape 33"/>
           <p:cNvSpPr/>
           <p:nvPr/>
         </p:nvSpPr>
@@ -12086,7 +12127,7 @@
       </p:sp>
       <p:sp>
         <p:nvSpPr>
-          <p:cNvPr id="35" name="Shape 33"/>
+          <p:cNvPr id="36" name="Shape 34"/>
           <p:cNvSpPr/>
           <p:nvPr/>
         </p:nvSpPr>
@@ -12106,7 +12147,7 @@
       </p:sp>
       <p:sp>
         <p:nvSpPr>
-          <p:cNvPr id="36" name="Shape 34"/>
+          <p:cNvPr id="37" name="Shape 35"/>
           <p:cNvSpPr/>
           <p:nvPr/>
         </p:nvSpPr>
@@ -12126,7 +12167,7 @@
       </p:sp>
       <p:sp>
         <p:nvSpPr>
-          <p:cNvPr id="37" name="Shape 35"/>
+          <p:cNvPr id="38" name="Shape 36"/>
           <p:cNvSpPr/>
           <p:nvPr/>
         </p:nvSpPr>
@@ -12146,7 +12187,7 @@
       </p:sp>
       <p:sp>
         <p:nvSpPr>
-          <p:cNvPr id="38" name="Shape 36"/>
+          <p:cNvPr id="39" name="Shape 37"/>
           <p:cNvSpPr/>
           <p:nvPr/>
         </p:nvSpPr>
@@ -12166,7 +12207,7 @@
       </p:sp>
       <p:sp>
         <p:nvSpPr>
-          <p:cNvPr id="39" name="Shape 37"/>
+          <p:cNvPr id="40" name="Shape 38"/>
           <p:cNvSpPr/>
           <p:nvPr/>
         </p:nvSpPr>
@@ -12186,7 +12227,7 @@
       </p:sp>
       <p:sp>
         <p:nvSpPr>
-          <p:cNvPr id="40" name="Shape 38"/>
+          <p:cNvPr id="41" name="Shape 39"/>
           <p:cNvSpPr/>
           <p:nvPr/>
         </p:nvSpPr>
@@ -12206,7 +12247,7 @@
       </p:sp>
       <p:sp>
         <p:nvSpPr>
-          <p:cNvPr id="41" name="Shape 39"/>
+          <p:cNvPr id="42" name="Shape 40"/>
           <p:cNvSpPr/>
           <p:nvPr/>
         </p:nvSpPr>
@@ -12226,7 +12267,7 @@
       </p:sp>
       <p:sp>
         <p:nvSpPr>
-          <p:cNvPr id="42" name="Shape 40"/>
+          <p:cNvPr id="43" name="Shape 41"/>
           <p:cNvSpPr/>
           <p:nvPr/>
         </p:nvSpPr>
@@ -12246,7 +12287,7 @@
       </p:sp>
       <p:sp>
         <p:nvSpPr>
-          <p:cNvPr id="43" name="Shape 41"/>
+          <p:cNvPr id="44" name="Shape 42"/>
           <p:cNvSpPr/>
           <p:nvPr/>
         </p:nvSpPr>
@@ -12266,7 +12307,7 @@
       </p:sp>
       <p:sp>
         <p:nvSpPr>
-          <p:cNvPr id="44" name="Shape 42"/>
+          <p:cNvPr id="45" name="Shape 43"/>
           <p:cNvSpPr/>
           <p:nvPr/>
         </p:nvSpPr>
@@ -12286,7 +12327,7 @@
       </p:sp>
       <p:sp>
         <p:nvSpPr>
-          <p:cNvPr id="45" name="Shape 43"/>
+          <p:cNvPr id="46" name="Shape 44"/>
           <p:cNvSpPr/>
           <p:nvPr/>
         </p:nvSpPr>
@@ -12306,7 +12347,7 @@
       </p:sp>
       <p:sp>
         <p:nvSpPr>
-          <p:cNvPr id="46" name="Shape 44"/>
+          <p:cNvPr id="47" name="Shape 45"/>
           <p:cNvSpPr/>
           <p:nvPr/>
         </p:nvSpPr>
@@ -12326,7 +12367,7 @@
       </p:sp>
       <p:sp>
         <p:nvSpPr>
-          <p:cNvPr id="47" name="Shape 45"/>
+          <p:cNvPr id="48" name="Shape 46"/>
           <p:cNvSpPr/>
           <p:nvPr/>
         </p:nvSpPr>
@@ -12346,7 +12387,7 @@
       </p:sp>
       <p:sp>
         <p:nvSpPr>
-          <p:cNvPr id="48" name="Shape 46"/>
+          <p:cNvPr id="49" name="Shape 47"/>
           <p:cNvSpPr/>
           <p:nvPr/>
         </p:nvSpPr>
@@ -12366,7 +12407,7 @@
       </p:sp>
       <p:sp>
         <p:nvSpPr>
-          <p:cNvPr id="49" name="Shape 47"/>
+          <p:cNvPr id="50" name="Shape 48"/>
           <p:cNvSpPr/>
           <p:nvPr/>
         </p:nvSpPr>
@@ -12386,7 +12427,7 @@
       </p:sp>
       <p:sp>
         <p:nvSpPr>
-          <p:cNvPr id="50" name="Shape 48"/>
+          <p:cNvPr id="51" name="Shape 49"/>
           <p:cNvSpPr/>
           <p:nvPr/>
         </p:nvSpPr>
@@ -12406,7 +12447,7 @@
       </p:sp>
       <p:sp>
         <p:nvSpPr>
-          <p:cNvPr id="51" name="Shape 49"/>
+          <p:cNvPr id="52" name="Shape 50"/>
           <p:cNvSpPr/>
           <p:nvPr/>
         </p:nvSpPr>
@@ -12426,7 +12467,7 @@
       </p:sp>
       <p:sp>
         <p:nvSpPr>
-          <p:cNvPr id="52" name="Shape 50"/>
+          <p:cNvPr id="53" name="Shape 51"/>
           <p:cNvSpPr/>
           <p:nvPr/>
         </p:nvSpPr>
@@ -12446,7 +12487,7 @@
       </p:sp>
       <p:sp>
         <p:nvSpPr>
-          <p:cNvPr id="53" name="Shape 51"/>
+          <p:cNvPr id="54" name="Shape 52"/>
           <p:cNvSpPr/>
           <p:nvPr/>
         </p:nvSpPr>
@@ -12466,7 +12507,7 @@
       </p:sp>
       <p:sp>
         <p:nvSpPr>
-          <p:cNvPr id="54" name="Shape 52"/>
+          <p:cNvPr id="55" name="Shape 53"/>
           <p:cNvSpPr/>
           <p:nvPr/>
         </p:nvSpPr>
@@ -12486,7 +12527,7 @@
       </p:sp>
       <p:sp>
         <p:nvSpPr>
-          <p:cNvPr id="55" name="Shape 53"/>
+          <p:cNvPr id="56" name="Shape 54"/>
           <p:cNvSpPr/>
           <p:nvPr/>
         </p:nvSpPr>
@@ -12506,7 +12547,7 @@
       </p:sp>
       <p:sp>
         <p:nvSpPr>
-          <p:cNvPr id="56" name="Shape 54"/>
+          <p:cNvPr id="57" name="Shape 55"/>
           <p:cNvSpPr/>
           <p:nvPr/>
         </p:nvSpPr>
@@ -12526,7 +12567,7 @@
       </p:sp>
       <p:sp>
         <p:nvSpPr>
-          <p:cNvPr id="57" name="Shape 55"/>
+          <p:cNvPr id="58" name="Shape 56"/>
           <p:cNvSpPr/>
           <p:nvPr/>
         </p:nvSpPr>
@@ -12546,7 +12587,7 @@
       </p:sp>
       <p:sp>
         <p:nvSpPr>
-          <p:cNvPr id="58" name="Shape 56"/>
+          <p:cNvPr id="59" name="Shape 57"/>
           <p:cNvSpPr/>
           <p:nvPr/>
         </p:nvSpPr>
@@ -12566,7 +12607,7 @@
       </p:sp>
       <p:sp>
         <p:nvSpPr>
-          <p:cNvPr id="59" name="Shape 57"/>
+          <p:cNvPr id="60" name="Shape 58"/>
           <p:cNvSpPr/>
           <p:nvPr/>
         </p:nvSpPr>
@@ -12586,7 +12627,7 @@
       </p:sp>
       <p:sp>
         <p:nvSpPr>
-          <p:cNvPr id="60" name="Shape 58"/>
+          <p:cNvPr id="61" name="Shape 59"/>
           <p:cNvSpPr/>
           <p:nvPr/>
         </p:nvSpPr>
@@ -12606,7 +12647,7 @@
       </p:sp>
       <p:sp>
         <p:nvSpPr>
-          <p:cNvPr id="61" name="Shape 59"/>
+          <p:cNvPr id="62" name="Shape 60"/>
           <p:cNvSpPr/>
           <p:nvPr/>
         </p:nvSpPr>
@@ -12626,7 +12667,7 @@
       </p:sp>
       <p:sp>
         <p:nvSpPr>
-          <p:cNvPr id="62" name="Shape 60"/>
+          <p:cNvPr id="63" name="Shape 61"/>
           <p:cNvSpPr/>
           <p:nvPr/>
         </p:nvSpPr>
@@ -12646,7 +12687,7 @@
       </p:sp>
       <p:sp>
         <p:nvSpPr>
-          <p:cNvPr id="63" name="Shape 61"/>
+          <p:cNvPr id="64" name="Shape 62"/>
           <p:cNvSpPr/>
           <p:nvPr/>
         </p:nvSpPr>
@@ -12666,7 +12707,7 @@
       </p:sp>
       <p:sp>
         <p:nvSpPr>
-          <p:cNvPr id="64" name="Shape 62"/>
+          <p:cNvPr id="65" name="Shape 63"/>
           <p:cNvSpPr/>
           <p:nvPr/>
         </p:nvSpPr>
@@ -12686,7 +12727,7 @@
       </p:sp>
       <p:sp>
         <p:nvSpPr>
-          <p:cNvPr id="65" name="Shape 63"/>
+          <p:cNvPr id="66" name="Shape 64"/>
           <p:cNvSpPr/>
           <p:nvPr/>
         </p:nvSpPr>
@@ -12706,7 +12747,7 @@
       </p:sp>
       <p:sp>
         <p:nvSpPr>
-          <p:cNvPr id="66" name="Shape 64"/>
+          <p:cNvPr id="67" name="Shape 65"/>
           <p:cNvSpPr/>
           <p:nvPr/>
         </p:nvSpPr>
@@ -12726,7 +12767,7 @@
       </p:sp>
       <p:sp>
         <p:nvSpPr>
-          <p:cNvPr id="67" name="Shape 65"/>
+          <p:cNvPr id="68" name="Shape 66"/>
           <p:cNvSpPr/>
           <p:nvPr/>
         </p:nvSpPr>
@@ -12746,7 +12787,7 @@
       </p:sp>
       <p:sp>
         <p:nvSpPr>
-          <p:cNvPr id="68" name="Shape 66"/>
+          <p:cNvPr id="69" name="Shape 67"/>
           <p:cNvSpPr/>
           <p:nvPr/>
         </p:nvSpPr>
@@ -12766,7 +12807,7 @@
       </p:sp>
       <p:sp>
         <p:nvSpPr>
-          <p:cNvPr id="69" name="Shape 67"/>
+          <p:cNvPr id="70" name="Shape 68"/>
           <p:cNvSpPr/>
           <p:nvPr/>
         </p:nvSpPr>
@@ -12786,7 +12827,7 @@
       </p:sp>
       <p:sp>
         <p:nvSpPr>
-          <p:cNvPr id="70" name="Shape 68"/>
+          <p:cNvPr id="71" name="Shape 69"/>
           <p:cNvSpPr/>
           <p:nvPr/>
         </p:nvSpPr>
@@ -12806,7 +12847,7 @@
       </p:sp>
       <p:sp>
         <p:nvSpPr>
-          <p:cNvPr id="71" name="Shape 69"/>
+          <p:cNvPr id="72" name="Shape 70"/>
           <p:cNvSpPr/>
           <p:nvPr/>
         </p:nvSpPr>
@@ -12826,7 +12867,7 @@
       </p:sp>
       <p:sp>
         <p:nvSpPr>
-          <p:cNvPr id="72" name="Shape 70"/>
+          <p:cNvPr id="73" name="Shape 71"/>
           <p:cNvSpPr/>
           <p:nvPr/>
         </p:nvSpPr>
@@ -12846,7 +12887,7 @@
       </p:sp>
       <p:sp>
         <p:nvSpPr>
-          <p:cNvPr id="73" name="Shape 71"/>
+          <p:cNvPr id="74" name="Shape 72"/>
           <p:cNvSpPr/>
           <p:nvPr/>
         </p:nvSpPr>
@@ -12866,7 +12907,7 @@
       </p:sp>
       <p:sp>
         <p:nvSpPr>
-          <p:cNvPr id="74" name="Shape 72"/>
+          <p:cNvPr id="75" name="Shape 73"/>
           <p:cNvSpPr/>
           <p:nvPr/>
         </p:nvSpPr>
@@ -12886,7 +12927,7 @@
       </p:sp>
       <p:sp>
         <p:nvSpPr>
-          <p:cNvPr id="75" name="Shape 73"/>
+          <p:cNvPr id="76" name="Shape 74"/>
           <p:cNvSpPr/>
           <p:nvPr/>
         </p:nvSpPr>
@@ -12906,7 +12947,7 @@
       </p:sp>
       <p:sp>
         <p:nvSpPr>
-          <p:cNvPr id="76" name="Shape 74"/>
+          <p:cNvPr id="77" name="Shape 75"/>
           <p:cNvSpPr/>
           <p:nvPr/>
         </p:nvSpPr>
@@ -12926,7 +12967,7 @@
       </p:sp>
       <p:sp>
         <p:nvSpPr>
-          <p:cNvPr id="77" name="Shape 75"/>
+          <p:cNvPr id="78" name="Shape 76"/>
           <p:cNvSpPr/>
           <p:nvPr/>
         </p:nvSpPr>
@@ -12946,7 +12987,7 @@
       </p:sp>
       <p:sp>
         <p:nvSpPr>
-          <p:cNvPr id="78" name="Shape 76"/>
+          <p:cNvPr id="79" name="Shape 77"/>
           <p:cNvSpPr/>
           <p:nvPr/>
         </p:nvSpPr>
@@ -12966,7 +13007,7 @@
       </p:sp>
       <p:sp>
         <p:nvSpPr>
-          <p:cNvPr id="79" name="Shape 77"/>
+          <p:cNvPr id="80" name="Shape 78"/>
           <p:cNvSpPr/>
           <p:nvPr/>
         </p:nvSpPr>
@@ -12986,7 +13027,7 @@
       </p:sp>
       <p:sp>
         <p:nvSpPr>
-          <p:cNvPr id="80" name="Shape 78"/>
+          <p:cNvPr id="81" name="Shape 79"/>
           <p:cNvSpPr/>
           <p:nvPr/>
         </p:nvSpPr>
@@ -13006,7 +13047,7 @@
       </p:sp>
       <p:sp>
         <p:nvSpPr>
-          <p:cNvPr id="81" name="Shape 79"/>
+          <p:cNvPr id="82" name="Shape 80"/>
           <p:cNvSpPr/>
           <p:nvPr/>
         </p:nvSpPr>
@@ -13026,7 +13067,7 @@
       </p:sp>
       <p:sp>
         <p:nvSpPr>
-          <p:cNvPr id="82" name="Shape 80"/>
+          <p:cNvPr id="83" name="Shape 81"/>
           <p:cNvSpPr/>
           <p:nvPr/>
         </p:nvSpPr>
@@ -13046,7 +13087,7 @@
       </p:sp>
       <p:sp>
         <p:nvSpPr>
-          <p:cNvPr id="83" name="Shape 81"/>
+          <p:cNvPr id="84" name="Shape 82"/>
           <p:cNvSpPr/>
           <p:nvPr/>
         </p:nvSpPr>
@@ -13066,7 +13107,7 @@
       </p:sp>
       <p:sp>
         <p:nvSpPr>
-          <p:cNvPr id="84" name="Shape 82"/>
+          <p:cNvPr id="85" name="Shape 83"/>
           <p:cNvSpPr/>
           <p:nvPr/>
         </p:nvSpPr>
@@ -13086,7 +13127,7 @@
       </p:sp>
       <p:sp>
         <p:nvSpPr>
-          <p:cNvPr id="85" name="Shape 83"/>
+          <p:cNvPr id="86" name="Shape 84"/>
           <p:cNvSpPr/>
           <p:nvPr/>
         </p:nvSpPr>
@@ -13106,7 +13147,7 @@
       </p:sp>
       <p:sp>
         <p:nvSpPr>
-          <p:cNvPr id="86" name="Shape 84"/>
+          <p:cNvPr id="87" name="Shape 85"/>
           <p:cNvSpPr/>
           <p:nvPr/>
         </p:nvSpPr>
@@ -13126,7 +13167,7 @@
       </p:sp>
       <p:sp>
         <p:nvSpPr>
-          <p:cNvPr id="87" name="Shape 85"/>
+          <p:cNvPr id="88" name="Shape 86"/>
           <p:cNvSpPr/>
           <p:nvPr/>
         </p:nvSpPr>
@@ -13146,7 +13187,7 @@
       </p:sp>
       <p:sp>
         <p:nvSpPr>
-          <p:cNvPr id="88" name="Shape 86"/>
+          <p:cNvPr id="89" name="Shape 87"/>
           <p:cNvSpPr/>
           <p:nvPr/>
         </p:nvSpPr>
@@ -13166,7 +13207,7 @@
       </p:sp>
       <p:sp>
         <p:nvSpPr>
-          <p:cNvPr id="89" name="Shape 87"/>
+          <p:cNvPr id="90" name="Shape 88"/>
           <p:cNvSpPr/>
           <p:nvPr/>
         </p:nvSpPr>
@@ -13186,7 +13227,7 @@
       </p:sp>
       <p:sp>
         <p:nvSpPr>
-          <p:cNvPr id="90" name="Shape 88"/>
+          <p:cNvPr id="91" name="Shape 89"/>
           <p:cNvSpPr/>
           <p:nvPr/>
         </p:nvSpPr>
@@ -13206,7 +13247,7 @@
       </p:sp>
       <p:sp>
         <p:nvSpPr>
-          <p:cNvPr id="91" name="Shape 89"/>
+          <p:cNvPr id="92" name="Shape 90"/>
           <p:cNvSpPr/>
           <p:nvPr/>
         </p:nvSpPr>
@@ -13226,7 +13267,7 @@
       </p:sp>
       <p:sp>
         <p:nvSpPr>
-          <p:cNvPr id="92" name="Shape 90"/>
+          <p:cNvPr id="93" name="Shape 91"/>
           <p:cNvSpPr/>
           <p:nvPr/>
         </p:nvSpPr>
@@ -13246,7 +13287,7 @@
       </p:sp>
       <p:sp>
         <p:nvSpPr>
-          <p:cNvPr id="93" name="Shape 91"/>
+          <p:cNvPr id="94" name="Shape 92"/>
           <p:cNvSpPr/>
           <p:nvPr/>
         </p:nvSpPr>
@@ -13266,7 +13307,7 @@
       </p:sp>
       <p:sp>
         <p:nvSpPr>
-          <p:cNvPr id="94" name="Shape 92"/>
+          <p:cNvPr id="95" name="Shape 93"/>
           <p:cNvSpPr/>
           <p:nvPr/>
         </p:nvSpPr>
@@ -13286,7 +13327,7 @@
       </p:sp>
       <p:sp>
         <p:nvSpPr>
-          <p:cNvPr id="95" name="Shape 93"/>
+          <p:cNvPr id="96" name="Shape 94"/>
           <p:cNvSpPr/>
           <p:nvPr/>
         </p:nvSpPr>
@@ -13306,7 +13347,7 @@
       </p:sp>
       <p:sp>
         <p:nvSpPr>
-          <p:cNvPr id="96" name="Shape 94"/>
+          <p:cNvPr id="97" name="Shape 95"/>
           <p:cNvSpPr/>
           <p:nvPr/>
         </p:nvSpPr>
@@ -13326,7 +13367,7 @@
       </p:sp>
       <p:sp>
         <p:nvSpPr>
-          <p:cNvPr id="97" name="Shape 95"/>
+          <p:cNvPr id="98" name="Shape 96"/>
           <p:cNvSpPr/>
           <p:nvPr/>
         </p:nvSpPr>
@@ -13346,7 +13387,7 @@
       </p:sp>
       <p:sp>
         <p:nvSpPr>
-          <p:cNvPr id="98" name="Shape 96"/>
+          <p:cNvPr id="99" name="Shape 97"/>
           <p:cNvSpPr/>
           <p:nvPr/>
         </p:nvSpPr>
@@ -13366,7 +13407,7 @@
       </p:sp>
       <p:sp>
         <p:nvSpPr>
-          <p:cNvPr id="99" name="Shape 97"/>
+          <p:cNvPr id="100" name="Shape 98"/>
           <p:cNvSpPr/>
           <p:nvPr/>
         </p:nvSpPr>
@@ -13386,7 +13427,7 @@
       </p:sp>
       <p:sp>
         <p:nvSpPr>
-          <p:cNvPr id="100" name="Shape 98"/>
+          <p:cNvPr id="101" name="Shape 99"/>
           <p:cNvSpPr/>
           <p:nvPr/>
         </p:nvSpPr>
@@ -13406,7 +13447,7 @@
       </p:sp>
       <p:sp>
         <p:nvSpPr>
-          <p:cNvPr id="101" name="Shape 99"/>
+          <p:cNvPr id="102" name="Shape 100"/>
           <p:cNvSpPr/>
           <p:nvPr/>
         </p:nvSpPr>
@@ -13426,7 +13467,7 @@
       </p:sp>
       <p:sp>
         <p:nvSpPr>
-          <p:cNvPr id="102" name="Shape 100"/>
+          <p:cNvPr id="103" name="Shape 101"/>
           <p:cNvSpPr/>
           <p:nvPr/>
         </p:nvSpPr>
@@ -13446,7 +13487,7 @@
       </p:sp>
       <p:sp>
         <p:nvSpPr>
-          <p:cNvPr id="103" name="Shape 101"/>
+          <p:cNvPr id="104" name="Shape 102"/>
           <p:cNvSpPr/>
           <p:nvPr/>
         </p:nvSpPr>
@@ -13466,7 +13507,7 @@
       </p:sp>
       <p:sp>
         <p:nvSpPr>
-          <p:cNvPr id="104" name="Shape 102"/>
+          <p:cNvPr id="105" name="Shape 103"/>
           <p:cNvSpPr/>
           <p:nvPr/>
         </p:nvSpPr>
@@ -13486,7 +13527,7 @@
       </p:sp>
       <p:sp>
         <p:nvSpPr>
-          <p:cNvPr id="105" name="Shape 103"/>
+          <p:cNvPr id="106" name="Shape 104"/>
           <p:cNvSpPr/>
           <p:nvPr/>
         </p:nvSpPr>
@@ -13506,7 +13547,7 @@
       </p:sp>
       <p:sp>
         <p:nvSpPr>
-          <p:cNvPr id="106" name="Shape 104"/>
+          <p:cNvPr id="107" name="Shape 105"/>
           <p:cNvSpPr/>
           <p:nvPr/>
         </p:nvSpPr>
@@ -13526,7 +13567,7 @@
       </p:sp>
       <p:sp>
         <p:nvSpPr>
-          <p:cNvPr id="107" name="Shape 105"/>
+          <p:cNvPr id="108" name="Shape 106"/>
           <p:cNvSpPr/>
           <p:nvPr/>
         </p:nvSpPr>
@@ -13546,7 +13587,7 @@
       </p:sp>
       <p:sp>
         <p:nvSpPr>
-          <p:cNvPr id="108" name="Shape 106"/>
+          <p:cNvPr id="109" name="Shape 107"/>
           <p:cNvSpPr/>
           <p:nvPr/>
         </p:nvSpPr>
@@ -13566,7 +13607,7 @@
       </p:sp>
       <p:sp>
         <p:nvSpPr>
-          <p:cNvPr id="109" name="Shape 107"/>
+          <p:cNvPr id="110" name="Shape 108"/>
           <p:cNvSpPr/>
           <p:nvPr/>
         </p:nvSpPr>
@@ -13586,7 +13627,7 @@
       </p:sp>
       <p:sp>
         <p:nvSpPr>
-          <p:cNvPr id="110" name="Shape 108"/>
+          <p:cNvPr id="111" name="Shape 109"/>
           <p:cNvSpPr/>
           <p:nvPr/>
         </p:nvSpPr>
@@ -13606,7 +13647,7 @@
       </p:sp>
       <p:sp>
         <p:nvSpPr>
-          <p:cNvPr id="111" name="Shape 109"/>
+          <p:cNvPr id="112" name="Shape 110"/>
           <p:cNvSpPr/>
           <p:nvPr/>
         </p:nvSpPr>
@@ -13626,7 +13667,7 @@
       </p:sp>
       <p:sp>
         <p:nvSpPr>
-          <p:cNvPr id="112" name="Shape 110"/>
+          <p:cNvPr id="113" name="Shape 111"/>
           <p:cNvSpPr/>
           <p:nvPr/>
         </p:nvSpPr>
@@ -13646,7 +13687,7 @@
       </p:sp>
       <p:sp>
         <p:nvSpPr>
-          <p:cNvPr id="113" name="Shape 111"/>
+          <p:cNvPr id="114" name="Shape 112"/>
           <p:cNvSpPr/>
           <p:nvPr/>
         </p:nvSpPr>
@@ -13666,7 +13707,7 @@
       </p:sp>
       <p:sp>
         <p:nvSpPr>
-          <p:cNvPr id="114" name="Shape 112"/>
+          <p:cNvPr id="115" name="Shape 113"/>
           <p:cNvSpPr/>
           <p:nvPr/>
         </p:nvSpPr>
@@ -13686,7 +13727,7 @@
       </p:sp>
       <p:sp>
         <p:nvSpPr>
-          <p:cNvPr id="115" name="Shape 113"/>
+          <p:cNvPr id="116" name="Shape 114"/>
           <p:cNvSpPr/>
           <p:nvPr/>
         </p:nvSpPr>
@@ -13706,7 +13747,7 @@
       </p:sp>
       <p:sp>
         <p:nvSpPr>
-          <p:cNvPr id="116" name="Shape 114"/>
+          <p:cNvPr id="117" name="Shape 115"/>
           <p:cNvSpPr/>
           <p:nvPr/>
         </p:nvSpPr>
@@ -13726,7 +13767,7 @@
       </p:sp>
       <p:sp>
         <p:nvSpPr>
-          <p:cNvPr id="117" name="Shape 115"/>
+          <p:cNvPr id="118" name="Shape 116"/>
           <p:cNvSpPr/>
           <p:nvPr/>
         </p:nvSpPr>
@@ -13746,7 +13787,7 @@
       </p:sp>
       <p:sp>
         <p:nvSpPr>
-          <p:cNvPr id="118" name="Shape 116"/>
+          <p:cNvPr id="119" name="Shape 117"/>
           <p:cNvSpPr/>
           <p:nvPr/>
         </p:nvSpPr>
@@ -13766,7 +13807,7 @@
       </p:sp>
       <p:sp>
         <p:nvSpPr>
-          <p:cNvPr id="119" name="Shape 117"/>
+          <p:cNvPr id="120" name="Shape 118"/>
           <p:cNvSpPr/>
           <p:nvPr/>
         </p:nvSpPr>
@@ -13786,7 +13827,7 @@
       </p:sp>
       <p:sp>
         <p:nvSpPr>
-          <p:cNvPr id="120" name="Shape 118"/>
+          <p:cNvPr id="121" name="Shape 119"/>
           <p:cNvSpPr/>
           <p:nvPr/>
         </p:nvSpPr>
@@ -13806,7 +13847,7 @@
       </p:sp>
       <p:sp>
         <p:nvSpPr>
-          <p:cNvPr id="121" name="Shape 119"/>
+          <p:cNvPr id="122" name="Shape 120"/>
           <p:cNvSpPr/>
           <p:nvPr/>
         </p:nvSpPr>
@@ -13826,7 +13867,7 @@
       </p:sp>
       <p:sp>
         <p:nvSpPr>
-          <p:cNvPr id="122" name="Shape 120"/>
+          <p:cNvPr id="123" name="Shape 121"/>
           <p:cNvSpPr/>
           <p:nvPr/>
         </p:nvSpPr>
@@ -13846,7 +13887,7 @@
       </p:sp>
       <p:sp>
         <p:nvSpPr>
-          <p:cNvPr id="123" name="Shape 121"/>
+          <p:cNvPr id="124" name="Shape 122"/>
           <p:cNvSpPr/>
           <p:nvPr/>
         </p:nvSpPr>
@@ -13866,7 +13907,7 @@
       </p:sp>
       <p:sp>
         <p:nvSpPr>
-          <p:cNvPr id="124" name="Shape 122"/>
+          <p:cNvPr id="125" name="Shape 123"/>
           <p:cNvSpPr/>
           <p:nvPr/>
         </p:nvSpPr>
@@ -13886,7 +13927,7 @@
       </p:sp>
       <p:sp>
         <p:nvSpPr>
-          <p:cNvPr id="125" name="Shape 123"/>
+          <p:cNvPr id="126" name="Shape 124"/>
           <p:cNvSpPr/>
           <p:nvPr/>
         </p:nvSpPr>
@@ -13906,7 +13947,7 @@
       </p:sp>
       <p:sp>
         <p:nvSpPr>
-          <p:cNvPr id="126" name="Shape 124"/>
+          <p:cNvPr id="127" name="Shape 125"/>
           <p:cNvSpPr/>
           <p:nvPr/>
         </p:nvSpPr>
@@ -13926,7 +13967,7 @@
       </p:sp>
       <p:sp>
         <p:nvSpPr>
-          <p:cNvPr id="127" name="Shape 125"/>
+          <p:cNvPr id="128" name="Shape 126"/>
           <p:cNvSpPr/>
           <p:nvPr/>
         </p:nvSpPr>
@@ -13946,7 +13987,7 @@
       </p:sp>
       <p:sp>
         <p:nvSpPr>
-          <p:cNvPr id="128" name="Shape 126"/>
+          <p:cNvPr id="129" name="Shape 127"/>
           <p:cNvSpPr/>
           <p:nvPr/>
         </p:nvSpPr>
@@ -13966,7 +14007,7 @@
       </p:sp>
       <p:sp>
         <p:nvSpPr>
-          <p:cNvPr id="129" name="Shape 127"/>
+          <p:cNvPr id="130" name="Shape 128"/>
           <p:cNvSpPr/>
           <p:nvPr/>
         </p:nvSpPr>
@@ -13986,7 +14027,7 @@
       </p:sp>
       <p:sp>
         <p:nvSpPr>
-          <p:cNvPr id="130" name="Shape 128"/>
+          <p:cNvPr id="131" name="Shape 129"/>
           <p:cNvSpPr/>
           <p:nvPr/>
         </p:nvSpPr>
@@ -14006,7 +14047,7 @@
       </p:sp>
       <p:sp>
         <p:nvSpPr>
-          <p:cNvPr id="131" name="Shape 129"/>
+          <p:cNvPr id="132" name="Shape 130"/>
           <p:cNvSpPr/>
           <p:nvPr/>
         </p:nvSpPr>
@@ -14026,7 +14067,7 @@
       </p:sp>
       <p:sp>
         <p:nvSpPr>
-          <p:cNvPr id="132" name="Shape 130"/>
+          <p:cNvPr id="133" name="Shape 131"/>
           <p:cNvSpPr/>
           <p:nvPr/>
         </p:nvSpPr>
@@ -14046,7 +14087,7 @@
       </p:sp>
       <p:sp>
         <p:nvSpPr>
-          <p:cNvPr id="133" name="Shape 131"/>
+          <p:cNvPr id="134" name="Shape 132"/>
           <p:cNvSpPr/>
           <p:nvPr/>
         </p:nvSpPr>
@@ -14066,7 +14107,7 @@
       </p:sp>
       <p:sp>
         <p:nvSpPr>
-          <p:cNvPr id="134" name="Shape 132"/>
+          <p:cNvPr id="135" name="Shape 133"/>
           <p:cNvSpPr/>
           <p:nvPr/>
         </p:nvSpPr>
@@ -14086,7 +14127,7 @@
       </p:sp>
       <p:sp>
         <p:nvSpPr>
-          <p:cNvPr id="135" name="Shape 133"/>
+          <p:cNvPr id="136" name="Shape 134"/>
           <p:cNvSpPr/>
           <p:nvPr/>
         </p:nvSpPr>
@@ -14106,7 +14147,7 @@
       </p:sp>
       <p:sp>
         <p:nvSpPr>
-          <p:cNvPr id="136" name="Shape 134"/>
+          <p:cNvPr id="137" name="Shape 135"/>
           <p:cNvSpPr/>
           <p:nvPr/>
         </p:nvSpPr>
@@ -14126,7 +14167,7 @@
       </p:sp>
       <p:sp>
         <p:nvSpPr>
-          <p:cNvPr id="137" name="Shape 135"/>
+          <p:cNvPr id="138" name="Shape 136"/>
           <p:cNvSpPr/>
           <p:nvPr/>
         </p:nvSpPr>
@@ -14146,7 +14187,7 @@
       </p:sp>
       <p:sp>
         <p:nvSpPr>
-          <p:cNvPr id="138" name="Shape 136"/>
+          <p:cNvPr id="139" name="Shape 137"/>
           <p:cNvSpPr/>
           <p:nvPr/>
         </p:nvSpPr>
@@ -14166,7 +14207,7 @@
       </p:sp>
       <p:sp>
         <p:nvSpPr>
-          <p:cNvPr id="139" name="Shape 137"/>
+          <p:cNvPr id="140" name="Shape 138"/>
           <p:cNvSpPr/>
           <p:nvPr/>
         </p:nvSpPr>
@@ -14186,7 +14227,7 @@
       </p:sp>
       <p:sp>
         <p:nvSpPr>
-          <p:cNvPr id="140" name="Shape 138"/>
+          <p:cNvPr id="141" name="Shape 139"/>
           <p:cNvSpPr/>
           <p:nvPr/>
         </p:nvSpPr>
@@ -14206,7 +14247,7 @@
       </p:sp>
       <p:sp>
         <p:nvSpPr>
-          <p:cNvPr id="141" name="Shape 139"/>
+          <p:cNvPr id="142" name="Shape 140"/>
           <p:cNvSpPr/>
           <p:nvPr/>
         </p:nvSpPr>
@@ -14226,7 +14267,7 @@
       </p:sp>
       <p:sp>
         <p:nvSpPr>
-          <p:cNvPr id="142" name="Shape 140"/>
+          <p:cNvPr id="143" name="Shape 141"/>
           <p:cNvSpPr/>
           <p:nvPr/>
         </p:nvSpPr>
@@ -14246,7 +14287,7 @@
       </p:sp>
       <p:sp>
         <p:nvSpPr>
-          <p:cNvPr id="143" name="Shape 141"/>
+          <p:cNvPr id="144" name="Shape 142"/>
           <p:cNvSpPr/>
           <p:nvPr/>
         </p:nvSpPr>
@@ -14266,7 +14307,7 @@
       </p:sp>
       <p:sp>
         <p:nvSpPr>
-          <p:cNvPr id="144" name="Shape 142"/>
+          <p:cNvPr id="145" name="Shape 143"/>
           <p:cNvSpPr/>
           <p:nvPr/>
         </p:nvSpPr>
@@ -14286,7 +14327,7 @@
       </p:sp>
       <p:sp>
         <p:nvSpPr>
-          <p:cNvPr id="145" name="Shape 143"/>
+          <p:cNvPr id="146" name="Shape 144"/>
           <p:cNvSpPr/>
           <p:nvPr/>
         </p:nvSpPr>
@@ -14306,7 +14347,7 @@
       </p:sp>
       <p:sp>
         <p:nvSpPr>
-          <p:cNvPr id="146" name="Shape 144"/>
+          <p:cNvPr id="147" name="Shape 145"/>
           <p:cNvSpPr/>
           <p:nvPr/>
         </p:nvSpPr>
@@ -14326,7 +14367,7 @@
       </p:sp>
       <p:sp>
         <p:nvSpPr>
-          <p:cNvPr id="147" name="Shape 145"/>
+          <p:cNvPr id="148" name="Shape 146"/>
           <p:cNvSpPr/>
           <p:nvPr/>
         </p:nvSpPr>
@@ -14346,7 +14387,7 @@
       </p:sp>
       <p:sp>
         <p:nvSpPr>
-          <p:cNvPr id="148" name="Shape 146"/>
+          <p:cNvPr id="149" name="Shape 147"/>
           <p:cNvSpPr/>
           <p:nvPr/>
         </p:nvSpPr>
@@ -14366,7 +14407,7 @@
       </p:sp>
       <p:sp>
         <p:nvSpPr>
-          <p:cNvPr id="149" name="Shape 147"/>
+          <p:cNvPr id="150" name="Shape 148"/>
           <p:cNvSpPr/>
           <p:nvPr/>
         </p:nvSpPr>
@@ -14386,7 +14427,7 @@
       </p:sp>
       <p:sp>
         <p:nvSpPr>
-          <p:cNvPr id="150" name="Shape 148"/>
+          <p:cNvPr id="151" name="Shape 149"/>
           <p:cNvSpPr/>
           <p:nvPr/>
         </p:nvSpPr>
@@ -14406,7 +14447,7 @@
       </p:sp>
       <p:sp>
         <p:nvSpPr>
-          <p:cNvPr id="151" name="Shape 149"/>
+          <p:cNvPr id="152" name="Shape 150"/>
           <p:cNvSpPr/>
           <p:nvPr/>
         </p:nvSpPr>
@@ -14426,7 +14467,7 @@
       </p:sp>
       <p:sp>
         <p:nvSpPr>
-          <p:cNvPr id="152" name="Shape 150"/>
+          <p:cNvPr id="153" name="Shape 151"/>
           <p:cNvSpPr/>
           <p:nvPr/>
         </p:nvSpPr>
@@ -14446,7 +14487,7 @@
       </p:sp>
       <p:sp>
         <p:nvSpPr>
-          <p:cNvPr id="153" name="Shape 151"/>
+          <p:cNvPr id="154" name="Shape 152"/>
           <p:cNvSpPr/>
           <p:nvPr/>
         </p:nvSpPr>
@@ -14466,7 +14507,7 @@
       </p:sp>
       <p:sp>
         <p:nvSpPr>
-          <p:cNvPr id="154" name="Shape 152"/>
+          <p:cNvPr id="155" name="Shape 153"/>
           <p:cNvSpPr/>
           <p:nvPr/>
         </p:nvSpPr>
@@ -14486,7 +14527,7 @@
       </p:sp>
       <p:sp>
         <p:nvSpPr>
-          <p:cNvPr id="155" name="Shape 153"/>
+          <p:cNvPr id="156" name="Shape 154"/>
           <p:cNvSpPr/>
           <p:nvPr/>
         </p:nvSpPr>
@@ -14506,7 +14547,7 @@
       </p:sp>
       <p:sp>
         <p:nvSpPr>
-          <p:cNvPr id="156" name="Shape 154"/>
+          <p:cNvPr id="157" name="Shape 155"/>
           <p:cNvSpPr/>
           <p:nvPr/>
         </p:nvSpPr>
@@ -14526,7 +14567,7 @@
       </p:sp>
       <p:sp>
         <p:nvSpPr>
-          <p:cNvPr id="157" name="Shape 155"/>
+          <p:cNvPr id="158" name="Shape 156"/>
           <p:cNvSpPr/>
           <p:nvPr/>
         </p:nvSpPr>
@@ -14546,7 +14587,7 @@
       </p:sp>
       <p:sp>
         <p:nvSpPr>
-          <p:cNvPr id="158" name="Shape 156"/>
+          <p:cNvPr id="159" name="Shape 157"/>
           <p:cNvSpPr/>
           <p:nvPr/>
         </p:nvSpPr>
@@ -14566,7 +14607,7 @@
       </p:sp>
       <p:sp>
         <p:nvSpPr>
-          <p:cNvPr id="159" name="Shape 157"/>
+          <p:cNvPr id="160" name="Shape 158"/>
           <p:cNvSpPr/>
           <p:nvPr/>
         </p:nvSpPr>
@@ -14586,7 +14627,7 @@
       </p:sp>
       <p:sp>
         <p:nvSpPr>
-          <p:cNvPr id="160" name="Shape 158"/>
+          <p:cNvPr id="161" name="Shape 159"/>
           <p:cNvSpPr/>
           <p:nvPr/>
         </p:nvSpPr>
@@ -14606,7 +14647,7 @@
       </p:sp>
       <p:sp>
         <p:nvSpPr>
-          <p:cNvPr id="161" name="Shape 159"/>
+          <p:cNvPr id="162" name="Shape 160"/>
           <p:cNvSpPr/>
           <p:nvPr/>
         </p:nvSpPr>
@@ -14626,7 +14667,7 @@
       </p:sp>
       <p:sp>
         <p:nvSpPr>
-          <p:cNvPr id="162" name="Shape 160"/>
+          <p:cNvPr id="163" name="Shape 161"/>
           <p:cNvSpPr/>
           <p:nvPr/>
         </p:nvSpPr>
@@ -14646,7 +14687,7 @@
       </p:sp>
       <p:sp>
         <p:nvSpPr>
-          <p:cNvPr id="163" name="Shape 161"/>
+          <p:cNvPr id="164" name="Shape 162"/>
           <p:cNvSpPr/>
           <p:nvPr/>
         </p:nvSpPr>
@@ -14666,7 +14707,7 @@
       </p:sp>
       <p:sp>
         <p:nvSpPr>
-          <p:cNvPr id="164" name="Shape 162"/>
+          <p:cNvPr id="165" name="Shape 163"/>
           <p:cNvSpPr/>
           <p:nvPr/>
         </p:nvSpPr>
@@ -14686,7 +14727,7 @@
       </p:sp>
       <p:sp>
         <p:nvSpPr>
-          <p:cNvPr id="165" name="Shape 163"/>
+          <p:cNvPr id="166" name="Shape 164"/>
           <p:cNvSpPr/>
           <p:nvPr/>
         </p:nvSpPr>
@@ -14706,7 +14747,7 @@
       </p:sp>
       <p:sp>
         <p:nvSpPr>
-          <p:cNvPr id="166" name="Shape 164"/>
+          <p:cNvPr id="167" name="Shape 165"/>
           <p:cNvSpPr/>
           <p:nvPr/>
         </p:nvSpPr>
@@ -14726,7 +14767,7 @@
       </p:sp>
       <p:sp>
         <p:nvSpPr>
-          <p:cNvPr id="167" name="Shape 165"/>
+          <p:cNvPr id="168" name="Shape 166"/>
           <p:cNvSpPr/>
           <p:nvPr/>
         </p:nvSpPr>
@@ -14746,7 +14787,7 @@
       </p:sp>
       <p:sp>
         <p:nvSpPr>
-          <p:cNvPr id="168" name="Shape 166"/>
+          <p:cNvPr id="169" name="Shape 167"/>
           <p:cNvSpPr/>
           <p:nvPr/>
         </p:nvSpPr>
@@ -14766,7 +14807,7 @@
       </p:sp>
       <p:sp>
         <p:nvSpPr>
-          <p:cNvPr id="169" name="Shape 167"/>
+          <p:cNvPr id="170" name="Shape 168"/>
           <p:cNvSpPr/>
           <p:nvPr/>
         </p:nvSpPr>
@@ -14786,7 +14827,7 @@
       </p:sp>
       <p:sp>
         <p:nvSpPr>
-          <p:cNvPr id="170" name="Shape 168"/>
+          <p:cNvPr id="171" name="Shape 169"/>
           <p:cNvSpPr/>
           <p:nvPr/>
         </p:nvSpPr>
@@ -14806,7 +14847,7 @@
       </p:sp>
       <p:sp>
         <p:nvSpPr>
-          <p:cNvPr id="171" name="Shape 169"/>
+          <p:cNvPr id="172" name="Shape 170"/>
           <p:cNvSpPr/>
           <p:nvPr/>
         </p:nvSpPr>
@@ -14826,7 +14867,7 @@
       </p:sp>
       <p:sp>
         <p:nvSpPr>
-          <p:cNvPr id="172" name="Shape 170"/>
+          <p:cNvPr id="173" name="Shape 171"/>
           <p:cNvSpPr/>
           <p:nvPr/>
         </p:nvSpPr>
@@ -14846,7 +14887,7 @@
       </p:sp>
       <p:sp>
         <p:nvSpPr>
-          <p:cNvPr id="173" name="Shape 171"/>
+          <p:cNvPr id="174" name="Shape 172"/>
           <p:cNvSpPr/>
           <p:nvPr/>
         </p:nvSpPr>
@@ -14866,7 +14907,7 @@
       </p:sp>
       <p:sp>
         <p:nvSpPr>
-          <p:cNvPr id="174" name="Text 172"/>
+          <p:cNvPr id="175" name="Text 173"/>
           <p:cNvSpPr/>
           <p:nvPr/>
         </p:nvSpPr>
@@ -14905,7 +14946,7 @@
       </p:sp>
       <p:sp>
         <p:nvSpPr>
-          <p:cNvPr id="175" name="Text 173"/>
+          <p:cNvPr id="176" name="Text 174"/>
           <p:cNvSpPr/>
           <p:nvPr/>
         </p:nvSpPr>
@@ -14944,7 +14985,7 @@
       </p:sp>
       <p:sp>
         <p:nvSpPr>
-          <p:cNvPr id="176" name="Shape 174"/>
+          <p:cNvPr id="177" name="Shape 175"/>
           <p:cNvSpPr/>
           <p:nvPr/>
         </p:nvSpPr>
@@ -14969,7 +15010,7 @@
       </p:sp>
       <p:sp>
         <p:nvSpPr>
-          <p:cNvPr id="177" name="Shape 175"/>
+          <p:cNvPr id="178" name="Shape 176"/>
           <p:cNvSpPr/>
           <p:nvPr/>
         </p:nvSpPr>
@@ -14989,7 +15030,7 @@
       </p:sp>
       <p:sp>
         <p:nvSpPr>
-          <p:cNvPr id="178" name="Shape 176"/>
+          <p:cNvPr id="179" name="Shape 177"/>
           <p:cNvSpPr/>
           <p:nvPr/>
         </p:nvSpPr>
@@ -15009,7 +15050,7 @@
       </p:sp>
       <p:sp>
         <p:nvSpPr>
-          <p:cNvPr id="179" name="Shape 177"/>
+          <p:cNvPr id="180" name="Shape 178"/>
           <p:cNvSpPr/>
           <p:nvPr/>
         </p:nvSpPr>
@@ -15029,7 +15070,7 @@
       </p:sp>
       <p:sp>
         <p:nvSpPr>
-          <p:cNvPr id="180" name="Shape 178"/>
+          <p:cNvPr id="181" name="Shape 179"/>
           <p:cNvSpPr/>
           <p:nvPr/>
         </p:nvSpPr>
@@ -15049,7 +15090,7 @@
       </p:sp>
       <p:sp>
         <p:nvSpPr>
-          <p:cNvPr id="181" name="Shape 179"/>
+          <p:cNvPr id="182" name="Shape 180"/>
           <p:cNvSpPr/>
           <p:nvPr/>
         </p:nvSpPr>
@@ -15069,7 +15110,7 @@
       </p:sp>
       <p:sp>
         <p:nvSpPr>
-          <p:cNvPr id="182" name="Shape 180"/>
+          <p:cNvPr id="183" name="Shape 181"/>
           <p:cNvSpPr/>
           <p:nvPr/>
         </p:nvSpPr>
@@ -15089,7 +15130,7 @@
       </p:sp>
       <p:sp>
         <p:nvSpPr>
-          <p:cNvPr id="183" name="Shape 181"/>
+          <p:cNvPr id="184" name="Shape 182"/>
           <p:cNvSpPr/>
           <p:nvPr/>
         </p:nvSpPr>
@@ -15109,7 +15150,7 @@
       </p:sp>
       <p:sp>
         <p:nvSpPr>
-          <p:cNvPr id="184" name="Shape 182"/>
+          <p:cNvPr id="185" name="Shape 183"/>
           <p:cNvSpPr/>
           <p:nvPr/>
         </p:nvSpPr>
@@ -15129,7 +15170,7 @@
       </p:sp>
       <p:sp>
         <p:nvSpPr>
-          <p:cNvPr id="185" name="Shape 183"/>
+          <p:cNvPr id="186" name="Shape 184"/>
           <p:cNvSpPr/>
           <p:nvPr/>
         </p:nvSpPr>
@@ -15149,7 +15190,7 @@
       </p:sp>
       <p:sp>
         <p:nvSpPr>
-          <p:cNvPr id="186" name="Shape 184"/>
+          <p:cNvPr id="187" name="Shape 185"/>
           <p:cNvSpPr/>
           <p:nvPr/>
         </p:nvSpPr>
@@ -15169,7 +15210,7 @@
       </p:sp>
       <p:sp>
         <p:nvSpPr>
-          <p:cNvPr id="187" name="Shape 185"/>
+          <p:cNvPr id="188" name="Shape 186"/>
           <p:cNvSpPr/>
           <p:nvPr/>
         </p:nvSpPr>
@@ -15189,7 +15230,7 @@
       </p:sp>
       <p:sp>
         <p:nvSpPr>
-          <p:cNvPr id="188" name="Shape 186"/>
+          <p:cNvPr id="189" name="Shape 187"/>
           <p:cNvSpPr/>
           <p:nvPr/>
         </p:nvSpPr>
@@ -15209,7 +15250,7 @@
       </p:sp>
       <p:sp>
         <p:nvSpPr>
-          <p:cNvPr id="189" name="Shape 187"/>
+          <p:cNvPr id="190" name="Shape 188"/>
           <p:cNvSpPr/>
           <p:nvPr/>
         </p:nvSpPr>
@@ -15229,7 +15270,7 @@
       </p:sp>
       <p:sp>
         <p:nvSpPr>
-          <p:cNvPr id="190" name="Shape 188"/>
+          <p:cNvPr id="191" name="Shape 189"/>
           <p:cNvSpPr/>
           <p:nvPr/>
         </p:nvSpPr>
@@ -15249,7 +15290,7 @@
       </p:sp>
       <p:sp>
         <p:nvSpPr>
-          <p:cNvPr id="191" name="Shape 189"/>
+          <p:cNvPr id="192" name="Shape 190"/>
           <p:cNvSpPr/>
           <p:nvPr/>
         </p:nvSpPr>
@@ -15269,7 +15310,7 @@
       </p:sp>
       <p:sp>
         <p:nvSpPr>
-          <p:cNvPr id="192" name="Shape 190"/>
+          <p:cNvPr id="193" name="Shape 191"/>
           <p:cNvSpPr/>
           <p:nvPr/>
         </p:nvSpPr>
@@ -15289,7 +15330,7 @@
       </p:sp>
       <p:sp>
         <p:nvSpPr>
-          <p:cNvPr id="193" name="Text 191"/>
+          <p:cNvPr id="194" name="Text 192"/>
           <p:cNvSpPr/>
           <p:nvPr/>
         </p:nvSpPr>
@@ -15328,13 +15369,13 @@
       </p:sp>
       <p:sp>
         <p:nvSpPr>
-          <p:cNvPr id="194" name="Shape 192"/>
-          <p:cNvSpPr/>
-          <p:nvPr/>
-        </p:nvSpPr>
-        <p:spPr>
-          <a:xfrm>
-            <a:off x="3220135" y="1810512"/>
+          <p:cNvPr id="195" name="Shape 193"/>
+          <p:cNvSpPr/>
+          <p:nvPr/>
+        </p:nvSpPr>
+        <p:spPr>
+          <a:xfrm>
+            <a:off x="3855637" y="1810512"/>
             <a:ext cx="0" cy="713232"/>
           </a:xfrm>
           <a:prstGeom prst="line">
@@ -15351,13 +15392,13 @@
       </p:sp>
       <p:sp>
         <p:nvSpPr>
-          <p:cNvPr id="195" name="Shape 193"/>
-          <p:cNvSpPr/>
-          <p:nvPr/>
-        </p:nvSpPr>
-        <p:spPr>
-          <a:xfrm>
-            <a:off x="7019479" y="1810512"/>
+          <p:cNvPr id="196" name="Shape 194"/>
+          <p:cNvSpPr/>
+          <p:nvPr/>
+        </p:nvSpPr>
+        <p:spPr>
+          <a:xfrm>
+            <a:off x="6957979" y="1810512"/>
             <a:ext cx="0" cy="713232"/>
           </a:xfrm>
           <a:prstGeom prst="line">
@@ -15374,7 +15415,7 @@
       </p:sp>
       <p:sp>
         <p:nvSpPr>
-          <p:cNvPr id="196" name="Shape 194"/>
+          <p:cNvPr id="197" name="Shape 195"/>
           <p:cNvSpPr/>
           <p:nvPr/>
         </p:nvSpPr>
@@ -15397,7 +15438,7 @@
       </p:sp>
       <p:sp>
         <p:nvSpPr>
-          <p:cNvPr id="197" name="Shape 195"/>
+          <p:cNvPr id="198" name="Shape 196"/>
           <p:cNvSpPr/>
           <p:nvPr/>
         </p:nvSpPr>
@@ -15420,7 +15461,7 @@
       </p:sp>
       <p:sp>
         <p:nvSpPr>
-          <p:cNvPr id="198" name="Text 196"/>
+          <p:cNvPr id="199" name="Text 197"/>
           <p:cNvSpPr/>
           <p:nvPr/>
         </p:nvSpPr>
@@ -15459,7 +15500,7 @@
       </p:sp>
       <p:sp>
         <p:nvSpPr>
-          <p:cNvPr id="199" name="Shape 197"/>
+          <p:cNvPr id="200" name="Shape 198"/>
           <p:cNvSpPr/>
           <p:nvPr/>
         </p:nvSpPr>
@@ -15482,7 +15523,7 @@
       </p:sp>
       <p:sp>
         <p:nvSpPr>
-          <p:cNvPr id="200" name="Text 198"/>
+          <p:cNvPr id="201" name="Text 199"/>
           <p:cNvSpPr/>
           <p:nvPr/>
         </p:nvSpPr>
@@ -15521,7 +15562,7 @@
       </p:sp>
       <p:sp>
         <p:nvSpPr>
-          <p:cNvPr id="201" name="Shape 199"/>
+          <p:cNvPr id="202" name="Shape 200"/>
           <p:cNvSpPr/>
           <p:nvPr/>
         </p:nvSpPr>
@@ -15544,7 +15585,7 @@
       </p:sp>
       <p:sp>
         <p:nvSpPr>
-          <p:cNvPr id="202" name="Text 200"/>
+          <p:cNvPr id="203" name="Text 201"/>
           <p:cNvSpPr/>
           <p:nvPr/>
         </p:nvSpPr>
@@ -15583,7 +15624,7 @@
       </p:sp>
       <p:sp>
         <p:nvSpPr>
-          <p:cNvPr id="203" name="Shape 201"/>
+          <p:cNvPr id="204" name="Shape 202"/>
           <p:cNvSpPr/>
           <p:nvPr/>
         </p:nvSpPr>
@@ -15606,7 +15647,7 @@
       </p:sp>
       <p:sp>
         <p:nvSpPr>
-          <p:cNvPr id="204" name="Text 202"/>
+          <p:cNvPr id="205" name="Text 203"/>
           <p:cNvSpPr/>
           <p:nvPr/>
         </p:nvSpPr>
@@ -15645,7 +15686,7 @@
       </p:sp>
       <p:sp>
         <p:nvSpPr>
-          <p:cNvPr id="205" name="Shape 203"/>
+          <p:cNvPr id="206" name="Shape 204"/>
           <p:cNvSpPr/>
           <p:nvPr/>
         </p:nvSpPr>
@@ -15668,7 +15709,7 @@
       </p:sp>
       <p:sp>
         <p:nvSpPr>
-          <p:cNvPr id="206" name="Text 204"/>
+          <p:cNvPr id="207" name="Text 205"/>
           <p:cNvSpPr/>
           <p:nvPr/>
         </p:nvSpPr>
@@ -15707,7 +15748,7 @@
       </p:sp>
       <p:sp>
         <p:nvSpPr>
-          <p:cNvPr id="207" name="Text 205"/>
+          <p:cNvPr id="208" name="Text 206"/>
           <p:cNvSpPr/>
           <p:nvPr/>
         </p:nvSpPr>
@@ -15746,7 +15787,7 @@
       </p:sp>
       <p:sp>
         <p:nvSpPr>
-          <p:cNvPr id="208" name="Shape 206"/>
+          <p:cNvPr id="209" name="Shape 207"/>
           <p:cNvSpPr/>
           <p:nvPr/>
         </p:nvSpPr>
@@ -15766,7 +15807,7 @@
       </p:sp>
       <p:sp>
         <p:nvSpPr>
-          <p:cNvPr id="209" name="Text 207"/>
+          <p:cNvPr id="210" name="Text 208"/>
           <p:cNvSpPr/>
           <p:nvPr/>
         </p:nvSpPr>
@@ -15805,7 +15846,7 @@
       </p:sp>
       <p:sp>
         <p:nvSpPr>
-          <p:cNvPr id="210" name="Shape 208"/>
+          <p:cNvPr id="211" name="Shape 209"/>
           <p:cNvSpPr/>
           <p:nvPr/>
         </p:nvSpPr>
@@ -15825,7 +15866,7 @@
       </p:sp>
       <p:sp>
         <p:nvSpPr>
-          <p:cNvPr id="211" name="Text 209"/>
+          <p:cNvPr id="212" name="Text 210"/>
           <p:cNvSpPr/>
           <p:nvPr/>
         </p:nvSpPr>
@@ -15864,7 +15905,7 @@
       </p:sp>
       <p:sp>
         <p:nvSpPr>
-          <p:cNvPr id="212" name="Shape 210"/>
+          <p:cNvPr id="213" name="Shape 211"/>
           <p:cNvSpPr/>
           <p:nvPr/>
         </p:nvSpPr>
@@ -15884,7 +15925,7 @@
       </p:sp>
       <p:sp>
         <p:nvSpPr>
-          <p:cNvPr id="213" name="Text 211"/>
+          <p:cNvPr id="214" name="Text 212"/>
           <p:cNvSpPr/>
           <p:nvPr/>
         </p:nvSpPr>
@@ -15923,7 +15964,7 @@
       </p:sp>
       <p:sp>
         <p:nvSpPr>
-          <p:cNvPr id="214" name="Shape 212"/>
+          <p:cNvPr id="215" name="Shape 213"/>
           <p:cNvSpPr/>
           <p:nvPr/>
         </p:nvSpPr>
@@ -15943,7 +15984,7 @@
       </p:sp>
       <p:sp>
         <p:nvSpPr>
-          <p:cNvPr id="215" name="Text 213"/>
+          <p:cNvPr id="216" name="Text 214"/>
           <p:cNvSpPr/>
           <p:nvPr/>
         </p:nvSpPr>
@@ -15977,6 +16018,45 @@
               <a:t>5</a:t>
             </a:r>
             <a:endParaRPr lang="en-US" sz="850" dirty="0"/>
+          </a:p>
+        </p:txBody>
+      </p:sp>
+      <p:sp>
+        <p:nvSpPr>
+          <p:cNvPr id="217" name="Text 215"/>
+          <p:cNvSpPr/>
+          <p:nvPr/>
+        </p:nvSpPr>
+        <p:spPr>
+          <a:xfrm>
+            <a:off x="1508760" y="2898648"/>
+            <a:ext cx="6126480" cy="164592"/>
+          </a:xfrm>
+          <a:prstGeom prst="rect">
+            <a:avLst/>
+          </a:prstGeom>
+          <a:noFill/>
+          <a:ln/>
+        </p:spPr>
+        <p:txBody>
+          <a:bodyPr wrap="square" lIns="0" tIns="0" rIns="0" bIns="0" rtlCol="0" anchor="ctr"/>
+          <a:lstStyle/>
+          <a:p>
+            <a:pPr indent="0" marL="0">
+              <a:buNone/>
+            </a:pPr>
+            <a:r>
+              <a:rPr lang="en-US" sz="800" i="1" dirty="0">
+                <a:solidFill>
+                  <a:srgbClr val="5E5E5E"/>
+                </a:solidFill>
+                <a:latin typeface="NVIDIA Sans" pitchFamily="34" charset="0"/>
+                <a:ea typeface="NVIDIA Sans" pitchFamily="34" charset="-122"/>
+                <a:cs typeface="NVIDIA Sans" pitchFamily="34" charset="-120"/>
+              </a:rPr>
+              <a:t>GPU busy in bands: prep 0, Qwen3.5 50, DiT 120 | DiT 224, Qwen3.5 123, optim 26 ms</a:t>
+            </a:r>
+            <a:endParaRPr lang="en-US" sz="800" dirty="0"/>
           </a:p>
         </p:txBody>
       </p:sp>
@@ -16681,7 +16761,7 @@
                           <a:ea typeface="NVIDIA Sans" pitchFamily="34" charset="-122"/>
                           <a:cs typeface="NVIDIA Sans" pitchFamily="34" charset="-120"/>
                         </a:rPr>
-                        <a:t>13,868 launches/step, median 8 µs, 79% &lt; 20 µs — 205 ms pure idle</a:t>
+                        <a:t>13,868 launches @ 8 µs median; occupancy fwd 34% vs bwd 70%; idle 205 ms</a:t>
                       </a:r>
                       <a:endParaRPr lang="en-US" sz="850" dirty="0">
                         <a:latin typeface="NVIDIA Sans" charset="0"/>
@@ -16998,7 +17078,7 @@
       </p:graphicFrame>
       <p:sp>
         <p:nvSpPr>
-          <p:cNvPr id="217" name="Text 214"/>
+          <p:cNvPr id="219" name="Text 216"/>
           <p:cNvSpPr/>
           <p:nvPr/>
         </p:nvSpPr>
@@ -17037,7 +17117,7 @@
       </p:sp>
       <p:sp>
         <p:nvSpPr>
-          <p:cNvPr id="218" name="Text 215"/>
+          <p:cNvPr id="220" name="Text 217"/>
           <p:cNvSpPr/>
           <p:nvPr/>
         </p:nvSpPr>
@@ -17076,7 +17156,7 @@
       </p:sp>
       <p:sp>
         <p:nvSpPr>
-          <p:cNvPr id="219" name="Shape 216"/>
+          <p:cNvPr id="221" name="Shape 218"/>
           <p:cNvSpPr/>
           <p:nvPr/>
         </p:nvSpPr>
@@ -17096,7 +17176,7 @@
       </p:sp>
       <p:pic>
         <p:nvPicPr>
-          <p:cNvPr id="220" name="Image 0" descr="/app/logos/nvidia-logo-blk-sm.png">    </p:cNvPr>
+          <p:cNvPr id="222" name="Image 0" descr="/app/logos/nvidia-logo-blk-sm.png">    </p:cNvPr>
           <p:cNvPicPr>
             <a:picLocks noChangeAspect="1"/>
           </p:cNvPicPr>

</xml_diff>

<commit_message>
docs(slides): split CUDA Graphs into launch-bound evidence page and 4-vs-1 design page
</commit_message>
<xml_diff>
--- a/docs/slides/qwenpi-optimization.pptx
+++ b/docs/slides/qwenpi-optimization.pptx
@@ -17,9 +17,10 @@
     <p:sldId id="265" r:id="rId11"/>
     <p:sldId id="266" r:id="rId12"/>
     <p:sldId id="267" r:id="rId13"/>
+    <p:sldId id="268" r:id="rId14"/>
   </p:sldIdLst>
   <p:notesMasterIdLst>
-    <p:notesMasterId r:id="rId14"/>
+    <p:notesMasterId r:id="rId15"/>
   </p:notesMasterIdLst>
   <p:sldSz cx="9144000" cy="5143500"/>
   <p:notesSz cx="5143500" cy="9144000"/>
@@ -3353,7 +3354,8 @@
           <a:p>
             <a:r>
               <a:rPr lang="en-US" dirty="0"/>
-              <a:t>[IMPORTANT] Recommendation: bs 24 is the throughput config, gated on customer-side convergence validation (lr recalibration).</a:t>
+              <a:t>Ledger method: exposed comm = NCCL busy while no compute kernel runs; idle = nothing on any stream.
+Remaining exposed comm is gradient-readiness-bound, not hook- or bandwidth-bound — verified by intervention experiments.</a:t>
             </a:r>
             <a:endParaRPr lang="en-US" dirty="0"/>
           </a:p>
@@ -3441,7 +3443,7 @@
           <a:p>
             <a:r>
               <a:rPr lang="en-US" dirty="0"/>
-              <a:t>This slide is the credibility anchor: what we did NOT ship is as evidence-based as what we did.</a:t>
+              <a:t>[IMPORTANT] Recommendation: bs 24 is the throughput config, gated on customer-side convergence validation (lr recalibration).</a:t>
             </a:r>
             <a:endParaRPr lang="en-US" dirty="0"/>
           </a:p>
@@ -3529,8 +3531,7 @@
           <a:p>
             <a:r>
               <a:rPr lang="en-US" dirty="0"/>
-              <a:t>Everything shipped is one MR per optimization with measured before/after — the repo history is the reproducibility story.
-[IMPORTANT] Close: 3.2x is banked; the roadmap above is how we keep going.</a:t>
+              <a:t>This slide is the credibility anchor: what we did NOT ship is as evidence-based as what we did.</a:t>
             </a:r>
             <a:endParaRPr lang="en-US" dirty="0"/>
           </a:p>
@@ -3554,6 +3555,95 @@
             <a:fld id="{F7021451-1387-4CA6-816F-3879F97B5CBC}" type="slidenum">
               <a:rPr lang="en-US"/>
               <a:t>12</a:t>
+            </a:fld>
+            <a:endParaRPr lang="en-US"/>
+          </a:p>
+        </p:txBody>
+      </p:sp>
+    </p:spTree>
+    <p:extLst>
+      <p:ext uri="{BB962C8B-B14F-4D97-AF65-F5344CB8AC3E}">
+        <p14:creationId xmlns:p14="http://schemas.microsoft.com/office/powerpoint/2010/main" val="1024086991"/>
+      </p:ext>
+    </p:extLst>
+  </p:cSld>
+  <p:clrMapOvr>
+    <a:masterClrMapping/>
+  </p:clrMapOvr>
+</p:notes>
+</file>
+
+<file path=ppt/notesSlides/notesSlide13.xml><?xml version="1.0" encoding="utf-8"?>
+<p:notes xmlns:a="http://schemas.openxmlformats.org/drawingml/2006/main" xmlns:r="http://schemas.openxmlformats.org/officeDocument/2006/relationships" xmlns:p="http://schemas.openxmlformats.org/presentationml/2006/main">
+  <p:cSld>
+    <p:spTree>
+      <p:nvGrpSpPr>
+        <p:cNvPr id="1" name=""/>
+        <p:cNvGrpSpPr/>
+        <p:nvPr/>
+      </p:nvGrpSpPr>
+      <p:grpSpPr>
+        <a:xfrm>
+          <a:off x="0" y="0"/>
+          <a:ext cx="0" cy="0"/>
+          <a:chOff x="0" y="0"/>
+          <a:chExt cx="0" cy="0"/>
+        </a:xfrm>
+      </p:grpSpPr>
+      <p:sp>
+        <p:nvSpPr>
+          <p:cNvPr id="2" name="Slide Image Placeholder 1"/>
+          <p:cNvSpPr>
+            <a:spLocks noGrp="1" noRot="1" noChangeAspect="1"/>
+          </p:cNvSpPr>
+          <p:nvPr>
+            <p:ph type="sldImg"/>
+          </p:nvPr>
+        </p:nvSpPr>
+        <p:spPr/>
+      </p:sp>
+      <p:sp>
+        <p:nvSpPr>
+          <p:cNvPr id="3" name="Notes Placeholder 2"/>
+          <p:cNvSpPr>
+            <a:spLocks noGrp="1"/>
+          </p:cNvSpPr>
+          <p:nvPr>
+            <p:ph type="body" idx="1"/>
+          </p:nvPr>
+        </p:nvSpPr>
+        <p:spPr/>
+        <p:txBody>
+          <a:bodyPr/>
+          <a:lstStyle/>
+          <a:p>
+            <a:r>
+              <a:rPr lang="en-US" dirty="0"/>
+              <a:t>Everything shipped is one MR per optimization with measured before/after — the repo history is the reproducibility story.
+[IMPORTANT] Close: 3.2x is banked; the roadmap above is how we keep going.</a:t>
+            </a:r>
+            <a:endParaRPr lang="en-US" dirty="0"/>
+          </a:p>
+        </p:txBody>
+      </p:sp>
+      <p:sp>
+        <p:nvSpPr>
+          <p:cNvPr id="4" name="Slide Number Placeholder 3"/>
+          <p:cNvSpPr>
+            <a:spLocks noGrp="1"/>
+          </p:cNvSpPr>
+          <p:nvPr>
+            <p:ph type="sldNum" sz="quarter" idx="10"/>
+          </p:nvPr>
+        </p:nvSpPr>
+        <p:spPr/>
+        <p:txBody>
+          <a:bodyPr/>
+          <a:lstStyle/>
+          <a:p>
+            <a:fld id="{F7021451-1387-4CA6-816F-3879F97B5CBC}" type="slidenum">
+              <a:rPr lang="en-US"/>
+              <a:t>13</a:t>
             </a:fld>
             <a:endParaRPr lang="en-US"/>
           </a:p>
@@ -4154,8 +4244,8 @@
           <a:p>
             <a:r>
               <a:rPr lang="en-US" dirty="0"/>
-              <a:t>Graph capture preserves exact hidden-state semantics — verified fullgraph fwd+bwd and unchanged loss trajectory.
-Group size 8 balances capture memory against launch savings; per-layer compile was ported but the fused graphs replaced it.</a:t>
+              <a:t>Baseline: qwenpi_baseline_nvtx train_step_33; optimized: milestone1 train_step_48. Launch-window attribution both sides.
+[IMPORTANT] This page motivates graphs with the customer's own trace numbers; the next page is the design and the 4-vs-1 answer.</a:t>
             </a:r>
             <a:endParaRPr lang="en-US" dirty="0"/>
           </a:p>
@@ -4243,8 +4333,8 @@
           <a:p>
             <a:r>
               <a:rPr lang="en-US" dirty="0"/>
-              <a:t>Ledger method: exposed comm = NCCL busy while no compute kernel runs; idle = nothing on any stream.
-Remaining exposed comm is gradient-readiness-bound, not hook- or bandwidth-bound — verified by intervention experiments.</a:t>
+              <a:t>Graph capture preserves exact hidden-state semantics — verified fullgraph fwd+bwd and unchanged loss trajectory.
+Group size 8 balances capture memory against launch savings; per-layer compile was ported but the fused graphs replaced it.</a:t>
             </a:r>
             <a:endParaRPr lang="en-US" dirty="0"/>
           </a:p>
@@ -4824,7 +4914,7 @@
                 <a:ea typeface="NVIDIA Sans" pitchFamily="34" charset="-122"/>
                 <a:cs typeface="NVIDIA Sans" pitchFamily="34" charset="-120"/>
               </a:rPr>
-              <a:t>Batch Scaling: Sweet Spot at 24 per GPU</a:t>
+              <a:t>ZeRO-2 Comm Tuning &amp; the Final Ledger</a:t>
             </a:r>
             <a:endParaRPr lang="en-US" sz="3000" dirty="0"/>
           </a:p>
@@ -4863,7 +4953,7 @@
                 <a:ea typeface="NVIDIA Sans" pitchFamily="34" charset="-122"/>
                 <a:cs typeface="NVIDIA Sans" pitchFamily="34" charset="-120"/>
               </a:rPr>
-              <a:t>Same optimized config, only per-GPU batch changes — peak 340 samples/node/s</a:t>
+              <a:t>271 → 249 ms.  Fewer, larger collectives — and an honest ledger of what remains</a:t>
             </a:r>
             <a:endParaRPr lang="en-US" sz="1500" dirty="0"/>
           </a:p>
@@ -4871,223 +4961,90 @@
       </p:sp>
       <p:sp>
         <p:nvSpPr>
-          <p:cNvPr id="4" name="Shape 2"/>
-          <p:cNvSpPr/>
-          <p:nvPr/>
-        </p:nvSpPr>
-        <p:spPr>
-          <a:xfrm>
-            <a:off x="1005840" y="3840480"/>
-            <a:ext cx="4846320" cy="0"/>
-          </a:xfrm>
-          <a:prstGeom prst="line">
+          <p:cNvPr id="4" name="Text 2"/>
+          <p:cNvSpPr/>
+          <p:nvPr/>
+        </p:nvSpPr>
+        <p:spPr>
+          <a:xfrm>
+            <a:off x="457200" y="1325880"/>
+            <a:ext cx="8229600" cy="1234440"/>
+          </a:xfrm>
+          <a:prstGeom prst="rect">
             <a:avLst/>
           </a:prstGeom>
           <a:noFill/>
-          <a:ln w="9525">
-            <a:solidFill>
-              <a:srgbClr val="EAEAEA"/>
-            </a:solidFill>
-            <a:prstDash val="solid"/>
-          </a:ln>
-        </p:spPr>
-      </p:sp>
-      <p:sp>
-        <p:nvSpPr>
-          <p:cNvPr id="5" name="Text 3"/>
-          <p:cNvSpPr/>
-          <p:nvPr/>
-        </p:nvSpPr>
-        <p:spPr>
-          <a:xfrm>
-            <a:off x="548640" y="3749040"/>
-            <a:ext cx="365760" cy="182880"/>
-          </a:xfrm>
-          <a:prstGeom prst="rect">
-            <a:avLst/>
-          </a:prstGeom>
-          <a:noFill/>
           <a:ln/>
         </p:spPr>
         <p:txBody>
-          <a:bodyPr wrap="square" lIns="0" tIns="0" rIns="0" bIns="0" rtlCol="0" anchor="ctr"/>
+          <a:bodyPr wrap="square" lIns="0" tIns="0" rIns="0" bIns="0" rtlCol="0" anchor="t"/>
           <a:lstStyle/>
           <a:p>
-            <a:pPr algn="r" indent="0" marL="0">
-              <a:buNone/>
+            <a:pPr marL="342900" indent="-342900">
+              <a:buSzPct val="100000"/>
+              <a:buChar char="•"/>
             </a:pPr>
             <a:r>
-              <a:rPr lang="en-US" sz="900" dirty="0">
+              <a:rPr lang="en-US" sz="1200" dirty="0">
                 <a:solidFill>
-                  <a:srgbClr val="8C8C8C"/>
+                  <a:srgbClr val="000000"/>
                 </a:solidFill>
                 <a:latin typeface="NVIDIA Sans" pitchFamily="34" charset="0"/>
                 <a:ea typeface="NVIDIA Sans" pitchFamily="34" charset="-122"/>
                 <a:cs typeface="NVIDIA Sans" pitchFamily="34" charset="-120"/>
               </a:rPr>
-              <a:t>0</a:t>
+              <a:t>reduce_bucket_size 5e8 → 1.5e9: 6 gradient AllReduces per step instead of ~20, scoped to this model's config only</a:t>
             </a:r>
-            <a:endParaRPr lang="en-US" sz="900" dirty="0"/>
-          </a:p>
-        </p:txBody>
-      </p:sp>
-      <p:sp>
-        <p:nvSpPr>
-          <p:cNvPr id="6" name="Shape 4"/>
-          <p:cNvSpPr/>
-          <p:nvPr/>
-        </p:nvSpPr>
-        <p:spPr>
-          <a:xfrm>
-            <a:off x="1005840" y="3223260"/>
-            <a:ext cx="4846320" cy="0"/>
-          </a:xfrm>
-          <a:prstGeom prst="line">
-            <a:avLst/>
-          </a:prstGeom>
-          <a:noFill/>
-          <a:ln w="9525">
-            <a:solidFill>
-              <a:srgbClr val="EAEAEA"/>
-            </a:solidFill>
-            <a:prstDash val="solid"/>
-          </a:ln>
-        </p:spPr>
-      </p:sp>
-      <p:sp>
-        <p:nvSpPr>
-          <p:cNvPr id="7" name="Text 5"/>
-          <p:cNvSpPr/>
-          <p:nvPr/>
-        </p:nvSpPr>
-        <p:spPr>
-          <a:xfrm>
-            <a:off x="548640" y="3131820"/>
-            <a:ext cx="365760" cy="182880"/>
-          </a:xfrm>
-          <a:prstGeom prst="rect">
-            <a:avLst/>
-          </a:prstGeom>
-          <a:noFill/>
-          <a:ln/>
-        </p:spPr>
-        <p:txBody>
-          <a:bodyPr wrap="square" lIns="0" tIns="0" rIns="0" bIns="0" rtlCol="0" anchor="ctr"/>
-          <a:lstStyle/>
-          <a:p>
-            <a:pPr algn="r" indent="0" marL="0">
-              <a:buNone/>
+            <a:endParaRPr lang="en-US" sz="1200" dirty="0"/>
+          </a:p>
+          <a:p>
+            <a:pPr marL="342900" indent="-342900">
+              <a:buSzPct val="100000"/>
+              <a:buChar char="•"/>
             </a:pPr>
             <a:r>
-              <a:rPr lang="en-US" sz="900" dirty="0">
+              <a:rPr lang="en-US" sz="1200" dirty="0">
                 <a:solidFill>
-                  <a:srgbClr val="8C8C8C"/>
+                  <a:srgbClr val="000000"/>
                 </a:solidFill>
                 <a:latin typeface="NVIDIA Sans" pitchFamily="34" charset="0"/>
                 <a:ea typeface="NVIDIA Sans" pitchFamily="34" charset="-122"/>
                 <a:cs typeface="NVIDIA Sans" pitchFamily="34" charset="-120"/>
               </a:rPr>
-              <a:t>100</a:t>
+              <a:t>reduce_scatter=false: drops DeepSpeed's redundant per-bucket flatten (CatArrayBatchedCopy) ahead of each AllReduce</a:t>
             </a:r>
-            <a:endParaRPr lang="en-US" sz="900" dirty="0"/>
-          </a:p>
-        </p:txBody>
-      </p:sp>
-      <p:sp>
-        <p:nvSpPr>
-          <p:cNvPr id="8" name="Shape 6"/>
-          <p:cNvSpPr/>
-          <p:nvPr/>
-        </p:nvSpPr>
-        <p:spPr>
-          <a:xfrm>
-            <a:off x="1005840" y="2606040"/>
-            <a:ext cx="4846320" cy="0"/>
-          </a:xfrm>
-          <a:prstGeom prst="line">
-            <a:avLst/>
-          </a:prstGeom>
-          <a:noFill/>
-          <a:ln w="9525">
-            <a:solidFill>
-              <a:srgbClr val="EAEAEA"/>
-            </a:solidFill>
-            <a:prstDash val="solid"/>
-          </a:ln>
-        </p:spPr>
-      </p:sp>
-      <p:sp>
-        <p:nvSpPr>
-          <p:cNvPr id="9" name="Text 7"/>
-          <p:cNvSpPr/>
-          <p:nvPr/>
-        </p:nvSpPr>
-        <p:spPr>
-          <a:xfrm>
-            <a:off x="548640" y="2514600"/>
-            <a:ext cx="365760" cy="182880"/>
-          </a:xfrm>
-          <a:prstGeom prst="rect">
-            <a:avLst/>
-          </a:prstGeom>
-          <a:noFill/>
-          <a:ln/>
-        </p:spPr>
-        <p:txBody>
-          <a:bodyPr wrap="square" lIns="0" tIns="0" rIns="0" bIns="0" rtlCol="0" anchor="ctr"/>
-          <a:lstStyle/>
-          <a:p>
-            <a:pPr algn="r" indent="0" marL="0">
-              <a:buNone/>
+            <a:endParaRPr lang="en-US" sz="1200" dirty="0"/>
+          </a:p>
+          <a:p>
+            <a:pPr marL="342900" indent="-342900">
+              <a:buSzPct val="100000"/>
+              <a:buChar char="•"/>
             </a:pPr>
             <a:r>
-              <a:rPr lang="en-US" sz="900" dirty="0">
+              <a:rPr lang="en-US" sz="1200" dirty="0">
                 <a:solidFill>
-                  <a:srgbClr val="8C8C8C"/>
+                  <a:srgbClr val="000000"/>
                 </a:solidFill>
                 <a:latin typeface="NVIDIA Sans" pitchFamily="34" charset="0"/>
                 <a:ea typeface="NVIDIA Sans" pitchFamily="34" charset="-122"/>
                 <a:cs typeface="NVIDIA Sans" pitchFamily="34" charset="-120"/>
               </a:rPr>
-              <a:t>200</a:t>
+              <a:t>Verified NOT bandwidth-bound: AllReduce microbenchmark hits 478 GB/s bus bandwidth — the NVLink per-direction ceiling. The remaining exposed comm can only shrink by sending fewer bytes.</a:t>
             </a:r>
-            <a:endParaRPr lang="en-US" sz="900" dirty="0"/>
+            <a:endParaRPr lang="en-US" sz="1200" dirty="0"/>
           </a:p>
         </p:txBody>
       </p:sp>
       <p:sp>
         <p:nvSpPr>
-          <p:cNvPr id="10" name="Shape 8"/>
-          <p:cNvSpPr/>
-          <p:nvPr/>
-        </p:nvSpPr>
-        <p:spPr>
-          <a:xfrm>
-            <a:off x="1005840" y="1988820"/>
-            <a:ext cx="4846320" cy="0"/>
-          </a:xfrm>
-          <a:prstGeom prst="line">
-            <a:avLst/>
-          </a:prstGeom>
-          <a:noFill/>
-          <a:ln w="9525">
-            <a:solidFill>
-              <a:srgbClr val="EAEAEA"/>
-            </a:solidFill>
-            <a:prstDash val="solid"/>
-          </a:ln>
-        </p:spPr>
-      </p:sp>
-      <p:sp>
-        <p:nvSpPr>
-          <p:cNvPr id="11" name="Text 9"/>
-          <p:cNvSpPr/>
-          <p:nvPr/>
-        </p:nvSpPr>
-        <p:spPr>
-          <a:xfrm>
-            <a:off x="548640" y="1897380"/>
-            <a:ext cx="365760" cy="182880"/>
+          <p:cNvPr id="5" name="Text 3"/>
+          <p:cNvSpPr/>
+          <p:nvPr/>
+        </p:nvSpPr>
+        <p:spPr>
+          <a:xfrm>
+            <a:off x="457200" y="2697480"/>
+            <a:ext cx="8229600" cy="274320"/>
           </a:xfrm>
           <a:prstGeom prst="rect">
             <a:avLst/>
@@ -5099,57 +5056,34 @@
           <a:bodyPr wrap="square" lIns="0" tIns="0" rIns="0" bIns="0" rtlCol="0" anchor="ctr"/>
           <a:lstStyle/>
           <a:p>
-            <a:pPr algn="r" indent="0" marL="0">
+            <a:pPr indent="0" marL="0">
               <a:buNone/>
             </a:pPr>
             <a:r>
-              <a:rPr lang="en-US" sz="900" dirty="0">
+              <a:rPr lang="en-US" sz="1300" b="1" dirty="0">
                 <a:solidFill>
-                  <a:srgbClr val="8C8C8C"/>
+                  <a:srgbClr val="000000"/>
                 </a:solidFill>
                 <a:latin typeface="NVIDIA Sans" pitchFamily="34" charset="0"/>
                 <a:ea typeface="NVIDIA Sans" pitchFamily="34" charset="-122"/>
                 <a:cs typeface="NVIDIA Sans" pitchFamily="34" charset="-120"/>
               </a:rPr>
-              <a:t>300</a:t>
+              <a:t>Per-step time ledger (same accounting, one steady step from each nsys capture)</a:t>
             </a:r>
-            <a:endParaRPr lang="en-US" sz="900" dirty="0"/>
+            <a:endParaRPr lang="en-US" sz="1300" dirty="0"/>
           </a:p>
         </p:txBody>
       </p:sp>
       <p:sp>
         <p:nvSpPr>
-          <p:cNvPr id="12" name="Shape 10"/>
-          <p:cNvSpPr/>
-          <p:nvPr/>
-        </p:nvSpPr>
-        <p:spPr>
-          <a:xfrm>
-            <a:off x="1005840" y="1371600"/>
-            <a:ext cx="4846320" cy="0"/>
-          </a:xfrm>
-          <a:prstGeom prst="line">
-            <a:avLst/>
-          </a:prstGeom>
-          <a:noFill/>
-          <a:ln w="9525">
-            <a:solidFill>
-              <a:srgbClr val="EAEAEA"/>
-            </a:solidFill>
-            <a:prstDash val="solid"/>
-          </a:ln>
-        </p:spPr>
-      </p:sp>
-      <p:sp>
-        <p:nvSpPr>
-          <p:cNvPr id="13" name="Text 11"/>
-          <p:cNvSpPr/>
-          <p:nvPr/>
-        </p:nvSpPr>
-        <p:spPr>
-          <a:xfrm>
-            <a:off x="548640" y="1280160"/>
-            <a:ext cx="365760" cy="182880"/>
+          <p:cNvPr id="6" name="Text 4"/>
+          <p:cNvSpPr/>
+          <p:nvPr/>
+        </p:nvSpPr>
+        <p:spPr>
+          <a:xfrm>
+            <a:off x="640080" y="3044952"/>
+            <a:ext cx="1463040" cy="310896"/>
           </a:xfrm>
           <a:prstGeom prst="rect">
             <a:avLst/>
@@ -5161,167 +5095,7 @@
           <a:bodyPr wrap="square" lIns="0" tIns="0" rIns="0" bIns="0" rtlCol="0" anchor="ctr"/>
           <a:lstStyle/>
           <a:p>
-            <a:pPr algn="r" indent="0" marL="0">
-              <a:buNone/>
-            </a:pPr>
-            <a:r>
-              <a:rPr lang="en-US" sz="900" dirty="0">
-                <a:solidFill>
-                  <a:srgbClr val="8C8C8C"/>
-                </a:solidFill>
-                <a:latin typeface="NVIDIA Sans" pitchFamily="34" charset="0"/>
-                <a:ea typeface="NVIDIA Sans" pitchFamily="34" charset="-122"/>
-                <a:cs typeface="NVIDIA Sans" pitchFamily="34" charset="-120"/>
-              </a:rPr>
-              <a:t>400</a:t>
-            </a:r>
-            <a:endParaRPr lang="en-US" sz="900" dirty="0"/>
-          </a:p>
-        </p:txBody>
-      </p:sp>
-      <p:sp>
-        <p:nvSpPr>
-          <p:cNvPr id="14" name="Shape 12"/>
-          <p:cNvSpPr/>
-          <p:nvPr/>
-        </p:nvSpPr>
-        <p:spPr>
-          <a:xfrm>
-            <a:off x="1005840" y="2606040"/>
-            <a:ext cx="4846320" cy="0"/>
-          </a:xfrm>
-          <a:prstGeom prst="line">
-            <a:avLst/>
-          </a:prstGeom>
-          <a:noFill/>
-          <a:ln w="15875">
-            <a:solidFill>
-              <a:srgbClr val="5E5E5E"/>
-            </a:solidFill>
-            <a:prstDash val="dash"/>
-          </a:ln>
-        </p:spPr>
-      </p:sp>
-      <p:sp>
-        <p:nvSpPr>
-          <p:cNvPr id="15" name="Text 13"/>
-          <p:cNvSpPr/>
-          <p:nvPr/>
-        </p:nvSpPr>
-        <p:spPr>
-          <a:xfrm>
-            <a:off x="1051560" y="1399032"/>
-            <a:ext cx="4114800" cy="182880"/>
-          </a:xfrm>
-          <a:prstGeom prst="rect">
-            <a:avLst/>
-          </a:prstGeom>
-          <a:noFill/>
-          <a:ln/>
-        </p:spPr>
-        <p:txBody>
-          <a:bodyPr wrap="square" lIns="0" tIns="0" rIns="0" bIns="0" rtlCol="0" anchor="ctr"/>
-          <a:lstStyle/>
-          <a:p>
             <a:pPr indent="0" marL="0">
-              <a:buNone/>
-            </a:pPr>
-            <a:r>
-              <a:rPr lang="en-US" sz="900" i="1" dirty="0">
-                <a:solidFill>
-                  <a:srgbClr val="5E5E5E"/>
-                </a:solidFill>
-                <a:latin typeface="NVIDIA Sans" pitchFamily="34" charset="0"/>
-                <a:ea typeface="NVIDIA Sans" pitchFamily="34" charset="-122"/>
-                <a:cs typeface="NVIDIA Sans" pitchFamily="34" charset="-120"/>
-              </a:rPr>
-              <a:t>samples / node / s   ·   dashed = 200/node/s target</a:t>
-            </a:r>
-            <a:endParaRPr lang="en-US" sz="900" dirty="0"/>
-          </a:p>
-        </p:txBody>
-      </p:sp>
-      <p:sp>
-        <p:nvSpPr>
-          <p:cNvPr id="16" name="Shape 14"/>
-          <p:cNvSpPr/>
-          <p:nvPr/>
-        </p:nvSpPr>
-        <p:spPr>
-          <a:xfrm>
-            <a:off x="1268730" y="2254225"/>
-            <a:ext cx="685800" cy="1586255"/>
-          </a:xfrm>
-          <a:prstGeom prst="rect">
-            <a:avLst/>
-          </a:prstGeom>
-          <a:solidFill>
-            <a:srgbClr val="008564"/>
-          </a:solidFill>
-          <a:ln/>
-        </p:spPr>
-      </p:sp>
-      <p:sp>
-        <p:nvSpPr>
-          <p:cNvPr id="17" name="Text 15"/>
-          <p:cNvSpPr/>
-          <p:nvPr/>
-        </p:nvSpPr>
-        <p:spPr>
-          <a:xfrm>
-            <a:off x="1131570" y="1998193"/>
-            <a:ext cx="960120" cy="228600"/>
-          </a:xfrm>
-          <a:prstGeom prst="rect">
-            <a:avLst/>
-          </a:prstGeom>
-          <a:noFill/>
-          <a:ln/>
-        </p:spPr>
-        <p:txBody>
-          <a:bodyPr wrap="square" lIns="0" tIns="0" rIns="0" bIns="0" rtlCol="0" anchor="ctr"/>
-          <a:lstStyle/>
-          <a:p>
-            <a:pPr algn="ctr" indent="0" marL="0">
-              <a:buNone/>
-            </a:pPr>
-            <a:r>
-              <a:rPr lang="en-US" sz="1300" b="1" dirty="0">
-                <a:solidFill>
-                  <a:srgbClr val="008564"/>
-                </a:solidFill>
-                <a:latin typeface="NVIDIA Sans" pitchFamily="34" charset="0"/>
-                <a:ea typeface="NVIDIA Sans" pitchFamily="34" charset="-122"/>
-                <a:cs typeface="NVIDIA Sans" pitchFamily="34" charset="-120"/>
-              </a:rPr>
-              <a:t>257</a:t>
-            </a:r>
-            <a:endParaRPr lang="en-US" sz="1300" dirty="0"/>
-          </a:p>
-        </p:txBody>
-      </p:sp>
-      <p:sp>
-        <p:nvSpPr>
-          <p:cNvPr id="18" name="Text 16"/>
-          <p:cNvSpPr/>
-          <p:nvPr/>
-        </p:nvSpPr>
-        <p:spPr>
-          <a:xfrm>
-            <a:off x="1131570" y="3895344"/>
-            <a:ext cx="960120" cy="201168"/>
-          </a:xfrm>
-          <a:prstGeom prst="rect">
-            <a:avLst/>
-          </a:prstGeom>
-          <a:noFill/>
-          <a:ln/>
-        </p:spPr>
-        <p:txBody>
-          <a:bodyPr wrap="square" lIns="0" tIns="0" rIns="0" bIns="0" rtlCol="0" anchor="ctr"/>
-          <a:lstStyle/>
-          <a:p>
-            <a:pPr algn="ctr" indent="0" marL="0">
               <a:buNone/>
             </a:pPr>
             <a:r>
@@ -5333,7 +5107,7 @@
                 <a:ea typeface="NVIDIA Sans" pitchFamily="34" charset="-122"/>
                 <a:cs typeface="NVIDIA Sans" pitchFamily="34" charset="-120"/>
               </a:rPr>
-              <a:t>bs 8</a:t>
+              <a:t>Baseline</a:t>
             </a:r>
             <a:endParaRPr lang="en-US" sz="1100" dirty="0"/>
           </a:p>
@@ -5341,14 +5115,34 @@
       </p:sp>
       <p:sp>
         <p:nvSpPr>
-          <p:cNvPr id="19" name="Text 17"/>
-          <p:cNvSpPr/>
-          <p:nvPr/>
-        </p:nvSpPr>
-        <p:spPr>
-          <a:xfrm>
-            <a:off x="1085850" y="4096512"/>
-            <a:ext cx="1051560" cy="182880"/>
+          <p:cNvPr id="7" name="Shape 5"/>
+          <p:cNvSpPr/>
+          <p:nvPr/>
+        </p:nvSpPr>
+        <p:spPr>
+          <a:xfrm>
+            <a:off x="2148840" y="3063240"/>
+            <a:ext cx="3605332" cy="310896"/>
+          </a:xfrm>
+          <a:prstGeom prst="rect">
+            <a:avLst/>
+          </a:prstGeom>
+          <a:solidFill>
+            <a:srgbClr val="76B900"/>
+          </a:solidFill>
+          <a:ln/>
+        </p:spPr>
+      </p:sp>
+      <p:sp>
+        <p:nvSpPr>
+          <p:cNvPr id="8" name="Text 6"/>
+          <p:cNvSpPr/>
+          <p:nvPr/>
+        </p:nvSpPr>
+        <p:spPr>
+          <a:xfrm>
+            <a:off x="2148840" y="3063240"/>
+            <a:ext cx="3605332" cy="310896"/>
           </a:xfrm>
           <a:prstGeom prst="rect">
             <a:avLst/>
@@ -5364,7 +5158,86 @@
               <a:buNone/>
             </a:pPr>
             <a:r>
-              <a:rPr lang="en-US" sz="900" dirty="0">
+              <a:rPr lang="en-US" sz="1000" b="1" dirty="0">
+                <a:solidFill>
+                  <a:srgbClr val="FFFFFF"/>
+                </a:solidFill>
+                <a:latin typeface="NVIDIA Sans" pitchFamily="34" charset="0"/>
+                <a:ea typeface="NVIDIA Sans" pitchFamily="34" charset="-122"/>
+                <a:cs typeface="NVIDIA Sans" pitchFamily="34" charset="-120"/>
+              </a:rPr>
+              <a:t>540</a:t>
+            </a:r>
+            <a:endParaRPr lang="en-US" sz="1000" dirty="0"/>
+          </a:p>
+        </p:txBody>
+      </p:sp>
+      <p:sp>
+        <p:nvSpPr>
+          <p:cNvPr id="9" name="Shape 7"/>
+          <p:cNvSpPr/>
+          <p:nvPr/>
+        </p:nvSpPr>
+        <p:spPr>
+          <a:xfrm>
+            <a:off x="5754172" y="3063240"/>
+            <a:ext cx="411123" cy="310896"/>
+          </a:xfrm>
+          <a:prstGeom prst="rect">
+            <a:avLst/>
+          </a:prstGeom>
+          <a:solidFill>
+            <a:srgbClr val="0071C5"/>
+          </a:solidFill>
+          <a:ln/>
+        </p:spPr>
+      </p:sp>
+      <p:sp>
+        <p:nvSpPr>
+          <p:cNvPr id="10" name="Shape 8"/>
+          <p:cNvSpPr/>
+          <p:nvPr/>
+        </p:nvSpPr>
+        <p:spPr>
+          <a:xfrm>
+            <a:off x="6165295" y="3063240"/>
+            <a:ext cx="1368852" cy="310896"/>
+          </a:xfrm>
+          <a:prstGeom prst="rect">
+            <a:avLst/>
+          </a:prstGeom>
+          <a:solidFill>
+            <a:srgbClr val="D9D9D9"/>
+          </a:solidFill>
+          <a:ln/>
+        </p:spPr>
+      </p:sp>
+      <p:sp>
+        <p:nvSpPr>
+          <p:cNvPr id="11" name="Text 9"/>
+          <p:cNvSpPr/>
+          <p:nvPr/>
+        </p:nvSpPr>
+        <p:spPr>
+          <a:xfrm>
+            <a:off x="6165295" y="3063240"/>
+            <a:ext cx="1368852" cy="310896"/>
+          </a:xfrm>
+          <a:prstGeom prst="rect">
+            <a:avLst/>
+          </a:prstGeom>
+          <a:noFill/>
+          <a:ln/>
+        </p:spPr>
+        <p:txBody>
+          <a:bodyPr wrap="square" lIns="0" tIns="0" rIns="0" bIns="0" rtlCol="0" anchor="ctr"/>
+          <a:lstStyle/>
+          <a:p>
+            <a:pPr algn="ctr" indent="0" marL="0">
+              <a:buNone/>
+            </a:pPr>
+            <a:r>
+              <a:rPr lang="en-US" sz="1000" b="1" dirty="0">
                 <a:solidFill>
                   <a:srgbClr val="5E5E5E"/>
                 </a:solidFill>
@@ -5372,42 +5245,22 @@
                 <a:ea typeface="NVIDIA Sans" pitchFamily="34" charset="-122"/>
                 <a:cs typeface="NVIDIA Sans" pitchFamily="34" charset="-120"/>
               </a:rPr>
-              <a:t>MFU 23.1%</a:t>
+              <a:t>205</a:t>
             </a:r>
-            <a:endParaRPr lang="en-US" sz="900" dirty="0"/>
+            <a:endParaRPr lang="en-US" sz="1000" dirty="0"/>
           </a:p>
         </p:txBody>
       </p:sp>
       <p:sp>
         <p:nvSpPr>
-          <p:cNvPr id="20" name="Shape 18"/>
-          <p:cNvSpPr/>
-          <p:nvPr/>
-        </p:nvSpPr>
-        <p:spPr>
-          <a:xfrm>
-            <a:off x="2480310" y="1883893"/>
-            <a:ext cx="685800" cy="1956587"/>
-          </a:xfrm>
-          <a:prstGeom prst="rect">
-            <a:avLst/>
-          </a:prstGeom>
-          <a:solidFill>
-            <a:srgbClr val="008564"/>
-          </a:solidFill>
-          <a:ln/>
-        </p:spPr>
-      </p:sp>
-      <p:sp>
-        <p:nvSpPr>
-          <p:cNvPr id="21" name="Text 19"/>
-          <p:cNvSpPr/>
-          <p:nvPr/>
-        </p:nvSpPr>
-        <p:spPr>
-          <a:xfrm>
-            <a:off x="2343150" y="1627861"/>
-            <a:ext cx="960120" cy="228600"/>
+          <p:cNvPr id="12" name="Text 10"/>
+          <p:cNvSpPr/>
+          <p:nvPr/>
+        </p:nvSpPr>
+        <p:spPr>
+          <a:xfrm>
+            <a:off x="7589010" y="3063240"/>
+            <a:ext cx="822960" cy="310896"/>
           </a:xfrm>
           <a:prstGeom prst="rect">
             <a:avLst/>
@@ -5419,46 +5272,7 @@
           <a:bodyPr wrap="square" lIns="0" tIns="0" rIns="0" bIns="0" rtlCol="0" anchor="ctr"/>
           <a:lstStyle/>
           <a:p>
-            <a:pPr algn="ctr" indent="0" marL="0">
-              <a:buNone/>
-            </a:pPr>
-            <a:r>
-              <a:rPr lang="en-US" sz="1300" b="1" dirty="0">
-                <a:solidFill>
-                  <a:srgbClr val="008564"/>
-                </a:solidFill>
-                <a:latin typeface="NVIDIA Sans" pitchFamily="34" charset="0"/>
-                <a:ea typeface="NVIDIA Sans" pitchFamily="34" charset="-122"/>
-                <a:cs typeface="NVIDIA Sans" pitchFamily="34" charset="-120"/>
-              </a:rPr>
-              <a:t>317</a:t>
-            </a:r>
-            <a:endParaRPr lang="en-US" sz="1300" dirty="0"/>
-          </a:p>
-        </p:txBody>
-      </p:sp>
-      <p:sp>
-        <p:nvSpPr>
-          <p:cNvPr id="22" name="Text 20"/>
-          <p:cNvSpPr/>
-          <p:nvPr/>
-        </p:nvSpPr>
-        <p:spPr>
-          <a:xfrm>
-            <a:off x="2343150" y="3895344"/>
-            <a:ext cx="960120" cy="201168"/>
-          </a:xfrm>
-          <a:prstGeom prst="rect">
-            <a:avLst/>
-          </a:prstGeom>
-          <a:noFill/>
-          <a:ln/>
-        </p:spPr>
-        <p:txBody>
-          <a:bodyPr wrap="square" lIns="0" tIns="0" rIns="0" bIns="0" rtlCol="0" anchor="ctr"/>
-          <a:lstStyle/>
-          <a:p>
-            <a:pPr algn="ctr" indent="0" marL="0">
+            <a:pPr indent="0" marL="0">
               <a:buNone/>
             </a:pPr>
             <a:r>
@@ -5470,7 +5284,7 @@
                 <a:ea typeface="NVIDIA Sans" pitchFamily="34" charset="-122"/>
                 <a:cs typeface="NVIDIA Sans" pitchFamily="34" charset="-120"/>
               </a:rPr>
-              <a:t>bs 16</a:t>
+              <a:t>807 ms</a:t>
             </a:r>
             <a:endParaRPr lang="en-US" sz="1100" dirty="0"/>
           </a:p>
@@ -5478,14 +5292,14 @@
       </p:sp>
       <p:sp>
         <p:nvSpPr>
-          <p:cNvPr id="23" name="Text 21"/>
-          <p:cNvSpPr/>
-          <p:nvPr/>
-        </p:nvSpPr>
-        <p:spPr>
-          <a:xfrm>
-            <a:off x="2297430" y="4096512"/>
-            <a:ext cx="1051560" cy="182880"/>
+          <p:cNvPr id="13" name="Text 11"/>
+          <p:cNvSpPr/>
+          <p:nvPr/>
+        </p:nvSpPr>
+        <p:spPr>
+          <a:xfrm>
+            <a:off x="640080" y="3502152"/>
+            <a:ext cx="1463040" cy="310896"/>
           </a:xfrm>
           <a:prstGeom prst="rect">
             <a:avLst/>
@@ -5497,105 +5311,7 @@
           <a:bodyPr wrap="square" lIns="0" tIns="0" rIns="0" bIns="0" rtlCol="0" anchor="ctr"/>
           <a:lstStyle/>
           <a:p>
-            <a:pPr algn="ctr" indent="0" marL="0">
-              <a:buNone/>
-            </a:pPr>
-            <a:r>
-              <a:rPr lang="en-US" sz="900" dirty="0">
-                <a:solidFill>
-                  <a:srgbClr val="5E5E5E"/>
-                </a:solidFill>
-                <a:latin typeface="NVIDIA Sans" pitchFamily="34" charset="0"/>
-                <a:ea typeface="NVIDIA Sans" pitchFamily="34" charset="-122"/>
-                <a:cs typeface="NVIDIA Sans" pitchFamily="34" charset="-120"/>
-              </a:rPr>
-              <a:t>MFU 28.4%</a:t>
-            </a:r>
-            <a:endParaRPr lang="en-US" sz="900" dirty="0"/>
-          </a:p>
-        </p:txBody>
-      </p:sp>
-      <p:sp>
-        <p:nvSpPr>
-          <p:cNvPr id="24" name="Shape 22"/>
-          <p:cNvSpPr/>
-          <p:nvPr/>
-        </p:nvSpPr>
-        <p:spPr>
-          <a:xfrm>
-            <a:off x="3691890" y="1741932"/>
-            <a:ext cx="685800" cy="2098548"/>
-          </a:xfrm>
-          <a:prstGeom prst="rect">
-            <a:avLst/>
-          </a:prstGeom>
-          <a:solidFill>
-            <a:srgbClr val="76B900"/>
-          </a:solidFill>
-          <a:ln/>
-        </p:spPr>
-      </p:sp>
-      <p:sp>
-        <p:nvSpPr>
-          <p:cNvPr id="25" name="Text 23"/>
-          <p:cNvSpPr/>
-          <p:nvPr/>
-        </p:nvSpPr>
-        <p:spPr>
-          <a:xfrm>
-            <a:off x="3554730" y="1485900"/>
-            <a:ext cx="960120" cy="228600"/>
-          </a:xfrm>
-          <a:prstGeom prst="rect">
-            <a:avLst/>
-          </a:prstGeom>
-          <a:noFill/>
-          <a:ln/>
-        </p:spPr>
-        <p:txBody>
-          <a:bodyPr wrap="square" lIns="0" tIns="0" rIns="0" bIns="0" rtlCol="0" anchor="ctr"/>
-          <a:lstStyle/>
-          <a:p>
-            <a:pPr algn="ctr" indent="0" marL="0">
-              <a:buNone/>
-            </a:pPr>
-            <a:r>
-              <a:rPr lang="en-US" sz="1300" b="1" dirty="0">
-                <a:solidFill>
-                  <a:srgbClr val="76B900"/>
-                </a:solidFill>
-                <a:latin typeface="NVIDIA Sans" pitchFamily="34" charset="0"/>
-                <a:ea typeface="NVIDIA Sans" pitchFamily="34" charset="-122"/>
-                <a:cs typeface="NVIDIA Sans" pitchFamily="34" charset="-120"/>
-              </a:rPr>
-              <a:t>340</a:t>
-            </a:r>
-            <a:endParaRPr lang="en-US" sz="1300" dirty="0"/>
-          </a:p>
-        </p:txBody>
-      </p:sp>
-      <p:sp>
-        <p:nvSpPr>
-          <p:cNvPr id="26" name="Text 24"/>
-          <p:cNvSpPr/>
-          <p:nvPr/>
-        </p:nvSpPr>
-        <p:spPr>
-          <a:xfrm>
-            <a:off x="3554730" y="3895344"/>
-            <a:ext cx="960120" cy="201168"/>
-          </a:xfrm>
-          <a:prstGeom prst="rect">
-            <a:avLst/>
-          </a:prstGeom>
-          <a:noFill/>
-          <a:ln/>
-        </p:spPr>
-        <p:txBody>
-          <a:bodyPr wrap="square" lIns="0" tIns="0" rIns="0" bIns="0" rtlCol="0" anchor="ctr"/>
-          <a:lstStyle/>
-          <a:p>
-            <a:pPr algn="ctr" indent="0" marL="0">
+            <a:pPr indent="0" marL="0">
               <a:buNone/>
             </a:pPr>
             <a:r>
@@ -5607,7 +5323,7 @@
                 <a:ea typeface="NVIDIA Sans" pitchFamily="34" charset="-122"/>
                 <a:cs typeface="NVIDIA Sans" pitchFamily="34" charset="-120"/>
               </a:rPr>
-              <a:t>bs 24</a:t>
+              <a:t>Optimized</a:t>
             </a:r>
             <a:endParaRPr lang="en-US" sz="1100" dirty="0"/>
           </a:p>
@@ -5615,14 +5331,34 @@
       </p:sp>
       <p:sp>
         <p:nvSpPr>
-          <p:cNvPr id="27" name="Text 25"/>
-          <p:cNvSpPr/>
-          <p:nvPr/>
-        </p:nvSpPr>
-        <p:spPr>
-          <a:xfrm>
-            <a:off x="3509010" y="4096512"/>
-            <a:ext cx="1051560" cy="182880"/>
+          <p:cNvPr id="14" name="Shape 12"/>
+          <p:cNvSpPr/>
+          <p:nvPr/>
+        </p:nvSpPr>
+        <p:spPr>
+          <a:xfrm>
+            <a:off x="2148840" y="3520440"/>
+            <a:ext cx="1169297" cy="310896"/>
+          </a:xfrm>
+          <a:prstGeom prst="rect">
+            <a:avLst/>
+          </a:prstGeom>
+          <a:solidFill>
+            <a:srgbClr val="76B900"/>
+          </a:solidFill>
+          <a:ln/>
+        </p:spPr>
+      </p:sp>
+      <p:sp>
+        <p:nvSpPr>
+          <p:cNvPr id="15" name="Text 13"/>
+          <p:cNvSpPr/>
+          <p:nvPr/>
+        </p:nvSpPr>
+        <p:spPr>
+          <a:xfrm>
+            <a:off x="2148840" y="3520440"/>
+            <a:ext cx="1169297" cy="310896"/>
           </a:xfrm>
           <a:prstGeom prst="rect">
             <a:avLst/>
@@ -5638,50 +5374,70 @@
               <a:buNone/>
             </a:pPr>
             <a:r>
-              <a:rPr lang="en-US" sz="900" dirty="0">
+              <a:rPr lang="en-US" sz="1000" b="1" dirty="0">
                 <a:solidFill>
-                  <a:srgbClr val="5E5E5E"/>
+                  <a:srgbClr val="FFFFFF"/>
                 </a:solidFill>
                 <a:latin typeface="NVIDIA Sans" pitchFamily="34" charset="0"/>
                 <a:ea typeface="NVIDIA Sans" pitchFamily="34" charset="-122"/>
                 <a:cs typeface="NVIDIA Sans" pitchFamily="34" charset="-120"/>
               </a:rPr>
-              <a:t>MFU 30.5%</a:t>
+              <a:t>175</a:t>
             </a:r>
-            <a:endParaRPr lang="en-US" sz="900" dirty="0"/>
+            <a:endParaRPr lang="en-US" sz="1000" dirty="0"/>
           </a:p>
         </p:txBody>
       </p:sp>
       <p:sp>
         <p:nvSpPr>
-          <p:cNvPr id="28" name="Shape 26"/>
-          <p:cNvSpPr/>
-          <p:nvPr/>
-        </p:nvSpPr>
-        <p:spPr>
-          <a:xfrm>
-            <a:off x="4903470" y="2235708"/>
-            <a:ext cx="685800" cy="1604772"/>
-          </a:xfrm>
-          <a:prstGeom prst="rect">
-            <a:avLst/>
-          </a:prstGeom>
-          <a:solidFill>
-            <a:srgbClr val="890C58"/>
-          </a:solidFill>
-          <a:ln/>
-        </p:spPr>
-      </p:sp>
-      <p:sp>
-        <p:nvSpPr>
-          <p:cNvPr id="29" name="Text 27"/>
-          <p:cNvSpPr/>
-          <p:nvPr/>
-        </p:nvSpPr>
-        <p:spPr>
-          <a:xfrm>
-            <a:off x="4766310" y="1979676"/>
-            <a:ext cx="960120" cy="228600"/>
+          <p:cNvPr id="16" name="Shape 14"/>
+          <p:cNvSpPr/>
+          <p:nvPr/>
+        </p:nvSpPr>
+        <p:spPr>
+          <a:xfrm>
+            <a:off x="3318137" y="3520440"/>
+            <a:ext cx="148164" cy="310896"/>
+          </a:xfrm>
+          <a:prstGeom prst="rect">
+            <a:avLst/>
+          </a:prstGeom>
+          <a:solidFill>
+            <a:srgbClr val="0071C5"/>
+          </a:solidFill>
+          <a:ln/>
+        </p:spPr>
+      </p:sp>
+      <p:sp>
+        <p:nvSpPr>
+          <p:cNvPr id="17" name="Shape 15"/>
+          <p:cNvSpPr/>
+          <p:nvPr/>
+        </p:nvSpPr>
+        <p:spPr>
+          <a:xfrm>
+            <a:off x="3466301" y="3520440"/>
+            <a:ext cx="289655" cy="310896"/>
+          </a:xfrm>
+          <a:prstGeom prst="rect">
+            <a:avLst/>
+          </a:prstGeom>
+          <a:solidFill>
+            <a:srgbClr val="D9D9D9"/>
+          </a:solidFill>
+          <a:ln/>
+        </p:spPr>
+      </p:sp>
+      <p:sp>
+        <p:nvSpPr>
+          <p:cNvPr id="18" name="Text 16"/>
+          <p:cNvSpPr/>
+          <p:nvPr/>
+        </p:nvSpPr>
+        <p:spPr>
+          <a:xfrm>
+            <a:off x="3810820" y="3520440"/>
+            <a:ext cx="822960" cy="310896"/>
           </a:xfrm>
           <a:prstGeom prst="rect">
             <a:avLst/>
@@ -5693,46 +5449,7 @@
           <a:bodyPr wrap="square" lIns="0" tIns="0" rIns="0" bIns="0" rtlCol="0" anchor="ctr"/>
           <a:lstStyle/>
           <a:p>
-            <a:pPr algn="ctr" indent="0" marL="0">
-              <a:buNone/>
-            </a:pPr>
-            <a:r>
-              <a:rPr lang="en-US" sz="1300" b="1" dirty="0">
-                <a:solidFill>
-                  <a:srgbClr val="890C58"/>
-                </a:solidFill>
-                <a:latin typeface="NVIDIA Sans" pitchFamily="34" charset="0"/>
-                <a:ea typeface="NVIDIA Sans" pitchFamily="34" charset="-122"/>
-                <a:cs typeface="NVIDIA Sans" pitchFamily="34" charset="-120"/>
-              </a:rPr>
-              <a:t>260</a:t>
-            </a:r>
-            <a:endParaRPr lang="en-US" sz="1300" dirty="0"/>
-          </a:p>
-        </p:txBody>
-      </p:sp>
-      <p:sp>
-        <p:nvSpPr>
-          <p:cNvPr id="30" name="Text 28"/>
-          <p:cNvSpPr/>
-          <p:nvPr/>
-        </p:nvSpPr>
-        <p:spPr>
-          <a:xfrm>
-            <a:off x="4766310" y="3895344"/>
-            <a:ext cx="960120" cy="201168"/>
-          </a:xfrm>
-          <a:prstGeom prst="rect">
-            <a:avLst/>
-          </a:prstGeom>
-          <a:noFill/>
-          <a:ln/>
-        </p:spPr>
-        <p:txBody>
-          <a:bodyPr wrap="square" lIns="0" tIns="0" rIns="0" bIns="0" rtlCol="0" anchor="ctr"/>
-          <a:lstStyle/>
-          <a:p>
-            <a:pPr algn="ctr" indent="0" marL="0">
+            <a:pPr indent="0" marL="0">
               <a:buNone/>
             </a:pPr>
             <a:r>
@@ -5744,7 +5461,7 @@
                 <a:ea typeface="NVIDIA Sans" pitchFamily="34" charset="-122"/>
                 <a:cs typeface="NVIDIA Sans" pitchFamily="34" charset="-120"/>
               </a:rPr>
-              <a:t>bs 32</a:t>
+              <a:t>249 ms</a:t>
             </a:r>
             <a:endParaRPr lang="en-US" sz="1100" dirty="0"/>
           </a:p>
@@ -5752,14 +5469,34 @@
       </p:sp>
       <p:sp>
         <p:nvSpPr>
-          <p:cNvPr id="31" name="Text 29"/>
-          <p:cNvSpPr/>
-          <p:nvPr/>
-        </p:nvSpPr>
-        <p:spPr>
-          <a:xfrm>
-            <a:off x="4720590" y="4096512"/>
-            <a:ext cx="1051560" cy="182880"/>
+          <p:cNvPr id="19" name="Shape 17"/>
+          <p:cNvSpPr/>
+          <p:nvPr/>
+        </p:nvSpPr>
+        <p:spPr>
+          <a:xfrm>
+            <a:off x="2148840" y="4005072"/>
+            <a:ext cx="164592" cy="128016"/>
+          </a:xfrm>
+          <a:prstGeom prst="rect">
+            <a:avLst/>
+          </a:prstGeom>
+          <a:solidFill>
+            <a:srgbClr val="76B900"/>
+          </a:solidFill>
+          <a:ln/>
+        </p:spPr>
+      </p:sp>
+      <p:sp>
+        <p:nvSpPr>
+          <p:cNvPr id="20" name="Text 18"/>
+          <p:cNvSpPr/>
+          <p:nvPr/>
+        </p:nvSpPr>
+        <p:spPr>
+          <a:xfrm>
+            <a:off x="2368296" y="3931920"/>
+            <a:ext cx="1600200" cy="274320"/>
           </a:xfrm>
           <a:prstGeom prst="rect">
             <a:avLst/>
@@ -5771,11 +5508,11 @@
           <a:bodyPr wrap="square" lIns="0" tIns="0" rIns="0" bIns="0" rtlCol="0" anchor="ctr"/>
           <a:lstStyle/>
           <a:p>
-            <a:pPr algn="ctr" indent="0" marL="0">
+            <a:pPr indent="0" marL="0">
               <a:buNone/>
             </a:pPr>
             <a:r>
-              <a:rPr lang="en-US" sz="900" dirty="0">
+              <a:rPr lang="en-US" sz="1000" dirty="0">
                 <a:solidFill>
                   <a:srgbClr val="5E5E5E"/>
                 </a:solidFill>
@@ -5783,22 +5520,42 @@
                 <a:ea typeface="NVIDIA Sans" pitchFamily="34" charset="-122"/>
                 <a:cs typeface="NVIDIA Sans" pitchFamily="34" charset="-120"/>
               </a:rPr>
-              <a:t>MFU 23.3%</a:t>
+              <a:t>Compute busy</a:t>
             </a:r>
-            <a:endParaRPr lang="en-US" sz="900" dirty="0"/>
+            <a:endParaRPr lang="en-US" sz="1000" dirty="0"/>
           </a:p>
         </p:txBody>
       </p:sp>
       <p:sp>
         <p:nvSpPr>
-          <p:cNvPr id="32" name="Text 30"/>
-          <p:cNvSpPr/>
-          <p:nvPr/>
-        </p:nvSpPr>
-        <p:spPr>
-          <a:xfrm>
-            <a:off x="1051560" y="1399032"/>
-            <a:ext cx="1828800" cy="182880"/>
+          <p:cNvPr id="21" name="Shape 19"/>
+          <p:cNvSpPr/>
+          <p:nvPr/>
+        </p:nvSpPr>
+        <p:spPr>
+          <a:xfrm>
+            <a:off x="3977640" y="4005072"/>
+            <a:ext cx="164592" cy="128016"/>
+          </a:xfrm>
+          <a:prstGeom prst="rect">
+            <a:avLst/>
+          </a:prstGeom>
+          <a:solidFill>
+            <a:srgbClr val="0071C5"/>
+          </a:solidFill>
+          <a:ln/>
+        </p:spPr>
+      </p:sp>
+      <p:sp>
+        <p:nvSpPr>
+          <p:cNvPr id="22" name="Text 20"/>
+          <p:cNvSpPr/>
+          <p:nvPr/>
+        </p:nvSpPr>
+        <p:spPr>
+          <a:xfrm>
+            <a:off x="4197096" y="3931920"/>
+            <a:ext cx="1600200" cy="274320"/>
           </a:xfrm>
           <a:prstGeom prst="rect">
             <a:avLst/>
@@ -5814,7 +5571,105 @@
               <a:buNone/>
             </a:pPr>
             <a:r>
-              <a:rPr lang="en-US" sz="900" i="1" dirty="0">
+              <a:rPr lang="en-US" sz="1000" dirty="0">
+                <a:solidFill>
+                  <a:srgbClr val="5E5E5E"/>
+                </a:solidFill>
+                <a:latin typeface="NVIDIA Sans" pitchFamily="34" charset="0"/>
+                <a:ea typeface="NVIDIA Sans" pitchFamily="34" charset="-122"/>
+                <a:cs typeface="NVIDIA Sans" pitchFamily="34" charset="-120"/>
+              </a:rPr>
+              <a:t>Exposed comm</a:t>
+            </a:r>
+            <a:endParaRPr lang="en-US" sz="1000" dirty="0"/>
+          </a:p>
+        </p:txBody>
+      </p:sp>
+      <p:sp>
+        <p:nvSpPr>
+          <p:cNvPr id="23" name="Shape 21"/>
+          <p:cNvSpPr/>
+          <p:nvPr/>
+        </p:nvSpPr>
+        <p:spPr>
+          <a:xfrm>
+            <a:off x="5806440" y="4005072"/>
+            <a:ext cx="164592" cy="128016"/>
+          </a:xfrm>
+          <a:prstGeom prst="rect">
+            <a:avLst/>
+          </a:prstGeom>
+          <a:solidFill>
+            <a:srgbClr val="D9D9D9"/>
+          </a:solidFill>
+          <a:ln/>
+        </p:spPr>
+      </p:sp>
+      <p:sp>
+        <p:nvSpPr>
+          <p:cNvPr id="24" name="Text 22"/>
+          <p:cNvSpPr/>
+          <p:nvPr/>
+        </p:nvSpPr>
+        <p:spPr>
+          <a:xfrm>
+            <a:off x="6025896" y="3931920"/>
+            <a:ext cx="1600200" cy="274320"/>
+          </a:xfrm>
+          <a:prstGeom prst="rect">
+            <a:avLst/>
+          </a:prstGeom>
+          <a:noFill/>
+          <a:ln/>
+        </p:spPr>
+        <p:txBody>
+          <a:bodyPr wrap="square" lIns="0" tIns="0" rIns="0" bIns="0" rtlCol="0" anchor="ctr"/>
+          <a:lstStyle/>
+          <a:p>
+            <a:pPr indent="0" marL="0">
+              <a:buNone/>
+            </a:pPr>
+            <a:r>
+              <a:rPr lang="en-US" sz="1000" dirty="0">
+                <a:solidFill>
+                  <a:srgbClr val="5E5E5E"/>
+                </a:solidFill>
+                <a:latin typeface="NVIDIA Sans" pitchFamily="34" charset="0"/>
+                <a:ea typeface="NVIDIA Sans" pitchFamily="34" charset="-122"/>
+                <a:cs typeface="NVIDIA Sans" pitchFamily="34" charset="-120"/>
+              </a:rPr>
+              <a:t>Idle / launch gaps</a:t>
+            </a:r>
+            <a:endParaRPr lang="en-US" sz="1000" dirty="0"/>
+          </a:p>
+        </p:txBody>
+      </p:sp>
+      <p:sp>
+        <p:nvSpPr>
+          <p:cNvPr id="25" name="Text 23"/>
+          <p:cNvSpPr/>
+          <p:nvPr/>
+        </p:nvSpPr>
+        <p:spPr>
+          <a:xfrm>
+            <a:off x="457200" y="4224528"/>
+            <a:ext cx="8229600" cy="228600"/>
+          </a:xfrm>
+          <a:prstGeom prst="rect">
+            <a:avLst/>
+          </a:prstGeom>
+          <a:noFill/>
+          <a:ln/>
+        </p:spPr>
+        <p:txBody>
+          <a:bodyPr wrap="square" lIns="0" tIns="0" rIns="0" bIns="0" rtlCol="0" anchor="ctr"/>
+          <a:lstStyle/>
+          <a:p>
+            <a:pPr indent="0" marL="0">
+              <a:buNone/>
+            </a:pPr>
+            <a:r>
+              <a:rPr lang="en-US" sz="950" i="1" dirty="0">
                 <a:solidFill>
                   <a:srgbClr val="8C8C8C"/>
                 </a:solidFill>
@@ -5822,91 +5677,15 @@
                 <a:ea typeface="NVIDIA Sans" pitchFamily="34" charset="-122"/>
                 <a:cs typeface="NVIDIA Sans" pitchFamily="34" charset="-120"/>
               </a:rPr>
-              <a:t>samples / node / s</a:t>
+              <a:t>Gradient AllReduce 15.1 GB/step + optimizer AllGather 15.1 GB/step (bf16). Idle from 254 ms to 43 ms.</a:t>
             </a:r>
-            <a:endParaRPr lang="en-US" sz="900" dirty="0"/>
+            <a:endParaRPr lang="en-US" sz="950" dirty="0"/>
           </a:p>
         </p:txBody>
       </p:sp>
       <p:sp>
         <p:nvSpPr>
-          <p:cNvPr id="33" name="Text 31"/>
-          <p:cNvSpPr/>
-          <p:nvPr/>
-        </p:nvSpPr>
-        <p:spPr>
-          <a:xfrm>
-            <a:off x="6400800" y="1417320"/>
-            <a:ext cx="2286000" cy="2743200"/>
-          </a:xfrm>
-          <a:prstGeom prst="rect">
-            <a:avLst/>
-          </a:prstGeom>
-          <a:noFill/>
-          <a:ln/>
-        </p:spPr>
-        <p:txBody>
-          <a:bodyPr wrap="square" lIns="0" tIns="0" rIns="0" bIns="0" rtlCol="0" anchor="t"/>
-          <a:lstStyle/>
-          <a:p>
-            <a:pPr marL="342900" indent="-342900">
-              <a:buSzPct val="100000"/>
-              <a:buChar char="•"/>
-            </a:pPr>
-            <a:r>
-              <a:rPr lang="en-US" sz="1150" dirty="0">
-                <a:solidFill>
-                  <a:srgbClr val="000000"/>
-                </a:solidFill>
-                <a:latin typeface="NVIDIA Sans" pitchFamily="34" charset="0"/>
-                <a:ea typeface="NVIDIA Sans" pitchFamily="34" charset="-122"/>
-                <a:cs typeface="NVIDIA Sans" pitchFamily="34" charset="-120"/>
-              </a:rPr>
-              <a:t>Batching amortizes launch and comm costs: MFU climbs 23% → 30.5%</a:t>
-            </a:r>
-            <a:endParaRPr lang="en-US" sz="1150" dirty="0"/>
-          </a:p>
-          <a:p>
-            <a:pPr marL="342900" indent="-342900">
-              <a:buSzPct val="100000"/>
-              <a:buChar char="•"/>
-            </a:pPr>
-            <a:r>
-              <a:rPr lang="en-US" sz="1150" dirty="0">
-                <a:solidFill>
-                  <a:srgbClr val="000000"/>
-                </a:solidFill>
-                <a:latin typeface="NVIDIA Sans" pitchFamily="34" charset="0"/>
-                <a:ea typeface="NVIDIA Sans" pitchFamily="34" charset="-122"/>
-                <a:cs typeface="NVIDIA Sans" pitchFamily="34" charset="-120"/>
-              </a:rPr>
-              <a:t>bs 32 regresses hard (986 ms/step): not OOM, not the dataloader — memory-pressure effects under investigation</a:t>
-            </a:r>
-            <a:endParaRPr lang="en-US" sz="1150" dirty="0"/>
-          </a:p>
-          <a:p>
-            <a:pPr marL="342900" indent="-342900">
-              <a:buSzPct val="100000"/>
-              <a:buChar char="•"/>
-            </a:pPr>
-            <a:r>
-              <a:rPr lang="en-US" sz="1150" dirty="0">
-                <a:solidFill>
-                  <a:srgbClr val="000000"/>
-                </a:solidFill>
-                <a:latin typeface="NVIDIA Sans" pitchFamily="34" charset="0"/>
-                <a:ea typeface="NVIDIA Sans" pitchFamily="34" charset="-122"/>
-                <a:cs typeface="NVIDIA Sans" pitchFamily="34" charset="-120"/>
-              </a:rPr>
-              <a:t>Larger global batch (192) changes optimization dynamics — needs a convergence run before adoption</a:t>
-            </a:r>
-            <a:endParaRPr lang="en-US" sz="1150" dirty="0"/>
-          </a:p>
-        </p:txBody>
-      </p:sp>
-      <p:sp>
-        <p:nvSpPr>
-          <p:cNvPr id="34" name="Text 32"/>
+          <p:cNvPr id="26" name="Text 24"/>
           <p:cNvSpPr/>
           <p:nvPr/>
         </p:nvSpPr>
@@ -5945,7 +5724,7 @@
       </p:sp>
       <p:sp>
         <p:nvSpPr>
-          <p:cNvPr id="35" name="Text 33"/>
+          <p:cNvPr id="27" name="Text 25"/>
           <p:cNvSpPr/>
           <p:nvPr/>
         </p:nvSpPr>
@@ -5984,7 +5763,7 @@
       </p:sp>
       <p:sp>
         <p:nvSpPr>
-          <p:cNvPr id="36" name="Shape 34"/>
+          <p:cNvPr id="28" name="Shape 26"/>
           <p:cNvSpPr/>
           <p:nvPr/>
         </p:nvSpPr>
@@ -6004,7 +5783,7 @@
       </p:sp>
       <p:pic>
         <p:nvPicPr>
-          <p:cNvPr id="37" name="Image 0" descr="/app/logos/nvidia-logo-blk-sm.png">    </p:cNvPr>
+          <p:cNvPr id="29" name="Image 0" descr="/app/logos/nvidia-logo-blk-sm.png">    </p:cNvPr>
           <p:cNvPicPr>
             <a:picLocks noChangeAspect="1"/>
           </p:cNvPicPr>
@@ -6091,6 +5870,1273 @@
                 <a:ea typeface="NVIDIA Sans" pitchFamily="34" charset="-122"/>
                 <a:cs typeface="NVIDIA Sans" pitchFamily="34" charset="-120"/>
               </a:rPr>
+              <a:t>Batch Scaling: Sweet Spot at 24 per GPU</a:t>
+            </a:r>
+            <a:endParaRPr lang="en-US" sz="3000" dirty="0"/>
+          </a:p>
+        </p:txBody>
+      </p:sp>
+      <p:sp>
+        <p:nvSpPr>
+          <p:cNvPr id="3" name="Text 1"/>
+          <p:cNvSpPr/>
+          <p:nvPr/>
+        </p:nvSpPr>
+        <p:spPr>
+          <a:xfrm>
+            <a:off x="457200" y="804672"/>
+            <a:ext cx="8229600" cy="329184"/>
+          </a:xfrm>
+          <a:prstGeom prst="rect">
+            <a:avLst/>
+          </a:prstGeom>
+          <a:noFill/>
+          <a:ln/>
+        </p:spPr>
+        <p:txBody>
+          <a:bodyPr wrap="square" lIns="0" tIns="0" rIns="0" bIns="0" rtlCol="0" anchor="ctr"/>
+          <a:lstStyle/>
+          <a:p>
+            <a:pPr indent="0" marL="0">
+              <a:buNone/>
+            </a:pPr>
+            <a:r>
+              <a:rPr lang="en-US" sz="1500" dirty="0">
+                <a:solidFill>
+                  <a:srgbClr val="76B900"/>
+                </a:solidFill>
+                <a:latin typeface="NVIDIA Sans" pitchFamily="34" charset="0"/>
+                <a:ea typeface="NVIDIA Sans" pitchFamily="34" charset="-122"/>
+                <a:cs typeface="NVIDIA Sans" pitchFamily="34" charset="-120"/>
+              </a:rPr>
+              <a:t>Same optimized config, only per-GPU batch changes — peak 340 samples/node/s</a:t>
+            </a:r>
+            <a:endParaRPr lang="en-US" sz="1500" dirty="0"/>
+          </a:p>
+        </p:txBody>
+      </p:sp>
+      <p:sp>
+        <p:nvSpPr>
+          <p:cNvPr id="4" name="Shape 2"/>
+          <p:cNvSpPr/>
+          <p:nvPr/>
+        </p:nvSpPr>
+        <p:spPr>
+          <a:xfrm>
+            <a:off x="1005840" y="3840480"/>
+            <a:ext cx="4846320" cy="0"/>
+          </a:xfrm>
+          <a:prstGeom prst="line">
+            <a:avLst/>
+          </a:prstGeom>
+          <a:noFill/>
+          <a:ln w="9525">
+            <a:solidFill>
+              <a:srgbClr val="EAEAEA"/>
+            </a:solidFill>
+            <a:prstDash val="solid"/>
+          </a:ln>
+        </p:spPr>
+      </p:sp>
+      <p:sp>
+        <p:nvSpPr>
+          <p:cNvPr id="5" name="Text 3"/>
+          <p:cNvSpPr/>
+          <p:nvPr/>
+        </p:nvSpPr>
+        <p:spPr>
+          <a:xfrm>
+            <a:off x="548640" y="3749040"/>
+            <a:ext cx="365760" cy="182880"/>
+          </a:xfrm>
+          <a:prstGeom prst="rect">
+            <a:avLst/>
+          </a:prstGeom>
+          <a:noFill/>
+          <a:ln/>
+        </p:spPr>
+        <p:txBody>
+          <a:bodyPr wrap="square" lIns="0" tIns="0" rIns="0" bIns="0" rtlCol="0" anchor="ctr"/>
+          <a:lstStyle/>
+          <a:p>
+            <a:pPr algn="r" indent="0" marL="0">
+              <a:buNone/>
+            </a:pPr>
+            <a:r>
+              <a:rPr lang="en-US" sz="900" dirty="0">
+                <a:solidFill>
+                  <a:srgbClr val="8C8C8C"/>
+                </a:solidFill>
+                <a:latin typeface="NVIDIA Sans" pitchFamily="34" charset="0"/>
+                <a:ea typeface="NVIDIA Sans" pitchFamily="34" charset="-122"/>
+                <a:cs typeface="NVIDIA Sans" pitchFamily="34" charset="-120"/>
+              </a:rPr>
+              <a:t>0</a:t>
+            </a:r>
+            <a:endParaRPr lang="en-US" sz="900" dirty="0"/>
+          </a:p>
+        </p:txBody>
+      </p:sp>
+      <p:sp>
+        <p:nvSpPr>
+          <p:cNvPr id="6" name="Shape 4"/>
+          <p:cNvSpPr/>
+          <p:nvPr/>
+        </p:nvSpPr>
+        <p:spPr>
+          <a:xfrm>
+            <a:off x="1005840" y="3223260"/>
+            <a:ext cx="4846320" cy="0"/>
+          </a:xfrm>
+          <a:prstGeom prst="line">
+            <a:avLst/>
+          </a:prstGeom>
+          <a:noFill/>
+          <a:ln w="9525">
+            <a:solidFill>
+              <a:srgbClr val="EAEAEA"/>
+            </a:solidFill>
+            <a:prstDash val="solid"/>
+          </a:ln>
+        </p:spPr>
+      </p:sp>
+      <p:sp>
+        <p:nvSpPr>
+          <p:cNvPr id="7" name="Text 5"/>
+          <p:cNvSpPr/>
+          <p:nvPr/>
+        </p:nvSpPr>
+        <p:spPr>
+          <a:xfrm>
+            <a:off x="548640" y="3131820"/>
+            <a:ext cx="365760" cy="182880"/>
+          </a:xfrm>
+          <a:prstGeom prst="rect">
+            <a:avLst/>
+          </a:prstGeom>
+          <a:noFill/>
+          <a:ln/>
+        </p:spPr>
+        <p:txBody>
+          <a:bodyPr wrap="square" lIns="0" tIns="0" rIns="0" bIns="0" rtlCol="0" anchor="ctr"/>
+          <a:lstStyle/>
+          <a:p>
+            <a:pPr algn="r" indent="0" marL="0">
+              <a:buNone/>
+            </a:pPr>
+            <a:r>
+              <a:rPr lang="en-US" sz="900" dirty="0">
+                <a:solidFill>
+                  <a:srgbClr val="8C8C8C"/>
+                </a:solidFill>
+                <a:latin typeface="NVIDIA Sans" pitchFamily="34" charset="0"/>
+                <a:ea typeface="NVIDIA Sans" pitchFamily="34" charset="-122"/>
+                <a:cs typeface="NVIDIA Sans" pitchFamily="34" charset="-120"/>
+              </a:rPr>
+              <a:t>100</a:t>
+            </a:r>
+            <a:endParaRPr lang="en-US" sz="900" dirty="0"/>
+          </a:p>
+        </p:txBody>
+      </p:sp>
+      <p:sp>
+        <p:nvSpPr>
+          <p:cNvPr id="8" name="Shape 6"/>
+          <p:cNvSpPr/>
+          <p:nvPr/>
+        </p:nvSpPr>
+        <p:spPr>
+          <a:xfrm>
+            <a:off x="1005840" y="2606040"/>
+            <a:ext cx="4846320" cy="0"/>
+          </a:xfrm>
+          <a:prstGeom prst="line">
+            <a:avLst/>
+          </a:prstGeom>
+          <a:noFill/>
+          <a:ln w="9525">
+            <a:solidFill>
+              <a:srgbClr val="EAEAEA"/>
+            </a:solidFill>
+            <a:prstDash val="solid"/>
+          </a:ln>
+        </p:spPr>
+      </p:sp>
+      <p:sp>
+        <p:nvSpPr>
+          <p:cNvPr id="9" name="Text 7"/>
+          <p:cNvSpPr/>
+          <p:nvPr/>
+        </p:nvSpPr>
+        <p:spPr>
+          <a:xfrm>
+            <a:off x="548640" y="2514600"/>
+            <a:ext cx="365760" cy="182880"/>
+          </a:xfrm>
+          <a:prstGeom prst="rect">
+            <a:avLst/>
+          </a:prstGeom>
+          <a:noFill/>
+          <a:ln/>
+        </p:spPr>
+        <p:txBody>
+          <a:bodyPr wrap="square" lIns="0" tIns="0" rIns="0" bIns="0" rtlCol="0" anchor="ctr"/>
+          <a:lstStyle/>
+          <a:p>
+            <a:pPr algn="r" indent="0" marL="0">
+              <a:buNone/>
+            </a:pPr>
+            <a:r>
+              <a:rPr lang="en-US" sz="900" dirty="0">
+                <a:solidFill>
+                  <a:srgbClr val="8C8C8C"/>
+                </a:solidFill>
+                <a:latin typeface="NVIDIA Sans" pitchFamily="34" charset="0"/>
+                <a:ea typeface="NVIDIA Sans" pitchFamily="34" charset="-122"/>
+                <a:cs typeface="NVIDIA Sans" pitchFamily="34" charset="-120"/>
+              </a:rPr>
+              <a:t>200</a:t>
+            </a:r>
+            <a:endParaRPr lang="en-US" sz="900" dirty="0"/>
+          </a:p>
+        </p:txBody>
+      </p:sp>
+      <p:sp>
+        <p:nvSpPr>
+          <p:cNvPr id="10" name="Shape 8"/>
+          <p:cNvSpPr/>
+          <p:nvPr/>
+        </p:nvSpPr>
+        <p:spPr>
+          <a:xfrm>
+            <a:off x="1005840" y="1988820"/>
+            <a:ext cx="4846320" cy="0"/>
+          </a:xfrm>
+          <a:prstGeom prst="line">
+            <a:avLst/>
+          </a:prstGeom>
+          <a:noFill/>
+          <a:ln w="9525">
+            <a:solidFill>
+              <a:srgbClr val="EAEAEA"/>
+            </a:solidFill>
+            <a:prstDash val="solid"/>
+          </a:ln>
+        </p:spPr>
+      </p:sp>
+      <p:sp>
+        <p:nvSpPr>
+          <p:cNvPr id="11" name="Text 9"/>
+          <p:cNvSpPr/>
+          <p:nvPr/>
+        </p:nvSpPr>
+        <p:spPr>
+          <a:xfrm>
+            <a:off x="548640" y="1897380"/>
+            <a:ext cx="365760" cy="182880"/>
+          </a:xfrm>
+          <a:prstGeom prst="rect">
+            <a:avLst/>
+          </a:prstGeom>
+          <a:noFill/>
+          <a:ln/>
+        </p:spPr>
+        <p:txBody>
+          <a:bodyPr wrap="square" lIns="0" tIns="0" rIns="0" bIns="0" rtlCol="0" anchor="ctr"/>
+          <a:lstStyle/>
+          <a:p>
+            <a:pPr algn="r" indent="0" marL="0">
+              <a:buNone/>
+            </a:pPr>
+            <a:r>
+              <a:rPr lang="en-US" sz="900" dirty="0">
+                <a:solidFill>
+                  <a:srgbClr val="8C8C8C"/>
+                </a:solidFill>
+                <a:latin typeface="NVIDIA Sans" pitchFamily="34" charset="0"/>
+                <a:ea typeface="NVIDIA Sans" pitchFamily="34" charset="-122"/>
+                <a:cs typeface="NVIDIA Sans" pitchFamily="34" charset="-120"/>
+              </a:rPr>
+              <a:t>300</a:t>
+            </a:r>
+            <a:endParaRPr lang="en-US" sz="900" dirty="0"/>
+          </a:p>
+        </p:txBody>
+      </p:sp>
+      <p:sp>
+        <p:nvSpPr>
+          <p:cNvPr id="12" name="Shape 10"/>
+          <p:cNvSpPr/>
+          <p:nvPr/>
+        </p:nvSpPr>
+        <p:spPr>
+          <a:xfrm>
+            <a:off x="1005840" y="1371600"/>
+            <a:ext cx="4846320" cy="0"/>
+          </a:xfrm>
+          <a:prstGeom prst="line">
+            <a:avLst/>
+          </a:prstGeom>
+          <a:noFill/>
+          <a:ln w="9525">
+            <a:solidFill>
+              <a:srgbClr val="EAEAEA"/>
+            </a:solidFill>
+            <a:prstDash val="solid"/>
+          </a:ln>
+        </p:spPr>
+      </p:sp>
+      <p:sp>
+        <p:nvSpPr>
+          <p:cNvPr id="13" name="Text 11"/>
+          <p:cNvSpPr/>
+          <p:nvPr/>
+        </p:nvSpPr>
+        <p:spPr>
+          <a:xfrm>
+            <a:off x="548640" y="1280160"/>
+            <a:ext cx="365760" cy="182880"/>
+          </a:xfrm>
+          <a:prstGeom prst="rect">
+            <a:avLst/>
+          </a:prstGeom>
+          <a:noFill/>
+          <a:ln/>
+        </p:spPr>
+        <p:txBody>
+          <a:bodyPr wrap="square" lIns="0" tIns="0" rIns="0" bIns="0" rtlCol="0" anchor="ctr"/>
+          <a:lstStyle/>
+          <a:p>
+            <a:pPr algn="r" indent="0" marL="0">
+              <a:buNone/>
+            </a:pPr>
+            <a:r>
+              <a:rPr lang="en-US" sz="900" dirty="0">
+                <a:solidFill>
+                  <a:srgbClr val="8C8C8C"/>
+                </a:solidFill>
+                <a:latin typeface="NVIDIA Sans" pitchFamily="34" charset="0"/>
+                <a:ea typeface="NVIDIA Sans" pitchFamily="34" charset="-122"/>
+                <a:cs typeface="NVIDIA Sans" pitchFamily="34" charset="-120"/>
+              </a:rPr>
+              <a:t>400</a:t>
+            </a:r>
+            <a:endParaRPr lang="en-US" sz="900" dirty="0"/>
+          </a:p>
+        </p:txBody>
+      </p:sp>
+      <p:sp>
+        <p:nvSpPr>
+          <p:cNvPr id="14" name="Shape 12"/>
+          <p:cNvSpPr/>
+          <p:nvPr/>
+        </p:nvSpPr>
+        <p:spPr>
+          <a:xfrm>
+            <a:off x="1005840" y="2606040"/>
+            <a:ext cx="4846320" cy="0"/>
+          </a:xfrm>
+          <a:prstGeom prst="line">
+            <a:avLst/>
+          </a:prstGeom>
+          <a:noFill/>
+          <a:ln w="15875">
+            <a:solidFill>
+              <a:srgbClr val="5E5E5E"/>
+            </a:solidFill>
+            <a:prstDash val="dash"/>
+          </a:ln>
+        </p:spPr>
+      </p:sp>
+      <p:sp>
+        <p:nvSpPr>
+          <p:cNvPr id="15" name="Text 13"/>
+          <p:cNvSpPr/>
+          <p:nvPr/>
+        </p:nvSpPr>
+        <p:spPr>
+          <a:xfrm>
+            <a:off x="1051560" y="1399032"/>
+            <a:ext cx="4114800" cy="182880"/>
+          </a:xfrm>
+          <a:prstGeom prst="rect">
+            <a:avLst/>
+          </a:prstGeom>
+          <a:noFill/>
+          <a:ln/>
+        </p:spPr>
+        <p:txBody>
+          <a:bodyPr wrap="square" lIns="0" tIns="0" rIns="0" bIns="0" rtlCol="0" anchor="ctr"/>
+          <a:lstStyle/>
+          <a:p>
+            <a:pPr indent="0" marL="0">
+              <a:buNone/>
+            </a:pPr>
+            <a:r>
+              <a:rPr lang="en-US" sz="900" i="1" dirty="0">
+                <a:solidFill>
+                  <a:srgbClr val="5E5E5E"/>
+                </a:solidFill>
+                <a:latin typeface="NVIDIA Sans" pitchFamily="34" charset="0"/>
+                <a:ea typeface="NVIDIA Sans" pitchFamily="34" charset="-122"/>
+                <a:cs typeface="NVIDIA Sans" pitchFamily="34" charset="-120"/>
+              </a:rPr>
+              <a:t>samples / node / s   ·   dashed = 200/node/s target</a:t>
+            </a:r>
+            <a:endParaRPr lang="en-US" sz="900" dirty="0"/>
+          </a:p>
+        </p:txBody>
+      </p:sp>
+      <p:sp>
+        <p:nvSpPr>
+          <p:cNvPr id="16" name="Shape 14"/>
+          <p:cNvSpPr/>
+          <p:nvPr/>
+        </p:nvSpPr>
+        <p:spPr>
+          <a:xfrm>
+            <a:off x="1268730" y="2254225"/>
+            <a:ext cx="685800" cy="1586255"/>
+          </a:xfrm>
+          <a:prstGeom prst="rect">
+            <a:avLst/>
+          </a:prstGeom>
+          <a:solidFill>
+            <a:srgbClr val="008564"/>
+          </a:solidFill>
+          <a:ln/>
+        </p:spPr>
+      </p:sp>
+      <p:sp>
+        <p:nvSpPr>
+          <p:cNvPr id="17" name="Text 15"/>
+          <p:cNvSpPr/>
+          <p:nvPr/>
+        </p:nvSpPr>
+        <p:spPr>
+          <a:xfrm>
+            <a:off x="1131570" y="1998193"/>
+            <a:ext cx="960120" cy="228600"/>
+          </a:xfrm>
+          <a:prstGeom prst="rect">
+            <a:avLst/>
+          </a:prstGeom>
+          <a:noFill/>
+          <a:ln/>
+        </p:spPr>
+        <p:txBody>
+          <a:bodyPr wrap="square" lIns="0" tIns="0" rIns="0" bIns="0" rtlCol="0" anchor="ctr"/>
+          <a:lstStyle/>
+          <a:p>
+            <a:pPr algn="ctr" indent="0" marL="0">
+              <a:buNone/>
+            </a:pPr>
+            <a:r>
+              <a:rPr lang="en-US" sz="1300" b="1" dirty="0">
+                <a:solidFill>
+                  <a:srgbClr val="008564"/>
+                </a:solidFill>
+                <a:latin typeface="NVIDIA Sans" pitchFamily="34" charset="0"/>
+                <a:ea typeface="NVIDIA Sans" pitchFamily="34" charset="-122"/>
+                <a:cs typeface="NVIDIA Sans" pitchFamily="34" charset="-120"/>
+              </a:rPr>
+              <a:t>257</a:t>
+            </a:r>
+            <a:endParaRPr lang="en-US" sz="1300" dirty="0"/>
+          </a:p>
+        </p:txBody>
+      </p:sp>
+      <p:sp>
+        <p:nvSpPr>
+          <p:cNvPr id="18" name="Text 16"/>
+          <p:cNvSpPr/>
+          <p:nvPr/>
+        </p:nvSpPr>
+        <p:spPr>
+          <a:xfrm>
+            <a:off x="1131570" y="3895344"/>
+            <a:ext cx="960120" cy="201168"/>
+          </a:xfrm>
+          <a:prstGeom prst="rect">
+            <a:avLst/>
+          </a:prstGeom>
+          <a:noFill/>
+          <a:ln/>
+        </p:spPr>
+        <p:txBody>
+          <a:bodyPr wrap="square" lIns="0" tIns="0" rIns="0" bIns="0" rtlCol="0" anchor="ctr"/>
+          <a:lstStyle/>
+          <a:p>
+            <a:pPr algn="ctr" indent="0" marL="0">
+              <a:buNone/>
+            </a:pPr>
+            <a:r>
+              <a:rPr lang="en-US" sz="1100" b="1" dirty="0">
+                <a:solidFill>
+                  <a:srgbClr val="000000"/>
+                </a:solidFill>
+                <a:latin typeface="NVIDIA Sans" pitchFamily="34" charset="0"/>
+                <a:ea typeface="NVIDIA Sans" pitchFamily="34" charset="-122"/>
+                <a:cs typeface="NVIDIA Sans" pitchFamily="34" charset="-120"/>
+              </a:rPr>
+              <a:t>bs 8</a:t>
+            </a:r>
+            <a:endParaRPr lang="en-US" sz="1100" dirty="0"/>
+          </a:p>
+        </p:txBody>
+      </p:sp>
+      <p:sp>
+        <p:nvSpPr>
+          <p:cNvPr id="19" name="Text 17"/>
+          <p:cNvSpPr/>
+          <p:nvPr/>
+        </p:nvSpPr>
+        <p:spPr>
+          <a:xfrm>
+            <a:off x="1085850" y="4096512"/>
+            <a:ext cx="1051560" cy="182880"/>
+          </a:xfrm>
+          <a:prstGeom prst="rect">
+            <a:avLst/>
+          </a:prstGeom>
+          <a:noFill/>
+          <a:ln/>
+        </p:spPr>
+        <p:txBody>
+          <a:bodyPr wrap="square" lIns="0" tIns="0" rIns="0" bIns="0" rtlCol="0" anchor="ctr"/>
+          <a:lstStyle/>
+          <a:p>
+            <a:pPr algn="ctr" indent="0" marL="0">
+              <a:buNone/>
+            </a:pPr>
+            <a:r>
+              <a:rPr lang="en-US" sz="900" dirty="0">
+                <a:solidFill>
+                  <a:srgbClr val="5E5E5E"/>
+                </a:solidFill>
+                <a:latin typeface="NVIDIA Sans" pitchFamily="34" charset="0"/>
+                <a:ea typeface="NVIDIA Sans" pitchFamily="34" charset="-122"/>
+                <a:cs typeface="NVIDIA Sans" pitchFamily="34" charset="-120"/>
+              </a:rPr>
+              <a:t>MFU 23.1%</a:t>
+            </a:r>
+            <a:endParaRPr lang="en-US" sz="900" dirty="0"/>
+          </a:p>
+        </p:txBody>
+      </p:sp>
+      <p:sp>
+        <p:nvSpPr>
+          <p:cNvPr id="20" name="Shape 18"/>
+          <p:cNvSpPr/>
+          <p:nvPr/>
+        </p:nvSpPr>
+        <p:spPr>
+          <a:xfrm>
+            <a:off x="2480310" y="1883893"/>
+            <a:ext cx="685800" cy="1956587"/>
+          </a:xfrm>
+          <a:prstGeom prst="rect">
+            <a:avLst/>
+          </a:prstGeom>
+          <a:solidFill>
+            <a:srgbClr val="008564"/>
+          </a:solidFill>
+          <a:ln/>
+        </p:spPr>
+      </p:sp>
+      <p:sp>
+        <p:nvSpPr>
+          <p:cNvPr id="21" name="Text 19"/>
+          <p:cNvSpPr/>
+          <p:nvPr/>
+        </p:nvSpPr>
+        <p:spPr>
+          <a:xfrm>
+            <a:off x="2343150" y="1627861"/>
+            <a:ext cx="960120" cy="228600"/>
+          </a:xfrm>
+          <a:prstGeom prst="rect">
+            <a:avLst/>
+          </a:prstGeom>
+          <a:noFill/>
+          <a:ln/>
+        </p:spPr>
+        <p:txBody>
+          <a:bodyPr wrap="square" lIns="0" tIns="0" rIns="0" bIns="0" rtlCol="0" anchor="ctr"/>
+          <a:lstStyle/>
+          <a:p>
+            <a:pPr algn="ctr" indent="0" marL="0">
+              <a:buNone/>
+            </a:pPr>
+            <a:r>
+              <a:rPr lang="en-US" sz="1300" b="1" dirty="0">
+                <a:solidFill>
+                  <a:srgbClr val="008564"/>
+                </a:solidFill>
+                <a:latin typeface="NVIDIA Sans" pitchFamily="34" charset="0"/>
+                <a:ea typeface="NVIDIA Sans" pitchFamily="34" charset="-122"/>
+                <a:cs typeface="NVIDIA Sans" pitchFamily="34" charset="-120"/>
+              </a:rPr>
+              <a:t>317</a:t>
+            </a:r>
+            <a:endParaRPr lang="en-US" sz="1300" dirty="0"/>
+          </a:p>
+        </p:txBody>
+      </p:sp>
+      <p:sp>
+        <p:nvSpPr>
+          <p:cNvPr id="22" name="Text 20"/>
+          <p:cNvSpPr/>
+          <p:nvPr/>
+        </p:nvSpPr>
+        <p:spPr>
+          <a:xfrm>
+            <a:off x="2343150" y="3895344"/>
+            <a:ext cx="960120" cy="201168"/>
+          </a:xfrm>
+          <a:prstGeom prst="rect">
+            <a:avLst/>
+          </a:prstGeom>
+          <a:noFill/>
+          <a:ln/>
+        </p:spPr>
+        <p:txBody>
+          <a:bodyPr wrap="square" lIns="0" tIns="0" rIns="0" bIns="0" rtlCol="0" anchor="ctr"/>
+          <a:lstStyle/>
+          <a:p>
+            <a:pPr algn="ctr" indent="0" marL="0">
+              <a:buNone/>
+            </a:pPr>
+            <a:r>
+              <a:rPr lang="en-US" sz="1100" b="1" dirty="0">
+                <a:solidFill>
+                  <a:srgbClr val="000000"/>
+                </a:solidFill>
+                <a:latin typeface="NVIDIA Sans" pitchFamily="34" charset="0"/>
+                <a:ea typeface="NVIDIA Sans" pitchFamily="34" charset="-122"/>
+                <a:cs typeface="NVIDIA Sans" pitchFamily="34" charset="-120"/>
+              </a:rPr>
+              <a:t>bs 16</a:t>
+            </a:r>
+            <a:endParaRPr lang="en-US" sz="1100" dirty="0"/>
+          </a:p>
+        </p:txBody>
+      </p:sp>
+      <p:sp>
+        <p:nvSpPr>
+          <p:cNvPr id="23" name="Text 21"/>
+          <p:cNvSpPr/>
+          <p:nvPr/>
+        </p:nvSpPr>
+        <p:spPr>
+          <a:xfrm>
+            <a:off x="2297430" y="4096512"/>
+            <a:ext cx="1051560" cy="182880"/>
+          </a:xfrm>
+          <a:prstGeom prst="rect">
+            <a:avLst/>
+          </a:prstGeom>
+          <a:noFill/>
+          <a:ln/>
+        </p:spPr>
+        <p:txBody>
+          <a:bodyPr wrap="square" lIns="0" tIns="0" rIns="0" bIns="0" rtlCol="0" anchor="ctr"/>
+          <a:lstStyle/>
+          <a:p>
+            <a:pPr algn="ctr" indent="0" marL="0">
+              <a:buNone/>
+            </a:pPr>
+            <a:r>
+              <a:rPr lang="en-US" sz="900" dirty="0">
+                <a:solidFill>
+                  <a:srgbClr val="5E5E5E"/>
+                </a:solidFill>
+                <a:latin typeface="NVIDIA Sans" pitchFamily="34" charset="0"/>
+                <a:ea typeface="NVIDIA Sans" pitchFamily="34" charset="-122"/>
+                <a:cs typeface="NVIDIA Sans" pitchFamily="34" charset="-120"/>
+              </a:rPr>
+              <a:t>MFU 28.4%</a:t>
+            </a:r>
+            <a:endParaRPr lang="en-US" sz="900" dirty="0"/>
+          </a:p>
+        </p:txBody>
+      </p:sp>
+      <p:sp>
+        <p:nvSpPr>
+          <p:cNvPr id="24" name="Shape 22"/>
+          <p:cNvSpPr/>
+          <p:nvPr/>
+        </p:nvSpPr>
+        <p:spPr>
+          <a:xfrm>
+            <a:off x="3691890" y="1741932"/>
+            <a:ext cx="685800" cy="2098548"/>
+          </a:xfrm>
+          <a:prstGeom prst="rect">
+            <a:avLst/>
+          </a:prstGeom>
+          <a:solidFill>
+            <a:srgbClr val="76B900"/>
+          </a:solidFill>
+          <a:ln/>
+        </p:spPr>
+      </p:sp>
+      <p:sp>
+        <p:nvSpPr>
+          <p:cNvPr id="25" name="Text 23"/>
+          <p:cNvSpPr/>
+          <p:nvPr/>
+        </p:nvSpPr>
+        <p:spPr>
+          <a:xfrm>
+            <a:off x="3554730" y="1485900"/>
+            <a:ext cx="960120" cy="228600"/>
+          </a:xfrm>
+          <a:prstGeom prst="rect">
+            <a:avLst/>
+          </a:prstGeom>
+          <a:noFill/>
+          <a:ln/>
+        </p:spPr>
+        <p:txBody>
+          <a:bodyPr wrap="square" lIns="0" tIns="0" rIns="0" bIns="0" rtlCol="0" anchor="ctr"/>
+          <a:lstStyle/>
+          <a:p>
+            <a:pPr algn="ctr" indent="0" marL="0">
+              <a:buNone/>
+            </a:pPr>
+            <a:r>
+              <a:rPr lang="en-US" sz="1300" b="1" dirty="0">
+                <a:solidFill>
+                  <a:srgbClr val="76B900"/>
+                </a:solidFill>
+                <a:latin typeface="NVIDIA Sans" pitchFamily="34" charset="0"/>
+                <a:ea typeface="NVIDIA Sans" pitchFamily="34" charset="-122"/>
+                <a:cs typeface="NVIDIA Sans" pitchFamily="34" charset="-120"/>
+              </a:rPr>
+              <a:t>340</a:t>
+            </a:r>
+            <a:endParaRPr lang="en-US" sz="1300" dirty="0"/>
+          </a:p>
+        </p:txBody>
+      </p:sp>
+      <p:sp>
+        <p:nvSpPr>
+          <p:cNvPr id="26" name="Text 24"/>
+          <p:cNvSpPr/>
+          <p:nvPr/>
+        </p:nvSpPr>
+        <p:spPr>
+          <a:xfrm>
+            <a:off x="3554730" y="3895344"/>
+            <a:ext cx="960120" cy="201168"/>
+          </a:xfrm>
+          <a:prstGeom prst="rect">
+            <a:avLst/>
+          </a:prstGeom>
+          <a:noFill/>
+          <a:ln/>
+        </p:spPr>
+        <p:txBody>
+          <a:bodyPr wrap="square" lIns="0" tIns="0" rIns="0" bIns="0" rtlCol="0" anchor="ctr"/>
+          <a:lstStyle/>
+          <a:p>
+            <a:pPr algn="ctr" indent="0" marL="0">
+              <a:buNone/>
+            </a:pPr>
+            <a:r>
+              <a:rPr lang="en-US" sz="1100" b="1" dirty="0">
+                <a:solidFill>
+                  <a:srgbClr val="000000"/>
+                </a:solidFill>
+                <a:latin typeface="NVIDIA Sans" pitchFamily="34" charset="0"/>
+                <a:ea typeface="NVIDIA Sans" pitchFamily="34" charset="-122"/>
+                <a:cs typeface="NVIDIA Sans" pitchFamily="34" charset="-120"/>
+              </a:rPr>
+              <a:t>bs 24</a:t>
+            </a:r>
+            <a:endParaRPr lang="en-US" sz="1100" dirty="0"/>
+          </a:p>
+        </p:txBody>
+      </p:sp>
+      <p:sp>
+        <p:nvSpPr>
+          <p:cNvPr id="27" name="Text 25"/>
+          <p:cNvSpPr/>
+          <p:nvPr/>
+        </p:nvSpPr>
+        <p:spPr>
+          <a:xfrm>
+            <a:off x="3509010" y="4096512"/>
+            <a:ext cx="1051560" cy="182880"/>
+          </a:xfrm>
+          <a:prstGeom prst="rect">
+            <a:avLst/>
+          </a:prstGeom>
+          <a:noFill/>
+          <a:ln/>
+        </p:spPr>
+        <p:txBody>
+          <a:bodyPr wrap="square" lIns="0" tIns="0" rIns="0" bIns="0" rtlCol="0" anchor="ctr"/>
+          <a:lstStyle/>
+          <a:p>
+            <a:pPr algn="ctr" indent="0" marL="0">
+              <a:buNone/>
+            </a:pPr>
+            <a:r>
+              <a:rPr lang="en-US" sz="900" dirty="0">
+                <a:solidFill>
+                  <a:srgbClr val="5E5E5E"/>
+                </a:solidFill>
+                <a:latin typeface="NVIDIA Sans" pitchFamily="34" charset="0"/>
+                <a:ea typeface="NVIDIA Sans" pitchFamily="34" charset="-122"/>
+                <a:cs typeface="NVIDIA Sans" pitchFamily="34" charset="-120"/>
+              </a:rPr>
+              <a:t>MFU 30.5%</a:t>
+            </a:r>
+            <a:endParaRPr lang="en-US" sz="900" dirty="0"/>
+          </a:p>
+        </p:txBody>
+      </p:sp>
+      <p:sp>
+        <p:nvSpPr>
+          <p:cNvPr id="28" name="Shape 26"/>
+          <p:cNvSpPr/>
+          <p:nvPr/>
+        </p:nvSpPr>
+        <p:spPr>
+          <a:xfrm>
+            <a:off x="4903470" y="2235708"/>
+            <a:ext cx="685800" cy="1604772"/>
+          </a:xfrm>
+          <a:prstGeom prst="rect">
+            <a:avLst/>
+          </a:prstGeom>
+          <a:solidFill>
+            <a:srgbClr val="890C58"/>
+          </a:solidFill>
+          <a:ln/>
+        </p:spPr>
+      </p:sp>
+      <p:sp>
+        <p:nvSpPr>
+          <p:cNvPr id="29" name="Text 27"/>
+          <p:cNvSpPr/>
+          <p:nvPr/>
+        </p:nvSpPr>
+        <p:spPr>
+          <a:xfrm>
+            <a:off x="4766310" y="1979676"/>
+            <a:ext cx="960120" cy="228600"/>
+          </a:xfrm>
+          <a:prstGeom prst="rect">
+            <a:avLst/>
+          </a:prstGeom>
+          <a:noFill/>
+          <a:ln/>
+        </p:spPr>
+        <p:txBody>
+          <a:bodyPr wrap="square" lIns="0" tIns="0" rIns="0" bIns="0" rtlCol="0" anchor="ctr"/>
+          <a:lstStyle/>
+          <a:p>
+            <a:pPr algn="ctr" indent="0" marL="0">
+              <a:buNone/>
+            </a:pPr>
+            <a:r>
+              <a:rPr lang="en-US" sz="1300" b="1" dirty="0">
+                <a:solidFill>
+                  <a:srgbClr val="890C58"/>
+                </a:solidFill>
+                <a:latin typeface="NVIDIA Sans" pitchFamily="34" charset="0"/>
+                <a:ea typeface="NVIDIA Sans" pitchFamily="34" charset="-122"/>
+                <a:cs typeface="NVIDIA Sans" pitchFamily="34" charset="-120"/>
+              </a:rPr>
+              <a:t>260</a:t>
+            </a:r>
+            <a:endParaRPr lang="en-US" sz="1300" dirty="0"/>
+          </a:p>
+        </p:txBody>
+      </p:sp>
+      <p:sp>
+        <p:nvSpPr>
+          <p:cNvPr id="30" name="Text 28"/>
+          <p:cNvSpPr/>
+          <p:nvPr/>
+        </p:nvSpPr>
+        <p:spPr>
+          <a:xfrm>
+            <a:off x="4766310" y="3895344"/>
+            <a:ext cx="960120" cy="201168"/>
+          </a:xfrm>
+          <a:prstGeom prst="rect">
+            <a:avLst/>
+          </a:prstGeom>
+          <a:noFill/>
+          <a:ln/>
+        </p:spPr>
+        <p:txBody>
+          <a:bodyPr wrap="square" lIns="0" tIns="0" rIns="0" bIns="0" rtlCol="0" anchor="ctr"/>
+          <a:lstStyle/>
+          <a:p>
+            <a:pPr algn="ctr" indent="0" marL="0">
+              <a:buNone/>
+            </a:pPr>
+            <a:r>
+              <a:rPr lang="en-US" sz="1100" b="1" dirty="0">
+                <a:solidFill>
+                  <a:srgbClr val="000000"/>
+                </a:solidFill>
+                <a:latin typeface="NVIDIA Sans" pitchFamily="34" charset="0"/>
+                <a:ea typeface="NVIDIA Sans" pitchFamily="34" charset="-122"/>
+                <a:cs typeface="NVIDIA Sans" pitchFamily="34" charset="-120"/>
+              </a:rPr>
+              <a:t>bs 32</a:t>
+            </a:r>
+            <a:endParaRPr lang="en-US" sz="1100" dirty="0"/>
+          </a:p>
+        </p:txBody>
+      </p:sp>
+      <p:sp>
+        <p:nvSpPr>
+          <p:cNvPr id="31" name="Text 29"/>
+          <p:cNvSpPr/>
+          <p:nvPr/>
+        </p:nvSpPr>
+        <p:spPr>
+          <a:xfrm>
+            <a:off x="4720590" y="4096512"/>
+            <a:ext cx="1051560" cy="182880"/>
+          </a:xfrm>
+          <a:prstGeom prst="rect">
+            <a:avLst/>
+          </a:prstGeom>
+          <a:noFill/>
+          <a:ln/>
+        </p:spPr>
+        <p:txBody>
+          <a:bodyPr wrap="square" lIns="0" tIns="0" rIns="0" bIns="0" rtlCol="0" anchor="ctr"/>
+          <a:lstStyle/>
+          <a:p>
+            <a:pPr algn="ctr" indent="0" marL="0">
+              <a:buNone/>
+            </a:pPr>
+            <a:r>
+              <a:rPr lang="en-US" sz="900" dirty="0">
+                <a:solidFill>
+                  <a:srgbClr val="5E5E5E"/>
+                </a:solidFill>
+                <a:latin typeface="NVIDIA Sans" pitchFamily="34" charset="0"/>
+                <a:ea typeface="NVIDIA Sans" pitchFamily="34" charset="-122"/>
+                <a:cs typeface="NVIDIA Sans" pitchFamily="34" charset="-120"/>
+              </a:rPr>
+              <a:t>MFU 23.3%</a:t>
+            </a:r>
+            <a:endParaRPr lang="en-US" sz="900" dirty="0"/>
+          </a:p>
+        </p:txBody>
+      </p:sp>
+      <p:sp>
+        <p:nvSpPr>
+          <p:cNvPr id="32" name="Text 30"/>
+          <p:cNvSpPr/>
+          <p:nvPr/>
+        </p:nvSpPr>
+        <p:spPr>
+          <a:xfrm>
+            <a:off x="1051560" y="1399032"/>
+            <a:ext cx="1828800" cy="182880"/>
+          </a:xfrm>
+          <a:prstGeom prst="rect">
+            <a:avLst/>
+          </a:prstGeom>
+          <a:noFill/>
+          <a:ln/>
+        </p:spPr>
+        <p:txBody>
+          <a:bodyPr wrap="square" lIns="0" tIns="0" rIns="0" bIns="0" rtlCol="0" anchor="ctr"/>
+          <a:lstStyle/>
+          <a:p>
+            <a:pPr indent="0" marL="0">
+              <a:buNone/>
+            </a:pPr>
+            <a:r>
+              <a:rPr lang="en-US" sz="900" i="1" dirty="0">
+                <a:solidFill>
+                  <a:srgbClr val="8C8C8C"/>
+                </a:solidFill>
+                <a:latin typeface="NVIDIA Sans" pitchFamily="34" charset="0"/>
+                <a:ea typeface="NVIDIA Sans" pitchFamily="34" charset="-122"/>
+                <a:cs typeface="NVIDIA Sans" pitchFamily="34" charset="-120"/>
+              </a:rPr>
+              <a:t>samples / node / s</a:t>
+            </a:r>
+            <a:endParaRPr lang="en-US" sz="900" dirty="0"/>
+          </a:p>
+        </p:txBody>
+      </p:sp>
+      <p:sp>
+        <p:nvSpPr>
+          <p:cNvPr id="33" name="Text 31"/>
+          <p:cNvSpPr/>
+          <p:nvPr/>
+        </p:nvSpPr>
+        <p:spPr>
+          <a:xfrm>
+            <a:off x="6400800" y="1417320"/>
+            <a:ext cx="2286000" cy="2743200"/>
+          </a:xfrm>
+          <a:prstGeom prst="rect">
+            <a:avLst/>
+          </a:prstGeom>
+          <a:noFill/>
+          <a:ln/>
+        </p:spPr>
+        <p:txBody>
+          <a:bodyPr wrap="square" lIns="0" tIns="0" rIns="0" bIns="0" rtlCol="0" anchor="t"/>
+          <a:lstStyle/>
+          <a:p>
+            <a:pPr marL="342900" indent="-342900">
+              <a:buSzPct val="100000"/>
+              <a:buChar char="•"/>
+            </a:pPr>
+            <a:r>
+              <a:rPr lang="en-US" sz="1150" dirty="0">
+                <a:solidFill>
+                  <a:srgbClr val="000000"/>
+                </a:solidFill>
+                <a:latin typeface="NVIDIA Sans" pitchFamily="34" charset="0"/>
+                <a:ea typeface="NVIDIA Sans" pitchFamily="34" charset="-122"/>
+                <a:cs typeface="NVIDIA Sans" pitchFamily="34" charset="-120"/>
+              </a:rPr>
+              <a:t>Batching amortizes launch and comm costs: MFU climbs 23% → 30.5%</a:t>
+            </a:r>
+            <a:endParaRPr lang="en-US" sz="1150" dirty="0"/>
+          </a:p>
+          <a:p>
+            <a:pPr marL="342900" indent="-342900">
+              <a:buSzPct val="100000"/>
+              <a:buChar char="•"/>
+            </a:pPr>
+            <a:r>
+              <a:rPr lang="en-US" sz="1150" dirty="0">
+                <a:solidFill>
+                  <a:srgbClr val="000000"/>
+                </a:solidFill>
+                <a:latin typeface="NVIDIA Sans" pitchFamily="34" charset="0"/>
+                <a:ea typeface="NVIDIA Sans" pitchFamily="34" charset="-122"/>
+                <a:cs typeface="NVIDIA Sans" pitchFamily="34" charset="-120"/>
+              </a:rPr>
+              <a:t>bs 32 regresses hard (986 ms/step): not OOM, not the dataloader — memory-pressure effects under investigation</a:t>
+            </a:r>
+            <a:endParaRPr lang="en-US" sz="1150" dirty="0"/>
+          </a:p>
+          <a:p>
+            <a:pPr marL="342900" indent="-342900">
+              <a:buSzPct val="100000"/>
+              <a:buChar char="•"/>
+            </a:pPr>
+            <a:r>
+              <a:rPr lang="en-US" sz="1150" dirty="0">
+                <a:solidFill>
+                  <a:srgbClr val="000000"/>
+                </a:solidFill>
+                <a:latin typeface="NVIDIA Sans" pitchFamily="34" charset="0"/>
+                <a:ea typeface="NVIDIA Sans" pitchFamily="34" charset="-122"/>
+                <a:cs typeface="NVIDIA Sans" pitchFamily="34" charset="-120"/>
+              </a:rPr>
+              <a:t>Larger global batch (192) changes optimization dynamics — needs a convergence run before adoption</a:t>
+            </a:r>
+            <a:endParaRPr lang="en-US" sz="1150" dirty="0"/>
+          </a:p>
+        </p:txBody>
+      </p:sp>
+      <p:sp>
+        <p:nvSpPr>
+          <p:cNvPr id="34" name="Text 32"/>
+          <p:cNvSpPr/>
+          <p:nvPr/>
+        </p:nvSpPr>
+        <p:spPr>
+          <a:xfrm>
+            <a:off x="457200" y="4617720"/>
+            <a:ext cx="4572000" cy="320040"/>
+          </a:xfrm>
+          <a:prstGeom prst="rect">
+            <a:avLst/>
+          </a:prstGeom>
+          <a:noFill/>
+          <a:ln/>
+        </p:spPr>
+        <p:txBody>
+          <a:bodyPr wrap="square" lIns="0" tIns="0" rIns="0" bIns="0" rtlCol="0" anchor="ctr"/>
+          <a:lstStyle/>
+          <a:p>
+            <a:pPr algn="l" indent="0" marL="0">
+              <a:buNone/>
+            </a:pPr>
+            <a:r>
+              <a:rPr lang="en-US" sz="1000" dirty="0">
+                <a:solidFill>
+                  <a:srgbClr val="5E5E5E"/>
+                </a:solidFill>
+                <a:latin typeface="NVIDIA Sans" pitchFamily="34" charset="0"/>
+                <a:ea typeface="NVIDIA Sans" pitchFamily="34" charset="-122"/>
+                <a:cs typeface="NVIDIA Sans" pitchFamily="34" charset="-120"/>
+              </a:rPr>
+              <a:t>QwenPI Training Optimization</a:t>
+            </a:r>
+            <a:endParaRPr lang="en-US" sz="1000" dirty="0"/>
+          </a:p>
+        </p:txBody>
+      </p:sp>
+      <p:sp>
+        <p:nvSpPr>
+          <p:cNvPr id="35" name="Text 33"/>
+          <p:cNvSpPr/>
+          <p:nvPr/>
+        </p:nvSpPr>
+        <p:spPr>
+          <a:xfrm>
+            <a:off x="7360920" y="4617720"/>
+            <a:ext cx="320040" cy="320040"/>
+          </a:xfrm>
+          <a:prstGeom prst="rect">
+            <a:avLst/>
+          </a:prstGeom>
+          <a:noFill/>
+          <a:ln/>
+        </p:spPr>
+        <p:txBody>
+          <a:bodyPr wrap="square" lIns="0" tIns="0" rIns="0" bIns="0" rtlCol="0" anchor="ctr"/>
+          <a:lstStyle/>
+          <a:p>
+            <a:pPr algn="r" indent="0" marL="0">
+              <a:buNone/>
+            </a:pPr>
+            <a:r>
+              <a:rPr lang="en-US" sz="1000" dirty="0">
+                <a:solidFill>
+                  <a:srgbClr val="5E5E5E"/>
+                </a:solidFill>
+                <a:latin typeface="NVIDIA Sans" pitchFamily="34" charset="0"/>
+                <a:ea typeface="NVIDIA Sans" pitchFamily="34" charset="-122"/>
+                <a:cs typeface="NVIDIA Sans" pitchFamily="34" charset="-120"/>
+              </a:rPr>
+              <a:t>11</a:t>
+            </a:r>
+            <a:endParaRPr lang="en-US" sz="1000" dirty="0"/>
+          </a:p>
+        </p:txBody>
+      </p:sp>
+      <p:sp>
+        <p:nvSpPr>
+          <p:cNvPr id="36" name="Shape 34"/>
+          <p:cNvSpPr/>
+          <p:nvPr/>
+        </p:nvSpPr>
+        <p:spPr>
+          <a:xfrm>
+            <a:off x="7726680" y="4617720"/>
+            <a:ext cx="36576" cy="320040"/>
+          </a:xfrm>
+          <a:prstGeom prst="rect">
+            <a:avLst/>
+          </a:prstGeom>
+          <a:solidFill>
+            <a:srgbClr val="76B900"/>
+          </a:solidFill>
+          <a:ln/>
+        </p:spPr>
+      </p:sp>
+      <p:pic>
+        <p:nvPicPr>
+          <p:cNvPr id="37" name="Image 0" descr="/app/logos/nvidia-logo-blk-sm.png">    </p:cNvPr>
+          <p:cNvPicPr>
+            <a:picLocks noChangeAspect="1"/>
+          </p:cNvPicPr>
+          <p:nvPr/>
+        </p:nvPicPr>
+        <p:blipFill>
+          <a:blip r:embed="rId1"/>
+          <a:stretch>
+            <a:fillRect/>
+          </a:stretch>
+        </p:blipFill>
+        <p:spPr>
+          <a:xfrm>
+            <a:off x="7863840" y="4604004"/>
+            <a:ext cx="1005840" cy="347472"/>
+          </a:xfrm>
+          <a:prstGeom prst="rect">
+            <a:avLst/>
+          </a:prstGeom>
+        </p:spPr>
+      </p:pic>
+    </p:spTree>
+  </p:cSld>
+  <p:clrMapOvr>
+    <a:masterClrMapping/>
+  </p:clrMapOvr>
+</p:sld>
+</file>
+
+<file path=ppt/slides/slide12.xml><?xml version="1.0" encoding="utf-8"?>
+<p:sld xmlns:a="http://schemas.openxmlformats.org/drawingml/2006/main" xmlns:r="http://schemas.openxmlformats.org/officeDocument/2006/relationships" xmlns:p="http://schemas.openxmlformats.org/presentationml/2006/main">
+  <p:cSld name="Slide 12">
+    <p:bg>
+      <p:bgPr>
+        <a:solidFill>
+          <a:srgbClr val="FFFFFF"/>
+        </a:solidFill>
+      </p:bgPr>
+    </p:bg>
+    <p:spTree>
+      <p:nvGrpSpPr>
+        <p:cNvPr id="1" name=""/>
+        <p:cNvGrpSpPr/>
+        <p:nvPr/>
+      </p:nvGrpSpPr>
+      <p:grpSpPr>
+        <a:xfrm>
+          <a:off x="0" y="0"/>
+          <a:ext cx="0" cy="0"/>
+          <a:chOff x="0" y="0"/>
+          <a:chExt cx="0" cy="0"/>
+        </a:xfrm>
+      </p:grpSpPr>
+      <p:sp>
+        <p:nvSpPr>
+          <p:cNvPr id="2" name="Text 0"/>
+          <p:cNvSpPr/>
+          <p:nvPr/>
+        </p:nvSpPr>
+        <p:spPr>
+          <a:xfrm>
+            <a:off x="457200" y="256032"/>
+            <a:ext cx="8229600" cy="548640"/>
+          </a:xfrm>
+          <a:prstGeom prst="rect">
+            <a:avLst/>
+          </a:prstGeom>
+          <a:noFill/>
+          <a:ln/>
+        </p:spPr>
+        <p:txBody>
+          <a:bodyPr wrap="square" lIns="0" tIns="0" rIns="0" bIns="0" rtlCol="0" anchor="ctr"/>
+          <a:lstStyle/>
+          <a:p>
+            <a:pPr indent="0" marL="0">
+              <a:buNone/>
+            </a:pPr>
+            <a:r>
+              <a:rPr lang="en-US" sz="3000" b="1" dirty="0">
+                <a:solidFill>
+                  <a:srgbClr val="000000"/>
+                </a:solidFill>
+                <a:latin typeface="NVIDIA Sans" pitchFamily="34" charset="0"/>
+                <a:ea typeface="NVIDIA Sans" pitchFamily="34" charset="-122"/>
+                <a:cs typeface="NVIDIA Sans" pitchFamily="34" charset="-120"/>
+              </a:rPr>
               <a:t>What We Ruled Out — and How</a:t>
             </a:r>
             <a:endParaRPr lang="en-US" sz="3000" dirty="0"/>
@@ -6138,7 +7184,7 @@
       </p:sp>
       <p:graphicFrame>
         <p:nvGraphicFramePr>
-          <p:cNvPr id="12" name="Table 0"/>
+          <p:cNvPr id="13" name="Table 0"/>
           <p:cNvGraphicFramePr>
             <a:graphicFrameLocks noGrp="1"/>
           </p:cNvGraphicFramePr>
@@ -7627,7 +8673,7 @@
                 <a:ea typeface="NVIDIA Sans" pitchFamily="34" charset="-122"/>
                 <a:cs typeface="NVIDIA Sans" pitchFamily="34" charset="-120"/>
               </a:rPr>
-              <a:t>11</a:t>
+              <a:t>12</a:t>
             </a:r>
             <a:endParaRPr lang="en-US" sz="1000" dirty="0"/>
           </a:p>
@@ -7685,9 +8731,9 @@
 </p:sld>
 </file>
 
-<file path=ppt/slides/slide12.xml><?xml version="1.0" encoding="utf-8"?>
+<file path=ppt/slides/slide13.xml><?xml version="1.0" encoding="utf-8"?>
 <p:sld xmlns:a="http://schemas.openxmlformats.org/drawingml/2006/main" xmlns:r="http://schemas.openxmlformats.org/officeDocument/2006/relationships" xmlns:p="http://schemas.openxmlformats.org/presentationml/2006/main">
-  <p:cSld name="Slide 12">
+  <p:cSld name="Slide 13">
     <p:bg>
       <p:bgPr>
         <a:solidFill>
@@ -8511,7 +9557,7 @@
                 <a:ea typeface="NVIDIA Sans" pitchFamily="34" charset="-122"/>
                 <a:cs typeface="NVIDIA Sans" pitchFamily="34" charset="-120"/>
               </a:rPr>
-              <a:t>12</a:t>
+              <a:t>13</a:t>
             </a:r>
             <a:endParaRPr lang="en-US" sz="1000" dirty="0"/>
           </a:p>
@@ -21885,7 +22931,7 @@
                 <a:ea typeface="NVIDIA Sans" pitchFamily="34" charset="-122"/>
                 <a:cs typeface="NVIDIA Sans" pitchFamily="34" charset="-120"/>
               </a:rPr>
-              <a:t>CUDA Graphs &amp; torch.compile: −126 ms</a:t>
+              <a:t>Why CUDA Graphs: Launch-Bound Forward</a:t>
             </a:r>
             <a:endParaRPr lang="en-US" sz="3000" dirty="0"/>
           </a:p>
@@ -21924,46 +22970,22 @@
                 <a:ea typeface="NVIDIA Sans" pitchFamily="34" charset="-122"/>
                 <a:cs typeface="NVIDIA Sans" pitchFamily="34" charset="-120"/>
               </a:rPr>
-              <a:t>398 → 271 ms.  Replay the whole network as six graphs instead of ~14k eager launches</a:t>
+              <a:t>Anatomy of the Qwen3.5 forward — same math, very different wall clock</a:t>
             </a:r>
             <a:endParaRPr lang="en-US" sz="1500" dirty="0"/>
           </a:p>
         </p:txBody>
       </p:sp>
-      <p:pic>
-        <p:nvPicPr>
-          <p:cNvPr id="4" name="Image 0" descr="/work/tikz-graphs.png">    </p:cNvPr>
-          <p:cNvPicPr>
-            <a:picLocks noChangeAspect="1"/>
-          </p:cNvPicPr>
-          <p:nvPr/>
-        </p:nvPicPr>
-        <p:blipFill>
-          <a:blip r:embed="rId1"/>
-          <a:stretch>
-            <a:fillRect/>
-          </a:stretch>
-        </p:blipFill>
-        <p:spPr>
-          <a:xfrm>
-            <a:off x="457200" y="1371600"/>
-            <a:ext cx="3291962" cy="2834640"/>
-          </a:xfrm>
-          <a:prstGeom prst="rect">
-            <a:avLst/>
-          </a:prstGeom>
-        </p:spPr>
-      </p:pic>
-      <p:sp>
-        <p:nvSpPr>
-          <p:cNvPr id="5" name="Text 2"/>
-          <p:cNvSpPr/>
-          <p:nvPr/>
-        </p:nvSpPr>
-        <p:spPr>
-          <a:xfrm>
-            <a:off x="4206362" y="1417320"/>
-            <a:ext cx="4480438" cy="2194560"/>
+      <p:sp>
+        <p:nvSpPr>
+          <p:cNvPr id="4" name="Text 2"/>
+          <p:cNvSpPr/>
+          <p:nvPr/>
+        </p:nvSpPr>
+        <p:spPr>
+          <a:xfrm>
+            <a:off x="457200" y="1399032"/>
+            <a:ext cx="1417320" cy="384048"/>
           </a:xfrm>
           <a:prstGeom prst="rect">
             <a:avLst/>
@@ -21972,15 +22994,14 @@
           <a:ln/>
         </p:spPr>
         <p:txBody>
-          <a:bodyPr wrap="square" lIns="0" tIns="0" rIns="0" bIns="0" rtlCol="0" anchor="t"/>
+          <a:bodyPr wrap="square" lIns="0" tIns="0" rIns="0" bIns="0" rtlCol="0" anchor="ctr"/>
           <a:lstStyle/>
           <a:p>
-            <a:pPr marL="342900" indent="-342900">
-              <a:buSzPct val="100000"/>
-              <a:buChar char="•"/>
+            <a:pPr indent="0" marL="0">
+              <a:buNone/>
             </a:pPr>
             <a:r>
-              <a:rPr lang="en-US" sz="1200" b="1" dirty="0">
+              <a:rPr lang="en-US" sz="1100" b="1" dirty="0">
                 <a:solidFill>
                   <a:srgbClr val="000000"/>
                 </a:solidFill>
@@ -21988,17 +23009,16 @@
                 <a:ea typeface="NVIDIA Sans" pitchFamily="34" charset="-122"/>
                 <a:cs typeface="NVIDIA Sans" pitchFamily="34" charset="-120"/>
               </a:rPr>
-              <a:t>Whole-model compile is blocked: the hybrid GDN layers (fla library) graph-break in dynamo</a:t>
+              <a:t>Baseline</a:t>
             </a:r>
-            <a:endParaRPr lang="en-US" sz="1200" dirty="0"/>
-          </a:p>
-          <a:p>
-            <a:pPr marL="342900" indent="-342900">
-              <a:buSzPct val="100000"/>
-              <a:buChar char="•"/>
+            <a:endParaRPr lang="en-US" sz="1100" dirty="0"/>
+          </a:p>
+          <a:p>
+            <a:pPr indent="0" marL="0">
+              <a:buNone/>
             </a:pPr>
             <a:r>
-              <a:rPr lang="en-US" sz="1200" dirty="0">
+              <a:rPr lang="en-US" sz="1100" b="1" dirty="0">
                 <a:solidFill>
                   <a:srgbClr val="000000"/>
                 </a:solidFill>
@@ -22006,116 +23026,140 @@
                 <a:ea typeface="NVIDIA Sans" pitchFamily="34" charset="-122"/>
                 <a:cs typeface="NVIDIA Sans" pitchFamily="34" charset="-120"/>
               </a:rPr>
-              <a:t>So we capture around it: 32 text layers grouped into 4 CUDA Graphs of 8 layers each</a:t>
+              <a:t>(eager)</a:t>
             </a:r>
-            <a:endParaRPr lang="en-US" sz="1200" dirty="0"/>
-          </a:p>
-          <a:p>
-            <a:pPr marL="342900" indent="-342900">
-              <a:buSzPct val="100000"/>
-              <a:buChar char="•"/>
+            <a:endParaRPr lang="en-US" sz="1100" dirty="0"/>
+          </a:p>
+        </p:txBody>
+      </p:sp>
+      <p:sp>
+        <p:nvSpPr>
+          <p:cNvPr id="5" name="Shape 3"/>
+          <p:cNvSpPr/>
+          <p:nvPr/>
+        </p:nvSpPr>
+        <p:spPr>
+          <a:xfrm>
+            <a:off x="1920240" y="1417320"/>
+            <a:ext cx="2131541" cy="384048"/>
+          </a:xfrm>
+          <a:prstGeom prst="rect">
+            <a:avLst/>
+          </a:prstGeom>
+          <a:solidFill>
+            <a:srgbClr val="76B900"/>
+          </a:solidFill>
+          <a:ln/>
+        </p:spPr>
+      </p:sp>
+      <p:sp>
+        <p:nvSpPr>
+          <p:cNvPr id="6" name="Text 4"/>
+          <p:cNvSpPr/>
+          <p:nvPr/>
+        </p:nvSpPr>
+        <p:spPr>
+          <a:xfrm>
+            <a:off x="1920240" y="1417320"/>
+            <a:ext cx="2131541" cy="384048"/>
+          </a:xfrm>
+          <a:prstGeom prst="rect">
+            <a:avLst/>
+          </a:prstGeom>
+          <a:noFill/>
+          <a:ln/>
+        </p:spPr>
+        <p:txBody>
+          <a:bodyPr wrap="square" lIns="0" tIns="0" rIns="0" bIns="0" rtlCol="0" anchor="ctr"/>
+          <a:lstStyle/>
+          <a:p>
+            <a:pPr algn="ctr" indent="0" marL="0">
+              <a:buNone/>
             </a:pPr>
             <a:r>
-              <a:rPr lang="en-US" sz="1200" dirty="0">
+              <a:rPr lang="en-US" sz="1000" b="1" dirty="0">
                 <a:solidFill>
-                  <a:srgbClr val="000000"/>
+                  <a:srgbClr val="FFFFFF"/>
                 </a:solidFill>
                 <a:latin typeface="NVIDIA Sans" pitchFamily="34" charset="0"/>
                 <a:ea typeface="NVIDIA Sans" pitchFamily="34" charset="-122"/>
                 <a:cs typeface="NVIDIA Sans" pitchFamily="34" charset="-120"/>
               </a:rPr>
-              <a:t>Vision tower captured as a single graph (FA2 kernels inside, host-cached max_seqlen)</a:t>
+              <a:t>GPU busy 50 ms</a:t>
             </a:r>
-            <a:endParaRPr lang="en-US" sz="1200" dirty="0"/>
-          </a:p>
-          <a:p>
-            <a:pPr marL="342900" indent="-342900">
-              <a:buSzPct val="100000"/>
-              <a:buChar char="•"/>
+            <a:endParaRPr lang="en-US" sz="1000" dirty="0"/>
+          </a:p>
+        </p:txBody>
+      </p:sp>
+      <p:sp>
+        <p:nvSpPr>
+          <p:cNvPr id="7" name="Shape 5"/>
+          <p:cNvSpPr/>
+          <p:nvPr/>
+        </p:nvSpPr>
+        <p:spPr>
+          <a:xfrm>
+            <a:off x="4051781" y="1417320"/>
+            <a:ext cx="4177819" cy="384048"/>
+          </a:xfrm>
+          <a:prstGeom prst="rect">
+            <a:avLst/>
+          </a:prstGeom>
+          <a:solidFill>
+            <a:srgbClr val="890C58"/>
+          </a:solidFill>
+          <a:ln/>
+        </p:spPr>
+      </p:sp>
+      <p:sp>
+        <p:nvSpPr>
+          <p:cNvPr id="8" name="Text 6"/>
+          <p:cNvSpPr/>
+          <p:nvPr/>
+        </p:nvSpPr>
+        <p:spPr>
+          <a:xfrm>
+            <a:off x="4051781" y="1417320"/>
+            <a:ext cx="4177819" cy="384048"/>
+          </a:xfrm>
+          <a:prstGeom prst="rect">
+            <a:avLst/>
+          </a:prstGeom>
+          <a:noFill/>
+          <a:ln/>
+        </p:spPr>
+        <p:txBody>
+          <a:bodyPr wrap="square" lIns="0" tIns="0" rIns="0" bIns="0" rtlCol="0" anchor="ctr"/>
+          <a:lstStyle/>
+          <a:p>
+            <a:pPr algn="ctr" indent="0" marL="0">
+              <a:buNone/>
             </a:pPr>
             <a:r>
-              <a:rPr lang="en-US" sz="1200" dirty="0">
+              <a:rPr lang="en-US" sz="1000" b="1" dirty="0">
                 <a:solidFill>
-                  <a:srgbClr val="000000"/>
+                  <a:srgbClr val="FFFFFF"/>
                 </a:solidFill>
                 <a:latin typeface="NVIDIA Sans" pitchFamily="34" charset="0"/>
                 <a:ea typeface="NVIDIA Sans" pitchFamily="34" charset="-122"/>
                 <a:cs typeface="NVIDIA Sans" pitchFamily="34" charset="-120"/>
               </a:rPr>
-              <a:t>Static shapes make it possible: text fixed at 192, encoder padded to 192</a:t>
+              <a:t>waiting for launches 98 ms</a:t>
             </a:r>
-            <a:endParaRPr lang="en-US" sz="1200" dirty="0"/>
-          </a:p>
-          <a:p>
-            <a:pPr marL="342900" indent="-342900">
-              <a:buSzPct val="100000"/>
-              <a:buChar char="•"/>
-            </a:pPr>
-            <a:r>
-              <a:rPr lang="en-US" sz="1200" dirty="0">
-                <a:solidFill>
-                  <a:srgbClr val="000000"/>
-                </a:solidFill>
-                <a:latin typeface="NVIDIA Sans" pitchFamily="34" charset="0"/>
-                <a:ea typeface="NVIDIA Sans" pitchFamily="34" charset="-122"/>
-                <a:cs typeface="NVIDIA Sans" pitchFamily="34" charset="-120"/>
-              </a:rPr>
-              <a:t>Sync-free multimodal merge: removed a device-to-host validation readback in the image-token scatter</a:t>
-            </a:r>
-            <a:endParaRPr lang="en-US" sz="1200" dirty="0"/>
+            <a:endParaRPr lang="en-US" sz="1000" dirty="0"/>
           </a:p>
         </p:txBody>
       </p:sp>
       <p:sp>
         <p:nvSpPr>
-          <p:cNvPr id="6" name="Shape 3"/>
-          <p:cNvSpPr/>
-          <p:nvPr/>
-        </p:nvSpPr>
-        <p:spPr>
-          <a:xfrm>
-            <a:off x="4206362" y="3657600"/>
-            <a:ext cx="4480438" cy="658368"/>
-          </a:xfrm>
-          <a:prstGeom prst="rect">
-            <a:avLst/>
-          </a:prstGeom>
-          <a:solidFill>
-            <a:srgbClr val="F5F5F5"/>
-          </a:solidFill>
-          <a:ln/>
-        </p:spPr>
-      </p:sp>
-      <p:sp>
-        <p:nvSpPr>
-          <p:cNvPr id="7" name="Shape 4"/>
-          <p:cNvSpPr/>
-          <p:nvPr/>
-        </p:nvSpPr>
-        <p:spPr>
-          <a:xfrm>
-            <a:off x="4206362" y="3657600"/>
-            <a:ext cx="54864" cy="658368"/>
-          </a:xfrm>
-          <a:prstGeom prst="rect">
-            <a:avLst/>
-          </a:prstGeom>
-          <a:solidFill>
-            <a:srgbClr val="76B900"/>
-          </a:solidFill>
-          <a:ln/>
-        </p:spPr>
-      </p:sp>
-      <p:sp>
-        <p:nvSpPr>
-          <p:cNvPr id="8" name="Text 5"/>
-          <p:cNvSpPr/>
-          <p:nvPr/>
-        </p:nvSpPr>
-        <p:spPr>
-          <a:xfrm>
-            <a:off x="4389242" y="3657600"/>
-            <a:ext cx="4206118" cy="658368"/>
+          <p:cNvPr id="9" name="Text 7"/>
+          <p:cNvSpPr/>
+          <p:nvPr/>
+        </p:nvSpPr>
+        <p:spPr>
+          <a:xfrm>
+            <a:off x="8302752" y="1417320"/>
+            <a:ext cx="822960" cy="384048"/>
           </a:xfrm>
           <a:prstGeom prst="rect">
             <a:avLst/>
@@ -22139,13 +23183,38 @@
                 <a:ea typeface="NVIDIA Sans" pitchFamily="34" charset="-122"/>
                 <a:cs typeface="NVIDIA Sans" pitchFamily="34" charset="-120"/>
               </a:rPr>
-              <a:t>Kernel launches: 13.9k → 6.4k per step. </a:t>
+              <a:t>148 ms</a:t>
             </a:r>
+            <a:endParaRPr lang="en-US" sz="1200" dirty="0"/>
+          </a:p>
+        </p:txBody>
+      </p:sp>
+      <p:sp>
+        <p:nvSpPr>
+          <p:cNvPr id="10" name="Text 8"/>
+          <p:cNvSpPr/>
+          <p:nvPr/>
+        </p:nvSpPr>
+        <p:spPr>
+          <a:xfrm>
+            <a:off x="1920240" y="1819656"/>
+            <a:ext cx="6400800" cy="201168"/>
+          </a:xfrm>
+          <a:prstGeom prst="rect">
+            <a:avLst/>
+          </a:prstGeom>
+          <a:noFill/>
+          <a:ln/>
+        </p:spPr>
+        <p:txBody>
+          <a:bodyPr wrap="square" lIns="0" tIns="0" rIns="0" bIns="0" rtlCol="0" anchor="ctr"/>
+          <a:lstStyle/>
+          <a:p>
             <a:pPr indent="0" marL="0">
               <a:buNone/>
             </a:pPr>
             <a:r>
-              <a:rPr lang="en-US" sz="1200" dirty="0">
+              <a:rPr lang="en-US" sz="950" i="1" dirty="0">
                 <a:solidFill>
                   <a:srgbClr val="5E5E5E"/>
                 </a:solidFill>
@@ -22153,7 +23222,220 @@
                 <a:ea typeface="NVIDIA Sans" pitchFamily="34" charset="-122"/>
                 <a:cs typeface="NVIDIA Sans" pitchFamily="34" charset="-120"/>
               </a:rPr>
-              <a:t>CPU launch cost leaves the critical path; GPU idle collapses.</a:t>
+              <a:t>3,929 kernel launches · 19.1 ms of cudaLaunchKernel CPU time · occupancy 34%</a:t>
+            </a:r>
+            <a:endParaRPr lang="en-US" sz="950" dirty="0"/>
+          </a:p>
+        </p:txBody>
+      </p:sp>
+      <p:sp>
+        <p:nvSpPr>
+          <p:cNvPr id="11" name="Text 9"/>
+          <p:cNvSpPr/>
+          <p:nvPr/>
+        </p:nvSpPr>
+        <p:spPr>
+          <a:xfrm>
+            <a:off x="457200" y="2267712"/>
+            <a:ext cx="1417320" cy="384048"/>
+          </a:xfrm>
+          <a:prstGeom prst="rect">
+            <a:avLst/>
+          </a:prstGeom>
+          <a:noFill/>
+          <a:ln/>
+        </p:spPr>
+        <p:txBody>
+          <a:bodyPr wrap="square" lIns="0" tIns="0" rIns="0" bIns="0" rtlCol="0" anchor="ctr"/>
+          <a:lstStyle/>
+          <a:p>
+            <a:pPr indent="0" marL="0">
+              <a:buNone/>
+            </a:pPr>
+            <a:r>
+              <a:rPr lang="en-US" sz="1100" b="1" dirty="0">
+                <a:solidFill>
+                  <a:srgbClr val="000000"/>
+                </a:solidFill>
+                <a:latin typeface="NVIDIA Sans" pitchFamily="34" charset="0"/>
+                <a:ea typeface="NVIDIA Sans" pitchFamily="34" charset="-122"/>
+                <a:cs typeface="NVIDIA Sans" pitchFamily="34" charset="-120"/>
+              </a:rPr>
+              <a:t>Optimized</a:t>
+            </a:r>
+            <a:endParaRPr lang="en-US" sz="1100" dirty="0"/>
+          </a:p>
+          <a:p>
+            <a:pPr indent="0" marL="0">
+              <a:buNone/>
+            </a:pPr>
+            <a:r>
+              <a:rPr lang="en-US" sz="1100" b="1" dirty="0">
+                <a:solidFill>
+                  <a:srgbClr val="000000"/>
+                </a:solidFill>
+                <a:latin typeface="NVIDIA Sans" pitchFamily="34" charset="0"/>
+                <a:ea typeface="NVIDIA Sans" pitchFamily="34" charset="-122"/>
+                <a:cs typeface="NVIDIA Sans" pitchFamily="34" charset="-120"/>
+              </a:rPr>
+              <a:t>(CUDA Graphs)</a:t>
+            </a:r>
+            <a:endParaRPr lang="en-US" sz="1100" dirty="0"/>
+          </a:p>
+        </p:txBody>
+      </p:sp>
+      <p:sp>
+        <p:nvSpPr>
+          <p:cNvPr id="12" name="Shape 10"/>
+          <p:cNvSpPr/>
+          <p:nvPr/>
+        </p:nvSpPr>
+        <p:spPr>
+          <a:xfrm>
+            <a:off x="1920240" y="2286000"/>
+            <a:ext cx="1577340" cy="384048"/>
+          </a:xfrm>
+          <a:prstGeom prst="rect">
+            <a:avLst/>
+          </a:prstGeom>
+          <a:solidFill>
+            <a:srgbClr val="76B900"/>
+          </a:solidFill>
+          <a:ln/>
+        </p:spPr>
+      </p:sp>
+      <p:sp>
+        <p:nvSpPr>
+          <p:cNvPr id="13" name="Text 11"/>
+          <p:cNvSpPr/>
+          <p:nvPr/>
+        </p:nvSpPr>
+        <p:spPr>
+          <a:xfrm>
+            <a:off x="1920240" y="2286000"/>
+            <a:ext cx="1577340" cy="384048"/>
+          </a:xfrm>
+          <a:prstGeom prst="rect">
+            <a:avLst/>
+          </a:prstGeom>
+          <a:noFill/>
+          <a:ln/>
+        </p:spPr>
+        <p:txBody>
+          <a:bodyPr wrap="square" lIns="0" tIns="0" rIns="0" bIns="0" rtlCol="0" anchor="ctr"/>
+          <a:lstStyle/>
+          <a:p>
+            <a:pPr algn="ctr" indent="0" marL="0">
+              <a:buNone/>
+            </a:pPr>
+            <a:r>
+              <a:rPr lang="en-US" sz="1000" b="1" dirty="0">
+                <a:solidFill>
+                  <a:srgbClr val="FFFFFF"/>
+                </a:solidFill>
+                <a:latin typeface="NVIDIA Sans" pitchFamily="34" charset="0"/>
+                <a:ea typeface="NVIDIA Sans" pitchFamily="34" charset="-122"/>
+                <a:cs typeface="NVIDIA Sans" pitchFamily="34" charset="-120"/>
+              </a:rPr>
+              <a:t>GPU busy 37 ms</a:t>
+            </a:r>
+            <a:endParaRPr lang="en-US" sz="1000" dirty="0"/>
+          </a:p>
+        </p:txBody>
+      </p:sp>
+      <p:sp>
+        <p:nvSpPr>
+          <p:cNvPr id="14" name="Shape 12"/>
+          <p:cNvSpPr/>
+          <p:nvPr/>
+        </p:nvSpPr>
+        <p:spPr>
+          <a:xfrm>
+            <a:off x="3497580" y="2286000"/>
+            <a:ext cx="1193663" cy="384048"/>
+          </a:xfrm>
+          <a:prstGeom prst="rect">
+            <a:avLst/>
+          </a:prstGeom>
+          <a:solidFill>
+            <a:srgbClr val="890C58"/>
+          </a:solidFill>
+          <a:ln/>
+        </p:spPr>
+      </p:sp>
+      <p:sp>
+        <p:nvSpPr>
+          <p:cNvPr id="15" name="Text 13"/>
+          <p:cNvSpPr/>
+          <p:nvPr/>
+        </p:nvSpPr>
+        <p:spPr>
+          <a:xfrm>
+            <a:off x="3497580" y="2286000"/>
+            <a:ext cx="1193663" cy="384048"/>
+          </a:xfrm>
+          <a:prstGeom prst="rect">
+            <a:avLst/>
+          </a:prstGeom>
+          <a:noFill/>
+          <a:ln/>
+        </p:spPr>
+        <p:txBody>
+          <a:bodyPr wrap="square" lIns="0" tIns="0" rIns="0" bIns="0" rtlCol="0" anchor="ctr"/>
+          <a:lstStyle/>
+          <a:p>
+            <a:pPr algn="ctr" indent="0" marL="0">
+              <a:buNone/>
+            </a:pPr>
+            <a:r>
+              <a:rPr lang="en-US" sz="1000" b="1" dirty="0">
+                <a:solidFill>
+                  <a:srgbClr val="FFFFFF"/>
+                </a:solidFill>
+                <a:latin typeface="NVIDIA Sans" pitchFamily="34" charset="0"/>
+                <a:ea typeface="NVIDIA Sans" pitchFamily="34" charset="-122"/>
+                <a:cs typeface="NVIDIA Sans" pitchFamily="34" charset="-120"/>
+              </a:rPr>
+              <a:t>waiting for launches 28 ms</a:t>
+            </a:r>
+            <a:endParaRPr lang="en-US" sz="1000" dirty="0"/>
+          </a:p>
+        </p:txBody>
+      </p:sp>
+      <p:sp>
+        <p:nvSpPr>
+          <p:cNvPr id="16" name="Text 14"/>
+          <p:cNvSpPr/>
+          <p:nvPr/>
+        </p:nvSpPr>
+        <p:spPr>
+          <a:xfrm>
+            <a:off x="4764395" y="2286000"/>
+            <a:ext cx="822960" cy="384048"/>
+          </a:xfrm>
+          <a:prstGeom prst="rect">
+            <a:avLst/>
+          </a:prstGeom>
+          <a:noFill/>
+          <a:ln/>
+        </p:spPr>
+        <p:txBody>
+          <a:bodyPr wrap="square" lIns="0" tIns="0" rIns="0" bIns="0" rtlCol="0" anchor="ctr"/>
+          <a:lstStyle/>
+          <a:p>
+            <a:pPr indent="0" marL="0">
+              <a:buNone/>
+            </a:pPr>
+            <a:r>
+              <a:rPr lang="en-US" sz="1200" b="1" dirty="0">
+                <a:solidFill>
+                  <a:srgbClr val="000000"/>
+                </a:solidFill>
+                <a:latin typeface="NVIDIA Sans" pitchFamily="34" charset="0"/>
+                <a:ea typeface="NVIDIA Sans" pitchFamily="34" charset="-122"/>
+                <a:cs typeface="NVIDIA Sans" pitchFamily="34" charset="-120"/>
+              </a:rPr>
+              <a:t>65 ms</a:t>
             </a:r>
             <a:endParaRPr lang="en-US" sz="1200" dirty="0"/>
           </a:p>
@@ -22161,7 +23443,214 @@
       </p:sp>
       <p:sp>
         <p:nvSpPr>
-          <p:cNvPr id="9" name="Text 6"/>
+          <p:cNvPr id="17" name="Text 15"/>
+          <p:cNvSpPr/>
+          <p:nvPr/>
+        </p:nvSpPr>
+        <p:spPr>
+          <a:xfrm>
+            <a:off x="1920240" y="2688336"/>
+            <a:ext cx="6400800" cy="201168"/>
+          </a:xfrm>
+          <a:prstGeom prst="rect">
+            <a:avLst/>
+          </a:prstGeom>
+          <a:noFill/>
+          <a:ln/>
+        </p:spPr>
+        <p:txBody>
+          <a:bodyPr wrap="square" lIns="0" tIns="0" rIns="0" bIns="0" rtlCol="0" anchor="ctr"/>
+          <a:lstStyle/>
+          <a:p>
+            <a:pPr indent="0" marL="0">
+              <a:buNone/>
+            </a:pPr>
+            <a:r>
+              <a:rPr lang="en-US" sz="950" i="1" dirty="0">
+                <a:solidFill>
+                  <a:srgbClr val="5E5E5E"/>
+                </a:solidFill>
+                <a:latin typeface="NVIDIA Sans" pitchFamily="34" charset="0"/>
+                <a:ea typeface="NVIDIA Sans" pitchFamily="34" charset="-122"/>
+                <a:cs typeface="NVIDIA Sans" pitchFamily="34" charset="-120"/>
+              </a:rPr>
+              <a:t>6 graph launches + 736 eager · 9.4 ms launch CPU · occupancy 57%</a:t>
+            </a:r>
+            <a:endParaRPr lang="en-US" sz="950" dirty="0"/>
+          </a:p>
+        </p:txBody>
+      </p:sp>
+      <p:sp>
+        <p:nvSpPr>
+          <p:cNvPr id="18" name="Text 16"/>
+          <p:cNvSpPr/>
+          <p:nvPr/>
+        </p:nvSpPr>
+        <p:spPr>
+          <a:xfrm>
+            <a:off x="1920240" y="2907792"/>
+            <a:ext cx="6400800" cy="365760"/>
+          </a:xfrm>
+          <a:prstGeom prst="rect">
+            <a:avLst/>
+          </a:prstGeom>
+          <a:noFill/>
+          <a:ln/>
+        </p:spPr>
+        <p:txBody>
+          <a:bodyPr wrap="square" lIns="0" tIns="0" rIns="0" bIns="0" rtlCol="0" anchor="ctr"/>
+          <a:lstStyle/>
+          <a:p>
+            <a:pPr indent="0" marL="0">
+              <a:buNone/>
+            </a:pPr>
+            <a:r>
+              <a:rPr lang="en-US" sz="2400" b="1" dirty="0">
+                <a:solidFill>
+                  <a:srgbClr val="76B900"/>
+                </a:solidFill>
+                <a:latin typeface="NVIDIA Sans" pitchFamily="34" charset="0"/>
+                <a:ea typeface="NVIDIA Sans" pitchFamily="34" charset="-122"/>
+                <a:cs typeface="NVIDIA Sans" pitchFamily="34" charset="-120"/>
+              </a:rPr>
+              <a:t>2.3× </a:t>
+            </a:r>
+            <a:pPr indent="0" marL="0">
+              <a:buNone/>
+            </a:pPr>
+            <a:r>
+              <a:rPr lang="en-US" sz="1300" b="1" dirty="0">
+                <a:solidFill>
+                  <a:srgbClr val="000000"/>
+                </a:solidFill>
+                <a:latin typeface="NVIDIA Sans" pitchFamily="34" charset="0"/>
+                <a:ea typeface="NVIDIA Sans" pitchFamily="34" charset="-122"/>
+                <a:cs typeface="NVIDIA Sans" pitchFamily="34" charset="-120"/>
+              </a:rPr>
+              <a:t>faster forward wall clock — with 81% fewer launches</a:t>
+            </a:r>
+            <a:endParaRPr lang="en-US" sz="2400" dirty="0"/>
+          </a:p>
+        </p:txBody>
+      </p:sp>
+      <p:sp>
+        <p:nvSpPr>
+          <p:cNvPr id="19" name="Text 17"/>
+          <p:cNvSpPr/>
+          <p:nvPr/>
+        </p:nvSpPr>
+        <p:spPr>
+          <a:xfrm>
+            <a:off x="457200" y="3346704"/>
+            <a:ext cx="8229600" cy="822960"/>
+          </a:xfrm>
+          <a:prstGeom prst="rect">
+            <a:avLst/>
+          </a:prstGeom>
+          <a:noFill/>
+          <a:ln/>
+        </p:spPr>
+        <p:txBody>
+          <a:bodyPr wrap="square" lIns="0" tIns="0" rIns="0" bIns="0" rtlCol="0" anchor="t"/>
+          <a:lstStyle/>
+          <a:p>
+            <a:pPr marL="342900" indent="-342900">
+              <a:buSzPct val="100000"/>
+              <a:buChar char="•"/>
+            </a:pPr>
+            <a:r>
+              <a:rPr lang="en-US" sz="1100" dirty="0">
+                <a:solidFill>
+                  <a:srgbClr val="000000"/>
+                </a:solidFill>
+                <a:latin typeface="NVIDIA Sans" pitchFamily="34" charset="0"/>
+                <a:ea typeface="NVIDIA Sans" pitchFamily="34" charset="-122"/>
+                <a:cs typeface="NVIDIA Sans" pitchFamily="34" charset="-120"/>
+              </a:rPr>
+              <a:t>An eager op costs 30–60 µs of Python dispatch + launch; the median kernel runs 8 µs — the GPU finishes before the CPU can feed the next one</a:t>
+            </a:r>
+            <a:endParaRPr lang="en-US" sz="1100" dirty="0"/>
+          </a:p>
+          <a:p>
+            <a:pPr marL="342900" indent="-342900">
+              <a:buSzPct val="100000"/>
+              <a:buChar char="•"/>
+            </a:pPr>
+            <a:r>
+              <a:rPr lang="en-US" sz="1100" dirty="0">
+                <a:solidFill>
+                  <a:srgbClr val="000000"/>
+                </a:solidFill>
+                <a:latin typeface="NVIDIA Sans" pitchFamily="34" charset="0"/>
+                <a:ea typeface="NVIDIA Sans" pitchFamily="34" charset="-122"/>
+                <a:cs typeface="NVIDIA Sans" pitchFamily="34" charset="-120"/>
+              </a:rPr>
+              <a:t>Backward suffers far less (C++ autograd engine, occupancy 70%) — forward is where launch overhead bites</a:t>
+            </a:r>
+            <a:endParaRPr lang="en-US" sz="1100" dirty="0"/>
+          </a:p>
+          <a:p>
+            <a:pPr marL="342900" indent="-342900">
+              <a:buSzPct val="100000"/>
+              <a:buChar char="•"/>
+            </a:pPr>
+            <a:r>
+              <a:rPr lang="en-US" sz="1100" dirty="0">
+                <a:solidFill>
+                  <a:srgbClr val="000000"/>
+                </a:solidFill>
+                <a:latin typeface="NVIDIA Sans" pitchFamily="34" charset="0"/>
+                <a:ea typeface="NVIDIA Sans" pitchFamily="34" charset="-122"/>
+                <a:cs typeface="NVIDIA Sans" pitchFamily="34" charset="-120"/>
+              </a:rPr>
+              <a:t>A CUDA Graph replays an entire 8-layer group as ONE cudaGraphLaunch — per-op dispatch leaves the critical path</a:t>
+            </a:r>
+            <a:endParaRPr lang="en-US" sz="1100" dirty="0"/>
+          </a:p>
+        </p:txBody>
+      </p:sp>
+      <p:sp>
+        <p:nvSpPr>
+          <p:cNvPr id="20" name="Text 18"/>
+          <p:cNvSpPr/>
+          <p:nvPr/>
+        </p:nvSpPr>
+        <p:spPr>
+          <a:xfrm>
+            <a:off x="457200" y="4206240"/>
+            <a:ext cx="8229600" cy="201168"/>
+          </a:xfrm>
+          <a:prstGeom prst="rect">
+            <a:avLst/>
+          </a:prstGeom>
+          <a:noFill/>
+          <a:ln/>
+        </p:spPr>
+        <p:txBody>
+          <a:bodyPr wrap="square" lIns="0" tIns="0" rIns="0" bIns="0" rtlCol="0" anchor="ctr"/>
+          <a:lstStyle/>
+          <a:p>
+            <a:pPr indent="0" marL="0">
+              <a:buNone/>
+            </a:pPr>
+            <a:r>
+              <a:rPr lang="en-US" sz="850" i="1" dirty="0">
+                <a:solidFill>
+                  <a:srgbClr val="8C8C8C"/>
+                </a:solidFill>
+                <a:latin typeface="NVIDIA Sans" pitchFamily="34" charset="0"/>
+                <a:ea typeface="NVIDIA Sans" pitchFamily="34" charset="-122"/>
+                <a:cs typeface="NVIDIA Sans" pitchFamily="34" charset="-120"/>
+              </a:rPr>
+              <a:t>Busy also shrinks 50 → 37 ms (mixed attention + fusion); the split isolates the launch effect. Windows: baseline Qwen3.5 fwd vs merged-main VLM fwd, same launch-window accounting.</a:t>
+            </a:r>
+            <a:endParaRPr lang="en-US" sz="850" dirty="0"/>
+          </a:p>
+        </p:txBody>
+      </p:sp>
+      <p:sp>
+        <p:nvSpPr>
+          <p:cNvPr id="21" name="Text 19"/>
           <p:cNvSpPr/>
           <p:nvPr/>
         </p:nvSpPr>
@@ -22200,7 +23689,7 @@
       </p:sp>
       <p:sp>
         <p:nvSpPr>
-          <p:cNvPr id="10" name="Text 7"/>
+          <p:cNvPr id="22" name="Text 20"/>
           <p:cNvSpPr/>
           <p:nvPr/>
         </p:nvSpPr>
@@ -22239,7 +23728,7 @@
       </p:sp>
       <p:sp>
         <p:nvSpPr>
-          <p:cNvPr id="11" name="Shape 8"/>
+          <p:cNvPr id="23" name="Shape 21"/>
           <p:cNvSpPr/>
           <p:nvPr/>
         </p:nvSpPr>
@@ -22259,14 +23748,14 @@
       </p:sp>
       <p:pic>
         <p:nvPicPr>
-          <p:cNvPr id="12" name="Image 1" descr="/app/logos/nvidia-logo-blk-sm.png">    </p:cNvPr>
+          <p:cNvPr id="24" name="Image 0" descr="/app/logos/nvidia-logo-blk-sm.png">    </p:cNvPr>
           <p:cNvPicPr>
             <a:picLocks noChangeAspect="1"/>
           </p:cNvPicPr>
           <p:nvPr/>
         </p:nvPicPr>
         <p:blipFill>
-          <a:blip r:embed="rId2"/>
+          <a:blip r:embed="rId1"/>
           <a:stretch>
             <a:fillRect/>
           </a:stretch>
@@ -22346,7 +23835,7 @@
                 <a:ea typeface="NVIDIA Sans" pitchFamily="34" charset="-122"/>
                 <a:cs typeface="NVIDIA Sans" pitchFamily="34" charset="-120"/>
               </a:rPr>
-              <a:t>ZeRO-2 Comm Tuning &amp; the Final Ledger</a:t>
+              <a:t>CUDA Graphs — and Why Four, Not One</a:t>
             </a:r>
             <a:endParaRPr lang="en-US" sz="3000" dirty="0"/>
           </a:p>
@@ -22385,22 +23874,46 @@
                 <a:ea typeface="NVIDIA Sans" pitchFamily="34" charset="-122"/>
                 <a:cs typeface="NVIDIA Sans" pitchFamily="34" charset="-120"/>
               </a:rPr>
-              <a:t>271 → 249 ms.  Fewer, larger collectives — and an honest ledger of what remains</a:t>
+              <a:t>398 → 271 ms (−126).  Capture once, replay every step</a:t>
             </a:r>
             <a:endParaRPr lang="en-US" sz="1500" dirty="0"/>
           </a:p>
         </p:txBody>
       </p:sp>
-      <p:sp>
-        <p:nvSpPr>
-          <p:cNvPr id="4" name="Text 2"/>
-          <p:cNvSpPr/>
-          <p:nvPr/>
-        </p:nvSpPr>
-        <p:spPr>
-          <a:xfrm>
-            <a:off x="457200" y="1325880"/>
-            <a:ext cx="8229600" cy="1234440"/>
+      <p:pic>
+        <p:nvPicPr>
+          <p:cNvPr id="4" name="Image 0" descr="/work/tikz-graphs.png">    </p:cNvPr>
+          <p:cNvPicPr>
+            <a:picLocks noChangeAspect="1"/>
+          </p:cNvPicPr>
+          <p:nvPr/>
+        </p:nvPicPr>
+        <p:blipFill>
+          <a:blip r:embed="rId1"/>
+          <a:stretch>
+            <a:fillRect/>
+          </a:stretch>
+        </p:blipFill>
+        <p:spPr>
+          <a:xfrm>
+            <a:off x="457200" y="1371600"/>
+            <a:ext cx="3291962" cy="2834640"/>
+          </a:xfrm>
+          <a:prstGeom prst="rect">
+            <a:avLst/>
+          </a:prstGeom>
+        </p:spPr>
+      </p:pic>
+      <p:sp>
+        <p:nvSpPr>
+          <p:cNvPr id="5" name="Text 2"/>
+          <p:cNvSpPr/>
+          <p:nvPr/>
+        </p:nvSpPr>
+        <p:spPr>
+          <a:xfrm>
+            <a:off x="4206362" y="1371600"/>
+            <a:ext cx="4480438" cy="502920"/>
           </a:xfrm>
           <a:prstGeom prst="rect">
             <a:avLst/>
@@ -22417,7 +23930,46 @@
               <a:buChar char="•"/>
             </a:pPr>
             <a:r>
-              <a:rPr lang="en-US" sz="1200" dirty="0">
+              <a:rPr lang="en-US" sz="1050" dirty="0">
+                <a:solidFill>
+                  <a:srgbClr val="5E5E5E"/>
+                </a:solidFill>
+                <a:latin typeface="NVIDIA Sans" pitchFamily="34" charset="0"/>
+                <a:ea typeface="NVIDIA Sans" pitchFamily="34" charset="-122"/>
+                <a:cs typeface="NVIDIA Sans" pitchFamily="34" charset="-120"/>
+              </a:rPr>
+              <a:t>Static shapes (pad-192) make capture possible; vision tower = 1 graph, DiT = torch.compile reduce-overhead, merge stays sync-free eager</a:t>
+            </a:r>
+            <a:endParaRPr lang="en-US" sz="1050" dirty="0"/>
+          </a:p>
+        </p:txBody>
+      </p:sp>
+      <p:sp>
+        <p:nvSpPr>
+          <p:cNvPr id="6" name="Text 3"/>
+          <p:cNvSpPr/>
+          <p:nvPr/>
+        </p:nvSpPr>
+        <p:spPr>
+          <a:xfrm>
+            <a:off x="4206362" y="1874520"/>
+            <a:ext cx="4480438" cy="274320"/>
+          </a:xfrm>
+          <a:prstGeom prst="rect">
+            <a:avLst/>
+          </a:prstGeom>
+          <a:noFill/>
+          <a:ln/>
+        </p:spPr>
+        <p:txBody>
+          <a:bodyPr wrap="square" lIns="0" tIns="0" rIns="0" bIns="0" rtlCol="0" anchor="ctr"/>
+          <a:lstStyle/>
+          <a:p>
+            <a:pPr indent="0" marL="0">
+              <a:buNone/>
+            </a:pPr>
+            <a:r>
+              <a:rPr lang="en-US" sz="1400" b="1" dirty="0">
                 <a:solidFill>
                   <a:srgbClr val="000000"/>
                 </a:solidFill>
@@ -22425,17 +23977,39 @@
                 <a:ea typeface="NVIDIA Sans" pitchFamily="34" charset="-122"/>
                 <a:cs typeface="NVIDIA Sans" pitchFamily="34" charset="-120"/>
               </a:rPr>
-              <a:t>reduce_bucket_size 5e8 → 1.5e9: 6 gradient AllReduces per step instead of ~20, scoped to this model's config only</a:t>
+              <a:t>Why is the decoder FOUR graphs, not one?</a:t>
             </a:r>
-            <a:endParaRPr lang="en-US" sz="1200" dirty="0"/>
-          </a:p>
+            <a:endParaRPr lang="en-US" sz="1400" dirty="0"/>
+          </a:p>
+        </p:txBody>
+      </p:sp>
+      <p:sp>
+        <p:nvSpPr>
+          <p:cNvPr id="7" name="Text 4"/>
+          <p:cNvSpPr/>
+          <p:nvPr/>
+        </p:nvSpPr>
+        <p:spPr>
+          <a:xfrm>
+            <a:off x="4206362" y="2176272"/>
+            <a:ext cx="4480438" cy="1371600"/>
+          </a:xfrm>
+          <a:prstGeom prst="rect">
+            <a:avLst/>
+          </a:prstGeom>
+          <a:noFill/>
+          <a:ln/>
+        </p:spPr>
+        <p:txBody>
+          <a:bodyPr wrap="square" lIns="0" tIns="0" rIns="0" bIns="0" rtlCol="0" anchor="t"/>
+          <a:lstStyle/>
           <a:p>
             <a:pPr marL="342900" indent="-342900">
               <a:buSzPct val="100000"/>
               <a:buChar char="•"/>
             </a:pPr>
             <a:r>
-              <a:rPr lang="en-US" sz="1200" dirty="0">
+              <a:rPr lang="en-US" sz="1000" dirty="0">
                 <a:solidFill>
                   <a:srgbClr val="000000"/>
                 </a:solidFill>
@@ -22443,9 +24017,9 @@
                 <a:ea typeface="NVIDIA Sans" pitchFamily="34" charset="-122"/>
                 <a:cs typeface="NVIDIA Sans" pitchFamily="34" charset="-120"/>
               </a:rPr>
-              <a:t>reduce_scatter=false: drops DeepSpeed's redundant per-bucket flatten (CatArrayBatchedCopy) ahead of each AllReduce</a:t>
+              <a:t>fla/GDN layers ship @torch.compiler.disable → dynamo graph-breaks: a whole-stack compile fragments into many cudagraph partitions sharing ONE memory pool</a:t>
             </a:r>
-            <a:endParaRPr lang="en-US" sz="1200" dirty="0"/>
+            <a:endParaRPr lang="en-US" sz="1000" dirty="0"/>
           </a:p>
           <a:p>
             <a:pPr marL="342900" indent="-342900">
@@ -22453,7 +24027,7 @@
               <a:buChar char="•"/>
             </a:pPr>
             <a:r>
-              <a:rPr lang="en-US" sz="1200" dirty="0">
+              <a:rPr lang="en-US" sz="1000" dirty="0">
                 <a:solidFill>
                   <a:srgbClr val="000000"/>
                 </a:solidFill>
@@ -22461,38 +24035,17 @@
                 <a:ea typeface="NVIDIA Sans" pitchFamily="34" charset="-122"/>
                 <a:cs typeface="NVIDIA Sans" pitchFamily="34" charset="-120"/>
               </a:rPr>
-              <a:t>Verified NOT bandwidth-bound: AllReduce microbenchmark hits 478 GB/s bus bandwidth — the NVLink per-direction ceiling. The remaining exposed comm can only shrink by sending fewer bytes.</a:t>
+              <a:t>That pool's allocator checkpointing collides with ZeRO-2's gradient-hook NCCL allocations in backward — hard crash on torch 2.6 AND 2.7.1</a:t>
             </a:r>
-            <a:endParaRPr lang="en-US" sz="1200" dirty="0"/>
-          </a:p>
-        </p:txBody>
-      </p:sp>
-      <p:sp>
-        <p:nvSpPr>
-          <p:cNvPr id="5" name="Text 3"/>
-          <p:cNvSpPr/>
-          <p:nvPr/>
-        </p:nvSpPr>
-        <p:spPr>
-          <a:xfrm>
-            <a:off x="457200" y="2697480"/>
-            <a:ext cx="8229600" cy="274320"/>
-          </a:xfrm>
-          <a:prstGeom prst="rect">
-            <a:avLst/>
-          </a:prstGeom>
-          <a:noFill/>
-          <a:ln/>
-        </p:spPr>
-        <p:txBody>
-          <a:bodyPr wrap="square" lIns="0" tIns="0" rIns="0" bIns="0" rtlCol="0" anchor="ctr"/>
-          <a:lstStyle/>
-          <a:p>
-            <a:pPr indent="0" marL="0">
-              <a:buNone/>
+            <a:endParaRPr lang="en-US" sz="1000" dirty="0"/>
+          </a:p>
+          <a:p>
+            <a:pPr marL="342900" indent="-342900">
+              <a:buSzPct val="100000"/>
+              <a:buChar char="•"/>
             </a:pPr>
             <a:r>
-              <a:rPr lang="en-US" sz="1300" b="1" dirty="0">
+              <a:rPr lang="en-US" sz="1000" dirty="0">
                 <a:solidFill>
                   <a:srgbClr val="000000"/>
                 </a:solidFill>
@@ -22500,22 +24053,80 @@
                 <a:ea typeface="NVIDIA Sans" pitchFamily="34" charset="-122"/>
                 <a:cs typeface="NVIDIA Sans" pitchFamily="34" charset="-120"/>
               </a:rPr>
-              <a:t>Per-step time ledger (same accounting, one steady step from each nsys capture)</a:t>
+              <a:t>Four independent compiles = private pools, and gradient hooks fire between replays — backward AllReduce keeps overlapping compute</a:t>
             </a:r>
-            <a:endParaRPr lang="en-US" sz="1300" dirty="0"/>
+            <a:endParaRPr lang="en-US" sz="1000" dirty="0"/>
+          </a:p>
+          <a:p>
+            <a:pPr marL="342900" indent="-342900">
+              <a:buSzPct val="100000"/>
+              <a:buChar char="•"/>
+            </a:pPr>
+            <a:r>
+              <a:rPr lang="en-US" sz="1000" dirty="0">
+                <a:solidFill>
+                  <a:srgbClr val="000000"/>
+                </a:solidFill>
+                <a:latin typeface="NVIDIA Sans" pitchFamily="34" charset="0"/>
+                <a:ea typeface="NVIDIA Sans" pitchFamily="34" charset="-122"/>
+                <a:cs typeface="NVIDIA Sans" pitchFamily="34" charset="-120"/>
+              </a:rPr>
+              <a:t>Cost: 4 launches vs 1 = microseconds. Group size 8 is the measured sweet spot</a:t>
+            </a:r>
+            <a:endParaRPr lang="en-US" sz="1000" dirty="0"/>
           </a:p>
         </p:txBody>
       </p:sp>
       <p:sp>
         <p:nvSpPr>
-          <p:cNvPr id="6" name="Text 4"/>
-          <p:cNvSpPr/>
-          <p:nvPr/>
-        </p:nvSpPr>
-        <p:spPr>
-          <a:xfrm>
-            <a:off x="640080" y="3044952"/>
-            <a:ext cx="1463040" cy="310896"/>
+          <p:cNvPr id="8" name="Shape 5"/>
+          <p:cNvSpPr/>
+          <p:nvPr/>
+        </p:nvSpPr>
+        <p:spPr>
+          <a:xfrm>
+            <a:off x="4206362" y="3785616"/>
+            <a:ext cx="4480438" cy="548640"/>
+          </a:xfrm>
+          <a:prstGeom prst="rect">
+            <a:avLst/>
+          </a:prstGeom>
+          <a:solidFill>
+            <a:srgbClr val="F5F5F5"/>
+          </a:solidFill>
+          <a:ln/>
+        </p:spPr>
+      </p:sp>
+      <p:sp>
+        <p:nvSpPr>
+          <p:cNvPr id="9" name="Shape 6"/>
+          <p:cNvSpPr/>
+          <p:nvPr/>
+        </p:nvSpPr>
+        <p:spPr>
+          <a:xfrm>
+            <a:off x="4206362" y="3785616"/>
+            <a:ext cx="54864" cy="548640"/>
+          </a:xfrm>
+          <a:prstGeom prst="rect">
+            <a:avLst/>
+          </a:prstGeom>
+          <a:solidFill>
+            <a:srgbClr val="76B900"/>
+          </a:solidFill>
+          <a:ln/>
+        </p:spPr>
+      </p:sp>
+      <p:sp>
+        <p:nvSpPr>
+          <p:cNvPr id="10" name="Text 7"/>
+          <p:cNvSpPr/>
+          <p:nvPr/>
+        </p:nvSpPr>
+        <p:spPr>
+          <a:xfrm>
+            <a:off x="4389242" y="3785616"/>
+            <a:ext cx="4206118" cy="548640"/>
           </a:xfrm>
           <a:prstGeom prst="rect">
             <a:avLst/>
@@ -22539,137 +24150,13 @@
                 <a:ea typeface="NVIDIA Sans" pitchFamily="34" charset="-122"/>
                 <a:cs typeface="NVIDIA Sans" pitchFamily="34" charset="-120"/>
               </a:rPr>
-              <a:t>Baseline</a:t>
+              <a:t>Kernel launches: 13.9k → 6.4k per step. </a:t>
             </a:r>
-            <a:endParaRPr lang="en-US" sz="1100" dirty="0"/>
-          </a:p>
-        </p:txBody>
-      </p:sp>
-      <p:sp>
-        <p:nvSpPr>
-          <p:cNvPr id="7" name="Shape 5"/>
-          <p:cNvSpPr/>
-          <p:nvPr/>
-        </p:nvSpPr>
-        <p:spPr>
-          <a:xfrm>
-            <a:off x="2148840" y="3063240"/>
-            <a:ext cx="3605332" cy="310896"/>
-          </a:xfrm>
-          <a:prstGeom prst="rect">
-            <a:avLst/>
-          </a:prstGeom>
-          <a:solidFill>
-            <a:srgbClr val="76B900"/>
-          </a:solidFill>
-          <a:ln/>
-        </p:spPr>
-      </p:sp>
-      <p:sp>
-        <p:nvSpPr>
-          <p:cNvPr id="8" name="Text 6"/>
-          <p:cNvSpPr/>
-          <p:nvPr/>
-        </p:nvSpPr>
-        <p:spPr>
-          <a:xfrm>
-            <a:off x="2148840" y="3063240"/>
-            <a:ext cx="3605332" cy="310896"/>
-          </a:xfrm>
-          <a:prstGeom prst="rect">
-            <a:avLst/>
-          </a:prstGeom>
-          <a:noFill/>
-          <a:ln/>
-        </p:spPr>
-        <p:txBody>
-          <a:bodyPr wrap="square" lIns="0" tIns="0" rIns="0" bIns="0" rtlCol="0" anchor="ctr"/>
-          <a:lstStyle/>
-          <a:p>
-            <a:pPr algn="ctr" indent="0" marL="0">
+            <a:pPr indent="0" marL="0">
               <a:buNone/>
             </a:pPr>
             <a:r>
-              <a:rPr lang="en-US" sz="1000" b="1" dirty="0">
-                <a:solidFill>
-                  <a:srgbClr val="FFFFFF"/>
-                </a:solidFill>
-                <a:latin typeface="NVIDIA Sans" pitchFamily="34" charset="0"/>
-                <a:ea typeface="NVIDIA Sans" pitchFamily="34" charset="-122"/>
-                <a:cs typeface="NVIDIA Sans" pitchFamily="34" charset="-120"/>
-              </a:rPr>
-              <a:t>540</a:t>
-            </a:r>
-            <a:endParaRPr lang="en-US" sz="1000" dirty="0"/>
-          </a:p>
-        </p:txBody>
-      </p:sp>
-      <p:sp>
-        <p:nvSpPr>
-          <p:cNvPr id="9" name="Shape 7"/>
-          <p:cNvSpPr/>
-          <p:nvPr/>
-        </p:nvSpPr>
-        <p:spPr>
-          <a:xfrm>
-            <a:off x="5754172" y="3063240"/>
-            <a:ext cx="411123" cy="310896"/>
-          </a:xfrm>
-          <a:prstGeom prst="rect">
-            <a:avLst/>
-          </a:prstGeom>
-          <a:solidFill>
-            <a:srgbClr val="0071C5"/>
-          </a:solidFill>
-          <a:ln/>
-        </p:spPr>
-      </p:sp>
-      <p:sp>
-        <p:nvSpPr>
-          <p:cNvPr id="10" name="Shape 8"/>
-          <p:cNvSpPr/>
-          <p:nvPr/>
-        </p:nvSpPr>
-        <p:spPr>
-          <a:xfrm>
-            <a:off x="6165295" y="3063240"/>
-            <a:ext cx="1368852" cy="310896"/>
-          </a:xfrm>
-          <a:prstGeom prst="rect">
-            <a:avLst/>
-          </a:prstGeom>
-          <a:solidFill>
-            <a:srgbClr val="D9D9D9"/>
-          </a:solidFill>
-          <a:ln/>
-        </p:spPr>
-      </p:sp>
-      <p:sp>
-        <p:nvSpPr>
-          <p:cNvPr id="11" name="Text 9"/>
-          <p:cNvSpPr/>
-          <p:nvPr/>
-        </p:nvSpPr>
-        <p:spPr>
-          <a:xfrm>
-            <a:off x="6165295" y="3063240"/>
-            <a:ext cx="1368852" cy="310896"/>
-          </a:xfrm>
-          <a:prstGeom prst="rect">
-            <a:avLst/>
-          </a:prstGeom>
-          <a:noFill/>
-          <a:ln/>
-        </p:spPr>
-        <p:txBody>
-          <a:bodyPr wrap="square" lIns="0" tIns="0" rIns="0" bIns="0" rtlCol="0" anchor="ctr"/>
-          <a:lstStyle/>
-          <a:p>
-            <a:pPr algn="ctr" indent="0" marL="0">
-              <a:buNone/>
-            </a:pPr>
-            <a:r>
-              <a:rPr lang="en-US" sz="1000" b="1" dirty="0">
+              <a:rPr lang="en-US" sz="1100" dirty="0">
                 <a:solidFill>
                   <a:srgbClr val="5E5E5E"/>
                 </a:solidFill>
@@ -22677,46 +24164,7 @@
                 <a:ea typeface="NVIDIA Sans" pitchFamily="34" charset="-122"/>
                 <a:cs typeface="NVIDIA Sans" pitchFamily="34" charset="-120"/>
               </a:rPr>
-              <a:t>205</a:t>
-            </a:r>
-            <a:endParaRPr lang="en-US" sz="1000" dirty="0"/>
-          </a:p>
-        </p:txBody>
-      </p:sp>
-      <p:sp>
-        <p:nvSpPr>
-          <p:cNvPr id="12" name="Text 10"/>
-          <p:cNvSpPr/>
-          <p:nvPr/>
-        </p:nvSpPr>
-        <p:spPr>
-          <a:xfrm>
-            <a:off x="7589010" y="3063240"/>
-            <a:ext cx="822960" cy="310896"/>
-          </a:xfrm>
-          <a:prstGeom prst="rect">
-            <a:avLst/>
-          </a:prstGeom>
-          <a:noFill/>
-          <a:ln/>
-        </p:spPr>
-        <p:txBody>
-          <a:bodyPr wrap="square" lIns="0" tIns="0" rIns="0" bIns="0" rtlCol="0" anchor="ctr"/>
-          <a:lstStyle/>
-          <a:p>
-            <a:pPr indent="0" marL="0">
-              <a:buNone/>
-            </a:pPr>
-            <a:r>
-              <a:rPr lang="en-US" sz="1100" b="1" dirty="0">
-                <a:solidFill>
-                  <a:srgbClr val="000000"/>
-                </a:solidFill>
-                <a:latin typeface="NVIDIA Sans" pitchFamily="34" charset="0"/>
-                <a:ea typeface="NVIDIA Sans" pitchFamily="34" charset="-122"/>
-                <a:cs typeface="NVIDIA Sans" pitchFamily="34" charset="-120"/>
-              </a:rPr>
-              <a:t>807 ms</a:t>
+              <a:t>CPU launch cost leaves the critical path; GPU idle collapses.</a:t>
             </a:r>
             <a:endParaRPr lang="en-US" sz="1100" dirty="0"/>
           </a:p>
@@ -22724,400 +24172,7 @@
       </p:sp>
       <p:sp>
         <p:nvSpPr>
-          <p:cNvPr id="13" name="Text 11"/>
-          <p:cNvSpPr/>
-          <p:nvPr/>
-        </p:nvSpPr>
-        <p:spPr>
-          <a:xfrm>
-            <a:off x="640080" y="3502152"/>
-            <a:ext cx="1463040" cy="310896"/>
-          </a:xfrm>
-          <a:prstGeom prst="rect">
-            <a:avLst/>
-          </a:prstGeom>
-          <a:noFill/>
-          <a:ln/>
-        </p:spPr>
-        <p:txBody>
-          <a:bodyPr wrap="square" lIns="0" tIns="0" rIns="0" bIns="0" rtlCol="0" anchor="ctr"/>
-          <a:lstStyle/>
-          <a:p>
-            <a:pPr indent="0" marL="0">
-              <a:buNone/>
-            </a:pPr>
-            <a:r>
-              <a:rPr lang="en-US" sz="1100" b="1" dirty="0">
-                <a:solidFill>
-                  <a:srgbClr val="000000"/>
-                </a:solidFill>
-                <a:latin typeface="NVIDIA Sans" pitchFamily="34" charset="0"/>
-                <a:ea typeface="NVIDIA Sans" pitchFamily="34" charset="-122"/>
-                <a:cs typeface="NVIDIA Sans" pitchFamily="34" charset="-120"/>
-              </a:rPr>
-              <a:t>Optimized</a:t>
-            </a:r>
-            <a:endParaRPr lang="en-US" sz="1100" dirty="0"/>
-          </a:p>
-        </p:txBody>
-      </p:sp>
-      <p:sp>
-        <p:nvSpPr>
-          <p:cNvPr id="14" name="Shape 12"/>
-          <p:cNvSpPr/>
-          <p:nvPr/>
-        </p:nvSpPr>
-        <p:spPr>
-          <a:xfrm>
-            <a:off x="2148840" y="3520440"/>
-            <a:ext cx="1169297" cy="310896"/>
-          </a:xfrm>
-          <a:prstGeom prst="rect">
-            <a:avLst/>
-          </a:prstGeom>
-          <a:solidFill>
-            <a:srgbClr val="76B900"/>
-          </a:solidFill>
-          <a:ln/>
-        </p:spPr>
-      </p:sp>
-      <p:sp>
-        <p:nvSpPr>
-          <p:cNvPr id="15" name="Text 13"/>
-          <p:cNvSpPr/>
-          <p:nvPr/>
-        </p:nvSpPr>
-        <p:spPr>
-          <a:xfrm>
-            <a:off x="2148840" y="3520440"/>
-            <a:ext cx="1169297" cy="310896"/>
-          </a:xfrm>
-          <a:prstGeom prst="rect">
-            <a:avLst/>
-          </a:prstGeom>
-          <a:noFill/>
-          <a:ln/>
-        </p:spPr>
-        <p:txBody>
-          <a:bodyPr wrap="square" lIns="0" tIns="0" rIns="0" bIns="0" rtlCol="0" anchor="ctr"/>
-          <a:lstStyle/>
-          <a:p>
-            <a:pPr algn="ctr" indent="0" marL="0">
-              <a:buNone/>
-            </a:pPr>
-            <a:r>
-              <a:rPr lang="en-US" sz="1000" b="1" dirty="0">
-                <a:solidFill>
-                  <a:srgbClr val="FFFFFF"/>
-                </a:solidFill>
-                <a:latin typeface="NVIDIA Sans" pitchFamily="34" charset="0"/>
-                <a:ea typeface="NVIDIA Sans" pitchFamily="34" charset="-122"/>
-                <a:cs typeface="NVIDIA Sans" pitchFamily="34" charset="-120"/>
-              </a:rPr>
-              <a:t>175</a:t>
-            </a:r>
-            <a:endParaRPr lang="en-US" sz="1000" dirty="0"/>
-          </a:p>
-        </p:txBody>
-      </p:sp>
-      <p:sp>
-        <p:nvSpPr>
-          <p:cNvPr id="16" name="Shape 14"/>
-          <p:cNvSpPr/>
-          <p:nvPr/>
-        </p:nvSpPr>
-        <p:spPr>
-          <a:xfrm>
-            <a:off x="3318137" y="3520440"/>
-            <a:ext cx="148164" cy="310896"/>
-          </a:xfrm>
-          <a:prstGeom prst="rect">
-            <a:avLst/>
-          </a:prstGeom>
-          <a:solidFill>
-            <a:srgbClr val="0071C5"/>
-          </a:solidFill>
-          <a:ln/>
-        </p:spPr>
-      </p:sp>
-      <p:sp>
-        <p:nvSpPr>
-          <p:cNvPr id="17" name="Shape 15"/>
-          <p:cNvSpPr/>
-          <p:nvPr/>
-        </p:nvSpPr>
-        <p:spPr>
-          <a:xfrm>
-            <a:off x="3466301" y="3520440"/>
-            <a:ext cx="289655" cy="310896"/>
-          </a:xfrm>
-          <a:prstGeom prst="rect">
-            <a:avLst/>
-          </a:prstGeom>
-          <a:solidFill>
-            <a:srgbClr val="D9D9D9"/>
-          </a:solidFill>
-          <a:ln/>
-        </p:spPr>
-      </p:sp>
-      <p:sp>
-        <p:nvSpPr>
-          <p:cNvPr id="18" name="Text 16"/>
-          <p:cNvSpPr/>
-          <p:nvPr/>
-        </p:nvSpPr>
-        <p:spPr>
-          <a:xfrm>
-            <a:off x="3810820" y="3520440"/>
-            <a:ext cx="822960" cy="310896"/>
-          </a:xfrm>
-          <a:prstGeom prst="rect">
-            <a:avLst/>
-          </a:prstGeom>
-          <a:noFill/>
-          <a:ln/>
-        </p:spPr>
-        <p:txBody>
-          <a:bodyPr wrap="square" lIns="0" tIns="0" rIns="0" bIns="0" rtlCol="0" anchor="ctr"/>
-          <a:lstStyle/>
-          <a:p>
-            <a:pPr indent="0" marL="0">
-              <a:buNone/>
-            </a:pPr>
-            <a:r>
-              <a:rPr lang="en-US" sz="1100" b="1" dirty="0">
-                <a:solidFill>
-                  <a:srgbClr val="000000"/>
-                </a:solidFill>
-                <a:latin typeface="NVIDIA Sans" pitchFamily="34" charset="0"/>
-                <a:ea typeface="NVIDIA Sans" pitchFamily="34" charset="-122"/>
-                <a:cs typeface="NVIDIA Sans" pitchFamily="34" charset="-120"/>
-              </a:rPr>
-              <a:t>249 ms</a:t>
-            </a:r>
-            <a:endParaRPr lang="en-US" sz="1100" dirty="0"/>
-          </a:p>
-        </p:txBody>
-      </p:sp>
-      <p:sp>
-        <p:nvSpPr>
-          <p:cNvPr id="19" name="Shape 17"/>
-          <p:cNvSpPr/>
-          <p:nvPr/>
-        </p:nvSpPr>
-        <p:spPr>
-          <a:xfrm>
-            <a:off x="2148840" y="4005072"/>
-            <a:ext cx="164592" cy="128016"/>
-          </a:xfrm>
-          <a:prstGeom prst="rect">
-            <a:avLst/>
-          </a:prstGeom>
-          <a:solidFill>
-            <a:srgbClr val="76B900"/>
-          </a:solidFill>
-          <a:ln/>
-        </p:spPr>
-      </p:sp>
-      <p:sp>
-        <p:nvSpPr>
-          <p:cNvPr id="20" name="Text 18"/>
-          <p:cNvSpPr/>
-          <p:nvPr/>
-        </p:nvSpPr>
-        <p:spPr>
-          <a:xfrm>
-            <a:off x="2368296" y="3931920"/>
-            <a:ext cx="1600200" cy="274320"/>
-          </a:xfrm>
-          <a:prstGeom prst="rect">
-            <a:avLst/>
-          </a:prstGeom>
-          <a:noFill/>
-          <a:ln/>
-        </p:spPr>
-        <p:txBody>
-          <a:bodyPr wrap="square" lIns="0" tIns="0" rIns="0" bIns="0" rtlCol="0" anchor="ctr"/>
-          <a:lstStyle/>
-          <a:p>
-            <a:pPr indent="0" marL="0">
-              <a:buNone/>
-            </a:pPr>
-            <a:r>
-              <a:rPr lang="en-US" sz="1000" dirty="0">
-                <a:solidFill>
-                  <a:srgbClr val="5E5E5E"/>
-                </a:solidFill>
-                <a:latin typeface="NVIDIA Sans" pitchFamily="34" charset="0"/>
-                <a:ea typeface="NVIDIA Sans" pitchFamily="34" charset="-122"/>
-                <a:cs typeface="NVIDIA Sans" pitchFamily="34" charset="-120"/>
-              </a:rPr>
-              <a:t>Compute busy</a:t>
-            </a:r>
-            <a:endParaRPr lang="en-US" sz="1000" dirty="0"/>
-          </a:p>
-        </p:txBody>
-      </p:sp>
-      <p:sp>
-        <p:nvSpPr>
-          <p:cNvPr id="21" name="Shape 19"/>
-          <p:cNvSpPr/>
-          <p:nvPr/>
-        </p:nvSpPr>
-        <p:spPr>
-          <a:xfrm>
-            <a:off x="3977640" y="4005072"/>
-            <a:ext cx="164592" cy="128016"/>
-          </a:xfrm>
-          <a:prstGeom prst="rect">
-            <a:avLst/>
-          </a:prstGeom>
-          <a:solidFill>
-            <a:srgbClr val="0071C5"/>
-          </a:solidFill>
-          <a:ln/>
-        </p:spPr>
-      </p:sp>
-      <p:sp>
-        <p:nvSpPr>
-          <p:cNvPr id="22" name="Text 20"/>
-          <p:cNvSpPr/>
-          <p:nvPr/>
-        </p:nvSpPr>
-        <p:spPr>
-          <a:xfrm>
-            <a:off x="4197096" y="3931920"/>
-            <a:ext cx="1600200" cy="274320"/>
-          </a:xfrm>
-          <a:prstGeom prst="rect">
-            <a:avLst/>
-          </a:prstGeom>
-          <a:noFill/>
-          <a:ln/>
-        </p:spPr>
-        <p:txBody>
-          <a:bodyPr wrap="square" lIns="0" tIns="0" rIns="0" bIns="0" rtlCol="0" anchor="ctr"/>
-          <a:lstStyle/>
-          <a:p>
-            <a:pPr indent="0" marL="0">
-              <a:buNone/>
-            </a:pPr>
-            <a:r>
-              <a:rPr lang="en-US" sz="1000" dirty="0">
-                <a:solidFill>
-                  <a:srgbClr val="5E5E5E"/>
-                </a:solidFill>
-                <a:latin typeface="NVIDIA Sans" pitchFamily="34" charset="0"/>
-                <a:ea typeface="NVIDIA Sans" pitchFamily="34" charset="-122"/>
-                <a:cs typeface="NVIDIA Sans" pitchFamily="34" charset="-120"/>
-              </a:rPr>
-              <a:t>Exposed comm</a:t>
-            </a:r>
-            <a:endParaRPr lang="en-US" sz="1000" dirty="0"/>
-          </a:p>
-        </p:txBody>
-      </p:sp>
-      <p:sp>
-        <p:nvSpPr>
-          <p:cNvPr id="23" name="Shape 21"/>
-          <p:cNvSpPr/>
-          <p:nvPr/>
-        </p:nvSpPr>
-        <p:spPr>
-          <a:xfrm>
-            <a:off x="5806440" y="4005072"/>
-            <a:ext cx="164592" cy="128016"/>
-          </a:xfrm>
-          <a:prstGeom prst="rect">
-            <a:avLst/>
-          </a:prstGeom>
-          <a:solidFill>
-            <a:srgbClr val="D9D9D9"/>
-          </a:solidFill>
-          <a:ln/>
-        </p:spPr>
-      </p:sp>
-      <p:sp>
-        <p:nvSpPr>
-          <p:cNvPr id="24" name="Text 22"/>
-          <p:cNvSpPr/>
-          <p:nvPr/>
-        </p:nvSpPr>
-        <p:spPr>
-          <a:xfrm>
-            <a:off x="6025896" y="3931920"/>
-            <a:ext cx="1600200" cy="274320"/>
-          </a:xfrm>
-          <a:prstGeom prst="rect">
-            <a:avLst/>
-          </a:prstGeom>
-          <a:noFill/>
-          <a:ln/>
-        </p:spPr>
-        <p:txBody>
-          <a:bodyPr wrap="square" lIns="0" tIns="0" rIns="0" bIns="0" rtlCol="0" anchor="ctr"/>
-          <a:lstStyle/>
-          <a:p>
-            <a:pPr indent="0" marL="0">
-              <a:buNone/>
-            </a:pPr>
-            <a:r>
-              <a:rPr lang="en-US" sz="1000" dirty="0">
-                <a:solidFill>
-                  <a:srgbClr val="5E5E5E"/>
-                </a:solidFill>
-                <a:latin typeface="NVIDIA Sans" pitchFamily="34" charset="0"/>
-                <a:ea typeface="NVIDIA Sans" pitchFamily="34" charset="-122"/>
-                <a:cs typeface="NVIDIA Sans" pitchFamily="34" charset="-120"/>
-              </a:rPr>
-              <a:t>Idle / launch gaps</a:t>
-            </a:r>
-            <a:endParaRPr lang="en-US" sz="1000" dirty="0"/>
-          </a:p>
-        </p:txBody>
-      </p:sp>
-      <p:sp>
-        <p:nvSpPr>
-          <p:cNvPr id="25" name="Text 23"/>
-          <p:cNvSpPr/>
-          <p:nvPr/>
-        </p:nvSpPr>
-        <p:spPr>
-          <a:xfrm>
-            <a:off x="457200" y="4224528"/>
-            <a:ext cx="8229600" cy="228600"/>
-          </a:xfrm>
-          <a:prstGeom prst="rect">
-            <a:avLst/>
-          </a:prstGeom>
-          <a:noFill/>
-          <a:ln/>
-        </p:spPr>
-        <p:txBody>
-          <a:bodyPr wrap="square" lIns="0" tIns="0" rIns="0" bIns="0" rtlCol="0" anchor="ctr"/>
-          <a:lstStyle/>
-          <a:p>
-            <a:pPr indent="0" marL="0">
-              <a:buNone/>
-            </a:pPr>
-            <a:r>
-              <a:rPr lang="en-US" sz="950" i="1" dirty="0">
-                <a:solidFill>
-                  <a:srgbClr val="8C8C8C"/>
-                </a:solidFill>
-                <a:latin typeface="NVIDIA Sans" pitchFamily="34" charset="0"/>
-                <a:ea typeface="NVIDIA Sans" pitchFamily="34" charset="-122"/>
-                <a:cs typeface="NVIDIA Sans" pitchFamily="34" charset="-120"/>
-              </a:rPr>
-              <a:t>Gradient AllReduce 15.1 GB/step + optimizer AllGather 15.1 GB/step (bf16). Idle from 254 ms to 43 ms.</a:t>
-            </a:r>
-            <a:endParaRPr lang="en-US" sz="950" dirty="0"/>
-          </a:p>
-        </p:txBody>
-      </p:sp>
-      <p:sp>
-        <p:nvSpPr>
-          <p:cNvPr id="26" name="Text 24"/>
+          <p:cNvPr id="11" name="Text 8"/>
           <p:cNvSpPr/>
           <p:nvPr/>
         </p:nvSpPr>
@@ -23156,7 +24211,7 @@
       </p:sp>
       <p:sp>
         <p:nvSpPr>
-          <p:cNvPr id="27" name="Text 25"/>
+          <p:cNvPr id="12" name="Text 9"/>
           <p:cNvSpPr/>
           <p:nvPr/>
         </p:nvSpPr>
@@ -23195,7 +24250,7 @@
       </p:sp>
       <p:sp>
         <p:nvSpPr>
-          <p:cNvPr id="28" name="Shape 26"/>
+          <p:cNvPr id="13" name="Shape 10"/>
           <p:cNvSpPr/>
           <p:nvPr/>
         </p:nvSpPr>
@@ -23215,14 +24270,14 @@
       </p:sp>
       <p:pic>
         <p:nvPicPr>
-          <p:cNvPr id="29" name="Image 0" descr="/app/logos/nvidia-logo-blk-sm.png">    </p:cNvPr>
+          <p:cNvPr id="14" name="Image 1" descr="/app/logos/nvidia-logo-blk-sm.png">    </p:cNvPr>
           <p:cNvPicPr>
             <a:picLocks noChangeAspect="1"/>
           </p:cNvPicPr>
           <p:nvPr/>
         </p:nvPicPr>
         <p:blipFill>
-          <a:blip r:embed="rId1"/>
+          <a:blip r:embed="rId2"/>
           <a:stretch>
             <a:fillRect/>
           </a:stretch>

</xml_diff>

<commit_message>
docs(slides): logging readback added as sync point 4 on the problem page
</commit_message>
<xml_diff>
--- a/docs/slides/qwenpi-optimization.pptx
+++ b/docs/slides/qwenpi-optimization.pptx
@@ -22163,7 +22163,7 @@
                 <a:ea typeface="NVIDIA Sans" pitchFamily="34" charset="-122"/>
                 <a:cs typeface="NVIDIA Sans" pitchFamily="34" charset="-120"/>
               </a:rPr>
-              <a:t>Three CPU round-trips hide inside every baseline forward pass</a:t>
+              <a:t>Four CPU round-trips hide inside every baseline training step</a:t>
             </a:r>
             <a:endParaRPr lang="en-US" sz="1500" dirty="0"/>
           </a:p>
@@ -22185,8 +22185,8 @@
         </p:blipFill>
         <p:spPr>
           <a:xfrm>
-            <a:off x="1702393" y="1280160"/>
-            <a:ext cx="5739214" cy="2103120"/>
+            <a:off x="1636316" y="1280160"/>
+            <a:ext cx="5871367" cy="2103120"/>
           </a:xfrm>
           <a:prstGeom prst="rect">
             <a:avLst/>
@@ -22361,7 +22361,7 @@
         <p:spPr>
           <a:xfrm>
             <a:off x="2595067" y="3547872"/>
-            <a:ext cx="1419149" cy="237744"/>
+            <a:ext cx="1309421" cy="237744"/>
           </a:xfrm>
           <a:prstGeom prst="rect">
             <a:avLst/>
@@ -22375,6 +22375,26 @@
       <p:sp>
         <p:nvSpPr>
           <p:cNvPr id="13" name="Shape 10"/>
+          <p:cNvSpPr/>
+          <p:nvPr/>
+        </p:nvSpPr>
+        <p:spPr>
+          <a:xfrm>
+            <a:off x="3904488" y="3547872"/>
+            <a:ext cx="109728" cy="237744"/>
+          </a:xfrm>
+          <a:prstGeom prst="rect">
+            <a:avLst/>
+          </a:prstGeom>
+          <a:solidFill>
+            <a:srgbClr val="890C58"/>
+          </a:solidFill>
+          <a:ln/>
+        </p:spPr>
+      </p:sp>
+      <p:sp>
+        <p:nvSpPr>
+          <p:cNvPr id="14" name="Shape 11"/>
           <p:cNvSpPr/>
           <p:nvPr/>
         </p:nvSpPr>
@@ -22394,7 +22414,7 @@
       </p:sp>
       <p:sp>
         <p:nvSpPr>
-          <p:cNvPr id="14" name="Shape 11"/>
+          <p:cNvPr id="15" name="Shape 12"/>
           <p:cNvSpPr/>
           <p:nvPr/>
         </p:nvSpPr>
@@ -22414,7 +22434,7 @@
       </p:sp>
       <p:sp>
         <p:nvSpPr>
-          <p:cNvPr id="15" name="Text 12"/>
+          <p:cNvPr id="16" name="Text 13"/>
           <p:cNvSpPr/>
           <p:nvPr/>
         </p:nvSpPr>
@@ -22453,7 +22473,7 @@
       </p:sp>
       <p:sp>
         <p:nvSpPr>
-          <p:cNvPr id="16" name="Text 13"/>
+          <p:cNvPr id="17" name="Text 14"/>
           <p:cNvSpPr/>
           <p:nvPr/>
         </p:nvSpPr>
@@ -22492,7 +22512,7 @@
       </p:sp>
       <p:sp>
         <p:nvSpPr>
-          <p:cNvPr id="17" name="Text 14"/>
+          <p:cNvPr id="18" name="Text 15"/>
           <p:cNvSpPr/>
           <p:nvPr/>
         </p:nvSpPr>
@@ -22531,7 +22551,46 @@
       </p:sp>
       <p:sp>
         <p:nvSpPr>
-          <p:cNvPr id="18" name="Text 15"/>
+          <p:cNvPr id="19" name="Text 16"/>
+          <p:cNvSpPr/>
+          <p:nvPr/>
+        </p:nvSpPr>
+        <p:spPr>
+          <a:xfrm>
+            <a:off x="3882542" y="3291840"/>
+            <a:ext cx="274320" cy="219456"/>
+          </a:xfrm>
+          <a:prstGeom prst="rect">
+            <a:avLst/>
+          </a:prstGeom>
+          <a:noFill/>
+          <a:ln/>
+        </p:spPr>
+        <p:txBody>
+          <a:bodyPr wrap="square" lIns="0" tIns="0" rIns="0" bIns="0" rtlCol="0" anchor="ctr"/>
+          <a:lstStyle/>
+          <a:p>
+            <a:pPr algn="ctr" indent="0" marL="0">
+              <a:buNone/>
+            </a:pPr>
+            <a:r>
+              <a:rPr lang="en-US" sz="1000" b="1" dirty="0">
+                <a:solidFill>
+                  <a:srgbClr val="890C58"/>
+                </a:solidFill>
+                <a:latin typeface="NVIDIA Sans" pitchFamily="34" charset="0"/>
+                <a:ea typeface="NVIDIA Sans" pitchFamily="34" charset="-122"/>
+                <a:cs typeface="NVIDIA Sans" pitchFamily="34" charset="-120"/>
+              </a:rPr>
+              <a:t>4</a:t>
+            </a:r>
+            <a:endParaRPr lang="en-US" sz="1000" dirty="0"/>
+          </a:p>
+        </p:txBody>
+      </p:sp>
+      <p:sp>
+        <p:nvSpPr>
+          <p:cNvPr id="20" name="Text 17"/>
           <p:cNvSpPr/>
           <p:nvPr/>
         </p:nvSpPr>
@@ -22570,7 +22629,7 @@
       </p:sp>
       <p:sp>
         <p:nvSpPr>
-          <p:cNvPr id="19" name="Text 16"/>
+          <p:cNvPr id="21" name="Text 18"/>
           <p:cNvSpPr/>
           <p:nvPr/>
         </p:nvSpPr>
@@ -22615,7 +22674,7 @@
                 <a:ea typeface="NVIDIA Sans" pitchFamily="34" charset="-122"/>
                 <a:cs typeface="NVIDIA Sans" pitchFamily="34" charset="-120"/>
               </a:rPr>
-              <a:t>stall 1 ≈ 37 ms at every step start; stall 3 ≈ 13 ms; plus loss/timer readbacks — together seeding the 205 ms/step of GPU idle. The next page removes all three.</a:t>
+              <a:t>stall 1 ≈ 37 ms at every step start; stall 3 ≈ 13 ms; stall 4 drains the launch pipeline twice per step — together seeding the 205 ms/step of GPU idle. The next page removes all four.</a:t>
             </a:r>
             <a:endParaRPr lang="en-US" sz="1100" dirty="0"/>
           </a:p>
@@ -22623,7 +22682,7 @@
       </p:sp>
       <p:sp>
         <p:nvSpPr>
-          <p:cNvPr id="20" name="Text 17"/>
+          <p:cNvPr id="22" name="Text 19"/>
           <p:cNvSpPr/>
           <p:nvPr/>
         </p:nvSpPr>
@@ -22662,7 +22721,7 @@
       </p:sp>
       <p:sp>
         <p:nvSpPr>
-          <p:cNvPr id="21" name="Text 18"/>
+          <p:cNvPr id="23" name="Text 20"/>
           <p:cNvSpPr/>
           <p:nvPr/>
         </p:nvSpPr>
@@ -22701,7 +22760,7 @@
       </p:sp>
       <p:sp>
         <p:nvSpPr>
-          <p:cNvPr id="22" name="Shape 19"/>
+          <p:cNvPr id="24" name="Shape 21"/>
           <p:cNvSpPr/>
           <p:nvPr/>
         </p:nvSpPr>
@@ -22721,7 +22780,7 @@
       </p:sp>
       <p:pic>
         <p:nvPicPr>
-          <p:cNvPr id="23" name="Image 1" descr="/app/logos/nvidia-logo-blk-sm.png">    </p:cNvPr>
+          <p:cNvPr id="25" name="Image 1" descr="/app/logos/nvidia-logo-blk-sm.png">    </p:cNvPr>
           <p:cNvPicPr>
             <a:picLocks noChangeAspect="1"/>
           </p:cNvPicPr>

</xml_diff>

<commit_message>
docs(slides): model-diagram overlap fixes, enlarged 4-vs-1 schematics
</commit_message>
<xml_diff>
--- a/docs/slides/qwenpi-optimization.pptx
+++ b/docs/slides/qwenpi-optimization.pptx
@@ -5067,7 +5067,7 @@
         <p:spPr>
           <a:xfrm>
             <a:off x="457200" y="1371600"/>
-            <a:ext cx="3291962" cy="2834640"/>
+            <a:ext cx="3026481" cy="2606040"/>
           </a:xfrm>
           <a:prstGeom prst="rect">
             <a:avLst/>
@@ -5082,8 +5082,8 @@
         </p:nvSpPr>
         <p:spPr>
           <a:xfrm>
-            <a:off x="4206362" y="1371600"/>
-            <a:ext cx="4480438" cy="502920"/>
+            <a:off x="457200" y="4087368"/>
+            <a:ext cx="3392241" cy="365760"/>
           </a:xfrm>
           <a:prstGeom prst="rect">
             <a:avLst/>
@@ -5092,15 +5092,14 @@
           <a:ln/>
         </p:spPr>
         <p:txBody>
-          <a:bodyPr wrap="square" lIns="0" tIns="0" rIns="0" bIns="0" rtlCol="0" anchor="t"/>
+          <a:bodyPr wrap="square" lIns="0" tIns="0" rIns="0" bIns="0" rtlCol="0" anchor="ctr"/>
           <a:lstStyle/>
           <a:p>
-            <a:pPr marL="342900" indent="-342900">
-              <a:buSzPct val="100000"/>
-              <a:buChar char="•"/>
+            <a:pPr indent="0" marL="0">
+              <a:buNone/>
             </a:pPr>
             <a:r>
-              <a:rPr lang="en-US" sz="1050" dirty="0">
+              <a:rPr lang="en-US" sz="900" i="1" dirty="0">
                 <a:solidFill>
                   <a:srgbClr val="5E5E5E"/>
                 </a:solidFill>
@@ -5108,9 +5107,9 @@
                 <a:ea typeface="NVIDIA Sans" pitchFamily="34" charset="-122"/>
                 <a:cs typeface="NVIDIA Sans" pitchFamily="34" charset="-120"/>
               </a:rPr>
-              <a:t>Static shapes (pad-192) make capture possible; vision tower = 1 graph, DiT = torch.compile reduce-overhead, merge stays sync-free eager</a:t>
-            </a:r>
-            <a:endParaRPr lang="en-US" sz="1050" dirty="0"/>
+              <a:t>Enablers: static shapes (pad-192) · vision tower = 1 graph · DiT = torch.compile · merge sync-free eager</a:t>
+            </a:r>
+            <a:endParaRPr lang="en-US" sz="900" dirty="0"/>
           </a:p>
         </p:txBody>
       </p:sp>
@@ -5122,8 +5121,8 @@
         </p:nvSpPr>
         <p:spPr>
           <a:xfrm>
-            <a:off x="4206362" y="1874520"/>
-            <a:ext cx="4480438" cy="274320"/>
+            <a:off x="3940881" y="1371600"/>
+            <a:ext cx="4745919" cy="274320"/>
           </a:xfrm>
           <a:prstGeom prst="rect">
             <a:avLst/>
@@ -5161,8 +5160,8 @@
         </p:nvSpPr>
         <p:spPr>
           <a:xfrm>
-            <a:off x="4206362" y="2139696"/>
-            <a:ext cx="4480438" cy="329184"/>
+            <a:off x="3940881" y="1682496"/>
+            <a:ext cx="4745919" cy="329184"/>
           </a:xfrm>
           <a:prstGeom prst="rect">
             <a:avLst/>
@@ -5214,8 +5213,8 @@
         </p:nvSpPr>
         <p:spPr>
           <a:xfrm>
-            <a:off x="4206362" y="2542032"/>
-            <a:ext cx="4480438" cy="182880"/>
+            <a:off x="3940881" y="2103120"/>
+            <a:ext cx="4745919" cy="219456"/>
           </a:xfrm>
           <a:prstGeom prst="rect">
             <a:avLst/>
@@ -5231,7 +5230,7 @@
               <a:buNone/>
             </a:pPr>
             <a:r>
-              <a:rPr lang="en-US" sz="950" b="1" dirty="0">
+              <a:rPr lang="en-US" sz="1050" b="1" dirty="0">
                 <a:solidFill>
                   <a:srgbClr val="000000"/>
                 </a:solidFill>
@@ -5241,7 +5240,7 @@
               </a:rPr>
               <a:t>4 graphs — AllReduce overlaps the group replays:</a:t>
             </a:r>
-            <a:endParaRPr lang="en-US" sz="950" dirty="0"/>
+            <a:endParaRPr lang="en-US" sz="1050" dirty="0"/>
           </a:p>
         </p:txBody>
       </p:sp>
@@ -5253,8 +5252,8 @@
         </p:nvSpPr>
         <p:spPr>
           <a:xfrm>
-            <a:off x="4206362" y="2743200"/>
-            <a:ext cx="457200" cy="146304"/>
+            <a:off x="3940881" y="2359152"/>
+            <a:ext cx="457200" cy="201168"/>
           </a:xfrm>
           <a:prstGeom prst="rect">
             <a:avLst/>
@@ -5270,7 +5269,7 @@
               <a:buNone/>
             </a:pPr>
             <a:r>
-              <a:rPr lang="en-US" sz="750" dirty="0">
+              <a:rPr lang="en-US" sz="850" dirty="0">
                 <a:solidFill>
                   <a:srgbClr val="5E5E5E"/>
                 </a:solidFill>
@@ -5280,7 +5279,7 @@
               </a:rPr>
               <a:t>GPU</a:t>
             </a:r>
-            <a:endParaRPr lang="en-US" sz="750" dirty="0"/>
+            <a:endParaRPr lang="en-US" sz="850" dirty="0"/>
           </a:p>
         </p:txBody>
       </p:sp>
@@ -5292,8 +5291,8 @@
         </p:nvSpPr>
         <p:spPr>
           <a:xfrm>
-            <a:off x="4206362" y="2907792"/>
-            <a:ext cx="457200" cy="146304"/>
+            <a:off x="3940881" y="2596896"/>
+            <a:ext cx="457200" cy="201168"/>
           </a:xfrm>
           <a:prstGeom prst="rect">
             <a:avLst/>
@@ -5309,7 +5308,7 @@
               <a:buNone/>
             </a:pPr>
             <a:r>
-              <a:rPr lang="en-US" sz="750" dirty="0">
+              <a:rPr lang="en-US" sz="850" dirty="0">
                 <a:solidFill>
                   <a:srgbClr val="5E5E5E"/>
                 </a:solidFill>
@@ -5319,7 +5318,7 @@
               </a:rPr>
               <a:t>NCCL</a:t>
             </a:r>
-            <a:endParaRPr lang="en-US" sz="750" dirty="0"/>
+            <a:endParaRPr lang="en-US" sz="850" dirty="0"/>
           </a:p>
         </p:txBody>
       </p:sp>
@@ -5331,8 +5330,8 @@
         </p:nvSpPr>
         <p:spPr>
           <a:xfrm>
-            <a:off x="4709282" y="2743200"/>
-            <a:ext cx="3931798" cy="146304"/>
+            <a:off x="4443801" y="2359152"/>
+            <a:ext cx="4197279" cy="201168"/>
           </a:xfrm>
           <a:prstGeom prst="rect">
             <a:avLst/>
@@ -5351,8 +5350,8 @@
         </p:nvSpPr>
         <p:spPr>
           <a:xfrm>
-            <a:off x="4709282" y="2907792"/>
-            <a:ext cx="3931798" cy="146304"/>
+            <a:off x="4443801" y="2596896"/>
+            <a:ext cx="4197279" cy="201168"/>
           </a:xfrm>
           <a:prstGeom prst="rect">
             <a:avLst/>
@@ -5371,8 +5370,8 @@
         </p:nvSpPr>
         <p:spPr>
           <a:xfrm>
-            <a:off x="4709282" y="2752344"/>
-            <a:ext cx="707724" cy="128016"/>
+            <a:off x="4443801" y="2368296"/>
+            <a:ext cx="755510" cy="182880"/>
           </a:xfrm>
           <a:prstGeom prst="rect">
             <a:avLst/>
@@ -5391,8 +5390,8 @@
         </p:nvSpPr>
         <p:spPr>
           <a:xfrm>
-            <a:off x="4709282" y="2743200"/>
-            <a:ext cx="707724" cy="146304"/>
+            <a:off x="4443801" y="2359152"/>
+            <a:ext cx="755510" cy="201168"/>
           </a:xfrm>
           <a:prstGeom prst="rect">
             <a:avLst/>
@@ -5408,7 +5407,7 @@
               <a:buNone/>
             </a:pPr>
             <a:r>
-              <a:rPr lang="en-US" sz="700" b="1" dirty="0">
+              <a:rPr lang="en-US" sz="800" b="1" dirty="0">
                 <a:solidFill>
                   <a:srgbClr val="FFFFFF"/>
                 </a:solidFill>
@@ -5418,7 +5417,7 @@
               </a:rPr>
               <a:t>bwd G4</a:t>
             </a:r>
-            <a:endParaRPr lang="en-US" sz="700" dirty="0"/>
+            <a:endParaRPr lang="en-US" sz="800" dirty="0"/>
           </a:p>
         </p:txBody>
       </p:sp>
@@ -5430,8 +5429,8 @@
         </p:nvSpPr>
         <p:spPr>
           <a:xfrm>
-            <a:off x="5495642" y="2752344"/>
-            <a:ext cx="707724" cy="128016"/>
+            <a:off x="5283257" y="2368296"/>
+            <a:ext cx="755510" cy="182880"/>
           </a:xfrm>
           <a:prstGeom prst="rect">
             <a:avLst/>
@@ -5450,8 +5449,8 @@
         </p:nvSpPr>
         <p:spPr>
           <a:xfrm>
-            <a:off x="5495642" y="2743200"/>
-            <a:ext cx="707724" cy="146304"/>
+            <a:off x="5283257" y="2359152"/>
+            <a:ext cx="755510" cy="201168"/>
           </a:xfrm>
           <a:prstGeom prst="rect">
             <a:avLst/>
@@ -5467,7 +5466,7 @@
               <a:buNone/>
             </a:pPr>
             <a:r>
-              <a:rPr lang="en-US" sz="700" b="1" dirty="0">
+              <a:rPr lang="en-US" sz="800" b="1" dirty="0">
                 <a:solidFill>
                   <a:srgbClr val="FFFFFF"/>
                 </a:solidFill>
@@ -5477,7 +5476,7 @@
               </a:rPr>
               <a:t>bwd G3</a:t>
             </a:r>
-            <a:endParaRPr lang="en-US" sz="700" dirty="0"/>
+            <a:endParaRPr lang="en-US" sz="800" dirty="0"/>
           </a:p>
         </p:txBody>
       </p:sp>
@@ -5489,8 +5488,8 @@
         </p:nvSpPr>
         <p:spPr>
           <a:xfrm>
-            <a:off x="6282001" y="2752344"/>
-            <a:ext cx="707724" cy="128016"/>
+            <a:off x="6122713" y="2368296"/>
+            <a:ext cx="755510" cy="182880"/>
           </a:xfrm>
           <a:prstGeom prst="rect">
             <a:avLst/>
@@ -5509,8 +5508,8 @@
         </p:nvSpPr>
         <p:spPr>
           <a:xfrm>
-            <a:off x="6282001" y="2743200"/>
-            <a:ext cx="707724" cy="146304"/>
+            <a:off x="6122713" y="2359152"/>
+            <a:ext cx="755510" cy="201168"/>
           </a:xfrm>
           <a:prstGeom prst="rect">
             <a:avLst/>
@@ -5526,7 +5525,7 @@
               <a:buNone/>
             </a:pPr>
             <a:r>
-              <a:rPr lang="en-US" sz="700" b="1" dirty="0">
+              <a:rPr lang="en-US" sz="800" b="1" dirty="0">
                 <a:solidFill>
                   <a:srgbClr val="FFFFFF"/>
                 </a:solidFill>
@@ -5536,7 +5535,7 @@
               </a:rPr>
               <a:t>bwd G2</a:t>
             </a:r>
-            <a:endParaRPr lang="en-US" sz="700" dirty="0"/>
+            <a:endParaRPr lang="en-US" sz="800" dirty="0"/>
           </a:p>
         </p:txBody>
       </p:sp>
@@ -5548,8 +5547,8 @@
         </p:nvSpPr>
         <p:spPr>
           <a:xfrm>
-            <a:off x="7068361" y="2752344"/>
-            <a:ext cx="707724" cy="128016"/>
+            <a:off x="6962168" y="2368296"/>
+            <a:ext cx="755510" cy="182880"/>
           </a:xfrm>
           <a:prstGeom prst="rect">
             <a:avLst/>
@@ -5568,8 +5567,8 @@
         </p:nvSpPr>
         <p:spPr>
           <a:xfrm>
-            <a:off x="7068361" y="2743200"/>
-            <a:ext cx="707724" cy="146304"/>
+            <a:off x="6962168" y="2359152"/>
+            <a:ext cx="755510" cy="201168"/>
           </a:xfrm>
           <a:prstGeom prst="rect">
             <a:avLst/>
@@ -5585,7 +5584,7 @@
               <a:buNone/>
             </a:pPr>
             <a:r>
-              <a:rPr lang="en-US" sz="700" b="1" dirty="0">
+              <a:rPr lang="en-US" sz="800" b="1" dirty="0">
                 <a:solidFill>
                   <a:srgbClr val="FFFFFF"/>
                 </a:solidFill>
@@ -5595,7 +5594,7 @@
               </a:rPr>
               <a:t>bwd G1</a:t>
             </a:r>
-            <a:endParaRPr lang="en-US" sz="700" dirty="0"/>
+            <a:endParaRPr lang="en-US" sz="800" dirty="0"/>
           </a:p>
         </p:txBody>
       </p:sp>
@@ -5607,8 +5606,8 @@
         </p:nvSpPr>
         <p:spPr>
           <a:xfrm>
-            <a:off x="5456324" y="2916936"/>
-            <a:ext cx="589770" cy="128016"/>
+            <a:off x="5241284" y="2606040"/>
+            <a:ext cx="629592" cy="182880"/>
           </a:xfrm>
           <a:prstGeom prst="rect">
             <a:avLst/>
@@ -5627,8 +5626,8 @@
         </p:nvSpPr>
         <p:spPr>
           <a:xfrm>
-            <a:off x="6242683" y="2916936"/>
-            <a:ext cx="589770" cy="128016"/>
+            <a:off x="6080740" y="2606040"/>
+            <a:ext cx="629592" cy="182880"/>
           </a:xfrm>
           <a:prstGeom prst="rect">
             <a:avLst/>
@@ -5647,8 +5646,8 @@
         </p:nvSpPr>
         <p:spPr>
           <a:xfrm>
-            <a:off x="7029043" y="2916936"/>
-            <a:ext cx="589770" cy="128016"/>
+            <a:off x="6920196" y="2606040"/>
+            <a:ext cx="629592" cy="182880"/>
           </a:xfrm>
           <a:prstGeom prst="rect">
             <a:avLst/>
@@ -5667,8 +5666,8 @@
         </p:nvSpPr>
         <p:spPr>
           <a:xfrm>
-            <a:off x="7815402" y="2916936"/>
-            <a:ext cx="275226" cy="128016"/>
+            <a:off x="7759651" y="2606040"/>
+            <a:ext cx="293810" cy="182880"/>
           </a:xfrm>
           <a:prstGeom prst="rect">
             <a:avLst/>
@@ -5687,14 +5686,14 @@
         </p:nvSpPr>
         <p:spPr>
           <a:xfrm>
-            <a:off x="8090628" y="2724912"/>
-            <a:ext cx="0" cy="365760"/>
+            <a:off x="8053461" y="2340864"/>
+            <a:ext cx="0" cy="475488"/>
           </a:xfrm>
           <a:prstGeom prst="line">
             <a:avLst/>
           </a:prstGeom>
           <a:noFill/>
-          <a:ln w="19050">
+          <a:ln w="22225">
             <a:solidFill>
               <a:srgbClr val="890C58"/>
             </a:solidFill>
@@ -5710,8 +5709,8 @@
         </p:nvSpPr>
         <p:spPr>
           <a:xfrm>
-            <a:off x="4206362" y="3108960"/>
-            <a:ext cx="4480438" cy="182880"/>
+            <a:off x="3940881" y="2907792"/>
+            <a:ext cx="4745919" cy="219456"/>
           </a:xfrm>
           <a:prstGeom prst="rect">
             <a:avLst/>
@@ -5727,7 +5726,7 @@
               <a:buNone/>
             </a:pPr>
             <a:r>
-              <a:rPr lang="en-US" sz="950" b="1" dirty="0">
+              <a:rPr lang="en-US" sz="1050" b="1" dirty="0">
                 <a:solidFill>
                   <a:srgbClr val="000000"/>
                 </a:solidFill>
@@ -5737,7 +5736,7 @@
               </a:rPr>
               <a:t>1 graph — every AllReduce waits for the whole backward:</a:t>
             </a:r>
-            <a:endParaRPr lang="en-US" sz="950" dirty="0"/>
+            <a:endParaRPr lang="en-US" sz="1050" dirty="0"/>
           </a:p>
         </p:txBody>
       </p:sp>
@@ -5749,8 +5748,8 @@
         </p:nvSpPr>
         <p:spPr>
           <a:xfrm>
-            <a:off x="4206362" y="3310128"/>
-            <a:ext cx="457200" cy="146304"/>
+            <a:off x="3940881" y="3163824"/>
+            <a:ext cx="457200" cy="201168"/>
           </a:xfrm>
           <a:prstGeom prst="rect">
             <a:avLst/>
@@ -5766,7 +5765,7 @@
               <a:buNone/>
             </a:pPr>
             <a:r>
-              <a:rPr lang="en-US" sz="750" dirty="0">
+              <a:rPr lang="en-US" sz="850" dirty="0">
                 <a:solidFill>
                   <a:srgbClr val="5E5E5E"/>
                 </a:solidFill>
@@ -5776,7 +5775,7 @@
               </a:rPr>
               <a:t>GPU</a:t>
             </a:r>
-            <a:endParaRPr lang="en-US" sz="750" dirty="0"/>
+            <a:endParaRPr lang="en-US" sz="850" dirty="0"/>
           </a:p>
         </p:txBody>
       </p:sp>
@@ -5788,8 +5787,8 @@
         </p:nvSpPr>
         <p:spPr>
           <a:xfrm>
-            <a:off x="4206362" y="3474720"/>
-            <a:ext cx="457200" cy="146304"/>
+            <a:off x="3940881" y="3401568"/>
+            <a:ext cx="457200" cy="201168"/>
           </a:xfrm>
           <a:prstGeom prst="rect">
             <a:avLst/>
@@ -5805,7 +5804,7 @@
               <a:buNone/>
             </a:pPr>
             <a:r>
-              <a:rPr lang="en-US" sz="750" dirty="0">
+              <a:rPr lang="en-US" sz="850" dirty="0">
                 <a:solidFill>
                   <a:srgbClr val="5E5E5E"/>
                 </a:solidFill>
@@ -5815,7 +5814,7 @@
               </a:rPr>
               <a:t>NCCL</a:t>
             </a:r>
-            <a:endParaRPr lang="en-US" sz="750" dirty="0"/>
+            <a:endParaRPr lang="en-US" sz="850" dirty="0"/>
           </a:p>
         </p:txBody>
       </p:sp>
@@ -5827,8 +5826,8 @@
         </p:nvSpPr>
         <p:spPr>
           <a:xfrm>
-            <a:off x="4709282" y="3310128"/>
-            <a:ext cx="3931798" cy="146304"/>
+            <a:off x="4443801" y="3163824"/>
+            <a:ext cx="4197279" cy="201168"/>
           </a:xfrm>
           <a:prstGeom prst="rect">
             <a:avLst/>
@@ -5847,8 +5846,8 @@
         </p:nvSpPr>
         <p:spPr>
           <a:xfrm>
-            <a:off x="4709282" y="3474720"/>
-            <a:ext cx="3931798" cy="146304"/>
+            <a:off x="4443801" y="3401568"/>
+            <a:ext cx="4197279" cy="201168"/>
           </a:xfrm>
           <a:prstGeom prst="rect">
             <a:avLst/>
@@ -5867,8 +5866,8 @@
         </p:nvSpPr>
         <p:spPr>
           <a:xfrm>
-            <a:off x="4709282" y="3319272"/>
-            <a:ext cx="3066803" cy="128016"/>
+            <a:off x="4443801" y="3172968"/>
+            <a:ext cx="3273878" cy="182880"/>
           </a:xfrm>
           <a:prstGeom prst="rect">
             <a:avLst/>
@@ -5887,8 +5886,8 @@
         </p:nvSpPr>
         <p:spPr>
           <a:xfrm>
-            <a:off x="4709282" y="3310128"/>
-            <a:ext cx="3066803" cy="146304"/>
+            <a:off x="4443801" y="3163824"/>
+            <a:ext cx="3273878" cy="201168"/>
           </a:xfrm>
           <a:prstGeom prst="rect">
             <a:avLst/>
@@ -5904,7 +5903,7 @@
               <a:buNone/>
             </a:pPr>
             <a:r>
-              <a:rPr lang="en-US" sz="700" b="1" dirty="0">
+              <a:rPr lang="en-US" sz="800" b="1" dirty="0">
                 <a:solidFill>
                   <a:srgbClr val="FFFFFF"/>
                 </a:solidFill>
@@ -5914,7 +5913,7 @@
               </a:rPr>
               <a:t>backward (one giant graph, hooks cannot fire inside)</a:t>
             </a:r>
-            <a:endParaRPr lang="en-US" sz="700" dirty="0"/>
+            <a:endParaRPr lang="en-US" sz="800" dirty="0"/>
           </a:p>
         </p:txBody>
       </p:sp>
@@ -5926,8 +5925,8 @@
         </p:nvSpPr>
         <p:spPr>
           <a:xfrm>
-            <a:off x="7776084" y="3483864"/>
-            <a:ext cx="275226" cy="128016"/>
+            <a:off x="7717679" y="3410712"/>
+            <a:ext cx="293810" cy="182880"/>
           </a:xfrm>
           <a:prstGeom prst="rect">
             <a:avLst/>
@@ -5946,8 +5945,8 @@
         </p:nvSpPr>
         <p:spPr>
           <a:xfrm>
-            <a:off x="8070969" y="3483864"/>
-            <a:ext cx="275226" cy="128016"/>
+            <a:off x="8032475" y="3410712"/>
+            <a:ext cx="293810" cy="182880"/>
           </a:xfrm>
           <a:prstGeom prst="rect">
             <a:avLst/>
@@ -5966,8 +5965,8 @@
         </p:nvSpPr>
         <p:spPr>
           <a:xfrm>
-            <a:off x="8365854" y="3483864"/>
-            <a:ext cx="275226" cy="128016"/>
+            <a:off x="8347270" y="3410712"/>
+            <a:ext cx="293810" cy="182880"/>
           </a:xfrm>
           <a:prstGeom prst="rect">
             <a:avLst/>
@@ -5986,14 +5985,14 @@
         </p:nvSpPr>
         <p:spPr>
           <a:xfrm>
-            <a:off x="8641080" y="3291840"/>
-            <a:ext cx="0" cy="365760"/>
+            <a:off x="8641080" y="3145536"/>
+            <a:ext cx="0" cy="475488"/>
           </a:xfrm>
           <a:prstGeom prst="line">
             <a:avLst/>
           </a:prstGeom>
           <a:noFill/>
-          <a:ln w="19050">
+          <a:ln w="22225">
             <a:solidFill>
               <a:srgbClr val="890C58"/>
             </a:solidFill>
@@ -6009,8 +6008,8 @@
         </p:nvSpPr>
         <p:spPr>
           <a:xfrm>
-            <a:off x="4206362" y="3639312"/>
-            <a:ext cx="4480438" cy="146304"/>
+            <a:off x="3940881" y="3621024"/>
+            <a:ext cx="4745919" cy="146304"/>
           </a:xfrm>
           <a:prstGeom prst="rect">
             <a:avLst/>
@@ -6026,7 +6025,7 @@
               <a:buNone/>
             </a:pPr>
             <a:r>
-              <a:rPr lang="en-US" sz="800" i="1" dirty="0">
+              <a:rPr lang="en-US" sz="850" i="1" dirty="0">
                 <a:solidFill>
                   <a:srgbClr val="8C8C8C"/>
                 </a:solidFill>
@@ -6036,7 +6035,7 @@
               </a:rPr>
               <a:t>same compute, same bytes — the red line is where the step ends</a:t>
             </a:r>
-            <a:endParaRPr lang="en-US" sz="800" dirty="0"/>
+            <a:endParaRPr lang="en-US" sz="850" dirty="0"/>
           </a:p>
         </p:txBody>
       </p:sp>
@@ -6048,8 +6047,8 @@
         </p:nvSpPr>
         <p:spPr>
           <a:xfrm>
-            <a:off x="4206362" y="3785616"/>
-            <a:ext cx="4480438" cy="548640"/>
+            <a:off x="3940881" y="3785616"/>
+            <a:ext cx="4745919" cy="548640"/>
           </a:xfrm>
           <a:prstGeom prst="rect">
             <a:avLst/>
@@ -6068,7 +6067,7 @@
         </p:nvSpPr>
         <p:spPr>
           <a:xfrm>
-            <a:off x="4206362" y="3785616"/>
+            <a:off x="3940881" y="3785616"/>
             <a:ext cx="54864" cy="548640"/>
           </a:xfrm>
           <a:prstGeom prst="rect">
@@ -6088,8 +6087,8 @@
         </p:nvSpPr>
         <p:spPr>
           <a:xfrm>
-            <a:off x="4389242" y="3785616"/>
-            <a:ext cx="4206118" cy="548640"/>
+            <a:off x="4123761" y="3785616"/>
+            <a:ext cx="4471599" cy="548640"/>
           </a:xfrm>
           <a:prstGeom prst="rect">
             <a:avLst/>
@@ -12120,7 +12119,7 @@
         <p:spPr>
           <a:xfrm>
             <a:off x="411480" y="1234440"/>
-            <a:ext cx="3522026" cy="3017520"/>
+            <a:ext cx="3582313" cy="3017520"/>
           </a:xfrm>
           <a:prstGeom prst="rect">
             <a:avLst/>

</xml_diff>

<commit_message>
docs(slides): bucket-size mechanism (ipg double-buffer stall) on the comm page
</commit_message>
<xml_diff>
--- a/docs/slides/qwenpi-optimization.pptx
+++ b/docs/slides/qwenpi-optimization.pptx
@@ -3445,7 +3445,9 @@
           <a:p>
             <a:r>
               <a:rPr lang="en-US" dirty="0"/>
-              <a:t>Ledger method: exposed comm = NCCL busy while no compute kernel runs; idle = nothing on any stream.
+              <a:t>Mechanism source (DeepSpeed 0.16.9 stage_1_and_2.py): TWO ipg buffers allocated when overlap_comm (L2055, 'Use double buffers...'); average_tensor makes the compute stream wait_stream(reduction_stream) at every bucket boundary (L1061-1062) - the pipeline depth is one in-flight reduction.
+Variance collapse (±17.7 → ±3.4 ms) is the fingerprint of removing the random waits on the reduction stream.
+Ledger method: exposed comm = NCCL busy while no compute kernel runs; idle = nothing on any stream.
 Remaining exposed comm is gradient-readiness-bound, not hook- or bandwidth-bound — verified by intervention experiments.</a:t>
             </a:r>
             <a:endParaRPr lang="en-US" dirty="0"/>
@@ -6372,8 +6374,8 @@
         </p:nvSpPr>
         <p:spPr>
           <a:xfrm>
-            <a:off x="457200" y="1325880"/>
-            <a:ext cx="8229600" cy="1234440"/>
+            <a:off x="457200" y="1298448"/>
+            <a:ext cx="8229600" cy="1417320"/>
           </a:xfrm>
           <a:prstGeom prst="rect">
             <a:avLst/>
@@ -6390,7 +6392,7 @@
               <a:buChar char="•"/>
             </a:pPr>
             <a:r>
-              <a:rPr lang="en-US" sz="1200" dirty="0">
+              <a:rPr lang="en-US" sz="1050" dirty="0">
                 <a:solidFill>
                   <a:srgbClr val="000000"/>
                 </a:solidFill>
@@ -6398,9 +6400,9 @@
                 <a:ea typeface="NVIDIA Sans" pitchFamily="34" charset="-122"/>
                 <a:cs typeface="NVIDIA Sans" pitchFamily="34" charset="-120"/>
               </a:rPr>
-              <a:t>reduce_bucket_size 5e8 → 1.5e9: 6 gradient AllReduces per step instead of ~20, scoped to this model's config only</a:t>
-            </a:r>
-            <a:endParaRPr lang="en-US" sz="1200" dirty="0"/>
+              <a:t>Why bucket size matters: with overlap_comm, DeepSpeed double-buffers gradients into just TWO flat buckets — and at every bucket boundary the compute stream must wait on the reduction stream. Small buckets = frequent rendezvous → backward stalls behind its own AllReduces</a:t>
+            </a:r>
+            <a:endParaRPr lang="en-US" sz="1050" dirty="0"/>
           </a:p>
           <a:p>
             <a:pPr marL="342900" indent="-342900">
@@ -6408,7 +6410,7 @@
               <a:buChar char="•"/>
             </a:pPr>
             <a:r>
-              <a:rPr lang="en-US" sz="1200" dirty="0">
+              <a:rPr lang="en-US" sz="1050" dirty="0">
                 <a:solidFill>
                   <a:srgbClr val="000000"/>
                 </a:solidFill>
@@ -6416,9 +6418,9 @@
                 <a:ea typeface="NVIDIA Sans" pitchFamily="34" charset="-122"/>
                 <a:cs typeface="NVIDIA Sans" pitchFamily="34" charset="-120"/>
               </a:rPr>
-              <a:t>reduce_scatter=false: drops DeepSpeed's redundant per-bucket flatten (CatArrayBatchedCopy) ahead of each AllReduce</a:t>
-            </a:r>
-            <a:endParaRPr lang="en-US" sz="1200" dirty="0"/>
+              <a:t>5e8 → 1.5e9 elements: 15 → 6 buckets/step; the DiT's contiguous ~3e9-element gradient region drops from 6 buckets to 2 — measured −11.3 ms AND step variance ±17.7 → ±3.4 ms (2e9 is worse: the coarser tail exposes more comm)</a:t>
+            </a:r>
+            <a:endParaRPr lang="en-US" sz="1050" dirty="0"/>
           </a:p>
           <a:p>
             <a:pPr marL="342900" indent="-342900">
@@ -6426,7 +6428,7 @@
               <a:buChar char="•"/>
             </a:pPr>
             <a:r>
-              <a:rPr lang="en-US" sz="1200" dirty="0">
+              <a:rPr lang="en-US" sz="1050" dirty="0">
                 <a:solidFill>
                   <a:srgbClr val="000000"/>
                 </a:solidFill>
@@ -6434,9 +6436,27 @@
                 <a:ea typeface="NVIDIA Sans" pitchFamily="34" charset="-122"/>
                 <a:cs typeface="NVIDIA Sans" pitchFamily="34" charset="-120"/>
               </a:rPr>
-              <a:t>Verified NOT bandwidth-bound: AllReduce microbenchmark hits 478 GB/s bus bandwidth — the NVLink per-direction ceiling. The remaining exposed comm can only shrink by sending fewer bytes.</a:t>
-            </a:r>
-            <a:endParaRPr lang="en-US" sz="1200" dirty="0"/>
+              <a:t>reduce_scatter=false: drops DeepSpeed's redundant per-bucket flatten — the 22 ms of CatArrayBatchedCopy from the diagnosis page</a:t>
+            </a:r>
+            <a:endParaRPr lang="en-US" sz="1050" dirty="0"/>
+          </a:p>
+          <a:p>
+            <a:pPr marL="342900" indent="-342900">
+              <a:buSzPct val="100000"/>
+              <a:buChar char="•"/>
+            </a:pPr>
+            <a:r>
+              <a:rPr lang="en-US" sz="1050" dirty="0">
+                <a:solidFill>
+                  <a:srgbClr val="000000"/>
+                </a:solidFill>
+                <a:latin typeface="NVIDIA Sans" pitchFamily="34" charset="0"/>
+                <a:ea typeface="NVIDIA Sans" pitchFamily="34" charset="-122"/>
+                <a:cs typeface="NVIDIA Sans" pitchFamily="34" charset="-120"/>
+              </a:rPr>
+              <a:t>Not bandwidth-bound: AllReduce microbench hits 478 GB/s busbw = the NVLink ceiling — past config hygiene, only fewer bytes can shrink comm</a:t>
+            </a:r>
+            <a:endParaRPr lang="en-US" sz="1050" dirty="0"/>
           </a:p>
         </p:txBody>
       </p:sp>
@@ -6448,8 +6468,8 @@
         </p:nvSpPr>
         <p:spPr>
           <a:xfrm>
-            <a:off x="457200" y="2697480"/>
-            <a:ext cx="8229600" cy="274320"/>
+            <a:off x="457200" y="2788920"/>
+            <a:ext cx="8229600" cy="256032"/>
           </a:xfrm>
           <a:prstGeom prst="rect">
             <a:avLst/>
@@ -6487,7 +6507,7 @@
         </p:nvSpPr>
         <p:spPr>
           <a:xfrm>
-            <a:off x="640080" y="3044952"/>
+            <a:off x="640080" y="3108960"/>
             <a:ext cx="1463040" cy="310896"/>
           </a:xfrm>
           <a:prstGeom prst="rect">
@@ -6526,7 +6546,7 @@
         </p:nvSpPr>
         <p:spPr>
           <a:xfrm>
-            <a:off x="2148840" y="3063240"/>
+            <a:off x="2148840" y="3127248"/>
             <a:ext cx="3605332" cy="310896"/>
           </a:xfrm>
           <a:prstGeom prst="rect">
@@ -6546,7 +6566,7 @@
         </p:nvSpPr>
         <p:spPr>
           <a:xfrm>
-            <a:off x="2148840" y="3063240"/>
+            <a:off x="2148840" y="3127248"/>
             <a:ext cx="3605332" cy="310896"/>
           </a:xfrm>
           <a:prstGeom prst="rect">
@@ -6585,7 +6605,7 @@
         </p:nvSpPr>
         <p:spPr>
           <a:xfrm>
-            <a:off x="5754172" y="3063240"/>
+            <a:off x="5754172" y="3127248"/>
             <a:ext cx="411123" cy="310896"/>
           </a:xfrm>
           <a:prstGeom prst="rect">
@@ -6605,7 +6625,7 @@
         </p:nvSpPr>
         <p:spPr>
           <a:xfrm>
-            <a:off x="6165295" y="3063240"/>
+            <a:off x="6165295" y="3127248"/>
             <a:ext cx="1368852" cy="310896"/>
           </a:xfrm>
           <a:prstGeom prst="rect">
@@ -6625,7 +6645,7 @@
         </p:nvSpPr>
         <p:spPr>
           <a:xfrm>
-            <a:off x="6165295" y="3063240"/>
+            <a:off x="6165295" y="3127248"/>
             <a:ext cx="1368852" cy="310896"/>
           </a:xfrm>
           <a:prstGeom prst="rect">
@@ -6664,7 +6684,7 @@
         </p:nvSpPr>
         <p:spPr>
           <a:xfrm>
-            <a:off x="7589010" y="3063240"/>
+            <a:off x="7589010" y="3127248"/>
             <a:ext cx="822960" cy="310896"/>
           </a:xfrm>
           <a:prstGeom prst="rect">
@@ -6703,7 +6723,7 @@
         </p:nvSpPr>
         <p:spPr>
           <a:xfrm>
-            <a:off x="640080" y="3502152"/>
+            <a:off x="640080" y="3566160"/>
             <a:ext cx="1463040" cy="310896"/>
           </a:xfrm>
           <a:prstGeom prst="rect">
@@ -6742,7 +6762,7 @@
         </p:nvSpPr>
         <p:spPr>
           <a:xfrm>
-            <a:off x="2148840" y="3520440"/>
+            <a:off x="2148840" y="3584448"/>
             <a:ext cx="1169297" cy="310896"/>
           </a:xfrm>
           <a:prstGeom prst="rect">
@@ -6762,7 +6782,7 @@
         </p:nvSpPr>
         <p:spPr>
           <a:xfrm>
-            <a:off x="2148840" y="3520440"/>
+            <a:off x="2148840" y="3584448"/>
             <a:ext cx="1169297" cy="310896"/>
           </a:xfrm>
           <a:prstGeom prst="rect">
@@ -6801,7 +6821,7 @@
         </p:nvSpPr>
         <p:spPr>
           <a:xfrm>
-            <a:off x="3318137" y="3520440"/>
+            <a:off x="3318137" y="3584448"/>
             <a:ext cx="148164" cy="310896"/>
           </a:xfrm>
           <a:prstGeom prst="rect">
@@ -6821,7 +6841,7 @@
         </p:nvSpPr>
         <p:spPr>
           <a:xfrm>
-            <a:off x="3466301" y="3520440"/>
+            <a:off x="3466301" y="3584448"/>
             <a:ext cx="289655" cy="310896"/>
           </a:xfrm>
           <a:prstGeom prst="rect">
@@ -6841,7 +6861,7 @@
         </p:nvSpPr>
         <p:spPr>
           <a:xfrm>
-            <a:off x="3810820" y="3520440"/>
+            <a:off x="3810820" y="3584448"/>
             <a:ext cx="822960" cy="310896"/>
           </a:xfrm>
           <a:prstGeom prst="rect">
@@ -6880,7 +6900,7 @@
         </p:nvSpPr>
         <p:spPr>
           <a:xfrm>
-            <a:off x="2148840" y="4005072"/>
+            <a:off x="2148840" y="4059936"/>
             <a:ext cx="164592" cy="128016"/>
           </a:xfrm>
           <a:prstGeom prst="rect">
@@ -6900,7 +6920,7 @@
         </p:nvSpPr>
         <p:spPr>
           <a:xfrm>
-            <a:off x="2368296" y="3931920"/>
+            <a:off x="2368296" y="3986784"/>
             <a:ext cx="1600200" cy="274320"/>
           </a:xfrm>
           <a:prstGeom prst="rect">
@@ -6939,7 +6959,7 @@
         </p:nvSpPr>
         <p:spPr>
           <a:xfrm>
-            <a:off x="3977640" y="4005072"/>
+            <a:off x="3977640" y="4059936"/>
             <a:ext cx="164592" cy="128016"/>
           </a:xfrm>
           <a:prstGeom prst="rect">
@@ -6959,7 +6979,7 @@
         </p:nvSpPr>
         <p:spPr>
           <a:xfrm>
-            <a:off x="4197096" y="3931920"/>
+            <a:off x="4197096" y="3986784"/>
             <a:ext cx="1600200" cy="274320"/>
           </a:xfrm>
           <a:prstGeom prst="rect">
@@ -6998,7 +7018,7 @@
         </p:nvSpPr>
         <p:spPr>
           <a:xfrm>
-            <a:off x="5806440" y="4005072"/>
+            <a:off x="5806440" y="4059936"/>
             <a:ext cx="164592" cy="128016"/>
           </a:xfrm>
           <a:prstGeom prst="rect">
@@ -7018,7 +7038,7 @@
         </p:nvSpPr>
         <p:spPr>
           <a:xfrm>
-            <a:off x="6025896" y="3931920"/>
+            <a:off x="6025896" y="3986784"/>
             <a:ext cx="1600200" cy="274320"/>
           </a:xfrm>
           <a:prstGeom prst="rect">
@@ -7057,8 +7077,8 @@
         </p:nvSpPr>
         <p:spPr>
           <a:xfrm>
-            <a:off x="457200" y="4224528"/>
-            <a:ext cx="8229600" cy="228600"/>
+            <a:off x="457200" y="4261104"/>
+            <a:ext cx="8229600" cy="182880"/>
           </a:xfrm>
           <a:prstGeom prst="rect">
             <a:avLst/>
@@ -7082,7 +7102,7 @@
                 <a:ea typeface="NVIDIA Sans" pitchFamily="34" charset="-122"/>
                 <a:cs typeface="NVIDIA Sans" pitchFamily="34" charset="-120"/>
               </a:rPr>
-              <a:t>Gradient AllReduce 15.1 GB/step + optimizer AllGather 15.1 GB/step (bf16). Idle from 254 ms to 43 ms.</a:t>
+              <a:t>Gradient AllReduce 15.1 GB/step + optimizer AllGather 15.1 GB/step (bf16). Idle from 205 ms to 43 ms.</a:t>
             </a:r>
             <a:endParaRPr lang="en-US" sz="950" dirty="0"/>
           </a:p>

</xml_diff>

<commit_message>
docs(slides): two-knob comm page with real bucket A/B stall lanes; AllGather/FSDP future direction
</commit_message>
<xml_diff>
--- a/docs/slides/qwenpi-optimization.pptx
+++ b/docs/slides/qwenpi-optimization.pptx
@@ -3445,10 +3445,9 @@
           <a:p>
             <a:r>
               <a:rPr lang="en-US" dirty="0"/>
-              <a:t>Mechanism source (DeepSpeed 0.16.9 stage_1_and_2.py): TWO ipg buffers allocated when overlap_comm (L2055, 'Use double buffers...'); average_tensor makes the compute stream wait_stream(reduction_stream) at every bucket boundary (L1061-1062) - the pipeline depth is one in-flight reduction.
-Variance collapse (±17.7 → ±3.4 ms) is the fingerprint of removing the random waits on the reduction stream.
-Ledger method: exposed comm = NCCL busy while no compute kernel runs; idle = nothing on any stream.
-Remaining exposed comm is gradient-readiness-bound, not hook- or bandwidth-bound — verified by intervention experiments.</a:t>
+              <a:t>Mechanism source (DeepSpeed 0.16.9 stage_1_and_2.py): TWO ipg buffers when overlap_comm (L2055); average_tensor enqueues compute.wait_stream(reduction_stream) at every bucket boundary (L1061-1062) - pipeline depth is one in-flight reduction.
+A/B re-captured on viking-prod-303 with node-level graph trace: 5e8 = 261 ms/step (std 4.2), 1.5e9 = 249 ms (std 3.9); AR busy equal within 1 ms (same bytes). Original-branch sweep: 2e9 was +4.7 ms; variance collapse +-17.7 -&gt; +-3.4 recorded there.
+Final ledger (moved off-slide): baseline 807 = 540 busy + 62 exposed + 205 idle; optimized 249 = 175 + 22 + 43.</a:t>
             </a:r>
             <a:endParaRPr lang="en-US" dirty="0"/>
           </a:p>
@@ -3712,7 +3711,8 @@
           <a:p>
             <a:r>
               <a:rPr lang="en-US" dirty="0"/>
-              <a:t>Everything shipped is one MR per optimization with measured before/after — the repo history is the reproducibility story.
+              <a:t>AllGather card: optimizer math itself (~26 ms busy) has a separate compiled-autograd / fused-optimizer lever; the 44 ms AllGather is the structural ZeRO-2 limit.
+Everything shipped is one MR per optimization with measured before/after — the repo history is the reproducibility story.
 [IMPORTANT] Close: 3.2x is banked; the roadmap above is how we keep going.</a:t>
             </a:r>
             <a:endParaRPr lang="en-US" dirty="0"/>
@@ -6321,7 +6321,7 @@
                 <a:ea typeface="NVIDIA Sans" pitchFamily="34" charset="-122"/>
                 <a:cs typeface="NVIDIA Sans" pitchFamily="34" charset="-120"/>
               </a:rPr>
-              <a:t>ZeRO-2 Comm Tuning &amp; the Final Ledger</a:t>
+              <a:t>ZeRO-2 Comm Tuning: Two Knobs</a:t>
             </a:r>
             <a:endParaRPr lang="en-US" sz="3000" dirty="0"/>
           </a:p>
@@ -6360,7 +6360,7 @@
                 <a:ea typeface="NVIDIA Sans" pitchFamily="34" charset="-122"/>
                 <a:cs typeface="NVIDIA Sans" pitchFamily="34" charset="-120"/>
               </a:rPr>
-              <a:t>271 → 249 ms.  Fewer, larger collectives — and an honest ledger of what remains</a:t>
+              <a:t>271 → 249 ms.  Two different problems: a redundant flatten, and a blocked backward</a:t>
             </a:r>
             <a:endParaRPr lang="en-US" sz="1500" dirty="0"/>
           </a:p>
@@ -6368,14 +6368,93 @@
       </p:sp>
       <p:sp>
         <p:nvSpPr>
-          <p:cNvPr id="4" name="Text 2"/>
-          <p:cNvSpPr/>
-          <p:nvPr/>
-        </p:nvSpPr>
-        <p:spPr>
-          <a:xfrm>
-            <a:off x="457200" y="1298448"/>
-            <a:ext cx="8229600" cy="1417320"/>
+          <p:cNvPr id="4" name="Shape 2"/>
+          <p:cNvSpPr/>
+          <p:nvPr/>
+        </p:nvSpPr>
+        <p:spPr>
+          <a:xfrm>
+            <a:off x="457200" y="1188720"/>
+            <a:ext cx="4023360" cy="969264"/>
+          </a:xfrm>
+          <a:prstGeom prst="rect">
+            <a:avLst/>
+          </a:prstGeom>
+          <a:solidFill>
+            <a:srgbClr val="F5F5F5"/>
+          </a:solidFill>
+          <a:ln/>
+        </p:spPr>
+      </p:sp>
+      <p:sp>
+        <p:nvSpPr>
+          <p:cNvPr id="5" name="Shape 3"/>
+          <p:cNvSpPr/>
+          <p:nvPr/>
+        </p:nvSpPr>
+        <p:spPr>
+          <a:xfrm>
+            <a:off x="457200" y="1188720"/>
+            <a:ext cx="54864" cy="969264"/>
+          </a:xfrm>
+          <a:prstGeom prst="rect">
+            <a:avLst/>
+          </a:prstGeom>
+          <a:solidFill>
+            <a:srgbClr val="76B900"/>
+          </a:solidFill>
+          <a:ln/>
+        </p:spPr>
+      </p:sp>
+      <p:sp>
+        <p:nvSpPr>
+          <p:cNvPr id="6" name="Text 4"/>
+          <p:cNvSpPr/>
+          <p:nvPr/>
+        </p:nvSpPr>
+        <p:spPr>
+          <a:xfrm>
+            <a:off x="621792" y="1243584"/>
+            <a:ext cx="3749040" cy="219456"/>
+          </a:xfrm>
+          <a:prstGeom prst="rect">
+            <a:avLst/>
+          </a:prstGeom>
+          <a:noFill/>
+          <a:ln/>
+        </p:spPr>
+        <p:txBody>
+          <a:bodyPr wrap="square" lIns="0" tIns="0" rIns="0" bIns="0" rtlCol="0" anchor="ctr"/>
+          <a:lstStyle/>
+          <a:p>
+            <a:pPr indent="0" marL="0">
+              <a:buNone/>
+            </a:pPr>
+            <a:r>
+              <a:rPr lang="en-US" sz="1150" b="1" dirty="0">
+                <a:solidFill>
+                  <a:srgbClr val="000000"/>
+                </a:solidFill>
+                <a:latin typeface="NVIDIA Sans" pitchFamily="34" charset="0"/>
+                <a:ea typeface="NVIDIA Sans" pitchFamily="34" charset="-122"/>
+                <a:cs typeface="NVIDIA Sans" pitchFamily="34" charset="-120"/>
+              </a:rPr>
+              <a:t>Knob 1 · reduce_scatter → false   (−13 ms)</a:t>
+            </a:r>
+            <a:endParaRPr lang="en-US" sz="1150" dirty="0"/>
+          </a:p>
+        </p:txBody>
+      </p:sp>
+      <p:sp>
+        <p:nvSpPr>
+          <p:cNvPr id="7" name="Text 5"/>
+          <p:cNvSpPr/>
+          <p:nvPr/>
+        </p:nvSpPr>
+        <p:spPr>
+          <a:xfrm>
+            <a:off x="621792" y="1481328"/>
+            <a:ext cx="3749040" cy="658368"/>
           </a:xfrm>
           <a:prstGeom prst="rect">
             <a:avLst/>
@@ -6392,7 +6471,7 @@
               <a:buChar char="•"/>
             </a:pPr>
             <a:r>
-              <a:rPr lang="en-US" sz="1050" dirty="0">
+              <a:rPr lang="en-US" sz="900" dirty="0">
                 <a:solidFill>
                   <a:srgbClr val="000000"/>
                 </a:solidFill>
@@ -6400,9 +6479,9 @@
                 <a:ea typeface="NVIDIA Sans" pitchFamily="34" charset="-122"/>
                 <a:cs typeface="NVIDIA Sans" pitchFamily="34" charset="-120"/>
               </a:rPr>
-              <a:t>Why bucket size matters: with overlap_comm, DeepSpeed double-buffers gradients into just TWO flat buckets — and at every bucket boundary the compute stream must wait on the reduction stream. Small buckets = frequent rendezvous → backward stalls behind its own AllReduces</a:t>
+              <a:t>Default path flattens every bucket (22 ms/step CatArrayBatchedCopy) — but grads already sit contiguous</a:t>
             </a:r>
-            <a:endParaRPr lang="en-US" sz="1050" dirty="0"/>
+            <a:endParaRPr lang="en-US" sz="900" dirty="0"/>
           </a:p>
           <a:p>
             <a:pPr marL="342900" indent="-342900">
@@ -6410,7 +6489,7 @@
               <a:buChar char="•"/>
             </a:pPr>
             <a:r>
-              <a:rPr lang="en-US" sz="1050" dirty="0">
+              <a:rPr lang="en-US" sz="900" dirty="0">
                 <a:solidFill>
                   <a:srgbClr val="000000"/>
                 </a:solidFill>
@@ -6418,58 +6497,62 @@
                 <a:ea typeface="NVIDIA Sans" pitchFamily="34" charset="-122"/>
                 <a:cs typeface="NVIDIA Sans" pitchFamily="34" charset="-120"/>
               </a:rPr>
-              <a:t>5e8 → 1.5e9 elements: 15 → 6 buckets/step; the DiT's contiguous ~3e9-element gradient region drops from 6 buckets to 2 — measured −11.3 ms AND step variance ±17.7 → ±3.4 ms (2e9 is worse: the coarser tail exposes more comm)</a:t>
+              <a:t>Plain AllReduce skips it. Cost: ~2× wire bytes — fine while comm overlaps and NVLink has headroom</a:t>
             </a:r>
-            <a:endParaRPr lang="en-US" sz="1050" dirty="0"/>
-          </a:p>
-          <a:p>
-            <a:pPr marL="342900" indent="-342900">
-              <a:buSzPct val="100000"/>
-              <a:buChar char="•"/>
-            </a:pPr>
-            <a:r>
-              <a:rPr lang="en-US" sz="1050" dirty="0">
-                <a:solidFill>
-                  <a:srgbClr val="000000"/>
-                </a:solidFill>
-                <a:latin typeface="NVIDIA Sans" pitchFamily="34" charset="0"/>
-                <a:ea typeface="NVIDIA Sans" pitchFamily="34" charset="-122"/>
-                <a:cs typeface="NVIDIA Sans" pitchFamily="34" charset="-120"/>
-              </a:rPr>
-              <a:t>reduce_scatter=false: drops DeepSpeed's redundant per-bucket flatten — the 22 ms of CatArrayBatchedCopy from the diagnosis page</a:t>
-            </a:r>
-            <a:endParaRPr lang="en-US" sz="1050" dirty="0"/>
-          </a:p>
-          <a:p>
-            <a:pPr marL="342900" indent="-342900">
-              <a:buSzPct val="100000"/>
-              <a:buChar char="•"/>
-            </a:pPr>
-            <a:r>
-              <a:rPr lang="en-US" sz="1050" dirty="0">
-                <a:solidFill>
-                  <a:srgbClr val="000000"/>
-                </a:solidFill>
-                <a:latin typeface="NVIDIA Sans" pitchFamily="34" charset="0"/>
-                <a:ea typeface="NVIDIA Sans" pitchFamily="34" charset="-122"/>
-                <a:cs typeface="NVIDIA Sans" pitchFamily="34" charset="-120"/>
-              </a:rPr>
-              <a:t>Not bandwidth-bound: AllReduce microbench hits 478 GB/s busbw = the NVLink ceiling — past config hygiene, only fewer bytes can shrink comm</a:t>
-            </a:r>
-            <a:endParaRPr lang="en-US" sz="1050" dirty="0"/>
+            <a:endParaRPr lang="en-US" sz="900" dirty="0"/>
           </a:p>
         </p:txBody>
       </p:sp>
       <p:sp>
         <p:nvSpPr>
-          <p:cNvPr id="5" name="Text 3"/>
-          <p:cNvSpPr/>
-          <p:nvPr/>
-        </p:nvSpPr>
-        <p:spPr>
-          <a:xfrm>
-            <a:off x="457200" y="2788920"/>
-            <a:ext cx="8229600" cy="256032"/>
+          <p:cNvPr id="8" name="Shape 6"/>
+          <p:cNvSpPr/>
+          <p:nvPr/>
+        </p:nvSpPr>
+        <p:spPr>
+          <a:xfrm>
+            <a:off x="4663440" y="1188720"/>
+            <a:ext cx="4023360" cy="969264"/>
+          </a:xfrm>
+          <a:prstGeom prst="rect">
+            <a:avLst/>
+          </a:prstGeom>
+          <a:solidFill>
+            <a:srgbClr val="F5F5F5"/>
+          </a:solidFill>
+          <a:ln/>
+        </p:spPr>
+      </p:sp>
+      <p:sp>
+        <p:nvSpPr>
+          <p:cNvPr id="9" name="Shape 7"/>
+          <p:cNvSpPr/>
+          <p:nvPr/>
+        </p:nvSpPr>
+        <p:spPr>
+          <a:xfrm>
+            <a:off x="4663440" y="1188720"/>
+            <a:ext cx="54864" cy="969264"/>
+          </a:xfrm>
+          <a:prstGeom prst="rect">
+            <a:avLst/>
+          </a:prstGeom>
+          <a:solidFill>
+            <a:srgbClr val="76B900"/>
+          </a:solidFill>
+          <a:ln/>
+        </p:spPr>
+      </p:sp>
+      <p:sp>
+        <p:nvSpPr>
+          <p:cNvPr id="10" name="Text 8"/>
+          <p:cNvSpPr/>
+          <p:nvPr/>
+        </p:nvSpPr>
+        <p:spPr>
+          <a:xfrm>
+            <a:off x="4828032" y="1243584"/>
+            <a:ext cx="3749040" cy="219456"/>
           </a:xfrm>
           <a:prstGeom prst="rect">
             <a:avLst/>
@@ -6485,7 +6568,7 @@
               <a:buNone/>
             </a:pPr>
             <a:r>
-              <a:rPr lang="en-US" sz="1300" b="1" dirty="0">
+              <a:rPr lang="en-US" sz="1150" b="1" dirty="0">
                 <a:solidFill>
                   <a:srgbClr val="000000"/>
                 </a:solidFill>
@@ -6493,22 +6576,80 @@
                 <a:ea typeface="NVIDIA Sans" pitchFamily="34" charset="-122"/>
                 <a:cs typeface="NVIDIA Sans" pitchFamily="34" charset="-120"/>
               </a:rPr>
-              <a:t>Per-step time ledger (same accounting, one steady step from each nsys capture)</a:t>
+              <a:t>Knob 2 · reduce_bucket_size → 1.5e9   (−12 ms)</a:t>
             </a:r>
-            <a:endParaRPr lang="en-US" sz="1300" dirty="0"/>
+            <a:endParaRPr lang="en-US" sz="1150" dirty="0"/>
           </a:p>
         </p:txBody>
       </p:sp>
       <p:sp>
         <p:nvSpPr>
-          <p:cNvPr id="6" name="Text 4"/>
-          <p:cNvSpPr/>
-          <p:nvPr/>
-        </p:nvSpPr>
-        <p:spPr>
-          <a:xfrm>
-            <a:off x="640080" y="3108960"/>
-            <a:ext cx="1463040" cy="310896"/>
+          <p:cNvPr id="11" name="Text 9"/>
+          <p:cNvSpPr/>
+          <p:nvPr/>
+        </p:nvSpPr>
+        <p:spPr>
+          <a:xfrm>
+            <a:off x="4828032" y="1481328"/>
+            <a:ext cx="3749040" cy="658368"/>
+          </a:xfrm>
+          <a:prstGeom prst="rect">
+            <a:avLst/>
+          </a:prstGeom>
+          <a:noFill/>
+          <a:ln/>
+        </p:spPr>
+        <p:txBody>
+          <a:bodyPr wrap="square" lIns="0" tIns="0" rIns="0" bIns="0" rtlCol="0" anchor="t"/>
+          <a:lstStyle/>
+          <a:p>
+            <a:pPr marL="342900" indent="-342900">
+              <a:buSzPct val="100000"/>
+              <a:buChar char="•"/>
+            </a:pPr>
+            <a:r>
+              <a:rPr lang="en-US" sz="900" dirty="0">
+                <a:solidFill>
+                  <a:srgbClr val="000000"/>
+                </a:solidFill>
+                <a:latin typeface="NVIDIA Sans" pitchFamily="34" charset="0"/>
+                <a:ea typeface="NVIDIA Sans" pitchFamily="34" charset="-122"/>
+                <a:cs typeface="NVIDIA Sans" pitchFamily="34" charset="-120"/>
+              </a:rPr>
+              <a:t>Grads double-buffer into TWO buckets; every boundary makes compute wait on the reduction stream</a:t>
+            </a:r>
+            <a:endParaRPr lang="en-US" sz="900" dirty="0"/>
+          </a:p>
+          <a:p>
+            <a:pPr marL="342900" indent="-342900">
+              <a:buSzPct val="100000"/>
+              <a:buChar char="•"/>
+            </a:pPr>
+            <a:r>
+              <a:rPr lang="en-US" sz="900" dirty="0">
+                <a:solidFill>
+                  <a:srgbClr val="000000"/>
+                </a:solidFill>
+                <a:latin typeface="NVIDIA Sans" pitchFamily="34" charset="0"/>
+                <a:ea typeface="NVIDIA Sans" pitchFamily="34" charset="-122"/>
+                <a:cs typeface="NVIDIA Sans" pitchFamily="34" charset="-120"/>
+              </a:rPr>
+              <a:t>Too small → backward stalls behind its own AllReduces (below). Too big → exposed tail (2e9 worse)</a:t>
+            </a:r>
+            <a:endParaRPr lang="en-US" sz="900" dirty="0"/>
+          </a:p>
+        </p:txBody>
+      </p:sp>
+      <p:sp>
+        <p:nvSpPr>
+          <p:cNvPr id="12" name="Text 10"/>
+          <p:cNvSpPr/>
+          <p:nvPr/>
+        </p:nvSpPr>
+        <p:spPr>
+          <a:xfrm>
+            <a:off x="457200" y="2304288"/>
+            <a:ext cx="8229600" cy="182880"/>
           </a:xfrm>
           <a:prstGeom prst="rect">
             <a:avLst/>
@@ -6524,7 +6665,7 @@
               <a:buNone/>
             </a:pPr>
             <a:r>
-              <a:rPr lang="en-US" sz="1100" b="1" dirty="0">
+              <a:rPr lang="en-US" sz="1050" b="1" dirty="0">
                 <a:solidFill>
                   <a:srgbClr val="000000"/>
                 </a:solidFill>
@@ -6532,42 +6673,22 @@
                 <a:ea typeface="NVIDIA Sans" pitchFamily="34" charset="-122"/>
                 <a:cs typeface="NVIDIA Sans" pitchFamily="34" charset="-120"/>
               </a:rPr>
-              <a:t>Baseline</a:t>
+              <a:t>bucket 5e8 — backward 167 ms · 18 AllReduces · 15 stalls, 47 ms of blocked compute</a:t>
             </a:r>
-            <a:endParaRPr lang="en-US" sz="1100" dirty="0"/>
+            <a:endParaRPr lang="en-US" sz="1050" dirty="0"/>
           </a:p>
         </p:txBody>
       </p:sp>
       <p:sp>
         <p:nvSpPr>
-          <p:cNvPr id="7" name="Shape 5"/>
-          <p:cNvSpPr/>
-          <p:nvPr/>
-        </p:nvSpPr>
-        <p:spPr>
-          <a:xfrm>
-            <a:off x="2148840" y="3127248"/>
-            <a:ext cx="3605332" cy="310896"/>
-          </a:xfrm>
-          <a:prstGeom prst="rect">
-            <a:avLst/>
-          </a:prstGeom>
-          <a:solidFill>
-            <a:srgbClr val="76B900"/>
-          </a:solidFill>
-          <a:ln/>
-        </p:spPr>
-      </p:sp>
-      <p:sp>
-        <p:nvSpPr>
-          <p:cNvPr id="8" name="Text 6"/>
-          <p:cNvSpPr/>
-          <p:nvPr/>
-        </p:nvSpPr>
-        <p:spPr>
-          <a:xfrm>
-            <a:off x="2148840" y="3127248"/>
-            <a:ext cx="3605332" cy="310896"/>
+          <p:cNvPr id="13" name="Text 11"/>
+          <p:cNvSpPr/>
+          <p:nvPr/>
+        </p:nvSpPr>
+        <p:spPr>
+          <a:xfrm>
+            <a:off x="457200" y="2523744"/>
+            <a:ext cx="713232" cy="201168"/>
           </a:xfrm>
           <a:prstGeom prst="rect">
             <a:avLst/>
@@ -6579,90 +6700,11 @@
           <a:bodyPr wrap="square" lIns="0" tIns="0" rIns="0" bIns="0" rtlCol="0" anchor="ctr"/>
           <a:lstStyle/>
           <a:p>
-            <a:pPr algn="ctr" indent="0" marL="0">
+            <a:pPr algn="r" indent="0" marL="0">
               <a:buNone/>
             </a:pPr>
             <a:r>
-              <a:rPr lang="en-US" sz="1000" b="1" dirty="0">
-                <a:solidFill>
-                  <a:srgbClr val="FFFFFF"/>
-                </a:solidFill>
-                <a:latin typeface="NVIDIA Sans" pitchFamily="34" charset="0"/>
-                <a:ea typeface="NVIDIA Sans" pitchFamily="34" charset="-122"/>
-                <a:cs typeface="NVIDIA Sans" pitchFamily="34" charset="-120"/>
-              </a:rPr>
-              <a:t>540</a:t>
-            </a:r>
-            <a:endParaRPr lang="en-US" sz="1000" dirty="0"/>
-          </a:p>
-        </p:txBody>
-      </p:sp>
-      <p:sp>
-        <p:nvSpPr>
-          <p:cNvPr id="9" name="Shape 7"/>
-          <p:cNvSpPr/>
-          <p:nvPr/>
-        </p:nvSpPr>
-        <p:spPr>
-          <a:xfrm>
-            <a:off x="5754172" y="3127248"/>
-            <a:ext cx="411123" cy="310896"/>
-          </a:xfrm>
-          <a:prstGeom prst="rect">
-            <a:avLst/>
-          </a:prstGeom>
-          <a:solidFill>
-            <a:srgbClr val="0071C5"/>
-          </a:solidFill>
-          <a:ln/>
-        </p:spPr>
-      </p:sp>
-      <p:sp>
-        <p:nvSpPr>
-          <p:cNvPr id="10" name="Shape 8"/>
-          <p:cNvSpPr/>
-          <p:nvPr/>
-        </p:nvSpPr>
-        <p:spPr>
-          <a:xfrm>
-            <a:off x="6165295" y="3127248"/>
-            <a:ext cx="1368852" cy="310896"/>
-          </a:xfrm>
-          <a:prstGeom prst="rect">
-            <a:avLst/>
-          </a:prstGeom>
-          <a:solidFill>
-            <a:srgbClr val="D9D9D9"/>
-          </a:solidFill>
-          <a:ln/>
-        </p:spPr>
-      </p:sp>
-      <p:sp>
-        <p:nvSpPr>
-          <p:cNvPr id="11" name="Text 9"/>
-          <p:cNvSpPr/>
-          <p:nvPr/>
-        </p:nvSpPr>
-        <p:spPr>
-          <a:xfrm>
-            <a:off x="6165295" y="3127248"/>
-            <a:ext cx="1368852" cy="310896"/>
-          </a:xfrm>
-          <a:prstGeom prst="rect">
-            <a:avLst/>
-          </a:prstGeom>
-          <a:noFill/>
-          <a:ln/>
-        </p:spPr>
-        <p:txBody>
-          <a:bodyPr wrap="square" lIns="0" tIns="0" rIns="0" bIns="0" rtlCol="0" anchor="ctr"/>
-          <a:lstStyle/>
-          <a:p>
-            <a:pPr algn="ctr" indent="0" marL="0">
-              <a:buNone/>
-            </a:pPr>
-            <a:r>
-              <a:rPr lang="en-US" sz="1000" b="1" dirty="0">
+              <a:rPr lang="en-US" sz="850" dirty="0">
                 <a:solidFill>
                   <a:srgbClr val="5E5E5E"/>
                 </a:solidFill>
@@ -6670,22 +6712,1061 @@
                 <a:ea typeface="NVIDIA Sans" pitchFamily="34" charset="-122"/>
                 <a:cs typeface="NVIDIA Sans" pitchFamily="34" charset="-120"/>
               </a:rPr>
-              <a:t>205</a:t>
+              <a:t>Compute</a:t>
             </a:r>
-            <a:endParaRPr lang="en-US" sz="1000" dirty="0"/>
+            <a:endParaRPr lang="en-US" sz="850" dirty="0"/>
           </a:p>
         </p:txBody>
       </p:sp>
       <p:sp>
         <p:nvSpPr>
-          <p:cNvPr id="12" name="Text 10"/>
-          <p:cNvSpPr/>
-          <p:nvPr/>
-        </p:nvSpPr>
-        <p:spPr>
-          <a:xfrm>
-            <a:off x="7589010" y="3127248"/>
-            <a:ext cx="822960" cy="310896"/>
+          <p:cNvPr id="14" name="Shape 12"/>
+          <p:cNvSpPr/>
+          <p:nvPr/>
+        </p:nvSpPr>
+        <p:spPr>
+          <a:xfrm>
+            <a:off x="1234440" y="2523744"/>
+            <a:ext cx="7360920" cy="201168"/>
+          </a:xfrm>
+          <a:prstGeom prst="rect">
+            <a:avLst/>
+          </a:prstGeom>
+          <a:solidFill>
+            <a:srgbClr val="F0F0F0"/>
+          </a:solidFill>
+          <a:ln/>
+        </p:spPr>
+      </p:sp>
+      <p:sp>
+        <p:nvSpPr>
+          <p:cNvPr id="15" name="Text 13"/>
+          <p:cNvSpPr/>
+          <p:nvPr/>
+        </p:nvSpPr>
+        <p:spPr>
+          <a:xfrm>
+            <a:off x="457200" y="2761488"/>
+            <a:ext cx="713232" cy="201168"/>
+          </a:xfrm>
+          <a:prstGeom prst="rect">
+            <a:avLst/>
+          </a:prstGeom>
+          <a:noFill/>
+          <a:ln/>
+        </p:spPr>
+        <p:txBody>
+          <a:bodyPr wrap="square" lIns="0" tIns="0" rIns="0" bIns="0" rtlCol="0" anchor="ctr"/>
+          <a:lstStyle/>
+          <a:p>
+            <a:pPr algn="r" indent="0" marL="0">
+              <a:buNone/>
+            </a:pPr>
+            <a:r>
+              <a:rPr lang="en-US" sz="850" dirty="0">
+                <a:solidFill>
+                  <a:srgbClr val="5E5E5E"/>
+                </a:solidFill>
+                <a:latin typeface="NVIDIA Sans" pitchFamily="34" charset="0"/>
+                <a:ea typeface="NVIDIA Sans" pitchFamily="34" charset="-122"/>
+                <a:cs typeface="NVIDIA Sans" pitchFamily="34" charset="-120"/>
+              </a:rPr>
+              <a:t>NCCL AR</a:t>
+            </a:r>
+            <a:endParaRPr lang="en-US" sz="850" dirty="0"/>
+          </a:p>
+        </p:txBody>
+      </p:sp>
+      <p:sp>
+        <p:nvSpPr>
+          <p:cNvPr id="16" name="Shape 14"/>
+          <p:cNvSpPr/>
+          <p:nvPr/>
+        </p:nvSpPr>
+        <p:spPr>
+          <a:xfrm>
+            <a:off x="1234440" y="2761488"/>
+            <a:ext cx="7360920" cy="201168"/>
+          </a:xfrm>
+          <a:prstGeom prst="rect">
+            <a:avLst/>
+          </a:prstGeom>
+          <a:solidFill>
+            <a:srgbClr val="F0F0F0"/>
+          </a:solidFill>
+          <a:ln/>
+        </p:spPr>
+      </p:sp>
+      <p:sp>
+        <p:nvSpPr>
+          <p:cNvPr id="17" name="Shape 15"/>
+          <p:cNvSpPr/>
+          <p:nvPr/>
+        </p:nvSpPr>
+        <p:spPr>
+          <a:xfrm>
+            <a:off x="1234873" y="2542032"/>
+            <a:ext cx="1204160" cy="164592"/>
+          </a:xfrm>
+          <a:prstGeom prst="rect">
+            <a:avLst/>
+          </a:prstGeom>
+          <a:solidFill>
+            <a:srgbClr val="76B900"/>
+          </a:solidFill>
+          <a:ln/>
+        </p:spPr>
+      </p:sp>
+      <p:sp>
+        <p:nvSpPr>
+          <p:cNvPr id="18" name="Shape 16"/>
+          <p:cNvSpPr/>
+          <p:nvPr/>
+        </p:nvSpPr>
+        <p:spPr>
+          <a:xfrm>
+            <a:off x="2665922" y="2542032"/>
+            <a:ext cx="20351" cy="164592"/>
+          </a:xfrm>
+          <a:prstGeom prst="rect">
+            <a:avLst/>
+          </a:prstGeom>
+          <a:solidFill>
+            <a:srgbClr val="76B900"/>
+          </a:solidFill>
+          <a:ln/>
+        </p:spPr>
+      </p:sp>
+      <p:sp>
+        <p:nvSpPr>
+          <p:cNvPr id="19" name="Shape 17"/>
+          <p:cNvSpPr/>
+          <p:nvPr/>
+        </p:nvSpPr>
+        <p:spPr>
+          <a:xfrm>
+            <a:off x="2879822" y="2542032"/>
+            <a:ext cx="19918" cy="164592"/>
+          </a:xfrm>
+          <a:prstGeom prst="rect">
+            <a:avLst/>
+          </a:prstGeom>
+          <a:solidFill>
+            <a:srgbClr val="76B900"/>
+          </a:solidFill>
+          <a:ln/>
+        </p:spPr>
+      </p:sp>
+      <p:sp>
+        <p:nvSpPr>
+          <p:cNvPr id="20" name="Shape 18"/>
+          <p:cNvSpPr/>
+          <p:nvPr/>
+        </p:nvSpPr>
+        <p:spPr>
+          <a:xfrm>
+            <a:off x="3089825" y="2542032"/>
+            <a:ext cx="19918" cy="164592"/>
+          </a:xfrm>
+          <a:prstGeom prst="rect">
+            <a:avLst/>
+          </a:prstGeom>
+          <a:solidFill>
+            <a:srgbClr val="76B900"/>
+          </a:solidFill>
+          <a:ln/>
+        </p:spPr>
+      </p:sp>
+      <p:sp>
+        <p:nvSpPr>
+          <p:cNvPr id="21" name="Shape 19"/>
+          <p:cNvSpPr/>
+          <p:nvPr/>
+        </p:nvSpPr>
+        <p:spPr>
+          <a:xfrm>
+            <a:off x="3300694" y="2542032"/>
+            <a:ext cx="19918" cy="164592"/>
+          </a:xfrm>
+          <a:prstGeom prst="rect">
+            <a:avLst/>
+          </a:prstGeom>
+          <a:solidFill>
+            <a:srgbClr val="76B900"/>
+          </a:solidFill>
+          <a:ln/>
+        </p:spPr>
+      </p:sp>
+      <p:sp>
+        <p:nvSpPr>
+          <p:cNvPr id="22" name="Shape 20"/>
+          <p:cNvSpPr/>
+          <p:nvPr/>
+        </p:nvSpPr>
+        <p:spPr>
+          <a:xfrm>
+            <a:off x="3363045" y="2542032"/>
+            <a:ext cx="11691" cy="164592"/>
+          </a:xfrm>
+          <a:prstGeom prst="rect">
+            <a:avLst/>
+          </a:prstGeom>
+          <a:solidFill>
+            <a:srgbClr val="76B900"/>
+          </a:solidFill>
+          <a:ln/>
+        </p:spPr>
+      </p:sp>
+      <p:sp>
+        <p:nvSpPr>
+          <p:cNvPr id="23" name="Shape 21"/>
+          <p:cNvSpPr/>
+          <p:nvPr/>
+        </p:nvSpPr>
+        <p:spPr>
+          <a:xfrm>
+            <a:off x="3503768" y="2542032"/>
+            <a:ext cx="763371" cy="164592"/>
+          </a:xfrm>
+          <a:prstGeom prst="rect">
+            <a:avLst/>
+          </a:prstGeom>
+          <a:solidFill>
+            <a:srgbClr val="76B900"/>
+          </a:solidFill>
+          <a:ln/>
+        </p:spPr>
+      </p:sp>
+      <p:sp>
+        <p:nvSpPr>
+          <p:cNvPr id="24" name="Shape 22"/>
+          <p:cNvSpPr/>
+          <p:nvPr/>
+        </p:nvSpPr>
+        <p:spPr>
+          <a:xfrm>
+            <a:off x="4338150" y="2542032"/>
+            <a:ext cx="692359" cy="164592"/>
+          </a:xfrm>
+          <a:prstGeom prst="rect">
+            <a:avLst/>
+          </a:prstGeom>
+          <a:solidFill>
+            <a:srgbClr val="76B900"/>
+          </a:solidFill>
+          <a:ln/>
+        </p:spPr>
+      </p:sp>
+      <p:sp>
+        <p:nvSpPr>
+          <p:cNvPr id="25" name="Shape 23"/>
+          <p:cNvSpPr/>
+          <p:nvPr/>
+        </p:nvSpPr>
+        <p:spPr>
+          <a:xfrm>
+            <a:off x="5212368" y="2542032"/>
+            <a:ext cx="19918" cy="164592"/>
+          </a:xfrm>
+          <a:prstGeom prst="rect">
+            <a:avLst/>
+          </a:prstGeom>
+          <a:solidFill>
+            <a:srgbClr val="76B900"/>
+          </a:solidFill>
+          <a:ln/>
+        </p:spPr>
+      </p:sp>
+      <p:sp>
+        <p:nvSpPr>
+          <p:cNvPr id="26" name="Shape 24"/>
+          <p:cNvSpPr/>
+          <p:nvPr/>
+        </p:nvSpPr>
+        <p:spPr>
+          <a:xfrm>
+            <a:off x="5259131" y="2542032"/>
+            <a:ext cx="705782" cy="164592"/>
+          </a:xfrm>
+          <a:prstGeom prst="rect">
+            <a:avLst/>
+          </a:prstGeom>
+          <a:solidFill>
+            <a:srgbClr val="76B900"/>
+          </a:solidFill>
+          <a:ln/>
+        </p:spPr>
+      </p:sp>
+      <p:sp>
+        <p:nvSpPr>
+          <p:cNvPr id="27" name="Shape 25"/>
+          <p:cNvSpPr/>
+          <p:nvPr/>
+        </p:nvSpPr>
+        <p:spPr>
+          <a:xfrm>
+            <a:off x="6158462" y="2542032"/>
+            <a:ext cx="19918" cy="164592"/>
+          </a:xfrm>
+          <a:prstGeom prst="rect">
+            <a:avLst/>
+          </a:prstGeom>
+          <a:solidFill>
+            <a:srgbClr val="76B900"/>
+          </a:solidFill>
+          <a:ln/>
+        </p:spPr>
+      </p:sp>
+      <p:sp>
+        <p:nvSpPr>
+          <p:cNvPr id="28" name="Shape 26"/>
+          <p:cNvSpPr/>
+          <p:nvPr/>
+        </p:nvSpPr>
+        <p:spPr>
+          <a:xfrm>
+            <a:off x="6196999" y="2542032"/>
+            <a:ext cx="708380" cy="164592"/>
+          </a:xfrm>
+          <a:prstGeom prst="rect">
+            <a:avLst/>
+          </a:prstGeom>
+          <a:solidFill>
+            <a:srgbClr val="76B900"/>
+          </a:solidFill>
+          <a:ln/>
+        </p:spPr>
+      </p:sp>
+      <p:sp>
+        <p:nvSpPr>
+          <p:cNvPr id="29" name="Shape 27"/>
+          <p:cNvSpPr/>
+          <p:nvPr/>
+        </p:nvSpPr>
+        <p:spPr>
+          <a:xfrm>
+            <a:off x="7116248" y="2542032"/>
+            <a:ext cx="19052" cy="164592"/>
+          </a:xfrm>
+          <a:prstGeom prst="rect">
+            <a:avLst/>
+          </a:prstGeom>
+          <a:solidFill>
+            <a:srgbClr val="76B900"/>
+          </a:solidFill>
+          <a:ln/>
+        </p:spPr>
+      </p:sp>
+      <p:sp>
+        <p:nvSpPr>
+          <p:cNvPr id="30" name="Shape 28"/>
+          <p:cNvSpPr/>
+          <p:nvPr/>
+        </p:nvSpPr>
+        <p:spPr>
+          <a:xfrm>
+            <a:off x="7150022" y="2542032"/>
+            <a:ext cx="655988" cy="164592"/>
+          </a:xfrm>
+          <a:prstGeom prst="rect">
+            <a:avLst/>
+          </a:prstGeom>
+          <a:solidFill>
+            <a:srgbClr val="76B900"/>
+          </a:solidFill>
+          <a:ln/>
+        </p:spPr>
+      </p:sp>
+      <p:sp>
+        <p:nvSpPr>
+          <p:cNvPr id="31" name="Shape 29"/>
+          <p:cNvSpPr/>
+          <p:nvPr/>
+        </p:nvSpPr>
+        <p:spPr>
+          <a:xfrm>
+            <a:off x="7867062" y="2542032"/>
+            <a:ext cx="123404" cy="164592"/>
+          </a:xfrm>
+          <a:prstGeom prst="rect">
+            <a:avLst/>
+          </a:prstGeom>
+          <a:solidFill>
+            <a:srgbClr val="76B900"/>
+          </a:solidFill>
+          <a:ln/>
+        </p:spPr>
+      </p:sp>
+      <p:sp>
+        <p:nvSpPr>
+          <p:cNvPr id="32" name="Shape 30"/>
+          <p:cNvSpPr/>
+          <p:nvPr/>
+        </p:nvSpPr>
+        <p:spPr>
+          <a:xfrm>
+            <a:off x="8054549" y="2542032"/>
+            <a:ext cx="19918" cy="164592"/>
+          </a:xfrm>
+          <a:prstGeom prst="rect">
+            <a:avLst/>
+          </a:prstGeom>
+          <a:solidFill>
+            <a:srgbClr val="76B900"/>
+          </a:solidFill>
+          <a:ln/>
+        </p:spPr>
+      </p:sp>
+      <p:sp>
+        <p:nvSpPr>
+          <p:cNvPr id="33" name="Shape 31"/>
+          <p:cNvSpPr/>
+          <p:nvPr/>
+        </p:nvSpPr>
+        <p:spPr>
+          <a:xfrm>
+            <a:off x="8340326" y="2542032"/>
+            <a:ext cx="25547" cy="164592"/>
+          </a:xfrm>
+          <a:prstGeom prst="rect">
+            <a:avLst/>
+          </a:prstGeom>
+          <a:solidFill>
+            <a:srgbClr val="76B900"/>
+          </a:solidFill>
+          <a:ln/>
+        </p:spPr>
+      </p:sp>
+      <p:sp>
+        <p:nvSpPr>
+          <p:cNvPr id="34" name="Shape 32"/>
+          <p:cNvSpPr/>
+          <p:nvPr/>
+        </p:nvSpPr>
+        <p:spPr>
+          <a:xfrm>
+            <a:off x="2439033" y="2519172"/>
+            <a:ext cx="226890" cy="41148"/>
+          </a:xfrm>
+          <a:prstGeom prst="rect">
+            <a:avLst/>
+          </a:prstGeom>
+          <a:solidFill>
+            <a:srgbClr val="890C58"/>
+          </a:solidFill>
+          <a:ln/>
+        </p:spPr>
+      </p:sp>
+      <p:sp>
+        <p:nvSpPr>
+          <p:cNvPr id="35" name="Shape 33"/>
+          <p:cNvSpPr/>
+          <p:nvPr/>
+        </p:nvSpPr>
+        <p:spPr>
+          <a:xfrm>
+            <a:off x="2686273" y="2519172"/>
+            <a:ext cx="193549" cy="41148"/>
+          </a:xfrm>
+          <a:prstGeom prst="rect">
+            <a:avLst/>
+          </a:prstGeom>
+          <a:solidFill>
+            <a:srgbClr val="890C58"/>
+          </a:solidFill>
+          <a:ln/>
+        </p:spPr>
+      </p:sp>
+      <p:sp>
+        <p:nvSpPr>
+          <p:cNvPr id="36" name="Shape 34"/>
+          <p:cNvSpPr/>
+          <p:nvPr/>
+        </p:nvSpPr>
+        <p:spPr>
+          <a:xfrm>
+            <a:off x="2899740" y="2519172"/>
+            <a:ext cx="190085" cy="41148"/>
+          </a:xfrm>
+          <a:prstGeom prst="rect">
+            <a:avLst/>
+          </a:prstGeom>
+          <a:solidFill>
+            <a:srgbClr val="890C58"/>
+          </a:solidFill>
+          <a:ln/>
+        </p:spPr>
+      </p:sp>
+      <p:sp>
+        <p:nvSpPr>
+          <p:cNvPr id="37" name="Shape 35"/>
+          <p:cNvSpPr/>
+          <p:nvPr/>
+        </p:nvSpPr>
+        <p:spPr>
+          <a:xfrm>
+            <a:off x="3109743" y="2519172"/>
+            <a:ext cx="190951" cy="41148"/>
+          </a:xfrm>
+          <a:prstGeom prst="rect">
+            <a:avLst/>
+          </a:prstGeom>
+          <a:solidFill>
+            <a:srgbClr val="890C58"/>
+          </a:solidFill>
+          <a:ln/>
+        </p:spPr>
+      </p:sp>
+      <p:sp>
+        <p:nvSpPr>
+          <p:cNvPr id="38" name="Shape 36"/>
+          <p:cNvSpPr/>
+          <p:nvPr/>
+        </p:nvSpPr>
+        <p:spPr>
+          <a:xfrm>
+            <a:off x="3320611" y="2519172"/>
+            <a:ext cx="42434" cy="41148"/>
+          </a:xfrm>
+          <a:prstGeom prst="rect">
+            <a:avLst/>
+          </a:prstGeom>
+          <a:solidFill>
+            <a:srgbClr val="890C58"/>
+          </a:solidFill>
+          <a:ln/>
+        </p:spPr>
+      </p:sp>
+      <p:sp>
+        <p:nvSpPr>
+          <p:cNvPr id="39" name="Shape 37"/>
+          <p:cNvSpPr/>
+          <p:nvPr/>
+        </p:nvSpPr>
+        <p:spPr>
+          <a:xfrm>
+            <a:off x="3374736" y="2519172"/>
+            <a:ext cx="129033" cy="41148"/>
+          </a:xfrm>
+          <a:prstGeom prst="rect">
+            <a:avLst/>
+          </a:prstGeom>
+          <a:solidFill>
+            <a:srgbClr val="890C58"/>
+          </a:solidFill>
+          <a:ln/>
+        </p:spPr>
+      </p:sp>
+      <p:sp>
+        <p:nvSpPr>
+          <p:cNvPr id="40" name="Shape 38"/>
+          <p:cNvSpPr/>
+          <p:nvPr/>
+        </p:nvSpPr>
+        <p:spPr>
+          <a:xfrm>
+            <a:off x="4267139" y="2519172"/>
+            <a:ext cx="71011" cy="41148"/>
+          </a:xfrm>
+          <a:prstGeom prst="rect">
+            <a:avLst/>
+          </a:prstGeom>
+          <a:solidFill>
+            <a:srgbClr val="890C58"/>
+          </a:solidFill>
+          <a:ln/>
+        </p:spPr>
+      </p:sp>
+      <p:sp>
+        <p:nvSpPr>
+          <p:cNvPr id="41" name="Shape 39"/>
+          <p:cNvSpPr/>
+          <p:nvPr/>
+        </p:nvSpPr>
+        <p:spPr>
+          <a:xfrm>
+            <a:off x="5030510" y="2519172"/>
+            <a:ext cx="181858" cy="41148"/>
+          </a:xfrm>
+          <a:prstGeom prst="rect">
+            <a:avLst/>
+          </a:prstGeom>
+          <a:solidFill>
+            <a:srgbClr val="890C58"/>
+          </a:solidFill>
+          <a:ln/>
+        </p:spPr>
+      </p:sp>
+      <p:sp>
+        <p:nvSpPr>
+          <p:cNvPr id="42" name="Shape 40"/>
+          <p:cNvSpPr/>
+          <p:nvPr/>
+        </p:nvSpPr>
+        <p:spPr>
+          <a:xfrm>
+            <a:off x="5232286" y="2519172"/>
+            <a:ext cx="26846" cy="41148"/>
+          </a:xfrm>
+          <a:prstGeom prst="rect">
+            <a:avLst/>
+          </a:prstGeom>
+          <a:solidFill>
+            <a:srgbClr val="890C58"/>
+          </a:solidFill>
+          <a:ln/>
+        </p:spPr>
+      </p:sp>
+      <p:sp>
+        <p:nvSpPr>
+          <p:cNvPr id="43" name="Shape 41"/>
+          <p:cNvSpPr/>
+          <p:nvPr/>
+        </p:nvSpPr>
+        <p:spPr>
+          <a:xfrm>
+            <a:off x="5964914" y="2519172"/>
+            <a:ext cx="193549" cy="41148"/>
+          </a:xfrm>
+          <a:prstGeom prst="rect">
+            <a:avLst/>
+          </a:prstGeom>
+          <a:solidFill>
+            <a:srgbClr val="890C58"/>
+          </a:solidFill>
+          <a:ln/>
+        </p:spPr>
+      </p:sp>
+      <p:sp>
+        <p:nvSpPr>
+          <p:cNvPr id="44" name="Shape 42"/>
+          <p:cNvSpPr/>
+          <p:nvPr/>
+        </p:nvSpPr>
+        <p:spPr>
+          <a:xfrm>
+            <a:off x="6905379" y="2519172"/>
+            <a:ext cx="210869" cy="41148"/>
+          </a:xfrm>
+          <a:prstGeom prst="rect">
+            <a:avLst/>
+          </a:prstGeom>
+          <a:solidFill>
+            <a:srgbClr val="890C58"/>
+          </a:solidFill>
+          <a:ln/>
+        </p:spPr>
+      </p:sp>
+      <p:sp>
+        <p:nvSpPr>
+          <p:cNvPr id="45" name="Shape 43"/>
+          <p:cNvSpPr/>
+          <p:nvPr/>
+        </p:nvSpPr>
+        <p:spPr>
+          <a:xfrm>
+            <a:off x="7806010" y="2519172"/>
+            <a:ext cx="61052" cy="41148"/>
+          </a:xfrm>
+          <a:prstGeom prst="rect">
+            <a:avLst/>
+          </a:prstGeom>
+          <a:solidFill>
+            <a:srgbClr val="890C58"/>
+          </a:solidFill>
+          <a:ln/>
+        </p:spPr>
+      </p:sp>
+      <p:sp>
+        <p:nvSpPr>
+          <p:cNvPr id="46" name="Shape 44"/>
+          <p:cNvSpPr/>
+          <p:nvPr/>
+        </p:nvSpPr>
+        <p:spPr>
+          <a:xfrm>
+            <a:off x="7990466" y="2519172"/>
+            <a:ext cx="64083" cy="41148"/>
+          </a:xfrm>
+          <a:prstGeom prst="rect">
+            <a:avLst/>
+          </a:prstGeom>
+          <a:solidFill>
+            <a:srgbClr val="890C58"/>
+          </a:solidFill>
+          <a:ln/>
+        </p:spPr>
+      </p:sp>
+      <p:sp>
+        <p:nvSpPr>
+          <p:cNvPr id="47" name="Shape 45"/>
+          <p:cNvSpPr/>
+          <p:nvPr/>
+        </p:nvSpPr>
+        <p:spPr>
+          <a:xfrm>
+            <a:off x="8074467" y="2519172"/>
+            <a:ext cx="56289" cy="41148"/>
+          </a:xfrm>
+          <a:prstGeom prst="rect">
+            <a:avLst/>
+          </a:prstGeom>
+          <a:solidFill>
+            <a:srgbClr val="890C58"/>
+          </a:solidFill>
+          <a:ln/>
+        </p:spPr>
+      </p:sp>
+      <p:sp>
+        <p:nvSpPr>
+          <p:cNvPr id="48" name="Shape 46"/>
+          <p:cNvSpPr/>
+          <p:nvPr/>
+        </p:nvSpPr>
+        <p:spPr>
+          <a:xfrm>
+            <a:off x="8131622" y="2519172"/>
+            <a:ext cx="208704" cy="41148"/>
+          </a:xfrm>
+          <a:prstGeom prst="rect">
+            <a:avLst/>
+          </a:prstGeom>
+          <a:solidFill>
+            <a:srgbClr val="890C58"/>
+          </a:solidFill>
+          <a:ln/>
+        </p:spPr>
+      </p:sp>
+      <p:sp>
+        <p:nvSpPr>
+          <p:cNvPr id="49" name="Shape 47"/>
+          <p:cNvSpPr/>
+          <p:nvPr/>
+        </p:nvSpPr>
+        <p:spPr>
+          <a:xfrm>
+            <a:off x="2492291" y="2779776"/>
+            <a:ext cx="173631" cy="164592"/>
+          </a:xfrm>
+          <a:prstGeom prst="rect">
+            <a:avLst/>
+          </a:prstGeom>
+          <a:solidFill>
+            <a:srgbClr val="0071C5"/>
+          </a:solidFill>
+          <a:ln/>
+        </p:spPr>
+      </p:sp>
+      <p:sp>
+        <p:nvSpPr>
+          <p:cNvPr id="50" name="Shape 48"/>
+          <p:cNvSpPr/>
+          <p:nvPr/>
+        </p:nvSpPr>
+        <p:spPr>
+          <a:xfrm>
+            <a:off x="2688438" y="2779776"/>
+            <a:ext cx="191384" cy="164592"/>
+          </a:xfrm>
+          <a:prstGeom prst="rect">
+            <a:avLst/>
+          </a:prstGeom>
+          <a:solidFill>
+            <a:srgbClr val="0071C5"/>
+          </a:solidFill>
+          <a:ln/>
+        </p:spPr>
+      </p:sp>
+      <p:sp>
+        <p:nvSpPr>
+          <p:cNvPr id="51" name="Shape 49"/>
+          <p:cNvSpPr/>
+          <p:nvPr/>
+        </p:nvSpPr>
+        <p:spPr>
+          <a:xfrm>
+            <a:off x="2901039" y="2779776"/>
+            <a:ext cx="188786" cy="164592"/>
+          </a:xfrm>
+          <a:prstGeom prst="rect">
+            <a:avLst/>
+          </a:prstGeom>
+          <a:solidFill>
+            <a:srgbClr val="0071C5"/>
+          </a:solidFill>
+          <a:ln/>
+        </p:spPr>
+      </p:sp>
+      <p:sp>
+        <p:nvSpPr>
+          <p:cNvPr id="52" name="Shape 50"/>
+          <p:cNvSpPr/>
+          <p:nvPr/>
+        </p:nvSpPr>
+        <p:spPr>
+          <a:xfrm>
+            <a:off x="3112341" y="2779776"/>
+            <a:ext cx="188353" cy="164592"/>
+          </a:xfrm>
+          <a:prstGeom prst="rect">
+            <a:avLst/>
+          </a:prstGeom>
+          <a:solidFill>
+            <a:srgbClr val="0071C5"/>
+          </a:solidFill>
+          <a:ln/>
+        </p:spPr>
+      </p:sp>
+      <p:sp>
+        <p:nvSpPr>
+          <p:cNvPr id="53" name="Shape 51"/>
+          <p:cNvSpPr/>
+          <p:nvPr/>
+        </p:nvSpPr>
+        <p:spPr>
+          <a:xfrm>
+            <a:off x="3321044" y="2779776"/>
+            <a:ext cx="182724" cy="164592"/>
+          </a:xfrm>
+          <a:prstGeom prst="rect">
+            <a:avLst/>
+          </a:prstGeom>
+          <a:solidFill>
+            <a:srgbClr val="0071C5"/>
+          </a:solidFill>
+          <a:ln/>
+        </p:spPr>
+      </p:sp>
+      <p:sp>
+        <p:nvSpPr>
+          <p:cNvPr id="54" name="Shape 52"/>
+          <p:cNvSpPr/>
+          <p:nvPr/>
+        </p:nvSpPr>
+        <p:spPr>
+          <a:xfrm>
+            <a:off x="3525418" y="2779776"/>
+            <a:ext cx="199178" cy="164592"/>
+          </a:xfrm>
+          <a:prstGeom prst="rect">
+            <a:avLst/>
+          </a:prstGeom>
+          <a:solidFill>
+            <a:srgbClr val="0071C5"/>
+          </a:solidFill>
+          <a:ln/>
+        </p:spPr>
+      </p:sp>
+      <p:sp>
+        <p:nvSpPr>
+          <p:cNvPr id="55" name="Shape 53"/>
+          <p:cNvSpPr/>
+          <p:nvPr/>
+        </p:nvSpPr>
+        <p:spPr>
+          <a:xfrm>
+            <a:off x="4296583" y="2779776"/>
+            <a:ext cx="198745" cy="164592"/>
+          </a:xfrm>
+          <a:prstGeom prst="rect">
+            <a:avLst/>
+          </a:prstGeom>
+          <a:solidFill>
+            <a:srgbClr val="0071C5"/>
+          </a:solidFill>
+          <a:ln/>
+        </p:spPr>
+      </p:sp>
+      <p:sp>
+        <p:nvSpPr>
+          <p:cNvPr id="56" name="Shape 54"/>
+          <p:cNvSpPr/>
+          <p:nvPr/>
+        </p:nvSpPr>
+        <p:spPr>
+          <a:xfrm>
+            <a:off x="5035273" y="2779776"/>
+            <a:ext cx="177095" cy="164592"/>
+          </a:xfrm>
+          <a:prstGeom prst="rect">
+            <a:avLst/>
+          </a:prstGeom>
+          <a:solidFill>
+            <a:srgbClr val="0071C5"/>
+          </a:solidFill>
+          <a:ln/>
+        </p:spPr>
+      </p:sp>
+      <p:sp>
+        <p:nvSpPr>
+          <p:cNvPr id="57" name="Shape 55"/>
+          <p:cNvSpPr/>
+          <p:nvPr/>
+        </p:nvSpPr>
+        <p:spPr>
+          <a:xfrm>
+            <a:off x="5233152" y="2779776"/>
+            <a:ext cx="210003" cy="164592"/>
+          </a:xfrm>
+          <a:prstGeom prst="rect">
+            <a:avLst/>
+          </a:prstGeom>
+          <a:solidFill>
+            <a:srgbClr val="0071C5"/>
+          </a:solidFill>
+          <a:ln/>
+        </p:spPr>
+      </p:sp>
+      <p:sp>
+        <p:nvSpPr>
+          <p:cNvPr id="58" name="Shape 56"/>
+          <p:cNvSpPr/>
+          <p:nvPr/>
+        </p:nvSpPr>
+        <p:spPr>
+          <a:xfrm>
+            <a:off x="5973573" y="2779776"/>
+            <a:ext cx="184889" cy="164592"/>
+          </a:xfrm>
+          <a:prstGeom prst="rect">
+            <a:avLst/>
+          </a:prstGeom>
+          <a:solidFill>
+            <a:srgbClr val="0071C5"/>
+          </a:solidFill>
+          <a:ln/>
+        </p:spPr>
+      </p:sp>
+      <p:sp>
+        <p:nvSpPr>
+          <p:cNvPr id="59" name="Shape 57"/>
+          <p:cNvSpPr/>
+          <p:nvPr/>
+        </p:nvSpPr>
+        <p:spPr>
+          <a:xfrm>
+            <a:off x="6179679" y="2779776"/>
+            <a:ext cx="206106" cy="164592"/>
+          </a:xfrm>
+          <a:prstGeom prst="rect">
+            <a:avLst/>
+          </a:prstGeom>
+          <a:solidFill>
+            <a:srgbClr val="0071C5"/>
+          </a:solidFill>
+          <a:ln/>
+        </p:spPr>
+      </p:sp>
+      <p:sp>
+        <p:nvSpPr>
+          <p:cNvPr id="60" name="Shape 58"/>
+          <p:cNvSpPr/>
+          <p:nvPr/>
+        </p:nvSpPr>
+        <p:spPr>
+          <a:xfrm>
+            <a:off x="6918802" y="2779776"/>
+            <a:ext cx="197013" cy="164592"/>
+          </a:xfrm>
+          <a:prstGeom prst="rect">
+            <a:avLst/>
+          </a:prstGeom>
+          <a:solidFill>
+            <a:srgbClr val="0071C5"/>
+          </a:solidFill>
+          <a:ln/>
+        </p:spPr>
+      </p:sp>
+      <p:sp>
+        <p:nvSpPr>
+          <p:cNvPr id="61" name="Shape 59"/>
+          <p:cNvSpPr/>
+          <p:nvPr/>
+        </p:nvSpPr>
+        <p:spPr>
+          <a:xfrm>
+            <a:off x="7136599" y="2779776"/>
+            <a:ext cx="208704" cy="164592"/>
+          </a:xfrm>
+          <a:prstGeom prst="rect">
+            <a:avLst/>
+          </a:prstGeom>
+          <a:solidFill>
+            <a:srgbClr val="0071C5"/>
+          </a:solidFill>
+          <a:ln/>
+        </p:spPr>
+      </p:sp>
+      <p:sp>
+        <p:nvSpPr>
+          <p:cNvPr id="62" name="Shape 60"/>
+          <p:cNvSpPr/>
+          <p:nvPr/>
+        </p:nvSpPr>
+        <p:spPr>
+          <a:xfrm>
+            <a:off x="7862732" y="2779776"/>
+            <a:ext cx="191817" cy="164592"/>
+          </a:xfrm>
+          <a:prstGeom prst="rect">
+            <a:avLst/>
+          </a:prstGeom>
+          <a:solidFill>
+            <a:srgbClr val="0071C5"/>
+          </a:solidFill>
+          <a:ln/>
+        </p:spPr>
+      </p:sp>
+      <p:sp>
+        <p:nvSpPr>
+          <p:cNvPr id="63" name="Shape 61"/>
+          <p:cNvSpPr/>
+          <p:nvPr/>
+        </p:nvSpPr>
+        <p:spPr>
+          <a:xfrm>
+            <a:off x="8118199" y="2779776"/>
+            <a:ext cx="12124" cy="164592"/>
+          </a:xfrm>
+          <a:prstGeom prst="rect">
+            <a:avLst/>
+          </a:prstGeom>
+          <a:solidFill>
+            <a:srgbClr val="0071C5"/>
+          </a:solidFill>
+          <a:ln/>
+        </p:spPr>
+      </p:sp>
+      <p:sp>
+        <p:nvSpPr>
+          <p:cNvPr id="64" name="Shape 62"/>
+          <p:cNvSpPr/>
+          <p:nvPr/>
+        </p:nvSpPr>
+        <p:spPr>
+          <a:xfrm>
+            <a:off x="8135519" y="2779776"/>
+            <a:ext cx="204807" cy="164592"/>
+          </a:xfrm>
+          <a:prstGeom prst="rect">
+            <a:avLst/>
+          </a:prstGeom>
+          <a:solidFill>
+            <a:srgbClr val="0071C5"/>
+          </a:solidFill>
+          <a:ln/>
+        </p:spPr>
+      </p:sp>
+      <p:sp>
+        <p:nvSpPr>
+          <p:cNvPr id="65" name="Text 63"/>
+          <p:cNvSpPr/>
+          <p:nvPr/>
+        </p:nvSpPr>
+        <p:spPr>
+          <a:xfrm>
+            <a:off x="457200" y="3127248"/>
+            <a:ext cx="8229600" cy="182880"/>
           </a:xfrm>
           <a:prstGeom prst="rect">
             <a:avLst/>
@@ -6701,7 +7782,7 @@
               <a:buNone/>
             </a:pPr>
             <a:r>
-              <a:rPr lang="en-US" sz="1100" b="1" dirty="0">
+              <a:rPr lang="en-US" sz="1050" b="1" dirty="0">
                 <a:solidFill>
                   <a:srgbClr val="000000"/>
                 </a:solidFill>
@@ -6709,22 +7790,620 @@
                 <a:ea typeface="NVIDIA Sans" pitchFamily="34" charset="-122"/>
                 <a:cs typeface="NVIDIA Sans" pitchFamily="34" charset="-120"/>
               </a:rPr>
-              <a:t>807 ms</a:t>
+              <a:t>bucket 1.5e9 — backward 154 ms · 8 AllReduces · 8 stalls, 27 ms</a:t>
             </a:r>
-            <a:endParaRPr lang="en-US" sz="1100" dirty="0"/>
+            <a:endParaRPr lang="en-US" sz="1050" dirty="0"/>
           </a:p>
         </p:txBody>
       </p:sp>
       <p:sp>
         <p:nvSpPr>
-          <p:cNvPr id="13" name="Text 11"/>
-          <p:cNvSpPr/>
-          <p:nvPr/>
-        </p:nvSpPr>
-        <p:spPr>
-          <a:xfrm>
-            <a:off x="640080" y="3566160"/>
-            <a:ext cx="1463040" cy="310896"/>
+          <p:cNvPr id="66" name="Text 64"/>
+          <p:cNvSpPr/>
+          <p:nvPr/>
+        </p:nvSpPr>
+        <p:spPr>
+          <a:xfrm>
+            <a:off x="457200" y="3346704"/>
+            <a:ext cx="713232" cy="201168"/>
+          </a:xfrm>
+          <a:prstGeom prst="rect">
+            <a:avLst/>
+          </a:prstGeom>
+          <a:noFill/>
+          <a:ln/>
+        </p:spPr>
+        <p:txBody>
+          <a:bodyPr wrap="square" lIns="0" tIns="0" rIns="0" bIns="0" rtlCol="0" anchor="ctr"/>
+          <a:lstStyle/>
+          <a:p>
+            <a:pPr algn="r" indent="0" marL="0">
+              <a:buNone/>
+            </a:pPr>
+            <a:r>
+              <a:rPr lang="en-US" sz="850" dirty="0">
+                <a:solidFill>
+                  <a:srgbClr val="5E5E5E"/>
+                </a:solidFill>
+                <a:latin typeface="NVIDIA Sans" pitchFamily="34" charset="0"/>
+                <a:ea typeface="NVIDIA Sans" pitchFamily="34" charset="-122"/>
+                <a:cs typeface="NVIDIA Sans" pitchFamily="34" charset="-120"/>
+              </a:rPr>
+              <a:t>Compute</a:t>
+            </a:r>
+            <a:endParaRPr lang="en-US" sz="850" dirty="0"/>
+          </a:p>
+        </p:txBody>
+      </p:sp>
+      <p:sp>
+        <p:nvSpPr>
+          <p:cNvPr id="67" name="Shape 65"/>
+          <p:cNvSpPr/>
+          <p:nvPr/>
+        </p:nvSpPr>
+        <p:spPr>
+          <a:xfrm>
+            <a:off x="1234440" y="3346704"/>
+            <a:ext cx="7360920" cy="201168"/>
+          </a:xfrm>
+          <a:prstGeom prst="rect">
+            <a:avLst/>
+          </a:prstGeom>
+          <a:solidFill>
+            <a:srgbClr val="F0F0F0"/>
+          </a:solidFill>
+          <a:ln/>
+        </p:spPr>
+      </p:sp>
+      <p:sp>
+        <p:nvSpPr>
+          <p:cNvPr id="68" name="Text 66"/>
+          <p:cNvSpPr/>
+          <p:nvPr/>
+        </p:nvSpPr>
+        <p:spPr>
+          <a:xfrm>
+            <a:off x="457200" y="3584448"/>
+            <a:ext cx="713232" cy="201168"/>
+          </a:xfrm>
+          <a:prstGeom prst="rect">
+            <a:avLst/>
+          </a:prstGeom>
+          <a:noFill/>
+          <a:ln/>
+        </p:spPr>
+        <p:txBody>
+          <a:bodyPr wrap="square" lIns="0" tIns="0" rIns="0" bIns="0" rtlCol="0" anchor="ctr"/>
+          <a:lstStyle/>
+          <a:p>
+            <a:pPr algn="r" indent="0" marL="0">
+              <a:buNone/>
+            </a:pPr>
+            <a:r>
+              <a:rPr lang="en-US" sz="850" dirty="0">
+                <a:solidFill>
+                  <a:srgbClr val="5E5E5E"/>
+                </a:solidFill>
+                <a:latin typeface="NVIDIA Sans" pitchFamily="34" charset="0"/>
+                <a:ea typeface="NVIDIA Sans" pitchFamily="34" charset="-122"/>
+                <a:cs typeface="NVIDIA Sans" pitchFamily="34" charset="-120"/>
+              </a:rPr>
+              <a:t>NCCL AR</a:t>
+            </a:r>
+            <a:endParaRPr lang="en-US" sz="850" dirty="0"/>
+          </a:p>
+        </p:txBody>
+      </p:sp>
+      <p:sp>
+        <p:nvSpPr>
+          <p:cNvPr id="69" name="Shape 67"/>
+          <p:cNvSpPr/>
+          <p:nvPr/>
+        </p:nvSpPr>
+        <p:spPr>
+          <a:xfrm>
+            <a:off x="1234440" y="3584448"/>
+            <a:ext cx="7360920" cy="201168"/>
+          </a:xfrm>
+          <a:prstGeom prst="rect">
+            <a:avLst/>
+          </a:prstGeom>
+          <a:solidFill>
+            <a:srgbClr val="F0F0F0"/>
+          </a:solidFill>
+          <a:ln/>
+        </p:spPr>
+      </p:sp>
+      <p:sp>
+        <p:nvSpPr>
+          <p:cNvPr id="70" name="Shape 68"/>
+          <p:cNvSpPr/>
+          <p:nvPr/>
+        </p:nvSpPr>
+        <p:spPr>
+          <a:xfrm>
+            <a:off x="1234873" y="3364992"/>
+            <a:ext cx="1191170" cy="164592"/>
+          </a:xfrm>
+          <a:prstGeom prst="rect">
+            <a:avLst/>
+          </a:prstGeom>
+          <a:solidFill>
+            <a:srgbClr val="76B900"/>
+          </a:solidFill>
+          <a:ln/>
+        </p:spPr>
+      </p:sp>
+      <p:sp>
+        <p:nvSpPr>
+          <p:cNvPr id="71" name="Shape 69"/>
+          <p:cNvSpPr/>
+          <p:nvPr/>
+        </p:nvSpPr>
+        <p:spPr>
+          <a:xfrm>
+            <a:off x="2714851" y="3364992"/>
+            <a:ext cx="888073" cy="164592"/>
+          </a:xfrm>
+          <a:prstGeom prst="rect">
+            <a:avLst/>
+          </a:prstGeom>
+          <a:solidFill>
+            <a:srgbClr val="76B900"/>
+          </a:solidFill>
+          <a:ln/>
+        </p:spPr>
+      </p:sp>
+      <p:sp>
+        <p:nvSpPr>
+          <p:cNvPr id="72" name="Shape 70"/>
+          <p:cNvSpPr/>
+          <p:nvPr/>
+        </p:nvSpPr>
+        <p:spPr>
+          <a:xfrm>
+            <a:off x="3681729" y="3364992"/>
+            <a:ext cx="866857" cy="164592"/>
+          </a:xfrm>
+          <a:prstGeom prst="rect">
+            <a:avLst/>
+          </a:prstGeom>
+          <a:solidFill>
+            <a:srgbClr val="76B900"/>
+          </a:solidFill>
+          <a:ln/>
+        </p:spPr>
+      </p:sp>
+      <p:sp>
+        <p:nvSpPr>
+          <p:cNvPr id="73" name="Shape 71"/>
+          <p:cNvSpPr/>
+          <p:nvPr/>
+        </p:nvSpPr>
+        <p:spPr>
+          <a:xfrm>
+            <a:off x="4610071" y="3364992"/>
+            <a:ext cx="871620" cy="164592"/>
+          </a:xfrm>
+          <a:prstGeom prst="rect">
+            <a:avLst/>
+          </a:prstGeom>
+          <a:solidFill>
+            <a:srgbClr val="76B900"/>
+          </a:solidFill>
+          <a:ln/>
+        </p:spPr>
+      </p:sp>
+      <p:sp>
+        <p:nvSpPr>
+          <p:cNvPr id="74" name="Shape 72"/>
+          <p:cNvSpPr/>
+          <p:nvPr/>
+        </p:nvSpPr>
+        <p:spPr>
+          <a:xfrm>
+            <a:off x="5535815" y="3364992"/>
+            <a:ext cx="615286" cy="164592"/>
+          </a:xfrm>
+          <a:prstGeom prst="rect">
+            <a:avLst/>
+          </a:prstGeom>
+          <a:solidFill>
+            <a:srgbClr val="76B900"/>
+          </a:solidFill>
+          <a:ln/>
+        </p:spPr>
+      </p:sp>
+      <p:sp>
+        <p:nvSpPr>
+          <p:cNvPr id="75" name="Shape 73"/>
+          <p:cNvSpPr/>
+          <p:nvPr/>
+        </p:nvSpPr>
+        <p:spPr>
+          <a:xfrm>
+            <a:off x="6222979" y="3364992"/>
+            <a:ext cx="824423" cy="164592"/>
+          </a:xfrm>
+          <a:prstGeom prst="rect">
+            <a:avLst/>
+          </a:prstGeom>
+          <a:solidFill>
+            <a:srgbClr val="76B900"/>
+          </a:solidFill>
+          <a:ln/>
+        </p:spPr>
+      </p:sp>
+      <p:sp>
+        <p:nvSpPr>
+          <p:cNvPr id="76" name="Shape 74"/>
+          <p:cNvSpPr/>
+          <p:nvPr/>
+        </p:nvSpPr>
+        <p:spPr>
+          <a:xfrm>
+            <a:off x="7103691" y="3364992"/>
+            <a:ext cx="87898" cy="164592"/>
+          </a:xfrm>
+          <a:prstGeom prst="rect">
+            <a:avLst/>
+          </a:prstGeom>
+          <a:solidFill>
+            <a:srgbClr val="76B900"/>
+          </a:solidFill>
+          <a:ln/>
+        </p:spPr>
+      </p:sp>
+      <p:sp>
+        <p:nvSpPr>
+          <p:cNvPr id="77" name="Shape 75"/>
+          <p:cNvSpPr/>
+          <p:nvPr/>
+        </p:nvSpPr>
+        <p:spPr>
+          <a:xfrm>
+            <a:off x="7509841" y="3364992"/>
+            <a:ext cx="37671" cy="164592"/>
+          </a:xfrm>
+          <a:prstGeom prst="rect">
+            <a:avLst/>
+          </a:prstGeom>
+          <a:solidFill>
+            <a:srgbClr val="76B900"/>
+          </a:solidFill>
+          <a:ln/>
+        </p:spPr>
+      </p:sp>
+      <p:sp>
+        <p:nvSpPr>
+          <p:cNvPr id="78" name="Shape 76"/>
+          <p:cNvSpPr/>
+          <p:nvPr/>
+        </p:nvSpPr>
+        <p:spPr>
+          <a:xfrm>
+            <a:off x="7798216" y="3364992"/>
+            <a:ext cx="25547" cy="164592"/>
+          </a:xfrm>
+          <a:prstGeom prst="rect">
+            <a:avLst/>
+          </a:prstGeom>
+          <a:solidFill>
+            <a:srgbClr val="76B900"/>
+          </a:solidFill>
+          <a:ln/>
+        </p:spPr>
+      </p:sp>
+      <p:sp>
+        <p:nvSpPr>
+          <p:cNvPr id="79" name="Shape 77"/>
+          <p:cNvSpPr/>
+          <p:nvPr/>
+        </p:nvSpPr>
+        <p:spPr>
+          <a:xfrm>
+            <a:off x="2426043" y="3342132"/>
+            <a:ext cx="288808" cy="41148"/>
+          </a:xfrm>
+          <a:prstGeom prst="rect">
+            <a:avLst/>
+          </a:prstGeom>
+          <a:solidFill>
+            <a:srgbClr val="890C58"/>
+          </a:solidFill>
+          <a:ln/>
+        </p:spPr>
+      </p:sp>
+      <p:sp>
+        <p:nvSpPr>
+          <p:cNvPr id="80" name="Shape 78"/>
+          <p:cNvSpPr/>
+          <p:nvPr/>
+        </p:nvSpPr>
+        <p:spPr>
+          <a:xfrm>
+            <a:off x="3602924" y="3342132"/>
+            <a:ext cx="78805" cy="41148"/>
+          </a:xfrm>
+          <a:prstGeom prst="rect">
+            <a:avLst/>
+          </a:prstGeom>
+          <a:solidFill>
+            <a:srgbClr val="890C58"/>
+          </a:solidFill>
+          <a:ln/>
+        </p:spPr>
+      </p:sp>
+      <p:sp>
+        <p:nvSpPr>
+          <p:cNvPr id="81" name="Shape 79"/>
+          <p:cNvSpPr/>
+          <p:nvPr/>
+        </p:nvSpPr>
+        <p:spPr>
+          <a:xfrm>
+            <a:off x="4548586" y="3342132"/>
+            <a:ext cx="61485" cy="41148"/>
+          </a:xfrm>
+          <a:prstGeom prst="rect">
+            <a:avLst/>
+          </a:prstGeom>
+          <a:solidFill>
+            <a:srgbClr val="890C58"/>
+          </a:solidFill>
+          <a:ln/>
+        </p:spPr>
+      </p:sp>
+      <p:sp>
+        <p:nvSpPr>
+          <p:cNvPr id="82" name="Shape 80"/>
+          <p:cNvSpPr/>
+          <p:nvPr/>
+        </p:nvSpPr>
+        <p:spPr>
+          <a:xfrm>
+            <a:off x="5481691" y="3342132"/>
+            <a:ext cx="54124" cy="41148"/>
+          </a:xfrm>
+          <a:prstGeom prst="rect">
+            <a:avLst/>
+          </a:prstGeom>
+          <a:solidFill>
+            <a:srgbClr val="890C58"/>
+          </a:solidFill>
+          <a:ln/>
+        </p:spPr>
+      </p:sp>
+      <p:sp>
+        <p:nvSpPr>
+          <p:cNvPr id="83" name="Shape 81"/>
+          <p:cNvSpPr/>
+          <p:nvPr/>
+        </p:nvSpPr>
+        <p:spPr>
+          <a:xfrm>
+            <a:off x="6151102" y="3342132"/>
+            <a:ext cx="71877" cy="41148"/>
+          </a:xfrm>
+          <a:prstGeom prst="rect">
+            <a:avLst/>
+          </a:prstGeom>
+          <a:solidFill>
+            <a:srgbClr val="890C58"/>
+          </a:solidFill>
+          <a:ln/>
+        </p:spPr>
+      </p:sp>
+      <p:sp>
+        <p:nvSpPr>
+          <p:cNvPr id="84" name="Shape 82"/>
+          <p:cNvSpPr/>
+          <p:nvPr/>
+        </p:nvSpPr>
+        <p:spPr>
+          <a:xfrm>
+            <a:off x="7047402" y="3342132"/>
+            <a:ext cx="56289" cy="41148"/>
+          </a:xfrm>
+          <a:prstGeom prst="rect">
+            <a:avLst/>
+          </a:prstGeom>
+          <a:solidFill>
+            <a:srgbClr val="890C58"/>
+          </a:solidFill>
+          <a:ln/>
+        </p:spPr>
+      </p:sp>
+      <p:sp>
+        <p:nvSpPr>
+          <p:cNvPr id="85" name="Shape 83"/>
+          <p:cNvSpPr/>
+          <p:nvPr/>
+        </p:nvSpPr>
+        <p:spPr>
+          <a:xfrm>
+            <a:off x="7191589" y="3342132"/>
+            <a:ext cx="318252" cy="41148"/>
+          </a:xfrm>
+          <a:prstGeom prst="rect">
+            <a:avLst/>
+          </a:prstGeom>
+          <a:solidFill>
+            <a:srgbClr val="890C58"/>
+          </a:solidFill>
+          <a:ln/>
+        </p:spPr>
+      </p:sp>
+      <p:sp>
+        <p:nvSpPr>
+          <p:cNvPr id="86" name="Shape 84"/>
+          <p:cNvSpPr/>
+          <p:nvPr/>
+        </p:nvSpPr>
+        <p:spPr>
+          <a:xfrm>
+            <a:off x="7547511" y="3342132"/>
+            <a:ext cx="250704" cy="41148"/>
+          </a:xfrm>
+          <a:prstGeom prst="rect">
+            <a:avLst/>
+          </a:prstGeom>
+          <a:solidFill>
+            <a:srgbClr val="890C58"/>
+          </a:solidFill>
+          <a:ln/>
+        </p:spPr>
+      </p:sp>
+      <p:sp>
+        <p:nvSpPr>
+          <p:cNvPr id="87" name="Shape 85"/>
+          <p:cNvSpPr/>
+          <p:nvPr/>
+        </p:nvSpPr>
+        <p:spPr>
+          <a:xfrm>
+            <a:off x="2584519" y="3602736"/>
+            <a:ext cx="523058" cy="164592"/>
+          </a:xfrm>
+          <a:prstGeom prst="rect">
+            <a:avLst/>
+          </a:prstGeom>
+          <a:solidFill>
+            <a:srgbClr val="0071C5"/>
+          </a:solidFill>
+          <a:ln/>
+        </p:spPr>
+      </p:sp>
+      <p:sp>
+        <p:nvSpPr>
+          <p:cNvPr id="88" name="Shape 86"/>
+          <p:cNvSpPr/>
+          <p:nvPr/>
+        </p:nvSpPr>
+        <p:spPr>
+          <a:xfrm>
+            <a:off x="3603357" y="3602736"/>
+            <a:ext cx="527821" cy="164592"/>
+          </a:xfrm>
+          <a:prstGeom prst="rect">
+            <a:avLst/>
+          </a:prstGeom>
+          <a:solidFill>
+            <a:srgbClr val="0071C5"/>
+          </a:solidFill>
+          <a:ln/>
+        </p:spPr>
+      </p:sp>
+      <p:sp>
+        <p:nvSpPr>
+          <p:cNvPr id="89" name="Shape 87"/>
+          <p:cNvSpPr/>
+          <p:nvPr/>
+        </p:nvSpPr>
+        <p:spPr>
+          <a:xfrm>
+            <a:off x="4583226" y="3602736"/>
+            <a:ext cx="513965" cy="164592"/>
+          </a:xfrm>
+          <a:prstGeom prst="rect">
+            <a:avLst/>
+          </a:prstGeom>
+          <a:solidFill>
+            <a:srgbClr val="0071C5"/>
+          </a:solidFill>
+          <a:ln/>
+        </p:spPr>
+      </p:sp>
+      <p:sp>
+        <p:nvSpPr>
+          <p:cNvPr id="90" name="Shape 88"/>
+          <p:cNvSpPr/>
+          <p:nvPr/>
+        </p:nvSpPr>
+        <p:spPr>
+          <a:xfrm>
+            <a:off x="6168421" y="3602736"/>
+            <a:ext cx="500110" cy="164592"/>
+          </a:xfrm>
+          <a:prstGeom prst="rect">
+            <a:avLst/>
+          </a:prstGeom>
+          <a:solidFill>
+            <a:srgbClr val="0071C5"/>
+          </a:solidFill>
+          <a:ln/>
+        </p:spPr>
+      </p:sp>
+      <p:sp>
+        <p:nvSpPr>
+          <p:cNvPr id="91" name="Shape 89"/>
+          <p:cNvSpPr/>
+          <p:nvPr/>
+        </p:nvSpPr>
+        <p:spPr>
+          <a:xfrm>
+            <a:off x="7191589" y="3602736"/>
+            <a:ext cx="317819" cy="164592"/>
+          </a:xfrm>
+          <a:prstGeom prst="rect">
+            <a:avLst/>
+          </a:prstGeom>
+          <a:solidFill>
+            <a:srgbClr val="0071C5"/>
+          </a:solidFill>
+          <a:ln/>
+        </p:spPr>
+      </p:sp>
+      <p:sp>
+        <p:nvSpPr>
+          <p:cNvPr id="92" name="Shape 90"/>
+          <p:cNvSpPr/>
+          <p:nvPr/>
+        </p:nvSpPr>
+        <p:spPr>
+          <a:xfrm>
+            <a:off x="7593409" y="3602736"/>
+            <a:ext cx="204807" cy="164592"/>
+          </a:xfrm>
+          <a:prstGeom prst="rect">
+            <a:avLst/>
+          </a:prstGeom>
+          <a:solidFill>
+            <a:srgbClr val="0071C5"/>
+          </a:solidFill>
+          <a:ln/>
+        </p:spPr>
+      </p:sp>
+      <p:sp>
+        <p:nvSpPr>
+          <p:cNvPr id="93" name="Shape 91"/>
+          <p:cNvSpPr/>
+          <p:nvPr/>
+        </p:nvSpPr>
+        <p:spPr>
+          <a:xfrm>
+            <a:off x="8459832" y="3602736"/>
+            <a:ext cx="9144" cy="164592"/>
+          </a:xfrm>
+          <a:prstGeom prst="rect">
+            <a:avLst/>
+          </a:prstGeom>
+          <a:solidFill>
+            <a:srgbClr val="0071C5"/>
+          </a:solidFill>
+          <a:ln/>
+        </p:spPr>
+      </p:sp>
+      <p:sp>
+        <p:nvSpPr>
+          <p:cNvPr id="94" name="Text 92"/>
+          <p:cNvSpPr/>
+          <p:nvPr/>
+        </p:nvSpPr>
+        <p:spPr>
+          <a:xfrm>
+            <a:off x="1234440" y="3913632"/>
+            <a:ext cx="7360920" cy="164592"/>
           </a:xfrm>
           <a:prstGeom prst="rect">
             <a:avLst/>
@@ -6740,7 +8419,60 @@
               <a:buNone/>
             </a:pPr>
             <a:r>
-              <a:rPr lang="en-US" sz="1100" b="1" dirty="0">
+              <a:rPr lang="en-US" sz="850" i="1" dirty="0">
+                <a:solidFill>
+                  <a:srgbClr val="8C8C8C"/>
+                </a:solidFill>
+                <a:latin typeface="NVIDIA Sans" pitchFamily="34" charset="0"/>
+                <a:ea typeface="NVIDIA Sans" pitchFamily="34" charset="-122"/>
+                <a:cs typeface="NVIDIA Sans" pitchFamily="34" charset="-120"/>
+              </a:rPr>
+              <a:t>one backward pass, real kernels (node-level nsys, same node, same bytes) · red = compute stream stalled at a bucket rendezvous</a:t>
+            </a:r>
+            <a:endParaRPr lang="en-US" sz="850" dirty="0"/>
+          </a:p>
+        </p:txBody>
+      </p:sp>
+      <p:sp>
+        <p:nvSpPr>
+          <p:cNvPr id="95" name="Text 93"/>
+          <p:cNvSpPr/>
+          <p:nvPr/>
+        </p:nvSpPr>
+        <p:spPr>
+          <a:xfrm>
+            <a:off x="640080" y="4114800"/>
+            <a:ext cx="7955280" cy="292608"/>
+          </a:xfrm>
+          <a:prstGeom prst="rect">
+            <a:avLst/>
+          </a:prstGeom>
+          <a:noFill/>
+          <a:ln/>
+        </p:spPr>
+        <p:txBody>
+          <a:bodyPr wrap="square" lIns="0" tIns="0" rIns="0" bIns="0" rtlCol="0" anchor="t"/>
+          <a:lstStyle/>
+          <a:p>
+            <a:pPr indent="0" marL="0">
+              <a:buNone/>
+            </a:pPr>
+            <a:r>
+              <a:rPr lang="en-US" b="1" dirty="0">
+                <a:solidFill>
+                  <a:srgbClr val="76B900"/>
+                </a:solidFill>
+                <a:latin typeface="NVIDIA Sans" pitchFamily="34" charset="0"/>
+                <a:ea typeface="NVIDIA Sans" pitchFamily="34" charset="-122"/>
+                <a:cs typeface="NVIDIA Sans" pitchFamily="34" charset="-120"/>
+              </a:rPr>
+              <a:t>No conflict — they compose: </a:t>
+            </a:r>
+            <a:pPr indent="0" marL="0">
+              <a:buNone/>
+            </a:pPr>
+            <a:r>
+              <a:rPr lang="en-US" sz="1000" dirty="0">
                 <a:solidFill>
                   <a:srgbClr val="000000"/>
                 </a:solidFill>
@@ -6748,66 +8480,7 @@
                 <a:ea typeface="NVIDIA Sans" pitchFamily="34" charset="-122"/>
                 <a:cs typeface="NVIDIA Sans" pitchFamily="34" charset="-120"/>
               </a:rPr>
-              <a:t>Optimized</a:t>
-            </a:r>
-            <a:endParaRPr lang="en-US" sz="1100" dirty="0"/>
-          </a:p>
-        </p:txBody>
-      </p:sp>
-      <p:sp>
-        <p:nvSpPr>
-          <p:cNvPr id="14" name="Shape 12"/>
-          <p:cNvSpPr/>
-          <p:nvPr/>
-        </p:nvSpPr>
-        <p:spPr>
-          <a:xfrm>
-            <a:off x="2148840" y="3584448"/>
-            <a:ext cx="1169297" cy="310896"/>
-          </a:xfrm>
-          <a:prstGeom prst="rect">
-            <a:avLst/>
-          </a:prstGeom>
-          <a:solidFill>
-            <a:srgbClr val="76B900"/>
-          </a:solidFill>
-          <a:ln/>
-        </p:spPr>
-      </p:sp>
-      <p:sp>
-        <p:nvSpPr>
-          <p:cNvPr id="15" name="Text 13"/>
-          <p:cNvSpPr/>
-          <p:nvPr/>
-        </p:nvSpPr>
-        <p:spPr>
-          <a:xfrm>
-            <a:off x="2148840" y="3584448"/>
-            <a:ext cx="1169297" cy="310896"/>
-          </a:xfrm>
-          <a:prstGeom prst="rect">
-            <a:avLst/>
-          </a:prstGeom>
-          <a:noFill/>
-          <a:ln/>
-        </p:spPr>
-        <p:txBody>
-          <a:bodyPr wrap="square" lIns="0" tIns="0" rIns="0" bIns="0" rtlCol="0" anchor="ctr"/>
-          <a:lstStyle/>
-          <a:p>
-            <a:pPr algn="ctr" indent="0" marL="0">
-              <a:buNone/>
-            </a:pPr>
-            <a:r>
-              <a:rPr lang="en-US" sz="1000" b="1" dirty="0">
-                <a:solidFill>
-                  <a:srgbClr val="FFFFFF"/>
-                </a:solidFill>
-                <a:latin typeface="NVIDIA Sans" pitchFamily="34" charset="0"/>
-                <a:ea typeface="NVIDIA Sans" pitchFamily="34" charset="-122"/>
-                <a:cs typeface="NVIDIA Sans" pitchFamily="34" charset="-120"/>
-              </a:rPr>
-              <a:t>175</a:t>
+              <a:t>bucket size = how OFTEN compute and reduction rendezvous; reduce_scatter = what each rendezvous COSTS. false makes each AR bigger, strengthening the case for large buckets.</a:t>
             </a:r>
             <a:endParaRPr lang="en-US" sz="1000" dirty="0"/>
           </a:p>
@@ -6815,302 +8488,7 @@
       </p:sp>
       <p:sp>
         <p:nvSpPr>
-          <p:cNvPr id="16" name="Shape 14"/>
-          <p:cNvSpPr/>
-          <p:nvPr/>
-        </p:nvSpPr>
-        <p:spPr>
-          <a:xfrm>
-            <a:off x="3318137" y="3584448"/>
-            <a:ext cx="148164" cy="310896"/>
-          </a:xfrm>
-          <a:prstGeom prst="rect">
-            <a:avLst/>
-          </a:prstGeom>
-          <a:solidFill>
-            <a:srgbClr val="0071C5"/>
-          </a:solidFill>
-          <a:ln/>
-        </p:spPr>
-      </p:sp>
-      <p:sp>
-        <p:nvSpPr>
-          <p:cNvPr id="17" name="Shape 15"/>
-          <p:cNvSpPr/>
-          <p:nvPr/>
-        </p:nvSpPr>
-        <p:spPr>
-          <a:xfrm>
-            <a:off x="3466301" y="3584448"/>
-            <a:ext cx="289655" cy="310896"/>
-          </a:xfrm>
-          <a:prstGeom prst="rect">
-            <a:avLst/>
-          </a:prstGeom>
-          <a:solidFill>
-            <a:srgbClr val="D9D9D9"/>
-          </a:solidFill>
-          <a:ln/>
-        </p:spPr>
-      </p:sp>
-      <p:sp>
-        <p:nvSpPr>
-          <p:cNvPr id="18" name="Text 16"/>
-          <p:cNvSpPr/>
-          <p:nvPr/>
-        </p:nvSpPr>
-        <p:spPr>
-          <a:xfrm>
-            <a:off x="3810820" y="3584448"/>
-            <a:ext cx="822960" cy="310896"/>
-          </a:xfrm>
-          <a:prstGeom prst="rect">
-            <a:avLst/>
-          </a:prstGeom>
-          <a:noFill/>
-          <a:ln/>
-        </p:spPr>
-        <p:txBody>
-          <a:bodyPr wrap="square" lIns="0" tIns="0" rIns="0" bIns="0" rtlCol="0" anchor="ctr"/>
-          <a:lstStyle/>
-          <a:p>
-            <a:pPr indent="0" marL="0">
-              <a:buNone/>
-            </a:pPr>
-            <a:r>
-              <a:rPr lang="en-US" sz="1100" b="1" dirty="0">
-                <a:solidFill>
-                  <a:srgbClr val="000000"/>
-                </a:solidFill>
-                <a:latin typeface="NVIDIA Sans" pitchFamily="34" charset="0"/>
-                <a:ea typeface="NVIDIA Sans" pitchFamily="34" charset="-122"/>
-                <a:cs typeface="NVIDIA Sans" pitchFamily="34" charset="-120"/>
-              </a:rPr>
-              <a:t>249 ms</a:t>
-            </a:r>
-            <a:endParaRPr lang="en-US" sz="1100" dirty="0"/>
-          </a:p>
-        </p:txBody>
-      </p:sp>
-      <p:sp>
-        <p:nvSpPr>
-          <p:cNvPr id="19" name="Shape 17"/>
-          <p:cNvSpPr/>
-          <p:nvPr/>
-        </p:nvSpPr>
-        <p:spPr>
-          <a:xfrm>
-            <a:off x="2148840" y="4059936"/>
-            <a:ext cx="164592" cy="128016"/>
-          </a:xfrm>
-          <a:prstGeom prst="rect">
-            <a:avLst/>
-          </a:prstGeom>
-          <a:solidFill>
-            <a:srgbClr val="76B900"/>
-          </a:solidFill>
-          <a:ln/>
-        </p:spPr>
-      </p:sp>
-      <p:sp>
-        <p:nvSpPr>
-          <p:cNvPr id="20" name="Text 18"/>
-          <p:cNvSpPr/>
-          <p:nvPr/>
-        </p:nvSpPr>
-        <p:spPr>
-          <a:xfrm>
-            <a:off x="2368296" y="3986784"/>
-            <a:ext cx="1600200" cy="274320"/>
-          </a:xfrm>
-          <a:prstGeom prst="rect">
-            <a:avLst/>
-          </a:prstGeom>
-          <a:noFill/>
-          <a:ln/>
-        </p:spPr>
-        <p:txBody>
-          <a:bodyPr wrap="square" lIns="0" tIns="0" rIns="0" bIns="0" rtlCol="0" anchor="ctr"/>
-          <a:lstStyle/>
-          <a:p>
-            <a:pPr indent="0" marL="0">
-              <a:buNone/>
-            </a:pPr>
-            <a:r>
-              <a:rPr lang="en-US" sz="1000" dirty="0">
-                <a:solidFill>
-                  <a:srgbClr val="5E5E5E"/>
-                </a:solidFill>
-                <a:latin typeface="NVIDIA Sans" pitchFamily="34" charset="0"/>
-                <a:ea typeface="NVIDIA Sans" pitchFamily="34" charset="-122"/>
-                <a:cs typeface="NVIDIA Sans" pitchFamily="34" charset="-120"/>
-              </a:rPr>
-              <a:t>Compute busy</a:t>
-            </a:r>
-            <a:endParaRPr lang="en-US" sz="1000" dirty="0"/>
-          </a:p>
-        </p:txBody>
-      </p:sp>
-      <p:sp>
-        <p:nvSpPr>
-          <p:cNvPr id="21" name="Shape 19"/>
-          <p:cNvSpPr/>
-          <p:nvPr/>
-        </p:nvSpPr>
-        <p:spPr>
-          <a:xfrm>
-            <a:off x="3977640" y="4059936"/>
-            <a:ext cx="164592" cy="128016"/>
-          </a:xfrm>
-          <a:prstGeom prst="rect">
-            <a:avLst/>
-          </a:prstGeom>
-          <a:solidFill>
-            <a:srgbClr val="0071C5"/>
-          </a:solidFill>
-          <a:ln/>
-        </p:spPr>
-      </p:sp>
-      <p:sp>
-        <p:nvSpPr>
-          <p:cNvPr id="22" name="Text 20"/>
-          <p:cNvSpPr/>
-          <p:nvPr/>
-        </p:nvSpPr>
-        <p:spPr>
-          <a:xfrm>
-            <a:off x="4197096" y="3986784"/>
-            <a:ext cx="1600200" cy="274320"/>
-          </a:xfrm>
-          <a:prstGeom prst="rect">
-            <a:avLst/>
-          </a:prstGeom>
-          <a:noFill/>
-          <a:ln/>
-        </p:spPr>
-        <p:txBody>
-          <a:bodyPr wrap="square" lIns="0" tIns="0" rIns="0" bIns="0" rtlCol="0" anchor="ctr"/>
-          <a:lstStyle/>
-          <a:p>
-            <a:pPr indent="0" marL="0">
-              <a:buNone/>
-            </a:pPr>
-            <a:r>
-              <a:rPr lang="en-US" sz="1000" dirty="0">
-                <a:solidFill>
-                  <a:srgbClr val="5E5E5E"/>
-                </a:solidFill>
-                <a:latin typeface="NVIDIA Sans" pitchFamily="34" charset="0"/>
-                <a:ea typeface="NVIDIA Sans" pitchFamily="34" charset="-122"/>
-                <a:cs typeface="NVIDIA Sans" pitchFamily="34" charset="-120"/>
-              </a:rPr>
-              <a:t>Exposed comm</a:t>
-            </a:r>
-            <a:endParaRPr lang="en-US" sz="1000" dirty="0"/>
-          </a:p>
-        </p:txBody>
-      </p:sp>
-      <p:sp>
-        <p:nvSpPr>
-          <p:cNvPr id="23" name="Shape 21"/>
-          <p:cNvSpPr/>
-          <p:nvPr/>
-        </p:nvSpPr>
-        <p:spPr>
-          <a:xfrm>
-            <a:off x="5806440" y="4059936"/>
-            <a:ext cx="164592" cy="128016"/>
-          </a:xfrm>
-          <a:prstGeom prst="rect">
-            <a:avLst/>
-          </a:prstGeom>
-          <a:solidFill>
-            <a:srgbClr val="D9D9D9"/>
-          </a:solidFill>
-          <a:ln/>
-        </p:spPr>
-      </p:sp>
-      <p:sp>
-        <p:nvSpPr>
-          <p:cNvPr id="24" name="Text 22"/>
-          <p:cNvSpPr/>
-          <p:nvPr/>
-        </p:nvSpPr>
-        <p:spPr>
-          <a:xfrm>
-            <a:off x="6025896" y="3986784"/>
-            <a:ext cx="1600200" cy="274320"/>
-          </a:xfrm>
-          <a:prstGeom prst="rect">
-            <a:avLst/>
-          </a:prstGeom>
-          <a:noFill/>
-          <a:ln/>
-        </p:spPr>
-        <p:txBody>
-          <a:bodyPr wrap="square" lIns="0" tIns="0" rIns="0" bIns="0" rtlCol="0" anchor="ctr"/>
-          <a:lstStyle/>
-          <a:p>
-            <a:pPr indent="0" marL="0">
-              <a:buNone/>
-            </a:pPr>
-            <a:r>
-              <a:rPr lang="en-US" sz="1000" dirty="0">
-                <a:solidFill>
-                  <a:srgbClr val="5E5E5E"/>
-                </a:solidFill>
-                <a:latin typeface="NVIDIA Sans" pitchFamily="34" charset="0"/>
-                <a:ea typeface="NVIDIA Sans" pitchFamily="34" charset="-122"/>
-                <a:cs typeface="NVIDIA Sans" pitchFamily="34" charset="-120"/>
-              </a:rPr>
-              <a:t>Idle / launch gaps</a:t>
-            </a:r>
-            <a:endParaRPr lang="en-US" sz="1000" dirty="0"/>
-          </a:p>
-        </p:txBody>
-      </p:sp>
-      <p:sp>
-        <p:nvSpPr>
-          <p:cNvPr id="25" name="Text 23"/>
-          <p:cNvSpPr/>
-          <p:nvPr/>
-        </p:nvSpPr>
-        <p:spPr>
-          <a:xfrm>
-            <a:off x="457200" y="4261104"/>
-            <a:ext cx="8229600" cy="182880"/>
-          </a:xfrm>
-          <a:prstGeom prst="rect">
-            <a:avLst/>
-          </a:prstGeom>
-          <a:noFill/>
-          <a:ln/>
-        </p:spPr>
-        <p:txBody>
-          <a:bodyPr wrap="square" lIns="0" tIns="0" rIns="0" bIns="0" rtlCol="0" anchor="ctr"/>
-          <a:lstStyle/>
-          <a:p>
-            <a:pPr indent="0" marL="0">
-              <a:buNone/>
-            </a:pPr>
-            <a:r>
-              <a:rPr lang="en-US" sz="950" i="1" dirty="0">
-                <a:solidFill>
-                  <a:srgbClr val="8C8C8C"/>
-                </a:solidFill>
-                <a:latin typeface="NVIDIA Sans" pitchFamily="34" charset="0"/>
-                <a:ea typeface="NVIDIA Sans" pitchFamily="34" charset="-122"/>
-                <a:cs typeface="NVIDIA Sans" pitchFamily="34" charset="-120"/>
-              </a:rPr>
-              <a:t>Gradient AllReduce 15.1 GB/step + optimizer AllGather 15.1 GB/step (bf16). Idle from 205 ms to 43 ms.</a:t>
-            </a:r>
-            <a:endParaRPr lang="en-US" sz="950" dirty="0"/>
-          </a:p>
-        </p:txBody>
-      </p:sp>
-      <p:sp>
-        <p:nvSpPr>
-          <p:cNvPr id="26" name="Text 24"/>
+          <p:cNvPr id="96" name="Text 94"/>
           <p:cNvSpPr/>
           <p:nvPr/>
         </p:nvSpPr>
@@ -7149,7 +8527,7 @@
       </p:sp>
       <p:sp>
         <p:nvSpPr>
-          <p:cNvPr id="27" name="Text 25"/>
+          <p:cNvPr id="97" name="Text 95"/>
           <p:cNvSpPr/>
           <p:nvPr/>
         </p:nvSpPr>
@@ -7188,7 +8566,7 @@
       </p:sp>
       <p:sp>
         <p:nvSpPr>
-          <p:cNvPr id="28" name="Shape 26"/>
+          <p:cNvPr id="98" name="Shape 96"/>
           <p:cNvSpPr/>
           <p:nvPr/>
         </p:nvSpPr>
@@ -7208,7 +8586,7 @@
       </p:sp>
       <p:pic>
         <p:nvPicPr>
-          <p:cNvPr id="29" name="Image 0" descr="/app/logos/nvidia-logo-blk-sm.png">    </p:cNvPr>
+          <p:cNvPr id="99" name="Image 0" descr="/app/logos/nvidia-logo-blk-sm.png">    </p:cNvPr>
           <p:cNvPicPr>
             <a:picLocks noChangeAspect="1"/>
           </p:cNvPicPr>
@@ -10688,7 +12066,7 @@
                 <a:ea typeface="NVIDIA Sans" pitchFamily="34" charset="-122"/>
                 <a:cs typeface="NVIDIA Sans" pitchFamily="34" charset="-120"/>
               </a:rPr>
-              <a:t>Optimizer tail (~25 ms)  </a:t>
+              <a:t>Exposed parameter AllGather (44 ms)  </a:t>
             </a:r>
             <a:pPr indent="0" marL="0">
               <a:buNone/>
@@ -10702,7 +12080,7 @@
                 <a:ea typeface="NVIDIA Sans" pitchFamily="34" charset="-122"/>
                 <a:cs typeface="NVIDIA Sans" pitchFamily="34" charset="-120"/>
               </a:rPr>
-              <a:t>[compiled autograd]</a:t>
+              <a:t>[FSDP or async ZeRO-2]</a:t>
             </a:r>
             <a:endParaRPr lang="en-US" sz="1250" dirty="0"/>
           </a:p>
@@ -10741,7 +12119,7 @@
                 <a:ea typeface="NVIDIA Sans" pitchFamily="34" charset="-122"/>
                 <a:cs typeface="NVIDIA Sans" pitchFamily="34" charset="-120"/>
               </a:rPr>
-              <a:t>ZeRO-2 optimizer step + AllGather at step end; compiled autograd / fused optimizer can overlap part of it.</a:t>
+              <a:t>Optimization shrank compute — the step-end AllGather is now fully exposed and ZeRO-2 cannot overlap it. Adopt FSDP (overlapped unshard) or extend ZeRO-2 with an async parameter gather.</a:t>
             </a:r>
             <a:endParaRPr lang="en-US" sz="1000" dirty="0"/>
           </a:p>

</xml_diff>

<commit_message>
docs(slides): merge ruled-out and headroom into one closing page (13 pages total)
</commit_message>
<xml_diff>
--- a/docs/slides/qwenpi-optimization.pptx
+++ b/docs/slides/qwenpi-optimization.pptx
@@ -18,10 +18,9 @@
     <p:sldId id="266" r:id="rId12"/>
     <p:sldId id="267" r:id="rId13"/>
     <p:sldId id="268" r:id="rId14"/>
-    <p:sldId id="269" r:id="rId15"/>
   </p:sldIdLst>
   <p:notesMasterIdLst>
-    <p:notesMasterId r:id="rId16"/>
+    <p:notesMasterId r:id="rId15"/>
   </p:notesMasterIdLst>
   <p:sldSz cx="9144000" cy="5143500"/>
   <p:notesSz cx="5143500" cy="9144000"/>
@@ -3623,7 +3622,9 @@
           <a:p>
             <a:r>
               <a:rPr lang="en-US" dirty="0"/>
-              <a:t>This slide is the credibility anchor: what we did NOT ship is as evidence-based as what we did.</a:t>
+              <a:t>Dropped from the old ruled-out table (internal detail, keep for Q&amp;A): masked_scatter nonzero-sync patch measured 0 ms (the AllReduce tail is gradient-readiness-bound); MRoPE cache is neutral at the final config (CUDA Graphs hide it) and kept for CPU headroom.
+Optimizer math (~26 ms busy) additionally has a compiled-autograd / fused-optimizer lever, separate from the AllGather overlap.
+[IMPORTANT] Close: 3.2x at bs8 and 340 samples/node/s at bs24 are banked; this page is the go-forward plan.</a:t>
             </a:r>
             <a:endParaRPr lang="en-US" dirty="0"/>
           </a:p>
@@ -3647,96 +3648,6 @@
             <a:fld id="{F7021451-1387-4CA6-816F-3879F97B5CBC}" type="slidenum">
               <a:rPr lang="en-US"/>
               <a:t>13</a:t>
-            </a:fld>
-            <a:endParaRPr lang="en-US"/>
-          </a:p>
-        </p:txBody>
-      </p:sp>
-    </p:spTree>
-    <p:extLst>
-      <p:ext uri="{BB962C8B-B14F-4D97-AF65-F5344CB8AC3E}">
-        <p14:creationId xmlns:p14="http://schemas.microsoft.com/office/powerpoint/2010/main" val="1024086991"/>
-      </p:ext>
-    </p:extLst>
-  </p:cSld>
-  <p:clrMapOvr>
-    <a:masterClrMapping/>
-  </p:clrMapOvr>
-</p:notes>
-</file>
-
-<file path=ppt/notesSlides/notesSlide14.xml><?xml version="1.0" encoding="utf-8"?>
-<p:notes xmlns:a="http://schemas.openxmlformats.org/drawingml/2006/main" xmlns:r="http://schemas.openxmlformats.org/officeDocument/2006/relationships" xmlns:p="http://schemas.openxmlformats.org/presentationml/2006/main">
-  <p:cSld>
-    <p:spTree>
-      <p:nvGrpSpPr>
-        <p:cNvPr id="1" name=""/>
-        <p:cNvGrpSpPr/>
-        <p:nvPr/>
-      </p:nvGrpSpPr>
-      <p:grpSpPr>
-        <a:xfrm>
-          <a:off x="0" y="0"/>
-          <a:ext cx="0" cy="0"/>
-          <a:chOff x="0" y="0"/>
-          <a:chExt cx="0" cy="0"/>
-        </a:xfrm>
-      </p:grpSpPr>
-      <p:sp>
-        <p:nvSpPr>
-          <p:cNvPr id="2" name="Slide Image Placeholder 1"/>
-          <p:cNvSpPr>
-            <a:spLocks noGrp="1" noRot="1" noChangeAspect="1"/>
-          </p:cNvSpPr>
-          <p:nvPr>
-            <p:ph type="sldImg"/>
-          </p:nvPr>
-        </p:nvSpPr>
-        <p:spPr/>
-      </p:sp>
-      <p:sp>
-        <p:nvSpPr>
-          <p:cNvPr id="3" name="Notes Placeholder 2"/>
-          <p:cNvSpPr>
-            <a:spLocks noGrp="1"/>
-          </p:cNvSpPr>
-          <p:nvPr>
-            <p:ph type="body" idx="1"/>
-          </p:nvPr>
-        </p:nvSpPr>
-        <p:spPr/>
-        <p:txBody>
-          <a:bodyPr/>
-          <a:lstStyle/>
-          <a:p>
-            <a:r>
-              <a:rPr lang="en-US" dirty="0"/>
-              <a:t>AllGather card: optimizer math itself (~26 ms busy) has a separate compiled-autograd / fused-optimizer lever; the 44 ms AllGather is the structural ZeRO-2 limit.
-Everything shipped is one MR per optimization with measured before/after — the repo history is the reproducibility story.
-[IMPORTANT] Close: 3.2x is banked; the roadmap above is how we keep going.</a:t>
-            </a:r>
-            <a:endParaRPr lang="en-US" dirty="0"/>
-          </a:p>
-        </p:txBody>
-      </p:sp>
-      <p:sp>
-        <p:nvSpPr>
-          <p:cNvPr id="4" name="Slide Number Placeholder 3"/>
-          <p:cNvSpPr>
-            <a:spLocks noGrp="1"/>
-          </p:cNvSpPr>
-          <p:nvPr>
-            <p:ph type="sldNum" sz="quarter" idx="10"/>
-          </p:nvPr>
-        </p:nvSpPr>
-        <p:spPr/>
-        <p:txBody>
-          <a:bodyPr/>
-          <a:lstStyle/>
-          <a:p>
-            <a:fld id="{F7021451-1387-4CA6-816F-3879F97B5CBC}" type="slidenum">
-              <a:rPr lang="en-US"/>
-              <a:t>14</a:t>
             </a:fld>
             <a:endParaRPr lang="en-US"/>
           </a:p>
@@ -9940,7 +9851,7 @@
                 <a:ea typeface="NVIDIA Sans" pitchFamily="34" charset="-122"/>
                 <a:cs typeface="NVIDIA Sans" pitchFamily="34" charset="-120"/>
               </a:rPr>
-              <a:t>What We Ruled Out — and How</a:t>
+              <a:t>What's Next — and What Not to Retry</a:t>
             </a:r>
             <a:endParaRPr lang="en-US" sz="3000" dirty="0"/>
           </a:p>
@@ -9979,1434 +9890,877 @@
                 <a:ea typeface="NVIDIA Sans" pitchFamily="34" charset="-122"/>
                 <a:cs typeface="NVIDIA Sans" pitchFamily="34" charset="-120"/>
               </a:rPr>
-              <a:t>Negative results are results: every hypothesis got a same-node experiment</a:t>
+              <a:t>Levers ranked by ceiling — and measured dead ends</a:t>
             </a:r>
             <a:endParaRPr lang="en-US" sz="1500" dirty="0"/>
           </a:p>
         </p:txBody>
       </p:sp>
-      <p:graphicFrame>
-        <p:nvGraphicFramePr>
-          <p:cNvPr id="14" name="Table 0"/>
-          <p:cNvGraphicFramePr>
-            <a:graphicFrameLocks noGrp="1"/>
-          </p:cNvGraphicFramePr>
-          <p:nvPr>
-            <p:extLst>
-              <p:ext uri="{D42A27DB-BD31-4B8C-83A1-F6EECF244321}">
-                <p14:modId xmlns:p14="http://schemas.microsoft.com/office/powerpoint/2010/main" val="1579011935"/>
-              </p:ext>
-            </p:extLst>
-          </p:nvPr>
-        </p:nvGraphicFramePr>
-        <p:xfrm>
-          <a:off x="457200" y="1325880"/>
-          <a:ext cx="8229600" cy="914400"/>
-        </p:xfrm>
-        <a:graphic>
-          <a:graphicData uri="http://schemas.openxmlformats.org/drawingml/2006/table">
-            <a:tbl>
-              <a:tblPr/>
-              <a:tblGrid>
-                <a:gridCol w="1965960"/>
-                <a:gridCol w="2011680"/>
-                <a:gridCol w="4251960"/>
-              </a:tblGrid>
-              <a:tr h="402336">
-                <a:tc>
-                  <a:txBody>
-                    <a:bodyPr/>
-                    <a:lstStyle/>
-                    <a:p>
-                      <a:pPr algn="l" indent="0" marL="0">
-                        <a:buNone/>
-                      </a:pPr>
-                      <a:r>
-                        <a:rPr lang="en-US" sz="1100" b="1" dirty="0">
-                          <a:solidFill>
-                            <a:srgbClr val="FFFFFF"/>
-                          </a:solidFill>
-                          <a:latin typeface="NVIDIA Sans" pitchFamily="34" charset="0"/>
-                          <a:ea typeface="NVIDIA Sans" pitchFamily="34" charset="-122"/>
-                          <a:cs typeface="NVIDIA Sans" pitchFamily="34" charset="-120"/>
-                        </a:rPr>
-                        <a:t>Hypothesis</a:t>
-                      </a:r>
-                      <a:endParaRPr lang="en-US" sz="1100" dirty="0">
-                        <a:latin typeface="NVIDIA Sans" charset="0"/>
-                        <a:ea typeface="NVIDIA Sans" charset="0"/>
-                        <a:cs typeface="NVIDIA Sans" charset="0"/>
-                      </a:endParaRPr>
-                    </a:p>
-                  </a:txBody>
-                  <a:tcPr marL="91440" marR="91440" marT="45720" marB="45720" anchor="ctr">
-                    <a:lnL w="6350" cap="flat" cmpd="sng" algn="ctr">
-                      <a:solidFill>
-                        <a:srgbClr val="CDCDCD"/>
-                      </a:solidFill>
-                      <a:prstDash val="solid"/>
-                      <a:round/>
-                      <a:headEnd type="none" w="med" len="med"/>
-                      <a:tailEnd type="none" w="med" len="med"/>
-                    </a:lnL>
-                    <a:lnR w="6350" cap="flat" cmpd="sng" algn="ctr">
-                      <a:solidFill>
-                        <a:srgbClr val="CDCDCD"/>
-                      </a:solidFill>
-                      <a:prstDash val="solid"/>
-                      <a:round/>
-                      <a:headEnd type="none" w="med" len="med"/>
-                      <a:tailEnd type="none" w="med" len="med"/>
-                    </a:lnR>
-                    <a:lnT w="6350" cap="flat" cmpd="sng" algn="ctr">
-                      <a:solidFill>
-                        <a:srgbClr val="CDCDCD"/>
-                      </a:solidFill>
-                      <a:prstDash val="solid"/>
-                      <a:round/>
-                      <a:headEnd type="none" w="med" len="med"/>
-                      <a:tailEnd type="none" w="med" len="med"/>
-                    </a:lnT>
-                    <a:lnB w="6350" cap="flat" cmpd="sng" algn="ctr">
-                      <a:solidFill>
-                        <a:srgbClr val="CDCDCD"/>
-                      </a:solidFill>
-                      <a:prstDash val="solid"/>
-                      <a:round/>
-                      <a:headEnd type="none" w="med" len="med"/>
-                      <a:tailEnd type="none" w="med" len="med"/>
-                    </a:lnB>
-                    <a:solidFill>
-                      <a:srgbClr val="76B900"/>
-                    </a:solidFill>
-                  </a:tcPr>
-                </a:tc>
-                <a:tc>
-                  <a:txBody>
-                    <a:bodyPr/>
-                    <a:lstStyle/>
-                    <a:p>
-                      <a:pPr algn="l" indent="0" marL="0">
-                        <a:buNone/>
-                      </a:pPr>
-                      <a:r>
-                        <a:rPr lang="en-US" sz="1100" b="1" dirty="0">
-                          <a:solidFill>
-                            <a:srgbClr val="FFFFFF"/>
-                          </a:solidFill>
-                          <a:latin typeface="NVIDIA Sans" pitchFamily="34" charset="0"/>
-                          <a:ea typeface="NVIDIA Sans" pitchFamily="34" charset="-122"/>
-                          <a:cs typeface="NVIDIA Sans" pitchFamily="34" charset="-120"/>
-                        </a:rPr>
-                        <a:t>Experiment</a:t>
-                      </a:r>
-                      <a:endParaRPr lang="en-US" sz="1100" dirty="0">
-                        <a:latin typeface="NVIDIA Sans" charset="0"/>
-                        <a:ea typeface="NVIDIA Sans" charset="0"/>
-                        <a:cs typeface="NVIDIA Sans" charset="0"/>
-                      </a:endParaRPr>
-                    </a:p>
-                  </a:txBody>
-                  <a:tcPr marL="91440" marR="91440" marT="45720" marB="45720" anchor="ctr">
-                    <a:lnL w="6350" cap="flat" cmpd="sng" algn="ctr">
-                      <a:solidFill>
-                        <a:srgbClr val="CDCDCD"/>
-                      </a:solidFill>
-                      <a:prstDash val="solid"/>
-                      <a:round/>
-                      <a:headEnd type="none" w="med" len="med"/>
-                      <a:tailEnd type="none" w="med" len="med"/>
-                    </a:lnL>
-                    <a:lnR w="6350" cap="flat" cmpd="sng" algn="ctr">
-                      <a:solidFill>
-                        <a:srgbClr val="CDCDCD"/>
-                      </a:solidFill>
-                      <a:prstDash val="solid"/>
-                      <a:round/>
-                      <a:headEnd type="none" w="med" len="med"/>
-                      <a:tailEnd type="none" w="med" len="med"/>
-                    </a:lnR>
-                    <a:lnT w="6350" cap="flat" cmpd="sng" algn="ctr">
-                      <a:solidFill>
-                        <a:srgbClr val="CDCDCD"/>
-                      </a:solidFill>
-                      <a:prstDash val="solid"/>
-                      <a:round/>
-                      <a:headEnd type="none" w="med" len="med"/>
-                      <a:tailEnd type="none" w="med" len="med"/>
-                    </a:lnT>
-                    <a:lnB w="6350" cap="flat" cmpd="sng" algn="ctr">
-                      <a:solidFill>
-                        <a:srgbClr val="CDCDCD"/>
-                      </a:solidFill>
-                      <a:prstDash val="solid"/>
-                      <a:round/>
-                      <a:headEnd type="none" w="med" len="med"/>
-                      <a:tailEnd type="none" w="med" len="med"/>
-                    </a:lnB>
-                    <a:solidFill>
-                      <a:srgbClr val="76B900"/>
-                    </a:solidFill>
-                  </a:tcPr>
-                </a:tc>
-                <a:tc>
-                  <a:txBody>
-                    <a:bodyPr/>
-                    <a:lstStyle/>
-                    <a:p>
-                      <a:pPr algn="l" indent="0" marL="0">
-                        <a:buNone/>
-                      </a:pPr>
-                      <a:r>
-                        <a:rPr lang="en-US" sz="1100" b="1" dirty="0">
-                          <a:solidFill>
-                            <a:srgbClr val="FFFFFF"/>
-                          </a:solidFill>
-                          <a:latin typeface="NVIDIA Sans" pitchFamily="34" charset="0"/>
-                          <a:ea typeface="NVIDIA Sans" pitchFamily="34" charset="-122"/>
-                          <a:cs typeface="NVIDIA Sans" pitchFamily="34" charset="-120"/>
-                        </a:rPr>
-                        <a:t>Verdict</a:t>
-                      </a:r>
-                      <a:endParaRPr lang="en-US" sz="1100" dirty="0">
-                        <a:latin typeface="NVIDIA Sans" charset="0"/>
-                        <a:ea typeface="NVIDIA Sans" charset="0"/>
-                        <a:cs typeface="NVIDIA Sans" charset="0"/>
-                      </a:endParaRPr>
-                    </a:p>
-                  </a:txBody>
-                  <a:tcPr marL="91440" marR="91440" marT="45720" marB="45720" anchor="ctr">
-                    <a:lnL w="6350" cap="flat" cmpd="sng" algn="ctr">
-                      <a:solidFill>
-                        <a:srgbClr val="CDCDCD"/>
-                      </a:solidFill>
-                      <a:prstDash val="solid"/>
-                      <a:round/>
-                      <a:headEnd type="none" w="med" len="med"/>
-                      <a:tailEnd type="none" w="med" len="med"/>
-                    </a:lnL>
-                    <a:lnR w="6350" cap="flat" cmpd="sng" algn="ctr">
-                      <a:solidFill>
-                        <a:srgbClr val="CDCDCD"/>
-                      </a:solidFill>
-                      <a:prstDash val="solid"/>
-                      <a:round/>
-                      <a:headEnd type="none" w="med" len="med"/>
-                      <a:tailEnd type="none" w="med" len="med"/>
-                    </a:lnR>
-                    <a:lnT w="6350" cap="flat" cmpd="sng" algn="ctr">
-                      <a:solidFill>
-                        <a:srgbClr val="CDCDCD"/>
-                      </a:solidFill>
-                      <a:prstDash val="solid"/>
-                      <a:round/>
-                      <a:headEnd type="none" w="med" len="med"/>
-                      <a:tailEnd type="none" w="med" len="med"/>
-                    </a:lnT>
-                    <a:lnB w="6350" cap="flat" cmpd="sng" algn="ctr">
-                      <a:solidFill>
-                        <a:srgbClr val="CDCDCD"/>
-                      </a:solidFill>
-                      <a:prstDash val="solid"/>
-                      <a:round/>
-                      <a:headEnd type="none" w="med" len="med"/>
-                      <a:tailEnd type="none" w="med" len="med"/>
-                    </a:lnB>
-                    <a:solidFill>
-                      <a:srgbClr val="76B900"/>
-                    </a:solidFill>
-                  </a:tcPr>
-                </a:tc>
-              </a:tr>
-              <a:tr h="402336">
-                <a:tc>
-                  <a:txBody>
-                    <a:bodyPr/>
-                    <a:lstStyle/>
-                    <a:p>
-                      <a:pPr algn="l" indent="0" marL="0">
-                        <a:buNone/>
-                      </a:pPr>
-                      <a:r>
-                        <a:rPr lang="en-US" sz="1050" b="1" dirty="0">
-                          <a:solidFill>
-                            <a:srgbClr val="000000"/>
-                          </a:solidFill>
-                          <a:latin typeface="NVIDIA Sans" pitchFamily="34" charset="0"/>
-                          <a:ea typeface="NVIDIA Sans" pitchFamily="34" charset="-122"/>
-                          <a:cs typeface="NVIDIA Sans" pitchFamily="34" charset="-120"/>
-                        </a:rPr>
-                        <a:t>FA2 for the text stack</a:t>
-                      </a:r>
-                      <a:endParaRPr lang="en-US" sz="1050" dirty="0">
-                        <a:latin typeface="NVIDIA Sans" charset="0"/>
-                        <a:ea typeface="NVIDIA Sans" charset="0"/>
-                        <a:cs typeface="NVIDIA Sans" charset="0"/>
-                      </a:endParaRPr>
-                    </a:p>
-                  </a:txBody>
-                  <a:tcPr marL="91440" marR="91440" marT="45720" marB="45720" anchor="ctr">
-                    <a:lnL w="6350" cap="flat" cmpd="sng" algn="ctr">
-                      <a:solidFill>
-                        <a:srgbClr val="CDCDCD"/>
-                      </a:solidFill>
-                      <a:prstDash val="solid"/>
-                      <a:round/>
-                      <a:headEnd type="none" w="med" len="med"/>
-                      <a:tailEnd type="none" w="med" len="med"/>
-                    </a:lnL>
-                    <a:lnR w="6350" cap="flat" cmpd="sng" algn="ctr">
-                      <a:solidFill>
-                        <a:srgbClr val="CDCDCD"/>
-                      </a:solidFill>
-                      <a:prstDash val="solid"/>
-                      <a:round/>
-                      <a:headEnd type="none" w="med" len="med"/>
-                      <a:tailEnd type="none" w="med" len="med"/>
-                    </a:lnR>
-                    <a:lnT w="6350" cap="flat" cmpd="sng" algn="ctr">
-                      <a:solidFill>
-                        <a:srgbClr val="CDCDCD"/>
-                      </a:solidFill>
-                      <a:prstDash val="solid"/>
-                      <a:round/>
-                      <a:headEnd type="none" w="med" len="med"/>
-                      <a:tailEnd type="none" w="med" len="med"/>
-                    </a:lnT>
-                    <a:lnB w="6350" cap="flat" cmpd="sng" algn="ctr">
-                      <a:solidFill>
-                        <a:srgbClr val="CDCDCD"/>
-                      </a:solidFill>
-                      <a:prstDash val="solid"/>
-                      <a:round/>
-                      <a:headEnd type="none" w="med" len="med"/>
-                      <a:tailEnd type="none" w="med" len="med"/>
-                    </a:lnB>
-                  </a:tcPr>
-                </a:tc>
-                <a:tc>
-                  <a:txBody>
-                    <a:bodyPr/>
-                    <a:lstStyle/>
-                    <a:p>
-                      <a:pPr algn="l" indent="0" marL="0">
-                        <a:buNone/>
-                      </a:pPr>
-                      <a:r>
-                        <a:rPr lang="en-US" sz="1000" dirty="0">
-                          <a:solidFill>
-                            <a:srgbClr val="000000"/>
-                          </a:solidFill>
-                          <a:latin typeface="NVIDIA Sans" pitchFamily="34" charset="0"/>
-                          <a:ea typeface="NVIDIA Sans" pitchFamily="34" charset="-122"/>
-                          <a:cs typeface="NVIDIA Sans" pitchFamily="34" charset="-120"/>
-                        </a:rPr>
-                        <a:t>A/B at seq 192</a:t>
-                      </a:r>
-                      <a:endParaRPr lang="en-US" sz="1000" dirty="0">
-                        <a:latin typeface="NVIDIA Sans" charset="0"/>
-                        <a:ea typeface="NVIDIA Sans" charset="0"/>
-                        <a:cs typeface="NVIDIA Sans" charset="0"/>
-                      </a:endParaRPr>
-                    </a:p>
-                  </a:txBody>
-                  <a:tcPr marL="91440" marR="91440" marT="45720" marB="45720" anchor="ctr">
-                    <a:lnL w="6350" cap="flat" cmpd="sng" algn="ctr">
-                      <a:solidFill>
-                        <a:srgbClr val="CDCDCD"/>
-                      </a:solidFill>
-                      <a:prstDash val="solid"/>
-                      <a:round/>
-                      <a:headEnd type="none" w="med" len="med"/>
-                      <a:tailEnd type="none" w="med" len="med"/>
-                    </a:lnL>
-                    <a:lnR w="6350" cap="flat" cmpd="sng" algn="ctr">
-                      <a:solidFill>
-                        <a:srgbClr val="CDCDCD"/>
-                      </a:solidFill>
-                      <a:prstDash val="solid"/>
-                      <a:round/>
-                      <a:headEnd type="none" w="med" len="med"/>
-                      <a:tailEnd type="none" w="med" len="med"/>
-                    </a:lnR>
-                    <a:lnT w="6350" cap="flat" cmpd="sng" algn="ctr">
-                      <a:solidFill>
-                        <a:srgbClr val="CDCDCD"/>
-                      </a:solidFill>
-                      <a:prstDash val="solid"/>
-                      <a:round/>
-                      <a:headEnd type="none" w="med" len="med"/>
-                      <a:tailEnd type="none" w="med" len="med"/>
-                    </a:lnT>
-                    <a:lnB w="6350" cap="flat" cmpd="sng" algn="ctr">
-                      <a:solidFill>
-                        <a:srgbClr val="CDCDCD"/>
-                      </a:solidFill>
-                      <a:prstDash val="solid"/>
-                      <a:round/>
-                      <a:headEnd type="none" w="med" len="med"/>
-                      <a:tailEnd type="none" w="med" len="med"/>
-                    </a:lnB>
-                  </a:tcPr>
-                </a:tc>
-                <a:tc>
-                  <a:txBody>
-                    <a:bodyPr/>
-                    <a:lstStyle/>
-                    <a:p>
-                      <a:pPr algn="l" indent="0" marL="0">
-                        <a:buNone/>
-                      </a:pPr>
-                      <a:r>
-                        <a:rPr lang="en-US" sz="1000" dirty="0">
-                          <a:solidFill>
-                            <a:srgbClr val="000000"/>
-                          </a:solidFill>
-                          <a:latin typeface="NVIDIA Sans" pitchFamily="34" charset="0"/>
-                          <a:ea typeface="NVIDIA Sans" pitchFamily="34" charset="-122"/>
-                          <a:cs typeface="NVIDIA Sans" pitchFamily="34" charset="-120"/>
-                        </a:rPr>
-                        <a:t>Slower (+10 ms): unpad/repad overhead exceeds kernel gains at short sequences</a:t>
-                      </a:r>
-                      <a:endParaRPr lang="en-US" sz="1000" dirty="0">
-                        <a:latin typeface="NVIDIA Sans" charset="0"/>
-                        <a:ea typeface="NVIDIA Sans" charset="0"/>
-                        <a:cs typeface="NVIDIA Sans" charset="0"/>
-                      </a:endParaRPr>
-                    </a:p>
-                  </a:txBody>
-                  <a:tcPr marL="91440" marR="91440" marT="45720" marB="45720" anchor="ctr">
-                    <a:lnL w="6350" cap="flat" cmpd="sng" algn="ctr">
-                      <a:solidFill>
-                        <a:srgbClr val="CDCDCD"/>
-                      </a:solidFill>
-                      <a:prstDash val="solid"/>
-                      <a:round/>
-                      <a:headEnd type="none" w="med" len="med"/>
-                      <a:tailEnd type="none" w="med" len="med"/>
-                    </a:lnL>
-                    <a:lnR w="6350" cap="flat" cmpd="sng" algn="ctr">
-                      <a:solidFill>
-                        <a:srgbClr val="CDCDCD"/>
-                      </a:solidFill>
-                      <a:prstDash val="solid"/>
-                      <a:round/>
-                      <a:headEnd type="none" w="med" len="med"/>
-                      <a:tailEnd type="none" w="med" len="med"/>
-                    </a:lnR>
-                    <a:lnT w="6350" cap="flat" cmpd="sng" algn="ctr">
-                      <a:solidFill>
-                        <a:srgbClr val="CDCDCD"/>
-                      </a:solidFill>
-                      <a:prstDash val="solid"/>
-                      <a:round/>
-                      <a:headEnd type="none" w="med" len="med"/>
-                      <a:tailEnd type="none" w="med" len="med"/>
-                    </a:lnT>
-                    <a:lnB w="6350" cap="flat" cmpd="sng" algn="ctr">
-                      <a:solidFill>
-                        <a:srgbClr val="CDCDCD"/>
-                      </a:solidFill>
-                      <a:prstDash val="solid"/>
-                      <a:round/>
-                      <a:headEnd type="none" w="med" len="med"/>
-                      <a:tailEnd type="none" w="med" len="med"/>
-                    </a:lnB>
-                  </a:tcPr>
-                </a:tc>
-              </a:tr>
-              <a:tr h="402336">
-                <a:tc>
-                  <a:txBody>
-                    <a:bodyPr/>
-                    <a:lstStyle/>
-                    <a:p>
-                      <a:pPr algn="l" indent="0" marL="0">
-                        <a:buNone/>
-                      </a:pPr>
-                      <a:r>
-                        <a:rPr lang="en-US" sz="1050" b="1" dirty="0">
-                          <a:solidFill>
-                            <a:srgbClr val="000000"/>
-                          </a:solidFill>
-                          <a:latin typeface="NVIDIA Sans" pitchFamily="34" charset="0"/>
-                          <a:ea typeface="NVIDIA Sans" pitchFamily="34" charset="-122"/>
-                          <a:cs typeface="NVIDIA Sans" pitchFamily="34" charset="-120"/>
-                        </a:rPr>
-                        <a:t>“NCCL is misconfigured”</a:t>
-                      </a:r>
-                      <a:endParaRPr lang="en-US" sz="1050" dirty="0">
-                        <a:latin typeface="NVIDIA Sans" charset="0"/>
-                        <a:ea typeface="NVIDIA Sans" charset="0"/>
-                        <a:cs typeface="NVIDIA Sans" charset="0"/>
-                      </a:endParaRPr>
-                    </a:p>
-                  </a:txBody>
-                  <a:tcPr marL="91440" marR="91440" marT="45720" marB="45720" anchor="ctr">
-                    <a:lnL w="6350" cap="flat" cmpd="sng" algn="ctr">
-                      <a:solidFill>
-                        <a:srgbClr val="CDCDCD"/>
-                      </a:solidFill>
-                      <a:prstDash val="solid"/>
-                      <a:round/>
-                      <a:headEnd type="none" w="med" len="med"/>
-                      <a:tailEnd type="none" w="med" len="med"/>
-                    </a:lnL>
-                    <a:lnR w="6350" cap="flat" cmpd="sng" algn="ctr">
-                      <a:solidFill>
-                        <a:srgbClr val="CDCDCD"/>
-                      </a:solidFill>
-                      <a:prstDash val="solid"/>
-                      <a:round/>
-                      <a:headEnd type="none" w="med" len="med"/>
-                      <a:tailEnd type="none" w="med" len="med"/>
-                    </a:lnR>
-                    <a:lnT w="6350" cap="flat" cmpd="sng" algn="ctr">
-                      <a:solidFill>
-                        <a:srgbClr val="CDCDCD"/>
-                      </a:solidFill>
-                      <a:prstDash val="solid"/>
-                      <a:round/>
-                      <a:headEnd type="none" w="med" len="med"/>
-                      <a:tailEnd type="none" w="med" len="med"/>
-                    </a:lnT>
-                    <a:lnB w="6350" cap="flat" cmpd="sng" algn="ctr">
-                      <a:solidFill>
-                        <a:srgbClr val="CDCDCD"/>
-                      </a:solidFill>
-                      <a:prstDash val="solid"/>
-                      <a:round/>
-                      <a:headEnd type="none" w="med" len="med"/>
-                      <a:tailEnd type="none" w="med" len="med"/>
-                    </a:lnB>
-                  </a:tcPr>
-                </a:tc>
-                <a:tc>
-                  <a:txBody>
-                    <a:bodyPr/>
-                    <a:lstStyle/>
-                    <a:p>
-                      <a:pPr algn="l" indent="0" marL="0">
-                        <a:buNone/>
-                      </a:pPr>
-                      <a:r>
-                        <a:rPr lang="en-US" sz="1000" dirty="0">
-                          <a:solidFill>
-                            <a:srgbClr val="000000"/>
-                          </a:solidFill>
-                          <a:latin typeface="NVIDIA Sans" pitchFamily="34" charset="0"/>
-                          <a:ea typeface="NVIDIA Sans" pitchFamily="34" charset="-122"/>
-                          <a:cs typeface="NVIDIA Sans" pitchFamily="34" charset="-120"/>
-                        </a:rPr>
-                        <a:t>Forced protocols, NCCL_DEBUG, microbenchmark</a:t>
-                      </a:r>
-                      <a:endParaRPr lang="en-US" sz="1000" dirty="0">
-                        <a:latin typeface="NVIDIA Sans" charset="0"/>
-                        <a:ea typeface="NVIDIA Sans" charset="0"/>
-                        <a:cs typeface="NVIDIA Sans" charset="0"/>
-                      </a:endParaRPr>
-                    </a:p>
-                  </a:txBody>
-                  <a:tcPr marL="91440" marR="91440" marT="45720" marB="45720" anchor="ctr">
-                    <a:lnL w="6350" cap="flat" cmpd="sng" algn="ctr">
-                      <a:solidFill>
-                        <a:srgbClr val="CDCDCD"/>
-                      </a:solidFill>
-                      <a:prstDash val="solid"/>
-                      <a:round/>
-                      <a:headEnd type="none" w="med" len="med"/>
-                      <a:tailEnd type="none" w="med" len="med"/>
-                    </a:lnL>
-                    <a:lnR w="6350" cap="flat" cmpd="sng" algn="ctr">
-                      <a:solidFill>
-                        <a:srgbClr val="CDCDCD"/>
-                      </a:solidFill>
-                      <a:prstDash val="solid"/>
-                      <a:round/>
-                      <a:headEnd type="none" w="med" len="med"/>
-                      <a:tailEnd type="none" w="med" len="med"/>
-                    </a:lnR>
-                    <a:lnT w="6350" cap="flat" cmpd="sng" algn="ctr">
-                      <a:solidFill>
-                        <a:srgbClr val="CDCDCD"/>
-                      </a:solidFill>
-                      <a:prstDash val="solid"/>
-                      <a:round/>
-                      <a:headEnd type="none" w="med" len="med"/>
-                      <a:tailEnd type="none" w="med" len="med"/>
-                    </a:lnT>
-                    <a:lnB w="6350" cap="flat" cmpd="sng" algn="ctr">
-                      <a:solidFill>
-                        <a:srgbClr val="CDCDCD"/>
-                      </a:solidFill>
-                      <a:prstDash val="solid"/>
-                      <a:round/>
-                      <a:headEnd type="none" w="med" len="med"/>
-                      <a:tailEnd type="none" w="med" len="med"/>
-                    </a:lnB>
-                  </a:tcPr>
-                </a:tc>
-                <a:tc>
-                  <a:txBody>
-                    <a:bodyPr/>
-                    <a:lstStyle/>
-                    <a:p>
-                      <a:pPr algn="l" indent="0" marL="0">
-                        <a:buNone/>
-                      </a:pPr>
-                      <a:r>
-                        <a:rPr lang="en-US" sz="1000" dirty="0">
-                          <a:solidFill>
-                            <a:srgbClr val="000000"/>
-                          </a:solidFill>
-                          <a:latin typeface="NVIDIA Sans" pitchFamily="34" charset="0"/>
-                          <a:ea typeface="NVIDIA Sans" pitchFamily="34" charset="-122"/>
-                          <a:cs typeface="NVIDIA Sans" pitchFamily="34" charset="-120"/>
-                        </a:rPr>
-                        <a:t>AllReduce already at 478 GB/s busbw = NVLink ceiling; kernel-name suffix was a red herring</a:t>
-                      </a:r>
-                      <a:endParaRPr lang="en-US" sz="1000" dirty="0">
-                        <a:latin typeface="NVIDIA Sans" charset="0"/>
-                        <a:ea typeface="NVIDIA Sans" charset="0"/>
-                        <a:cs typeface="NVIDIA Sans" charset="0"/>
-                      </a:endParaRPr>
-                    </a:p>
-                  </a:txBody>
-                  <a:tcPr marL="91440" marR="91440" marT="45720" marB="45720" anchor="ctr">
-                    <a:lnL w="6350" cap="flat" cmpd="sng" algn="ctr">
-                      <a:solidFill>
-                        <a:srgbClr val="CDCDCD"/>
-                      </a:solidFill>
-                      <a:prstDash val="solid"/>
-                      <a:round/>
-                      <a:headEnd type="none" w="med" len="med"/>
-                      <a:tailEnd type="none" w="med" len="med"/>
-                    </a:lnL>
-                    <a:lnR w="6350" cap="flat" cmpd="sng" algn="ctr">
-                      <a:solidFill>
-                        <a:srgbClr val="CDCDCD"/>
-                      </a:solidFill>
-                      <a:prstDash val="solid"/>
-                      <a:round/>
-                      <a:headEnd type="none" w="med" len="med"/>
-                      <a:tailEnd type="none" w="med" len="med"/>
-                    </a:lnR>
-                    <a:lnT w="6350" cap="flat" cmpd="sng" algn="ctr">
-                      <a:solidFill>
-                        <a:srgbClr val="CDCDCD"/>
-                      </a:solidFill>
-                      <a:prstDash val="solid"/>
-                      <a:round/>
-                      <a:headEnd type="none" w="med" len="med"/>
-                      <a:tailEnd type="none" w="med" len="med"/>
-                    </a:lnT>
-                    <a:lnB w="6350" cap="flat" cmpd="sng" algn="ctr">
-                      <a:solidFill>
-                        <a:srgbClr val="CDCDCD"/>
-                      </a:solidFill>
-                      <a:prstDash val="solid"/>
-                      <a:round/>
-                      <a:headEnd type="none" w="med" len="med"/>
-                      <a:tailEnd type="none" w="med" len="med"/>
-                    </a:lnB>
-                  </a:tcPr>
-                </a:tc>
-              </a:tr>
-              <a:tr h="402336">
-                <a:tc>
-                  <a:txBody>
-                    <a:bodyPr/>
-                    <a:lstStyle/>
-                    <a:p>
-                      <a:pPr algn="l" indent="0" marL="0">
-                        <a:buNone/>
-                      </a:pPr>
-                      <a:r>
-                        <a:rPr lang="en-US" sz="1050" b="1" dirty="0">
-                          <a:solidFill>
-                            <a:srgbClr val="000000"/>
-                          </a:solidFill>
-                          <a:latin typeface="NVIDIA Sans" pitchFamily="34" charset="0"/>
-                          <a:ea typeface="NVIDIA Sans" pitchFamily="34" charset="-122"/>
-                          <a:cs typeface="NVIDIA Sans" pitchFamily="34" charset="-120"/>
-                        </a:rPr>
-                        <a:t>masked_scatter nonzero sync</a:t>
-                      </a:r>
-                      <a:endParaRPr lang="en-US" sz="1050" dirty="0">
-                        <a:latin typeface="NVIDIA Sans" charset="0"/>
-                        <a:ea typeface="NVIDIA Sans" charset="0"/>
-                        <a:cs typeface="NVIDIA Sans" charset="0"/>
-                      </a:endParaRPr>
-                    </a:p>
-                  </a:txBody>
-                  <a:tcPr marL="91440" marR="91440" marT="45720" marB="45720" anchor="ctr">
-                    <a:lnL w="6350" cap="flat" cmpd="sng" algn="ctr">
-                      <a:solidFill>
-                        <a:srgbClr val="CDCDCD"/>
-                      </a:solidFill>
-                      <a:prstDash val="solid"/>
-                      <a:round/>
-                      <a:headEnd type="none" w="med" len="med"/>
-                      <a:tailEnd type="none" w="med" len="med"/>
-                    </a:lnL>
-                    <a:lnR w="6350" cap="flat" cmpd="sng" algn="ctr">
-                      <a:solidFill>
-                        <a:srgbClr val="CDCDCD"/>
-                      </a:solidFill>
-                      <a:prstDash val="solid"/>
-                      <a:round/>
-                      <a:headEnd type="none" w="med" len="med"/>
-                      <a:tailEnd type="none" w="med" len="med"/>
-                    </a:lnR>
-                    <a:lnT w="6350" cap="flat" cmpd="sng" algn="ctr">
-                      <a:solidFill>
-                        <a:srgbClr val="CDCDCD"/>
-                      </a:solidFill>
-                      <a:prstDash val="solid"/>
-                      <a:round/>
-                      <a:headEnd type="none" w="med" len="med"/>
-                      <a:tailEnd type="none" w="med" len="med"/>
-                    </a:lnT>
-                    <a:lnB w="6350" cap="flat" cmpd="sng" algn="ctr">
-                      <a:solidFill>
-                        <a:srgbClr val="CDCDCD"/>
-                      </a:solidFill>
-                      <a:prstDash val="solid"/>
-                      <a:round/>
-                      <a:headEnd type="none" w="med" len="med"/>
-                      <a:tailEnd type="none" w="med" len="med"/>
-                    </a:lnB>
-                  </a:tcPr>
-                </a:tc>
-                <a:tc>
-                  <a:txBody>
-                    <a:bodyPr/>
-                    <a:lstStyle/>
-                    <a:p>
-                      <a:pPr algn="l" indent="0" marL="0">
-                        <a:buNone/>
-                      </a:pPr>
-                      <a:r>
-                        <a:rPr lang="en-US" sz="1000" dirty="0">
-                          <a:solidFill>
-                            <a:srgbClr val="000000"/>
-                          </a:solidFill>
-                          <a:latin typeface="NVIDIA Sans" pitchFamily="34" charset="0"/>
-                          <a:ea typeface="NVIDIA Sans" pitchFamily="34" charset="-122"/>
-                          <a:cs typeface="NVIDIA Sans" pitchFamily="34" charset="-120"/>
-                        </a:rPr>
-                        <a:t>index_copy patch, bitwise-equal unit test</a:t>
-                      </a:r>
-                      <a:endParaRPr lang="en-US" sz="1000" dirty="0">
-                        <a:latin typeface="NVIDIA Sans" charset="0"/>
-                        <a:ea typeface="NVIDIA Sans" charset="0"/>
-                        <a:cs typeface="NVIDIA Sans" charset="0"/>
-                      </a:endParaRPr>
-                    </a:p>
-                  </a:txBody>
-                  <a:tcPr marL="91440" marR="91440" marT="45720" marB="45720" anchor="ctr">
-                    <a:lnL w="6350" cap="flat" cmpd="sng" algn="ctr">
-                      <a:solidFill>
-                        <a:srgbClr val="CDCDCD"/>
-                      </a:solidFill>
-                      <a:prstDash val="solid"/>
-                      <a:round/>
-                      <a:headEnd type="none" w="med" len="med"/>
-                      <a:tailEnd type="none" w="med" len="med"/>
-                    </a:lnL>
-                    <a:lnR w="6350" cap="flat" cmpd="sng" algn="ctr">
-                      <a:solidFill>
-                        <a:srgbClr val="CDCDCD"/>
-                      </a:solidFill>
-                      <a:prstDash val="solid"/>
-                      <a:round/>
-                      <a:headEnd type="none" w="med" len="med"/>
-                      <a:tailEnd type="none" w="med" len="med"/>
-                    </a:lnR>
-                    <a:lnT w="6350" cap="flat" cmpd="sng" algn="ctr">
-                      <a:solidFill>
-                        <a:srgbClr val="CDCDCD"/>
-                      </a:solidFill>
-                      <a:prstDash val="solid"/>
-                      <a:round/>
-                      <a:headEnd type="none" w="med" len="med"/>
-                      <a:tailEnd type="none" w="med" len="med"/>
-                    </a:lnT>
-                    <a:lnB w="6350" cap="flat" cmpd="sng" algn="ctr">
-                      <a:solidFill>
-                        <a:srgbClr val="CDCDCD"/>
-                      </a:solidFill>
-                      <a:prstDash val="solid"/>
-                      <a:round/>
-                      <a:headEnd type="none" w="med" len="med"/>
-                      <a:tailEnd type="none" w="med" len="med"/>
-                    </a:lnB>
-                  </a:tcPr>
-                </a:tc>
-                <a:tc>
-                  <a:txBody>
-                    <a:bodyPr/>
-                    <a:lstStyle/>
-                    <a:p>
-                      <a:pPr algn="l" indent="0" marL="0">
-                        <a:buNone/>
-                      </a:pPr>
-                      <a:r>
-                        <a:rPr lang="en-US" sz="1000" dirty="0">
-                          <a:solidFill>
-                            <a:srgbClr val="000000"/>
-                          </a:solidFill>
-                          <a:latin typeface="NVIDIA Sans" pitchFamily="34" charset="0"/>
-                          <a:ea typeface="NVIDIA Sans" pitchFamily="34" charset="-122"/>
-                          <a:cs typeface="NVIDIA Sans" pitchFamily="34" charset="-120"/>
-                        </a:rPr>
-                        <a:t>0 ms: the AllReduce tail is gradient-readiness-bound, so hiding the sync moves nothing</a:t>
-                      </a:r>
-                      <a:endParaRPr lang="en-US" sz="1000" dirty="0">
-                        <a:latin typeface="NVIDIA Sans" charset="0"/>
-                        <a:ea typeface="NVIDIA Sans" charset="0"/>
-                        <a:cs typeface="NVIDIA Sans" charset="0"/>
-                      </a:endParaRPr>
-                    </a:p>
-                  </a:txBody>
-                  <a:tcPr marL="91440" marR="91440" marT="45720" marB="45720" anchor="ctr">
-                    <a:lnL w="6350" cap="flat" cmpd="sng" algn="ctr">
-                      <a:solidFill>
-                        <a:srgbClr val="CDCDCD"/>
-                      </a:solidFill>
-                      <a:prstDash val="solid"/>
-                      <a:round/>
-                      <a:headEnd type="none" w="med" len="med"/>
-                      <a:tailEnd type="none" w="med" len="med"/>
-                    </a:lnL>
-                    <a:lnR w="6350" cap="flat" cmpd="sng" algn="ctr">
-                      <a:solidFill>
-                        <a:srgbClr val="CDCDCD"/>
-                      </a:solidFill>
-                      <a:prstDash val="solid"/>
-                      <a:round/>
-                      <a:headEnd type="none" w="med" len="med"/>
-                      <a:tailEnd type="none" w="med" len="med"/>
-                    </a:lnR>
-                    <a:lnT w="6350" cap="flat" cmpd="sng" algn="ctr">
-                      <a:solidFill>
-                        <a:srgbClr val="CDCDCD"/>
-                      </a:solidFill>
-                      <a:prstDash val="solid"/>
-                      <a:round/>
-                      <a:headEnd type="none" w="med" len="med"/>
-                      <a:tailEnd type="none" w="med" len="med"/>
-                    </a:lnT>
-                    <a:lnB w="6350" cap="flat" cmpd="sng" algn="ctr">
-                      <a:solidFill>
-                        <a:srgbClr val="CDCDCD"/>
-                      </a:solidFill>
-                      <a:prstDash val="solid"/>
-                      <a:round/>
-                      <a:headEnd type="none" w="med" len="med"/>
-                      <a:tailEnd type="none" w="med" len="med"/>
-                    </a:lnB>
-                  </a:tcPr>
-                </a:tc>
-              </a:tr>
-              <a:tr h="402336">
-                <a:tc>
-                  <a:txBody>
-                    <a:bodyPr/>
-                    <a:lstStyle/>
-                    <a:p>
-                      <a:pPr algn="l" indent="0" marL="0">
-                        <a:buNone/>
-                      </a:pPr>
-                      <a:r>
-                        <a:rPr lang="en-US" sz="1050" b="1" dirty="0">
-                          <a:solidFill>
-                            <a:srgbClr val="000000"/>
-                          </a:solidFill>
-                          <a:latin typeface="NVIDIA Sans" pitchFamily="34" charset="0"/>
-                          <a:ea typeface="NVIDIA Sans" pitchFamily="34" charset="-122"/>
-                          <a:cs typeface="NVIDIA Sans" pitchFamily="34" charset="-120"/>
-                        </a:rPr>
-                        <a:t>MRoPE cache still needed?</a:t>
-                      </a:r>
-                      <a:endParaRPr lang="en-US" sz="1050" dirty="0">
-                        <a:latin typeface="NVIDIA Sans" charset="0"/>
-                        <a:ea typeface="NVIDIA Sans" charset="0"/>
-                        <a:cs typeface="NVIDIA Sans" charset="0"/>
-                      </a:endParaRPr>
-                    </a:p>
-                  </a:txBody>
-                  <a:tcPr marL="91440" marR="91440" marT="45720" marB="45720" anchor="ctr">
-                    <a:lnL w="6350" cap="flat" cmpd="sng" algn="ctr">
-                      <a:solidFill>
-                        <a:srgbClr val="CDCDCD"/>
-                      </a:solidFill>
-                      <a:prstDash val="solid"/>
-                      <a:round/>
-                      <a:headEnd type="none" w="med" len="med"/>
-                      <a:tailEnd type="none" w="med" len="med"/>
-                    </a:lnL>
-                    <a:lnR w="6350" cap="flat" cmpd="sng" algn="ctr">
-                      <a:solidFill>
-                        <a:srgbClr val="CDCDCD"/>
-                      </a:solidFill>
-                      <a:prstDash val="solid"/>
-                      <a:round/>
-                      <a:headEnd type="none" w="med" len="med"/>
-                      <a:tailEnd type="none" w="med" len="med"/>
-                    </a:lnR>
-                    <a:lnT w="6350" cap="flat" cmpd="sng" algn="ctr">
-                      <a:solidFill>
-                        <a:srgbClr val="CDCDCD"/>
-                      </a:solidFill>
-                      <a:prstDash val="solid"/>
-                      <a:round/>
-                      <a:headEnd type="none" w="med" len="med"/>
-                      <a:tailEnd type="none" w="med" len="med"/>
-                    </a:lnT>
-                    <a:lnB w="6350" cap="flat" cmpd="sng" algn="ctr">
-                      <a:solidFill>
-                        <a:srgbClr val="CDCDCD"/>
-                      </a:solidFill>
-                      <a:prstDash val="solid"/>
-                      <a:round/>
-                      <a:headEnd type="none" w="med" len="med"/>
-                      <a:tailEnd type="none" w="med" len="med"/>
-                    </a:lnB>
-                  </a:tcPr>
-                </a:tc>
-                <a:tc>
-                  <a:txBody>
-                    <a:bodyPr/>
-                    <a:lstStyle/>
-                    <a:p>
-                      <a:pPr algn="l" indent="0" marL="0">
-                        <a:buNone/>
-                      </a:pPr>
-                      <a:r>
-                        <a:rPr lang="en-US" sz="1000" dirty="0">
-                          <a:solidFill>
-                            <a:srgbClr val="000000"/>
-                          </a:solidFill>
-                          <a:latin typeface="NVIDIA Sans" pitchFamily="34" charset="0"/>
-                          <a:ea typeface="NVIDIA Sans" pitchFamily="34" charset="-122"/>
-                          <a:cs typeface="NVIDIA Sans" pitchFamily="34" charset="-120"/>
-                        </a:rPr>
-                        <a:t>Toggle at final config</a:t>
-                      </a:r>
-                      <a:endParaRPr lang="en-US" sz="1000" dirty="0">
-                        <a:latin typeface="NVIDIA Sans" charset="0"/>
-                        <a:ea typeface="NVIDIA Sans" charset="0"/>
-                        <a:cs typeface="NVIDIA Sans" charset="0"/>
-                      </a:endParaRPr>
-                    </a:p>
-                  </a:txBody>
-                  <a:tcPr marL="91440" marR="91440" marT="45720" marB="45720" anchor="ctr">
-                    <a:lnL w="6350" cap="flat" cmpd="sng" algn="ctr">
-                      <a:solidFill>
-                        <a:srgbClr val="CDCDCD"/>
-                      </a:solidFill>
-                      <a:prstDash val="solid"/>
-                      <a:round/>
-                      <a:headEnd type="none" w="med" len="med"/>
-                      <a:tailEnd type="none" w="med" len="med"/>
-                    </a:lnL>
-                    <a:lnR w="6350" cap="flat" cmpd="sng" algn="ctr">
-                      <a:solidFill>
-                        <a:srgbClr val="CDCDCD"/>
-                      </a:solidFill>
-                      <a:prstDash val="solid"/>
-                      <a:round/>
-                      <a:headEnd type="none" w="med" len="med"/>
-                      <a:tailEnd type="none" w="med" len="med"/>
-                    </a:lnR>
-                    <a:lnT w="6350" cap="flat" cmpd="sng" algn="ctr">
-                      <a:solidFill>
-                        <a:srgbClr val="CDCDCD"/>
-                      </a:solidFill>
-                      <a:prstDash val="solid"/>
-                      <a:round/>
-                      <a:headEnd type="none" w="med" len="med"/>
-                      <a:tailEnd type="none" w="med" len="med"/>
-                    </a:lnT>
-                    <a:lnB w="6350" cap="flat" cmpd="sng" algn="ctr">
-                      <a:solidFill>
-                        <a:srgbClr val="CDCDCD"/>
-                      </a:solidFill>
-                      <a:prstDash val="solid"/>
-                      <a:round/>
-                      <a:headEnd type="none" w="med" len="med"/>
-                      <a:tailEnd type="none" w="med" len="med"/>
-                    </a:lnB>
-                  </a:tcPr>
-                </a:tc>
-                <a:tc>
-                  <a:txBody>
-                    <a:bodyPr/>
-                    <a:lstStyle/>
-                    <a:p>
-                      <a:pPr algn="l" indent="0" marL="0">
-                        <a:buNone/>
-                      </a:pPr>
-                      <a:r>
-                        <a:rPr lang="en-US" sz="1000" dirty="0">
-                          <a:solidFill>
-                            <a:srgbClr val="000000"/>
-                          </a:solidFill>
-                          <a:latin typeface="NVIDIA Sans" pitchFamily="34" charset="0"/>
-                          <a:ea typeface="NVIDIA Sans" pitchFamily="34" charset="-122"/>
-                          <a:cs typeface="NVIDIA Sans" pitchFamily="34" charset="-120"/>
-                        </a:rPr>
-                        <a:t>Neutral at the tip (CUDA Graphs hide it) — kept for CPU headroom, one-knob rollback</a:t>
-                      </a:r>
-                      <a:endParaRPr lang="en-US" sz="1000" dirty="0">
-                        <a:latin typeface="NVIDIA Sans" charset="0"/>
-                        <a:ea typeface="NVIDIA Sans" charset="0"/>
-                        <a:cs typeface="NVIDIA Sans" charset="0"/>
-                      </a:endParaRPr>
-                    </a:p>
-                  </a:txBody>
-                  <a:tcPr marL="91440" marR="91440" marT="45720" marB="45720" anchor="ctr">
-                    <a:lnL w="6350" cap="flat" cmpd="sng" algn="ctr">
-                      <a:solidFill>
-                        <a:srgbClr val="CDCDCD"/>
-                      </a:solidFill>
-                      <a:prstDash val="solid"/>
-                      <a:round/>
-                      <a:headEnd type="none" w="med" len="med"/>
-                      <a:tailEnd type="none" w="med" len="med"/>
-                    </a:lnL>
-                    <a:lnR w="6350" cap="flat" cmpd="sng" algn="ctr">
-                      <a:solidFill>
-                        <a:srgbClr val="CDCDCD"/>
-                      </a:solidFill>
-                      <a:prstDash val="solid"/>
-                      <a:round/>
-                      <a:headEnd type="none" w="med" len="med"/>
-                      <a:tailEnd type="none" w="med" len="med"/>
-                    </a:lnR>
-                    <a:lnT w="6350" cap="flat" cmpd="sng" algn="ctr">
-                      <a:solidFill>
-                        <a:srgbClr val="CDCDCD"/>
-                      </a:solidFill>
-                      <a:prstDash val="solid"/>
-                      <a:round/>
-                      <a:headEnd type="none" w="med" len="med"/>
-                      <a:tailEnd type="none" w="med" len="med"/>
-                    </a:lnT>
-                    <a:lnB w="6350" cap="flat" cmpd="sng" algn="ctr">
-                      <a:solidFill>
-                        <a:srgbClr val="CDCDCD"/>
-                      </a:solidFill>
-                      <a:prstDash val="solid"/>
-                      <a:round/>
-                      <a:headEnd type="none" w="med" len="med"/>
-                      <a:tailEnd type="none" w="med" len="med"/>
-                    </a:lnB>
-                  </a:tcPr>
-                </a:tc>
-              </a:tr>
-              <a:tr h="402336">
-                <a:tc>
-                  <a:txBody>
-                    <a:bodyPr/>
-                    <a:lstStyle/>
-                    <a:p>
-                      <a:pPr algn="l" indent="0" marL="0">
-                        <a:buNone/>
-                      </a:pPr>
-                      <a:r>
-                        <a:rPr lang="en-US" sz="1050" b="1" dirty="0">
-                          <a:solidFill>
-                            <a:srgbClr val="000000"/>
-                          </a:solidFill>
-                          <a:latin typeface="NVIDIA Sans" pitchFamily="34" charset="0"/>
-                          <a:ea typeface="NVIDIA Sans" pitchFamily="34" charset="-122"/>
-                          <a:cs typeface="NVIDIA Sans" pitchFamily="34" charset="-120"/>
-                        </a:rPr>
-                        <a:t>Whole-model torch.compile</a:t>
-                      </a:r>
-                      <a:endParaRPr lang="en-US" sz="1050" dirty="0">
-                        <a:latin typeface="NVIDIA Sans" charset="0"/>
-                        <a:ea typeface="NVIDIA Sans" charset="0"/>
-                        <a:cs typeface="NVIDIA Sans" charset="0"/>
-                      </a:endParaRPr>
-                    </a:p>
-                  </a:txBody>
-                  <a:tcPr marL="91440" marR="91440" marT="45720" marB="45720" anchor="ctr">
-                    <a:lnL w="6350" cap="flat" cmpd="sng" algn="ctr">
-                      <a:solidFill>
-                        <a:srgbClr val="CDCDCD"/>
-                      </a:solidFill>
-                      <a:prstDash val="solid"/>
-                      <a:round/>
-                      <a:headEnd type="none" w="med" len="med"/>
-                      <a:tailEnd type="none" w="med" len="med"/>
-                    </a:lnL>
-                    <a:lnR w="6350" cap="flat" cmpd="sng" algn="ctr">
-                      <a:solidFill>
-                        <a:srgbClr val="CDCDCD"/>
-                      </a:solidFill>
-                      <a:prstDash val="solid"/>
-                      <a:round/>
-                      <a:headEnd type="none" w="med" len="med"/>
-                      <a:tailEnd type="none" w="med" len="med"/>
-                    </a:lnR>
-                    <a:lnT w="6350" cap="flat" cmpd="sng" algn="ctr">
-                      <a:solidFill>
-                        <a:srgbClr val="CDCDCD"/>
-                      </a:solidFill>
-                      <a:prstDash val="solid"/>
-                      <a:round/>
-                      <a:headEnd type="none" w="med" len="med"/>
-                      <a:tailEnd type="none" w="med" len="med"/>
-                    </a:lnT>
-                    <a:lnB w="6350" cap="flat" cmpd="sng" algn="ctr">
-                      <a:solidFill>
-                        <a:srgbClr val="CDCDCD"/>
-                      </a:solidFill>
-                      <a:prstDash val="solid"/>
-                      <a:round/>
-                      <a:headEnd type="none" w="med" len="med"/>
-                      <a:tailEnd type="none" w="med" len="med"/>
-                    </a:lnB>
-                  </a:tcPr>
-                </a:tc>
-                <a:tc>
-                  <a:txBody>
-                    <a:bodyPr/>
-                    <a:lstStyle/>
-                    <a:p>
-                      <a:pPr algn="l" indent="0" marL="0">
-                        <a:buNone/>
-                      </a:pPr>
-                      <a:r>
-                        <a:rPr lang="en-US" sz="1000" dirty="0">
-                          <a:solidFill>
-                            <a:srgbClr val="000000"/>
-                          </a:solidFill>
-                          <a:latin typeface="NVIDIA Sans" pitchFamily="34" charset="0"/>
-                          <a:ea typeface="NVIDIA Sans" pitchFamily="34" charset="-122"/>
-                          <a:cs typeface="NVIDIA Sans" pitchFamily="34" charset="-120"/>
-                        </a:rPr>
-                        <a:t>Compile attempts on torch 2.6 &amp; 2.7</a:t>
-                      </a:r>
-                      <a:endParaRPr lang="en-US" sz="1000" dirty="0">
-                        <a:latin typeface="NVIDIA Sans" charset="0"/>
-                        <a:ea typeface="NVIDIA Sans" charset="0"/>
-                        <a:cs typeface="NVIDIA Sans" charset="0"/>
-                      </a:endParaRPr>
-                    </a:p>
-                  </a:txBody>
-                  <a:tcPr marL="91440" marR="91440" marT="45720" marB="45720" anchor="ctr">
-                    <a:lnL w="6350" cap="flat" cmpd="sng" algn="ctr">
-                      <a:solidFill>
-                        <a:srgbClr val="CDCDCD"/>
-                      </a:solidFill>
-                      <a:prstDash val="solid"/>
-                      <a:round/>
-                      <a:headEnd type="none" w="med" len="med"/>
-                      <a:tailEnd type="none" w="med" len="med"/>
-                    </a:lnL>
-                    <a:lnR w="6350" cap="flat" cmpd="sng" algn="ctr">
-                      <a:solidFill>
-                        <a:srgbClr val="CDCDCD"/>
-                      </a:solidFill>
-                      <a:prstDash val="solid"/>
-                      <a:round/>
-                      <a:headEnd type="none" w="med" len="med"/>
-                      <a:tailEnd type="none" w="med" len="med"/>
-                    </a:lnR>
-                    <a:lnT w="6350" cap="flat" cmpd="sng" algn="ctr">
-                      <a:solidFill>
-                        <a:srgbClr val="CDCDCD"/>
-                      </a:solidFill>
-                      <a:prstDash val="solid"/>
-                      <a:round/>
-                      <a:headEnd type="none" w="med" len="med"/>
-                      <a:tailEnd type="none" w="med" len="med"/>
-                    </a:lnT>
-                    <a:lnB w="6350" cap="flat" cmpd="sng" algn="ctr">
-                      <a:solidFill>
-                        <a:srgbClr val="CDCDCD"/>
-                      </a:solidFill>
-                      <a:prstDash val="solid"/>
-                      <a:round/>
-                      <a:headEnd type="none" w="med" len="med"/>
-                      <a:tailEnd type="none" w="med" len="med"/>
-                    </a:lnB>
-                  </a:tcPr>
-                </a:tc>
-                <a:tc>
-                  <a:txBody>
-                    <a:bodyPr/>
-                    <a:lstStyle/>
-                    <a:p>
-                      <a:pPr algn="l" indent="0" marL="0">
-                        <a:buNone/>
-                      </a:pPr>
-                      <a:r>
-                        <a:rPr lang="en-US" sz="1000" dirty="0">
-                          <a:solidFill>
-                            <a:srgbClr val="000000"/>
-                          </a:solidFill>
-                          <a:latin typeface="NVIDIA Sans" pitchFamily="34" charset="0"/>
-                          <a:ea typeface="NVIDIA Sans" pitchFamily="34" charset="-122"/>
-                          <a:cs typeface="NVIDIA Sans" pitchFamily="34" charset="-120"/>
-                        </a:rPr>
-                        <a:t>Hybrid GDN layers graph-break in dynamo → group-graph capture instead</a:t>
-                      </a:r>
-                      <a:endParaRPr lang="en-US" sz="1000" dirty="0">
-                        <a:latin typeface="NVIDIA Sans" charset="0"/>
-                        <a:ea typeface="NVIDIA Sans" charset="0"/>
-                        <a:cs typeface="NVIDIA Sans" charset="0"/>
-                      </a:endParaRPr>
-                    </a:p>
-                  </a:txBody>
-                  <a:tcPr marL="91440" marR="91440" marT="45720" marB="45720" anchor="ctr">
-                    <a:lnL w="6350" cap="flat" cmpd="sng" algn="ctr">
-                      <a:solidFill>
-                        <a:srgbClr val="CDCDCD"/>
-                      </a:solidFill>
-                      <a:prstDash val="solid"/>
-                      <a:round/>
-                      <a:headEnd type="none" w="med" len="med"/>
-                      <a:tailEnd type="none" w="med" len="med"/>
-                    </a:lnL>
-                    <a:lnR w="6350" cap="flat" cmpd="sng" algn="ctr">
-                      <a:solidFill>
-                        <a:srgbClr val="CDCDCD"/>
-                      </a:solidFill>
-                      <a:prstDash val="solid"/>
-                      <a:round/>
-                      <a:headEnd type="none" w="med" len="med"/>
-                      <a:tailEnd type="none" w="med" len="med"/>
-                    </a:lnR>
-                    <a:lnT w="6350" cap="flat" cmpd="sng" algn="ctr">
-                      <a:solidFill>
-                        <a:srgbClr val="CDCDCD"/>
-                      </a:solidFill>
-                      <a:prstDash val="solid"/>
-                      <a:round/>
-                      <a:headEnd type="none" w="med" len="med"/>
-                      <a:tailEnd type="none" w="med" len="med"/>
-                    </a:lnT>
-                    <a:lnB w="6350" cap="flat" cmpd="sng" algn="ctr">
-                      <a:solidFill>
-                        <a:srgbClr val="CDCDCD"/>
-                      </a:solidFill>
-                      <a:prstDash val="solid"/>
-                      <a:round/>
-                      <a:headEnd type="none" w="med" len="med"/>
-                      <a:tailEnd type="none" w="med" len="med"/>
-                    </a:lnB>
-                  </a:tcPr>
-                </a:tc>
-              </a:tr>
-              <a:tr h="402336">
-                <a:tc>
-                  <a:txBody>
-                    <a:bodyPr/>
-                    <a:lstStyle/>
-                    <a:p>
-                      <a:pPr algn="l" indent="0" marL="0">
-                        <a:buNone/>
-                      </a:pPr>
-                      <a:r>
-                        <a:rPr lang="en-US" sz="1050" b="1" dirty="0">
-                          <a:solidFill>
-                            <a:srgbClr val="000000"/>
-                          </a:solidFill>
-                          <a:latin typeface="NVIDIA Sans" pitchFamily="34" charset="0"/>
-                          <a:ea typeface="NVIDIA Sans" pitchFamily="34" charset="-122"/>
-                          <a:cs typeface="NVIDIA Sans" pitchFamily="34" charset="-120"/>
-                        </a:rPr>
-                        <a:t>FlashQLA GDN kernels</a:t>
-                      </a:r>
-                      <a:endParaRPr lang="en-US" sz="1050" dirty="0">
-                        <a:latin typeface="NVIDIA Sans" charset="0"/>
-                        <a:ea typeface="NVIDIA Sans" charset="0"/>
-                        <a:cs typeface="NVIDIA Sans" charset="0"/>
-                      </a:endParaRPr>
-                    </a:p>
-                  </a:txBody>
-                  <a:tcPr marL="91440" marR="91440" marT="45720" marB="45720" anchor="ctr">
-                    <a:lnL w="6350" cap="flat" cmpd="sng" algn="ctr">
-                      <a:solidFill>
-                        <a:srgbClr val="CDCDCD"/>
-                      </a:solidFill>
-                      <a:prstDash val="solid"/>
-                      <a:round/>
-                      <a:headEnd type="none" w="med" len="med"/>
-                      <a:tailEnd type="none" w="med" len="med"/>
-                    </a:lnL>
-                    <a:lnR w="6350" cap="flat" cmpd="sng" algn="ctr">
-                      <a:solidFill>
-                        <a:srgbClr val="CDCDCD"/>
-                      </a:solidFill>
-                      <a:prstDash val="solid"/>
-                      <a:round/>
-                      <a:headEnd type="none" w="med" len="med"/>
-                      <a:tailEnd type="none" w="med" len="med"/>
-                    </a:lnR>
-                    <a:lnT w="6350" cap="flat" cmpd="sng" algn="ctr">
-                      <a:solidFill>
-                        <a:srgbClr val="CDCDCD"/>
-                      </a:solidFill>
-                      <a:prstDash val="solid"/>
-                      <a:round/>
-                      <a:headEnd type="none" w="med" len="med"/>
-                      <a:tailEnd type="none" w="med" len="med"/>
-                    </a:lnT>
-                    <a:lnB w="6350" cap="flat" cmpd="sng" algn="ctr">
-                      <a:solidFill>
-                        <a:srgbClr val="CDCDCD"/>
-                      </a:solidFill>
-                      <a:prstDash val="solid"/>
-                      <a:round/>
-                      <a:headEnd type="none" w="med" len="med"/>
-                      <a:tailEnd type="none" w="med" len="med"/>
-                    </a:lnB>
-                  </a:tcPr>
-                </a:tc>
-                <a:tc>
-                  <a:txBody>
-                    <a:bodyPr/>
-                    <a:lstStyle/>
-                    <a:p>
-                      <a:pPr algn="l" indent="0" marL="0">
-                        <a:buNone/>
-                      </a:pPr>
-                      <a:r>
-                        <a:rPr lang="en-US" sz="1000" dirty="0">
-                          <a:solidFill>
-                            <a:srgbClr val="000000"/>
-                          </a:solidFill>
-                          <a:latin typeface="NVIDIA Sans" pitchFamily="34" charset="0"/>
-                          <a:ea typeface="NVIDIA Sans" pitchFamily="34" charset="-122"/>
-                          <a:cs typeface="NVIDIA Sans" pitchFamily="34" charset="-120"/>
-                        </a:rPr>
-                        <a:t>Kernel-time ceiling analysis</a:t>
-                      </a:r>
-                      <a:endParaRPr lang="en-US" sz="1000" dirty="0">
-                        <a:latin typeface="NVIDIA Sans" charset="0"/>
-                        <a:ea typeface="NVIDIA Sans" charset="0"/>
-                        <a:cs typeface="NVIDIA Sans" charset="0"/>
-                      </a:endParaRPr>
-                    </a:p>
-                  </a:txBody>
-                  <a:tcPr marL="91440" marR="91440" marT="45720" marB="45720" anchor="ctr">
-                    <a:lnL w="6350" cap="flat" cmpd="sng" algn="ctr">
-                      <a:solidFill>
-                        <a:srgbClr val="CDCDCD"/>
-                      </a:solidFill>
-                      <a:prstDash val="solid"/>
-                      <a:round/>
-                      <a:headEnd type="none" w="med" len="med"/>
-                      <a:tailEnd type="none" w="med" len="med"/>
-                    </a:lnL>
-                    <a:lnR w="6350" cap="flat" cmpd="sng" algn="ctr">
-                      <a:solidFill>
-                        <a:srgbClr val="CDCDCD"/>
-                      </a:solidFill>
-                      <a:prstDash val="solid"/>
-                      <a:round/>
-                      <a:headEnd type="none" w="med" len="med"/>
-                      <a:tailEnd type="none" w="med" len="med"/>
-                    </a:lnR>
-                    <a:lnT w="6350" cap="flat" cmpd="sng" algn="ctr">
-                      <a:solidFill>
-                        <a:srgbClr val="CDCDCD"/>
-                      </a:solidFill>
-                      <a:prstDash val="solid"/>
-                      <a:round/>
-                      <a:headEnd type="none" w="med" len="med"/>
-                      <a:tailEnd type="none" w="med" len="med"/>
-                    </a:lnT>
-                    <a:lnB w="6350" cap="flat" cmpd="sng" algn="ctr">
-                      <a:solidFill>
-                        <a:srgbClr val="CDCDCD"/>
-                      </a:solidFill>
-                      <a:prstDash val="solid"/>
-                      <a:round/>
-                      <a:headEnd type="none" w="med" len="med"/>
-                      <a:tailEnd type="none" w="med" len="med"/>
-                    </a:lnB>
-                  </a:tcPr>
-                </a:tc>
-                <a:tc>
-                  <a:txBody>
-                    <a:bodyPr/>
-                    <a:lstStyle/>
-                    <a:p>
-                      <a:pPr algn="l" indent="0" marL="0">
-                        <a:buNone/>
-                      </a:pPr>
-                      <a:r>
-                        <a:rPr lang="en-US" sz="1000" dirty="0">
-                          <a:solidFill>
-                            <a:srgbClr val="000000"/>
-                          </a:solidFill>
-                          <a:latin typeface="NVIDIA Sans" pitchFamily="34" charset="0"/>
-                          <a:ea typeface="NVIDIA Sans" pitchFamily="34" charset="-122"/>
-                          <a:cs typeface="NVIDIA Sans" pitchFamily="34" charset="-120"/>
-                        </a:rPr>
-                        <a:t>Only ~10.5 ms/step of GDN time exists; needs torch ≥ 2.8 — deferred, not worth the risk now</a:t>
-                      </a:r>
-                      <a:endParaRPr lang="en-US" sz="1000" dirty="0">
-                        <a:latin typeface="NVIDIA Sans" charset="0"/>
-                        <a:ea typeface="NVIDIA Sans" charset="0"/>
-                        <a:cs typeface="NVIDIA Sans" charset="0"/>
-                      </a:endParaRPr>
-                    </a:p>
-                  </a:txBody>
-                  <a:tcPr marL="91440" marR="91440" marT="45720" marB="45720" anchor="ctr">
-                    <a:lnL w="6350" cap="flat" cmpd="sng" algn="ctr">
-                      <a:solidFill>
-                        <a:srgbClr val="CDCDCD"/>
-                      </a:solidFill>
-                      <a:prstDash val="solid"/>
-                      <a:round/>
-                      <a:headEnd type="none" w="med" len="med"/>
-                      <a:tailEnd type="none" w="med" len="med"/>
-                    </a:lnL>
-                    <a:lnR w="6350" cap="flat" cmpd="sng" algn="ctr">
-                      <a:solidFill>
-                        <a:srgbClr val="CDCDCD"/>
-                      </a:solidFill>
-                      <a:prstDash val="solid"/>
-                      <a:round/>
-                      <a:headEnd type="none" w="med" len="med"/>
-                      <a:tailEnd type="none" w="med" len="med"/>
-                    </a:lnR>
-                    <a:lnT w="6350" cap="flat" cmpd="sng" algn="ctr">
-                      <a:solidFill>
-                        <a:srgbClr val="CDCDCD"/>
-                      </a:solidFill>
-                      <a:prstDash val="solid"/>
-                      <a:round/>
-                      <a:headEnd type="none" w="med" len="med"/>
-                      <a:tailEnd type="none" w="med" len="med"/>
-                    </a:lnT>
-                    <a:lnB w="6350" cap="flat" cmpd="sng" algn="ctr">
-                      <a:solidFill>
-                        <a:srgbClr val="CDCDCD"/>
-                      </a:solidFill>
-                      <a:prstDash val="solid"/>
-                      <a:round/>
-                      <a:headEnd type="none" w="med" len="med"/>
-                      <a:tailEnd type="none" w="med" len="med"/>
-                    </a:lnB>
-                  </a:tcPr>
-                </a:tc>
-              </a:tr>
-            </a:tbl>
-          </a:graphicData>
-        </a:graphic>
-      </p:graphicFrame>
-      <p:sp>
-        <p:nvSpPr>
-          <p:cNvPr id="5" name="Text 2"/>
+      <p:sp>
+        <p:nvSpPr>
+          <p:cNvPr id="4" name="Text 2"/>
+          <p:cNvSpPr/>
+          <p:nvPr/>
+        </p:nvSpPr>
+        <p:spPr>
+          <a:xfrm>
+            <a:off x="457200" y="1261872"/>
+            <a:ext cx="4023360" cy="274320"/>
+          </a:xfrm>
+          <a:prstGeom prst="rect">
+            <a:avLst/>
+          </a:prstGeom>
+          <a:noFill/>
+          <a:ln/>
+        </p:spPr>
+        <p:txBody>
+          <a:bodyPr wrap="square" lIns="0" tIns="0" rIns="0" bIns="0" rtlCol="0" anchor="ctr"/>
+          <a:lstStyle/>
+          <a:p>
+            <a:pPr indent="0" marL="0">
+              <a:buNone/>
+            </a:pPr>
+            <a:r>
+              <a:rPr lang="en-US" sz="1400" b="1" dirty="0">
+                <a:solidFill>
+                  <a:srgbClr val="76B900"/>
+                </a:solidFill>
+                <a:latin typeface="NVIDIA Sans" pitchFamily="34" charset="0"/>
+                <a:ea typeface="NVIDIA Sans" pitchFamily="34" charset="-122"/>
+                <a:cs typeface="NVIDIA Sans" pitchFamily="34" charset="-120"/>
+              </a:rPr>
+              <a:t>Next levers (ranked by ceiling)</a:t>
+            </a:r>
+            <a:endParaRPr lang="en-US" sz="1400" dirty="0"/>
+          </a:p>
+        </p:txBody>
+      </p:sp>
+      <p:sp>
+        <p:nvSpPr>
+          <p:cNvPr id="5" name="Shape 3"/>
+          <p:cNvSpPr/>
+          <p:nvPr/>
+        </p:nvSpPr>
+        <p:spPr>
+          <a:xfrm>
+            <a:off x="457200" y="1609344"/>
+            <a:ext cx="45720" cy="603504"/>
+          </a:xfrm>
+          <a:prstGeom prst="rect">
+            <a:avLst/>
+          </a:prstGeom>
+          <a:solidFill>
+            <a:srgbClr val="76B900"/>
+          </a:solidFill>
+          <a:ln/>
+        </p:spPr>
+      </p:sp>
+      <p:sp>
+        <p:nvSpPr>
+          <p:cNvPr id="6" name="Text 4"/>
+          <p:cNvSpPr/>
+          <p:nvPr/>
+        </p:nvSpPr>
+        <p:spPr>
+          <a:xfrm>
+            <a:off x="603504" y="1591056"/>
+            <a:ext cx="3877056" cy="201168"/>
+          </a:xfrm>
+          <a:prstGeom prst="rect">
+            <a:avLst/>
+          </a:prstGeom>
+          <a:noFill/>
+          <a:ln/>
+        </p:spPr>
+        <p:txBody>
+          <a:bodyPr wrap="square" lIns="0" tIns="0" rIns="0" bIns="0" rtlCol="0" anchor="ctr"/>
+          <a:lstStyle/>
+          <a:p>
+            <a:pPr indent="0" marL="0">
+              <a:buNone/>
+            </a:pPr>
+            <a:r>
+              <a:rPr lang="en-US" sz="1100" b="1" dirty="0">
+                <a:solidFill>
+                  <a:srgbClr val="000000"/>
+                </a:solidFill>
+                <a:latin typeface="NVIDIA Sans" pitchFamily="34" charset="0"/>
+                <a:ea typeface="NVIDIA Sans" pitchFamily="34" charset="-122"/>
+                <a:cs typeface="NVIDIA Sans" pitchFamily="34" charset="-120"/>
+              </a:rPr>
+              <a:t>fp8 for the backward GEMMs</a:t>
+            </a:r>
+            <a:endParaRPr lang="en-US" sz="1100" dirty="0"/>
+          </a:p>
+        </p:txBody>
+      </p:sp>
+      <p:sp>
+        <p:nvSpPr>
+          <p:cNvPr id="7" name="Text 5"/>
+          <p:cNvSpPr/>
+          <p:nvPr/>
+        </p:nvSpPr>
+        <p:spPr>
+          <a:xfrm>
+            <a:off x="603504" y="1792224"/>
+            <a:ext cx="3877056" cy="438912"/>
+          </a:xfrm>
+          <a:prstGeom prst="rect">
+            <a:avLst/>
+          </a:prstGeom>
+          <a:noFill/>
+          <a:ln/>
+        </p:spPr>
+        <p:txBody>
+          <a:bodyPr wrap="square" lIns="0" tIns="0" rIns="0" bIns="0" rtlCol="0" anchor="t"/>
+          <a:lstStyle/>
+          <a:p>
+            <a:pPr indent="0" marL="0">
+              <a:buNone/>
+            </a:pPr>
+            <a:r>
+              <a:rPr lang="en-US" sz="900" dirty="0">
+                <a:solidFill>
+                  <a:srgbClr val="5E5E5E"/>
+                </a:solidFill>
+                <a:latin typeface="NVIDIA Sans" pitchFamily="34" charset="0"/>
+                <a:ea typeface="NVIDIA Sans" pitchFamily="34" charset="-122"/>
+                <a:cs typeface="NVIDIA Sans" pitchFamily="34" charset="-120"/>
+              </a:rPr>
+              <a:t>Sustained GEMM throughput caps at ~622 TFLOPS on this node (power wall, not occupancy) — fp8 is the only math lever left.</a:t>
+            </a:r>
+            <a:endParaRPr lang="en-US" sz="900" dirty="0"/>
+          </a:p>
+        </p:txBody>
+      </p:sp>
+      <p:sp>
+        <p:nvSpPr>
+          <p:cNvPr id="8" name="Shape 6"/>
+          <p:cNvSpPr/>
+          <p:nvPr/>
+        </p:nvSpPr>
+        <p:spPr>
+          <a:xfrm>
+            <a:off x="457200" y="2322576"/>
+            <a:ext cx="45720" cy="603504"/>
+          </a:xfrm>
+          <a:prstGeom prst="rect">
+            <a:avLst/>
+          </a:prstGeom>
+          <a:solidFill>
+            <a:srgbClr val="76B900"/>
+          </a:solidFill>
+          <a:ln/>
+        </p:spPr>
+      </p:sp>
+      <p:sp>
+        <p:nvSpPr>
+          <p:cNvPr id="9" name="Text 7"/>
+          <p:cNvSpPr/>
+          <p:nvPr/>
+        </p:nvSpPr>
+        <p:spPr>
+          <a:xfrm>
+            <a:off x="603504" y="2304288"/>
+            <a:ext cx="3877056" cy="201168"/>
+          </a:xfrm>
+          <a:prstGeom prst="rect">
+            <a:avLst/>
+          </a:prstGeom>
+          <a:noFill/>
+          <a:ln/>
+        </p:spPr>
+        <p:txBody>
+          <a:bodyPr wrap="square" lIns="0" tIns="0" rIns="0" bIns="0" rtlCol="0" anchor="ctr"/>
+          <a:lstStyle/>
+          <a:p>
+            <a:pPr indent="0" marL="0">
+              <a:buNone/>
+            </a:pPr>
+            <a:r>
+              <a:rPr lang="en-US" sz="1100" b="1" dirty="0">
+                <a:solidFill>
+                  <a:srgbClr val="000000"/>
+                </a:solidFill>
+                <a:latin typeface="NVIDIA Sans" pitchFamily="34" charset="0"/>
+                <a:ea typeface="NVIDIA Sans" pitchFamily="34" charset="-122"/>
+                <a:cs typeface="NVIDIA Sans" pitchFamily="34" charset="-120"/>
+              </a:rPr>
+              <a:t>Gradient compression / 1-bit Adam</a:t>
+            </a:r>
+            <a:endParaRPr lang="en-US" sz="1100" dirty="0"/>
+          </a:p>
+        </p:txBody>
+      </p:sp>
+      <p:sp>
+        <p:nvSpPr>
+          <p:cNvPr id="10" name="Text 8"/>
+          <p:cNvSpPr/>
+          <p:nvPr/>
+        </p:nvSpPr>
+        <p:spPr>
+          <a:xfrm>
+            <a:off x="603504" y="2505456"/>
+            <a:ext cx="3877056" cy="438912"/>
+          </a:xfrm>
+          <a:prstGeom prst="rect">
+            <a:avLst/>
+          </a:prstGeom>
+          <a:noFill/>
+          <a:ln/>
+        </p:spPr>
+        <p:txBody>
+          <a:bodyPr wrap="square" lIns="0" tIns="0" rIns="0" bIns="0" rtlCol="0" anchor="t"/>
+          <a:lstStyle/>
+          <a:p>
+            <a:pPr indent="0" marL="0">
+              <a:buNone/>
+            </a:pPr>
+            <a:r>
+              <a:rPr lang="en-US" sz="900" dirty="0">
+                <a:solidFill>
+                  <a:srgbClr val="5E5E5E"/>
+                </a:solidFill>
+                <a:latin typeface="NVIDIA Sans" pitchFamily="34" charset="0"/>
+                <a:ea typeface="NVIDIA Sans" pitchFamily="34" charset="-122"/>
+                <a:cs typeface="NVIDIA Sans" pitchFamily="34" charset="-120"/>
+              </a:rPr>
+              <a:t>NVLink is at its ceiling, so bytes are the only comm lever for the ~30 ms of exposed AllReduce. Needs convergence sign-off.</a:t>
+            </a:r>
+            <a:endParaRPr lang="en-US" sz="900" dirty="0"/>
+          </a:p>
+        </p:txBody>
+      </p:sp>
+      <p:sp>
+        <p:nvSpPr>
+          <p:cNvPr id="11" name="Shape 9"/>
+          <p:cNvSpPr/>
+          <p:nvPr/>
+        </p:nvSpPr>
+        <p:spPr>
+          <a:xfrm>
+            <a:off x="457200" y="3035808"/>
+            <a:ext cx="45720" cy="603504"/>
+          </a:xfrm>
+          <a:prstGeom prst="rect">
+            <a:avLst/>
+          </a:prstGeom>
+          <a:solidFill>
+            <a:srgbClr val="76B900"/>
+          </a:solidFill>
+          <a:ln/>
+        </p:spPr>
+      </p:sp>
+      <p:sp>
+        <p:nvSpPr>
+          <p:cNvPr id="12" name="Text 10"/>
+          <p:cNvSpPr/>
+          <p:nvPr/>
+        </p:nvSpPr>
+        <p:spPr>
+          <a:xfrm>
+            <a:off x="603504" y="3017520"/>
+            <a:ext cx="3877056" cy="201168"/>
+          </a:xfrm>
+          <a:prstGeom prst="rect">
+            <a:avLst/>
+          </a:prstGeom>
+          <a:noFill/>
+          <a:ln/>
+        </p:spPr>
+        <p:txBody>
+          <a:bodyPr wrap="square" lIns="0" tIns="0" rIns="0" bIns="0" rtlCol="0" anchor="ctr"/>
+          <a:lstStyle/>
+          <a:p>
+            <a:pPr indent="0" marL="0">
+              <a:buNone/>
+            </a:pPr>
+            <a:r>
+              <a:rPr lang="en-US" sz="1100" b="1" dirty="0">
+                <a:solidFill>
+                  <a:srgbClr val="000000"/>
+                </a:solidFill>
+                <a:latin typeface="NVIDIA Sans" pitchFamily="34" charset="0"/>
+                <a:ea typeface="NVIDIA Sans" pitchFamily="34" charset="-122"/>
+                <a:cs typeface="NVIDIA Sans" pitchFamily="34" charset="-120"/>
+              </a:rPr>
+              <a:t>Overlap the param AllGather (44 ms)</a:t>
+            </a:r>
+            <a:endParaRPr lang="en-US" sz="1100" dirty="0"/>
+          </a:p>
+        </p:txBody>
+      </p:sp>
+      <p:sp>
+        <p:nvSpPr>
+          <p:cNvPr id="13" name="Text 11"/>
+          <p:cNvSpPr/>
+          <p:nvPr/>
+        </p:nvSpPr>
+        <p:spPr>
+          <a:xfrm>
+            <a:off x="603504" y="3218688"/>
+            <a:ext cx="3877056" cy="438912"/>
+          </a:xfrm>
+          <a:prstGeom prst="rect">
+            <a:avLst/>
+          </a:prstGeom>
+          <a:noFill/>
+          <a:ln/>
+        </p:spPr>
+        <p:txBody>
+          <a:bodyPr wrap="square" lIns="0" tIns="0" rIns="0" bIns="0" rtlCol="0" anchor="t"/>
+          <a:lstStyle/>
+          <a:p>
+            <a:pPr indent="0" marL="0">
+              <a:buNone/>
+            </a:pPr>
+            <a:r>
+              <a:rPr lang="en-US" sz="900" dirty="0">
+                <a:solidFill>
+                  <a:srgbClr val="5E5E5E"/>
+                </a:solidFill>
+                <a:latin typeface="NVIDIA Sans" pitchFamily="34" charset="0"/>
+                <a:ea typeface="NVIDIA Sans" pitchFamily="34" charset="-122"/>
+                <a:cs typeface="NVIDIA Sans" pitchFamily="34" charset="-120"/>
+              </a:rPr>
+              <a:t>The step-end AllGather is now fully exposed and ZeRO-2 cannot overlap it — adopt FSDP, or add an async gather to ZeRO-2.</a:t>
+            </a:r>
+            <a:endParaRPr lang="en-US" sz="900" dirty="0"/>
+          </a:p>
+        </p:txBody>
+      </p:sp>
+      <p:sp>
+        <p:nvSpPr>
+          <p:cNvPr id="14" name="Shape 12"/>
+          <p:cNvSpPr/>
+          <p:nvPr/>
+        </p:nvSpPr>
+        <p:spPr>
+          <a:xfrm>
+            <a:off x="457200" y="3749040"/>
+            <a:ext cx="45720" cy="603504"/>
+          </a:xfrm>
+          <a:prstGeom prst="rect">
+            <a:avLst/>
+          </a:prstGeom>
+          <a:solidFill>
+            <a:srgbClr val="76B900"/>
+          </a:solidFill>
+          <a:ln/>
+        </p:spPr>
+      </p:sp>
+      <p:sp>
+        <p:nvSpPr>
+          <p:cNvPr id="15" name="Text 13"/>
+          <p:cNvSpPr/>
+          <p:nvPr/>
+        </p:nvSpPr>
+        <p:spPr>
+          <a:xfrm>
+            <a:off x="603504" y="3730752"/>
+            <a:ext cx="3877056" cy="201168"/>
+          </a:xfrm>
+          <a:prstGeom prst="rect">
+            <a:avLst/>
+          </a:prstGeom>
+          <a:noFill/>
+          <a:ln/>
+        </p:spPr>
+        <p:txBody>
+          <a:bodyPr wrap="square" lIns="0" tIns="0" rIns="0" bIns="0" rtlCol="0" anchor="ctr"/>
+          <a:lstStyle/>
+          <a:p>
+            <a:pPr indent="0" marL="0">
+              <a:buNone/>
+            </a:pPr>
+            <a:r>
+              <a:rPr lang="en-US" sz="1100" b="1" dirty="0">
+                <a:solidFill>
+                  <a:srgbClr val="000000"/>
+                </a:solidFill>
+                <a:latin typeface="NVIDIA Sans" pitchFamily="34" charset="0"/>
+                <a:ea typeface="NVIDIA Sans" pitchFamily="34" charset="-122"/>
+                <a:cs typeface="NVIDIA Sans" pitchFamily="34" charset="-120"/>
+              </a:rPr>
+              <a:t>Deployment &amp; batch</a:t>
+            </a:r>
+            <a:endParaRPr lang="en-US" sz="1100" dirty="0"/>
+          </a:p>
+        </p:txBody>
+      </p:sp>
+      <p:sp>
+        <p:nvSpPr>
+          <p:cNvPr id="16" name="Text 14"/>
+          <p:cNvSpPr/>
+          <p:nvPr/>
+        </p:nvSpPr>
+        <p:spPr>
+          <a:xfrm>
+            <a:off x="603504" y="3931920"/>
+            <a:ext cx="3877056" cy="438912"/>
+          </a:xfrm>
+          <a:prstGeom prst="rect">
+            <a:avLst/>
+          </a:prstGeom>
+          <a:noFill/>
+          <a:ln/>
+        </p:spPr>
+        <p:txBody>
+          <a:bodyPr wrap="square" lIns="0" tIns="0" rIns="0" bIns="0" rtlCol="0" anchor="t"/>
+          <a:lstStyle/>
+          <a:p>
+            <a:pPr indent="0" marL="0">
+              <a:buNone/>
+            </a:pPr>
+            <a:r>
+              <a:rPr lang="en-US" sz="900" dirty="0">
+                <a:solidFill>
+                  <a:srgbClr val="5E5E5E"/>
+                </a:solidFill>
+                <a:latin typeface="NVIDIA Sans" pitchFamily="34" charset="0"/>
+                <a:ea typeface="NVIDIA Sans" pitchFamily="34" charset="-122"/>
+                <a:cs typeface="NVIDIA Sans" pitchFamily="34" charset="-120"/>
+              </a:rPr>
+              <a:t>Split-topology nodes (4+4 NVLink) need NCCL_P2P_LEVEL=NVL. bs 24 (340 samples/node/s) is gated on a convergence run.</a:t>
+            </a:r>
+            <a:endParaRPr lang="en-US" sz="900" dirty="0"/>
+          </a:p>
+        </p:txBody>
+      </p:sp>
+      <p:sp>
+        <p:nvSpPr>
+          <p:cNvPr id="17" name="Text 15"/>
+          <p:cNvSpPr/>
+          <p:nvPr/>
+        </p:nvSpPr>
+        <p:spPr>
+          <a:xfrm>
+            <a:off x="4663440" y="1261872"/>
+            <a:ext cx="4023360" cy="274320"/>
+          </a:xfrm>
+          <a:prstGeom prst="rect">
+            <a:avLst/>
+          </a:prstGeom>
+          <a:noFill/>
+          <a:ln/>
+        </p:spPr>
+        <p:txBody>
+          <a:bodyPr wrap="square" lIns="0" tIns="0" rIns="0" bIns="0" rtlCol="0" anchor="ctr"/>
+          <a:lstStyle/>
+          <a:p>
+            <a:pPr indent="0" marL="0">
+              <a:buNone/>
+            </a:pPr>
+            <a:r>
+              <a:rPr lang="en-US" sz="1400" b="1" dirty="0">
+                <a:solidFill>
+                  <a:srgbClr val="890C58"/>
+                </a:solidFill>
+                <a:latin typeface="NVIDIA Sans" pitchFamily="34" charset="0"/>
+                <a:ea typeface="NVIDIA Sans" pitchFamily="34" charset="-122"/>
+                <a:cs typeface="NVIDIA Sans" pitchFamily="34" charset="-120"/>
+              </a:rPr>
+              <a:t>Don't retry — we measured</a:t>
+            </a:r>
+            <a:endParaRPr lang="en-US" sz="1400" dirty="0"/>
+          </a:p>
+        </p:txBody>
+      </p:sp>
+      <p:sp>
+        <p:nvSpPr>
+          <p:cNvPr id="18" name="Shape 16"/>
+          <p:cNvSpPr/>
+          <p:nvPr/>
+        </p:nvSpPr>
+        <p:spPr>
+          <a:xfrm>
+            <a:off x="4663440" y="1609344"/>
+            <a:ext cx="45720" cy="603504"/>
+          </a:xfrm>
+          <a:prstGeom prst="rect">
+            <a:avLst/>
+          </a:prstGeom>
+          <a:solidFill>
+            <a:srgbClr val="890C58"/>
+          </a:solidFill>
+          <a:ln/>
+        </p:spPr>
+      </p:sp>
+      <p:sp>
+        <p:nvSpPr>
+          <p:cNvPr id="19" name="Text 17"/>
+          <p:cNvSpPr/>
+          <p:nvPr/>
+        </p:nvSpPr>
+        <p:spPr>
+          <a:xfrm>
+            <a:off x="4809744" y="1591056"/>
+            <a:ext cx="3877056" cy="201168"/>
+          </a:xfrm>
+          <a:prstGeom prst="rect">
+            <a:avLst/>
+          </a:prstGeom>
+          <a:noFill/>
+          <a:ln/>
+        </p:spPr>
+        <p:txBody>
+          <a:bodyPr wrap="square" lIns="0" tIns="0" rIns="0" bIns="0" rtlCol="0" anchor="ctr"/>
+          <a:lstStyle/>
+          <a:p>
+            <a:pPr indent="0" marL="0">
+              <a:buNone/>
+            </a:pPr>
+            <a:r>
+              <a:rPr lang="en-US" sz="1100" b="1" dirty="0">
+                <a:solidFill>
+                  <a:srgbClr val="000000"/>
+                </a:solidFill>
+                <a:latin typeface="NVIDIA Sans" pitchFamily="34" charset="0"/>
+                <a:ea typeface="NVIDIA Sans" pitchFamily="34" charset="-122"/>
+                <a:cs typeface="NVIDIA Sans" pitchFamily="34" charset="-120"/>
+              </a:rPr>
+              <a:t>FA2 for the text stack too</a:t>
+            </a:r>
+            <a:endParaRPr lang="en-US" sz="1100" dirty="0"/>
+          </a:p>
+        </p:txBody>
+      </p:sp>
+      <p:sp>
+        <p:nvSpPr>
+          <p:cNvPr id="20" name="Text 18"/>
+          <p:cNvSpPr/>
+          <p:nvPr/>
+        </p:nvSpPr>
+        <p:spPr>
+          <a:xfrm>
+            <a:off x="4809744" y="1792224"/>
+            <a:ext cx="3877056" cy="438912"/>
+          </a:xfrm>
+          <a:prstGeom prst="rect">
+            <a:avLst/>
+          </a:prstGeom>
+          <a:noFill/>
+          <a:ln/>
+        </p:spPr>
+        <p:txBody>
+          <a:bodyPr wrap="square" lIns="0" tIns="0" rIns="0" bIns="0" rtlCol="0" anchor="t"/>
+          <a:lstStyle/>
+          <a:p>
+            <a:pPr indent="0" marL="0">
+              <a:buNone/>
+            </a:pPr>
+            <a:r>
+              <a:rPr lang="en-US" sz="900" dirty="0">
+                <a:solidFill>
+                  <a:srgbClr val="5E5E5E"/>
+                </a:solidFill>
+                <a:latin typeface="NVIDIA Sans" pitchFamily="34" charset="0"/>
+                <a:ea typeface="NVIDIA Sans" pitchFamily="34" charset="-122"/>
+                <a:cs typeface="NVIDIA Sans" pitchFamily="34" charset="-120"/>
+              </a:rPr>
+              <a:t>+10 ms at seq 192: unpad/repad overhead outweighs the kernel gains. Mixed (vision-only FA2) is the right split.</a:t>
+            </a:r>
+            <a:endParaRPr lang="en-US" sz="900" dirty="0"/>
+          </a:p>
+        </p:txBody>
+      </p:sp>
+      <p:sp>
+        <p:nvSpPr>
+          <p:cNvPr id="21" name="Shape 19"/>
+          <p:cNvSpPr/>
+          <p:nvPr/>
+        </p:nvSpPr>
+        <p:spPr>
+          <a:xfrm>
+            <a:off x="4663440" y="2322576"/>
+            <a:ext cx="45720" cy="603504"/>
+          </a:xfrm>
+          <a:prstGeom prst="rect">
+            <a:avLst/>
+          </a:prstGeom>
+          <a:solidFill>
+            <a:srgbClr val="890C58"/>
+          </a:solidFill>
+          <a:ln/>
+        </p:spPr>
+      </p:sp>
+      <p:sp>
+        <p:nvSpPr>
+          <p:cNvPr id="22" name="Text 20"/>
+          <p:cNvSpPr/>
+          <p:nvPr/>
+        </p:nvSpPr>
+        <p:spPr>
+          <a:xfrm>
+            <a:off x="4809744" y="2304288"/>
+            <a:ext cx="3877056" cy="201168"/>
+          </a:xfrm>
+          <a:prstGeom prst="rect">
+            <a:avLst/>
+          </a:prstGeom>
+          <a:noFill/>
+          <a:ln/>
+        </p:spPr>
+        <p:txBody>
+          <a:bodyPr wrap="square" lIns="0" tIns="0" rIns="0" bIns="0" rtlCol="0" anchor="ctr"/>
+          <a:lstStyle/>
+          <a:p>
+            <a:pPr indent="0" marL="0">
+              <a:buNone/>
+            </a:pPr>
+            <a:r>
+              <a:rPr lang="en-US" sz="1100" b="1" dirty="0">
+                <a:solidFill>
+                  <a:srgbClr val="000000"/>
+                </a:solidFill>
+                <a:latin typeface="NVIDIA Sans" pitchFamily="34" charset="0"/>
+                <a:ea typeface="NVIDIA Sans" pitchFamily="34" charset="-122"/>
+                <a:cs typeface="NVIDIA Sans" pitchFamily="34" charset="-120"/>
+              </a:rPr>
+              <a:t>NCCL knob tuning (NVLS / protocol / channels)</a:t>
+            </a:r>
+            <a:endParaRPr lang="en-US" sz="1100" dirty="0"/>
+          </a:p>
+        </p:txBody>
+      </p:sp>
+      <p:sp>
+        <p:nvSpPr>
+          <p:cNvPr id="23" name="Text 21"/>
+          <p:cNvSpPr/>
+          <p:nvPr/>
+        </p:nvSpPr>
+        <p:spPr>
+          <a:xfrm>
+            <a:off x="4809744" y="2505456"/>
+            <a:ext cx="3877056" cy="438912"/>
+          </a:xfrm>
+          <a:prstGeom prst="rect">
+            <a:avLst/>
+          </a:prstGeom>
+          <a:noFill/>
+          <a:ln/>
+        </p:spPr>
+        <p:txBody>
+          <a:bodyPr wrap="square" lIns="0" tIns="0" rIns="0" bIns="0" rtlCol="0" anchor="t"/>
+          <a:lstStyle/>
+          <a:p>
+            <a:pPr indent="0" marL="0">
+              <a:buNone/>
+            </a:pPr>
+            <a:r>
+              <a:rPr lang="en-US" sz="900" dirty="0">
+                <a:solidFill>
+                  <a:srgbClr val="5E5E5E"/>
+                </a:solidFill>
+                <a:latin typeface="NVIDIA Sans" pitchFamily="34" charset="0"/>
+                <a:ea typeface="NVIDIA Sans" pitchFamily="34" charset="-122"/>
+                <a:cs typeface="NVIDIA Sans" pitchFamily="34" charset="-120"/>
+              </a:rPr>
+              <a:t>AllReduce microbench already hits 478 GB/s busbw — the NVLink per-direction ceiling. Config cannot add bandwidth.</a:t>
+            </a:r>
+            <a:endParaRPr lang="en-US" sz="900" dirty="0"/>
+          </a:p>
+        </p:txBody>
+      </p:sp>
+      <p:sp>
+        <p:nvSpPr>
+          <p:cNvPr id="24" name="Shape 22"/>
+          <p:cNvSpPr/>
+          <p:nvPr/>
+        </p:nvSpPr>
+        <p:spPr>
+          <a:xfrm>
+            <a:off x="4663440" y="3035808"/>
+            <a:ext cx="45720" cy="603504"/>
+          </a:xfrm>
+          <a:prstGeom prst="rect">
+            <a:avLst/>
+          </a:prstGeom>
+          <a:solidFill>
+            <a:srgbClr val="890C58"/>
+          </a:solidFill>
+          <a:ln/>
+        </p:spPr>
+      </p:sp>
+      <p:sp>
+        <p:nvSpPr>
+          <p:cNvPr id="25" name="Text 23"/>
+          <p:cNvSpPr/>
+          <p:nvPr/>
+        </p:nvSpPr>
+        <p:spPr>
+          <a:xfrm>
+            <a:off x="4809744" y="3017520"/>
+            <a:ext cx="3877056" cy="201168"/>
+          </a:xfrm>
+          <a:prstGeom prst="rect">
+            <a:avLst/>
+          </a:prstGeom>
+          <a:noFill/>
+          <a:ln/>
+        </p:spPr>
+        <p:txBody>
+          <a:bodyPr wrap="square" lIns="0" tIns="0" rIns="0" bIns="0" rtlCol="0" anchor="ctr"/>
+          <a:lstStyle/>
+          <a:p>
+            <a:pPr indent="0" marL="0">
+              <a:buNone/>
+            </a:pPr>
+            <a:r>
+              <a:rPr lang="en-US" sz="1100" b="1" dirty="0">
+                <a:solidFill>
+                  <a:srgbClr val="000000"/>
+                </a:solidFill>
+                <a:latin typeface="NVIDIA Sans" pitchFamily="34" charset="0"/>
+                <a:ea typeface="NVIDIA Sans" pitchFamily="34" charset="-122"/>
+                <a:cs typeface="NVIDIA Sans" pitchFamily="34" charset="-120"/>
+              </a:rPr>
+              <a:t>One giant decoder graph</a:t>
+            </a:r>
+            <a:endParaRPr lang="en-US" sz="1100" dirty="0"/>
+          </a:p>
+        </p:txBody>
+      </p:sp>
+      <p:sp>
+        <p:nvSpPr>
+          <p:cNvPr id="26" name="Text 24"/>
+          <p:cNvSpPr/>
+          <p:nvPr/>
+        </p:nvSpPr>
+        <p:spPr>
+          <a:xfrm>
+            <a:off x="4809744" y="3218688"/>
+            <a:ext cx="3877056" cy="438912"/>
+          </a:xfrm>
+          <a:prstGeom prst="rect">
+            <a:avLst/>
+          </a:prstGeom>
+          <a:noFill/>
+          <a:ln/>
+        </p:spPr>
+        <p:txBody>
+          <a:bodyPr wrap="square" lIns="0" tIns="0" rIns="0" bIns="0" rtlCol="0" anchor="t"/>
+          <a:lstStyle/>
+          <a:p>
+            <a:pPr indent="0" marL="0">
+              <a:buNone/>
+            </a:pPr>
+            <a:r>
+              <a:rPr lang="en-US" sz="900" dirty="0">
+                <a:solidFill>
+                  <a:srgbClr val="5E5E5E"/>
+                </a:solidFill>
+                <a:latin typeface="NVIDIA Sans" pitchFamily="34" charset="0"/>
+                <a:ea typeface="NVIDIA Sans" pitchFamily="34" charset="-122"/>
+                <a:cs typeface="NVIDIA Sans" pitchFamily="34" charset="-120"/>
+              </a:rPr>
+              <a:t>Library graph-breaks fragment the capture, and a single graph would defer every AllReduce to the step end (page 10).</a:t>
+            </a:r>
+            <a:endParaRPr lang="en-US" sz="900" dirty="0"/>
+          </a:p>
+        </p:txBody>
+      </p:sp>
+      <p:sp>
+        <p:nvSpPr>
+          <p:cNvPr id="27" name="Shape 25"/>
+          <p:cNvSpPr/>
+          <p:nvPr/>
+        </p:nvSpPr>
+        <p:spPr>
+          <a:xfrm>
+            <a:off x="4663440" y="3749040"/>
+            <a:ext cx="45720" cy="603504"/>
+          </a:xfrm>
+          <a:prstGeom prst="rect">
+            <a:avLst/>
+          </a:prstGeom>
+          <a:solidFill>
+            <a:srgbClr val="890C58"/>
+          </a:solidFill>
+          <a:ln/>
+        </p:spPr>
+      </p:sp>
+      <p:sp>
+        <p:nvSpPr>
+          <p:cNvPr id="28" name="Text 26"/>
+          <p:cNvSpPr/>
+          <p:nvPr/>
+        </p:nvSpPr>
+        <p:spPr>
+          <a:xfrm>
+            <a:off x="4809744" y="3730752"/>
+            <a:ext cx="3877056" cy="201168"/>
+          </a:xfrm>
+          <a:prstGeom prst="rect">
+            <a:avLst/>
+          </a:prstGeom>
+          <a:noFill/>
+          <a:ln/>
+        </p:spPr>
+        <p:txBody>
+          <a:bodyPr wrap="square" lIns="0" tIns="0" rIns="0" bIns="0" rtlCol="0" anchor="ctr"/>
+          <a:lstStyle/>
+          <a:p>
+            <a:pPr indent="0" marL="0">
+              <a:buNone/>
+            </a:pPr>
+            <a:r>
+              <a:rPr lang="en-US" sz="1100" b="1" dirty="0">
+                <a:solidFill>
+                  <a:srgbClr val="000000"/>
+                </a:solidFill>
+                <a:latin typeface="NVIDIA Sans" pitchFamily="34" charset="0"/>
+                <a:ea typeface="NVIDIA Sans" pitchFamily="34" charset="-122"/>
+                <a:cs typeface="NVIDIA Sans" pitchFamily="34" charset="-120"/>
+              </a:rPr>
+              <a:t>FlashQLA GDN kernels</a:t>
+            </a:r>
+            <a:endParaRPr lang="en-US" sz="1100" dirty="0"/>
+          </a:p>
+        </p:txBody>
+      </p:sp>
+      <p:sp>
+        <p:nvSpPr>
+          <p:cNvPr id="29" name="Text 27"/>
+          <p:cNvSpPr/>
+          <p:nvPr/>
+        </p:nvSpPr>
+        <p:spPr>
+          <a:xfrm>
+            <a:off x="4809744" y="3931920"/>
+            <a:ext cx="3877056" cy="438912"/>
+          </a:xfrm>
+          <a:prstGeom prst="rect">
+            <a:avLst/>
+          </a:prstGeom>
+          <a:noFill/>
+          <a:ln/>
+        </p:spPr>
+        <p:txBody>
+          <a:bodyPr wrap="square" lIns="0" tIns="0" rIns="0" bIns="0" rtlCol="0" anchor="t"/>
+          <a:lstStyle/>
+          <a:p>
+            <a:pPr indent="0" marL="0">
+              <a:buNone/>
+            </a:pPr>
+            <a:r>
+              <a:rPr lang="en-US" sz="900" dirty="0">
+                <a:solidFill>
+                  <a:srgbClr val="5E5E5E"/>
+                </a:solidFill>
+                <a:latin typeface="NVIDIA Sans" pitchFamily="34" charset="0"/>
+                <a:ea typeface="NVIDIA Sans" pitchFamily="34" charset="-122"/>
+                <a:cs typeface="NVIDIA Sans" pitchFamily="34" charset="-120"/>
+              </a:rPr>
+              <a:t>Total GDN kernel time is only ~10.5 ms/step at seq 192 — below the integration risk; also needs torch ≥ 2.8.</a:t>
+            </a:r>
+            <a:endParaRPr lang="en-US" sz="900" dirty="0"/>
+          </a:p>
+        </p:txBody>
+      </p:sp>
+      <p:sp>
+        <p:nvSpPr>
+          <p:cNvPr id="30" name="Text 28"/>
           <p:cNvSpPr/>
           <p:nvPr/>
         </p:nvSpPr>
@@ -11445,7 +10799,7 @@
       </p:sp>
       <p:sp>
         <p:nvSpPr>
-          <p:cNvPr id="6" name="Text 3"/>
+          <p:cNvPr id="31" name="Text 29"/>
           <p:cNvSpPr/>
           <p:nvPr/>
         </p:nvSpPr>
@@ -11484,7 +10838,7 @@
       </p:sp>
       <p:sp>
         <p:nvSpPr>
-          <p:cNvPr id="7" name="Shape 4"/>
+          <p:cNvPr id="32" name="Shape 30"/>
           <p:cNvSpPr/>
           <p:nvPr/>
         </p:nvSpPr>
@@ -11504,7 +10858,7 @@
       </p:sp>
       <p:pic>
         <p:nvPicPr>
-          <p:cNvPr id="8" name="Image 0" descr="/app/logos/nvidia-logo-blk-sm.png">    </p:cNvPr>
+          <p:cNvPr id="33" name="Image 0" descr="/app/logos/nvidia-logo-blk-sm.png">    </p:cNvPr>
           <p:cNvPicPr>
             <a:picLocks noChangeAspect="1"/>
           </p:cNvPicPr>
@@ -11512,890 +10866,6 @@
         </p:nvPicPr>
         <p:blipFill>
           <a:blip r:embed="rId1"/>
-          <a:stretch>
-            <a:fillRect/>
-          </a:stretch>
-        </p:blipFill>
-        <p:spPr>
-          <a:xfrm>
-            <a:off x="7863840" y="4604004"/>
-            <a:ext cx="1005840" cy="347472"/>
-          </a:xfrm>
-          <a:prstGeom prst="rect">
-            <a:avLst/>
-          </a:prstGeom>
-        </p:spPr>
-      </p:pic>
-    </p:spTree>
-  </p:cSld>
-  <p:clrMapOvr>
-    <a:masterClrMapping/>
-  </p:clrMapOvr>
-</p:sld>
-</file>
-
-<file path=ppt/slides/slide14.xml><?xml version="1.0" encoding="utf-8"?>
-<p:sld xmlns:a="http://schemas.openxmlformats.org/drawingml/2006/main" xmlns:r="http://schemas.openxmlformats.org/officeDocument/2006/relationships" xmlns:p="http://schemas.openxmlformats.org/presentationml/2006/main">
-  <p:cSld name="Slide 14">
-    <p:bg>
-      <p:bgPr>
-        <a:solidFill>
-          <a:srgbClr val="FFFFFF"/>
-        </a:solidFill>
-      </p:bgPr>
-    </p:bg>
-    <p:spTree>
-      <p:nvGrpSpPr>
-        <p:cNvPr id="1" name=""/>
-        <p:cNvGrpSpPr/>
-        <p:nvPr/>
-      </p:nvGrpSpPr>
-      <p:grpSpPr>
-        <a:xfrm>
-          <a:off x="0" y="0"/>
-          <a:ext cx="0" cy="0"/>
-          <a:chOff x="0" y="0"/>
-          <a:chExt cx="0" cy="0"/>
-        </a:xfrm>
-      </p:grpSpPr>
-      <p:sp>
-        <p:nvSpPr>
-          <p:cNvPr id="2" name="Text 0"/>
-          <p:cNvSpPr/>
-          <p:nvPr/>
-        </p:nvSpPr>
-        <p:spPr>
-          <a:xfrm>
-            <a:off x="457200" y="256032"/>
-            <a:ext cx="8229600" cy="548640"/>
-          </a:xfrm>
-          <a:prstGeom prst="rect">
-            <a:avLst/>
-          </a:prstGeom>
-          <a:noFill/>
-          <a:ln/>
-        </p:spPr>
-        <p:txBody>
-          <a:bodyPr wrap="square" lIns="0" tIns="0" rIns="0" bIns="0" rtlCol="0" anchor="ctr"/>
-          <a:lstStyle/>
-          <a:p>
-            <a:pPr indent="0" marL="0">
-              <a:buNone/>
-            </a:pPr>
-            <a:r>
-              <a:rPr lang="en-US" sz="3000" b="1" dirty="0">
-                <a:solidFill>
-                  <a:srgbClr val="000000"/>
-                </a:solidFill>
-                <a:latin typeface="NVIDIA Sans" pitchFamily="34" charset="0"/>
-                <a:ea typeface="NVIDIA Sans" pitchFamily="34" charset="-122"/>
-                <a:cs typeface="NVIDIA Sans" pitchFamily="34" charset="-120"/>
-              </a:rPr>
-              <a:t>Remaining Headroom &amp; Next Steps</a:t>
-            </a:r>
-            <a:endParaRPr lang="en-US" sz="3000" dirty="0"/>
-          </a:p>
-        </p:txBody>
-      </p:sp>
-      <p:sp>
-        <p:nvSpPr>
-          <p:cNvPr id="3" name="Text 1"/>
-          <p:cNvSpPr/>
-          <p:nvPr/>
-        </p:nvSpPr>
-        <p:spPr>
-          <a:xfrm>
-            <a:off x="457200" y="804672"/>
-            <a:ext cx="8229600" cy="329184"/>
-          </a:xfrm>
-          <a:prstGeom prst="rect">
-            <a:avLst/>
-          </a:prstGeom>
-          <a:noFill/>
-          <a:ln/>
-        </p:spPr>
-        <p:txBody>
-          <a:bodyPr wrap="square" lIns="0" tIns="0" rIns="0" bIns="0" rtlCol="0" anchor="ctr"/>
-          <a:lstStyle/>
-          <a:p>
-            <a:pPr indent="0" marL="0">
-              <a:buNone/>
-            </a:pPr>
-            <a:r>
-              <a:rPr lang="en-US" sz="1500" dirty="0">
-                <a:solidFill>
-                  <a:srgbClr val="76B900"/>
-                </a:solidFill>
-                <a:latin typeface="NVIDIA Sans" pitchFamily="34" charset="0"/>
-                <a:ea typeface="NVIDIA Sans" pitchFamily="34" charset="-122"/>
-                <a:cs typeface="NVIDIA Sans" pitchFamily="34" charset="-120"/>
-              </a:rPr>
-              <a:t>Where the next milliseconds live, ranked by ceiling — measured, not guessed</a:t>
-            </a:r>
-            <a:endParaRPr lang="en-US" sz="1500" dirty="0"/>
-          </a:p>
-        </p:txBody>
-      </p:sp>
-      <p:sp>
-        <p:nvSpPr>
-          <p:cNvPr id="4" name="Shape 2"/>
-          <p:cNvSpPr/>
-          <p:nvPr/>
-        </p:nvSpPr>
-        <p:spPr>
-          <a:xfrm>
-            <a:off x="457200" y="1371600"/>
-            <a:ext cx="8229600" cy="640080"/>
-          </a:xfrm>
-          <a:prstGeom prst="rect">
-            <a:avLst/>
-          </a:prstGeom>
-          <a:solidFill>
-            <a:srgbClr val="FFFFFF"/>
-          </a:solidFill>
-          <a:ln/>
-          <a:effectLst>
-            <a:outerShdw sx="100000" sy="100000" kx="0" ky="0" algn="bl" rotWithShape="0" blurRad="38100" dist="12700" dir="8100000">
-              <a:srgbClr val="000000">
-                <a:alpha val="15000"/>
-              </a:srgbClr>
-            </a:outerShdw>
-          </a:effectLst>
-        </p:spPr>
-      </p:sp>
-      <p:sp>
-        <p:nvSpPr>
-          <p:cNvPr id="5" name="Shape 3"/>
-          <p:cNvSpPr/>
-          <p:nvPr/>
-        </p:nvSpPr>
-        <p:spPr>
-          <a:xfrm>
-            <a:off x="457200" y="1371600"/>
-            <a:ext cx="54864" cy="640080"/>
-          </a:xfrm>
-          <a:prstGeom prst="rect">
-            <a:avLst/>
-          </a:prstGeom>
-          <a:solidFill>
-            <a:srgbClr val="76B900"/>
-          </a:solidFill>
-          <a:ln/>
-        </p:spPr>
-      </p:sp>
-      <p:pic>
-        <p:nvPicPr>
-          <p:cNvPr id="6" name="Image 0" descr="/app/icons/m48-gpu-chip-256px-grn.png">    </p:cNvPr>
-          <p:cNvPicPr>
-            <a:picLocks noChangeAspect="1"/>
-          </p:cNvPicPr>
-          <p:nvPr/>
-        </p:nvPicPr>
-        <p:blipFill>
-          <a:blip r:embed="rId1"/>
-          <a:stretch>
-            <a:fillRect/>
-          </a:stretch>
-        </p:blipFill>
-        <p:spPr>
-          <a:xfrm>
-            <a:off x="658368" y="1517904"/>
-            <a:ext cx="347472" cy="347472"/>
-          </a:xfrm>
-          <a:prstGeom prst="rect">
-            <a:avLst/>
-          </a:prstGeom>
-        </p:spPr>
-      </p:pic>
-      <p:sp>
-        <p:nvSpPr>
-          <p:cNvPr id="7" name="Text 4"/>
-          <p:cNvSpPr/>
-          <p:nvPr/>
-        </p:nvSpPr>
-        <p:spPr>
-          <a:xfrm>
-            <a:off x="1143000" y="1417320"/>
-            <a:ext cx="7406640" cy="274320"/>
-          </a:xfrm>
-          <a:prstGeom prst="rect">
-            <a:avLst/>
-          </a:prstGeom>
-          <a:noFill/>
-          <a:ln/>
-        </p:spPr>
-        <p:txBody>
-          <a:bodyPr wrap="square" lIns="0" tIns="0" rIns="0" bIns="0" rtlCol="0" anchor="ctr"/>
-          <a:lstStyle/>
-          <a:p>
-            <a:pPr indent="0" marL="0">
-              <a:buNone/>
-            </a:pPr>
-            <a:r>
-              <a:rPr lang="en-US" sz="1250" b="1" dirty="0">
-                <a:solidFill>
-                  <a:srgbClr val="000000"/>
-                </a:solidFill>
-                <a:latin typeface="NVIDIA Sans" pitchFamily="34" charset="0"/>
-                <a:ea typeface="NVIDIA Sans" pitchFamily="34" charset="-122"/>
-                <a:cs typeface="NVIDIA Sans" pitchFamily="34" charset="-120"/>
-              </a:rPr>
-              <a:t>Backward GEMMs at the power wall  </a:t>
-            </a:r>
-            <a:pPr indent="0" marL="0">
-              <a:buNone/>
-            </a:pPr>
-            <a:r>
-              <a:rPr lang="en-US" sz="1100" b="1" dirty="0">
-                <a:solidFill>
-                  <a:srgbClr val="76B900"/>
-                </a:solidFill>
-                <a:latin typeface="NVIDIA Sans" pitchFamily="34" charset="0"/>
-                <a:ea typeface="NVIDIA Sans" pitchFamily="34" charset="-122"/>
-                <a:cs typeface="NVIDIA Sans" pitchFamily="34" charset="-120"/>
-              </a:rPr>
-              <a:t>[fp8 territory]</a:t>
-            </a:r>
-            <a:endParaRPr lang="en-US" sz="1250" dirty="0"/>
-          </a:p>
-        </p:txBody>
-      </p:sp>
-      <p:sp>
-        <p:nvSpPr>
-          <p:cNvPr id="8" name="Text 5"/>
-          <p:cNvSpPr/>
-          <p:nvPr/>
-        </p:nvSpPr>
-        <p:spPr>
-          <a:xfrm>
-            <a:off x="1143000" y="1682496"/>
-            <a:ext cx="7406640" cy="292608"/>
-          </a:xfrm>
-          <a:prstGeom prst="rect">
-            <a:avLst/>
-          </a:prstGeom>
-          <a:noFill/>
-          <a:ln/>
-        </p:spPr>
-        <p:txBody>
-          <a:bodyPr wrap="square" lIns="0" tIns="0" rIns="0" bIns="0" rtlCol="0" anchor="t"/>
-          <a:lstStyle/>
-          <a:p>
-            <a:pPr indent="0" marL="0">
-              <a:buNone/>
-            </a:pPr>
-            <a:r>
-              <a:rPr lang="en-US" sz="1000" dirty="0">
-                <a:solidFill>
-                  <a:srgbClr val="5E5E5E"/>
-                </a:solidFill>
-                <a:latin typeface="NVIDIA Sans" pitchFamily="34" charset="0"/>
-                <a:ea typeface="NVIDIA Sans" pitchFamily="34" charset="-122"/>
-                <a:cs typeface="NVIDIA Sans" pitchFamily="34" charset="-120"/>
-              </a:rPr>
-              <a:t>Sustained GEMM throughput caps at ~622 TFLOPS on this node (power, not occupancy). The only lever left for the math itself is fp8.</a:t>
-            </a:r>
-            <a:endParaRPr lang="en-US" sz="1000" dirty="0"/>
-          </a:p>
-        </p:txBody>
-      </p:sp>
-      <p:sp>
-        <p:nvSpPr>
-          <p:cNvPr id="9" name="Shape 6"/>
-          <p:cNvSpPr/>
-          <p:nvPr/>
-        </p:nvSpPr>
-        <p:spPr>
-          <a:xfrm>
-            <a:off x="457200" y="2121408"/>
-            <a:ext cx="8229600" cy="640080"/>
-          </a:xfrm>
-          <a:prstGeom prst="rect">
-            <a:avLst/>
-          </a:prstGeom>
-          <a:solidFill>
-            <a:srgbClr val="FFFFFF"/>
-          </a:solidFill>
-          <a:ln/>
-          <a:effectLst>
-            <a:outerShdw sx="100000" sy="100000" kx="0" ky="0" algn="bl" rotWithShape="0" blurRad="38100" dist="12700" dir="8100000">
-              <a:srgbClr val="000000">
-                <a:alpha val="15000"/>
-              </a:srgbClr>
-            </a:outerShdw>
-          </a:effectLst>
-        </p:spPr>
-      </p:sp>
-      <p:sp>
-        <p:nvSpPr>
-          <p:cNvPr id="10" name="Shape 7"/>
-          <p:cNvSpPr/>
-          <p:nvPr/>
-        </p:nvSpPr>
-        <p:spPr>
-          <a:xfrm>
-            <a:off x="457200" y="2121408"/>
-            <a:ext cx="54864" cy="640080"/>
-          </a:xfrm>
-          <a:prstGeom prst="rect">
-            <a:avLst/>
-          </a:prstGeom>
-          <a:solidFill>
-            <a:srgbClr val="76B900"/>
-          </a:solidFill>
-          <a:ln/>
-        </p:spPr>
-      </p:sp>
-      <p:pic>
-        <p:nvPicPr>
-          <p:cNvPr id="11" name="Image 1" descr="/app/icons/m48-distributed-learning-256px-grn.png">    </p:cNvPr>
-          <p:cNvPicPr>
-            <a:picLocks noChangeAspect="1"/>
-          </p:cNvPicPr>
-          <p:nvPr/>
-        </p:nvPicPr>
-        <p:blipFill>
-          <a:blip r:embed="rId2"/>
-          <a:stretch>
-            <a:fillRect/>
-          </a:stretch>
-        </p:blipFill>
-        <p:spPr>
-          <a:xfrm>
-            <a:off x="658368" y="2267712"/>
-            <a:ext cx="347472" cy="347472"/>
-          </a:xfrm>
-          <a:prstGeom prst="rect">
-            <a:avLst/>
-          </a:prstGeom>
-        </p:spPr>
-      </p:pic>
-      <p:sp>
-        <p:nvSpPr>
-          <p:cNvPr id="12" name="Text 8"/>
-          <p:cNvSpPr/>
-          <p:nvPr/>
-        </p:nvSpPr>
-        <p:spPr>
-          <a:xfrm>
-            <a:off x="1143000" y="2167128"/>
-            <a:ext cx="7406640" cy="274320"/>
-          </a:xfrm>
-          <a:prstGeom prst="rect">
-            <a:avLst/>
-          </a:prstGeom>
-          <a:noFill/>
-          <a:ln/>
-        </p:spPr>
-        <p:txBody>
-          <a:bodyPr wrap="square" lIns="0" tIns="0" rIns="0" bIns="0" rtlCol="0" anchor="ctr"/>
-          <a:lstStyle/>
-          <a:p>
-            <a:pPr indent="0" marL="0">
-              <a:buNone/>
-            </a:pPr>
-            <a:r>
-              <a:rPr lang="en-US" sz="1250" b="1" dirty="0">
-                <a:solidFill>
-                  <a:srgbClr val="000000"/>
-                </a:solidFill>
-                <a:latin typeface="NVIDIA Sans" pitchFamily="34" charset="0"/>
-                <a:ea typeface="NVIDIA Sans" pitchFamily="34" charset="-122"/>
-                <a:cs typeface="NVIDIA Sans" pitchFamily="34" charset="-120"/>
-              </a:rPr>
-              <a:t>Exposed communication (~30-55 ms)  </a:t>
-            </a:r>
-            <a:pPr indent="0" marL="0">
-              <a:buNone/>
-            </a:pPr>
-            <a:r>
-              <a:rPr lang="en-US" sz="1100" b="1" dirty="0">
-                <a:solidFill>
-                  <a:srgbClr val="76B900"/>
-                </a:solidFill>
-                <a:latin typeface="NVIDIA Sans" pitchFamily="34" charset="0"/>
-                <a:ea typeface="NVIDIA Sans" pitchFamily="34" charset="-122"/>
-                <a:cs typeface="NVIDIA Sans" pitchFamily="34" charset="-120"/>
-              </a:rPr>
-              <a:t>[compression]</a:t>
-            </a:r>
-            <a:endParaRPr lang="en-US" sz="1250" dirty="0"/>
-          </a:p>
-        </p:txBody>
-      </p:sp>
-      <p:sp>
-        <p:nvSpPr>
-          <p:cNvPr id="13" name="Text 9"/>
-          <p:cNvSpPr/>
-          <p:nvPr/>
-        </p:nvSpPr>
-        <p:spPr>
-          <a:xfrm>
-            <a:off x="1143000" y="2432304"/>
-            <a:ext cx="7406640" cy="292608"/>
-          </a:xfrm>
-          <a:prstGeom prst="rect">
-            <a:avLst/>
-          </a:prstGeom>
-          <a:noFill/>
-          <a:ln/>
-        </p:spPr>
-        <p:txBody>
-          <a:bodyPr wrap="square" lIns="0" tIns="0" rIns="0" bIns="0" rtlCol="0" anchor="t"/>
-          <a:lstStyle/>
-          <a:p>
-            <a:pPr indent="0" marL="0">
-              <a:buNone/>
-            </a:pPr>
-            <a:r>
-              <a:rPr lang="en-US" sz="1000" dirty="0">
-                <a:solidFill>
-                  <a:srgbClr val="5E5E5E"/>
-                </a:solidFill>
-                <a:latin typeface="NVIDIA Sans" pitchFamily="34" charset="0"/>
-                <a:ea typeface="NVIDIA Sans" pitchFamily="34" charset="-122"/>
-                <a:cs typeface="NVIDIA Sans" pitchFamily="34" charset="-120"/>
-              </a:rPr>
-              <a:t>Bandwidth is at the NVLink ceiling; bytes are the only lever — 1-bit Adam / gradient compression, with convergence sign-off.</a:t>
-            </a:r>
-            <a:endParaRPr lang="en-US" sz="1000" dirty="0"/>
-          </a:p>
-        </p:txBody>
-      </p:sp>
-      <p:sp>
-        <p:nvSpPr>
-          <p:cNvPr id="14" name="Shape 10"/>
-          <p:cNvSpPr/>
-          <p:nvPr/>
-        </p:nvSpPr>
-        <p:spPr>
-          <a:xfrm>
-            <a:off x="457200" y="2871216"/>
-            <a:ext cx="8229600" cy="640080"/>
-          </a:xfrm>
-          <a:prstGeom prst="rect">
-            <a:avLst/>
-          </a:prstGeom>
-          <a:solidFill>
-            <a:srgbClr val="FFFFFF"/>
-          </a:solidFill>
-          <a:ln/>
-          <a:effectLst>
-            <a:outerShdw sx="100000" sy="100000" kx="0" ky="0" algn="bl" rotWithShape="0" blurRad="38100" dist="12700" dir="8100000">
-              <a:srgbClr val="000000">
-                <a:alpha val="15000"/>
-              </a:srgbClr>
-            </a:outerShdw>
-          </a:effectLst>
-        </p:spPr>
-      </p:sp>
-      <p:sp>
-        <p:nvSpPr>
-          <p:cNvPr id="15" name="Shape 11"/>
-          <p:cNvSpPr/>
-          <p:nvPr/>
-        </p:nvSpPr>
-        <p:spPr>
-          <a:xfrm>
-            <a:off x="457200" y="2871216"/>
-            <a:ext cx="54864" cy="640080"/>
-          </a:xfrm>
-          <a:prstGeom prst="rect">
-            <a:avLst/>
-          </a:prstGeom>
-          <a:solidFill>
-            <a:srgbClr val="76B900"/>
-          </a:solidFill>
-          <a:ln/>
-        </p:spPr>
-      </p:sp>
-      <p:pic>
-        <p:nvPicPr>
-          <p:cNvPr id="16" name="Image 2" descr="/app/icons/m48-cog-gear-256x-grn.png">    </p:cNvPr>
-          <p:cNvPicPr>
-            <a:picLocks noChangeAspect="1"/>
-          </p:cNvPicPr>
-          <p:nvPr/>
-        </p:nvPicPr>
-        <p:blipFill>
-          <a:blip r:embed="rId3"/>
-          <a:stretch>
-            <a:fillRect/>
-          </a:stretch>
-        </p:blipFill>
-        <p:spPr>
-          <a:xfrm>
-            <a:off x="658368" y="3017520"/>
-            <a:ext cx="347472" cy="347472"/>
-          </a:xfrm>
-          <a:prstGeom prst="rect">
-            <a:avLst/>
-          </a:prstGeom>
-        </p:spPr>
-      </p:pic>
-      <p:sp>
-        <p:nvSpPr>
-          <p:cNvPr id="17" name="Text 12"/>
-          <p:cNvSpPr/>
-          <p:nvPr/>
-        </p:nvSpPr>
-        <p:spPr>
-          <a:xfrm>
-            <a:off x="1143000" y="2916936"/>
-            <a:ext cx="7406640" cy="274320"/>
-          </a:xfrm>
-          <a:prstGeom prst="rect">
-            <a:avLst/>
-          </a:prstGeom>
-          <a:noFill/>
-          <a:ln/>
-        </p:spPr>
-        <p:txBody>
-          <a:bodyPr wrap="square" lIns="0" tIns="0" rIns="0" bIns="0" rtlCol="0" anchor="ctr"/>
-          <a:lstStyle/>
-          <a:p>
-            <a:pPr indent="0" marL="0">
-              <a:buNone/>
-            </a:pPr>
-            <a:r>
-              <a:rPr lang="en-US" sz="1250" b="1" dirty="0">
-                <a:solidFill>
-                  <a:srgbClr val="000000"/>
-                </a:solidFill>
-                <a:latin typeface="NVIDIA Sans" pitchFamily="34" charset="0"/>
-                <a:ea typeface="NVIDIA Sans" pitchFamily="34" charset="-122"/>
-                <a:cs typeface="NVIDIA Sans" pitchFamily="34" charset="-120"/>
-              </a:rPr>
-              <a:t>Exposed parameter AllGather (44 ms)  </a:t>
-            </a:r>
-            <a:pPr indent="0" marL="0">
-              <a:buNone/>
-            </a:pPr>
-            <a:r>
-              <a:rPr lang="en-US" sz="1100" b="1" dirty="0">
-                <a:solidFill>
-                  <a:srgbClr val="76B900"/>
-                </a:solidFill>
-                <a:latin typeface="NVIDIA Sans" pitchFamily="34" charset="0"/>
-                <a:ea typeface="NVIDIA Sans" pitchFamily="34" charset="-122"/>
-                <a:cs typeface="NVIDIA Sans" pitchFamily="34" charset="-120"/>
-              </a:rPr>
-              <a:t>[FSDP or async ZeRO-2]</a:t>
-            </a:r>
-            <a:endParaRPr lang="en-US" sz="1250" dirty="0"/>
-          </a:p>
-        </p:txBody>
-      </p:sp>
-      <p:sp>
-        <p:nvSpPr>
-          <p:cNvPr id="18" name="Text 13"/>
-          <p:cNvSpPr/>
-          <p:nvPr/>
-        </p:nvSpPr>
-        <p:spPr>
-          <a:xfrm>
-            <a:off x="1143000" y="3182112"/>
-            <a:ext cx="7406640" cy="292608"/>
-          </a:xfrm>
-          <a:prstGeom prst="rect">
-            <a:avLst/>
-          </a:prstGeom>
-          <a:noFill/>
-          <a:ln/>
-        </p:spPr>
-        <p:txBody>
-          <a:bodyPr wrap="square" lIns="0" tIns="0" rIns="0" bIns="0" rtlCol="0" anchor="t"/>
-          <a:lstStyle/>
-          <a:p>
-            <a:pPr indent="0" marL="0">
-              <a:buNone/>
-            </a:pPr>
-            <a:r>
-              <a:rPr lang="en-US" sz="1000" dirty="0">
-                <a:solidFill>
-                  <a:srgbClr val="5E5E5E"/>
-                </a:solidFill>
-                <a:latin typeface="NVIDIA Sans" pitchFamily="34" charset="0"/>
-                <a:ea typeface="NVIDIA Sans" pitchFamily="34" charset="-122"/>
-                <a:cs typeface="NVIDIA Sans" pitchFamily="34" charset="-120"/>
-              </a:rPr>
-              <a:t>Optimization shrank compute — the step-end AllGather is now fully exposed and ZeRO-2 cannot overlap it. Adopt FSDP (overlapped unshard) or extend ZeRO-2 with an async parameter gather.</a:t>
-            </a:r>
-            <a:endParaRPr lang="en-US" sz="1000" dirty="0"/>
-          </a:p>
-        </p:txBody>
-      </p:sp>
-      <p:sp>
-        <p:nvSpPr>
-          <p:cNvPr id="19" name="Shape 14"/>
-          <p:cNvSpPr/>
-          <p:nvPr/>
-        </p:nvSpPr>
-        <p:spPr>
-          <a:xfrm>
-            <a:off x="457200" y="3621024"/>
-            <a:ext cx="8229600" cy="640080"/>
-          </a:xfrm>
-          <a:prstGeom prst="rect">
-            <a:avLst/>
-          </a:prstGeom>
-          <a:solidFill>
-            <a:srgbClr val="FFFFFF"/>
-          </a:solidFill>
-          <a:ln/>
-          <a:effectLst>
-            <a:outerShdw sx="100000" sy="100000" kx="0" ky="0" algn="bl" rotWithShape="0" blurRad="38100" dist="12700" dir="8100000">
-              <a:srgbClr val="000000">
-                <a:alpha val="15000"/>
-              </a:srgbClr>
-            </a:outerShdw>
-          </a:effectLst>
-        </p:spPr>
-      </p:sp>
-      <p:sp>
-        <p:nvSpPr>
-          <p:cNvPr id="20" name="Shape 15"/>
-          <p:cNvSpPr/>
-          <p:nvPr/>
-        </p:nvSpPr>
-        <p:spPr>
-          <a:xfrm>
-            <a:off x="457200" y="3621024"/>
-            <a:ext cx="54864" cy="640080"/>
-          </a:xfrm>
-          <a:prstGeom prst="rect">
-            <a:avLst/>
-          </a:prstGeom>
-          <a:solidFill>
-            <a:srgbClr val="76B900"/>
-          </a:solidFill>
-          <a:ln/>
-        </p:spPr>
-      </p:sp>
-      <p:pic>
-        <p:nvPicPr>
-          <p:cNvPr id="21" name="Image 3" descr="/app/icons/m48-scalability-up-sample-256px-grn.png">    </p:cNvPr>
-          <p:cNvPicPr>
-            <a:picLocks noChangeAspect="1"/>
-          </p:cNvPicPr>
-          <p:nvPr/>
-        </p:nvPicPr>
-        <p:blipFill>
-          <a:blip r:embed="rId4"/>
-          <a:stretch>
-            <a:fillRect/>
-          </a:stretch>
-        </p:blipFill>
-        <p:spPr>
-          <a:xfrm>
-            <a:off x="658368" y="3767328"/>
-            <a:ext cx="347472" cy="347472"/>
-          </a:xfrm>
-          <a:prstGeom prst="rect">
-            <a:avLst/>
-          </a:prstGeom>
-        </p:spPr>
-      </p:pic>
-      <p:sp>
-        <p:nvSpPr>
-          <p:cNvPr id="22" name="Text 16"/>
-          <p:cNvSpPr/>
-          <p:nvPr/>
-        </p:nvSpPr>
-        <p:spPr>
-          <a:xfrm>
-            <a:off x="1143000" y="3666744"/>
-            <a:ext cx="7406640" cy="274320"/>
-          </a:xfrm>
-          <a:prstGeom prst="rect">
-            <a:avLst/>
-          </a:prstGeom>
-          <a:noFill/>
-          <a:ln/>
-        </p:spPr>
-        <p:txBody>
-          <a:bodyPr wrap="square" lIns="0" tIns="0" rIns="0" bIns="0" rtlCol="0" anchor="ctr"/>
-          <a:lstStyle/>
-          <a:p>
-            <a:pPr indent="0" marL="0">
-              <a:buNone/>
-            </a:pPr>
-            <a:r>
-              <a:rPr lang="en-US" sz="1250" b="1" dirty="0">
-                <a:solidFill>
-                  <a:srgbClr val="000000"/>
-                </a:solidFill>
-                <a:latin typeface="NVIDIA Sans" pitchFamily="34" charset="0"/>
-                <a:ea typeface="NVIDIA Sans" pitchFamily="34" charset="-122"/>
-                <a:cs typeface="NVIDIA Sans" pitchFamily="34" charset="-120"/>
-              </a:rPr>
-              <a:t>Scale-out readiness  </a:t>
-            </a:r>
-            <a:pPr indent="0" marL="0">
-              <a:buNone/>
-            </a:pPr>
-            <a:r>
-              <a:rPr lang="en-US" sz="1100" b="1" dirty="0">
-                <a:solidFill>
-                  <a:srgbClr val="76B900"/>
-                </a:solidFill>
-                <a:latin typeface="NVIDIA Sans" pitchFamily="34" charset="0"/>
-                <a:ea typeface="NVIDIA Sans" pitchFamily="34" charset="-122"/>
-                <a:cs typeface="NVIDIA Sans" pitchFamily="34" charset="-120"/>
-              </a:rPr>
-              <a:t>[deployment]</a:t>
-            </a:r>
-            <a:endParaRPr lang="en-US" sz="1250" dirty="0"/>
-          </a:p>
-        </p:txBody>
-      </p:sp>
-      <p:sp>
-        <p:nvSpPr>
-          <p:cNvPr id="23" name="Text 17"/>
-          <p:cNvSpPr/>
-          <p:nvPr/>
-        </p:nvSpPr>
-        <p:spPr>
-          <a:xfrm>
-            <a:off x="1143000" y="3931920"/>
-            <a:ext cx="7406640" cy="292608"/>
-          </a:xfrm>
-          <a:prstGeom prst="rect">
-            <a:avLst/>
-          </a:prstGeom>
-          <a:noFill/>
-          <a:ln/>
-        </p:spPr>
-        <p:txBody>
-          <a:bodyPr wrap="square" lIns="0" tIns="0" rIns="0" bIns="0" rtlCol="0" anchor="t"/>
-          <a:lstStyle/>
-          <a:p>
-            <a:pPr indent="0" marL="0">
-              <a:buNone/>
-            </a:pPr>
-            <a:r>
-              <a:rPr lang="en-US" sz="1000" dirty="0">
-                <a:solidFill>
-                  <a:srgbClr val="5E5E5E"/>
-                </a:solidFill>
-                <a:latin typeface="NVIDIA Sans" pitchFamily="34" charset="0"/>
-                <a:ea typeface="NVIDIA Sans" pitchFamily="34" charset="-122"/>
-                <a:cs typeface="NVIDIA Sans" pitchFamily="34" charset="-120"/>
-              </a:rPr>
-              <a:t>On split-topology nodes (4+4 NVLink islands) set NCCL_P2P_LEVEL=NVL — first collective hangs otherwise. bs24 adoption gated on a convergence run.</a:t>
-            </a:r>
-            <a:endParaRPr lang="en-US" sz="1000" dirty="0"/>
-          </a:p>
-        </p:txBody>
-      </p:sp>
-      <p:sp>
-        <p:nvSpPr>
-          <p:cNvPr id="24" name="Text 18"/>
-          <p:cNvSpPr/>
-          <p:nvPr/>
-        </p:nvSpPr>
-        <p:spPr>
-          <a:xfrm>
-            <a:off x="457200" y="4617720"/>
-            <a:ext cx="4572000" cy="320040"/>
-          </a:xfrm>
-          <a:prstGeom prst="rect">
-            <a:avLst/>
-          </a:prstGeom>
-          <a:noFill/>
-          <a:ln/>
-        </p:spPr>
-        <p:txBody>
-          <a:bodyPr wrap="square" lIns="0" tIns="0" rIns="0" bIns="0" rtlCol="0" anchor="ctr"/>
-          <a:lstStyle/>
-          <a:p>
-            <a:pPr algn="l" indent="0" marL="0">
-              <a:buNone/>
-            </a:pPr>
-            <a:r>
-              <a:rPr lang="en-US" sz="1000" dirty="0">
-                <a:solidFill>
-                  <a:srgbClr val="5E5E5E"/>
-                </a:solidFill>
-                <a:latin typeface="NVIDIA Sans" pitchFamily="34" charset="0"/>
-                <a:ea typeface="NVIDIA Sans" pitchFamily="34" charset="-122"/>
-                <a:cs typeface="NVIDIA Sans" pitchFamily="34" charset="-120"/>
-              </a:rPr>
-              <a:t>QwenPI Training Optimization</a:t>
-            </a:r>
-            <a:endParaRPr lang="en-US" sz="1000" dirty="0"/>
-          </a:p>
-        </p:txBody>
-      </p:sp>
-      <p:sp>
-        <p:nvSpPr>
-          <p:cNvPr id="25" name="Text 19"/>
-          <p:cNvSpPr/>
-          <p:nvPr/>
-        </p:nvSpPr>
-        <p:spPr>
-          <a:xfrm>
-            <a:off x="7360920" y="4617720"/>
-            <a:ext cx="320040" cy="320040"/>
-          </a:xfrm>
-          <a:prstGeom prst="rect">
-            <a:avLst/>
-          </a:prstGeom>
-          <a:noFill/>
-          <a:ln/>
-        </p:spPr>
-        <p:txBody>
-          <a:bodyPr wrap="square" lIns="0" tIns="0" rIns="0" bIns="0" rtlCol="0" anchor="ctr"/>
-          <a:lstStyle/>
-          <a:p>
-            <a:pPr algn="r" indent="0" marL="0">
-              <a:buNone/>
-            </a:pPr>
-            <a:r>
-              <a:rPr lang="en-US" sz="1000" dirty="0">
-                <a:solidFill>
-                  <a:srgbClr val="5E5E5E"/>
-                </a:solidFill>
-                <a:latin typeface="NVIDIA Sans" pitchFamily="34" charset="0"/>
-                <a:ea typeface="NVIDIA Sans" pitchFamily="34" charset="-122"/>
-                <a:cs typeface="NVIDIA Sans" pitchFamily="34" charset="-120"/>
-              </a:rPr>
-              <a:t>14</a:t>
-            </a:r>
-            <a:endParaRPr lang="en-US" sz="1000" dirty="0"/>
-          </a:p>
-        </p:txBody>
-      </p:sp>
-      <p:sp>
-        <p:nvSpPr>
-          <p:cNvPr id="26" name="Shape 20"/>
-          <p:cNvSpPr/>
-          <p:nvPr/>
-        </p:nvSpPr>
-        <p:spPr>
-          <a:xfrm>
-            <a:off x="7726680" y="4617720"/>
-            <a:ext cx="36576" cy="320040"/>
-          </a:xfrm>
-          <a:prstGeom prst="rect">
-            <a:avLst/>
-          </a:prstGeom>
-          <a:solidFill>
-            <a:srgbClr val="76B900"/>
-          </a:solidFill>
-          <a:ln/>
-        </p:spPr>
-      </p:sp>
-      <p:pic>
-        <p:nvPicPr>
-          <p:cNvPr id="27" name="Image 4" descr="/app/logos/nvidia-logo-blk-sm.png">    </p:cNvPr>
-          <p:cNvPicPr>
-            <a:picLocks noChangeAspect="1"/>
-          </p:cNvPicPr>
-          <p:nvPr/>
-        </p:nvPicPr>
-        <p:blipFill>
-          <a:blip r:embed="rId5"/>
           <a:stretch>
             <a:fillRect/>
           </a:stretch>

</xml_diff>

<commit_message>
docs(slides): agenda page; deck finalized at 14 pages
</commit_message>
<xml_diff>
--- a/docs/slides/qwenpi-optimization.pptx
+++ b/docs/slides/qwenpi-optimization.pptx
@@ -18,9 +18,10 @@
     <p:sldId id="266" r:id="rId12"/>
     <p:sldId id="267" r:id="rId13"/>
     <p:sldId id="268" r:id="rId14"/>
+    <p:sldId id="269" r:id="rId15"/>
   </p:sldIdLst>
   <p:notesMasterIdLst>
-    <p:notesMasterId r:id="rId15"/>
+    <p:notesMasterId r:id="rId16"/>
   </p:notesMasterIdLst>
   <p:sldSz cx="9144000" cy="5143500"/>
   <p:notesSz cx="5143500" cy="9144000"/>
@@ -12954,9 +12955,8 @@
           <a:p>
             <a:r>
               <a:rPr lang="en-US" dirty="0"/>
-              <a:t>Graph capture preserves exact hidden-state semantics - verified fullgraph fwd+bwd and unchanged loss trajectory.
-If pressed on details: a whole-stack compile also fails outright here (fla graph-breaks fragment it into cudagraph partitions sharing one memory pool, whose allocator checkpointing collides with ZeRO-2 hook NCCL allocations - crash on torch 2.6 and 2.7.1). Keep it at 'engineering constraints' unless the audience digs.
-Group size 8 = measured sweet spot; 4 replays vs 1 costs microseconds.</a:t>
+              <a:t>Baseline: qwenpi_baseline_nvtx train_step_33; optimized: milestone1 train_step_48. Launch-window attribution both sides.
+[IMPORTANT] This page motivates graphs with the customer's own trace numbers; the next page is the design and the 4-vs-1 answer.</a:t>
             </a:r>
             <a:endParaRPr lang="en-US" dirty="0"/>
           </a:p>
@@ -13044,9 +13044,9 @@
           <a:p>
             <a:r>
               <a:rPr lang="en-US" dirty="0"/>
-              <a:t>Mechanism source (DeepSpeed 0.16.9 stage_1_and_2.py): TWO ipg buffers when overlap_comm (L2055); average_tensor enqueues compute.wait_stream(reduction_stream) at every bucket boundary (L1061-1062) - pipeline depth is one in-flight reduction.
-A/B re-captured on viking-prod-303 with node-level graph trace: period basis 5e8 = 319 ms/step, 1.5e9 = 306 ms (in-step walls 261/249, gaps ~57 both); AR busy equal within 1 ms (same bytes). Original-branch sweep: 2e9 was +4.7 ms.
-Final ledger (moved off-slide): baseline 807 = 540 busy + 62 exposed + 205 idle; optimized 249 = 175 + 22 + 43.</a:t>
+              <a:t>Graph capture preserves exact hidden-state semantics - verified fullgraph fwd+bwd and unchanged loss trajectory.
+If pressed on details: a whole-stack compile also fails outright here (fla graph-breaks fragment it into cudagraph partitions sharing one memory pool, whose allocator checkpointing collides with ZeRO-2 hook NCCL allocations - crash on torch 2.6 and 2.7.1). Keep it at 'engineering constraints' unless the audience digs.
+Group size 8 = measured sweet spot; 4 replays vs 1 costs microseconds.</a:t>
             </a:r>
             <a:endParaRPr lang="en-US" dirty="0"/>
           </a:p>
@@ -13134,7 +13134,9 @@
           <a:p>
             <a:r>
               <a:rPr lang="en-US" dirty="0"/>
-              <a:t>[IMPORTANT] Recommendation: bs 24 is the throughput config, gated on customer-side convergence validation (lr recalibration).</a:t>
+              <a:t>Mechanism source (DeepSpeed 0.16.9 stage_1_and_2.py): TWO ipg buffers when overlap_comm (L2055); average_tensor enqueues compute.wait_stream(reduction_stream) at every bucket boundary (L1061-1062) - pipeline depth is one in-flight reduction.
+A/B re-captured on viking-prod-303 with node-level graph trace: period basis 5e8 = 319 ms/step, 1.5e9 = 306 ms (in-step walls 261/249, gaps ~57 both); AR busy equal within 1 ms (same bytes). Original-branch sweep: 2e9 was +4.7 ms.
+Final ledger (moved off-slide): baseline 807 = 540 busy + 62 exposed + 205 idle; optimized 249 = 175 + 22 + 43.</a:t>
             </a:r>
             <a:endParaRPr lang="en-US" dirty="0"/>
           </a:p>
@@ -13222,6 +13224,94 @@
           <a:p>
             <a:r>
               <a:rPr lang="en-US" dirty="0"/>
+              <a:t>[IMPORTANT] Recommendation: bs 24 is the throughput config, gated on customer-side convergence validation (lr recalibration).</a:t>
+            </a:r>
+            <a:endParaRPr lang="en-US" dirty="0"/>
+          </a:p>
+        </p:txBody>
+      </p:sp>
+      <p:sp>
+        <p:nvSpPr>
+          <p:cNvPr id="4" name="Slide Number Placeholder 3"/>
+          <p:cNvSpPr>
+            <a:spLocks noGrp="1"/>
+          </p:cNvSpPr>
+          <p:nvPr>
+            <p:ph type="sldNum" sz="quarter" idx="10"/>
+          </p:nvPr>
+        </p:nvSpPr>
+        <p:spPr/>
+        <p:txBody>
+          <a:bodyPr/>
+          <a:lstStyle/>
+          <a:p>
+            <a:fld id="{F7021451-1387-4CA6-816F-3879F97B5CBC}" type="slidenum">
+              <a:rPr lang="en-US"/>
+              <a:t>13</a:t>
+            </a:fld>
+            <a:endParaRPr lang="en-US"/>
+          </a:p>
+        </p:txBody>
+      </p:sp>
+    </p:spTree>
+    <p:extLst>
+      <p:ext uri="{BB962C8B-B14F-4D97-AF65-F5344CB8AC3E}">
+        <p14:creationId xmlns:p14="http://schemas.microsoft.com/office/powerpoint/2010/main" val="1024086991"/>
+      </p:ext>
+    </p:extLst>
+  </p:cSld>
+  <p:clrMapOvr>
+    <a:masterClrMapping/>
+  </p:clrMapOvr>
+</p:notes>
+</file>
+
+<file path=ppt/notesSlides/notesSlide14.xml><?xml version="1.0" encoding="utf-8"?>
+<p:notes xmlns:a="http://schemas.openxmlformats.org/drawingml/2006/main" xmlns:r="http://schemas.openxmlformats.org/officeDocument/2006/relationships" xmlns:p="http://schemas.openxmlformats.org/presentationml/2006/main">
+  <p:cSld>
+    <p:spTree>
+      <p:nvGrpSpPr>
+        <p:cNvPr id="1" name=""/>
+        <p:cNvGrpSpPr/>
+        <p:nvPr/>
+      </p:nvGrpSpPr>
+      <p:grpSpPr>
+        <a:xfrm>
+          <a:off x="0" y="0"/>
+          <a:ext cx="0" cy="0"/>
+          <a:chOff x="0" y="0"/>
+          <a:chExt cx="0" cy="0"/>
+        </a:xfrm>
+      </p:grpSpPr>
+      <p:sp>
+        <p:nvSpPr>
+          <p:cNvPr id="2" name="Slide Image Placeholder 1"/>
+          <p:cNvSpPr>
+            <a:spLocks noGrp="1" noRot="1" noChangeAspect="1"/>
+          </p:cNvSpPr>
+          <p:nvPr>
+            <p:ph type="sldImg"/>
+          </p:nvPr>
+        </p:nvSpPr>
+        <p:spPr/>
+      </p:sp>
+      <p:sp>
+        <p:nvSpPr>
+          <p:cNvPr id="3" name="Notes Placeholder 2"/>
+          <p:cNvSpPr>
+            <a:spLocks noGrp="1"/>
+          </p:cNvSpPr>
+          <p:nvPr>
+            <p:ph type="body" idx="1"/>
+          </p:nvPr>
+        </p:nvSpPr>
+        <p:spPr/>
+        <p:txBody>
+          <a:bodyPr/>
+          <a:lstStyle/>
+          <a:p>
+            <a:r>
+              <a:rPr lang="en-US" dirty="0"/>
               <a:t>Timeline: qwenpi_bktAB_15e9 train_step_48 through the next step start (node-level trace). AllGather = 2 x 22 ms, fully exposed - the single biggest remaining block.
 Ruled-out list (keep for Q&amp;A): full FA2 +10 ms at seq 192; NCCL knobs futile (478 GB/s busbw = ceiling); one giant decoder graph breaks + kills AR overlap; FlashQLA ceiling ~10.5 ms and needs torch&gt;=2.8; masked_scatter nonzero patch 0 ms; MRoPE cache neutral at tip.
 Optimizer math (~10 ms Adam) additionally has a compiled-autograd lever. Deployment notes: 4+4-topology nodes need NCCL_P2P_LEVEL=NVL; bs24 gated on convergence run.
@@ -13248,7 +13338,7 @@
           <a:p>
             <a:fld id="{F7021451-1387-4CA6-816F-3879F97B5CBC}" type="slidenum">
               <a:rPr lang="en-US"/>
-              <a:t>13</a:t>
+              <a:t>14</a:t>
             </a:fld>
             <a:endParaRPr lang="en-US"/>
           </a:p>
@@ -13313,7 +13403,7 @@
           <a:p>
             <a:r>
               <a:rPr lang="en-US" dirty="0"/>
-              <a:t>Anchor slide: 3.2x step time, 3.2x throughput at same batch; batch scaling adds another 32% on top.</a:t>
+              <a:t>Story spine: problems first (pages 5-6), then one fix per problem, each with same-node A/B evidence; close with scaling and the go-forward plan.</a:t>
             </a:r>
             <a:endParaRPr lang="en-US" dirty="0"/>
           </a:p>
@@ -13401,8 +13491,7 @@
           <a:p>
             <a:r>
               <a:rPr lang="en-US" dirty="0"/>
-              <a:t>Hybrid decoder = full attention + gated-delta-net (linear attention) layers — this matters later: GDN blocks whole-model torch.compile.
-Action expert consumes VLM hidden states layer-wise (layerwise DiT).</a:t>
+              <a:t>Anchor slide: 3.2x step time, 3.2x throughput at same batch; batch scaling adds another 32% on top.</a:t>
             </a:r>
             <a:endParaRPr lang="en-US" dirty="0"/>
           </a:p>
@@ -13490,12 +13579,8 @@
           <a:p>
             <a:r>
               <a:rPr lang="en-US" dirty="0"/>
-              <a:t>Timeline from the NVTX-instrumented baseline re-capture (qwenpi_baseline_nvtx, viking-prod-303, train_step_33, 807 ms, bs 8/GPU). Both strips use the GPU-execution clock: kernels attributed to phases/modules by their CPU launch window (correlationId join).
-CPU-side forward() returns at 225 ms - the GPU is still executing DiT forward kernels until 309 ms (eager launch-ahead). That is why phases here are defined on GPU execution, not CPU ranges.
-Qwen3.5 bwd:fwd busy = 123:50 = 2.46x, matching theory (GEMM exactly 1.94x). The SPAN ratio is only 1.18x because forward is launch-starved: occupancy 34% vs 70% in backward (Python-side launches vs C++ autograd).
-Module bands = GPU execution spans, attributed by launch-window correlation (kernels joined to their CPU launch time via correlationId). GPU busy inside the bands: Qwen3.5 fwd 50 ms, DiT fwd 120 ms, DiT bwd 224 ms, Qwen3.5 bwd 123 ms - DiT owns 43% of all GPU busy time.
-Rows 2+3 land as one ladder level (pipeline &amp; caching, -117 ms); row 5 combines bucket sizing (PR11) and the redundant-flatten removal (PR12); row 6 covers the two config-level fixes.
-[IMPORTANT] Key message: every fix in this deck was first SEEN here as a trace shape or a measured kernel cost - problems first, solutions second.</a:t>
+              <a:t>Hybrid decoder = full attention + gated-delta-net (linear attention) layers — this matters later: GDN blocks whole-model torch.compile.
+Action expert consumes VLM hidden states layer-wise (layerwise DiT).</a:t>
             </a:r>
             <a:endParaRPr lang="en-US" dirty="0"/>
           </a:p>
@@ -13583,7 +13668,12 @@
           <a:p>
             <a:r>
               <a:rPr lang="en-US" dirty="0"/>
-              <a:t>Each bar is a separate 60-step run at that cumulative level; bars show ACTUAL step time, not deltas. The next slides walk these levels.</a:t>
+              <a:t>Timeline from the NVTX-instrumented baseline re-capture (qwenpi_baseline_nvtx, viking-prod-303, train_step_33, 807 ms, bs 8/GPU). Both strips use the GPU-execution clock: kernels attributed to phases/modules by their CPU launch window (correlationId join).
+CPU-side forward() returns at 225 ms - the GPU is still executing DiT forward kernels until 309 ms (eager launch-ahead). That is why phases here are defined on GPU execution, not CPU ranges.
+Qwen3.5 bwd:fwd busy = 123:50 = 2.46x, matching theory (GEMM exactly 1.94x). The SPAN ratio is only 1.18x because forward is launch-starved: occupancy 34% vs 70% in backward (Python-side launches vs C++ autograd).
+Module bands = GPU execution spans, attributed by launch-window correlation (kernels joined to their CPU launch time via correlationId). GPU busy inside the bands: Qwen3.5 fwd 50 ms, DiT fwd 120 ms, DiT bwd 224 ms, Qwen3.5 bwd 123 ms - DiT owns 43% of all GPU busy time.
+Rows 2+3 land as one ladder level (pipeline &amp; caching, -117 ms); row 5 combines bucket sizing (PR11) and the redundant-flatten removal (PR12); row 6 covers the two config-level fixes.
+[IMPORTANT] Key message: every fix in this deck was first SEEN here as a trace shape or a measured kernel cost - problems first, solutions second.</a:t>
             </a:r>
             <a:endParaRPr lang="en-US" dirty="0"/>
           </a:p>
@@ -13671,8 +13761,7 @@
           <a:p>
             <a:r>
               <a:rPr lang="en-US" dirty="0"/>
-              <a:t>Kernel classes measured on the instrumented baseline capture (qwenpi_baseline_nvtx).
-Loss curves: 1000-step clean A/B at the merged best config, only DIT_DTYPE differs (qwenpi_loss1k_fp32 vs qwenpi_loss1k_bf16, 2026-07-22, viking-prod-303). Final-100 means match to 4 decimals. Task-level accuracy is validated customer-side; loss trajectory is our correctness evidence.</a:t>
+              <a:t>Each bar is a separate 60-step run at that cumulative level; bars show ACTUAL step time, not deltas. The next slides walk these levels.</a:t>
             </a:r>
             <a:endParaRPr lang="en-US" dirty="0"/>
           </a:p>
@@ -13760,8 +13849,8 @@
           <a:p>
             <a:r>
               <a:rPr lang="en-US" dirty="0"/>
-              <a:t>All three sync points are CPU work serialized inside forward: data parsing at the top, ViT rotary/positional embedding, and MRoPE position ids between ViT and decoder.
-Stall sizes from the instrumented baseline; the timeline is a schematic, proportions follow the trace.</a:t>
+              <a:t>Kernel classes measured on the instrumented baseline capture (qwenpi_baseline_nvtx).
+Loss curves: 1000-step clean A/B at the merged best config, only DIT_DTYPE differs (qwenpi_loss1k_fp32 vs qwenpi_loss1k_bf16, 2026-07-22, viking-prod-303). Final-100 means match to 4 decimals. Task-level accuracy is validated customer-side; loss trajectory is our correctness evidence.</a:t>
             </a:r>
             <a:endParaRPr lang="en-US" dirty="0"/>
           </a:p>
@@ -13849,8 +13938,8 @@
           <a:p>
             <a:r>
               <a:rPr lang="en-US" dirty="0"/>
-              <a:t>Idle quantification from the instrumented baseline: 205 ms/step total idle - ~40 ms preprocessing gap at step start, plus sync stalls and launch gaps.
-Schematic is illustrative; proportions follow the measured trace (preprocess ~40 ms of a 807 ms step at baseline, fully hidden after.</a:t>
+              <a:t>All three sync points are CPU work serialized inside forward: data parsing at the top, ViT rotary/positional embedding, and MRoPE position ids between ViT and decoder.
+Stall sizes from the instrumented baseline; the timeline is a schematic, proportions follow the trace.</a:t>
             </a:r>
             <a:endParaRPr lang="en-US" dirty="0"/>
           </a:p>
@@ -13938,8 +14027,8 @@
           <a:p>
             <a:r>
               <a:rPr lang="en-US" dirty="0"/>
-              <a:t>Baseline: qwenpi_baseline_nvtx train_step_33; optimized: milestone1 train_step_48. Launch-window attribution both sides.
-[IMPORTANT] This page motivates graphs with the customer's own trace numbers; the next page is the design and the 4-vs-1 answer.</a:t>
+              <a:t>Idle quantification from the instrumented baseline: 205 ms/step total idle - ~40 ms preprocessing gap at step start, plus sync stalls and launch gaps.
+Schematic is illustrative; proportions follow the measured trace (preprocess ~40 ms of a 807 ms step at baseline, fully hidden after.</a:t>
             </a:r>
             <a:endParaRPr lang="en-US" dirty="0"/>
           </a:p>
@@ -14519,6 +14608,910 @@
                 <a:ea typeface="NVIDIA Sans" pitchFamily="34" charset="-122"/>
                 <a:cs typeface="NVIDIA Sans" pitchFamily="34" charset="-120"/>
               </a:rPr>
+              <a:t>Why CUDA Graphs: Launch-Bound Forward</a:t>
+            </a:r>
+            <a:endParaRPr lang="en-US" sz="3000" dirty="0"/>
+          </a:p>
+        </p:txBody>
+      </p:sp>
+      <p:sp>
+        <p:nvSpPr>
+          <p:cNvPr id="3" name="Text 1"/>
+          <p:cNvSpPr/>
+          <p:nvPr/>
+        </p:nvSpPr>
+        <p:spPr>
+          <a:xfrm>
+            <a:off x="457200" y="804672"/>
+            <a:ext cx="8229600" cy="329184"/>
+          </a:xfrm>
+          <a:prstGeom prst="rect">
+            <a:avLst/>
+          </a:prstGeom>
+          <a:noFill/>
+          <a:ln/>
+        </p:spPr>
+        <p:txBody>
+          <a:bodyPr wrap="square" lIns="0" tIns="0" rIns="0" bIns="0" rtlCol="0" anchor="ctr"/>
+          <a:lstStyle/>
+          <a:p>
+            <a:pPr indent="0" marL="0">
+              <a:buNone/>
+            </a:pPr>
+            <a:r>
+              <a:rPr lang="en-US" sz="1500" dirty="0">
+                <a:solidFill>
+                  <a:srgbClr val="76B900"/>
+                </a:solidFill>
+                <a:latin typeface="NVIDIA Sans" pitchFamily="34" charset="0"/>
+                <a:ea typeface="NVIDIA Sans" pitchFamily="34" charset="-122"/>
+                <a:cs typeface="NVIDIA Sans" pitchFamily="34" charset="-120"/>
+              </a:rPr>
+              <a:t>Anatomy of the Qwen3.5 forward — same math, very different wall clock</a:t>
+            </a:r>
+            <a:endParaRPr lang="en-US" sz="1500" dirty="0"/>
+          </a:p>
+        </p:txBody>
+      </p:sp>
+      <p:sp>
+        <p:nvSpPr>
+          <p:cNvPr id="4" name="Text 2"/>
+          <p:cNvSpPr/>
+          <p:nvPr/>
+        </p:nvSpPr>
+        <p:spPr>
+          <a:xfrm>
+            <a:off x="457200" y="1399032"/>
+            <a:ext cx="1417320" cy="384048"/>
+          </a:xfrm>
+          <a:prstGeom prst="rect">
+            <a:avLst/>
+          </a:prstGeom>
+          <a:noFill/>
+          <a:ln/>
+        </p:spPr>
+        <p:txBody>
+          <a:bodyPr wrap="square" lIns="0" tIns="0" rIns="0" bIns="0" rtlCol="0" anchor="ctr"/>
+          <a:lstStyle/>
+          <a:p>
+            <a:pPr indent="0" marL="0">
+              <a:buNone/>
+            </a:pPr>
+            <a:r>
+              <a:rPr lang="en-US" sz="1100" b="1" dirty="0">
+                <a:solidFill>
+                  <a:srgbClr val="000000"/>
+                </a:solidFill>
+                <a:latin typeface="NVIDIA Sans" pitchFamily="34" charset="0"/>
+                <a:ea typeface="NVIDIA Sans" pitchFamily="34" charset="-122"/>
+                <a:cs typeface="NVIDIA Sans" pitchFamily="34" charset="-120"/>
+              </a:rPr>
+              <a:t>Baseline</a:t>
+            </a:r>
+            <a:endParaRPr lang="en-US" sz="1100" dirty="0"/>
+          </a:p>
+          <a:p>
+            <a:pPr indent="0" marL="0">
+              <a:buNone/>
+            </a:pPr>
+            <a:r>
+              <a:rPr lang="en-US" sz="1100" b="1" dirty="0">
+                <a:solidFill>
+                  <a:srgbClr val="000000"/>
+                </a:solidFill>
+                <a:latin typeface="NVIDIA Sans" pitchFamily="34" charset="0"/>
+                <a:ea typeface="NVIDIA Sans" pitchFamily="34" charset="-122"/>
+                <a:cs typeface="NVIDIA Sans" pitchFamily="34" charset="-120"/>
+              </a:rPr>
+              <a:t>(eager)</a:t>
+            </a:r>
+            <a:endParaRPr lang="en-US" sz="1100" dirty="0"/>
+          </a:p>
+        </p:txBody>
+      </p:sp>
+      <p:sp>
+        <p:nvSpPr>
+          <p:cNvPr id="5" name="Shape 3"/>
+          <p:cNvSpPr/>
+          <p:nvPr/>
+        </p:nvSpPr>
+        <p:spPr>
+          <a:xfrm>
+            <a:off x="1920240" y="1417320"/>
+            <a:ext cx="2131541" cy="384048"/>
+          </a:xfrm>
+          <a:prstGeom prst="rect">
+            <a:avLst/>
+          </a:prstGeom>
+          <a:solidFill>
+            <a:srgbClr val="76B900"/>
+          </a:solidFill>
+          <a:ln/>
+        </p:spPr>
+      </p:sp>
+      <p:sp>
+        <p:nvSpPr>
+          <p:cNvPr id="6" name="Text 4"/>
+          <p:cNvSpPr/>
+          <p:nvPr/>
+        </p:nvSpPr>
+        <p:spPr>
+          <a:xfrm>
+            <a:off x="1920240" y="1417320"/>
+            <a:ext cx="2131541" cy="384048"/>
+          </a:xfrm>
+          <a:prstGeom prst="rect">
+            <a:avLst/>
+          </a:prstGeom>
+          <a:noFill/>
+          <a:ln/>
+        </p:spPr>
+        <p:txBody>
+          <a:bodyPr wrap="square" lIns="0" tIns="0" rIns="0" bIns="0" rtlCol="0" anchor="ctr"/>
+          <a:lstStyle/>
+          <a:p>
+            <a:pPr algn="ctr" indent="0" marL="0">
+              <a:buNone/>
+            </a:pPr>
+            <a:r>
+              <a:rPr lang="en-US" sz="1000" b="1" dirty="0">
+                <a:solidFill>
+                  <a:srgbClr val="FFFFFF"/>
+                </a:solidFill>
+                <a:latin typeface="NVIDIA Sans" pitchFamily="34" charset="0"/>
+                <a:ea typeface="NVIDIA Sans" pitchFamily="34" charset="-122"/>
+                <a:cs typeface="NVIDIA Sans" pitchFamily="34" charset="-120"/>
+              </a:rPr>
+              <a:t>GPU busy 50 ms</a:t>
+            </a:r>
+            <a:endParaRPr lang="en-US" sz="1000" dirty="0"/>
+          </a:p>
+        </p:txBody>
+      </p:sp>
+      <p:sp>
+        <p:nvSpPr>
+          <p:cNvPr id="7" name="Shape 5"/>
+          <p:cNvSpPr/>
+          <p:nvPr/>
+        </p:nvSpPr>
+        <p:spPr>
+          <a:xfrm>
+            <a:off x="4051781" y="1417320"/>
+            <a:ext cx="4177819" cy="384048"/>
+          </a:xfrm>
+          <a:prstGeom prst="rect">
+            <a:avLst/>
+          </a:prstGeom>
+          <a:solidFill>
+            <a:srgbClr val="890C58"/>
+          </a:solidFill>
+          <a:ln/>
+        </p:spPr>
+      </p:sp>
+      <p:sp>
+        <p:nvSpPr>
+          <p:cNvPr id="8" name="Text 6"/>
+          <p:cNvSpPr/>
+          <p:nvPr/>
+        </p:nvSpPr>
+        <p:spPr>
+          <a:xfrm>
+            <a:off x="4051781" y="1417320"/>
+            <a:ext cx="4177819" cy="384048"/>
+          </a:xfrm>
+          <a:prstGeom prst="rect">
+            <a:avLst/>
+          </a:prstGeom>
+          <a:noFill/>
+          <a:ln/>
+        </p:spPr>
+        <p:txBody>
+          <a:bodyPr wrap="square" lIns="0" tIns="0" rIns="0" bIns="0" rtlCol="0" anchor="ctr"/>
+          <a:lstStyle/>
+          <a:p>
+            <a:pPr algn="ctr" indent="0" marL="0">
+              <a:buNone/>
+            </a:pPr>
+            <a:r>
+              <a:rPr lang="en-US" sz="1000" b="1" dirty="0">
+                <a:solidFill>
+                  <a:srgbClr val="FFFFFF"/>
+                </a:solidFill>
+                <a:latin typeface="NVIDIA Sans" pitchFamily="34" charset="0"/>
+                <a:ea typeface="NVIDIA Sans" pitchFamily="34" charset="-122"/>
+                <a:cs typeface="NVIDIA Sans" pitchFamily="34" charset="-120"/>
+              </a:rPr>
+              <a:t>waiting for launches 98 ms</a:t>
+            </a:r>
+            <a:endParaRPr lang="en-US" sz="1000" dirty="0"/>
+          </a:p>
+        </p:txBody>
+      </p:sp>
+      <p:sp>
+        <p:nvSpPr>
+          <p:cNvPr id="9" name="Text 7"/>
+          <p:cNvSpPr/>
+          <p:nvPr/>
+        </p:nvSpPr>
+        <p:spPr>
+          <a:xfrm>
+            <a:off x="8302752" y="1417320"/>
+            <a:ext cx="822960" cy="384048"/>
+          </a:xfrm>
+          <a:prstGeom prst="rect">
+            <a:avLst/>
+          </a:prstGeom>
+          <a:noFill/>
+          <a:ln/>
+        </p:spPr>
+        <p:txBody>
+          <a:bodyPr wrap="square" lIns="0" tIns="0" rIns="0" bIns="0" rtlCol="0" anchor="ctr"/>
+          <a:lstStyle/>
+          <a:p>
+            <a:pPr indent="0" marL="0">
+              <a:buNone/>
+            </a:pPr>
+            <a:r>
+              <a:rPr lang="en-US" sz="1200" b="1" dirty="0">
+                <a:solidFill>
+                  <a:srgbClr val="000000"/>
+                </a:solidFill>
+                <a:latin typeface="NVIDIA Sans" pitchFamily="34" charset="0"/>
+                <a:ea typeface="NVIDIA Sans" pitchFamily="34" charset="-122"/>
+                <a:cs typeface="NVIDIA Sans" pitchFamily="34" charset="-120"/>
+              </a:rPr>
+              <a:t>148 ms</a:t>
+            </a:r>
+            <a:endParaRPr lang="en-US" sz="1200" dirty="0"/>
+          </a:p>
+        </p:txBody>
+      </p:sp>
+      <p:sp>
+        <p:nvSpPr>
+          <p:cNvPr id="10" name="Text 8"/>
+          <p:cNvSpPr/>
+          <p:nvPr/>
+        </p:nvSpPr>
+        <p:spPr>
+          <a:xfrm>
+            <a:off x="1920240" y="1819656"/>
+            <a:ext cx="6400800" cy="201168"/>
+          </a:xfrm>
+          <a:prstGeom prst="rect">
+            <a:avLst/>
+          </a:prstGeom>
+          <a:noFill/>
+          <a:ln/>
+        </p:spPr>
+        <p:txBody>
+          <a:bodyPr wrap="square" lIns="0" tIns="0" rIns="0" bIns="0" rtlCol="0" anchor="ctr"/>
+          <a:lstStyle/>
+          <a:p>
+            <a:pPr indent="0" marL="0">
+              <a:buNone/>
+            </a:pPr>
+            <a:r>
+              <a:rPr lang="en-US" sz="950" i="1" dirty="0">
+                <a:solidFill>
+                  <a:srgbClr val="5E5E5E"/>
+                </a:solidFill>
+                <a:latin typeface="NVIDIA Sans" pitchFamily="34" charset="0"/>
+                <a:ea typeface="NVIDIA Sans" pitchFamily="34" charset="-122"/>
+                <a:cs typeface="NVIDIA Sans" pitchFamily="34" charset="-120"/>
+              </a:rPr>
+              <a:t>3,929 kernel launches · 19.1 ms of cudaLaunchKernel CPU time · occupancy 34%</a:t>
+            </a:r>
+            <a:endParaRPr lang="en-US" sz="950" dirty="0"/>
+          </a:p>
+        </p:txBody>
+      </p:sp>
+      <p:sp>
+        <p:nvSpPr>
+          <p:cNvPr id="11" name="Text 9"/>
+          <p:cNvSpPr/>
+          <p:nvPr/>
+        </p:nvSpPr>
+        <p:spPr>
+          <a:xfrm>
+            <a:off x="457200" y="2267712"/>
+            <a:ext cx="1417320" cy="384048"/>
+          </a:xfrm>
+          <a:prstGeom prst="rect">
+            <a:avLst/>
+          </a:prstGeom>
+          <a:noFill/>
+          <a:ln/>
+        </p:spPr>
+        <p:txBody>
+          <a:bodyPr wrap="square" lIns="0" tIns="0" rIns="0" bIns="0" rtlCol="0" anchor="ctr"/>
+          <a:lstStyle/>
+          <a:p>
+            <a:pPr indent="0" marL="0">
+              <a:buNone/>
+            </a:pPr>
+            <a:r>
+              <a:rPr lang="en-US" sz="1100" b="1" dirty="0">
+                <a:solidFill>
+                  <a:srgbClr val="000000"/>
+                </a:solidFill>
+                <a:latin typeface="NVIDIA Sans" pitchFamily="34" charset="0"/>
+                <a:ea typeface="NVIDIA Sans" pitchFamily="34" charset="-122"/>
+                <a:cs typeface="NVIDIA Sans" pitchFamily="34" charset="-120"/>
+              </a:rPr>
+              <a:t>Optimized</a:t>
+            </a:r>
+            <a:endParaRPr lang="en-US" sz="1100" dirty="0"/>
+          </a:p>
+          <a:p>
+            <a:pPr indent="0" marL="0">
+              <a:buNone/>
+            </a:pPr>
+            <a:r>
+              <a:rPr lang="en-US" sz="1100" b="1" dirty="0">
+                <a:solidFill>
+                  <a:srgbClr val="000000"/>
+                </a:solidFill>
+                <a:latin typeface="NVIDIA Sans" pitchFamily="34" charset="0"/>
+                <a:ea typeface="NVIDIA Sans" pitchFamily="34" charset="-122"/>
+                <a:cs typeface="NVIDIA Sans" pitchFamily="34" charset="-120"/>
+              </a:rPr>
+              <a:t>(CUDA Graphs)</a:t>
+            </a:r>
+            <a:endParaRPr lang="en-US" sz="1100" dirty="0"/>
+          </a:p>
+        </p:txBody>
+      </p:sp>
+      <p:sp>
+        <p:nvSpPr>
+          <p:cNvPr id="12" name="Shape 10"/>
+          <p:cNvSpPr/>
+          <p:nvPr/>
+        </p:nvSpPr>
+        <p:spPr>
+          <a:xfrm>
+            <a:off x="1920240" y="2286000"/>
+            <a:ext cx="1577340" cy="384048"/>
+          </a:xfrm>
+          <a:prstGeom prst="rect">
+            <a:avLst/>
+          </a:prstGeom>
+          <a:solidFill>
+            <a:srgbClr val="76B900"/>
+          </a:solidFill>
+          <a:ln/>
+        </p:spPr>
+      </p:sp>
+      <p:sp>
+        <p:nvSpPr>
+          <p:cNvPr id="13" name="Text 11"/>
+          <p:cNvSpPr/>
+          <p:nvPr/>
+        </p:nvSpPr>
+        <p:spPr>
+          <a:xfrm>
+            <a:off x="1920240" y="2286000"/>
+            <a:ext cx="1577340" cy="384048"/>
+          </a:xfrm>
+          <a:prstGeom prst="rect">
+            <a:avLst/>
+          </a:prstGeom>
+          <a:noFill/>
+          <a:ln/>
+        </p:spPr>
+        <p:txBody>
+          <a:bodyPr wrap="square" lIns="0" tIns="0" rIns="0" bIns="0" rtlCol="0" anchor="ctr"/>
+          <a:lstStyle/>
+          <a:p>
+            <a:pPr algn="ctr" indent="0" marL="0">
+              <a:buNone/>
+            </a:pPr>
+            <a:r>
+              <a:rPr lang="en-US" sz="1000" b="1" dirty="0">
+                <a:solidFill>
+                  <a:srgbClr val="FFFFFF"/>
+                </a:solidFill>
+                <a:latin typeface="NVIDIA Sans" pitchFamily="34" charset="0"/>
+                <a:ea typeface="NVIDIA Sans" pitchFamily="34" charset="-122"/>
+                <a:cs typeface="NVIDIA Sans" pitchFamily="34" charset="-120"/>
+              </a:rPr>
+              <a:t>GPU busy 37 ms</a:t>
+            </a:r>
+            <a:endParaRPr lang="en-US" sz="1000" dirty="0"/>
+          </a:p>
+        </p:txBody>
+      </p:sp>
+      <p:sp>
+        <p:nvSpPr>
+          <p:cNvPr id="14" name="Shape 12"/>
+          <p:cNvSpPr/>
+          <p:nvPr/>
+        </p:nvSpPr>
+        <p:spPr>
+          <a:xfrm>
+            <a:off x="3497580" y="2286000"/>
+            <a:ext cx="1193663" cy="384048"/>
+          </a:xfrm>
+          <a:prstGeom prst="rect">
+            <a:avLst/>
+          </a:prstGeom>
+          <a:solidFill>
+            <a:srgbClr val="890C58"/>
+          </a:solidFill>
+          <a:ln/>
+        </p:spPr>
+      </p:sp>
+      <p:sp>
+        <p:nvSpPr>
+          <p:cNvPr id="15" name="Text 13"/>
+          <p:cNvSpPr/>
+          <p:nvPr/>
+        </p:nvSpPr>
+        <p:spPr>
+          <a:xfrm>
+            <a:off x="3497580" y="2286000"/>
+            <a:ext cx="1193663" cy="384048"/>
+          </a:xfrm>
+          <a:prstGeom prst="rect">
+            <a:avLst/>
+          </a:prstGeom>
+          <a:noFill/>
+          <a:ln/>
+        </p:spPr>
+        <p:txBody>
+          <a:bodyPr wrap="square" lIns="0" tIns="0" rIns="0" bIns="0" rtlCol="0" anchor="ctr"/>
+          <a:lstStyle/>
+          <a:p>
+            <a:pPr algn="ctr" indent="0" marL="0">
+              <a:buNone/>
+            </a:pPr>
+            <a:r>
+              <a:rPr lang="en-US" sz="1000" b="1" dirty="0">
+                <a:solidFill>
+                  <a:srgbClr val="FFFFFF"/>
+                </a:solidFill>
+                <a:latin typeface="NVIDIA Sans" pitchFamily="34" charset="0"/>
+                <a:ea typeface="NVIDIA Sans" pitchFamily="34" charset="-122"/>
+                <a:cs typeface="NVIDIA Sans" pitchFamily="34" charset="-120"/>
+              </a:rPr>
+              <a:t>waiting for launches 28 ms</a:t>
+            </a:r>
+            <a:endParaRPr lang="en-US" sz="1000" dirty="0"/>
+          </a:p>
+        </p:txBody>
+      </p:sp>
+      <p:sp>
+        <p:nvSpPr>
+          <p:cNvPr id="16" name="Text 14"/>
+          <p:cNvSpPr/>
+          <p:nvPr/>
+        </p:nvSpPr>
+        <p:spPr>
+          <a:xfrm>
+            <a:off x="4764395" y="2286000"/>
+            <a:ext cx="822960" cy="384048"/>
+          </a:xfrm>
+          <a:prstGeom prst="rect">
+            <a:avLst/>
+          </a:prstGeom>
+          <a:noFill/>
+          <a:ln/>
+        </p:spPr>
+        <p:txBody>
+          <a:bodyPr wrap="square" lIns="0" tIns="0" rIns="0" bIns="0" rtlCol="0" anchor="ctr"/>
+          <a:lstStyle/>
+          <a:p>
+            <a:pPr indent="0" marL="0">
+              <a:buNone/>
+            </a:pPr>
+            <a:r>
+              <a:rPr lang="en-US" sz="1200" b="1" dirty="0">
+                <a:solidFill>
+                  <a:srgbClr val="000000"/>
+                </a:solidFill>
+                <a:latin typeface="NVIDIA Sans" pitchFamily="34" charset="0"/>
+                <a:ea typeface="NVIDIA Sans" pitchFamily="34" charset="-122"/>
+                <a:cs typeface="NVIDIA Sans" pitchFamily="34" charset="-120"/>
+              </a:rPr>
+              <a:t>65 ms</a:t>
+            </a:r>
+            <a:endParaRPr lang="en-US" sz="1200" dirty="0"/>
+          </a:p>
+        </p:txBody>
+      </p:sp>
+      <p:sp>
+        <p:nvSpPr>
+          <p:cNvPr id="17" name="Text 15"/>
+          <p:cNvSpPr/>
+          <p:nvPr/>
+        </p:nvSpPr>
+        <p:spPr>
+          <a:xfrm>
+            <a:off x="1920240" y="2688336"/>
+            <a:ext cx="6400800" cy="201168"/>
+          </a:xfrm>
+          <a:prstGeom prst="rect">
+            <a:avLst/>
+          </a:prstGeom>
+          <a:noFill/>
+          <a:ln/>
+        </p:spPr>
+        <p:txBody>
+          <a:bodyPr wrap="square" lIns="0" tIns="0" rIns="0" bIns="0" rtlCol="0" anchor="ctr"/>
+          <a:lstStyle/>
+          <a:p>
+            <a:pPr indent="0" marL="0">
+              <a:buNone/>
+            </a:pPr>
+            <a:r>
+              <a:rPr lang="en-US" sz="950" i="1" dirty="0">
+                <a:solidFill>
+                  <a:srgbClr val="5E5E5E"/>
+                </a:solidFill>
+                <a:latin typeface="NVIDIA Sans" pitchFamily="34" charset="0"/>
+                <a:ea typeface="NVIDIA Sans" pitchFamily="34" charset="-122"/>
+                <a:cs typeface="NVIDIA Sans" pitchFamily="34" charset="-120"/>
+              </a:rPr>
+              <a:t>6 graph launches + 736 eager · 9.4 ms launch CPU · occupancy 57%</a:t>
+            </a:r>
+            <a:endParaRPr lang="en-US" sz="950" dirty="0"/>
+          </a:p>
+        </p:txBody>
+      </p:sp>
+      <p:sp>
+        <p:nvSpPr>
+          <p:cNvPr id="18" name="Text 16"/>
+          <p:cNvSpPr/>
+          <p:nvPr/>
+        </p:nvSpPr>
+        <p:spPr>
+          <a:xfrm>
+            <a:off x="1920240" y="2907792"/>
+            <a:ext cx="6400800" cy="365760"/>
+          </a:xfrm>
+          <a:prstGeom prst="rect">
+            <a:avLst/>
+          </a:prstGeom>
+          <a:noFill/>
+          <a:ln/>
+        </p:spPr>
+        <p:txBody>
+          <a:bodyPr wrap="square" lIns="0" tIns="0" rIns="0" bIns="0" rtlCol="0" anchor="ctr"/>
+          <a:lstStyle/>
+          <a:p>
+            <a:pPr indent="0" marL="0">
+              <a:buNone/>
+            </a:pPr>
+            <a:r>
+              <a:rPr lang="en-US" sz="2400" b="1" dirty="0">
+                <a:solidFill>
+                  <a:srgbClr val="76B900"/>
+                </a:solidFill>
+                <a:latin typeface="NVIDIA Sans" pitchFamily="34" charset="0"/>
+                <a:ea typeface="NVIDIA Sans" pitchFamily="34" charset="-122"/>
+                <a:cs typeface="NVIDIA Sans" pitchFamily="34" charset="-120"/>
+              </a:rPr>
+              <a:t>2.3× </a:t>
+            </a:r>
+            <a:pPr indent="0" marL="0">
+              <a:buNone/>
+            </a:pPr>
+            <a:r>
+              <a:rPr lang="en-US" sz="1300" b="1" dirty="0">
+                <a:solidFill>
+                  <a:srgbClr val="000000"/>
+                </a:solidFill>
+                <a:latin typeface="NVIDIA Sans" pitchFamily="34" charset="0"/>
+                <a:ea typeface="NVIDIA Sans" pitchFamily="34" charset="-122"/>
+                <a:cs typeface="NVIDIA Sans" pitchFamily="34" charset="-120"/>
+              </a:rPr>
+              <a:t>faster forward wall clock — with 81% fewer launches</a:t>
+            </a:r>
+            <a:endParaRPr lang="en-US" sz="2400" dirty="0"/>
+          </a:p>
+        </p:txBody>
+      </p:sp>
+      <p:sp>
+        <p:nvSpPr>
+          <p:cNvPr id="19" name="Text 17"/>
+          <p:cNvSpPr/>
+          <p:nvPr/>
+        </p:nvSpPr>
+        <p:spPr>
+          <a:xfrm>
+            <a:off x="457200" y="3346704"/>
+            <a:ext cx="8229600" cy="822960"/>
+          </a:xfrm>
+          <a:prstGeom prst="rect">
+            <a:avLst/>
+          </a:prstGeom>
+          <a:noFill/>
+          <a:ln/>
+        </p:spPr>
+        <p:txBody>
+          <a:bodyPr wrap="square" lIns="0" tIns="0" rIns="0" bIns="0" rtlCol="0" anchor="t"/>
+          <a:lstStyle/>
+          <a:p>
+            <a:pPr marL="342900" indent="-342900">
+              <a:buSzPct val="100000"/>
+              <a:buChar char="•"/>
+            </a:pPr>
+            <a:r>
+              <a:rPr lang="en-US" sz="1100" dirty="0">
+                <a:solidFill>
+                  <a:srgbClr val="000000"/>
+                </a:solidFill>
+                <a:latin typeface="NVIDIA Sans" pitchFamily="34" charset="0"/>
+                <a:ea typeface="NVIDIA Sans" pitchFamily="34" charset="-122"/>
+                <a:cs typeface="NVIDIA Sans" pitchFamily="34" charset="-120"/>
+              </a:rPr>
+              <a:t>An eager op costs 30–60 µs of Python dispatch + launch; the median kernel runs 8 µs — the GPU finishes before the CPU can feed the next one</a:t>
+            </a:r>
+            <a:endParaRPr lang="en-US" sz="1100" dirty="0"/>
+          </a:p>
+          <a:p>
+            <a:pPr marL="342900" indent="-342900">
+              <a:buSzPct val="100000"/>
+              <a:buChar char="•"/>
+            </a:pPr>
+            <a:r>
+              <a:rPr lang="en-US" sz="1100" dirty="0">
+                <a:solidFill>
+                  <a:srgbClr val="000000"/>
+                </a:solidFill>
+                <a:latin typeface="NVIDIA Sans" pitchFamily="34" charset="0"/>
+                <a:ea typeface="NVIDIA Sans" pitchFamily="34" charset="-122"/>
+                <a:cs typeface="NVIDIA Sans" pitchFamily="34" charset="-120"/>
+              </a:rPr>
+              <a:t>Backward suffers far less (C++ autograd engine, occupancy 70%) — forward is where launch overhead bites</a:t>
+            </a:r>
+            <a:endParaRPr lang="en-US" sz="1100" dirty="0"/>
+          </a:p>
+          <a:p>
+            <a:pPr marL="342900" indent="-342900">
+              <a:buSzPct val="100000"/>
+              <a:buChar char="•"/>
+            </a:pPr>
+            <a:r>
+              <a:rPr lang="en-US" sz="1100" dirty="0">
+                <a:solidFill>
+                  <a:srgbClr val="000000"/>
+                </a:solidFill>
+                <a:latin typeface="NVIDIA Sans" pitchFamily="34" charset="0"/>
+                <a:ea typeface="NVIDIA Sans" pitchFamily="34" charset="-122"/>
+                <a:cs typeface="NVIDIA Sans" pitchFamily="34" charset="-120"/>
+              </a:rPr>
+              <a:t>A CUDA Graph replays an entire 8-layer group as ONE cudaGraphLaunch — per-op dispatch leaves the critical path</a:t>
+            </a:r>
+            <a:endParaRPr lang="en-US" sz="1100" dirty="0"/>
+          </a:p>
+        </p:txBody>
+      </p:sp>
+      <p:sp>
+        <p:nvSpPr>
+          <p:cNvPr id="20" name="Text 18"/>
+          <p:cNvSpPr/>
+          <p:nvPr/>
+        </p:nvSpPr>
+        <p:spPr>
+          <a:xfrm>
+            <a:off x="457200" y="4206240"/>
+            <a:ext cx="8229600" cy="201168"/>
+          </a:xfrm>
+          <a:prstGeom prst="rect">
+            <a:avLst/>
+          </a:prstGeom>
+          <a:noFill/>
+          <a:ln/>
+        </p:spPr>
+        <p:txBody>
+          <a:bodyPr wrap="square" lIns="0" tIns="0" rIns="0" bIns="0" rtlCol="0" anchor="ctr"/>
+          <a:lstStyle/>
+          <a:p>
+            <a:pPr indent="0" marL="0">
+              <a:buNone/>
+            </a:pPr>
+            <a:r>
+              <a:rPr lang="en-US" sz="850" i="1" dirty="0">
+                <a:solidFill>
+                  <a:srgbClr val="8C8C8C"/>
+                </a:solidFill>
+                <a:latin typeface="NVIDIA Sans" pitchFamily="34" charset="0"/>
+                <a:ea typeface="NVIDIA Sans" pitchFamily="34" charset="-122"/>
+                <a:cs typeface="NVIDIA Sans" pitchFamily="34" charset="-120"/>
+              </a:rPr>
+              <a:t>Busy also shrinks 50 → 37 ms (mixed attention + fusion); the split isolates the launch effect. Windows: baseline Qwen3.5 fwd vs merged-main VLM fwd, same launch-window accounting.</a:t>
+            </a:r>
+            <a:endParaRPr lang="en-US" sz="850" dirty="0"/>
+          </a:p>
+        </p:txBody>
+      </p:sp>
+      <p:sp>
+        <p:nvSpPr>
+          <p:cNvPr id="21" name="Text 19"/>
+          <p:cNvSpPr/>
+          <p:nvPr/>
+        </p:nvSpPr>
+        <p:spPr>
+          <a:xfrm>
+            <a:off x="457200" y="4617720"/>
+            <a:ext cx="4572000" cy="320040"/>
+          </a:xfrm>
+          <a:prstGeom prst="rect">
+            <a:avLst/>
+          </a:prstGeom>
+          <a:noFill/>
+          <a:ln/>
+        </p:spPr>
+        <p:txBody>
+          <a:bodyPr wrap="square" lIns="0" tIns="0" rIns="0" bIns="0" rtlCol="0" anchor="ctr"/>
+          <a:lstStyle/>
+          <a:p>
+            <a:pPr algn="l" indent="0" marL="0">
+              <a:buNone/>
+            </a:pPr>
+            <a:r>
+              <a:rPr lang="en-US" sz="1000" dirty="0">
+                <a:solidFill>
+                  <a:srgbClr val="5E5E5E"/>
+                </a:solidFill>
+                <a:latin typeface="NVIDIA Sans" pitchFamily="34" charset="0"/>
+                <a:ea typeface="NVIDIA Sans" pitchFamily="34" charset="-122"/>
+                <a:cs typeface="NVIDIA Sans" pitchFamily="34" charset="-120"/>
+              </a:rPr>
+              <a:t>QwenPI Training Optimization</a:t>
+            </a:r>
+            <a:endParaRPr lang="en-US" sz="1000" dirty="0"/>
+          </a:p>
+        </p:txBody>
+      </p:sp>
+      <p:sp>
+        <p:nvSpPr>
+          <p:cNvPr id="22" name="Text 20"/>
+          <p:cNvSpPr/>
+          <p:nvPr/>
+        </p:nvSpPr>
+        <p:spPr>
+          <a:xfrm>
+            <a:off x="7360920" y="4617720"/>
+            <a:ext cx="320040" cy="320040"/>
+          </a:xfrm>
+          <a:prstGeom prst="rect">
+            <a:avLst/>
+          </a:prstGeom>
+          <a:noFill/>
+          <a:ln/>
+        </p:spPr>
+        <p:txBody>
+          <a:bodyPr wrap="square" lIns="0" tIns="0" rIns="0" bIns="0" rtlCol="0" anchor="ctr"/>
+          <a:lstStyle/>
+          <a:p>
+            <a:pPr algn="r" indent="0" marL="0">
+              <a:buNone/>
+            </a:pPr>
+            <a:r>
+              <a:rPr lang="en-US" sz="1000" dirty="0">
+                <a:solidFill>
+                  <a:srgbClr val="5E5E5E"/>
+                </a:solidFill>
+                <a:latin typeface="NVIDIA Sans" pitchFamily="34" charset="0"/>
+                <a:ea typeface="NVIDIA Sans" pitchFamily="34" charset="-122"/>
+                <a:cs typeface="NVIDIA Sans" pitchFamily="34" charset="-120"/>
+              </a:rPr>
+              <a:t>10</a:t>
+            </a:r>
+            <a:endParaRPr lang="en-US" sz="1000" dirty="0"/>
+          </a:p>
+        </p:txBody>
+      </p:sp>
+      <p:sp>
+        <p:nvSpPr>
+          <p:cNvPr id="23" name="Shape 21"/>
+          <p:cNvSpPr/>
+          <p:nvPr/>
+        </p:nvSpPr>
+        <p:spPr>
+          <a:xfrm>
+            <a:off x="7726680" y="4617720"/>
+            <a:ext cx="36576" cy="320040"/>
+          </a:xfrm>
+          <a:prstGeom prst="rect">
+            <a:avLst/>
+          </a:prstGeom>
+          <a:solidFill>
+            <a:srgbClr val="76B900"/>
+          </a:solidFill>
+          <a:ln/>
+        </p:spPr>
+      </p:sp>
+      <p:pic>
+        <p:nvPicPr>
+          <p:cNvPr id="24" name="Image 0" descr="/app/logos/nvidia-logo-blk-sm.png">    </p:cNvPr>
+          <p:cNvPicPr>
+            <a:picLocks noChangeAspect="1"/>
+          </p:cNvPicPr>
+          <p:nvPr/>
+        </p:nvPicPr>
+        <p:blipFill>
+          <a:blip r:embed="rId1"/>
+          <a:stretch>
+            <a:fillRect/>
+          </a:stretch>
+        </p:blipFill>
+        <p:spPr>
+          <a:xfrm>
+            <a:off x="7863840" y="4604004"/>
+            <a:ext cx="1005840" cy="347472"/>
+          </a:xfrm>
+          <a:prstGeom prst="rect">
+            <a:avLst/>
+          </a:prstGeom>
+        </p:spPr>
+      </p:pic>
+    </p:spTree>
+  </p:cSld>
+  <p:clrMapOvr>
+    <a:masterClrMapping/>
+  </p:clrMapOvr>
+</p:sld>
+</file>
+
+<file path=ppt/slides/slide11.xml><?xml version="1.0" encoding="utf-8"?>
+<p:sld xmlns:a="http://schemas.openxmlformats.org/drawingml/2006/main" xmlns:r="http://schemas.openxmlformats.org/officeDocument/2006/relationships" xmlns:p="http://schemas.openxmlformats.org/presentationml/2006/main">
+  <p:cSld name="Slide 11">
+    <p:bg>
+      <p:bgPr>
+        <a:solidFill>
+          <a:srgbClr val="FFFFFF"/>
+        </a:solidFill>
+      </p:bgPr>
+    </p:bg>
+    <p:spTree>
+      <p:nvGrpSpPr>
+        <p:cNvPr id="1" name=""/>
+        <p:cNvGrpSpPr/>
+        <p:nvPr/>
+      </p:nvGrpSpPr>
+      <p:grpSpPr>
+        <a:xfrm>
+          <a:off x="0" y="0"/>
+          <a:ext cx="0" cy="0"/>
+          <a:chOff x="0" y="0"/>
+          <a:chExt cx="0" cy="0"/>
+        </a:xfrm>
+      </p:grpSpPr>
+      <p:sp>
+        <p:nvSpPr>
+          <p:cNvPr id="2" name="Text 0"/>
+          <p:cNvSpPr/>
+          <p:nvPr/>
+        </p:nvSpPr>
+        <p:spPr>
+          <a:xfrm>
+            <a:off x="457200" y="256032"/>
+            <a:ext cx="8229600" cy="548640"/>
+          </a:xfrm>
+          <a:prstGeom prst="rect">
+            <a:avLst/>
+          </a:prstGeom>
+          <a:noFill/>
+          <a:ln/>
+        </p:spPr>
+        <p:txBody>
+          <a:bodyPr wrap="square" lIns="0" tIns="0" rIns="0" bIns="0" rtlCol="0" anchor="ctr"/>
+          <a:lstStyle/>
+          <a:p>
+            <a:pPr indent="0" marL="0">
+              <a:buNone/>
+            </a:pPr>
+            <a:r>
+              <a:rPr lang="en-US" sz="3000" b="1" dirty="0">
+                <a:solidFill>
+                  <a:srgbClr val="000000"/>
+                </a:solidFill>
+                <a:latin typeface="NVIDIA Sans" pitchFamily="34" charset="0"/>
+                <a:ea typeface="NVIDIA Sans" pitchFamily="34" charset="-122"/>
+                <a:cs typeface="NVIDIA Sans" pitchFamily="34" charset="-120"/>
+              </a:rPr>
               <a:t>CUDA Graphs — and Why Four, Not One</a:t>
             </a:r>
             <a:endParaRPr lang="en-US" sz="3000" dirty="0"/>
@@ -15718,7 +16711,7 @@
                 <a:ea typeface="NVIDIA Sans" pitchFamily="34" charset="-122"/>
                 <a:cs typeface="NVIDIA Sans" pitchFamily="34" charset="-120"/>
               </a:rPr>
-              <a:t>10</a:t>
+              <a:t>11</a:t>
             </a:r>
             <a:endParaRPr lang="en-US" sz="1000" dirty="0"/>
           </a:p>
@@ -15776,9 +16769,9 @@
 </p:sld>
 </file>
 
-<file path=ppt/slides/slide11.xml><?xml version="1.0" encoding="utf-8"?>
+<file path=ppt/slides/slide12.xml><?xml version="1.0" encoding="utf-8"?>
 <p:sld xmlns:a="http://schemas.openxmlformats.org/drawingml/2006/main" xmlns:r="http://schemas.openxmlformats.org/officeDocument/2006/relationships" xmlns:p="http://schemas.openxmlformats.org/presentationml/2006/main">
-  <p:cSld name="Slide 11">
+  <p:cSld name="Slide 12">
     <p:bg>
       <p:bgPr>
         <a:solidFill>
@@ -18070,7 +19063,7 @@
                 <a:ea typeface="NVIDIA Sans" pitchFamily="34" charset="-122"/>
                 <a:cs typeface="NVIDIA Sans" pitchFamily="34" charset="-120"/>
               </a:rPr>
-              <a:t>11</a:t>
+              <a:t>12</a:t>
             </a:r>
             <a:endParaRPr lang="en-US" sz="1000" dirty="0"/>
           </a:p>
@@ -18128,9 +19121,9 @@
 </p:sld>
 </file>
 
-<file path=ppt/slides/slide12.xml><?xml version="1.0" encoding="utf-8"?>
+<file path=ppt/slides/slide13.xml><?xml version="1.0" encoding="utf-8"?>
 <p:sld xmlns:a="http://schemas.openxmlformats.org/drawingml/2006/main" xmlns:r="http://schemas.openxmlformats.org/officeDocument/2006/relationships" xmlns:p="http://schemas.openxmlformats.org/presentationml/2006/main">
-  <p:cSld name="Slide 12">
+  <p:cSld name="Slide 13">
     <p:bg>
       <p:bgPr>
         <a:solidFill>
@@ -19337,7 +20330,7 @@
                 <a:ea typeface="NVIDIA Sans" pitchFamily="34" charset="-122"/>
                 <a:cs typeface="NVIDIA Sans" pitchFamily="34" charset="-120"/>
               </a:rPr>
-              <a:t>12</a:t>
+              <a:t>13</a:t>
             </a:r>
             <a:endParaRPr lang="en-US" sz="1000" dirty="0"/>
           </a:p>
@@ -19395,9 +20388,9 @@
 </p:sld>
 </file>
 
-<file path=ppt/slides/slide13.xml><?xml version="1.0" encoding="utf-8"?>
+<file path=ppt/slides/slide14.xml><?xml version="1.0" encoding="utf-8"?>
 <p:sld xmlns:a="http://schemas.openxmlformats.org/drawingml/2006/main" xmlns:r="http://schemas.openxmlformats.org/officeDocument/2006/relationships" xmlns:p="http://schemas.openxmlformats.org/presentationml/2006/main">
-  <p:cSld name="Slide 13">
+  <p:cSld name="Slide 14">
     <p:bg>
       <p:bgPr>
         <a:solidFill>
@@ -22339,7 +23332,7 @@
                 <a:ea typeface="NVIDIA Sans" pitchFamily="34" charset="-122"/>
                 <a:cs typeface="NVIDIA Sans" pitchFamily="34" charset="-120"/>
               </a:rPr>
-              <a:t>13</a:t>
+              <a:t>14</a:t>
             </a:r>
             <a:endParaRPr lang="en-US" sz="1000" dirty="0"/>
           </a:p>
@@ -22400,6 +23393,1021 @@
 <file path=ppt/slides/slide2.xml><?xml version="1.0" encoding="utf-8"?>
 <p:sld xmlns:a="http://schemas.openxmlformats.org/drawingml/2006/main" xmlns:r="http://schemas.openxmlformats.org/officeDocument/2006/relationships" xmlns:p="http://schemas.openxmlformats.org/presentationml/2006/main">
   <p:cSld name="Slide 2">
+    <p:bg>
+      <p:bgPr>
+        <a:solidFill>
+          <a:srgbClr val="FFFFFF"/>
+        </a:solidFill>
+      </p:bgPr>
+    </p:bg>
+    <p:spTree>
+      <p:nvGrpSpPr>
+        <p:cNvPr id="1" name=""/>
+        <p:cNvGrpSpPr/>
+        <p:nvPr/>
+      </p:nvGrpSpPr>
+      <p:grpSpPr>
+        <a:xfrm>
+          <a:off x="0" y="0"/>
+          <a:ext cx="0" cy="0"/>
+          <a:chOff x="0" y="0"/>
+          <a:chExt cx="0" cy="0"/>
+        </a:xfrm>
+      </p:grpSpPr>
+      <p:sp>
+        <p:nvSpPr>
+          <p:cNvPr id="2" name="Text 0"/>
+          <p:cNvSpPr/>
+          <p:nvPr/>
+        </p:nvSpPr>
+        <p:spPr>
+          <a:xfrm>
+            <a:off x="457200" y="256032"/>
+            <a:ext cx="8229600" cy="548640"/>
+          </a:xfrm>
+          <a:prstGeom prst="rect">
+            <a:avLst/>
+          </a:prstGeom>
+          <a:noFill/>
+          <a:ln/>
+        </p:spPr>
+        <p:txBody>
+          <a:bodyPr wrap="square" lIns="0" tIns="0" rIns="0" bIns="0" rtlCol="0" anchor="ctr"/>
+          <a:lstStyle/>
+          <a:p>
+            <a:pPr indent="0" marL="0">
+              <a:buNone/>
+            </a:pPr>
+            <a:r>
+              <a:rPr lang="en-US" sz="3000" b="1" dirty="0">
+                <a:solidFill>
+                  <a:srgbClr val="000000"/>
+                </a:solidFill>
+                <a:latin typeface="NVIDIA Sans" pitchFamily="34" charset="0"/>
+                <a:ea typeface="NVIDIA Sans" pitchFamily="34" charset="-122"/>
+                <a:cs typeface="NVIDIA Sans" pitchFamily="34" charset="-120"/>
+              </a:rPr>
+              <a:t>Agenda</a:t>
+            </a:r>
+            <a:endParaRPr lang="en-US" sz="3000" dirty="0"/>
+          </a:p>
+        </p:txBody>
+      </p:sp>
+      <p:sp>
+        <p:nvSpPr>
+          <p:cNvPr id="3" name="Shape 1"/>
+          <p:cNvSpPr/>
+          <p:nvPr/>
+        </p:nvSpPr>
+        <p:spPr>
+          <a:xfrm>
+            <a:off x="640080" y="1271016"/>
+            <a:ext cx="365760" cy="365760"/>
+          </a:xfrm>
+          <a:prstGeom prst="ellipse">
+            <a:avLst/>
+          </a:prstGeom>
+          <a:solidFill>
+            <a:srgbClr val="76B900"/>
+          </a:solidFill>
+          <a:ln/>
+        </p:spPr>
+      </p:sp>
+      <p:sp>
+        <p:nvSpPr>
+          <p:cNvPr id="4" name="Text 2"/>
+          <p:cNvSpPr/>
+          <p:nvPr/>
+        </p:nvSpPr>
+        <p:spPr>
+          <a:xfrm>
+            <a:off x="640080" y="1271016"/>
+            <a:ext cx="365760" cy="365760"/>
+          </a:xfrm>
+          <a:prstGeom prst="rect">
+            <a:avLst/>
+          </a:prstGeom>
+          <a:noFill/>
+          <a:ln/>
+        </p:spPr>
+        <p:txBody>
+          <a:bodyPr wrap="square" lIns="0" tIns="0" rIns="0" bIns="0" rtlCol="0" anchor="ctr"/>
+          <a:lstStyle/>
+          <a:p>
+            <a:pPr algn="ctr" indent="0" marL="0">
+              <a:buNone/>
+            </a:pPr>
+            <a:r>
+              <a:rPr lang="en-US" sz="1500" b="1" dirty="0">
+                <a:solidFill>
+                  <a:srgbClr val="FFFFFF"/>
+                </a:solidFill>
+                <a:latin typeface="NVIDIA Sans" pitchFamily="34" charset="0"/>
+                <a:ea typeface="NVIDIA Sans" pitchFamily="34" charset="-122"/>
+                <a:cs typeface="NVIDIA Sans" pitchFamily="34" charset="-120"/>
+              </a:rPr>
+              <a:t>1</a:t>
+            </a:r>
+            <a:endParaRPr lang="en-US" sz="1500" dirty="0"/>
+          </a:p>
+        </p:txBody>
+      </p:sp>
+      <p:sp>
+        <p:nvSpPr>
+          <p:cNvPr id="5" name="Text 3"/>
+          <p:cNvSpPr/>
+          <p:nvPr/>
+        </p:nvSpPr>
+        <p:spPr>
+          <a:xfrm>
+            <a:off x="1234440" y="1234440"/>
+            <a:ext cx="6309360" cy="438912"/>
+          </a:xfrm>
+          <a:prstGeom prst="rect">
+            <a:avLst/>
+          </a:prstGeom>
+          <a:noFill/>
+          <a:ln/>
+        </p:spPr>
+        <p:txBody>
+          <a:bodyPr wrap="square" lIns="0" tIns="0" rIns="0" bIns="0" rtlCol="0" anchor="ctr"/>
+          <a:lstStyle/>
+          <a:p>
+            <a:pPr indent="0" marL="0">
+              <a:buNone/>
+            </a:pPr>
+            <a:r>
+              <a:rPr lang="en-US" sz="1700" dirty="0">
+                <a:solidFill>
+                  <a:srgbClr val="000000"/>
+                </a:solidFill>
+                <a:latin typeface="NVIDIA Sans" pitchFamily="34" charset="0"/>
+                <a:ea typeface="NVIDIA Sans" pitchFamily="34" charset="-122"/>
+                <a:cs typeface="NVIDIA Sans" pitchFamily="34" charset="-120"/>
+              </a:rPr>
+              <a:t>Results at a glance</a:t>
+            </a:r>
+            <a:endParaRPr lang="en-US" sz="1700" dirty="0"/>
+          </a:p>
+        </p:txBody>
+      </p:sp>
+      <p:sp>
+        <p:nvSpPr>
+          <p:cNvPr id="6" name="Text 4"/>
+          <p:cNvSpPr/>
+          <p:nvPr/>
+        </p:nvSpPr>
+        <p:spPr>
+          <a:xfrm>
+            <a:off x="7680960" y="1234440"/>
+            <a:ext cx="914400" cy="438912"/>
+          </a:xfrm>
+          <a:prstGeom prst="rect">
+            <a:avLst/>
+          </a:prstGeom>
+          <a:noFill/>
+          <a:ln/>
+        </p:spPr>
+        <p:txBody>
+          <a:bodyPr wrap="square" lIns="0" tIns="0" rIns="0" bIns="0" rtlCol="0" anchor="ctr"/>
+          <a:lstStyle/>
+          <a:p>
+            <a:pPr algn="r" indent="0" marL="0">
+              <a:buNone/>
+            </a:pPr>
+            <a:r>
+              <a:rPr lang="en-US" sz="1400" b="1" dirty="0">
+                <a:solidFill>
+                  <a:srgbClr val="76B900"/>
+                </a:solidFill>
+                <a:latin typeface="NVIDIA Sans" pitchFamily="34" charset="0"/>
+                <a:ea typeface="NVIDIA Sans" pitchFamily="34" charset="-122"/>
+                <a:cs typeface="NVIDIA Sans" pitchFamily="34" charset="-120"/>
+              </a:rPr>
+              <a:t>3</a:t>
+            </a:r>
+            <a:endParaRPr lang="en-US" sz="1400" dirty="0"/>
+          </a:p>
+        </p:txBody>
+      </p:sp>
+      <p:sp>
+        <p:nvSpPr>
+          <p:cNvPr id="7" name="Shape 5"/>
+          <p:cNvSpPr/>
+          <p:nvPr/>
+        </p:nvSpPr>
+        <p:spPr>
+          <a:xfrm>
+            <a:off x="640080" y="1783080"/>
+            <a:ext cx="365760" cy="365760"/>
+          </a:xfrm>
+          <a:prstGeom prst="ellipse">
+            <a:avLst/>
+          </a:prstGeom>
+          <a:solidFill>
+            <a:srgbClr val="76B900"/>
+          </a:solidFill>
+          <a:ln/>
+        </p:spPr>
+      </p:sp>
+      <p:sp>
+        <p:nvSpPr>
+          <p:cNvPr id="8" name="Text 6"/>
+          <p:cNvSpPr/>
+          <p:nvPr/>
+        </p:nvSpPr>
+        <p:spPr>
+          <a:xfrm>
+            <a:off x="640080" y="1783080"/>
+            <a:ext cx="365760" cy="365760"/>
+          </a:xfrm>
+          <a:prstGeom prst="rect">
+            <a:avLst/>
+          </a:prstGeom>
+          <a:noFill/>
+          <a:ln/>
+        </p:spPr>
+        <p:txBody>
+          <a:bodyPr wrap="square" lIns="0" tIns="0" rIns="0" bIns="0" rtlCol="0" anchor="ctr"/>
+          <a:lstStyle/>
+          <a:p>
+            <a:pPr algn="ctr" indent="0" marL="0">
+              <a:buNone/>
+            </a:pPr>
+            <a:r>
+              <a:rPr lang="en-US" sz="1500" b="1" dirty="0">
+                <a:solidFill>
+                  <a:srgbClr val="FFFFFF"/>
+                </a:solidFill>
+                <a:latin typeface="NVIDIA Sans" pitchFamily="34" charset="0"/>
+                <a:ea typeface="NVIDIA Sans" pitchFamily="34" charset="-122"/>
+                <a:cs typeface="NVIDIA Sans" pitchFamily="34" charset="-120"/>
+              </a:rPr>
+              <a:t>2</a:t>
+            </a:r>
+            <a:endParaRPr lang="en-US" sz="1500" dirty="0"/>
+          </a:p>
+        </p:txBody>
+      </p:sp>
+      <p:sp>
+        <p:nvSpPr>
+          <p:cNvPr id="9" name="Text 7"/>
+          <p:cNvSpPr/>
+          <p:nvPr/>
+        </p:nvSpPr>
+        <p:spPr>
+          <a:xfrm>
+            <a:off x="1234440" y="1746504"/>
+            <a:ext cx="6309360" cy="438912"/>
+          </a:xfrm>
+          <a:prstGeom prst="rect">
+            <a:avLst/>
+          </a:prstGeom>
+          <a:noFill/>
+          <a:ln/>
+        </p:spPr>
+        <p:txBody>
+          <a:bodyPr wrap="square" lIns="0" tIns="0" rIns="0" bIns="0" rtlCol="0" anchor="ctr"/>
+          <a:lstStyle/>
+          <a:p>
+            <a:pPr indent="0" marL="0">
+              <a:buNone/>
+            </a:pPr>
+            <a:r>
+              <a:rPr lang="en-US" sz="1700" dirty="0">
+                <a:solidFill>
+                  <a:srgbClr val="000000"/>
+                </a:solidFill>
+                <a:latin typeface="NVIDIA Sans" pitchFamily="34" charset="0"/>
+                <a:ea typeface="NVIDIA Sans" pitchFamily="34" charset="-122"/>
+                <a:cs typeface="NVIDIA Sans" pitchFamily="34" charset="-120"/>
+              </a:rPr>
+              <a:t>Model &amp; workload</a:t>
+            </a:r>
+            <a:endParaRPr lang="en-US" sz="1700" dirty="0"/>
+          </a:p>
+        </p:txBody>
+      </p:sp>
+      <p:sp>
+        <p:nvSpPr>
+          <p:cNvPr id="10" name="Text 8"/>
+          <p:cNvSpPr/>
+          <p:nvPr/>
+        </p:nvSpPr>
+        <p:spPr>
+          <a:xfrm>
+            <a:off x="7680960" y="1746504"/>
+            <a:ext cx="914400" cy="438912"/>
+          </a:xfrm>
+          <a:prstGeom prst="rect">
+            <a:avLst/>
+          </a:prstGeom>
+          <a:noFill/>
+          <a:ln/>
+        </p:spPr>
+        <p:txBody>
+          <a:bodyPr wrap="square" lIns="0" tIns="0" rIns="0" bIns="0" rtlCol="0" anchor="ctr"/>
+          <a:lstStyle/>
+          <a:p>
+            <a:pPr algn="r" indent="0" marL="0">
+              <a:buNone/>
+            </a:pPr>
+            <a:r>
+              <a:rPr lang="en-US" sz="1400" b="1" dirty="0">
+                <a:solidFill>
+                  <a:srgbClr val="76B900"/>
+                </a:solidFill>
+                <a:latin typeface="NVIDIA Sans" pitchFamily="34" charset="0"/>
+                <a:ea typeface="NVIDIA Sans" pitchFamily="34" charset="-122"/>
+                <a:cs typeface="NVIDIA Sans" pitchFamily="34" charset="-120"/>
+              </a:rPr>
+              <a:t>4</a:t>
+            </a:r>
+            <a:endParaRPr lang="en-US" sz="1400" dirty="0"/>
+          </a:p>
+        </p:txBody>
+      </p:sp>
+      <p:sp>
+        <p:nvSpPr>
+          <p:cNvPr id="11" name="Shape 9"/>
+          <p:cNvSpPr/>
+          <p:nvPr/>
+        </p:nvSpPr>
+        <p:spPr>
+          <a:xfrm>
+            <a:off x="640080" y="2295144"/>
+            <a:ext cx="365760" cy="365760"/>
+          </a:xfrm>
+          <a:prstGeom prst="ellipse">
+            <a:avLst/>
+          </a:prstGeom>
+          <a:solidFill>
+            <a:srgbClr val="76B900"/>
+          </a:solidFill>
+          <a:ln/>
+        </p:spPr>
+      </p:sp>
+      <p:sp>
+        <p:nvSpPr>
+          <p:cNvPr id="12" name="Text 10"/>
+          <p:cNvSpPr/>
+          <p:nvPr/>
+        </p:nvSpPr>
+        <p:spPr>
+          <a:xfrm>
+            <a:off x="640080" y="2295144"/>
+            <a:ext cx="365760" cy="365760"/>
+          </a:xfrm>
+          <a:prstGeom prst="rect">
+            <a:avLst/>
+          </a:prstGeom>
+          <a:noFill/>
+          <a:ln/>
+        </p:spPr>
+        <p:txBody>
+          <a:bodyPr wrap="square" lIns="0" tIns="0" rIns="0" bIns="0" rtlCol="0" anchor="ctr"/>
+          <a:lstStyle/>
+          <a:p>
+            <a:pPr algn="ctr" indent="0" marL="0">
+              <a:buNone/>
+            </a:pPr>
+            <a:r>
+              <a:rPr lang="en-US" sz="1500" b="1" dirty="0">
+                <a:solidFill>
+                  <a:srgbClr val="FFFFFF"/>
+                </a:solidFill>
+                <a:latin typeface="NVIDIA Sans" pitchFamily="34" charset="0"/>
+                <a:ea typeface="NVIDIA Sans" pitchFamily="34" charset="-122"/>
+                <a:cs typeface="NVIDIA Sans" pitchFamily="34" charset="-120"/>
+              </a:rPr>
+              <a:t>3</a:t>
+            </a:r>
+            <a:endParaRPr lang="en-US" sz="1500" dirty="0"/>
+          </a:p>
+        </p:txBody>
+      </p:sp>
+      <p:sp>
+        <p:nvSpPr>
+          <p:cNvPr id="13" name="Text 11"/>
+          <p:cNvSpPr/>
+          <p:nvPr/>
+        </p:nvSpPr>
+        <p:spPr>
+          <a:xfrm>
+            <a:off x="1234440" y="2258568"/>
+            <a:ext cx="6309360" cy="438912"/>
+          </a:xfrm>
+          <a:prstGeom prst="rect">
+            <a:avLst/>
+          </a:prstGeom>
+          <a:noFill/>
+          <a:ln/>
+        </p:spPr>
+        <p:txBody>
+          <a:bodyPr wrap="square" lIns="0" tIns="0" rIns="0" bIns="0" rtlCol="0" anchor="ctr"/>
+          <a:lstStyle/>
+          <a:p>
+            <a:pPr indent="0" marL="0">
+              <a:buNone/>
+            </a:pPr>
+            <a:r>
+              <a:rPr lang="en-US" sz="1700" dirty="0">
+                <a:solidFill>
+                  <a:srgbClr val="000000"/>
+                </a:solidFill>
+                <a:latin typeface="NVIDIA Sans" pitchFamily="34" charset="0"/>
+                <a:ea typeface="NVIDIA Sans" pitchFamily="34" charset="-122"/>
+                <a:cs typeface="NVIDIA Sans" pitchFamily="34" charset="-120"/>
+              </a:rPr>
+              <a:t>Diagnosis — where did 800 ms go</a:t>
+            </a:r>
+            <a:endParaRPr lang="en-US" sz="1700" dirty="0"/>
+          </a:p>
+        </p:txBody>
+      </p:sp>
+      <p:sp>
+        <p:nvSpPr>
+          <p:cNvPr id="14" name="Text 12"/>
+          <p:cNvSpPr/>
+          <p:nvPr/>
+        </p:nvSpPr>
+        <p:spPr>
+          <a:xfrm>
+            <a:off x="7680960" y="2258568"/>
+            <a:ext cx="914400" cy="438912"/>
+          </a:xfrm>
+          <a:prstGeom prst="rect">
+            <a:avLst/>
+          </a:prstGeom>
+          <a:noFill/>
+          <a:ln/>
+        </p:spPr>
+        <p:txBody>
+          <a:bodyPr wrap="square" lIns="0" tIns="0" rIns="0" bIns="0" rtlCol="0" anchor="ctr"/>
+          <a:lstStyle/>
+          <a:p>
+            <a:pPr algn="r" indent="0" marL="0">
+              <a:buNone/>
+            </a:pPr>
+            <a:r>
+              <a:rPr lang="en-US" sz="1400" b="1" dirty="0">
+                <a:solidFill>
+                  <a:srgbClr val="76B900"/>
+                </a:solidFill>
+                <a:latin typeface="NVIDIA Sans" pitchFamily="34" charset="0"/>
+                <a:ea typeface="NVIDIA Sans" pitchFamily="34" charset="-122"/>
+                <a:cs typeface="NVIDIA Sans" pitchFamily="34" charset="-120"/>
+              </a:rPr>
+              <a:t>5 – 6</a:t>
+            </a:r>
+            <a:endParaRPr lang="en-US" sz="1400" dirty="0"/>
+          </a:p>
+        </p:txBody>
+      </p:sp>
+      <p:sp>
+        <p:nvSpPr>
+          <p:cNvPr id="15" name="Shape 13"/>
+          <p:cNvSpPr/>
+          <p:nvPr/>
+        </p:nvSpPr>
+        <p:spPr>
+          <a:xfrm>
+            <a:off x="640080" y="2807208"/>
+            <a:ext cx="365760" cy="365760"/>
+          </a:xfrm>
+          <a:prstGeom prst="ellipse">
+            <a:avLst/>
+          </a:prstGeom>
+          <a:solidFill>
+            <a:srgbClr val="76B900"/>
+          </a:solidFill>
+          <a:ln/>
+        </p:spPr>
+      </p:sp>
+      <p:sp>
+        <p:nvSpPr>
+          <p:cNvPr id="16" name="Text 14"/>
+          <p:cNvSpPr/>
+          <p:nvPr/>
+        </p:nvSpPr>
+        <p:spPr>
+          <a:xfrm>
+            <a:off x="640080" y="2807208"/>
+            <a:ext cx="365760" cy="365760"/>
+          </a:xfrm>
+          <a:prstGeom prst="rect">
+            <a:avLst/>
+          </a:prstGeom>
+          <a:noFill/>
+          <a:ln/>
+        </p:spPr>
+        <p:txBody>
+          <a:bodyPr wrap="square" lIns="0" tIns="0" rIns="0" bIns="0" rtlCol="0" anchor="ctr"/>
+          <a:lstStyle/>
+          <a:p>
+            <a:pPr algn="ctr" indent="0" marL="0">
+              <a:buNone/>
+            </a:pPr>
+            <a:r>
+              <a:rPr lang="en-US" sz="1500" b="1" dirty="0">
+                <a:solidFill>
+                  <a:srgbClr val="FFFFFF"/>
+                </a:solidFill>
+                <a:latin typeface="NVIDIA Sans" pitchFamily="34" charset="0"/>
+                <a:ea typeface="NVIDIA Sans" pitchFamily="34" charset="-122"/>
+                <a:cs typeface="NVIDIA Sans" pitchFamily="34" charset="-120"/>
+              </a:rPr>
+              <a:t>4</a:t>
+            </a:r>
+            <a:endParaRPr lang="en-US" sz="1500" dirty="0"/>
+          </a:p>
+        </p:txBody>
+      </p:sp>
+      <p:sp>
+        <p:nvSpPr>
+          <p:cNvPr id="17" name="Text 15"/>
+          <p:cNvSpPr/>
+          <p:nvPr/>
+        </p:nvSpPr>
+        <p:spPr>
+          <a:xfrm>
+            <a:off x="1234440" y="2770632"/>
+            <a:ext cx="6309360" cy="438912"/>
+          </a:xfrm>
+          <a:prstGeom prst="rect">
+            <a:avLst/>
+          </a:prstGeom>
+          <a:noFill/>
+          <a:ln/>
+        </p:spPr>
+        <p:txBody>
+          <a:bodyPr wrap="square" lIns="0" tIns="0" rIns="0" bIns="0" rtlCol="0" anchor="ctr"/>
+          <a:lstStyle/>
+          <a:p>
+            <a:pPr indent="0" marL="0">
+              <a:buNone/>
+            </a:pPr>
+            <a:r>
+              <a:rPr lang="en-US" sz="1700" dirty="0">
+                <a:solidFill>
+                  <a:srgbClr val="000000"/>
+                </a:solidFill>
+                <a:latin typeface="NVIDIA Sans" pitchFamily="34" charset="0"/>
+                <a:ea typeface="NVIDIA Sans" pitchFamily="34" charset="-122"/>
+                <a:cs typeface="NVIDIA Sans" pitchFamily="34" charset="-120"/>
+              </a:rPr>
+              <a:t>The six fixes — precision, syncs, CUDA Graphs, comm</a:t>
+            </a:r>
+            <a:endParaRPr lang="en-US" sz="1700" dirty="0"/>
+          </a:p>
+        </p:txBody>
+      </p:sp>
+      <p:sp>
+        <p:nvSpPr>
+          <p:cNvPr id="18" name="Text 16"/>
+          <p:cNvSpPr/>
+          <p:nvPr/>
+        </p:nvSpPr>
+        <p:spPr>
+          <a:xfrm>
+            <a:off x="7680960" y="2770632"/>
+            <a:ext cx="914400" cy="438912"/>
+          </a:xfrm>
+          <a:prstGeom prst="rect">
+            <a:avLst/>
+          </a:prstGeom>
+          <a:noFill/>
+          <a:ln/>
+        </p:spPr>
+        <p:txBody>
+          <a:bodyPr wrap="square" lIns="0" tIns="0" rIns="0" bIns="0" rtlCol="0" anchor="ctr"/>
+          <a:lstStyle/>
+          <a:p>
+            <a:pPr algn="r" indent="0" marL="0">
+              <a:buNone/>
+            </a:pPr>
+            <a:r>
+              <a:rPr lang="en-US" sz="1400" b="1" dirty="0">
+                <a:solidFill>
+                  <a:srgbClr val="76B900"/>
+                </a:solidFill>
+                <a:latin typeface="NVIDIA Sans" pitchFamily="34" charset="0"/>
+                <a:ea typeface="NVIDIA Sans" pitchFamily="34" charset="-122"/>
+                <a:cs typeface="NVIDIA Sans" pitchFamily="34" charset="-120"/>
+              </a:rPr>
+              <a:t>7 – 12</a:t>
+            </a:r>
+            <a:endParaRPr lang="en-US" sz="1400" dirty="0"/>
+          </a:p>
+        </p:txBody>
+      </p:sp>
+      <p:sp>
+        <p:nvSpPr>
+          <p:cNvPr id="19" name="Shape 17"/>
+          <p:cNvSpPr/>
+          <p:nvPr/>
+        </p:nvSpPr>
+        <p:spPr>
+          <a:xfrm>
+            <a:off x="640080" y="3319272"/>
+            <a:ext cx="365760" cy="365760"/>
+          </a:xfrm>
+          <a:prstGeom prst="ellipse">
+            <a:avLst/>
+          </a:prstGeom>
+          <a:solidFill>
+            <a:srgbClr val="76B900"/>
+          </a:solidFill>
+          <a:ln/>
+        </p:spPr>
+      </p:sp>
+      <p:sp>
+        <p:nvSpPr>
+          <p:cNvPr id="20" name="Text 18"/>
+          <p:cNvSpPr/>
+          <p:nvPr/>
+        </p:nvSpPr>
+        <p:spPr>
+          <a:xfrm>
+            <a:off x="640080" y="3319272"/>
+            <a:ext cx="365760" cy="365760"/>
+          </a:xfrm>
+          <a:prstGeom prst="rect">
+            <a:avLst/>
+          </a:prstGeom>
+          <a:noFill/>
+          <a:ln/>
+        </p:spPr>
+        <p:txBody>
+          <a:bodyPr wrap="square" lIns="0" tIns="0" rIns="0" bIns="0" rtlCol="0" anchor="ctr"/>
+          <a:lstStyle/>
+          <a:p>
+            <a:pPr algn="ctr" indent="0" marL="0">
+              <a:buNone/>
+            </a:pPr>
+            <a:r>
+              <a:rPr lang="en-US" sz="1500" b="1" dirty="0">
+                <a:solidFill>
+                  <a:srgbClr val="FFFFFF"/>
+                </a:solidFill>
+                <a:latin typeface="NVIDIA Sans" pitchFamily="34" charset="0"/>
+                <a:ea typeface="NVIDIA Sans" pitchFamily="34" charset="-122"/>
+                <a:cs typeface="NVIDIA Sans" pitchFamily="34" charset="-120"/>
+              </a:rPr>
+              <a:t>5</a:t>
+            </a:r>
+            <a:endParaRPr lang="en-US" sz="1500" dirty="0"/>
+          </a:p>
+        </p:txBody>
+      </p:sp>
+      <p:sp>
+        <p:nvSpPr>
+          <p:cNvPr id="21" name="Text 19"/>
+          <p:cNvSpPr/>
+          <p:nvPr/>
+        </p:nvSpPr>
+        <p:spPr>
+          <a:xfrm>
+            <a:off x="1234440" y="3282696"/>
+            <a:ext cx="6309360" cy="438912"/>
+          </a:xfrm>
+          <a:prstGeom prst="rect">
+            <a:avLst/>
+          </a:prstGeom>
+          <a:noFill/>
+          <a:ln/>
+        </p:spPr>
+        <p:txBody>
+          <a:bodyPr wrap="square" lIns="0" tIns="0" rIns="0" bIns="0" rtlCol="0" anchor="ctr"/>
+          <a:lstStyle/>
+          <a:p>
+            <a:pPr indent="0" marL="0">
+              <a:buNone/>
+            </a:pPr>
+            <a:r>
+              <a:rPr lang="en-US" sz="1700" dirty="0">
+                <a:solidFill>
+                  <a:srgbClr val="000000"/>
+                </a:solidFill>
+                <a:latin typeface="NVIDIA Sans" pitchFamily="34" charset="0"/>
+                <a:ea typeface="NVIDIA Sans" pitchFamily="34" charset="-122"/>
+                <a:cs typeface="NVIDIA Sans" pitchFamily="34" charset="-120"/>
+              </a:rPr>
+              <a:t>Batch scaling</a:t>
+            </a:r>
+            <a:endParaRPr lang="en-US" sz="1700" dirty="0"/>
+          </a:p>
+        </p:txBody>
+      </p:sp>
+      <p:sp>
+        <p:nvSpPr>
+          <p:cNvPr id="22" name="Text 20"/>
+          <p:cNvSpPr/>
+          <p:nvPr/>
+        </p:nvSpPr>
+        <p:spPr>
+          <a:xfrm>
+            <a:off x="7680960" y="3282696"/>
+            <a:ext cx="914400" cy="438912"/>
+          </a:xfrm>
+          <a:prstGeom prst="rect">
+            <a:avLst/>
+          </a:prstGeom>
+          <a:noFill/>
+          <a:ln/>
+        </p:spPr>
+        <p:txBody>
+          <a:bodyPr wrap="square" lIns="0" tIns="0" rIns="0" bIns="0" rtlCol="0" anchor="ctr"/>
+          <a:lstStyle/>
+          <a:p>
+            <a:pPr algn="r" indent="0" marL="0">
+              <a:buNone/>
+            </a:pPr>
+            <a:r>
+              <a:rPr lang="en-US" sz="1400" b="1" dirty="0">
+                <a:solidFill>
+                  <a:srgbClr val="76B900"/>
+                </a:solidFill>
+                <a:latin typeface="NVIDIA Sans" pitchFamily="34" charset="0"/>
+                <a:ea typeface="NVIDIA Sans" pitchFamily="34" charset="-122"/>
+                <a:cs typeface="NVIDIA Sans" pitchFamily="34" charset="-120"/>
+              </a:rPr>
+              <a:t>13</a:t>
+            </a:r>
+            <a:endParaRPr lang="en-US" sz="1400" dirty="0"/>
+          </a:p>
+        </p:txBody>
+      </p:sp>
+      <p:sp>
+        <p:nvSpPr>
+          <p:cNvPr id="23" name="Shape 21"/>
+          <p:cNvSpPr/>
+          <p:nvPr/>
+        </p:nvSpPr>
+        <p:spPr>
+          <a:xfrm>
+            <a:off x="640080" y="3831336"/>
+            <a:ext cx="365760" cy="365760"/>
+          </a:xfrm>
+          <a:prstGeom prst="ellipse">
+            <a:avLst/>
+          </a:prstGeom>
+          <a:solidFill>
+            <a:srgbClr val="76B900"/>
+          </a:solidFill>
+          <a:ln/>
+        </p:spPr>
+      </p:sp>
+      <p:sp>
+        <p:nvSpPr>
+          <p:cNvPr id="24" name="Text 22"/>
+          <p:cNvSpPr/>
+          <p:nvPr/>
+        </p:nvSpPr>
+        <p:spPr>
+          <a:xfrm>
+            <a:off x="640080" y="3831336"/>
+            <a:ext cx="365760" cy="365760"/>
+          </a:xfrm>
+          <a:prstGeom prst="rect">
+            <a:avLst/>
+          </a:prstGeom>
+          <a:noFill/>
+          <a:ln/>
+        </p:spPr>
+        <p:txBody>
+          <a:bodyPr wrap="square" lIns="0" tIns="0" rIns="0" bIns="0" rtlCol="0" anchor="ctr"/>
+          <a:lstStyle/>
+          <a:p>
+            <a:pPr algn="ctr" indent="0" marL="0">
+              <a:buNone/>
+            </a:pPr>
+            <a:r>
+              <a:rPr lang="en-US" sz="1500" b="1" dirty="0">
+                <a:solidFill>
+                  <a:srgbClr val="FFFFFF"/>
+                </a:solidFill>
+                <a:latin typeface="NVIDIA Sans" pitchFamily="34" charset="0"/>
+                <a:ea typeface="NVIDIA Sans" pitchFamily="34" charset="-122"/>
+                <a:cs typeface="NVIDIA Sans" pitchFamily="34" charset="-120"/>
+              </a:rPr>
+              <a:t>6</a:t>
+            </a:r>
+            <a:endParaRPr lang="en-US" sz="1500" dirty="0"/>
+          </a:p>
+        </p:txBody>
+      </p:sp>
+      <p:sp>
+        <p:nvSpPr>
+          <p:cNvPr id="25" name="Text 23"/>
+          <p:cNvSpPr/>
+          <p:nvPr/>
+        </p:nvSpPr>
+        <p:spPr>
+          <a:xfrm>
+            <a:off x="1234440" y="3794760"/>
+            <a:ext cx="6309360" cy="438912"/>
+          </a:xfrm>
+          <a:prstGeom prst="rect">
+            <a:avLst/>
+          </a:prstGeom>
+          <a:noFill/>
+          <a:ln/>
+        </p:spPr>
+        <p:txBody>
+          <a:bodyPr wrap="square" lIns="0" tIns="0" rIns="0" bIns="0" rtlCol="0" anchor="ctr"/>
+          <a:lstStyle/>
+          <a:p>
+            <a:pPr indent="0" marL="0">
+              <a:buNone/>
+            </a:pPr>
+            <a:r>
+              <a:rPr lang="en-US" sz="1700" dirty="0">
+                <a:solidFill>
+                  <a:srgbClr val="000000"/>
+                </a:solidFill>
+                <a:latin typeface="NVIDIA Sans" pitchFamily="34" charset="0"/>
+                <a:ea typeface="NVIDIA Sans" pitchFamily="34" charset="-122"/>
+                <a:cs typeface="NVIDIA Sans" pitchFamily="34" charset="-120"/>
+              </a:rPr>
+              <a:t>What's next</a:t>
+            </a:r>
+            <a:endParaRPr lang="en-US" sz="1700" dirty="0"/>
+          </a:p>
+        </p:txBody>
+      </p:sp>
+      <p:sp>
+        <p:nvSpPr>
+          <p:cNvPr id="26" name="Text 24"/>
+          <p:cNvSpPr/>
+          <p:nvPr/>
+        </p:nvSpPr>
+        <p:spPr>
+          <a:xfrm>
+            <a:off x="7680960" y="3794760"/>
+            <a:ext cx="914400" cy="438912"/>
+          </a:xfrm>
+          <a:prstGeom prst="rect">
+            <a:avLst/>
+          </a:prstGeom>
+          <a:noFill/>
+          <a:ln/>
+        </p:spPr>
+        <p:txBody>
+          <a:bodyPr wrap="square" lIns="0" tIns="0" rIns="0" bIns="0" rtlCol="0" anchor="ctr"/>
+          <a:lstStyle/>
+          <a:p>
+            <a:pPr algn="r" indent="0" marL="0">
+              <a:buNone/>
+            </a:pPr>
+            <a:r>
+              <a:rPr lang="en-US" sz="1400" b="1" dirty="0">
+                <a:solidFill>
+                  <a:srgbClr val="76B900"/>
+                </a:solidFill>
+                <a:latin typeface="NVIDIA Sans" pitchFamily="34" charset="0"/>
+                <a:ea typeface="NVIDIA Sans" pitchFamily="34" charset="-122"/>
+                <a:cs typeface="NVIDIA Sans" pitchFamily="34" charset="-120"/>
+              </a:rPr>
+              <a:t>14</a:t>
+            </a:r>
+            <a:endParaRPr lang="en-US" sz="1400" dirty="0"/>
+          </a:p>
+        </p:txBody>
+      </p:sp>
+      <p:sp>
+        <p:nvSpPr>
+          <p:cNvPr id="27" name="Text 25"/>
+          <p:cNvSpPr/>
+          <p:nvPr/>
+        </p:nvSpPr>
+        <p:spPr>
+          <a:xfrm>
+            <a:off x="457200" y="4617720"/>
+            <a:ext cx="4572000" cy="320040"/>
+          </a:xfrm>
+          <a:prstGeom prst="rect">
+            <a:avLst/>
+          </a:prstGeom>
+          <a:noFill/>
+          <a:ln/>
+        </p:spPr>
+        <p:txBody>
+          <a:bodyPr wrap="square" lIns="0" tIns="0" rIns="0" bIns="0" rtlCol="0" anchor="ctr"/>
+          <a:lstStyle/>
+          <a:p>
+            <a:pPr algn="l" indent="0" marL="0">
+              <a:buNone/>
+            </a:pPr>
+            <a:r>
+              <a:rPr lang="en-US" sz="1000" dirty="0">
+                <a:solidFill>
+                  <a:srgbClr val="5E5E5E"/>
+                </a:solidFill>
+                <a:latin typeface="NVIDIA Sans" pitchFamily="34" charset="0"/>
+                <a:ea typeface="NVIDIA Sans" pitchFamily="34" charset="-122"/>
+                <a:cs typeface="NVIDIA Sans" pitchFamily="34" charset="-120"/>
+              </a:rPr>
+              <a:t>QwenPI Training Optimization</a:t>
+            </a:r>
+            <a:endParaRPr lang="en-US" sz="1000" dirty="0"/>
+          </a:p>
+        </p:txBody>
+      </p:sp>
+      <p:sp>
+        <p:nvSpPr>
+          <p:cNvPr id="28" name="Text 26"/>
+          <p:cNvSpPr/>
+          <p:nvPr/>
+        </p:nvSpPr>
+        <p:spPr>
+          <a:xfrm>
+            <a:off x="7360920" y="4617720"/>
+            <a:ext cx="320040" cy="320040"/>
+          </a:xfrm>
+          <a:prstGeom prst="rect">
+            <a:avLst/>
+          </a:prstGeom>
+          <a:noFill/>
+          <a:ln/>
+        </p:spPr>
+        <p:txBody>
+          <a:bodyPr wrap="square" lIns="0" tIns="0" rIns="0" bIns="0" rtlCol="0" anchor="ctr"/>
+          <a:lstStyle/>
+          <a:p>
+            <a:pPr algn="r" indent="0" marL="0">
+              <a:buNone/>
+            </a:pPr>
+            <a:r>
+              <a:rPr lang="en-US" sz="1000" dirty="0">
+                <a:solidFill>
+                  <a:srgbClr val="5E5E5E"/>
+                </a:solidFill>
+                <a:latin typeface="NVIDIA Sans" pitchFamily="34" charset="0"/>
+                <a:ea typeface="NVIDIA Sans" pitchFamily="34" charset="-122"/>
+                <a:cs typeface="NVIDIA Sans" pitchFamily="34" charset="-120"/>
+              </a:rPr>
+              <a:t>2</a:t>
+            </a:r>
+            <a:endParaRPr lang="en-US" sz="1000" dirty="0"/>
+          </a:p>
+        </p:txBody>
+      </p:sp>
+      <p:sp>
+        <p:nvSpPr>
+          <p:cNvPr id="29" name="Shape 27"/>
+          <p:cNvSpPr/>
+          <p:nvPr/>
+        </p:nvSpPr>
+        <p:spPr>
+          <a:xfrm>
+            <a:off x="7726680" y="4617720"/>
+            <a:ext cx="36576" cy="320040"/>
+          </a:xfrm>
+          <a:prstGeom prst="rect">
+            <a:avLst/>
+          </a:prstGeom>
+          <a:solidFill>
+            <a:srgbClr val="76B900"/>
+          </a:solidFill>
+          <a:ln/>
+        </p:spPr>
+      </p:sp>
+      <p:pic>
+        <p:nvPicPr>
+          <p:cNvPr id="30" name="Image 0" descr="/app/logos/nvidia-logo-blk-sm.png">    </p:cNvPr>
+          <p:cNvPicPr>
+            <a:picLocks noChangeAspect="1"/>
+          </p:cNvPicPr>
+          <p:nvPr/>
+        </p:nvPicPr>
+        <p:blipFill>
+          <a:blip r:embed="rId1"/>
+          <a:stretch>
+            <a:fillRect/>
+          </a:stretch>
+        </p:blipFill>
+        <p:spPr>
+          <a:xfrm>
+            <a:off x="7863840" y="4604004"/>
+            <a:ext cx="1005840" cy="347472"/>
+          </a:xfrm>
+          <a:prstGeom prst="rect">
+            <a:avLst/>
+          </a:prstGeom>
+        </p:spPr>
+      </p:pic>
+    </p:spTree>
+  </p:cSld>
+  <p:clrMapOvr>
+    <a:masterClrMapping/>
+  </p:clrMapOvr>
+</p:sld>
+</file>
+
+<file path=ppt/slides/slide3.xml><?xml version="1.0" encoding="utf-8"?>
+<p:sld xmlns:a="http://schemas.openxmlformats.org/drawingml/2006/main" xmlns:r="http://schemas.openxmlformats.org/officeDocument/2006/relationships" xmlns:p="http://schemas.openxmlformats.org/presentationml/2006/main">
+  <p:cSld name="Slide 3">
     <p:bg>
       <p:bgPr>
         <a:solidFill>
@@ -23319,7 +25327,7 @@
                 <a:ea typeface="NVIDIA Sans" pitchFamily="34" charset="-122"/>
                 <a:cs typeface="NVIDIA Sans" pitchFamily="34" charset="-120"/>
               </a:rPr>
-              <a:t>2</a:t>
+              <a:t>3</a:t>
             </a:r>
             <a:endParaRPr lang="en-US" sz="1000" dirty="0"/>
           </a:p>
@@ -23377,9 +25385,9 @@
 </p:sld>
 </file>
 
-<file path=ppt/slides/slide3.xml><?xml version="1.0" encoding="utf-8"?>
+<file path=ppt/slides/slide4.xml><?xml version="1.0" encoding="utf-8"?>
 <p:sld xmlns:a="http://schemas.openxmlformats.org/drawingml/2006/main" xmlns:r="http://schemas.openxmlformats.org/officeDocument/2006/relationships" xmlns:p="http://schemas.openxmlformats.org/presentationml/2006/main">
-  <p:cSld name="Slide 3">
+  <p:cSld name="Slide 4">
     <p:bg>
       <p:bgPr>
         <a:solidFill>
@@ -23505,7 +25513,7 @@
       </p:pic>
       <p:graphicFrame>
         <p:nvGraphicFramePr>
-          <p:cNvPr id="4" name="Table 0"/>
+          <p:cNvPr id="5" name="Table 0"/>
           <p:cNvGraphicFramePr>
             <a:graphicFrameLocks noGrp="1"/>
           </p:cNvGraphicFramePr>
@@ -24920,7 +26928,7 @@
                 <a:ea typeface="NVIDIA Sans" pitchFamily="34" charset="-122"/>
                 <a:cs typeface="NVIDIA Sans" pitchFamily="34" charset="-120"/>
               </a:rPr>
-              <a:t>3</a:t>
+              <a:t>4</a:t>
             </a:r>
             <a:endParaRPr lang="en-US" sz="1000" dirty="0"/>
           </a:p>
@@ -24978,9 +26986,9 @@
 </p:sld>
 </file>
 
-<file path=ppt/slides/slide4.xml><?xml version="1.0" encoding="utf-8"?>
+<file path=ppt/slides/slide5.xml><?xml version="1.0" encoding="utf-8"?>
 <p:sld xmlns:a="http://schemas.openxmlformats.org/drawingml/2006/main" xmlns:r="http://schemas.openxmlformats.org/officeDocument/2006/relationships" xmlns:p="http://schemas.openxmlformats.org/presentationml/2006/main">
-  <p:cSld name="Slide 4">
+  <p:cSld name="Slide 5">
     <p:bg>
       <p:bgPr>
         <a:solidFill>
@@ -29890,7 +31898,7 @@
       </p:sp>
       <p:graphicFrame>
         <p:nvGraphicFramePr>
-          <p:cNvPr id="5" name="Table 0"/>
+          <p:cNvPr id="6" name="Table 0"/>
           <p:cNvGraphicFramePr>
             <a:graphicFrameLocks noGrp="1"/>
           </p:cNvGraphicFramePr>
@@ -30976,7 +32984,7 @@
                 <a:ea typeface="NVIDIA Sans" pitchFamily="34" charset="-122"/>
                 <a:cs typeface="NVIDIA Sans" pitchFamily="34" charset="-120"/>
               </a:rPr>
-              <a:t>4</a:t>
+              <a:t>5</a:t>
             </a:r>
             <a:endParaRPr lang="en-US" sz="1000" dirty="0"/>
           </a:p>
@@ -31034,9 +33042,9 @@
 </p:sld>
 </file>
 
-<file path=ppt/slides/slide5.xml><?xml version="1.0" encoding="utf-8"?>
+<file path=ppt/slides/slide6.xml><?xml version="1.0" encoding="utf-8"?>
 <p:sld xmlns:a="http://schemas.openxmlformats.org/drawingml/2006/main" xmlns:r="http://schemas.openxmlformats.org/officeDocument/2006/relationships" xmlns:p="http://schemas.openxmlformats.org/presentationml/2006/main">
-  <p:cSld name="Slide 5">
+  <p:cSld name="Slide 6">
     <p:bg>
       <p:bgPr>
         <a:solidFill>
@@ -32286,7 +34294,7 @@
                 <a:ea typeface="NVIDIA Sans" pitchFamily="34" charset="-122"/>
                 <a:cs typeface="NVIDIA Sans" pitchFamily="34" charset="-120"/>
               </a:rPr>
-              <a:t>5</a:t>
+              <a:t>6</a:t>
             </a:r>
             <a:endParaRPr lang="en-US" sz="1000" dirty="0"/>
           </a:p>
@@ -32344,9 +34352,9 @@
 </p:sld>
 </file>
 
-<file path=ppt/slides/slide6.xml><?xml version="1.0" encoding="utf-8"?>
+<file path=ppt/slides/slide7.xml><?xml version="1.0" encoding="utf-8"?>
 <p:sld xmlns:a="http://schemas.openxmlformats.org/drawingml/2006/main" xmlns:r="http://schemas.openxmlformats.org/officeDocument/2006/relationships" xmlns:p="http://schemas.openxmlformats.org/presentationml/2006/main">
-  <p:cSld name="Slide 6">
+  <p:cSld name="Slide 7">
     <p:bg>
       <p:bgPr>
         <a:solidFill>
@@ -33385,7 +35393,7 @@
                 <a:ea typeface="NVIDIA Sans" pitchFamily="34" charset="-122"/>
                 <a:cs typeface="NVIDIA Sans" pitchFamily="34" charset="-120"/>
               </a:rPr>
-              <a:t>6</a:t>
+              <a:t>7</a:t>
             </a:r>
             <a:endParaRPr lang="en-US" sz="1000" dirty="0"/>
           </a:p>
@@ -33443,9 +35451,9 @@
 </p:sld>
 </file>
 
-<file path=ppt/slides/slide7.xml><?xml version="1.0" encoding="utf-8"?>
+<file path=ppt/slides/slide8.xml><?xml version="1.0" encoding="utf-8"?>
 <p:sld xmlns:a="http://schemas.openxmlformats.org/drawingml/2006/main" xmlns:r="http://schemas.openxmlformats.org/officeDocument/2006/relationships" xmlns:p="http://schemas.openxmlformats.org/presentationml/2006/main">
-  <p:cSld name="Slide 7">
+  <p:cSld name="Slide 8">
     <p:bg>
       <p:bgPr>
         <a:solidFill>
@@ -34128,7 +36136,7 @@
                 <a:ea typeface="NVIDIA Sans" pitchFamily="34" charset="-122"/>
                 <a:cs typeface="NVIDIA Sans" pitchFamily="34" charset="-120"/>
               </a:rPr>
-              <a:t>7</a:t>
+              <a:t>8</a:t>
             </a:r>
             <a:endParaRPr lang="en-US" sz="1000" dirty="0"/>
           </a:p>
@@ -34186,9 +36194,9 @@
 </p:sld>
 </file>
 
-<file path=ppt/slides/slide8.xml><?xml version="1.0" encoding="utf-8"?>
+<file path=ppt/slides/slide9.xml><?xml version="1.0" encoding="utf-8"?>
 <p:sld xmlns:a="http://schemas.openxmlformats.org/drawingml/2006/main" xmlns:r="http://schemas.openxmlformats.org/officeDocument/2006/relationships" xmlns:p="http://schemas.openxmlformats.org/presentationml/2006/main">
-  <p:cSld name="Slide 8">
+  <p:cSld name="Slide 9">
     <p:bg>
       <p:bgPr>
         <a:solidFill>
@@ -35255,7 +37263,7 @@
       </p:sp>
       <p:graphicFrame>
         <p:nvGraphicFramePr>
-          <p:cNvPr id="9" name="Table 0"/>
+          <p:cNvPr id="10" name="Table 0"/>
           <p:cNvGraphicFramePr>
             <a:graphicFrameLocks noGrp="1"/>
           </p:cNvGraphicFramePr>
@@ -36341,910 +38349,6 @@
                 <a:ea typeface="NVIDIA Sans" pitchFamily="34" charset="-122"/>
                 <a:cs typeface="NVIDIA Sans" pitchFamily="34" charset="-120"/>
               </a:rPr>
-              <a:t>8</a:t>
-            </a:r>
-            <a:endParaRPr lang="en-US" sz="1000" dirty="0"/>
-          </a:p>
-        </p:txBody>
-      </p:sp>
-      <p:sp>
-        <p:nvSpPr>
-          <p:cNvPr id="41" name="Shape 38"/>
-          <p:cNvSpPr/>
-          <p:nvPr/>
-        </p:nvSpPr>
-        <p:spPr>
-          <a:xfrm>
-            <a:off x="7726680" y="4617720"/>
-            <a:ext cx="36576" cy="320040"/>
-          </a:xfrm>
-          <a:prstGeom prst="rect">
-            <a:avLst/>
-          </a:prstGeom>
-          <a:solidFill>
-            <a:srgbClr val="76B900"/>
-          </a:solidFill>
-          <a:ln/>
-        </p:spPr>
-      </p:sp>
-      <p:pic>
-        <p:nvPicPr>
-          <p:cNvPr id="42" name="Image 0" descr="/app/logos/nvidia-logo-blk-sm.png">    </p:cNvPr>
-          <p:cNvPicPr>
-            <a:picLocks noChangeAspect="1"/>
-          </p:cNvPicPr>
-          <p:nvPr/>
-        </p:nvPicPr>
-        <p:blipFill>
-          <a:blip r:embed="rId1"/>
-          <a:stretch>
-            <a:fillRect/>
-          </a:stretch>
-        </p:blipFill>
-        <p:spPr>
-          <a:xfrm>
-            <a:off x="7863840" y="4604004"/>
-            <a:ext cx="1005840" cy="347472"/>
-          </a:xfrm>
-          <a:prstGeom prst="rect">
-            <a:avLst/>
-          </a:prstGeom>
-        </p:spPr>
-      </p:pic>
-    </p:spTree>
-  </p:cSld>
-  <p:clrMapOvr>
-    <a:masterClrMapping/>
-  </p:clrMapOvr>
-</p:sld>
-</file>
-
-<file path=ppt/slides/slide9.xml><?xml version="1.0" encoding="utf-8"?>
-<p:sld xmlns:a="http://schemas.openxmlformats.org/drawingml/2006/main" xmlns:r="http://schemas.openxmlformats.org/officeDocument/2006/relationships" xmlns:p="http://schemas.openxmlformats.org/presentationml/2006/main">
-  <p:cSld name="Slide 9">
-    <p:bg>
-      <p:bgPr>
-        <a:solidFill>
-          <a:srgbClr val="FFFFFF"/>
-        </a:solidFill>
-      </p:bgPr>
-    </p:bg>
-    <p:spTree>
-      <p:nvGrpSpPr>
-        <p:cNvPr id="1" name=""/>
-        <p:cNvGrpSpPr/>
-        <p:nvPr/>
-      </p:nvGrpSpPr>
-      <p:grpSpPr>
-        <a:xfrm>
-          <a:off x="0" y="0"/>
-          <a:ext cx="0" cy="0"/>
-          <a:chOff x="0" y="0"/>
-          <a:chExt cx="0" cy="0"/>
-        </a:xfrm>
-      </p:grpSpPr>
-      <p:sp>
-        <p:nvSpPr>
-          <p:cNvPr id="2" name="Text 0"/>
-          <p:cNvSpPr/>
-          <p:nvPr/>
-        </p:nvSpPr>
-        <p:spPr>
-          <a:xfrm>
-            <a:off x="457200" y="256032"/>
-            <a:ext cx="8229600" cy="548640"/>
-          </a:xfrm>
-          <a:prstGeom prst="rect">
-            <a:avLst/>
-          </a:prstGeom>
-          <a:noFill/>
-          <a:ln/>
-        </p:spPr>
-        <p:txBody>
-          <a:bodyPr wrap="square" lIns="0" tIns="0" rIns="0" bIns="0" rtlCol="0" anchor="ctr"/>
-          <a:lstStyle/>
-          <a:p>
-            <a:pPr indent="0" marL="0">
-              <a:buNone/>
-            </a:pPr>
-            <a:r>
-              <a:rPr lang="en-US" sz="3000" b="1" dirty="0">
-                <a:solidFill>
-                  <a:srgbClr val="000000"/>
-                </a:solidFill>
-                <a:latin typeface="NVIDIA Sans" pitchFamily="34" charset="0"/>
-                <a:ea typeface="NVIDIA Sans" pitchFamily="34" charset="-122"/>
-                <a:cs typeface="NVIDIA Sans" pitchFamily="34" charset="-120"/>
-              </a:rPr>
-              <a:t>Why CUDA Graphs: Launch-Bound Forward</a:t>
-            </a:r>
-            <a:endParaRPr lang="en-US" sz="3000" dirty="0"/>
-          </a:p>
-        </p:txBody>
-      </p:sp>
-      <p:sp>
-        <p:nvSpPr>
-          <p:cNvPr id="3" name="Text 1"/>
-          <p:cNvSpPr/>
-          <p:nvPr/>
-        </p:nvSpPr>
-        <p:spPr>
-          <a:xfrm>
-            <a:off x="457200" y="804672"/>
-            <a:ext cx="8229600" cy="329184"/>
-          </a:xfrm>
-          <a:prstGeom prst="rect">
-            <a:avLst/>
-          </a:prstGeom>
-          <a:noFill/>
-          <a:ln/>
-        </p:spPr>
-        <p:txBody>
-          <a:bodyPr wrap="square" lIns="0" tIns="0" rIns="0" bIns="0" rtlCol="0" anchor="ctr"/>
-          <a:lstStyle/>
-          <a:p>
-            <a:pPr indent="0" marL="0">
-              <a:buNone/>
-            </a:pPr>
-            <a:r>
-              <a:rPr lang="en-US" sz="1500" dirty="0">
-                <a:solidFill>
-                  <a:srgbClr val="76B900"/>
-                </a:solidFill>
-                <a:latin typeface="NVIDIA Sans" pitchFamily="34" charset="0"/>
-                <a:ea typeface="NVIDIA Sans" pitchFamily="34" charset="-122"/>
-                <a:cs typeface="NVIDIA Sans" pitchFamily="34" charset="-120"/>
-              </a:rPr>
-              <a:t>Anatomy of the Qwen3.5 forward — same math, very different wall clock</a:t>
-            </a:r>
-            <a:endParaRPr lang="en-US" sz="1500" dirty="0"/>
-          </a:p>
-        </p:txBody>
-      </p:sp>
-      <p:sp>
-        <p:nvSpPr>
-          <p:cNvPr id="4" name="Text 2"/>
-          <p:cNvSpPr/>
-          <p:nvPr/>
-        </p:nvSpPr>
-        <p:spPr>
-          <a:xfrm>
-            <a:off x="457200" y="1399032"/>
-            <a:ext cx="1417320" cy="384048"/>
-          </a:xfrm>
-          <a:prstGeom prst="rect">
-            <a:avLst/>
-          </a:prstGeom>
-          <a:noFill/>
-          <a:ln/>
-        </p:spPr>
-        <p:txBody>
-          <a:bodyPr wrap="square" lIns="0" tIns="0" rIns="0" bIns="0" rtlCol="0" anchor="ctr"/>
-          <a:lstStyle/>
-          <a:p>
-            <a:pPr indent="0" marL="0">
-              <a:buNone/>
-            </a:pPr>
-            <a:r>
-              <a:rPr lang="en-US" sz="1100" b="1" dirty="0">
-                <a:solidFill>
-                  <a:srgbClr val="000000"/>
-                </a:solidFill>
-                <a:latin typeface="NVIDIA Sans" pitchFamily="34" charset="0"/>
-                <a:ea typeface="NVIDIA Sans" pitchFamily="34" charset="-122"/>
-                <a:cs typeface="NVIDIA Sans" pitchFamily="34" charset="-120"/>
-              </a:rPr>
-              <a:t>Baseline</a:t>
-            </a:r>
-            <a:endParaRPr lang="en-US" sz="1100" dirty="0"/>
-          </a:p>
-          <a:p>
-            <a:pPr indent="0" marL="0">
-              <a:buNone/>
-            </a:pPr>
-            <a:r>
-              <a:rPr lang="en-US" sz="1100" b="1" dirty="0">
-                <a:solidFill>
-                  <a:srgbClr val="000000"/>
-                </a:solidFill>
-                <a:latin typeface="NVIDIA Sans" pitchFamily="34" charset="0"/>
-                <a:ea typeface="NVIDIA Sans" pitchFamily="34" charset="-122"/>
-                <a:cs typeface="NVIDIA Sans" pitchFamily="34" charset="-120"/>
-              </a:rPr>
-              <a:t>(eager)</a:t>
-            </a:r>
-            <a:endParaRPr lang="en-US" sz="1100" dirty="0"/>
-          </a:p>
-        </p:txBody>
-      </p:sp>
-      <p:sp>
-        <p:nvSpPr>
-          <p:cNvPr id="5" name="Shape 3"/>
-          <p:cNvSpPr/>
-          <p:nvPr/>
-        </p:nvSpPr>
-        <p:spPr>
-          <a:xfrm>
-            <a:off x="1920240" y="1417320"/>
-            <a:ext cx="2131541" cy="384048"/>
-          </a:xfrm>
-          <a:prstGeom prst="rect">
-            <a:avLst/>
-          </a:prstGeom>
-          <a:solidFill>
-            <a:srgbClr val="76B900"/>
-          </a:solidFill>
-          <a:ln/>
-        </p:spPr>
-      </p:sp>
-      <p:sp>
-        <p:nvSpPr>
-          <p:cNvPr id="6" name="Text 4"/>
-          <p:cNvSpPr/>
-          <p:nvPr/>
-        </p:nvSpPr>
-        <p:spPr>
-          <a:xfrm>
-            <a:off x="1920240" y="1417320"/>
-            <a:ext cx="2131541" cy="384048"/>
-          </a:xfrm>
-          <a:prstGeom prst="rect">
-            <a:avLst/>
-          </a:prstGeom>
-          <a:noFill/>
-          <a:ln/>
-        </p:spPr>
-        <p:txBody>
-          <a:bodyPr wrap="square" lIns="0" tIns="0" rIns="0" bIns="0" rtlCol="0" anchor="ctr"/>
-          <a:lstStyle/>
-          <a:p>
-            <a:pPr algn="ctr" indent="0" marL="0">
-              <a:buNone/>
-            </a:pPr>
-            <a:r>
-              <a:rPr lang="en-US" sz="1000" b="1" dirty="0">
-                <a:solidFill>
-                  <a:srgbClr val="FFFFFF"/>
-                </a:solidFill>
-                <a:latin typeface="NVIDIA Sans" pitchFamily="34" charset="0"/>
-                <a:ea typeface="NVIDIA Sans" pitchFamily="34" charset="-122"/>
-                <a:cs typeface="NVIDIA Sans" pitchFamily="34" charset="-120"/>
-              </a:rPr>
-              <a:t>GPU busy 50 ms</a:t>
-            </a:r>
-            <a:endParaRPr lang="en-US" sz="1000" dirty="0"/>
-          </a:p>
-        </p:txBody>
-      </p:sp>
-      <p:sp>
-        <p:nvSpPr>
-          <p:cNvPr id="7" name="Shape 5"/>
-          <p:cNvSpPr/>
-          <p:nvPr/>
-        </p:nvSpPr>
-        <p:spPr>
-          <a:xfrm>
-            <a:off x="4051781" y="1417320"/>
-            <a:ext cx="4177819" cy="384048"/>
-          </a:xfrm>
-          <a:prstGeom prst="rect">
-            <a:avLst/>
-          </a:prstGeom>
-          <a:solidFill>
-            <a:srgbClr val="890C58"/>
-          </a:solidFill>
-          <a:ln/>
-        </p:spPr>
-      </p:sp>
-      <p:sp>
-        <p:nvSpPr>
-          <p:cNvPr id="8" name="Text 6"/>
-          <p:cNvSpPr/>
-          <p:nvPr/>
-        </p:nvSpPr>
-        <p:spPr>
-          <a:xfrm>
-            <a:off x="4051781" y="1417320"/>
-            <a:ext cx="4177819" cy="384048"/>
-          </a:xfrm>
-          <a:prstGeom prst="rect">
-            <a:avLst/>
-          </a:prstGeom>
-          <a:noFill/>
-          <a:ln/>
-        </p:spPr>
-        <p:txBody>
-          <a:bodyPr wrap="square" lIns="0" tIns="0" rIns="0" bIns="0" rtlCol="0" anchor="ctr"/>
-          <a:lstStyle/>
-          <a:p>
-            <a:pPr algn="ctr" indent="0" marL="0">
-              <a:buNone/>
-            </a:pPr>
-            <a:r>
-              <a:rPr lang="en-US" sz="1000" b="1" dirty="0">
-                <a:solidFill>
-                  <a:srgbClr val="FFFFFF"/>
-                </a:solidFill>
-                <a:latin typeface="NVIDIA Sans" pitchFamily="34" charset="0"/>
-                <a:ea typeface="NVIDIA Sans" pitchFamily="34" charset="-122"/>
-                <a:cs typeface="NVIDIA Sans" pitchFamily="34" charset="-120"/>
-              </a:rPr>
-              <a:t>waiting for launches 98 ms</a:t>
-            </a:r>
-            <a:endParaRPr lang="en-US" sz="1000" dirty="0"/>
-          </a:p>
-        </p:txBody>
-      </p:sp>
-      <p:sp>
-        <p:nvSpPr>
-          <p:cNvPr id="9" name="Text 7"/>
-          <p:cNvSpPr/>
-          <p:nvPr/>
-        </p:nvSpPr>
-        <p:spPr>
-          <a:xfrm>
-            <a:off x="8302752" y="1417320"/>
-            <a:ext cx="822960" cy="384048"/>
-          </a:xfrm>
-          <a:prstGeom prst="rect">
-            <a:avLst/>
-          </a:prstGeom>
-          <a:noFill/>
-          <a:ln/>
-        </p:spPr>
-        <p:txBody>
-          <a:bodyPr wrap="square" lIns="0" tIns="0" rIns="0" bIns="0" rtlCol="0" anchor="ctr"/>
-          <a:lstStyle/>
-          <a:p>
-            <a:pPr indent="0" marL="0">
-              <a:buNone/>
-            </a:pPr>
-            <a:r>
-              <a:rPr lang="en-US" sz="1200" b="1" dirty="0">
-                <a:solidFill>
-                  <a:srgbClr val="000000"/>
-                </a:solidFill>
-                <a:latin typeface="NVIDIA Sans" pitchFamily="34" charset="0"/>
-                <a:ea typeface="NVIDIA Sans" pitchFamily="34" charset="-122"/>
-                <a:cs typeface="NVIDIA Sans" pitchFamily="34" charset="-120"/>
-              </a:rPr>
-              <a:t>148 ms</a:t>
-            </a:r>
-            <a:endParaRPr lang="en-US" sz="1200" dirty="0"/>
-          </a:p>
-        </p:txBody>
-      </p:sp>
-      <p:sp>
-        <p:nvSpPr>
-          <p:cNvPr id="10" name="Text 8"/>
-          <p:cNvSpPr/>
-          <p:nvPr/>
-        </p:nvSpPr>
-        <p:spPr>
-          <a:xfrm>
-            <a:off x="1920240" y="1819656"/>
-            <a:ext cx="6400800" cy="201168"/>
-          </a:xfrm>
-          <a:prstGeom prst="rect">
-            <a:avLst/>
-          </a:prstGeom>
-          <a:noFill/>
-          <a:ln/>
-        </p:spPr>
-        <p:txBody>
-          <a:bodyPr wrap="square" lIns="0" tIns="0" rIns="0" bIns="0" rtlCol="0" anchor="ctr"/>
-          <a:lstStyle/>
-          <a:p>
-            <a:pPr indent="0" marL="0">
-              <a:buNone/>
-            </a:pPr>
-            <a:r>
-              <a:rPr lang="en-US" sz="950" i="1" dirty="0">
-                <a:solidFill>
-                  <a:srgbClr val="5E5E5E"/>
-                </a:solidFill>
-                <a:latin typeface="NVIDIA Sans" pitchFamily="34" charset="0"/>
-                <a:ea typeface="NVIDIA Sans" pitchFamily="34" charset="-122"/>
-                <a:cs typeface="NVIDIA Sans" pitchFamily="34" charset="-120"/>
-              </a:rPr>
-              <a:t>3,929 kernel launches · 19.1 ms of cudaLaunchKernel CPU time · occupancy 34%</a:t>
-            </a:r>
-            <a:endParaRPr lang="en-US" sz="950" dirty="0"/>
-          </a:p>
-        </p:txBody>
-      </p:sp>
-      <p:sp>
-        <p:nvSpPr>
-          <p:cNvPr id="11" name="Text 9"/>
-          <p:cNvSpPr/>
-          <p:nvPr/>
-        </p:nvSpPr>
-        <p:spPr>
-          <a:xfrm>
-            <a:off x="457200" y="2267712"/>
-            <a:ext cx="1417320" cy="384048"/>
-          </a:xfrm>
-          <a:prstGeom prst="rect">
-            <a:avLst/>
-          </a:prstGeom>
-          <a:noFill/>
-          <a:ln/>
-        </p:spPr>
-        <p:txBody>
-          <a:bodyPr wrap="square" lIns="0" tIns="0" rIns="0" bIns="0" rtlCol="0" anchor="ctr"/>
-          <a:lstStyle/>
-          <a:p>
-            <a:pPr indent="0" marL="0">
-              <a:buNone/>
-            </a:pPr>
-            <a:r>
-              <a:rPr lang="en-US" sz="1100" b="1" dirty="0">
-                <a:solidFill>
-                  <a:srgbClr val="000000"/>
-                </a:solidFill>
-                <a:latin typeface="NVIDIA Sans" pitchFamily="34" charset="0"/>
-                <a:ea typeface="NVIDIA Sans" pitchFamily="34" charset="-122"/>
-                <a:cs typeface="NVIDIA Sans" pitchFamily="34" charset="-120"/>
-              </a:rPr>
-              <a:t>Optimized</a:t>
-            </a:r>
-            <a:endParaRPr lang="en-US" sz="1100" dirty="0"/>
-          </a:p>
-          <a:p>
-            <a:pPr indent="0" marL="0">
-              <a:buNone/>
-            </a:pPr>
-            <a:r>
-              <a:rPr lang="en-US" sz="1100" b="1" dirty="0">
-                <a:solidFill>
-                  <a:srgbClr val="000000"/>
-                </a:solidFill>
-                <a:latin typeface="NVIDIA Sans" pitchFamily="34" charset="0"/>
-                <a:ea typeface="NVIDIA Sans" pitchFamily="34" charset="-122"/>
-                <a:cs typeface="NVIDIA Sans" pitchFamily="34" charset="-120"/>
-              </a:rPr>
-              <a:t>(CUDA Graphs)</a:t>
-            </a:r>
-            <a:endParaRPr lang="en-US" sz="1100" dirty="0"/>
-          </a:p>
-        </p:txBody>
-      </p:sp>
-      <p:sp>
-        <p:nvSpPr>
-          <p:cNvPr id="12" name="Shape 10"/>
-          <p:cNvSpPr/>
-          <p:nvPr/>
-        </p:nvSpPr>
-        <p:spPr>
-          <a:xfrm>
-            <a:off x="1920240" y="2286000"/>
-            <a:ext cx="1577340" cy="384048"/>
-          </a:xfrm>
-          <a:prstGeom prst="rect">
-            <a:avLst/>
-          </a:prstGeom>
-          <a:solidFill>
-            <a:srgbClr val="76B900"/>
-          </a:solidFill>
-          <a:ln/>
-        </p:spPr>
-      </p:sp>
-      <p:sp>
-        <p:nvSpPr>
-          <p:cNvPr id="13" name="Text 11"/>
-          <p:cNvSpPr/>
-          <p:nvPr/>
-        </p:nvSpPr>
-        <p:spPr>
-          <a:xfrm>
-            <a:off x="1920240" y="2286000"/>
-            <a:ext cx="1577340" cy="384048"/>
-          </a:xfrm>
-          <a:prstGeom prst="rect">
-            <a:avLst/>
-          </a:prstGeom>
-          <a:noFill/>
-          <a:ln/>
-        </p:spPr>
-        <p:txBody>
-          <a:bodyPr wrap="square" lIns="0" tIns="0" rIns="0" bIns="0" rtlCol="0" anchor="ctr"/>
-          <a:lstStyle/>
-          <a:p>
-            <a:pPr algn="ctr" indent="0" marL="0">
-              <a:buNone/>
-            </a:pPr>
-            <a:r>
-              <a:rPr lang="en-US" sz="1000" b="1" dirty="0">
-                <a:solidFill>
-                  <a:srgbClr val="FFFFFF"/>
-                </a:solidFill>
-                <a:latin typeface="NVIDIA Sans" pitchFamily="34" charset="0"/>
-                <a:ea typeface="NVIDIA Sans" pitchFamily="34" charset="-122"/>
-                <a:cs typeface="NVIDIA Sans" pitchFamily="34" charset="-120"/>
-              </a:rPr>
-              <a:t>GPU busy 37 ms</a:t>
-            </a:r>
-            <a:endParaRPr lang="en-US" sz="1000" dirty="0"/>
-          </a:p>
-        </p:txBody>
-      </p:sp>
-      <p:sp>
-        <p:nvSpPr>
-          <p:cNvPr id="14" name="Shape 12"/>
-          <p:cNvSpPr/>
-          <p:nvPr/>
-        </p:nvSpPr>
-        <p:spPr>
-          <a:xfrm>
-            <a:off x="3497580" y="2286000"/>
-            <a:ext cx="1193663" cy="384048"/>
-          </a:xfrm>
-          <a:prstGeom prst="rect">
-            <a:avLst/>
-          </a:prstGeom>
-          <a:solidFill>
-            <a:srgbClr val="890C58"/>
-          </a:solidFill>
-          <a:ln/>
-        </p:spPr>
-      </p:sp>
-      <p:sp>
-        <p:nvSpPr>
-          <p:cNvPr id="15" name="Text 13"/>
-          <p:cNvSpPr/>
-          <p:nvPr/>
-        </p:nvSpPr>
-        <p:spPr>
-          <a:xfrm>
-            <a:off x="3497580" y="2286000"/>
-            <a:ext cx="1193663" cy="384048"/>
-          </a:xfrm>
-          <a:prstGeom prst="rect">
-            <a:avLst/>
-          </a:prstGeom>
-          <a:noFill/>
-          <a:ln/>
-        </p:spPr>
-        <p:txBody>
-          <a:bodyPr wrap="square" lIns="0" tIns="0" rIns="0" bIns="0" rtlCol="0" anchor="ctr"/>
-          <a:lstStyle/>
-          <a:p>
-            <a:pPr algn="ctr" indent="0" marL="0">
-              <a:buNone/>
-            </a:pPr>
-            <a:r>
-              <a:rPr lang="en-US" sz="1000" b="1" dirty="0">
-                <a:solidFill>
-                  <a:srgbClr val="FFFFFF"/>
-                </a:solidFill>
-                <a:latin typeface="NVIDIA Sans" pitchFamily="34" charset="0"/>
-                <a:ea typeface="NVIDIA Sans" pitchFamily="34" charset="-122"/>
-                <a:cs typeface="NVIDIA Sans" pitchFamily="34" charset="-120"/>
-              </a:rPr>
-              <a:t>waiting for launches 28 ms</a:t>
-            </a:r>
-            <a:endParaRPr lang="en-US" sz="1000" dirty="0"/>
-          </a:p>
-        </p:txBody>
-      </p:sp>
-      <p:sp>
-        <p:nvSpPr>
-          <p:cNvPr id="16" name="Text 14"/>
-          <p:cNvSpPr/>
-          <p:nvPr/>
-        </p:nvSpPr>
-        <p:spPr>
-          <a:xfrm>
-            <a:off x="4764395" y="2286000"/>
-            <a:ext cx="822960" cy="384048"/>
-          </a:xfrm>
-          <a:prstGeom prst="rect">
-            <a:avLst/>
-          </a:prstGeom>
-          <a:noFill/>
-          <a:ln/>
-        </p:spPr>
-        <p:txBody>
-          <a:bodyPr wrap="square" lIns="0" tIns="0" rIns="0" bIns="0" rtlCol="0" anchor="ctr"/>
-          <a:lstStyle/>
-          <a:p>
-            <a:pPr indent="0" marL="0">
-              <a:buNone/>
-            </a:pPr>
-            <a:r>
-              <a:rPr lang="en-US" sz="1200" b="1" dirty="0">
-                <a:solidFill>
-                  <a:srgbClr val="000000"/>
-                </a:solidFill>
-                <a:latin typeface="NVIDIA Sans" pitchFamily="34" charset="0"/>
-                <a:ea typeface="NVIDIA Sans" pitchFamily="34" charset="-122"/>
-                <a:cs typeface="NVIDIA Sans" pitchFamily="34" charset="-120"/>
-              </a:rPr>
-              <a:t>65 ms</a:t>
-            </a:r>
-            <a:endParaRPr lang="en-US" sz="1200" dirty="0"/>
-          </a:p>
-        </p:txBody>
-      </p:sp>
-      <p:sp>
-        <p:nvSpPr>
-          <p:cNvPr id="17" name="Text 15"/>
-          <p:cNvSpPr/>
-          <p:nvPr/>
-        </p:nvSpPr>
-        <p:spPr>
-          <a:xfrm>
-            <a:off x="1920240" y="2688336"/>
-            <a:ext cx="6400800" cy="201168"/>
-          </a:xfrm>
-          <a:prstGeom prst="rect">
-            <a:avLst/>
-          </a:prstGeom>
-          <a:noFill/>
-          <a:ln/>
-        </p:spPr>
-        <p:txBody>
-          <a:bodyPr wrap="square" lIns="0" tIns="0" rIns="0" bIns="0" rtlCol="0" anchor="ctr"/>
-          <a:lstStyle/>
-          <a:p>
-            <a:pPr indent="0" marL="0">
-              <a:buNone/>
-            </a:pPr>
-            <a:r>
-              <a:rPr lang="en-US" sz="950" i="1" dirty="0">
-                <a:solidFill>
-                  <a:srgbClr val="5E5E5E"/>
-                </a:solidFill>
-                <a:latin typeface="NVIDIA Sans" pitchFamily="34" charset="0"/>
-                <a:ea typeface="NVIDIA Sans" pitchFamily="34" charset="-122"/>
-                <a:cs typeface="NVIDIA Sans" pitchFamily="34" charset="-120"/>
-              </a:rPr>
-              <a:t>6 graph launches + 736 eager · 9.4 ms launch CPU · occupancy 57%</a:t>
-            </a:r>
-            <a:endParaRPr lang="en-US" sz="950" dirty="0"/>
-          </a:p>
-        </p:txBody>
-      </p:sp>
-      <p:sp>
-        <p:nvSpPr>
-          <p:cNvPr id="18" name="Text 16"/>
-          <p:cNvSpPr/>
-          <p:nvPr/>
-        </p:nvSpPr>
-        <p:spPr>
-          <a:xfrm>
-            <a:off x="1920240" y="2907792"/>
-            <a:ext cx="6400800" cy="365760"/>
-          </a:xfrm>
-          <a:prstGeom prst="rect">
-            <a:avLst/>
-          </a:prstGeom>
-          <a:noFill/>
-          <a:ln/>
-        </p:spPr>
-        <p:txBody>
-          <a:bodyPr wrap="square" lIns="0" tIns="0" rIns="0" bIns="0" rtlCol="0" anchor="ctr"/>
-          <a:lstStyle/>
-          <a:p>
-            <a:pPr indent="0" marL="0">
-              <a:buNone/>
-            </a:pPr>
-            <a:r>
-              <a:rPr lang="en-US" sz="2400" b="1" dirty="0">
-                <a:solidFill>
-                  <a:srgbClr val="76B900"/>
-                </a:solidFill>
-                <a:latin typeface="NVIDIA Sans" pitchFamily="34" charset="0"/>
-                <a:ea typeface="NVIDIA Sans" pitchFamily="34" charset="-122"/>
-                <a:cs typeface="NVIDIA Sans" pitchFamily="34" charset="-120"/>
-              </a:rPr>
-              <a:t>2.3× </a:t>
-            </a:r>
-            <a:pPr indent="0" marL="0">
-              <a:buNone/>
-            </a:pPr>
-            <a:r>
-              <a:rPr lang="en-US" sz="1300" b="1" dirty="0">
-                <a:solidFill>
-                  <a:srgbClr val="000000"/>
-                </a:solidFill>
-                <a:latin typeface="NVIDIA Sans" pitchFamily="34" charset="0"/>
-                <a:ea typeface="NVIDIA Sans" pitchFamily="34" charset="-122"/>
-                <a:cs typeface="NVIDIA Sans" pitchFamily="34" charset="-120"/>
-              </a:rPr>
-              <a:t>faster forward wall clock — with 81% fewer launches</a:t>
-            </a:r>
-            <a:endParaRPr lang="en-US" sz="2400" dirty="0"/>
-          </a:p>
-        </p:txBody>
-      </p:sp>
-      <p:sp>
-        <p:nvSpPr>
-          <p:cNvPr id="19" name="Text 17"/>
-          <p:cNvSpPr/>
-          <p:nvPr/>
-        </p:nvSpPr>
-        <p:spPr>
-          <a:xfrm>
-            <a:off x="457200" y="3346704"/>
-            <a:ext cx="8229600" cy="822960"/>
-          </a:xfrm>
-          <a:prstGeom prst="rect">
-            <a:avLst/>
-          </a:prstGeom>
-          <a:noFill/>
-          <a:ln/>
-        </p:spPr>
-        <p:txBody>
-          <a:bodyPr wrap="square" lIns="0" tIns="0" rIns="0" bIns="0" rtlCol="0" anchor="t"/>
-          <a:lstStyle/>
-          <a:p>
-            <a:pPr marL="342900" indent="-342900">
-              <a:buSzPct val="100000"/>
-              <a:buChar char="•"/>
-            </a:pPr>
-            <a:r>
-              <a:rPr lang="en-US" sz="1100" dirty="0">
-                <a:solidFill>
-                  <a:srgbClr val="000000"/>
-                </a:solidFill>
-                <a:latin typeface="NVIDIA Sans" pitchFamily="34" charset="0"/>
-                <a:ea typeface="NVIDIA Sans" pitchFamily="34" charset="-122"/>
-                <a:cs typeface="NVIDIA Sans" pitchFamily="34" charset="-120"/>
-              </a:rPr>
-              <a:t>An eager op costs 30–60 µs of Python dispatch + launch; the median kernel runs 8 µs — the GPU finishes before the CPU can feed the next one</a:t>
-            </a:r>
-            <a:endParaRPr lang="en-US" sz="1100" dirty="0"/>
-          </a:p>
-          <a:p>
-            <a:pPr marL="342900" indent="-342900">
-              <a:buSzPct val="100000"/>
-              <a:buChar char="•"/>
-            </a:pPr>
-            <a:r>
-              <a:rPr lang="en-US" sz="1100" dirty="0">
-                <a:solidFill>
-                  <a:srgbClr val="000000"/>
-                </a:solidFill>
-                <a:latin typeface="NVIDIA Sans" pitchFamily="34" charset="0"/>
-                <a:ea typeface="NVIDIA Sans" pitchFamily="34" charset="-122"/>
-                <a:cs typeface="NVIDIA Sans" pitchFamily="34" charset="-120"/>
-              </a:rPr>
-              <a:t>Backward suffers far less (C++ autograd engine, occupancy 70%) — forward is where launch overhead bites</a:t>
-            </a:r>
-            <a:endParaRPr lang="en-US" sz="1100" dirty="0"/>
-          </a:p>
-          <a:p>
-            <a:pPr marL="342900" indent="-342900">
-              <a:buSzPct val="100000"/>
-              <a:buChar char="•"/>
-            </a:pPr>
-            <a:r>
-              <a:rPr lang="en-US" sz="1100" dirty="0">
-                <a:solidFill>
-                  <a:srgbClr val="000000"/>
-                </a:solidFill>
-                <a:latin typeface="NVIDIA Sans" pitchFamily="34" charset="0"/>
-                <a:ea typeface="NVIDIA Sans" pitchFamily="34" charset="-122"/>
-                <a:cs typeface="NVIDIA Sans" pitchFamily="34" charset="-120"/>
-              </a:rPr>
-              <a:t>A CUDA Graph replays an entire 8-layer group as ONE cudaGraphLaunch — per-op dispatch leaves the critical path</a:t>
-            </a:r>
-            <a:endParaRPr lang="en-US" sz="1100" dirty="0"/>
-          </a:p>
-        </p:txBody>
-      </p:sp>
-      <p:sp>
-        <p:nvSpPr>
-          <p:cNvPr id="20" name="Text 18"/>
-          <p:cNvSpPr/>
-          <p:nvPr/>
-        </p:nvSpPr>
-        <p:spPr>
-          <a:xfrm>
-            <a:off x="457200" y="4206240"/>
-            <a:ext cx="8229600" cy="201168"/>
-          </a:xfrm>
-          <a:prstGeom prst="rect">
-            <a:avLst/>
-          </a:prstGeom>
-          <a:noFill/>
-          <a:ln/>
-        </p:spPr>
-        <p:txBody>
-          <a:bodyPr wrap="square" lIns="0" tIns="0" rIns="0" bIns="0" rtlCol="0" anchor="ctr"/>
-          <a:lstStyle/>
-          <a:p>
-            <a:pPr indent="0" marL="0">
-              <a:buNone/>
-            </a:pPr>
-            <a:r>
-              <a:rPr lang="en-US" sz="850" i="1" dirty="0">
-                <a:solidFill>
-                  <a:srgbClr val="8C8C8C"/>
-                </a:solidFill>
-                <a:latin typeface="NVIDIA Sans" pitchFamily="34" charset="0"/>
-                <a:ea typeface="NVIDIA Sans" pitchFamily="34" charset="-122"/>
-                <a:cs typeface="NVIDIA Sans" pitchFamily="34" charset="-120"/>
-              </a:rPr>
-              <a:t>Busy also shrinks 50 → 37 ms (mixed attention + fusion); the split isolates the launch effect. Windows: baseline Qwen3.5 fwd vs merged-main VLM fwd, same launch-window accounting.</a:t>
-            </a:r>
-            <a:endParaRPr lang="en-US" sz="850" dirty="0"/>
-          </a:p>
-        </p:txBody>
-      </p:sp>
-      <p:sp>
-        <p:nvSpPr>
-          <p:cNvPr id="21" name="Text 19"/>
-          <p:cNvSpPr/>
-          <p:nvPr/>
-        </p:nvSpPr>
-        <p:spPr>
-          <a:xfrm>
-            <a:off x="457200" y="4617720"/>
-            <a:ext cx="4572000" cy="320040"/>
-          </a:xfrm>
-          <a:prstGeom prst="rect">
-            <a:avLst/>
-          </a:prstGeom>
-          <a:noFill/>
-          <a:ln/>
-        </p:spPr>
-        <p:txBody>
-          <a:bodyPr wrap="square" lIns="0" tIns="0" rIns="0" bIns="0" rtlCol="0" anchor="ctr"/>
-          <a:lstStyle/>
-          <a:p>
-            <a:pPr algn="l" indent="0" marL="0">
-              <a:buNone/>
-            </a:pPr>
-            <a:r>
-              <a:rPr lang="en-US" sz="1000" dirty="0">
-                <a:solidFill>
-                  <a:srgbClr val="5E5E5E"/>
-                </a:solidFill>
-                <a:latin typeface="NVIDIA Sans" pitchFamily="34" charset="0"/>
-                <a:ea typeface="NVIDIA Sans" pitchFamily="34" charset="-122"/>
-                <a:cs typeface="NVIDIA Sans" pitchFamily="34" charset="-120"/>
-              </a:rPr>
-              <a:t>QwenPI Training Optimization</a:t>
-            </a:r>
-            <a:endParaRPr lang="en-US" sz="1000" dirty="0"/>
-          </a:p>
-        </p:txBody>
-      </p:sp>
-      <p:sp>
-        <p:nvSpPr>
-          <p:cNvPr id="22" name="Text 20"/>
-          <p:cNvSpPr/>
-          <p:nvPr/>
-        </p:nvSpPr>
-        <p:spPr>
-          <a:xfrm>
-            <a:off x="7360920" y="4617720"/>
-            <a:ext cx="320040" cy="320040"/>
-          </a:xfrm>
-          <a:prstGeom prst="rect">
-            <a:avLst/>
-          </a:prstGeom>
-          <a:noFill/>
-          <a:ln/>
-        </p:spPr>
-        <p:txBody>
-          <a:bodyPr wrap="square" lIns="0" tIns="0" rIns="0" bIns="0" rtlCol="0" anchor="ctr"/>
-          <a:lstStyle/>
-          <a:p>
-            <a:pPr algn="r" indent="0" marL="0">
-              <a:buNone/>
-            </a:pPr>
-            <a:r>
-              <a:rPr lang="en-US" sz="1000" dirty="0">
-                <a:solidFill>
-                  <a:srgbClr val="5E5E5E"/>
-                </a:solidFill>
-                <a:latin typeface="NVIDIA Sans" pitchFamily="34" charset="0"/>
-                <a:ea typeface="NVIDIA Sans" pitchFamily="34" charset="-122"/>
-                <a:cs typeface="NVIDIA Sans" pitchFamily="34" charset="-120"/>
-              </a:rPr>
               <a:t>9</a:t>
             </a:r>
             <a:endParaRPr lang="en-US" sz="1000" dirty="0"/>
@@ -37253,7 +38357,7 @@
       </p:sp>
       <p:sp>
         <p:nvSpPr>
-          <p:cNvPr id="23" name="Shape 21"/>
+          <p:cNvPr id="41" name="Shape 38"/>
           <p:cNvSpPr/>
           <p:nvPr/>
         </p:nvSpPr>
@@ -37273,7 +38377,7 @@
       </p:sp>
       <p:pic>
         <p:nvPicPr>
-          <p:cNvPr id="24" name="Image 0" descr="/app/logos/nvidia-logo-blk-sm.png">    </p:cNvPr>
+          <p:cNvPr id="42" name="Image 0" descr="/app/logos/nvidia-logo-blk-sm.png">    </p:cNvPr>
           <p:cNvPicPr>
             <a:picLocks noChangeAspect="1"/>
           </p:cNvPicPr>

</xml_diff>

<commit_message>
docs(slides): simplify agenda to five items
</commit_message>
<xml_diff>
--- a/docs/slides/qwenpi-optimization.pptx
+++ b/docs/slides/qwenpi-optimization.pptx
@@ -23819,7 +23819,7 @@
                 <a:ea typeface="NVIDIA Sans" pitchFamily="34" charset="-122"/>
                 <a:cs typeface="NVIDIA Sans" pitchFamily="34" charset="-120"/>
               </a:rPr>
-              <a:t>Diagnosis — where did 800 ms go</a:t>
+              <a:t>Diagnosis</a:t>
             </a:r>
             <a:endParaRPr lang="en-US" sz="1700" dirty="0"/>
           </a:p>
@@ -23956,7 +23956,7 @@
                 <a:ea typeface="NVIDIA Sans" pitchFamily="34" charset="-122"/>
                 <a:cs typeface="NVIDIA Sans" pitchFamily="34" charset="-120"/>
               </a:rPr>
-              <a:t>The six fixes — precision, syncs, CUDA Graphs, comm</a:t>
+              <a:t>Optimizations</a:t>
             </a:r>
             <a:endParaRPr lang="en-US" sz="1700" dirty="0"/>
           </a:p>
@@ -24093,7 +24093,7 @@
                 <a:ea typeface="NVIDIA Sans" pitchFamily="34" charset="-122"/>
                 <a:cs typeface="NVIDIA Sans" pitchFamily="34" charset="-120"/>
               </a:rPr>
-              <a:t>Batch scaling</a:t>
+              <a:t>What's next</a:t>
             </a:r>
             <a:endParaRPr lang="en-US" sz="1700" dirty="0"/>
           </a:p>
@@ -24132,7 +24132,7 @@
                 <a:ea typeface="NVIDIA Sans" pitchFamily="34" charset="-122"/>
                 <a:cs typeface="NVIDIA Sans" pitchFamily="34" charset="-120"/>
               </a:rPr>
-              <a:t>13</a:t>
+              <a:t>13 – 14</a:t>
             </a:r>
             <a:endParaRPr lang="en-US" sz="1400" dirty="0"/>
           </a:p>
@@ -24140,144 +24140,7 @@
       </p:sp>
       <p:sp>
         <p:nvSpPr>
-          <p:cNvPr id="23" name="Shape 21"/>
-          <p:cNvSpPr/>
-          <p:nvPr/>
-        </p:nvSpPr>
-        <p:spPr>
-          <a:xfrm>
-            <a:off x="640080" y="3831336"/>
-            <a:ext cx="365760" cy="365760"/>
-          </a:xfrm>
-          <a:prstGeom prst="ellipse">
-            <a:avLst/>
-          </a:prstGeom>
-          <a:solidFill>
-            <a:srgbClr val="76B900"/>
-          </a:solidFill>
-          <a:ln/>
-        </p:spPr>
-      </p:sp>
-      <p:sp>
-        <p:nvSpPr>
-          <p:cNvPr id="24" name="Text 22"/>
-          <p:cNvSpPr/>
-          <p:nvPr/>
-        </p:nvSpPr>
-        <p:spPr>
-          <a:xfrm>
-            <a:off x="640080" y="3831336"/>
-            <a:ext cx="365760" cy="365760"/>
-          </a:xfrm>
-          <a:prstGeom prst="rect">
-            <a:avLst/>
-          </a:prstGeom>
-          <a:noFill/>
-          <a:ln/>
-        </p:spPr>
-        <p:txBody>
-          <a:bodyPr wrap="square" lIns="0" tIns="0" rIns="0" bIns="0" rtlCol="0" anchor="ctr"/>
-          <a:lstStyle/>
-          <a:p>
-            <a:pPr algn="ctr" indent="0" marL="0">
-              <a:buNone/>
-            </a:pPr>
-            <a:r>
-              <a:rPr lang="en-US" sz="1500" b="1" dirty="0">
-                <a:solidFill>
-                  <a:srgbClr val="FFFFFF"/>
-                </a:solidFill>
-                <a:latin typeface="NVIDIA Sans" pitchFamily="34" charset="0"/>
-                <a:ea typeface="NVIDIA Sans" pitchFamily="34" charset="-122"/>
-                <a:cs typeface="NVIDIA Sans" pitchFamily="34" charset="-120"/>
-              </a:rPr>
-              <a:t>6</a:t>
-            </a:r>
-            <a:endParaRPr lang="en-US" sz="1500" dirty="0"/>
-          </a:p>
-        </p:txBody>
-      </p:sp>
-      <p:sp>
-        <p:nvSpPr>
-          <p:cNvPr id="25" name="Text 23"/>
-          <p:cNvSpPr/>
-          <p:nvPr/>
-        </p:nvSpPr>
-        <p:spPr>
-          <a:xfrm>
-            <a:off x="1234440" y="3794760"/>
-            <a:ext cx="6309360" cy="438912"/>
-          </a:xfrm>
-          <a:prstGeom prst="rect">
-            <a:avLst/>
-          </a:prstGeom>
-          <a:noFill/>
-          <a:ln/>
-        </p:spPr>
-        <p:txBody>
-          <a:bodyPr wrap="square" lIns="0" tIns="0" rIns="0" bIns="0" rtlCol="0" anchor="ctr"/>
-          <a:lstStyle/>
-          <a:p>
-            <a:pPr indent="0" marL="0">
-              <a:buNone/>
-            </a:pPr>
-            <a:r>
-              <a:rPr lang="en-US" sz="1700" dirty="0">
-                <a:solidFill>
-                  <a:srgbClr val="000000"/>
-                </a:solidFill>
-                <a:latin typeface="NVIDIA Sans" pitchFamily="34" charset="0"/>
-                <a:ea typeface="NVIDIA Sans" pitchFamily="34" charset="-122"/>
-                <a:cs typeface="NVIDIA Sans" pitchFamily="34" charset="-120"/>
-              </a:rPr>
-              <a:t>What's next</a:t>
-            </a:r>
-            <a:endParaRPr lang="en-US" sz="1700" dirty="0"/>
-          </a:p>
-        </p:txBody>
-      </p:sp>
-      <p:sp>
-        <p:nvSpPr>
-          <p:cNvPr id="26" name="Text 24"/>
-          <p:cNvSpPr/>
-          <p:nvPr/>
-        </p:nvSpPr>
-        <p:spPr>
-          <a:xfrm>
-            <a:off x="7680960" y="3794760"/>
-            <a:ext cx="914400" cy="438912"/>
-          </a:xfrm>
-          <a:prstGeom prst="rect">
-            <a:avLst/>
-          </a:prstGeom>
-          <a:noFill/>
-          <a:ln/>
-        </p:spPr>
-        <p:txBody>
-          <a:bodyPr wrap="square" lIns="0" tIns="0" rIns="0" bIns="0" rtlCol="0" anchor="ctr"/>
-          <a:lstStyle/>
-          <a:p>
-            <a:pPr algn="r" indent="0" marL="0">
-              <a:buNone/>
-            </a:pPr>
-            <a:r>
-              <a:rPr lang="en-US" sz="1400" b="1" dirty="0">
-                <a:solidFill>
-                  <a:srgbClr val="76B900"/>
-                </a:solidFill>
-                <a:latin typeface="NVIDIA Sans" pitchFamily="34" charset="0"/>
-                <a:ea typeface="NVIDIA Sans" pitchFamily="34" charset="-122"/>
-                <a:cs typeface="NVIDIA Sans" pitchFamily="34" charset="-120"/>
-              </a:rPr>
-              <a:t>14</a:t>
-            </a:r>
-            <a:endParaRPr lang="en-US" sz="1400" dirty="0"/>
-          </a:p>
-        </p:txBody>
-      </p:sp>
-      <p:sp>
-        <p:nvSpPr>
-          <p:cNvPr id="27" name="Text 25"/>
+          <p:cNvPr id="23" name="Text 21"/>
           <p:cNvSpPr/>
           <p:nvPr/>
         </p:nvSpPr>
@@ -24316,7 +24179,7 @@
       </p:sp>
       <p:sp>
         <p:nvSpPr>
-          <p:cNvPr id="28" name="Text 26"/>
+          <p:cNvPr id="24" name="Text 22"/>
           <p:cNvSpPr/>
           <p:nvPr/>
         </p:nvSpPr>
@@ -24355,7 +24218,7 @@
       </p:sp>
       <p:sp>
         <p:nvSpPr>
-          <p:cNvPr id="29" name="Shape 27"/>
+          <p:cNvPr id="25" name="Shape 23"/>
           <p:cNvSpPr/>
           <p:nvPr/>
         </p:nvSpPr>
@@ -24375,7 +24238,7 @@
       </p:sp>
       <p:pic>
         <p:nvPicPr>
-          <p:cNvPr id="30" name="Image 0" descr="/app/logos/nvidia-logo-blk-sm.png">    </p:cNvPr>
+          <p:cNvPr id="26" name="Image 0" descr="/app/logos/nvidia-logo-blk-sm.png">    </p:cNvPr>
           <p:cNvPicPr>
             <a:picLocks noChangeAspect="1"/>
           </p:cNvPicPr>

</xml_diff>

<commit_message>
docs(slides): per-slide talk track with anticipated Q&A (pptx notes + markdown)
</commit_message>
<xml_diff>
--- a/docs/slides/qwenpi-optimization.pptx
+++ b/docs/slides/qwenpi-optimization.pptx
@@ -12867,7 +12867,8 @@
           <a:p>
             <a:r>
               <a:rPr lang="en-US" dirty="0"/>
-              <a:t>[IMPORTANT] All numbers in this deck are same-node A/B measurements on 8×H200 (NVLink), nsys-verified.</a:t>
+              <a:t>讲稿:各位好。今天汇报我们在 starVLA QwenPI 训练上的性能优化工作:8 张 H200 上,把每步训练时间从 800 毫秒压到 306 毫秒。整个过程的方法论只有一句话——先用 nsys 找到问题,再针对问题做修复,每一步都有同机 A/B 数据。今天所有数字,大家都可以拿我们公开的 nsys trace 复核。
+Q: 测试环境是什么? A: 单节点 8x H200 SXM、全 NVLink 互联,DeepSpeed ZeRO-2 全参数微调,数据是 LIBERO;软件栈稍后第 4 页详述。</a:t>
             </a:r>
             <a:endParaRPr lang="en-US" dirty="0"/>
           </a:p>
@@ -12955,8 +12956,9 @@
           <a:p>
             <a:r>
               <a:rPr lang="en-US" dirty="0"/>
-              <a:t>Baseline: qwenpi_baseline_nvtx train_step_33; optimized: milestone1 train_step_48. Launch-window attribution both sides.
-[IMPORTANT] This page motivates graphs with the customer's own trace numbers; the next page is the design and the 4-vs-1 answer.</a:t>
+              <a:t>讲稿:进入 CUDA Graph 之前,先看动机。同样的数学,Qwen3.5 前向在基线要 148 毫秒墙钟,其中 GPU 真正在算的只有 50 毫秒——三分之二在等 CPU 发射:3,929 次 kernel launch,每个 op 的 Python 调度加发射要 30 到 60 微秒,而 kernel 中位只有 8 微秒。优化后:6 次 graph launch 替代几千次发射,墙钟 65 毫秒,快 2.3 倍。
+Q: 优化后占空比也才 57%? A: 剩余间隙是图之间的 eager 胶水——多模态 merge、embedding 等,以及本页只看前向的窗口效应;整步的 GPU 空闲从 205ms 降到了 43ms。继续压胶水收益递减,所以下一步的优先级给了 AllGather。
+Q: 为什么反向问题不大? A: 反向由 autograd 引擎在 C++ 里发射,没有 Python 逐层开销,占空比本来就有 70%。所以我们只对前向做图,反向图是 reduce-overhead 顺带的。</a:t>
             </a:r>
             <a:endParaRPr lang="en-US" dirty="0"/>
           </a:p>
@@ -13044,9 +13046,10 @@
           <a:p>
             <a:r>
               <a:rPr lang="en-US" dirty="0"/>
-              <a:t>Graph capture preserves exact hidden-state semantics - verified fullgraph fwd+bwd and unchanged loss trajectory.
-If pressed on details: a whole-stack compile also fails outright here (fla graph-breaks fragment it into cudagraph partitions sharing one memory pool, whose allocator checkpointing collides with ZeRO-2 hook NCCL allocations - crash on torch 2.6 and 2.7.1). Keep it at 'engineering constraints' unless the audience digs.
-Group size 8 = measured sweet spot; 4 replays vs 1 costs microseconds.</a:t>
+              <a:t>讲稿:CUDA Graph 的设计。左边:vision tower 一张图,32 层 decoder 分四张图,DiT 走 torch.compile。客户最常问的问题——为什么是四张不是一张?右图就是答案:DeepSpeed 的梯度 AllReduce 靠 hook 触发,而 hook 只能在图与图之间执行。四张图,反向每重放完一组,hook 就把该组梯度的 AllReduce 发出去,通信和计算重叠;一张大图,所有通信只能挤在反向结束后串行——同样的计算和字节,红线(步结束)明显更晚。
+Q: 模型结构改了,图要重做吗?维护成本多大? A: 捕获在训练启动时自动完成,分组 runner 对层列表是通用的,改层数不用改代码;换注意力结构则需要回归验证。我们还保留了逐层 compile 模式作为回退。
+Q: 为什么每组 8 层? A: 实测甜点:发射节省在组大小 8 就饱和了,更大的组只增加编译时间和故障影响面。
+Q: 一张大图真的不行吗? A: 除了重叠问题,技术上也过不去——线性注意力库的 graph-break 会把单图切成共享显存池的多个分区,和 ZeRO-2 hook 的显存分配冲突,在 torch 2.6 和 2.7.1 上都稳定崩溃。细节可以会后展开。</a:t>
             </a:r>
             <a:endParaRPr lang="en-US" dirty="0"/>
           </a:p>
@@ -13134,9 +13137,10 @@
           <a:p>
             <a:r>
               <a:rPr lang="en-US" dirty="0"/>
-              <a:t>Mechanism source (DeepSpeed 0.16.9 stage_1_and_2.py): TWO ipg buffers when overlap_comm (L2055); average_tensor enqueues compute.wait_stream(reduction_stream) at every bucket boundary (L1061-1062) - pipeline depth is one in-flight reduction.
-A/B re-captured on viking-prod-303 with node-level graph trace: period basis 5e8 = 319 ms/step, 1.5e9 = 306 ms (in-step walls 261/249, gaps ~57 both); AR busy equal within 1 ms (same bytes). Original-branch sweep: 2e9 was +4.7 ms.
-Final ledger (moved off-slide): baseline 807 = 540 busy + 62 exposed + 205 idle; optimized 249 = 175 + 22 + 43.</a:t>
+              <a:t>讲稿:通信配置两个旋钮,解决两个不同的问题。旋钮一 reduce_scatter 关掉:DeepSpeed 默认在每个桶发送前做一次 flatten 拷贝,就是诊断页那 22 毫秒的 CatArrayBatchedCopy,而梯度本来就在连续缓冲里——纯冗余。旋钮二桶大小:DeepSpeed 只有两个梯度缓冲,每次桶满,计算流必须等上一次 reduction 排空。下面是真实对照:5e8 的桶,反向被打断 15 次、47 毫秒;1.5e9 只有 8 次、27 毫秒。两个旋钮正交且同向。
+Q: reduce_scatter 改 AllReduce,线上字节翻倍,多节点上还成立吗? A: 直说:这是单节点 NVLink 的结论——节点内带宽有余量且通信被重叠,flatten 的收益占优。跨节点 IB 上这个权衡很可能反转,部署你们集群前需要重新 A/B,桶大小也要按拓扑重调。这两项都是 15 分钟级的实验,我们可以一起跑。
+Q: 1.5e9 能直接抄到别的模型吗? A: 不能——桶按梯度元素计数,合适的值取决于参数布局(这里是 DiT 那段 30 亿元素的连续梯度)。所以我们把它做成了模型级配置,没动共享默认值。
+Q: 双缓冲这个限制 DeepSpeed 为什么不修? A: 上游的设计取舍(显存换流水深度)。我们后面提的 ZeRO-2 异步 gather 改造会动同一份代码,可以一并评估。</a:t>
             </a:r>
             <a:endParaRPr lang="en-US" dirty="0"/>
           </a:p>
@@ -13224,7 +13228,9 @@
           <a:p>
             <a:r>
               <a:rPr lang="en-US" dirty="0"/>
-              <a:t>[IMPORTANT] Recommendation: bs 24 is the throughput config, gated on customer-side convergence validation (lr recalibration).</a:t>
+              <a:t>讲稿:横向扩 batch:8 到 24,吞吐 209 到 309,MFU 到 27.7%——发射、通信、AllGather 排空这些每步固定开销被摊薄了。甜点在 24;32 反而回落,已排除 OOM 和数据加载,初步指向显存压力,trace 在手。重要边界:bs24 意味着全局 batch 192,收敛性需要在你们的数据和评测器上验证后才能采纳。
+Q: bs24 的学习率怎么调?收敛验证怎么做? A: 建议从线性缩放加 warmup 起步;验证需要你们的任务评测器,我们提供陪跑和训练侧支持。在此之前 deck 的推荐配置仍是 bs8。
+Q: bs32 为什么塌? A: 现场不猜。已排除 OOM 和 dataloader;疑似 allocator/显存压力效应,nsys trace 已采集,需要的话作为后续项深挖。</a:t>
             </a:r>
             <a:endParaRPr lang="en-US" dirty="0"/>
           </a:p>
@@ -13312,10 +13318,10 @@
           <a:p>
             <a:r>
               <a:rPr lang="en-US" dirty="0"/>
-              <a:t>Timeline: qwenpi_bktAB_15e9 train_step_48 through the next step start (node-level trace). AllGather = 2 x 22 ms, fully exposed - the single biggest remaining block.
-Ruled-out list (keep for Q&amp;A): full FA2 +10 ms at seq 192; NCCL knobs futile (478 GB/s busbw = ceiling); one giant decoder graph breaks + kills AR overlap; FlashQLA ceiling ~10.5 ms and needs torch&gt;=2.8; masked_scatter nonzero patch 0 ms; MRoPE cache neutral at tip.
-Optimizer math (~10 ms Adam) additionally has a compiled-autograd lever. Deployment notes: 4+4-topology nodes need NCCL_P2P_LEVEL=NVL; bs24 gated on convergence run.
-[IMPORTANT] Close: 2.6x at bs8 (209 samples/node/s), 309 at bs24 - and the road to ~250+ at bs8 runs through the AllGather.</a:t>
+              <a:t>讲稿:收尾。上图是优化后的完整一步:计算结束后,44 毫秒的参数 AllGather 完全裸露——占每步 18%,这是当前最大的单块损耗。左下 kernel 分布已经平坦:最大类 GEMM 95 毫秒,且已顶在这台机器 622 TFLOPS 的功耗墙上——kernel 层面没有可榨的了,剩下的都是结构性机会。三个方向按规模排序:重叠 AllGather 约 50 毫秒,ZeRO-2 今天做不到,要么 FSDP 要么给 ZeRO-2 加异步 gather;fp8 突破功耗墙;梯度压缩拿回步内约 20 毫秒的暴露 AllReduce。2.6 倍已经落袋,bs8 通往 250+ 的路在 AllGather 上。
+Q: FSDP 迁移成本多大,收益确定吗? A: 收益上限就是实测的 44-57 毫秒,不是估算。两条路成本不同:FSDP 迁移动 checkpoint 格式和训练配置,面大但一劳永逸;ZeRO-2 异步 gather 补丁改动集中在一个文件,面小。我们建议先做一周级的 PoC 把两条路的数字跑出来再定。
+Q: fp8 对收敛的影响? A: 需要 per-tensor scaling(Transformer-Engine 路线)加收敛验证,和 bf16 一样走「先千步 loss 对照、再任务评测」的流程。它是唯一能提高 GEMM 上限的杠杆。
+Q: 有些方向你们试过没有? A: 试过并否证的都有数据:文本栈全 FA2 慢 10ms;NCCL 参数调优无效(带宽已在 478 GB/s 线速);单张大图不可行;FlashQLA 天花板只有 10.5ms。这些清单可以发给你们,避免重复踩坑。</a:t>
             </a:r>
             <a:endParaRPr lang="en-US" dirty="0"/>
           </a:p>
@@ -13403,7 +13409,7 @@
           <a:p>
             <a:r>
               <a:rPr lang="en-US" dirty="0"/>
-              <a:t>Story spine: problems first (pages 5-6), then one fix per problem, each with same-node A/B evidence; close with scaling and the go-forward plan.</a:t>
+              <a:t>讲稿:流程很简单:先给结果,然后花一分钟对齐模型和负载,重点在中间两段——我们诊断出了哪些问题、每个问题怎么修的;最后讲还剩下什么、下一步怎么走。中间任何一页都欢迎随时打断提问。</a:t>
             </a:r>
             <a:endParaRPr lang="en-US" dirty="0"/>
           </a:p>
@@ -13491,7 +13497,10 @@
           <a:p>
             <a:r>
               <a:rPr lang="en-US" dirty="0"/>
-              <a:t>Anchor slide: 3.2x step time, 3.2x throughput at same batch; batch scaling adds another 32% on top.</a:t>
+              <a:t>讲稿:四个数:步时 800 到 306 毫秒,2.6 倍;吞吐从交接时的 80 到 209 samples/node/s,超过 200 的目标线;MFU 从 7.2% 到 18.8%;batch 24 时吞吐 309,是目标的 1.5 倍。特别说明口径:我们的「步时」是步间周期——包含了步尾参数 AllGather 的排空,不是只算前反向的窗口;并且用 1000 步不带 profiler 的干净跑验证过,稳态 303 到 313 毫秒。
+Q: 你们之前沟通提过 249ms,为什么现在是 306? A: 我们自己发现并修正了口径问题:免同步日志优化之后,训练器的 in-step 计时器漏掉了步间约 57ms 的 AllGather 排空。249 是计时器窗口,306 是真实步间周期——你们用 nsys 量到的会是 306。宁可数字难看一点,也要经得起复核。
+Q: 209 离 200 目标太近了? A: 两个答案:batch 24 是 309,余量充足;bs8 下最大的单块损耗就是那 57ms 的 AllGather 暴露,最后一页有把它重叠掉的方案,修复后 bs8 预期回到 250 左右。
+Q: MFU 18.8% 是不是太低? A: 分母用的是 H200 纸面 989.5 TFLOPS;这台机器 GEMM 的持续上限实测只有 622(功耗墙),所以 kernel 层面其实已经接近打满,详见最后一页的 kernel 分布。bs24 时 MFU 27.7%。</a:t>
             </a:r>
             <a:endParaRPr lang="en-US" dirty="0"/>
           </a:p>
@@ -13579,8 +13588,10 @@
           <a:p>
             <a:r>
               <a:rPr lang="en-US" dirty="0"/>
-              <a:t>Hybrid decoder = full attention + gated-delta-net (linear attention) layers — this matters later: GDN blocks whole-model torch.compile.
-Action expert consumes VLM hidden states layer-wise (layerwise DiT).</a:t>
+              <a:t>讲稿:对齐一下负载。7.52B 参数全部参与训练:Qwen3.5-VL 4B 做主干——注意它的 decoder 是 32 层混合结构,全注意力和 gated-delta-net 线性注意力交替,这个细节在讲 CUDA Graph 时会变得很重要;动作专家是 2.96B 的 cross-attention DiT,深度和宽度跟随 VLM(32 块、hidden 2560),逐层交叉注意 VLM 的 hidden states。右边是训练配置,重点:ZeRO-2、bs 8 到 24、文本定长 192。
+Q: 为什么用 ZeRO-2 而不是 ZeRO-3 或 FSDP? A: 这是与你们对齐的基线选型,本次优化不改训练语义。但优化到今天,ZeRO-2 无法重叠参数 AllGather 已成为第一大结构性损耗,最后一页我们正是建议评估 FSDP 或改造 ZeRO-2。
+Q: 文本定长 192 对真实数据成立吗?更长指令怎么办? A: pad 长度是配置项;当前数据分布下 192 覆盖良好、padding 开销实测很小。若上更长指令,按长度分桶、每桶各自捕获一张图即可,方案现成。
+Q: transformers 为什么停在 5.3? A: 有意不动——与你们的环境钉板对齐。我们所有优化都绕开了升级需求,包括一个 5.3 特有的 hidden-states 捕获兼容问题。</a:t>
             </a:r>
             <a:endParaRPr lang="en-US" dirty="0"/>
           </a:p>
@@ -13668,12 +13679,10 @@
           <a:p>
             <a:r>
               <a:rPr lang="en-US" dirty="0"/>
-              <a:t>Timeline from the NVTX-instrumented baseline re-capture (qwenpi_baseline_nvtx, viking-prod-303, train_step_33, 807 ms, bs 8/GPU). Both strips use the GPU-execution clock: kernels attributed to phases/modules by their CPU launch window (correlationId join).
-CPU-side forward() returns at 225 ms - the GPU is still executing DiT forward kernels until 309 ms (eager launch-ahead). That is why phases here are defined on GPU execution, not CPU ranges.
-Qwen3.5 bwd:fwd busy = 123:50 = 2.46x, matching theory (GEMM exactly 1.94x). The SPAN ratio is only 1.18x because forward is launch-starved: occupancy 34% vs 70% in backward (Python-side launches vs C++ autograd).
-Module bands = GPU execution spans, attributed by launch-window correlation (kernels joined to their CPU launch time via correlationId). GPU busy inside the bands: Qwen3.5 fwd 50 ms, DiT fwd 120 ms, DiT bwd 224 ms, Qwen3.5 bwd 123 ms - DiT owns 43% of all GPU busy time.
-Rows 2+3 land as one ladder level (pipeline &amp; caching, -117 ms); row 5 combines bucket sizing (PR11) and the redundant-flatten removal (PR12); row 6 covers the two config-level fixes.
-[IMPORTANT] Key message: every fix in this deck was first SEEN here as a trace shape or a measured kernel cost - problems first, solutions second.</a:t>
+              <a:t>讲稿:这是基线的一个真实训练步,807 毫秒,全部按 GPU 执行时钟画。上面两行:模型阶段和模块归属——前向 309 里 Qwen3.5 占 148、DiT 占 124,反向里 DiT 234、Qwen3.5 175。下面泳道是真实 kernel。五个可见的问题,每个都标了修复方案和收益:fp32 的动作头、CPU 在 forward 里做预处理、每步同步点、发射瓶颈、通信配置。这一页是整个 deck 的地图,后面每页修一个。
+Q: 为什么 CPU 侧 forward 只有 225ms,这里画 309? A: eager 下 CPU 发射超前于 GPU 执行:forward 函数在 225ms 返回,但 GPU 队列里的 DiT 前向 kernel 一直执行到 309。所以本图统一用 GPU 执行时钟,kernel 按发射窗口归属——两行的边界才能严格对齐,你们用 correlationId 关联可以复算。
+Q: Qwen3.5 反向为什么不是前向的两倍? A: 按 GPU busy 恰好是 2.46 倍,符合理论(纯 GEMM 是 1.94)。墙钟跨度只有 1.18 倍,是因为前向发射饥饿——占空比 34% 对反向的 70%,Python 逐层发射喂不饱 GPU。这正是第 10 页的主题。
+Q: 13,868 个 kernel 怎么来的? A: eager 模式每个算子独立发射,中位 kernel 只有 8 微秒;79% 不到 20 微秒。发射成本反而成了主导,这是 CUDA Graph 的动机。</a:t>
             </a:r>
             <a:endParaRPr lang="en-US" dirty="0"/>
           </a:p>
@@ -13761,7 +13770,9 @@
           <a:p>
             <a:r>
               <a:rPr lang="en-US" dirty="0"/>
-              <a:t>Each bar is a separate 60-step run at that cumulative level; bars show ACTUAL step time, not deltas. The next slides walk these levels.</a:t>
+              <a:t>讲稿:优化路线图,柱子是每级落地后的真实步时——注意是周期口径,包含 AllGather 排空。六级:bf16 动作头单项最大,-214;流水线与同步点 -104(其中环境升级折算 -37);混合注意力 -32;CUDA Graph -122;通信调优 -22。累计 2.6 倍。每一根柱子都是同一台机器上的独立 60 步实测,不是估算叠加。
+Q: 为什么不标每项的增量? A: 柱子的差就是增量;我们刻意展示绝对时间,因为那才是你们真实感受到的训练速度。
+Q: 顺序可以变吗?能只挑其中几项吗? A: 大部分独立可选,但有依赖:CUDA Graph 需要定长 shape(来自流水线级的 pad-192)和 torch 2.7.1;混合注意力需要 flash-attn 2.8。想分阶段合入的话,我们可以给依赖图。</a:t>
             </a:r>
             <a:endParaRPr lang="en-US" dirty="0"/>
           </a:p>
@@ -13849,8 +13860,9 @@
           <a:p>
             <a:r>
               <a:rPr lang="en-US" dirty="0"/>
-              <a:t>Kernel classes measured on the instrumented baseline capture (qwenpi_baseline_nvtx).
-Loss curves: 1000-step clean A/B at the merged best config, only DIT_DTYPE differs (qwenpi_loss1k_fp32 vs qwenpi_loss1k_bf16, 2026-07-22, viking-prod-303). Final-100 means match to 4 decimals. Task-level accuracy is validated customer-side; loss trajectory is our correctness evidence.</a:t>
+              <a:t>讲稿:第一个修复,也是最大的单项。左图:基线中 37% 的 GPU 计算时间是 fp32 GEMM,而且全部来自动作头——2.96B 的 DiT 泡在 fp32 里。修复是一个配置开关:DiT 主体进 bf16 autocast,timestep 编码和 loss 数学保持 fp32。右图是正确性证据:1000 步、只有 dtype 不同的干净对照,最后 100 步的平均 loss 两边都是 0.1473,四位小数一致。
+Q: loss 一致不代表任务成功率一致,操作精度怎么保证? A: 同意,任务级评测需要在你们的评测器上做,这是我们建议的联合验证项。我们能给的证据是:损失轨迹千步统计不可区分、对数值最敏感的两处(timestep、loss)保留 fp32——这与业界 VLA 训练的通行做法一致。
+Q: 为什么当初是 fp32? A: 继承自参考实现对 diffusion 数值的保守处理。逐步 |Δ|=0.02 完全来自未固定种子的扩散采样噪声;如果你们需要,我们可以加固定采样种子的模式做逐位验证。</a:t>
             </a:r>
             <a:endParaRPr lang="en-US" dirty="0"/>
           </a:p>
@@ -13938,8 +13950,8 @@
           <a:p>
             <a:r>
               <a:rPr lang="en-US" dirty="0"/>
-              <a:t>All three sync points are CPU work serialized inside forward: data parsing at the top, ViT rotary/positional embedding, and MRoPE position ids between ViT and decoder.
-Stall sizes from the instrumented baseline; the timeline is a schematic, proportions follow the trace.</a:t>
+              <a:t>讲稿:第二类问题:同步点。上图是前向的计算流,四条虚线都是 GPU 必须等 CPU 的往返:图像解码和 tokenize 在 forward 里做,每步开头 GPU 干等 37 毫秒;ViT 的 RoPE 和位置编码在 CPU 上逐步算;ViT 到 decoder 之间的 MRoPE 位置索引也在 CPU;最后 loss 读回和计时器每步两次拉停发射流水线。下面时间线标了它们在真实步里的位置。
+Q: 这些是 HuggingFace 的 bug 吗? A: 不是 bug,是通用性设计——HF 要兼容任意输入形状和推理路径,所以在 CPU 上算这些最稳妥。但训练热循环里输入形状固定,这些就成了纯开销,可以预计算或缓存。</a:t>
             </a:r>
             <a:endParaRPr lang="en-US" dirty="0"/>
           </a:p>
@@ -14027,8 +14039,9 @@
           <a:p>
             <a:r>
               <a:rPr lang="en-US" dirty="0"/>
-              <a:t>Idle quantification from the instrumented baseline: 205 ms/step total idle - ~40 ms preprocessing gap at step start, plus sync stalls and launch gaps.
-Schematic is illustrative; proportions follow the measured trace (preprocess ~40 ms of a 807 ms step at baseline, fully hidden after.</a:t>
+              <a:t>讲稿:对应的四个修复:预处理搬进 8 个 DataLoader worker,和上一步 GPU 计算完全重叠;H2D 用锁页内存加专用拷贝流;日志免同步——loss 只在记录时读回、DeepSpeed 计时器不做强制同步;MRoPE 位置索引按图像网格缓存。加上混合注意力,这一段合计周期从 549 降到 450。
+Q: 标题是 -67,之前不是说这级省了 117 吗? A: 117 是 in-step 计时器口径。把同步点移出计时窗口的同时,原本藏在窗口里的 AllGather 排空也被移出去了,按诚实的周期口径这级净赚 67。我们主动把两个口径都讲清楚。
+Q: 8 个 worker 会不会抢 CPU?数据顺序会变吗? A: 预处理后 data_times 稳定在 1-2ms,CPU 有富余;采样器和数据顺序完全不变,只是预处理的执行位置变了,有逐位验证。</a:t>
             </a:r>
             <a:endParaRPr lang="en-US" dirty="0"/>
           </a:p>

</xml_diff>

<commit_message>
docs(slides): precision-boundary summary (bf16 vs fp32 split, loss statistics) in P7 notes and talk track
</commit_message>
<xml_diff>
--- a/docs/slides/qwenpi-optimization.pptx
+++ b/docs/slides/qwenpi-optimization.pptx
@@ -13860,9 +13860,12 @@
           <a:p>
             <a:r>
               <a:rPr lang="en-US" dirty="0"/>
-              <a:t>讲稿:第一个修复,也是最大的单项。左图:基线中 37% 的 GPU 计算时间是 fp32 GEMM,而且全部来自动作头——2.96B 的 DiT 泡在 fp32 里。修复是一个配置开关:DiT 主体进 bf16 autocast,timestep 编码和 loss 数学保持 fp32。右图是正确性证据:1000 步、只有 dtype 不同的干净对照,最后 100 步的平均 loss 两边都是 0.1473,四位小数一致。
-Q: loss 一致不代表任务成功率一致,操作精度怎么保证? A: 同意,任务级评测需要在你们的评测器上做,这是我们建议的联合验证项。我们能给的证据是:损失轨迹千步统计不可区分、对数值最敏感的两处(timestep、loss)保留 fp32——这与业界 VLA 训练的通行做法一致。
-Q: 为什么当初是 fp32? A: 继承自参考实现对 diffusion 数值的保守处理。逐步 |Δ|=0.02 完全来自未固定种子的扩散采样噪声;如果你们需要,我们可以加固定采样种子的模式做逐位验证。</a:t>
+              <a:t>讲稿:最大单项。左图:基线 37% 的 GPU 计算是 fp32 GEMM,全部来自 2.96B 的动作头。先澄清事实:权重存储本来就是 bf16(DeepSpeed bf16 引擎),fp32 只在优化器 master 副本里;基线的 fp32 计算来自一个作用域过宽的 autocast(float32) 上下文。我们的修复就是收窄它。
+精度边界:转 bf16 的只有 DiT transformer 那一次调用(32 block 的矩阵乘,前反向,tensor core 上 fp32 累加)。保留 fp32:flow-matching 标量数学(噪声插值/velocity/timestep)、action-state encoder、action_decoder、MSE loss、DiT 内 LayerNorm(白名单)、TimestepEncoder、优化器 fp32 master 与 grad-norm。
+结果:训练 loss 无可测退化——1000 步对照,末段百步均值 0.1473 vs 0.1473;末段逐步差 std 0.014,仅为曲线自身步间波动 0.080 的 0.4 倍,精度差异淹没在采样噪声之下。
+Q: loss 一致不代表任务成功率一致? A: 同意,任务级评测在你们评测器上做,建议联合验证;我们的证据是千步轨迹统计不可区分 + 数值敏感处全保 fp32,与业界通行做法一致。
+Q: 为什么当初是 fp32?收窄合理吗? A: 权重本就 bf16 存储,外层 fp32 从未保护权重精度,两倍 GEMM 代价只买到激活精度。收窄用 autocast 标准嵌套机制(内层覆盖外层、白名单仍 fp32),与 VLM 主干既有跑法一致,是 AMP/Megatron/DeepSpeed 标准配方。
+Q: 前 200 步曲线有偏差? A: 扩散采样未固定种子,陡降段对抽到的 t 敏感;平稳段偏移严格归零(401-600 与 901-1000 的均值差均为 0.0000)。要逐位验证可加固定采样种子模式。</a:t>
             </a:r>
             <a:endParaRPr lang="en-US" dirty="0"/>
           </a:p>

</xml_diff>

<commit_message>
docs(slides): mixed-precision feasibility rationale with references in P7
</commit_message>
<xml_diff>
--- a/docs/slides/qwenpi-optimization.pptx
+++ b/docs/slides/qwenpi-optimization.pptx
@@ -13865,7 +13865,9 @@
 结果:训练 loss 无可测退化——1000 步对照,末段百步均值 0.1473 vs 0.1473;末段逐步差 std 0.014,仅为曲线自身步间波动 0.080 的 0.4 倍,精度差异淹没在采样噪声之下。
 Q: loss 一致不代表任务成功率一致? A: 同意,任务级评测在你们评测器上做,建议联合验证;我们的证据是千步轨迹统计不可区分 + 数值敏感处全保 fp32,与业界通行做法一致。
 Q: 为什么当初是 fp32?收窄合理吗? A: 权重本就 bf16 存储,外层 fp32 从未保护权重精度,两倍 GEMM 代价只买到激活精度。收窄用 autocast 标准嵌套机制(内层覆盖外层、白名单仍 fp32),与 VLM 主干既有跑法一致,是 AMP/Megatron/DeepSpeed 标准配方。
-Q: 前 200 步曲线有偏差? A: 扩散采样未固定种子,陡降段对抽到的 t 敏感;平稳段偏移严格归零(401-600 与 901-1000 的均值差均为 0.0000)。要逐位验证可加固定采样种子模式。</a:t>
+Q: 前 200 步曲线有偏差? A: 扩散采样未固定种子,陡降段对抽到的 t 敏感;平稳段偏移严格归零(401-600 与 901-1000 的均值差均为 0.0000)。要逐位验证可加固定采样种子模式。
+可行性:bf16 与 fp32 指数位相同(无溢出、无需 loss scaling);GEMM 在 tensor core 上 fp32 累加;优化器 fp32 master;归约/LN/loss 走 autocast 白名单 fp32。业界:BLOOM/Llama 3/Megatron/DeepSpeed 均以 bf16 为标准训练精度,OpenVLA 等 VLA 实现默认 bf16 微调;本仓库 VLM 主干本就全程 bf16。
+参考:Micikevicius et al. ICLR18 (arXiv:1710.03740);Kalamkar et al. (1905.12322);BLOOM (2211.05100) / OPT (2205.01068);Llama 3 (2407.21783);PyTorch AMP 与 NVIDIA Mixed Precision 指南;OpenVLA (2406.09246)。</a:t>
             </a:r>
             <a:endParaRPr lang="en-US" dirty="0"/>
           </a:p>

</xml_diff>

<commit_message>
docs(slides): correct reduce_scatter framing — default true is a full all_reduce (same bytes), not a real reduce-scatter
</commit_message>
<xml_diff>
--- a/docs/slides/qwenpi-optimization.pptx
+++ b/docs/slides/qwenpi-optimization.pptx
@@ -13137,10 +13137,11 @@
           <a:p>
             <a:r>
               <a:rPr lang="en-US" dirty="0"/>
-              <a:t>讲稿:通信配置两个旋钮,解决两个不同的问题。旋钮一 reduce_scatter 关掉:DeepSpeed 默认在每个桶发送前做一次 flatten 拷贝,就是诊断页那 22 毫秒的 CatArrayBatchedCopy,而梯度本来就在连续缓冲里——纯冗余。旋钮二桶大小:DeepSpeed 只有两个梯度缓冲,每次桶满,计算流必须等上一次 reduction 排空。下面是真实对照:5e8 的桶,反向被打断 15 次、47 毫秒;1.5e9 只有 8 次、27 毫秒。两个旋钮正交且同向。
-Q: reduce_scatter 改 AllReduce,线上字节翻倍,多节点上还成立吗? A: 直说:这是单节点 NVLink 的结论——节点内带宽有余量且通信被重叠,flatten 的收益占优。跨节点 IB 上这个权衡很可能反转,部署你们集群前需要重新 A/B,桶大小也要按拓扑重调。这两项都是 15 分钟级的实验,我们可以一起跑。
-Q: 1.5e9 能直接抄到别的模型吗? A: 不能——桶按梯度元素计数,合适的值取决于参数布局(这里是 DiT 那段 30 亿元素的连续梯度)。所以我们把它做成了模型级配置,没动共享默认值。
-Q: 双缓冲这个限制 DeepSpeed 为什么不修? A: 上游的设计取舍(显存换流水深度)。我们后面提的 ZeRO-2 异步 gather 改造会动同一份代码,可以一并评估。</a:t>
+              <a:t>讲稿:通信两个旋钮。旋钮一 reduce_scatter=false:关键事实——DeepSpeed 默认的 reduce_scatter=true 底层其实仍是整桶 all_reduce(allreduce_bucket L1521,rank=None→dist.all_reduce),只是多付了每桶的 flatten(诊断页那 22ms CatArrayBatchedCopy)和 copy-back;false 对本就连续的桶直接一次 all_reduce,字节完全不变、纯省两轮拷贝(−13ms)。旋钮二桶大小:只有两个梯度缓冲,每次桶满计算流要等上次 reduction 排空(L2055 双缓冲 + L1061-62 wait_stream)。真实对照:5e8 打断 15 次/47ms,1.5e9 只有 8 次/27ms。
+Q(最尖锐): all_reduce 不就是 reduce-scatter + all-gather 吗?那 reduce_scatter=true 该省一半字节才对? A: 理论完全对——纯 reduce-scatter 跳过 all-gather 段、只搬一半字节,正是 ZeRO-2 该用的。但陷阱在于:DeepSpeed 默认的 reduce_scatter=true(use_multi_rank_bucket_allreduce=True,构造默认 L120)底层调的是 dist.all_reduce,不是真 reduce-scatter,搬满量字节还加重排——所以关掉它是纯赚,不是权衡。真正的 reduce-scatter 在另一条子路径(use_multi_rank=false → allreduce_no_retain → dist.reduce 逐分片)。
+Q: 那真 reduce-scatter 为什么不用?多节点呢? A: 我们测过真 RS 路径在单机反而更慢:NVLink 上梯度通信与反向计算重叠、非带宽瓶颈(478 GB/s 已到顶但被藏住),砍一半字节几乎不缩短暴露时间,而它碎成很多小 dist.reduce 且照样 flatten。多节点上通信暴露且带宽受限,砍字节才真正值钱——但正确做法是上真正实现 RS 的路径/新版 DS,不是把开关拨回默认 true(那只是 all_reduce+重排)。桶大小也需按拓扑重调;均为 15 分钟级实验。
+Q: 1.5e9 能抄到别的模型吗? A: 不能——桶按梯度元素计数,取决于参数布局(DiT 那段 30 亿元素连续梯度),所以做成了模型级配置,没动共享默认值。
+Q: 双缓冲 DeepSpeed 为什么不修? A: 上游设计取舍(显存换流水深度);我们的 ZeRO-2 异步 gather 改造会动同一份代码,可一并评估。</a:t>
             </a:r>
             <a:endParaRPr lang="en-US" dirty="0"/>
           </a:p>
@@ -17002,7 +17003,7 @@
                 <a:ea typeface="NVIDIA Sans" pitchFamily="34" charset="-122"/>
                 <a:cs typeface="NVIDIA Sans" pitchFamily="34" charset="-120"/>
               </a:rPr>
-              <a:t>Default path flattens every bucket (22 ms/step CatArrayBatchedCopy) — but grads already sit contiguous</a:t>
+              <a:t>reduce_scatter=true is still a full all_reduce underneath — it just adds a per-bucket flatten (22 ms CatArrayBatchedCopy) + copy-back</a:t>
             </a:r>
             <a:endParaRPr lang="en-US" sz="900" dirty="0"/>
           </a:p>
@@ -17020,7 +17021,7 @@
                 <a:ea typeface="NVIDIA Sans" pitchFamily="34" charset="-122"/>
                 <a:cs typeface="NVIDIA Sans" pitchFamily="34" charset="-120"/>
               </a:rPr>
-              <a:t>Plain AllReduce skips it. Cost: ~2× wire bytes — fine while comm overlaps and NVLink has headroom</a:t>
+              <a:t>false = one all_reduce on the already-contiguous bucket: same bytes, no reshuffle</a:t>
             </a:r>
             <a:endParaRPr lang="en-US" sz="900" dirty="0"/>
           </a:p>
@@ -19003,7 +19004,7 @@
                 <a:ea typeface="NVIDIA Sans" pitchFamily="34" charset="-122"/>
                 <a:cs typeface="NVIDIA Sans" pitchFamily="34" charset="-120"/>
               </a:rPr>
-              <a:t>bucket size = how OFTEN compute and reduction rendezvous; reduce_scatter = what each rendezvous COSTS. false makes each AR bigger, strengthening the case for large buckets.</a:t>
+              <a:t>bucket size sets how OFTEN compute and reduction rendezvous; reduce_scatter sets how much copy work rides on each reduction. Both shrink the backward stall, independently.</a:t>
             </a:r>
             <a:endParaRPr lang="en-US" sz="1000" dirty="0"/>
           </a:p>

</xml_diff>

<commit_message>
docs(slides): overhead-dominated thesis (attention 6%, dense-linear 47%) + MRoPE explainer in notes/talk-track
</commit_message>
<xml_diff>
--- a/docs/slides/qwenpi-optimization.pptx
+++ b/docs/slides/qwenpi-optimization.pptx
@@ -13683,7 +13683,8 @@
               <a:t>讲稿:这是基线的一个真实训练步,807 毫秒,全部按 GPU 执行时钟画。上面两行:模型阶段和模块归属——前向 309 里 Qwen3.5 占 148、DiT 占 124,反向里 DiT 234、Qwen3.5 175。下面泳道是真实 kernel。五个可见的问题,每个都标了修复方案和收益:fp32 的动作头、CPU 在 forward 里做预处理、每步同步点、发射瓶颈、通信配置。这一页是整个 deck 的地图,后面每页修一个。
 Q: 为什么 CPU 侧 forward 只有 225ms,这里画 309? A: eager 下 CPU 发射超前于 GPU 执行:forward 函数在 225ms 返回,但 GPU 队列里的 DiT 前向 kernel 一直执行到 309。所以本图统一用 GPU 执行时钟,kernel 按发射窗口归属——两行的边界才能严格对齐,你们用 correlationId 关联可以复算。
 Q: Qwen3.5 反向为什么不是前向的两倍? A: 按 GPU busy 恰好是 2.46 倍,符合理论(纯 GEMM 是 1.94)。墙钟跨度只有 1.18 倍,是因为前向发射饥饿——占空比 34% 对反向的 70%,Python 逐层发射喂不饱 GPU。这正是第 10 页的主题。
-Q: 13,868 个 kernel 怎么来的? A: eager 模式每个算子独立发射,中位 kernel 只有 8 微秒;79% 不到 20 微秒。发射成本反而成了主导,这是 CUDA Graph 的动机。</a:t>
+Q: 13,868 个 kernel 怎么来的? A: eager 模式每个算子独立发射,中位 kernel 只有 8 微秒;79% 不到 20 微秒。发射成本反而成了主导,这是 CUDA Graph 的动机。
+全场定调(可在这一页点出):这是开销主导的负载,不是计算或注意力主导。序列很短(LLM 192、DiT ~80),所以 O(seq²) 的 attention 只占计算 6%(理论 seq/hidden≈8%),主导的是 O(seq) 的稠密线性层(投影+FFN,47%)且已饱和;每步 GEMM busy 只 95ms、占一步 306ms 的 31%,其余 69% 是发射/同步/通信。推论:优化开销(CUDA Graph/免同步/ZeRO-2),不碰 attention(全 FA2 更慢、FlashQLA 天花板 10.5ms 的根因),不写自定义 GEMM(已饱和);剩 fp8(功耗墙)与重叠 AllGather 两个杠杆。序列/batch 增大 → 向 compute-bound 迁移 → fp8 接棒(P13 的 MFU 18.8%→27.7% 已在演示)。</a:t>
             </a:r>
             <a:endParaRPr lang="en-US" dirty="0"/>
           </a:p>
@@ -13957,7 +13958,8 @@
             <a:r>
               <a:rPr lang="en-US" dirty="0"/>
               <a:t>讲稿:第二类问题:同步点。上图是前向的计算流,四条虚线都是 GPU 必须等 CPU 的往返:图像解码和 tokenize 在 forward 里做,每步开头 GPU 干等 37 毫秒;ViT 的 RoPE 和位置编码在 CPU 上逐步算;ViT 到 decoder 之间的 MRoPE 位置索引也在 CPU;最后 loss 读回和计时器每步两次拉停发射流水线。下面时间线标了它们在真实步里的位置。
-Q: 这些是 HuggingFace 的 bug 吗? A: 不是 bug,是通用性设计——HF 要兼容任意输入形状和推理路径,所以在 CPU 上算这些最稳妥。但训练热循环里输入形状固定,这些就成了纯开销,可以预计算或缓存。</a:t>
+Q: 这些是 HuggingFace 的 bug 吗? A: 不是 bug,是通用性设计——HF 要兼容任意输入形状和推理路径,所以在 CPU 上算这些最稳妥。但训练热循环里输入形状固定,这些就成了纯开销,可以预计算或缓存。
+Q: MRoPE 是干嘛的?为什么是同步点? A: MRoPE 是 Qwen-VL 的多模态位置编码(arXiv:2409.12191):给每个 token 一个 3D 位置 (t,h,w)——文本三坐标一起走,视觉 token 的 h/w 编码 patch 在图像 2D 网格里的行列,让 decoder 理解视觉 token 的空间结构和视频时序。它只取决于序列结构(image_grid_thw + 图/文布局 + mask),与像素内容无关;HF 用 Python 循环算含每图 .item() 读回(~13ms 同步)。我们图像尺寸固定、pad-192 → 每步位置 id 一样 → 按 grid 缓存只算一次(用 HF 自己的 compute_3d_position_ids,语义零风险,STARVLA_CHECK_POSIDS 逐位校验)。</a:t>
             </a:r>
             <a:endParaRPr lang="en-US" dirty="0"/>
           </a:p>

</xml_diff>